<commit_message>
nightly deck: data through 2026-09-06
</commit_message>
<xml_diff>
--- a/docs/nc-drug-checking-latest.pptx
+++ b/docs/nc-drug-checking-latest.pptx
@@ -2418,7 +2418,7 @@
                 <a:ea typeface="Helvetica Neue"/>
                 <a:sym typeface="Helvetica Neue"/>
               </a:rPr>
-              <a:t>Generated Saturday, September 05, 2026 · 7:20 AM ET UNC Street Drug Analysis Lab · OpioidData.org · results.streetsafe.supply Download as PowerPoint</a:t>
+              <a:t>Generated Sunday, September 06, 2026 · 7:43 AM ET UNC Street Drug Analysis Lab · OpioidData.org · results.streetsafe.supply Download as PowerPoint</a:t>
             </a:r>
           </a:p>
         </p:txBody>
@@ -3184,7 +3184,7 @@
                 <a:ea typeface="Helvetica Neue"/>
                 <a:sym typeface="Helvetica Neue"/>
               </a:rPr>
-              <a:t>County = samplecounty · left: ≥1 completed analysis ever · right: unique samples per county (sqrt color scale) · all time: 26 Jan 2022 – 02 Sep 2026 · last 12 months: 05 Sep 2025 – 02 Sep 2026* · coverage reflects participation, not prevalence</a:t>
+              <a:t>County = samplecounty · left: ≥1 completed analysis ever · right: unique samples per county (sqrt color scale) · all time: 26 Jan 2022 – 02 Sep 2026 · last 12 months: 06 Sep 2025 – 02 Sep 2026* · coverage reflects participation, not prevalence</a:t>
             </a:r>
           </a:p>
         </p:txBody>
@@ -4323,7 +4323,7 @@
                 <a:ea typeface="Helvetica Neue"/>
                 <a:sym typeface="Helvetica Neue"/>
               </a:rPr>
-              <a:t>Samples with methamphetamine or cocaine detected (any abundance); samples in both classes appear on both slides · sensations semicolon lists parsed + sen_strength (own denominator) · consumed = 1 only · before: 26 Jan 2022 – 02 Sep 2025 · past 12 months: 05 Sep 2025 – 02 Sep 2026* · Δ in percentage points</a:t>
+              <a:t>Samples with methamphetamine or cocaine detected (any abundance); samples in both classes appear on both slides · sensations semicolon lists parsed + sen_strength (own denominator) · consumed = 1 only · before: 26 Jan 2022 – 02 Sep 2025 · past 12 months: 06 Sep 2025 – 02 Sep 2026* · Δ in percentage points</a:t>
             </a:r>
           </a:p>
         </p:txBody>
@@ -4742,7 +4742,7 @@
                 <a:ea typeface="Helvetica Neue"/>
                 <a:sym typeface="Helvetica Neue"/>
               </a:rPr>
-              <a:t>Samples with an opioid (fentanyl, heroin) or benzodiazepine detected (any abundance); samples in both classes appear on both slides · sensations semicolon lists parsed + sen_strength (own denominator) · consumed = 1 only · before: 26 Jan 2022 – 02 Sep 2025 · past 12 months: 05 Sep 2025 – 02 Sep 2026* · Δ in percentage points</a:t>
+              <a:t>Samples with an opioid (fentanyl, heroin) or benzodiazepine detected (any abundance); samples in both classes appear on both slides · sensations semicolon lists parsed + sen_strength (own denominator) · consumed = 1 only · before: 26 Jan 2022 – 02 Sep 2025 · past 12 months: 06 Sep 2025 – 02 Sep 2026* · Δ in percentage points</a:t>
             </a:r>
           </a:p>
         </p:txBody>
@@ -5855,7 +5855,7 @@
                 <a:ea typeface="Helvetica Neue"/>
                 <a:sym typeface="Helvetica Neue"/>
               </a:rPr>
-              <a:t>lab_detail.substance counts · solid = primary abundance, light = trace · standardized names (PubChem-linked) · window: date_complete 05 Sep 2025 – 02 Sep 2026* (trailing 12 months, current month partial)</a:t>
+              <a:t>lab_detail.substance counts · solid = primary abundance, light = trace · standardized names (PubChem-linked) · window: date_complete 06 Sep 2025 – 02 Sep 2026* (trailing 12 months, current month partial)</a:t>
             </a:r>
           </a:p>
         </p:txBody>
@@ -6053,7 +6053,7 @@
                 <a:ea typeface="Helvetica Neue"/>
                 <a:sym typeface="Helvetica Neue"/>
               </a:rPr>
-              <a:t>Distribution of substances detected per sample, both definitions shown side by side · window: date_complete 05 Sep 2025 – 02 Sep 2026* (trailing 12 months, current month partial)</a:t>
+              <a:t>Distribution of substances detected per sample, both definitions shown side by side · window: date_complete 06 Sep 2025 – 02 Sep 2026* (trailing 12 months, current month partial)</a:t>
             </a:r>
           </a:p>
         </p:txBody>

</xml_diff>

<commit_message>
nightly deck: data through 2026-09-07
</commit_message>
<xml_diff>
--- a/docs/nc-drug-checking-latest.pptx
+++ b/docs/nc-drug-checking-latest.pptx
@@ -2418,7 +2418,7 @@
                 <a:ea typeface="Helvetica Neue"/>
                 <a:sym typeface="Helvetica Neue"/>
               </a:rPr>
-              <a:t>Generated Sunday, September 06, 2026 · 7:43 AM ET UNC Street Drug Analysis Lab · OpioidData.org · results.streetsafe.supply Download as PowerPoint</a:t>
+              <a:t>Generated Monday, September 07, 2026 · 9:36 AM ET UNC Street Drug Analysis Lab · OpioidData.org · results.streetsafe.supply Download as PowerPoint</a:t>
             </a:r>
           </a:p>
         </p:txBody>
@@ -3184,7 +3184,7 @@
                 <a:ea typeface="Helvetica Neue"/>
                 <a:sym typeface="Helvetica Neue"/>
               </a:rPr>
-              <a:t>County = samplecounty · left: ≥1 completed analysis ever · right: unique samples per county (sqrt color scale) · all time: 26 Jan 2022 – 02 Sep 2026 · last 12 months: 06 Sep 2025 – 02 Sep 2026* · coverage reflects participation, not prevalence</a:t>
+              <a:t>County = samplecounty · left: ≥1 completed analysis ever · right: unique samples per county (sqrt color scale) · all time: 26 Jan 2022 – 02 Sep 2026 · last 12 months: 07 Sep 2025 – 02 Sep 2026* · coverage reflects participation, not prevalence</a:t>
             </a:r>
           </a:p>
         </p:txBody>
@@ -4323,7 +4323,7 @@
                 <a:ea typeface="Helvetica Neue"/>
                 <a:sym typeface="Helvetica Neue"/>
               </a:rPr>
-              <a:t>Samples with methamphetamine or cocaine detected (any abundance); samples in both classes appear on both slides · sensations semicolon lists parsed + sen_strength (own denominator) · consumed = 1 only · before: 26 Jan 2022 – 02 Sep 2025 · past 12 months: 06 Sep 2025 – 02 Sep 2026* · Δ in percentage points</a:t>
+              <a:t>Samples with methamphetamine or cocaine detected (any abundance); samples in both classes appear on both slides · sensations semicolon lists parsed + sen_strength (own denominator) · consumed = 1 only · before: 26 Jan 2022 – 02 Sep 2025 · past 12 months: 07 Sep 2025 – 02 Sep 2026* · Δ in percentage points</a:t>
             </a:r>
           </a:p>
         </p:txBody>
@@ -4742,7 +4742,7 @@
                 <a:ea typeface="Helvetica Neue"/>
                 <a:sym typeface="Helvetica Neue"/>
               </a:rPr>
-              <a:t>Samples with an opioid (fentanyl, heroin) or benzodiazepine detected (any abundance); samples in both classes appear on both slides · sensations semicolon lists parsed + sen_strength (own denominator) · consumed = 1 only · before: 26 Jan 2022 – 02 Sep 2025 · past 12 months: 06 Sep 2025 – 02 Sep 2026* · Δ in percentage points</a:t>
+              <a:t>Samples with an opioid (fentanyl, heroin) or benzodiazepine detected (any abundance); samples in both classes appear on both slides · sensations semicolon lists parsed + sen_strength (own denominator) · consumed = 1 only · before: 26 Jan 2022 – 02 Sep 2025 · past 12 months: 07 Sep 2025 – 02 Sep 2026* · Δ in percentage points</a:t>
             </a:r>
           </a:p>
         </p:txBody>
@@ -5855,7 +5855,7 @@
                 <a:ea typeface="Helvetica Neue"/>
                 <a:sym typeface="Helvetica Neue"/>
               </a:rPr>
-              <a:t>lab_detail.substance counts · solid = primary abundance, light = trace · standardized names (PubChem-linked) · window: date_complete 06 Sep 2025 – 02 Sep 2026* (trailing 12 months, current month partial)</a:t>
+              <a:t>lab_detail.substance counts · solid = primary abundance, light = trace · standardized names (PubChem-linked) · window: date_complete 07 Sep 2025 – 02 Sep 2026* (trailing 12 months, current month partial)</a:t>
             </a:r>
           </a:p>
         </p:txBody>
@@ -6053,7 +6053,7 @@
                 <a:ea typeface="Helvetica Neue"/>
                 <a:sym typeface="Helvetica Neue"/>
               </a:rPr>
-              <a:t>Distribution of substances detected per sample, both definitions shown side by side · window: date_complete 06 Sep 2025 – 02 Sep 2026* (trailing 12 months, current month partial)</a:t>
+              <a:t>Distribution of substances detected per sample, both definitions shown side by side · window: date_complete 07 Sep 2025 – 02 Sep 2026* (trailing 12 months, current month partial)</a:t>
             </a:r>
           </a:p>
         </p:txBody>

</xml_diff>

<commit_message>
nightly deck: data through 2026-09-08
</commit_message>
<xml_diff>
--- a/docs/nc-drug-checking-latest.pptx
+++ b/docs/nc-drug-checking-latest.pptx
@@ -2418,7 +2418,7 @@
                 <a:ea typeface="Helvetica Neue"/>
                 <a:sym typeface="Helvetica Neue"/>
               </a:rPr>
-              <a:t>Generated Monday, September 07, 2026 · 9:36 AM ET UNC Street Drug Analysis Lab · OpioidData.org · results.streetsafe.supply Download as PowerPoint</a:t>
+              <a:t>Generated Tuesday, September 08, 2026 · 8:14 AM ET UNC Street Drug Analysis Lab · OpioidData.org · results.streetsafe.supply Download as PowerPoint</a:t>
             </a:r>
           </a:p>
         </p:txBody>
@@ -3184,7 +3184,7 @@
                 <a:ea typeface="Helvetica Neue"/>
                 <a:sym typeface="Helvetica Neue"/>
               </a:rPr>
-              <a:t>County = samplecounty · left: ≥1 completed analysis ever · right: unique samples per county (sqrt color scale) · all time: 26 Jan 2022 – 02 Sep 2026 · last 12 months: 07 Sep 2025 – 02 Sep 2026* · coverage reflects participation, not prevalence</a:t>
+              <a:t>County = samplecounty · left: ≥1 completed analysis ever · right: unique samples per county (sqrt color scale) · all time: 26 Jan 2022 – 02 Sep 2026 · last 12 months: 08 Sep 2025 – 02 Sep 2026* · coverage reflects participation, not prevalence</a:t>
             </a:r>
           </a:p>
         </p:txBody>
@@ -4323,7 +4323,7 @@
                 <a:ea typeface="Helvetica Neue"/>
                 <a:sym typeface="Helvetica Neue"/>
               </a:rPr>
-              <a:t>Samples with methamphetamine or cocaine detected (any abundance); samples in both classes appear on both slides · sensations semicolon lists parsed + sen_strength (own denominator) · consumed = 1 only · before: 26 Jan 2022 – 02 Sep 2025 · past 12 months: 07 Sep 2025 – 02 Sep 2026* · Δ in percentage points</a:t>
+              <a:t>Samples with methamphetamine or cocaine detected (any abundance); samples in both classes appear on both slides · sensations semicolon lists parsed + sen_strength (own denominator) · consumed = 1 only · before: 26 Jan 2022 – 02 Sep 2025 · past 12 months: 08 Sep 2025 – 02 Sep 2026* · Δ in percentage points</a:t>
             </a:r>
           </a:p>
         </p:txBody>
@@ -4742,7 +4742,7 @@
                 <a:ea typeface="Helvetica Neue"/>
                 <a:sym typeface="Helvetica Neue"/>
               </a:rPr>
-              <a:t>Samples with an opioid (fentanyl, heroin) or benzodiazepine detected (any abundance); samples in both classes appear on both slides · sensations semicolon lists parsed + sen_strength (own denominator) · consumed = 1 only · before: 26 Jan 2022 – 02 Sep 2025 · past 12 months: 07 Sep 2025 – 02 Sep 2026* · Δ in percentage points</a:t>
+              <a:t>Samples with an opioid (fentanyl, heroin) or benzodiazepine detected (any abundance); samples in both classes appear on both slides · sensations semicolon lists parsed + sen_strength (own denominator) · consumed = 1 only · before: 26 Jan 2022 – 02 Sep 2025 · past 12 months: 08 Sep 2025 – 02 Sep 2026* · Δ in percentage points</a:t>
             </a:r>
           </a:p>
         </p:txBody>
@@ -5855,7 +5855,7 @@
                 <a:ea typeface="Helvetica Neue"/>
                 <a:sym typeface="Helvetica Neue"/>
               </a:rPr>
-              <a:t>lab_detail.substance counts · solid = primary abundance, light = trace · standardized names (PubChem-linked) · window: date_complete 07 Sep 2025 – 02 Sep 2026* (trailing 12 months, current month partial)</a:t>
+              <a:t>lab_detail.substance counts · solid = primary abundance, light = trace · standardized names (PubChem-linked) · window: date_complete 08 Sep 2025 – 02 Sep 2026* (trailing 12 months, current month partial)</a:t>
             </a:r>
           </a:p>
         </p:txBody>
@@ -6053,7 +6053,7 @@
                 <a:ea typeface="Helvetica Neue"/>
                 <a:sym typeface="Helvetica Neue"/>
               </a:rPr>
-              <a:t>Distribution of substances detected per sample, both definitions shown side by side · window: date_complete 07 Sep 2025 – 02 Sep 2026* (trailing 12 months, current month partial)</a:t>
+              <a:t>Distribution of substances detected per sample, both definitions shown side by side · window: date_complete 08 Sep 2025 – 02 Sep 2026* (trailing 12 months, current month partial)</a:t>
             </a:r>
           </a:p>
         </p:txBody>

</xml_diff>

<commit_message>
nightly deck: data through 2026-09-09
</commit_message>
<xml_diff>
--- a/docs/nc-drug-checking-latest.pptx
+++ b/docs/nc-drug-checking-latest.pptx
@@ -2418,7 +2418,7 @@
                 <a:ea typeface="Helvetica Neue"/>
                 <a:sym typeface="Helvetica Neue"/>
               </a:rPr>
-              <a:t>Generated Tuesday, September 08, 2026 · 8:14 AM ET UNC Street Drug Analysis Lab · OpioidData.org · results.streetsafe.supply Download as PowerPoint</a:t>
+              <a:t>Generated Wednesday, September 09, 2026 · 8:25 AM ET UNC Street Drug Analysis Lab · OpioidData.org · results.streetsafe.supply Download as PowerPoint</a:t>
             </a:r>
           </a:p>
         </p:txBody>
@@ -2713,7 +2713,7 @@
                 <a:ea typeface="Helvetica Neue"/>
                 <a:sym typeface="Helvetica Neue"/>
               </a:rPr>
-              <a:t>PLACEHOLDER · figs/stats.json January 2022 to Wednesday, September 02, 2026 N = 2,786 NC samples analyzed Mailed in from 86 harm reduction programs Collected across 57 counties 244 distinct substances detected to date Unique samples = n_distinct(sampleid) · substances from lab_detail.substance · includes samples with date_complete 26 Jan 2022 – 02 Sep 2026 r/build_nightly.R → figs/stats.json</a:t>
+              <a:t>PLACEHOLDER · figs/stats.json January 2022 to Tuesday, September 08, 2026 N = 2,798 NC samples analyzed Mailed in from 86 harm reduction programs Collected across 58 counties 244 distinct substances detected to date Unique samples = n_distinct(sampleid) · substances from lab_detail.substance · includes samples with date_complete 26 Jan 2022 – 08 Sep 2026 r/build_nightly.R → figs/stats.json</a:t>
             </a:r>
           </a:p>
         </p:txBody>
@@ -2762,7 +2762,7 @@
                 <a:ea typeface="Helvetica Neue"/>
                 <a:sym typeface="Helvetica Neue"/>
               </a:rPr>
-              <a:t>Unique samples = n_distinct(sampleid) · substances from lab_detail.substance · includes samples with date_complete 26 Jan 2022 – 02 Sep 2026</a:t>
+              <a:t>Unique samples = n_distinct(sampleid) · substances from lab_detail.substance · includes samples with date_complete 26 Jan 2022 – 08 Sep 2026</a:t>
             </a:r>
           </a:p>
         </p:txBody>
@@ -3184,7 +3184,7 @@
                 <a:ea typeface="Helvetica Neue"/>
                 <a:sym typeface="Helvetica Neue"/>
               </a:rPr>
-              <a:t>County = samplecounty · left: ≥1 completed analysis ever · right: unique samples per county (sqrt color scale) · all time: 26 Jan 2022 – 02 Sep 2026 · last 12 months: 08 Sep 2025 – 02 Sep 2026* · coverage reflects participation, not prevalence</a:t>
+              <a:t>County = samplecounty · left: ≥1 completed analysis ever · right: unique samples per county (sqrt color scale) · all time: 26 Jan 2022 – 08 Sep 2026 · last 12 months: 09 Sep 2025 – 08 Sep 2026* · coverage reflects participation, not prevalence</a:t>
             </a:r>
           </a:p>
         </p:txBody>
@@ -3505,7 +3505,7 @@
                 <a:ea typeface="Helvetica Neue"/>
                 <a:sym typeface="Helvetica Neue"/>
               </a:rPr>
-              <a:t>expectedsubstance (verbatim card write-in, semicolon lists split) · derived flags: expect_opioid, expect_fentanyl, expect_meth, expect_cocaine, expect_stimulant… · includes samples with date_complete 26 Jan 2022 – 02 Sep 2026 · data table: Appendix A2</a:t>
+              <a:t>expectedsubstance (verbatim card write-in, semicolon lists split) · derived flags: expect_opioid, expect_fentanyl, expect_meth, expect_cocaine, expect_stimulant… · includes samples with date_complete 26 Jan 2022 – 08 Sep 2026 · data table: Appendix A2</a:t>
             </a:r>
           </a:p>
         </p:txBody>
@@ -3703,7 +3703,7 @@
                 <a:ea typeface="Helvetica Neue"/>
                 <a:sym typeface="Helvetica Neue"/>
               </a:rPr>
-              <a:t>Numerator uses lab_*_any (primary or trace) among samples with expect_* = 1 · includes samples with date_complete 26 Jan 2022 – 02 Sep 2026 · data table: Appendix A3</a:t>
+              <a:t>Numerator uses lab_*_any (primary or trace) among samples with expect_* = 1 · includes samples with date_complete 26 Jan 2022 – 08 Sep 2026 · data table: Appendix A3</a:t>
             </a:r>
           </a:p>
         </p:txBody>
@@ -3901,7 +3901,7 @@
                 <a:ea typeface="Helvetica Neue"/>
                 <a:sym typeface="Helvetica Neue"/>
               </a:rPr>
-              <a:t>sensations (circled on card, semicolon lists split) · post-consumption samples only (consumed = 1) · includes samples with date_complete 26 Jan 2022 – 02 Sep 2026</a:t>
+              <a:t>sensations (circled on card, semicolon lists split) · post-consumption samples only (consumed = 1) · includes samples with date_complete 26 Jan 2022 – 08 Sep 2026</a:t>
             </a:r>
           </a:p>
         </p:txBody>
@@ -4125,7 +4125,7 @@
                 <a:ea typeface="Helvetica Neue"/>
                 <a:sym typeface="Helvetica Neue"/>
               </a:rPr>
-              <a:t>sensations semicolon lists parsed per report · consumed = 1 only · denominator: consumed samples with lab_*_any = 1 · includes samples with date_complete 26 Jan 2022 – 02 Sep 2026</a:t>
+              <a:t>sensations semicolon lists parsed per report · consumed = 1 only · denominator: consumed samples with lab_*_any = 1 · includes samples with date_complete 26 Jan 2022 – 08 Sep 2026</a:t>
             </a:r>
           </a:p>
         </p:txBody>
@@ -4323,7 +4323,7 @@
                 <a:ea typeface="Helvetica Neue"/>
                 <a:sym typeface="Helvetica Neue"/>
               </a:rPr>
-              <a:t>Samples with methamphetamine or cocaine detected (any abundance); samples in both classes appear on both slides · sensations semicolon lists parsed + sen_strength (own denominator) · consumed = 1 only · before: 26 Jan 2022 – 02 Sep 2025 · past 12 months: 08 Sep 2025 – 02 Sep 2026* · Δ in percentage points</a:t>
+              <a:t>Samples with methamphetamine or cocaine detected (any abundance); samples in both classes appear on both slides · sensations semicolon lists parsed + sen_strength (own denominator) · consumed = 1 only · before: 26 Jan 2022 – 08 Sep 2025 · past 12 months: 09 Sep 2025 – 08 Sep 2026* · Δ in percentage points</a:t>
             </a:r>
           </a:p>
         </p:txBody>
@@ -4742,7 +4742,7 @@
                 <a:ea typeface="Helvetica Neue"/>
                 <a:sym typeface="Helvetica Neue"/>
               </a:rPr>
-              <a:t>Samples with an opioid (fentanyl, heroin) or benzodiazepine detected (any abundance); samples in both classes appear on both slides · sensations semicolon lists parsed + sen_strength (own denominator) · consumed = 1 only · before: 26 Jan 2022 – 02 Sep 2025 · past 12 months: 08 Sep 2025 – 02 Sep 2026* · Δ in percentage points</a:t>
+              <a:t>Samples with an opioid (fentanyl, heroin) or benzodiazepine detected (any abundance); samples in both classes appear on both slides · sensations semicolon lists parsed + sen_strength (own denominator) · consumed = 1 only · before: 26 Jan 2022 – 08 Sep 2025 · past 12 months: 09 Sep 2025 – 08 Sep 2026* · Δ in percentage points</a:t>
             </a:r>
           </a:p>
         </p:txBody>
@@ -5138,7 +5138,7 @@
                 <a:ea typeface="Helvetica Neue"/>
                 <a:sym typeface="Helvetica Neue"/>
               </a:rPr>
-              <a:t>color, texture (card v3+, semicolon lists split) · derived: bright_color excludes white/tan/brown family — orange bar above · includes samples with date_complete 26 Jan 2022 – 02 Sep 2026</a:t>
+              <a:t>color, texture (card v3+, semicolon lists split) · derived: bright_color excludes white/tan/brown family — orange bar above · includes samples with date_complete 26 Jan 2022 – 08 Sep 2026</a:t>
             </a:r>
           </a:p>
         </p:txBody>
@@ -5459,7 +5459,7 @@
                 <a:ea typeface="Helvetica Neue"/>
                 <a:sym typeface="Helvetica Neue"/>
               </a:rPr>
-              <a:t>Distribution of substances detected per sample, both definitions shown side by side · includes samples with date_complete 26 Jan 2022 – 02 Sep 2026</a:t>
+              <a:t>Distribution of substances detected per sample, both definitions shown side by side · includes samples with date_complete 26 Jan 2022 – 08 Sep 2026</a:t>
             </a:r>
           </a:p>
         </p:txBody>
@@ -5657,7 +5657,7 @@
                 <a:ea typeface="Helvetica Neue"/>
                 <a:sym typeface="Helvetica Neue"/>
               </a:rPr>
-              <a:t>lab_detail.substance counts · solid = primary abundance, light = trace · standardized names (PubChem-linked) · includes samples with date_complete 26 Jan 2022 – 02 Sep 2026</a:t>
+              <a:t>lab_detail.substance counts · solid = primary abundance, light = trace · standardized names (PubChem-linked) · includes samples with date_complete 26 Jan 2022 – 08 Sep 2026</a:t>
             </a:r>
           </a:p>
         </p:txBody>
@@ -5855,7 +5855,7 @@
                 <a:ea typeface="Helvetica Neue"/>
                 <a:sym typeface="Helvetica Neue"/>
               </a:rPr>
-              <a:t>lab_detail.substance counts · solid = primary abundance, light = trace · standardized names (PubChem-linked) · window: date_complete 08 Sep 2025 – 02 Sep 2026* (trailing 12 months, current month partial)</a:t>
+              <a:t>lab_detail.substance counts · solid = primary abundance, light = trace · standardized names (PubChem-linked) · window: date_complete 09 Sep 2025 – 08 Sep 2026* (trailing 12 months, current month partial)</a:t>
             </a:r>
           </a:p>
         </p:txBody>
@@ -6053,7 +6053,7 @@
                 <a:ea typeface="Helvetica Neue"/>
                 <a:sym typeface="Helvetica Neue"/>
               </a:rPr>
-              <a:t>Distribution of substances detected per sample, both definitions shown side by side · window: date_complete 08 Sep 2025 – 02 Sep 2026* (trailing 12 months, current month partial)</a:t>
+              <a:t>Distribution of substances detected per sample, both definitions shown side by side · window: date_complete 09 Sep 2025 – 08 Sep 2026* (trailing 12 months, current month partial)</a:t>
             </a:r>
           </a:p>
         </p:txBody>
@@ -18510,7 +18510,7 @@
                           <a:ea typeface="Helvetica Neue"/>
                           <a:sym typeface="Helvetica Neue"/>
                         </a:rPr>
-                        <a:t>1,424</a:t>
+                        <a:t>1,433</a:t>
                       </a:r>
                     </a:p>
                   </a:txBody>
@@ -18626,7 +18626,7 @@
                           <a:ea typeface="Helvetica Neue"/>
                           <a:sym typeface="Helvetica Neue"/>
                         </a:rPr>
-                        <a:t>433</a:t>
+                        <a:t>434</a:t>
                       </a:r>
                     </a:p>
                   </a:txBody>
@@ -19554,7 +19554,7 @@
                           <a:ea typeface="Helvetica Neue"/>
                           <a:sym typeface="Helvetica Neue"/>
                         </a:rPr>
-                        <a:t>50</a:t>
+                        <a:t>52</a:t>
                       </a:r>
                     </a:p>
                   </a:txBody>
@@ -20591,7 +20591,7 @@
                           <a:ea typeface="Helvetica Neue"/>
                           <a:sym typeface="Helvetica Neue"/>
                         </a:rPr>
-                        <a:t>1,634</a:t>
+                        <a:t>1,645</a:t>
                       </a:r>
                     </a:p>
                   </a:txBody>
@@ -20821,7 +20821,7 @@
                           <a:ea typeface="Helvetica Neue"/>
                           <a:sym typeface="Helvetica Neue"/>
                         </a:rPr>
-                        <a:t>497</a:t>
+                        <a:t>500</a:t>
                       </a:r>
                     </a:p>
                   </a:txBody>

</xml_diff>

<commit_message>
nightly deck: data through 2026-09-10
</commit_message>
<xml_diff>
--- a/docs/nc-drug-checking-latest.pptx
+++ b/docs/nc-drug-checking-latest.pptx
@@ -2418,7 +2418,7 @@
                 <a:ea typeface="Helvetica Neue"/>
                 <a:sym typeface="Helvetica Neue"/>
               </a:rPr>
-              <a:t>Generated Wednesday, September 09, 2026 · 8:25 AM ET UNC Street Drug Analysis Lab · OpioidData.org · results.streetsafe.supply Download as PowerPoint</a:t>
+              <a:t>Generated Thursday, September 10, 2026 · 8:20 AM ET UNC Street Drug Analysis Lab · OpioidData.org · results.streetsafe.supply Download as PowerPoint</a:t>
             </a:r>
           </a:p>
         </p:txBody>
@@ -3184,7 +3184,7 @@
                 <a:ea typeface="Helvetica Neue"/>
                 <a:sym typeface="Helvetica Neue"/>
               </a:rPr>
-              <a:t>County = samplecounty · left: ≥1 completed analysis ever · right: unique samples per county (sqrt color scale) · all time: 26 Jan 2022 – 08 Sep 2026 · last 12 months: 09 Sep 2025 – 08 Sep 2026* · coverage reflects participation, not prevalence</a:t>
+              <a:t>County = samplecounty · left: ≥1 completed analysis ever · right: unique samples per county (sqrt color scale) · all time: 26 Jan 2022 – 08 Sep 2026 · last 12 months: 10 Sep 2025 – 08 Sep 2026* · coverage reflects participation, not prevalence</a:t>
             </a:r>
           </a:p>
         </p:txBody>
@@ -4323,7 +4323,7 @@
                 <a:ea typeface="Helvetica Neue"/>
                 <a:sym typeface="Helvetica Neue"/>
               </a:rPr>
-              <a:t>Samples with methamphetamine or cocaine detected (any abundance); samples in both classes appear on both slides · sensations semicolon lists parsed + sen_strength (own denominator) · consumed = 1 only · before: 26 Jan 2022 – 08 Sep 2025 · past 12 months: 09 Sep 2025 – 08 Sep 2026* · Δ in percentage points</a:t>
+              <a:t>Samples with methamphetamine or cocaine detected (any abundance); samples in both classes appear on both slides · sensations semicolon lists parsed + sen_strength (own denominator) · consumed = 1 only · before: 26 Jan 2022 – 08 Sep 2025 · past 12 months: 10 Sep 2025 – 08 Sep 2026* · Δ in percentage points</a:t>
             </a:r>
           </a:p>
         </p:txBody>
@@ -4742,7 +4742,7 @@
                 <a:ea typeface="Helvetica Neue"/>
                 <a:sym typeface="Helvetica Neue"/>
               </a:rPr>
-              <a:t>Samples with an opioid (fentanyl, heroin) or benzodiazepine detected (any abundance); samples in both classes appear on both slides · sensations semicolon lists parsed + sen_strength (own denominator) · consumed = 1 only · before: 26 Jan 2022 – 08 Sep 2025 · past 12 months: 09 Sep 2025 – 08 Sep 2026* · Δ in percentage points</a:t>
+              <a:t>Samples with an opioid (fentanyl, heroin) or benzodiazepine detected (any abundance); samples in both classes appear on both slides · sensations semicolon lists parsed + sen_strength (own denominator) · consumed = 1 only · before: 26 Jan 2022 – 08 Sep 2025 · past 12 months: 10 Sep 2025 – 08 Sep 2026* · Δ in percentage points</a:t>
             </a:r>
           </a:p>
         </p:txBody>
@@ -5855,7 +5855,7 @@
                 <a:ea typeface="Helvetica Neue"/>
                 <a:sym typeface="Helvetica Neue"/>
               </a:rPr>
-              <a:t>lab_detail.substance counts · solid = primary abundance, light = trace · standardized names (PubChem-linked) · window: date_complete 09 Sep 2025 – 08 Sep 2026* (trailing 12 months, current month partial)</a:t>
+              <a:t>lab_detail.substance counts · solid = primary abundance, light = trace · standardized names (PubChem-linked) · window: date_complete 10 Sep 2025 – 08 Sep 2026* (trailing 12 months, current month partial)</a:t>
             </a:r>
           </a:p>
         </p:txBody>
@@ -6053,7 +6053,7 @@
                 <a:ea typeface="Helvetica Neue"/>
                 <a:sym typeface="Helvetica Neue"/>
               </a:rPr>
-              <a:t>Distribution of substances detected per sample, both definitions shown side by side · window: date_complete 09 Sep 2025 – 08 Sep 2026* (trailing 12 months, current month partial)</a:t>
+              <a:t>Distribution of substances detected per sample, both definitions shown side by side · window: date_complete 10 Sep 2025 – 08 Sep 2026* (trailing 12 months, current month partial)</a:t>
             </a:r>
           </a:p>
         </p:txBody>

</xml_diff>

<commit_message>
nightly deck: data through 2026-09-11
</commit_message>
<xml_diff>
--- a/docs/nc-drug-checking-latest.pptx
+++ b/docs/nc-drug-checking-latest.pptx
@@ -2418,7 +2418,7 @@
                 <a:ea typeface="Helvetica Neue"/>
                 <a:sym typeface="Helvetica Neue"/>
               </a:rPr>
-              <a:t>Generated Thursday, September 10, 2026 · 8:20 AM ET UNC Street Drug Analysis Lab · OpioidData.org · results.streetsafe.supply Download as PowerPoint</a:t>
+              <a:t>Generated Friday, September 11, 2026 · 8:17 AM ET UNC Street Drug Analysis Lab · OpioidData.org · results.streetsafe.supply Download as PowerPoint</a:t>
             </a:r>
           </a:p>
         </p:txBody>
@@ -3184,7 +3184,7 @@
                 <a:ea typeface="Helvetica Neue"/>
                 <a:sym typeface="Helvetica Neue"/>
               </a:rPr>
-              <a:t>County = samplecounty · left: ≥1 completed analysis ever · right: unique samples per county (sqrt color scale) · all time: 26 Jan 2022 – 08 Sep 2026 · last 12 months: 10 Sep 2025 – 08 Sep 2026* · coverage reflects participation, not prevalence</a:t>
+              <a:t>County = samplecounty · left: ≥1 completed analysis ever · right: unique samples per county (sqrt color scale) · all time: 26 Jan 2022 – 08 Sep 2026 · last 12 months: 11 Sep 2025 – 08 Sep 2026* · coverage reflects participation, not prevalence</a:t>
             </a:r>
           </a:p>
         </p:txBody>
@@ -4323,7 +4323,7 @@
                 <a:ea typeface="Helvetica Neue"/>
                 <a:sym typeface="Helvetica Neue"/>
               </a:rPr>
-              <a:t>Samples with methamphetamine or cocaine detected (any abundance); samples in both classes appear on both slides · sensations semicolon lists parsed + sen_strength (own denominator) · consumed = 1 only · before: 26 Jan 2022 – 08 Sep 2025 · past 12 months: 10 Sep 2025 – 08 Sep 2026* · Δ in percentage points</a:t>
+              <a:t>Samples with methamphetamine or cocaine detected (any abundance); samples in both classes appear on both slides · sensations semicolon lists parsed + sen_strength (own denominator) · consumed = 1 only · before: 26 Jan 2022 – 08 Sep 2025 · past 12 months: 11 Sep 2025 – 08 Sep 2026* · Δ in percentage points</a:t>
             </a:r>
           </a:p>
         </p:txBody>
@@ -4742,7 +4742,7 @@
                 <a:ea typeface="Helvetica Neue"/>
                 <a:sym typeface="Helvetica Neue"/>
               </a:rPr>
-              <a:t>Samples with an opioid (fentanyl, heroin) or benzodiazepine detected (any abundance); samples in both classes appear on both slides · sensations semicolon lists parsed + sen_strength (own denominator) · consumed = 1 only · before: 26 Jan 2022 – 08 Sep 2025 · past 12 months: 10 Sep 2025 – 08 Sep 2026* · Δ in percentage points</a:t>
+              <a:t>Samples with an opioid (fentanyl, heroin) or benzodiazepine detected (any abundance); samples in both classes appear on both slides · sensations semicolon lists parsed + sen_strength (own denominator) · consumed = 1 only · before: 26 Jan 2022 – 08 Sep 2025 · past 12 months: 11 Sep 2025 – 08 Sep 2026* · Δ in percentage points</a:t>
             </a:r>
           </a:p>
         </p:txBody>
@@ -5855,7 +5855,7 @@
                 <a:ea typeface="Helvetica Neue"/>
                 <a:sym typeface="Helvetica Neue"/>
               </a:rPr>
-              <a:t>lab_detail.substance counts · solid = primary abundance, light = trace · standardized names (PubChem-linked) · window: date_complete 10 Sep 2025 – 08 Sep 2026* (trailing 12 months, current month partial)</a:t>
+              <a:t>lab_detail.substance counts · solid = primary abundance, light = trace · standardized names (PubChem-linked) · window: date_complete 11 Sep 2025 – 08 Sep 2026* (trailing 12 months, current month partial)</a:t>
             </a:r>
           </a:p>
         </p:txBody>
@@ -6053,7 +6053,7 @@
                 <a:ea typeface="Helvetica Neue"/>
                 <a:sym typeface="Helvetica Neue"/>
               </a:rPr>
-              <a:t>Distribution of substances detected per sample, both definitions shown side by side · window: date_complete 10 Sep 2025 – 08 Sep 2026* (trailing 12 months, current month partial)</a:t>
+              <a:t>Distribution of substances detected per sample, both definitions shown side by side · window: date_complete 11 Sep 2025 – 08 Sep 2026* (trailing 12 months, current month partial)</a:t>
             </a:r>
           </a:p>
         </p:txBody>
@@ -14206,7 +14206,7 @@
                           <a:ea typeface="Helvetica Neue"/>
                           <a:sym typeface="Helvetica Neue"/>
                         </a:rPr>
-                        <a:t>2-fluoro-2-oxo-PCPr</a:t>
+                        <a:t>2-fluoro-2-oxo-PCiPr</a:t>
                       </a:r>
                     </a:p>
                   </a:txBody>
@@ -28099,7 +28099,7 @@
                           <a:ea typeface="Helvetica Neue"/>
                           <a:sym typeface="Helvetica Neue"/>
                         </a:rPr>
-                        <a:t>2-fluoro-2-oxo-PCPr</a:t>
+                        <a:t>2-fluoro-2-oxo-PCiPr</a:t>
                       </a:r>
                     </a:p>
                   </a:txBody>

</xml_diff>

<commit_message>
nightly deck: data through 2026-09-12
</commit_message>
<xml_diff>
--- a/docs/nc-drug-checking-latest.pptx
+++ b/docs/nc-drug-checking-latest.pptx
@@ -2418,7 +2418,7 @@
                 <a:ea typeface="Helvetica Neue"/>
                 <a:sym typeface="Helvetica Neue"/>
               </a:rPr>
-              <a:t>Generated Friday, September 11, 2026 · 8:17 AM ET UNC Street Drug Analysis Lab · OpioidData.org · results.streetsafe.supply Download as PowerPoint</a:t>
+              <a:t>Generated Saturday, September 12, 2026 · 7:41 AM ET UNC Street Drug Analysis Lab · OpioidData.org · results.streetsafe.supply Download as PowerPoint</a:t>
             </a:r>
           </a:p>
         </p:txBody>
@@ -3184,7 +3184,7 @@
                 <a:ea typeface="Helvetica Neue"/>
                 <a:sym typeface="Helvetica Neue"/>
               </a:rPr>
-              <a:t>County = samplecounty · left: ≥1 completed analysis ever · right: unique samples per county (sqrt color scale) · all time: 26 Jan 2022 – 08 Sep 2026 · last 12 months: 11 Sep 2025 – 08 Sep 2026* · coverage reflects participation, not prevalence</a:t>
+              <a:t>County = samplecounty · left: ≥1 completed analysis ever · right: unique samples per county (sqrt color scale) · all time: 26 Jan 2022 – 08 Sep 2026 · last 12 months: 12 Sep 2025 – 08 Sep 2026* · coverage reflects participation, not prevalence</a:t>
             </a:r>
           </a:p>
         </p:txBody>
@@ -4323,7 +4323,7 @@
                 <a:ea typeface="Helvetica Neue"/>
                 <a:sym typeface="Helvetica Neue"/>
               </a:rPr>
-              <a:t>Samples with methamphetamine or cocaine detected (any abundance); samples in both classes appear on both slides · sensations semicolon lists parsed + sen_strength (own denominator) · consumed = 1 only · before: 26 Jan 2022 – 08 Sep 2025 · past 12 months: 11 Sep 2025 – 08 Sep 2026* · Δ in percentage points</a:t>
+              <a:t>Samples with methamphetamine or cocaine detected (any abundance); samples in both classes appear on both slides · sensations semicolon lists parsed + sen_strength (own denominator) · consumed = 1 only · before: 26 Jan 2022 – 08 Sep 2025 · past 12 months: 12 Sep 2025 – 08 Sep 2026* · Δ in percentage points</a:t>
             </a:r>
           </a:p>
         </p:txBody>
@@ -4742,7 +4742,7 @@
                 <a:ea typeface="Helvetica Neue"/>
                 <a:sym typeface="Helvetica Neue"/>
               </a:rPr>
-              <a:t>Samples with an opioid (fentanyl, heroin) or benzodiazepine detected (any abundance); samples in both classes appear on both slides · sensations semicolon lists parsed + sen_strength (own denominator) · consumed = 1 only · before: 26 Jan 2022 – 08 Sep 2025 · past 12 months: 11 Sep 2025 – 08 Sep 2026* · Δ in percentage points</a:t>
+              <a:t>Samples with an opioid (fentanyl, heroin) or benzodiazepine detected (any abundance); samples in both classes appear on both slides · sensations semicolon lists parsed + sen_strength (own denominator) · consumed = 1 only · before: 26 Jan 2022 – 08 Sep 2025 · past 12 months: 12 Sep 2025 – 08 Sep 2026* · Δ in percentage points</a:t>
             </a:r>
           </a:p>
         </p:txBody>
@@ -5855,7 +5855,7 @@
                 <a:ea typeface="Helvetica Neue"/>
                 <a:sym typeface="Helvetica Neue"/>
               </a:rPr>
-              <a:t>lab_detail.substance counts · solid = primary abundance, light = trace · standardized names (PubChem-linked) · window: date_complete 11 Sep 2025 – 08 Sep 2026* (trailing 12 months, current month partial)</a:t>
+              <a:t>lab_detail.substance counts · solid = primary abundance, light = trace · standardized names (PubChem-linked) · window: date_complete 12 Sep 2025 – 08 Sep 2026* (trailing 12 months, current month partial)</a:t>
             </a:r>
           </a:p>
         </p:txBody>
@@ -6053,7 +6053,7 @@
                 <a:ea typeface="Helvetica Neue"/>
                 <a:sym typeface="Helvetica Neue"/>
               </a:rPr>
-              <a:t>Distribution of substances detected per sample, both definitions shown side by side · window: date_complete 11 Sep 2025 – 08 Sep 2026* (trailing 12 months, current month partial)</a:t>
+              <a:t>Distribution of substances detected per sample, both definitions shown side by side · window: date_complete 12 Sep 2025 – 08 Sep 2026* (trailing 12 months, current month partial)</a:t>
             </a:r>
           </a:p>
         </p:txBody>

</xml_diff>

<commit_message>
nightly deck: data through 2026-09-13
</commit_message>
<xml_diff>
--- a/docs/nc-drug-checking-latest.pptx
+++ b/docs/nc-drug-checking-latest.pptx
@@ -2418,7 +2418,7 @@
                 <a:ea typeface="Helvetica Neue"/>
                 <a:sym typeface="Helvetica Neue"/>
               </a:rPr>
-              <a:t>Generated Saturday, September 12, 2026 · 7:41 AM ET UNC Street Drug Analysis Lab · OpioidData.org · results.streetsafe.supply Download as PowerPoint</a:t>
+              <a:t>Generated Sunday, September 13, 2026 · 8:48 AM ET UNC Street Drug Analysis Lab · OpioidData.org · results.streetsafe.supply Download as PowerPoint</a:t>
             </a:r>
           </a:p>
         </p:txBody>
@@ -3184,7 +3184,7 @@
                 <a:ea typeface="Helvetica Neue"/>
                 <a:sym typeface="Helvetica Neue"/>
               </a:rPr>
-              <a:t>County = samplecounty · left: ≥1 completed analysis ever · right: unique samples per county (sqrt color scale) · all time: 26 Jan 2022 – 08 Sep 2026 · last 12 months: 12 Sep 2025 – 08 Sep 2026* · coverage reflects participation, not prevalence</a:t>
+              <a:t>County = samplecounty · left: ≥1 completed analysis ever · right: unique samples per county (sqrt color scale) · all time: 26 Jan 2022 – 08 Sep 2026 · last 12 months: 13 Sep 2025 – 08 Sep 2026* · coverage reflects participation, not prevalence</a:t>
             </a:r>
           </a:p>
         </p:txBody>
@@ -4323,7 +4323,7 @@
                 <a:ea typeface="Helvetica Neue"/>
                 <a:sym typeface="Helvetica Neue"/>
               </a:rPr>
-              <a:t>Samples with methamphetamine or cocaine detected (any abundance); samples in both classes appear on both slides · sensations semicolon lists parsed + sen_strength (own denominator) · consumed = 1 only · before: 26 Jan 2022 – 08 Sep 2025 · past 12 months: 12 Sep 2025 – 08 Sep 2026* · Δ in percentage points</a:t>
+              <a:t>Samples with methamphetamine or cocaine detected (any abundance); samples in both classes appear on both slides · sensations semicolon lists parsed + sen_strength (own denominator) · consumed = 1 only · before: 26 Jan 2022 – 08 Sep 2025 · past 12 months: 13 Sep 2025 – 08 Sep 2026* · Δ in percentage points</a:t>
             </a:r>
           </a:p>
         </p:txBody>
@@ -4742,7 +4742,7 @@
                 <a:ea typeface="Helvetica Neue"/>
                 <a:sym typeface="Helvetica Neue"/>
               </a:rPr>
-              <a:t>Samples with an opioid (fentanyl, heroin) or benzodiazepine detected (any abundance); samples in both classes appear on both slides · sensations semicolon lists parsed + sen_strength (own denominator) · consumed = 1 only · before: 26 Jan 2022 – 08 Sep 2025 · past 12 months: 12 Sep 2025 – 08 Sep 2026* · Δ in percentage points</a:t>
+              <a:t>Samples with an opioid (fentanyl, heroin) or benzodiazepine detected (any abundance); samples in both classes appear on both slides · sensations semicolon lists parsed + sen_strength (own denominator) · consumed = 1 only · before: 26 Jan 2022 – 08 Sep 2025 · past 12 months: 13 Sep 2025 – 08 Sep 2026* · Δ in percentage points</a:t>
             </a:r>
           </a:p>
         </p:txBody>
@@ -5855,7 +5855,7 @@
                 <a:ea typeface="Helvetica Neue"/>
                 <a:sym typeface="Helvetica Neue"/>
               </a:rPr>
-              <a:t>lab_detail.substance counts · solid = primary abundance, light = trace · standardized names (PubChem-linked) · window: date_complete 12 Sep 2025 – 08 Sep 2026* (trailing 12 months, current month partial)</a:t>
+              <a:t>lab_detail.substance counts · solid = primary abundance, light = trace · standardized names (PubChem-linked) · window: date_complete 13 Sep 2025 – 08 Sep 2026* (trailing 12 months, current month partial)</a:t>
             </a:r>
           </a:p>
         </p:txBody>
@@ -6053,7 +6053,7 @@
                 <a:ea typeface="Helvetica Neue"/>
                 <a:sym typeface="Helvetica Neue"/>
               </a:rPr>
-              <a:t>Distribution of substances detected per sample, both definitions shown side by side · window: date_complete 12 Sep 2025 – 08 Sep 2026* (trailing 12 months, current month partial)</a:t>
+              <a:t>Distribution of substances detected per sample, both definitions shown side by side · window: date_complete 13 Sep 2025 – 08 Sep 2026* (trailing 12 months, current month partial)</a:t>
             </a:r>
           </a:p>
         </p:txBody>

</xml_diff>

<commit_message>
nightly deck: data through 2026-09-14
</commit_message>
<xml_diff>
--- a/docs/nc-drug-checking-latest.pptx
+++ b/docs/nc-drug-checking-latest.pptx
@@ -2418,7 +2418,7 @@
                 <a:ea typeface="Helvetica Neue"/>
                 <a:sym typeface="Helvetica Neue"/>
               </a:rPr>
-              <a:t>Generated Sunday, September 13, 2026 · 8:48 AM ET UNC Street Drug Analysis Lab · OpioidData.org · results.streetsafe.supply Download as PowerPoint</a:t>
+              <a:t>Generated Monday, September 14, 2026 · 10:18 AM ET UNC Street Drug Analysis Lab · OpioidData.org · results.streetsafe.supply Download as PowerPoint</a:t>
             </a:r>
           </a:p>
         </p:txBody>
@@ -2713,7 +2713,7 @@
                 <a:ea typeface="Helvetica Neue"/>
                 <a:sym typeface="Helvetica Neue"/>
               </a:rPr>
-              <a:t>PLACEHOLDER · figs/stats.json January 2022 to Tuesday, September 08, 2026 N = 2,798 NC samples analyzed Mailed in from 86 harm reduction programs Collected across 58 counties 244 distinct substances detected to date Unique samples = n_distinct(sampleid) · substances from lab_detail.substance · includes samples with date_complete 26 Jan 2022 – 08 Sep 2026 r/build_nightly.R → figs/stats.json</a:t>
+              <a:t>PLACEHOLDER · figs/stats.json January 2022 to Monday, September 14, 2026 N = 2,799 NC samples analyzed Mailed in from 86 harm reduction programs Collected across 58 counties 245 distinct substances detected to date Unique samples = n_distinct(sampleid) · substances from lab_detail.substance · includes samples with date_complete 26 Jan 2022 – 14 Sep 2026 r/build_nightly.R → figs/stats.json</a:t>
             </a:r>
           </a:p>
         </p:txBody>
@@ -2762,7 +2762,7 @@
                 <a:ea typeface="Helvetica Neue"/>
                 <a:sym typeface="Helvetica Neue"/>
               </a:rPr>
-              <a:t>Unique samples = n_distinct(sampleid) · substances from lab_detail.substance · includes samples with date_complete 26 Jan 2022 – 08 Sep 2026</a:t>
+              <a:t>Unique samples = n_distinct(sampleid) · substances from lab_detail.substance · includes samples with date_complete 26 Jan 2022 – 14 Sep 2026</a:t>
             </a:r>
           </a:p>
         </p:txBody>
@@ -3184,7 +3184,7 @@
                 <a:ea typeface="Helvetica Neue"/>
                 <a:sym typeface="Helvetica Neue"/>
               </a:rPr>
-              <a:t>County = samplecounty · left: ≥1 completed analysis ever · right: unique samples per county (sqrt color scale) · all time: 26 Jan 2022 – 08 Sep 2026 · last 12 months: 13 Sep 2025 – 08 Sep 2026* · coverage reflects participation, not prevalence</a:t>
+              <a:t>County = samplecounty · left: ≥1 completed analysis ever · right: unique samples per county (sqrt color scale) · all time: 26 Jan 2022 – 14 Sep 2026 · last 12 months: 14 Sep 2025 – 14 Sep 2026* · coverage reflects participation, not prevalence</a:t>
             </a:r>
           </a:p>
         </p:txBody>
@@ -3505,7 +3505,7 @@
                 <a:ea typeface="Helvetica Neue"/>
                 <a:sym typeface="Helvetica Neue"/>
               </a:rPr>
-              <a:t>expectedsubstance (verbatim card write-in, semicolon lists split) · derived flags: expect_opioid, expect_fentanyl, expect_meth, expect_cocaine, expect_stimulant… · includes samples with date_complete 26 Jan 2022 – 08 Sep 2026 · data table: Appendix A2</a:t>
+              <a:t>expectedsubstance (verbatim card write-in, semicolon lists split) · derived flags: expect_opioid, expect_fentanyl, expect_meth, expect_cocaine, expect_stimulant… · includes samples with date_complete 26 Jan 2022 – 14 Sep 2026 · data table: Appendix A2</a:t>
             </a:r>
           </a:p>
         </p:txBody>
@@ -3703,7 +3703,7 @@
                 <a:ea typeface="Helvetica Neue"/>
                 <a:sym typeface="Helvetica Neue"/>
               </a:rPr>
-              <a:t>Numerator uses lab_*_any (primary or trace) among samples with expect_* = 1 · includes samples with date_complete 26 Jan 2022 – 08 Sep 2026 · data table: Appendix A3</a:t>
+              <a:t>Numerator uses lab_*_any (primary or trace) among samples with expect_* = 1 · includes samples with date_complete 26 Jan 2022 – 14 Sep 2026 · data table: Appendix A3</a:t>
             </a:r>
           </a:p>
         </p:txBody>
@@ -3901,7 +3901,7 @@
                 <a:ea typeface="Helvetica Neue"/>
                 <a:sym typeface="Helvetica Neue"/>
               </a:rPr>
-              <a:t>sensations (circled on card, semicolon lists split) · post-consumption samples only (consumed = 1) · includes samples with date_complete 26 Jan 2022 – 08 Sep 2026</a:t>
+              <a:t>sensations (circled on card, semicolon lists split) · post-consumption samples only (consumed = 1) · includes samples with date_complete 26 Jan 2022 – 14 Sep 2026</a:t>
             </a:r>
           </a:p>
         </p:txBody>
@@ -4125,7 +4125,7 @@
                 <a:ea typeface="Helvetica Neue"/>
                 <a:sym typeface="Helvetica Neue"/>
               </a:rPr>
-              <a:t>sensations semicolon lists parsed per report · consumed = 1 only · denominator: consumed samples with lab_*_any = 1 · includes samples with date_complete 26 Jan 2022 – 08 Sep 2026</a:t>
+              <a:t>sensations semicolon lists parsed per report · consumed = 1 only · denominator: consumed samples with lab_*_any = 1 · includes samples with date_complete 26 Jan 2022 – 14 Sep 2026</a:t>
             </a:r>
           </a:p>
         </p:txBody>
@@ -4323,7 +4323,7 @@
                 <a:ea typeface="Helvetica Neue"/>
                 <a:sym typeface="Helvetica Neue"/>
               </a:rPr>
-              <a:t>Samples with methamphetamine or cocaine detected (any abundance); samples in both classes appear on both slides · sensations semicolon lists parsed + sen_strength (own denominator) · consumed = 1 only · before: 26 Jan 2022 – 08 Sep 2025 · past 12 months: 13 Sep 2025 – 08 Sep 2026* · Δ in percentage points</a:t>
+              <a:t>Samples with methamphetamine or cocaine detected (any abundance); samples in both classes appear on both slides · sensations semicolon lists parsed + sen_strength (own denominator) · consumed = 1 only · before: 26 Jan 2022 – 14 Sep 2025 · past 12 months: 14 Sep 2025 – 14 Sep 2026* · Δ in percentage points</a:t>
             </a:r>
           </a:p>
         </p:txBody>
@@ -4742,7 +4742,7 @@
                 <a:ea typeface="Helvetica Neue"/>
                 <a:sym typeface="Helvetica Neue"/>
               </a:rPr>
-              <a:t>Samples with an opioid (fentanyl, heroin) or benzodiazepine detected (any abundance); samples in both classes appear on both slides · sensations semicolon lists parsed + sen_strength (own denominator) · consumed = 1 only · before: 26 Jan 2022 – 08 Sep 2025 · past 12 months: 13 Sep 2025 – 08 Sep 2026* · Δ in percentage points</a:t>
+              <a:t>Samples with an opioid (fentanyl, heroin) or benzodiazepine detected (any abundance); samples in both classes appear on both slides · sensations semicolon lists parsed + sen_strength (own denominator) · consumed = 1 only · before: 26 Jan 2022 – 14 Sep 2025 · past 12 months: 14 Sep 2025 – 14 Sep 2026* · Δ in percentage points</a:t>
             </a:r>
           </a:p>
         </p:txBody>
@@ -5138,7 +5138,7 @@
                 <a:ea typeface="Helvetica Neue"/>
                 <a:sym typeface="Helvetica Neue"/>
               </a:rPr>
-              <a:t>color, texture (card v3+, semicolon lists split) · derived: bright_color excludes white/tan/brown family — orange bar above · includes samples with date_complete 26 Jan 2022 – 08 Sep 2026</a:t>
+              <a:t>color, texture (card v3+, semicolon lists split) · derived: bright_color excludes white/tan/brown family — orange bar above · includes samples with date_complete 26 Jan 2022 – 14 Sep 2026</a:t>
             </a:r>
           </a:p>
         </p:txBody>
@@ -5459,7 +5459,7 @@
                 <a:ea typeface="Helvetica Neue"/>
                 <a:sym typeface="Helvetica Neue"/>
               </a:rPr>
-              <a:t>Distribution of substances detected per sample, both definitions shown side by side · includes samples with date_complete 26 Jan 2022 – 08 Sep 2026</a:t>
+              <a:t>Distribution of substances detected per sample, both definitions shown side by side · includes samples with date_complete 26 Jan 2022 – 14 Sep 2026</a:t>
             </a:r>
           </a:p>
         </p:txBody>
@@ -5657,7 +5657,7 @@
                 <a:ea typeface="Helvetica Neue"/>
                 <a:sym typeface="Helvetica Neue"/>
               </a:rPr>
-              <a:t>lab_detail.substance counts · solid = primary abundance, light = trace · standardized names (PubChem-linked) · includes samples with date_complete 26 Jan 2022 – 08 Sep 2026</a:t>
+              <a:t>lab_detail.substance counts · solid = primary abundance, light = trace · standardized names (PubChem-linked) · includes samples with date_complete 26 Jan 2022 – 14 Sep 2026</a:t>
             </a:r>
           </a:p>
         </p:txBody>
@@ -5855,7 +5855,7 @@
                 <a:ea typeface="Helvetica Neue"/>
                 <a:sym typeface="Helvetica Neue"/>
               </a:rPr>
-              <a:t>lab_detail.substance counts · solid = primary abundance, light = trace · standardized names (PubChem-linked) · window: date_complete 13 Sep 2025 – 08 Sep 2026* (trailing 12 months, current month partial)</a:t>
+              <a:t>lab_detail.substance counts · solid = primary abundance, light = trace · standardized names (PubChem-linked) · window: date_complete 14 Sep 2025 – 14 Sep 2026* (trailing 12 months, current month partial)</a:t>
             </a:r>
           </a:p>
         </p:txBody>
@@ -6053,7 +6053,7 @@
                 <a:ea typeface="Helvetica Neue"/>
                 <a:sym typeface="Helvetica Neue"/>
               </a:rPr>
-              <a:t>Distribution of substances detected per sample, both definitions shown side by side · window: date_complete 13 Sep 2025 – 08 Sep 2026* (trailing 12 months, current month partial)</a:t>
+              <a:t>Distribution of substances detected per sample, both definitions shown side by side · window: date_complete 14 Sep 2025 – 14 Sep 2026* (trailing 12 months, current month partial)</a:t>
             </a:r>
           </a:p>
         </p:txBody>
@@ -11049,6 +11049,293 @@
                           <a:ea typeface="Helvetica Neue"/>
                           <a:sym typeface="Helvetica Neue"/>
                         </a:rPr>
+                        <a:t>SR 17018</a:t>
+                      </a:r>
+                    </a:p>
+                  </a:txBody>
+                  <a:tcPr anchor="ctr" marB="63500" marT="63500" marR="0" marL="0">
+                    <a:lnL algn="ctr" cmpd="sng" cap="flat" w="0">
+                      <a:noFill/>
+                      <a:prstDash val="solid"/>
+                    </a:lnL>
+                    <a:lnR algn="ctr" cmpd="sng" cap="flat" w="0">
+                      <a:noFill/>
+                      <a:prstDash val="solid"/>
+                    </a:lnR>
+                    <a:lnT algn="ctr" cmpd="sng" cap="flat" w="0">
+                      <a:noFill/>
+                      <a:prstDash val="solid"/>
+                    </a:lnT>
+                    <a:lnB algn="ctr" cmpd="sng" cap="flat" w="0">
+                      <a:noFill/>
+                      <a:prstDash val="solid"/>
+                    </a:lnB>
+                    <a:solidFill>
+                      <a:srgbClr val="FFFFFF">
+                        <a:alpha val="0"/>
+                      </a:srgbClr>
+                    </a:solidFill>
+                  </a:tcPr>
+                </a:tc>
+                <a:tc>
+                  <a:txBody>
+                    <a:bodyPr/>
+                    <a:lstStyle/>
+                    <a:p>
+                      <a:pPr algn="l" marL="63500" marR="63500">
+                        <a:lnSpc>
+                          <a:spcPct val="100000"/>
+                        </a:lnSpc>
+                        <a:spcBef>
+                          <a:spcPts val="500"/>
+                        </a:spcBef>
+                        <a:spcAft>
+                          <a:spcPts val="500"/>
+                        </a:spcAft>
+                        <a:buNone/>
+                      </a:pPr>
+                      <a:r>
+                        <a:rPr cap="none" sz="1200" i="0" b="0" u="none" strike="noStrike">
+                          <a:solidFill>
+                            <a:srgbClr val="5B6770">
+                              <a:alpha val="100000"/>
+                            </a:srgbClr>
+                          </a:solidFill>
+                          <a:latin typeface="Helvetica Neue"/>
+                          <a:cs typeface="Helvetica Neue"/>
+                          <a:ea typeface="Helvetica Neue"/>
+                          <a:sym typeface="Helvetica Neue"/>
+                        </a:rPr>
+                        <a:t>14 Sep 2026</a:t>
+                      </a:r>
+                    </a:p>
+                  </a:txBody>
+                  <a:tcPr anchor="ctr" marB="63500" marT="63500" marR="0" marL="0">
+                    <a:lnL algn="ctr" cmpd="sng" cap="flat" w="0">
+                      <a:noFill/>
+                      <a:prstDash val="solid"/>
+                    </a:lnL>
+                    <a:lnR algn="ctr" cmpd="sng" cap="flat" w="0">
+                      <a:noFill/>
+                      <a:prstDash val="solid"/>
+                    </a:lnR>
+                    <a:lnT algn="ctr" cmpd="sng" cap="flat" w="0">
+                      <a:noFill/>
+                      <a:prstDash val="solid"/>
+                    </a:lnT>
+                    <a:lnB algn="ctr" cmpd="sng" cap="flat" w="0">
+                      <a:noFill/>
+                      <a:prstDash val="solid"/>
+                    </a:lnB>
+                    <a:solidFill>
+                      <a:srgbClr val="FFFFFF">
+                        <a:alpha val="0"/>
+                      </a:srgbClr>
+                    </a:solidFill>
+                  </a:tcPr>
+                </a:tc>
+                <a:tc>
+                  <a:txBody>
+                    <a:bodyPr/>
+                    <a:lstStyle/>
+                    <a:p>
+                      <a:pPr algn="l" marL="63500" marR="63500">
+                        <a:lnSpc>
+                          <a:spcPct val="100000"/>
+                        </a:lnSpc>
+                        <a:spcBef>
+                          <a:spcPts val="500"/>
+                        </a:spcBef>
+                        <a:spcAft>
+                          <a:spcPts val="500"/>
+                        </a:spcAft>
+                        <a:buNone/>
+                      </a:pPr>
+                      <a:r>
+                        <a:rPr cap="none" sz="1200" i="0" b="0" u="none" strike="noStrike">
+                          <a:solidFill>
+                            <a:srgbClr val="5B6770">
+                              <a:alpha val="100000"/>
+                            </a:srgbClr>
+                          </a:solidFill>
+                          <a:latin typeface="Helvetica Neue"/>
+                          <a:cs typeface="Helvetica Neue"/>
+                          <a:ea typeface="Helvetica Neue"/>
+                          <a:sym typeface="Helvetica Neue"/>
+                        </a:rPr>
+                        <a:t>primary</a:t>
+                      </a:r>
+                    </a:p>
+                  </a:txBody>
+                  <a:tcPr anchor="ctr" marB="63500" marT="63500" marR="0" marL="0">
+                    <a:lnL algn="ctr" cmpd="sng" cap="flat" w="0">
+                      <a:noFill/>
+                      <a:prstDash val="solid"/>
+                    </a:lnL>
+                    <a:lnR algn="ctr" cmpd="sng" cap="flat" w="0">
+                      <a:noFill/>
+                      <a:prstDash val="solid"/>
+                    </a:lnR>
+                    <a:lnT algn="ctr" cmpd="sng" cap="flat" w="0">
+                      <a:noFill/>
+                      <a:prstDash val="solid"/>
+                    </a:lnT>
+                    <a:lnB algn="ctr" cmpd="sng" cap="flat" w="0">
+                      <a:noFill/>
+                      <a:prstDash val="solid"/>
+                    </a:lnB>
+                    <a:solidFill>
+                      <a:srgbClr val="FFFFFF">
+                        <a:alpha val="0"/>
+                      </a:srgbClr>
+                    </a:solidFill>
+                  </a:tcPr>
+                </a:tc>
+                <a:tc>
+                  <a:txBody>
+                    <a:bodyPr/>
+                    <a:lstStyle/>
+                    <a:p>
+                      <a:pPr algn="r" marL="63500" marR="63500">
+                        <a:lnSpc>
+                          <a:spcPct val="100000"/>
+                        </a:lnSpc>
+                        <a:spcBef>
+                          <a:spcPts val="500"/>
+                        </a:spcBef>
+                        <a:spcAft>
+                          <a:spcPts val="500"/>
+                        </a:spcAft>
+                        <a:buNone/>
+                      </a:pPr>
+                      <a:r>
+                        <a:rPr cap="none" sz="1200" i="0" b="0" u="none" strike="noStrike">
+                          <a:solidFill>
+                            <a:srgbClr val="5B6770">
+                              <a:alpha val="100000"/>
+                            </a:srgbClr>
+                          </a:solidFill>
+                          <a:latin typeface="Helvetica Neue"/>
+                          <a:cs typeface="Helvetica Neue"/>
+                          <a:ea typeface="Helvetica Neue"/>
+                          <a:sym typeface="Helvetica Neue"/>
+                        </a:rPr>
+                        <a:t>1</a:t>
+                      </a:r>
+                    </a:p>
+                  </a:txBody>
+                  <a:tcPr anchor="ctr" marB="63500" marT="63500" marR="0" marL="0">
+                    <a:lnL algn="ctr" cmpd="sng" cap="flat" w="0">
+                      <a:noFill/>
+                      <a:prstDash val="solid"/>
+                    </a:lnL>
+                    <a:lnR algn="ctr" cmpd="sng" cap="flat" w="0">
+                      <a:noFill/>
+                      <a:prstDash val="solid"/>
+                    </a:lnR>
+                    <a:lnT algn="ctr" cmpd="sng" cap="flat" w="0">
+                      <a:noFill/>
+                      <a:prstDash val="solid"/>
+                    </a:lnT>
+                    <a:lnB algn="ctr" cmpd="sng" cap="flat" w="0">
+                      <a:noFill/>
+                      <a:prstDash val="solid"/>
+                    </a:lnB>
+                    <a:solidFill>
+                      <a:srgbClr val="FFFFFF">
+                        <a:alpha val="0"/>
+                      </a:srgbClr>
+                    </a:solidFill>
+                  </a:tcPr>
+                </a:tc>
+                <a:tc>
+                  <a:txBody>
+                    <a:bodyPr/>
+                    <a:lstStyle/>
+                    <a:p>
+                      <a:pPr algn="l" marL="63500" marR="63500">
+                        <a:lnSpc>
+                          <a:spcPct val="100000"/>
+                        </a:lnSpc>
+                        <a:spcBef>
+                          <a:spcPts val="500"/>
+                        </a:spcBef>
+                        <a:spcAft>
+                          <a:spcPts val="500"/>
+                        </a:spcAft>
+                        <a:buNone/>
+                      </a:pPr>
+                      <a:r>
+                        <a:rPr cap="none" sz="1200" i="0" b="0" u="none" strike="noStrike">
+                          <a:solidFill>
+                            <a:srgbClr val="5B6770">
+                              <a:alpha val="100000"/>
+                            </a:srgbClr>
+                          </a:solidFill>
+                          <a:latin typeface="Helvetica Neue"/>
+                          <a:cs typeface="Helvetica Neue"/>
+                          <a:ea typeface="Helvetica Neue"/>
+                          <a:sym typeface="Helvetica Neue"/>
+                        </a:rPr>
+                        <a:t>604357</a:t>
+                      </a:r>
+                    </a:p>
+                  </a:txBody>
+                  <a:tcPr anchor="ctr" marB="63500" marT="63500" marR="0" marL="0">
+                    <a:lnL algn="ctr" cmpd="sng" cap="flat" w="0">
+                      <a:noFill/>
+                      <a:prstDash val="solid"/>
+                    </a:lnL>
+                    <a:lnR algn="ctr" cmpd="sng" cap="flat" w="0">
+                      <a:noFill/>
+                      <a:prstDash val="solid"/>
+                    </a:lnR>
+                    <a:lnT algn="ctr" cmpd="sng" cap="flat" w="0">
+                      <a:noFill/>
+                      <a:prstDash val="solid"/>
+                    </a:lnT>
+                    <a:lnB algn="ctr" cmpd="sng" cap="flat" w="0">
+                      <a:noFill/>
+                      <a:prstDash val="solid"/>
+                    </a:lnB>
+                    <a:solidFill>
+                      <a:srgbClr val="FFFFFF">
+                        <a:alpha val="0"/>
+                      </a:srgbClr>
+                    </a:solidFill>
+                  </a:tcPr>
+                </a:tc>
+              </a:tr>
+              <a:tr h="401320">
+                <a:tc>
+                  <a:txBody>
+                    <a:bodyPr/>
+                    <a:lstStyle/>
+                    <a:p>
+                      <a:pPr algn="l" marL="63500" marR="63500">
+                        <a:lnSpc>
+                          <a:spcPct val="100000"/>
+                        </a:lnSpc>
+                        <a:spcBef>
+                          <a:spcPts val="500"/>
+                        </a:spcBef>
+                        <a:spcAft>
+                          <a:spcPts val="500"/>
+                        </a:spcAft>
+                        <a:buNone/>
+                      </a:pPr>
+                      <a:r>
+                        <a:rPr cap="none" sz="1200" i="0" b="0" u="none" strike="noStrike">
+                          <a:solidFill>
+                            <a:srgbClr val="5B6770">
+                              <a:alpha val="100000"/>
+                            </a:srgbClr>
+                          </a:solidFill>
+                          <a:latin typeface="Helvetica Neue"/>
+                          <a:cs typeface="Helvetica Neue"/>
+                          <a:ea typeface="Helvetica Neue"/>
+                          <a:sym typeface="Helvetica Neue"/>
+                        </a:rPr>
                         <a:t>chlorphenamine</a:t>
                       </a:r>
                     </a:p>
@@ -11071,8 +11358,8 @@
                       <a:prstDash val="solid"/>
                     </a:lnB>
                     <a:solidFill>
-                      <a:srgbClr val="FFFFFF">
-                        <a:alpha val="0"/>
+                      <a:srgbClr val="F4F8FB">
+                        <a:alpha val="100000"/>
                       </a:srgbClr>
                     </a:solidFill>
                   </a:tcPr>
@@ -11128,8 +11415,8 @@
                       <a:prstDash val="solid"/>
                     </a:lnB>
                     <a:solidFill>
-                      <a:srgbClr val="FFFFFF">
-                        <a:alpha val="0"/>
+                      <a:srgbClr val="F4F8FB">
+                        <a:alpha val="100000"/>
                       </a:srgbClr>
                     </a:solidFill>
                   </a:tcPr>
@@ -11185,8 +11472,8 @@
                       <a:prstDash val="solid"/>
                     </a:lnB>
                     <a:solidFill>
-                      <a:srgbClr val="FFFFFF">
-                        <a:alpha val="0"/>
+                      <a:srgbClr val="F4F8FB">
+                        <a:alpha val="100000"/>
                       </a:srgbClr>
                     </a:solidFill>
                   </a:tcPr>
@@ -11242,8 +11529,8 @@
                       <a:prstDash val="solid"/>
                     </a:lnB>
                     <a:solidFill>
-                      <a:srgbClr val="FFFFFF">
-                        <a:alpha val="0"/>
+                      <a:srgbClr val="F4F8FB">
+                        <a:alpha val="100000"/>
                       </a:srgbClr>
                     </a:solidFill>
                   </a:tcPr>
@@ -11299,8 +11586,8 @@
                       <a:prstDash val="solid"/>
                     </a:lnB>
                     <a:solidFill>
-                      <a:srgbClr val="FFFFFF">
-                        <a:alpha val="0"/>
+                      <a:srgbClr val="F4F8FB">
+                        <a:alpha val="100000"/>
                       </a:srgbClr>
                     </a:solidFill>
                   </a:tcPr>
@@ -11358,8 +11645,8 @@
                       <a:prstDash val="solid"/>
                     </a:lnB>
                     <a:solidFill>
-                      <a:srgbClr val="F4F8FB">
-                        <a:alpha val="100000"/>
+                      <a:srgbClr val="FFFFFF">
+                        <a:alpha val="0"/>
                       </a:srgbClr>
                     </a:solidFill>
                   </a:tcPr>
@@ -11415,8 +11702,8 @@
                       <a:prstDash val="solid"/>
                     </a:lnB>
                     <a:solidFill>
-                      <a:srgbClr val="F4F8FB">
-                        <a:alpha val="100000"/>
+                      <a:srgbClr val="FFFFFF">
+                        <a:alpha val="0"/>
                       </a:srgbClr>
                     </a:solidFill>
                   </a:tcPr>
@@ -11472,8 +11759,8 @@
                       <a:prstDash val="solid"/>
                     </a:lnB>
                     <a:solidFill>
-                      <a:srgbClr val="F4F8FB">
-                        <a:alpha val="100000"/>
+                      <a:srgbClr val="FFFFFF">
+                        <a:alpha val="0"/>
                       </a:srgbClr>
                     </a:solidFill>
                   </a:tcPr>
@@ -11529,8 +11816,8 @@
                       <a:prstDash val="solid"/>
                     </a:lnB>
                     <a:solidFill>
-                      <a:srgbClr val="F4F8FB">
-                        <a:alpha val="100000"/>
+                      <a:srgbClr val="FFFFFF">
+                        <a:alpha val="0"/>
                       </a:srgbClr>
                     </a:solidFill>
                   </a:tcPr>
@@ -11586,8 +11873,8 @@
                       <a:prstDash val="solid"/>
                     </a:lnB>
                     <a:solidFill>
-                      <a:srgbClr val="F4F8FB">
-                        <a:alpha val="100000"/>
+                      <a:srgbClr val="FFFFFF">
+                        <a:alpha val="0"/>
                       </a:srgbClr>
                     </a:solidFill>
                   </a:tcPr>
@@ -11645,8 +11932,8 @@
                       <a:prstDash val="solid"/>
                     </a:lnB>
                     <a:solidFill>
-                      <a:srgbClr val="FFFFFF">
-                        <a:alpha val="0"/>
+                      <a:srgbClr val="F4F8FB">
+                        <a:alpha val="100000"/>
                       </a:srgbClr>
                     </a:solidFill>
                   </a:tcPr>
@@ -11702,8 +11989,8 @@
                       <a:prstDash val="solid"/>
                     </a:lnB>
                     <a:solidFill>
-                      <a:srgbClr val="FFFFFF">
-                        <a:alpha val="0"/>
+                      <a:srgbClr val="F4F8FB">
+                        <a:alpha val="100000"/>
                       </a:srgbClr>
                     </a:solidFill>
                   </a:tcPr>
@@ -11759,8 +12046,8 @@
                       <a:prstDash val="solid"/>
                     </a:lnB>
                     <a:solidFill>
-                      <a:srgbClr val="FFFFFF">
-                        <a:alpha val="0"/>
+                      <a:srgbClr val="F4F8FB">
+                        <a:alpha val="100000"/>
                       </a:srgbClr>
                     </a:solidFill>
                   </a:tcPr>
@@ -11816,8 +12103,8 @@
                       <a:prstDash val="solid"/>
                     </a:lnB>
                     <a:solidFill>
-                      <a:srgbClr val="FFFFFF">
-                        <a:alpha val="0"/>
+                      <a:srgbClr val="F4F8FB">
+                        <a:alpha val="100000"/>
                       </a:srgbClr>
                     </a:solidFill>
                   </a:tcPr>
@@ -11873,8 +12160,8 @@
                       <a:prstDash val="solid"/>
                     </a:lnB>
                     <a:solidFill>
-                      <a:srgbClr val="FFFFFF">
-                        <a:alpha val="0"/>
+                      <a:srgbClr val="F4F8FB">
+                        <a:alpha val="100000"/>
                       </a:srgbClr>
                     </a:solidFill>
                   </a:tcPr>
@@ -11932,8 +12219,8 @@
                       <a:prstDash val="solid"/>
                     </a:lnB>
                     <a:solidFill>
-                      <a:srgbClr val="F4F8FB">
-                        <a:alpha val="100000"/>
+                      <a:srgbClr val="FFFFFF">
+                        <a:alpha val="0"/>
                       </a:srgbClr>
                     </a:solidFill>
                   </a:tcPr>
@@ -11989,8 +12276,8 @@
                       <a:prstDash val="solid"/>
                     </a:lnB>
                     <a:solidFill>
-                      <a:srgbClr val="F4F8FB">
-                        <a:alpha val="100000"/>
+                      <a:srgbClr val="FFFFFF">
+                        <a:alpha val="0"/>
                       </a:srgbClr>
                     </a:solidFill>
                   </a:tcPr>
@@ -12046,8 +12333,8 @@
                       <a:prstDash val="solid"/>
                     </a:lnB>
                     <a:solidFill>
-                      <a:srgbClr val="F4F8FB">
-                        <a:alpha val="100000"/>
+                      <a:srgbClr val="FFFFFF">
+                        <a:alpha val="0"/>
                       </a:srgbClr>
                     </a:solidFill>
                   </a:tcPr>
@@ -12103,8 +12390,8 @@
                       <a:prstDash val="solid"/>
                     </a:lnB>
                     <a:solidFill>
-                      <a:srgbClr val="F4F8FB">
-                        <a:alpha val="100000"/>
+                      <a:srgbClr val="FFFFFF">
+                        <a:alpha val="0"/>
                       </a:srgbClr>
                     </a:solidFill>
                   </a:tcPr>
@@ -12160,8 +12447,8 @@
                       <a:prstDash val="solid"/>
                     </a:lnB>
                     <a:solidFill>
-                      <a:srgbClr val="F4F8FB">
-                        <a:alpha val="100000"/>
+                      <a:srgbClr val="FFFFFF">
+                        <a:alpha val="0"/>
                       </a:srgbClr>
                     </a:solidFill>
                   </a:tcPr>
@@ -12219,8 +12506,8 @@
                       <a:prstDash val="solid"/>
                     </a:lnB>
                     <a:solidFill>
-                      <a:srgbClr val="FFFFFF">
-                        <a:alpha val="0"/>
+                      <a:srgbClr val="F4F8FB">
+                        <a:alpha val="100000"/>
                       </a:srgbClr>
                     </a:solidFill>
                   </a:tcPr>
@@ -12276,8 +12563,8 @@
                       <a:prstDash val="solid"/>
                     </a:lnB>
                     <a:solidFill>
-                      <a:srgbClr val="FFFFFF">
-                        <a:alpha val="0"/>
+                      <a:srgbClr val="F4F8FB">
+                        <a:alpha val="100000"/>
                       </a:srgbClr>
                     </a:solidFill>
                   </a:tcPr>
@@ -12333,8 +12620,8 @@
                       <a:prstDash val="solid"/>
                     </a:lnB>
                     <a:solidFill>
-                      <a:srgbClr val="FFFFFF">
-                        <a:alpha val="0"/>
+                      <a:srgbClr val="F4F8FB">
+                        <a:alpha val="100000"/>
                       </a:srgbClr>
                     </a:solidFill>
                   </a:tcPr>
@@ -12390,8 +12677,8 @@
                       <a:prstDash val="solid"/>
                     </a:lnB>
                     <a:solidFill>
-                      <a:srgbClr val="FFFFFF">
-                        <a:alpha val="0"/>
+                      <a:srgbClr val="F4F8FB">
+                        <a:alpha val="100000"/>
                       </a:srgbClr>
                     </a:solidFill>
                   </a:tcPr>
@@ -12447,8 +12734,8 @@
                       <a:prstDash val="solid"/>
                     </a:lnB>
                     <a:solidFill>
-                      <a:srgbClr val="FFFFFF">
-                        <a:alpha val="0"/>
+                      <a:srgbClr val="F4F8FB">
+                        <a:alpha val="100000"/>
                       </a:srgbClr>
                     </a:solidFill>
                   </a:tcPr>
@@ -12506,8 +12793,8 @@
                       <a:prstDash val="solid"/>
                     </a:lnB>
                     <a:solidFill>
-                      <a:srgbClr val="F4F8FB">
-                        <a:alpha val="100000"/>
+                      <a:srgbClr val="FFFFFF">
+                        <a:alpha val="0"/>
                       </a:srgbClr>
                     </a:solidFill>
                   </a:tcPr>
@@ -12563,8 +12850,8 @@
                       <a:prstDash val="solid"/>
                     </a:lnB>
                     <a:solidFill>
-                      <a:srgbClr val="F4F8FB">
-                        <a:alpha val="100000"/>
+                      <a:srgbClr val="FFFFFF">
+                        <a:alpha val="0"/>
                       </a:srgbClr>
                     </a:solidFill>
                   </a:tcPr>
@@ -12620,8 +12907,8 @@
                       <a:prstDash val="solid"/>
                     </a:lnB>
                     <a:solidFill>
-                      <a:srgbClr val="F4F8FB">
-                        <a:alpha val="100000"/>
+                      <a:srgbClr val="FFFFFF">
+                        <a:alpha val="0"/>
                       </a:srgbClr>
                     </a:solidFill>
                   </a:tcPr>
@@ -12677,8 +12964,8 @@
                       <a:prstDash val="solid"/>
                     </a:lnB>
                     <a:solidFill>
-                      <a:srgbClr val="F4F8FB">
-                        <a:alpha val="100000"/>
+                      <a:srgbClr val="FFFFFF">
+                        <a:alpha val="0"/>
                       </a:srgbClr>
                     </a:solidFill>
                   </a:tcPr>
@@ -12734,8 +13021,8 @@
                       <a:prstDash val="solid"/>
                     </a:lnB>
                     <a:solidFill>
-                      <a:srgbClr val="F4F8FB">
-                        <a:alpha val="100000"/>
+                      <a:srgbClr val="FFFFFF">
+                        <a:alpha val="0"/>
                       </a:srgbClr>
                     </a:solidFill>
                   </a:tcPr>
@@ -12793,8 +13080,8 @@
                       <a:prstDash val="solid"/>
                     </a:lnB>
                     <a:solidFill>
-                      <a:srgbClr val="FFFFFF">
-                        <a:alpha val="0"/>
+                      <a:srgbClr val="F4F8FB">
+                        <a:alpha val="100000"/>
                       </a:srgbClr>
                     </a:solidFill>
                   </a:tcPr>
@@ -12850,8 +13137,8 @@
                       <a:prstDash val="solid"/>
                     </a:lnB>
                     <a:solidFill>
-                      <a:srgbClr val="FFFFFF">
-                        <a:alpha val="0"/>
+                      <a:srgbClr val="F4F8FB">
+                        <a:alpha val="100000"/>
                       </a:srgbClr>
                     </a:solidFill>
                   </a:tcPr>
@@ -12907,8 +13194,8 @@
                       <a:prstDash val="solid"/>
                     </a:lnB>
                     <a:solidFill>
-                      <a:srgbClr val="FFFFFF">
-                        <a:alpha val="0"/>
+                      <a:srgbClr val="F4F8FB">
+                        <a:alpha val="100000"/>
                       </a:srgbClr>
                     </a:solidFill>
                   </a:tcPr>
@@ -12964,8 +13251,8 @@
                       <a:prstDash val="solid"/>
                     </a:lnB>
                     <a:solidFill>
-                      <a:srgbClr val="FFFFFF">
-                        <a:alpha val="0"/>
+                      <a:srgbClr val="F4F8FB">
+                        <a:alpha val="100000"/>
                       </a:srgbClr>
                     </a:solidFill>
                   </a:tcPr>
@@ -13021,8 +13308,8 @@
                       <a:prstDash val="solid"/>
                     </a:lnB>
                     <a:solidFill>
-                      <a:srgbClr val="FFFFFF">
-                        <a:alpha val="0"/>
+                      <a:srgbClr val="F4F8FB">
+                        <a:alpha val="100000"/>
                       </a:srgbClr>
                     </a:solidFill>
                   </a:tcPr>
@@ -13080,8 +13367,8 @@
                       <a:prstDash val="solid"/>
                     </a:lnB>
                     <a:solidFill>
-                      <a:srgbClr val="F4F8FB">
-                        <a:alpha val="100000"/>
+                      <a:srgbClr val="FFFFFF">
+                        <a:alpha val="0"/>
                       </a:srgbClr>
                     </a:solidFill>
                   </a:tcPr>
@@ -13137,8 +13424,8 @@
                       <a:prstDash val="solid"/>
                     </a:lnB>
                     <a:solidFill>
-                      <a:srgbClr val="F4F8FB">
-                        <a:alpha val="100000"/>
+                      <a:srgbClr val="FFFFFF">
+                        <a:alpha val="0"/>
                       </a:srgbClr>
                     </a:solidFill>
                   </a:tcPr>
@@ -13194,8 +13481,8 @@
                       <a:prstDash val="solid"/>
                     </a:lnB>
                     <a:solidFill>
-                      <a:srgbClr val="F4F8FB">
-                        <a:alpha val="100000"/>
+                      <a:srgbClr val="FFFFFF">
+                        <a:alpha val="0"/>
                       </a:srgbClr>
                     </a:solidFill>
                   </a:tcPr>
@@ -13251,8 +13538,8 @@
                       <a:prstDash val="solid"/>
                     </a:lnB>
                     <a:solidFill>
-                      <a:srgbClr val="F4F8FB">
-                        <a:alpha val="100000"/>
+                      <a:srgbClr val="FFFFFF">
+                        <a:alpha val="0"/>
                       </a:srgbClr>
                     </a:solidFill>
                   </a:tcPr>
@@ -13308,8 +13595,8 @@
                       <a:prstDash val="solid"/>
                     </a:lnB>
                     <a:solidFill>
-                      <a:srgbClr val="F4F8FB">
-                        <a:alpha val="100000"/>
+                      <a:srgbClr val="FFFFFF">
+                        <a:alpha val="0"/>
                       </a:srgbClr>
                     </a:solidFill>
                   </a:tcPr>
@@ -13367,8 +13654,8 @@
                       <a:prstDash val="solid"/>
                     </a:lnB>
                     <a:solidFill>
-                      <a:srgbClr val="FFFFFF">
-                        <a:alpha val="0"/>
+                      <a:srgbClr val="F4F8FB">
+                        <a:alpha val="100000"/>
                       </a:srgbClr>
                     </a:solidFill>
                   </a:tcPr>
@@ -13424,8 +13711,8 @@
                       <a:prstDash val="solid"/>
                     </a:lnB>
                     <a:solidFill>
-                      <a:srgbClr val="FFFFFF">
-                        <a:alpha val="0"/>
+                      <a:srgbClr val="F4F8FB">
+                        <a:alpha val="100000"/>
                       </a:srgbClr>
                     </a:solidFill>
                   </a:tcPr>
@@ -13481,8 +13768,8 @@
                       <a:prstDash val="solid"/>
                     </a:lnB>
                     <a:solidFill>
-                      <a:srgbClr val="FFFFFF">
-                        <a:alpha val="0"/>
+                      <a:srgbClr val="F4F8FB">
+                        <a:alpha val="100000"/>
                       </a:srgbClr>
                     </a:solidFill>
                   </a:tcPr>
@@ -13538,8 +13825,8 @@
                       <a:prstDash val="solid"/>
                     </a:lnB>
                     <a:solidFill>
-                      <a:srgbClr val="FFFFFF">
-                        <a:alpha val="0"/>
+                      <a:srgbClr val="F4F8FB">
+                        <a:alpha val="100000"/>
                       </a:srgbClr>
                     </a:solidFill>
                   </a:tcPr>
@@ -13595,8 +13882,8 @@
                       <a:prstDash val="solid"/>
                     </a:lnB>
                     <a:solidFill>
-                      <a:srgbClr val="FFFFFF">
-                        <a:alpha val="0"/>
+                      <a:srgbClr val="F4F8FB">
+                        <a:alpha val="100000"/>
                       </a:srgbClr>
                     </a:solidFill>
                   </a:tcPr>
@@ -13654,8 +13941,8 @@
                       <a:prstDash val="solid"/>
                     </a:lnB>
                     <a:solidFill>
-                      <a:srgbClr val="F4F8FB">
-                        <a:alpha val="100000"/>
+                      <a:srgbClr val="FFFFFF">
+                        <a:alpha val="0"/>
                       </a:srgbClr>
                     </a:solidFill>
                   </a:tcPr>
@@ -13711,8 +13998,8 @@
                       <a:prstDash val="solid"/>
                     </a:lnB>
                     <a:solidFill>
-                      <a:srgbClr val="F4F8FB">
-                        <a:alpha val="100000"/>
+                      <a:srgbClr val="FFFFFF">
+                        <a:alpha val="0"/>
                       </a:srgbClr>
                     </a:solidFill>
                   </a:tcPr>
@@ -13768,8 +14055,8 @@
                       <a:prstDash val="solid"/>
                     </a:lnB>
                     <a:solidFill>
-                      <a:srgbClr val="F4F8FB">
-                        <a:alpha val="100000"/>
+                      <a:srgbClr val="FFFFFF">
+                        <a:alpha val="0"/>
                       </a:srgbClr>
                     </a:solidFill>
                   </a:tcPr>
@@ -13825,8 +14112,8 @@
                       <a:prstDash val="solid"/>
                     </a:lnB>
                     <a:solidFill>
-                      <a:srgbClr val="F4F8FB">
-                        <a:alpha val="100000"/>
+                      <a:srgbClr val="FFFFFF">
+                        <a:alpha val="0"/>
                       </a:srgbClr>
                     </a:solidFill>
                   </a:tcPr>
@@ -13882,14 +14169,14 @@
                       <a:prstDash val="solid"/>
                     </a:lnB>
                     <a:solidFill>
-                      <a:srgbClr val="F4F8FB">
-                        <a:alpha val="100000"/>
+                      <a:srgbClr val="FFFFFF">
+                        <a:alpha val="0"/>
                       </a:srgbClr>
                     </a:solidFill>
                   </a:tcPr>
                 </a:tc>
               </a:tr>
-              <a:tr h="401320">
+              <a:tr h="410845">
                 <a:tc>
                   <a:txBody>
                     <a:bodyPr/>
@@ -13936,13 +14223,17 @@
                       <a:noFill/>
                       <a:prstDash val="solid"/>
                     </a:lnT>
-                    <a:lnB algn="ctr" cmpd="sng" cap="flat" w="0">
-                      <a:noFill/>
+                    <a:lnB algn="ctr" cmpd="sng" cap="flat" w="19050">
+                      <a:solidFill>
+                        <a:srgbClr val="666666">
+                          <a:alpha val="100000"/>
+                        </a:srgbClr>
+                      </a:solidFill>
                       <a:prstDash val="solid"/>
                     </a:lnB>
                     <a:solidFill>
-                      <a:srgbClr val="FFFFFF">
-                        <a:alpha val="0"/>
+                      <a:srgbClr val="F4F8FB">
+                        <a:alpha val="100000"/>
                       </a:srgbClr>
                     </a:solidFill>
                   </a:tcPr>
@@ -13993,13 +14284,17 @@
                       <a:noFill/>
                       <a:prstDash val="solid"/>
                     </a:lnT>
-                    <a:lnB algn="ctr" cmpd="sng" cap="flat" w="0">
-                      <a:noFill/>
+                    <a:lnB algn="ctr" cmpd="sng" cap="flat" w="19050">
+                      <a:solidFill>
+                        <a:srgbClr val="666666">
+                          <a:alpha val="100000"/>
+                        </a:srgbClr>
+                      </a:solidFill>
                       <a:prstDash val="solid"/>
                     </a:lnB>
                     <a:solidFill>
-                      <a:srgbClr val="FFFFFF">
-                        <a:alpha val="0"/>
+                      <a:srgbClr val="F4F8FB">
+                        <a:alpha val="100000"/>
                       </a:srgbClr>
                     </a:solidFill>
                   </a:tcPr>
@@ -14050,13 +14345,17 @@
                       <a:noFill/>
                       <a:prstDash val="solid"/>
                     </a:lnT>
-                    <a:lnB algn="ctr" cmpd="sng" cap="flat" w="0">
-                      <a:noFill/>
+                    <a:lnB algn="ctr" cmpd="sng" cap="flat" w="19050">
+                      <a:solidFill>
+                        <a:srgbClr val="666666">
+                          <a:alpha val="100000"/>
+                        </a:srgbClr>
+                      </a:solidFill>
                       <a:prstDash val="solid"/>
                     </a:lnB>
                     <a:solidFill>
-                      <a:srgbClr val="FFFFFF">
-                        <a:alpha val="0"/>
+                      <a:srgbClr val="F4F8FB">
+                        <a:alpha val="100000"/>
                       </a:srgbClr>
                     </a:solidFill>
                   </a:tcPr>
@@ -14107,122 +14406,6 @@
                       <a:noFill/>
                       <a:prstDash val="solid"/>
                     </a:lnT>
-                    <a:lnB algn="ctr" cmpd="sng" cap="flat" w="0">
-                      <a:noFill/>
-                      <a:prstDash val="solid"/>
-                    </a:lnB>
-                    <a:solidFill>
-                      <a:srgbClr val="FFFFFF">
-                        <a:alpha val="0"/>
-                      </a:srgbClr>
-                    </a:solidFill>
-                  </a:tcPr>
-                </a:tc>
-                <a:tc>
-                  <a:txBody>
-                    <a:bodyPr/>
-                    <a:lstStyle/>
-                    <a:p>
-                      <a:pPr algn="l" marL="63500" marR="63500">
-                        <a:lnSpc>
-                          <a:spcPct val="100000"/>
-                        </a:lnSpc>
-                        <a:spcBef>
-                          <a:spcPts val="500"/>
-                        </a:spcBef>
-                        <a:spcAft>
-                          <a:spcPts val="500"/>
-                        </a:spcAft>
-                        <a:buNone/>
-                      </a:pPr>
-                      <a:r>
-                        <a:rPr cap="none" sz="1200" i="0" b="0" u="none" strike="noStrike">
-                          <a:solidFill>
-                            <a:srgbClr val="5B6770">
-                              <a:alpha val="100000"/>
-                            </a:srgbClr>
-                          </a:solidFill>
-                          <a:latin typeface="Helvetica Neue"/>
-                          <a:cs typeface="Helvetica Neue"/>
-                          <a:ea typeface="Helvetica Neue"/>
-                          <a:sym typeface="Helvetica Neue"/>
-                        </a:rPr>
-                        <a:t>900817</a:t>
-                      </a:r>
-                    </a:p>
-                  </a:txBody>
-                  <a:tcPr anchor="ctr" marB="63500" marT="63500" marR="0" marL="0">
-                    <a:lnL algn="ctr" cmpd="sng" cap="flat" w="0">
-                      <a:noFill/>
-                      <a:prstDash val="solid"/>
-                    </a:lnL>
-                    <a:lnR algn="ctr" cmpd="sng" cap="flat" w="0">
-                      <a:noFill/>
-                      <a:prstDash val="solid"/>
-                    </a:lnR>
-                    <a:lnT algn="ctr" cmpd="sng" cap="flat" w="0">
-                      <a:noFill/>
-                      <a:prstDash val="solid"/>
-                    </a:lnT>
-                    <a:lnB algn="ctr" cmpd="sng" cap="flat" w="0">
-                      <a:noFill/>
-                      <a:prstDash val="solid"/>
-                    </a:lnB>
-                    <a:solidFill>
-                      <a:srgbClr val="FFFFFF">
-                        <a:alpha val="0"/>
-                      </a:srgbClr>
-                    </a:solidFill>
-                  </a:tcPr>
-                </a:tc>
-              </a:tr>
-              <a:tr h="410845">
-                <a:tc>
-                  <a:txBody>
-                    <a:bodyPr/>
-                    <a:lstStyle/>
-                    <a:p>
-                      <a:pPr algn="l" marL="63500" marR="63500">
-                        <a:lnSpc>
-                          <a:spcPct val="100000"/>
-                        </a:lnSpc>
-                        <a:spcBef>
-                          <a:spcPts val="500"/>
-                        </a:spcBef>
-                        <a:spcAft>
-                          <a:spcPts val="500"/>
-                        </a:spcAft>
-                        <a:buNone/>
-                      </a:pPr>
-                      <a:r>
-                        <a:rPr cap="none" sz="1200" i="0" b="0" u="none" strike="noStrike">
-                          <a:solidFill>
-                            <a:srgbClr val="5B6770">
-                              <a:alpha val="100000"/>
-                            </a:srgbClr>
-                          </a:solidFill>
-                          <a:latin typeface="Helvetica Neue"/>
-                          <a:cs typeface="Helvetica Neue"/>
-                          <a:ea typeface="Helvetica Neue"/>
-                          <a:sym typeface="Helvetica Neue"/>
-                        </a:rPr>
-                        <a:t>2-fluoro-2-oxo-PCiPr</a:t>
-                      </a:r>
-                    </a:p>
-                  </a:txBody>
-                  <a:tcPr anchor="ctr" marB="63500" marT="63500" marR="0" marL="0">
-                    <a:lnL algn="ctr" cmpd="sng" cap="flat" w="0">
-                      <a:noFill/>
-                      <a:prstDash val="solid"/>
-                    </a:lnL>
-                    <a:lnR algn="ctr" cmpd="sng" cap="flat" w="0">
-                      <a:noFill/>
-                      <a:prstDash val="solid"/>
-                    </a:lnR>
-                    <a:lnT algn="ctr" cmpd="sng" cap="flat" w="0">
-                      <a:noFill/>
-                      <a:prstDash val="solid"/>
-                    </a:lnT>
                     <a:lnB algn="ctr" cmpd="sng" cap="flat" w="19050">
                       <a:solidFill>
                         <a:srgbClr val="666666">
@@ -14267,190 +14450,7 @@
                           <a:ea typeface="Helvetica Neue"/>
                           <a:sym typeface="Helvetica Neue"/>
                         </a:rPr>
-                        <a:t>16 Jun 2026</a:t>
-                      </a:r>
-                    </a:p>
-                  </a:txBody>
-                  <a:tcPr anchor="ctr" marB="63500" marT="63500" marR="0" marL="0">
-                    <a:lnL algn="ctr" cmpd="sng" cap="flat" w="0">
-                      <a:noFill/>
-                      <a:prstDash val="solid"/>
-                    </a:lnL>
-                    <a:lnR algn="ctr" cmpd="sng" cap="flat" w="0">
-                      <a:noFill/>
-                      <a:prstDash val="solid"/>
-                    </a:lnR>
-                    <a:lnT algn="ctr" cmpd="sng" cap="flat" w="0">
-                      <a:noFill/>
-                      <a:prstDash val="solid"/>
-                    </a:lnT>
-                    <a:lnB algn="ctr" cmpd="sng" cap="flat" w="19050">
-                      <a:solidFill>
-                        <a:srgbClr val="666666">
-                          <a:alpha val="100000"/>
-                        </a:srgbClr>
-                      </a:solidFill>
-                      <a:prstDash val="solid"/>
-                    </a:lnB>
-                    <a:solidFill>
-                      <a:srgbClr val="F4F8FB">
-                        <a:alpha val="100000"/>
-                      </a:srgbClr>
-                    </a:solidFill>
-                  </a:tcPr>
-                </a:tc>
-                <a:tc>
-                  <a:txBody>
-                    <a:bodyPr/>
-                    <a:lstStyle/>
-                    <a:p>
-                      <a:pPr algn="l" marL="63500" marR="63500">
-                        <a:lnSpc>
-                          <a:spcPct val="100000"/>
-                        </a:lnSpc>
-                        <a:spcBef>
-                          <a:spcPts val="500"/>
-                        </a:spcBef>
-                        <a:spcAft>
-                          <a:spcPts val="500"/>
-                        </a:spcAft>
-                        <a:buNone/>
-                      </a:pPr>
-                      <a:r>
-                        <a:rPr cap="none" sz="1200" i="0" b="0" u="none" strike="noStrike">
-                          <a:solidFill>
-                            <a:srgbClr val="5B6770">
-                              <a:alpha val="100000"/>
-                            </a:srgbClr>
-                          </a:solidFill>
-                          <a:latin typeface="Helvetica Neue"/>
-                          <a:cs typeface="Helvetica Neue"/>
-                          <a:ea typeface="Helvetica Neue"/>
-                          <a:sym typeface="Helvetica Neue"/>
-                        </a:rPr>
-                        <a:t>primary</a:t>
-                      </a:r>
-                    </a:p>
-                  </a:txBody>
-                  <a:tcPr anchor="ctr" marB="63500" marT="63500" marR="0" marL="0">
-                    <a:lnL algn="ctr" cmpd="sng" cap="flat" w="0">
-                      <a:noFill/>
-                      <a:prstDash val="solid"/>
-                    </a:lnL>
-                    <a:lnR algn="ctr" cmpd="sng" cap="flat" w="0">
-                      <a:noFill/>
-                      <a:prstDash val="solid"/>
-                    </a:lnR>
-                    <a:lnT algn="ctr" cmpd="sng" cap="flat" w="0">
-                      <a:noFill/>
-                      <a:prstDash val="solid"/>
-                    </a:lnT>
-                    <a:lnB algn="ctr" cmpd="sng" cap="flat" w="19050">
-                      <a:solidFill>
-                        <a:srgbClr val="666666">
-                          <a:alpha val="100000"/>
-                        </a:srgbClr>
-                      </a:solidFill>
-                      <a:prstDash val="solid"/>
-                    </a:lnB>
-                    <a:solidFill>
-                      <a:srgbClr val="F4F8FB">
-                        <a:alpha val="100000"/>
-                      </a:srgbClr>
-                    </a:solidFill>
-                  </a:tcPr>
-                </a:tc>
-                <a:tc>
-                  <a:txBody>
-                    <a:bodyPr/>
-                    <a:lstStyle/>
-                    <a:p>
-                      <a:pPr algn="r" marL="63500" marR="63500">
-                        <a:lnSpc>
-                          <a:spcPct val="100000"/>
-                        </a:lnSpc>
-                        <a:spcBef>
-                          <a:spcPts val="500"/>
-                        </a:spcBef>
-                        <a:spcAft>
-                          <a:spcPts val="500"/>
-                        </a:spcAft>
-                        <a:buNone/>
-                      </a:pPr>
-                      <a:r>
-                        <a:rPr cap="none" sz="1200" i="0" b="0" u="none" strike="noStrike">
-                          <a:solidFill>
-                            <a:srgbClr val="5B6770">
-                              <a:alpha val="100000"/>
-                            </a:srgbClr>
-                          </a:solidFill>
-                          <a:latin typeface="Helvetica Neue"/>
-                          <a:cs typeface="Helvetica Neue"/>
-                          <a:ea typeface="Helvetica Neue"/>
-                          <a:sym typeface="Helvetica Neue"/>
-                        </a:rPr>
-                        <a:t>1</a:t>
-                      </a:r>
-                    </a:p>
-                  </a:txBody>
-                  <a:tcPr anchor="ctr" marB="63500" marT="63500" marR="0" marL="0">
-                    <a:lnL algn="ctr" cmpd="sng" cap="flat" w="0">
-                      <a:noFill/>
-                      <a:prstDash val="solid"/>
-                    </a:lnL>
-                    <a:lnR algn="ctr" cmpd="sng" cap="flat" w="0">
-                      <a:noFill/>
-                      <a:prstDash val="solid"/>
-                    </a:lnR>
-                    <a:lnT algn="ctr" cmpd="sng" cap="flat" w="0">
-                      <a:noFill/>
-                      <a:prstDash val="solid"/>
-                    </a:lnT>
-                    <a:lnB algn="ctr" cmpd="sng" cap="flat" w="19050">
-                      <a:solidFill>
-                        <a:srgbClr val="666666">
-                          <a:alpha val="100000"/>
-                        </a:srgbClr>
-                      </a:solidFill>
-                      <a:prstDash val="solid"/>
-                    </a:lnB>
-                    <a:solidFill>
-                      <a:srgbClr val="F4F8FB">
-                        <a:alpha val="100000"/>
-                      </a:srgbClr>
-                    </a:solidFill>
-                  </a:tcPr>
-                </a:tc>
-                <a:tc>
-                  <a:txBody>
-                    <a:bodyPr/>
-                    <a:lstStyle/>
-                    <a:p>
-                      <a:pPr algn="l" marL="63500" marR="63500">
-                        <a:lnSpc>
-                          <a:spcPct val="100000"/>
-                        </a:lnSpc>
-                        <a:spcBef>
-                          <a:spcPts val="500"/>
-                        </a:spcBef>
-                        <a:spcAft>
-                          <a:spcPts val="500"/>
-                        </a:spcAft>
-                        <a:buNone/>
-                      </a:pPr>
-                      <a:r>
-                        <a:rPr cap="none" sz="1200" i="0" b="0" u="none" strike="noStrike">
-                          <a:solidFill>
-                            <a:srgbClr val="5B6770">
-                              <a:alpha val="100000"/>
-                            </a:srgbClr>
-                          </a:solidFill>
-                          <a:latin typeface="Helvetica Neue"/>
-                          <a:cs typeface="Helvetica Neue"/>
-                          <a:ea typeface="Helvetica Neue"/>
-                          <a:sym typeface="Helvetica Neue"/>
-                        </a:rPr>
-                        <a:t>603838</a:t>
+                        <a:t>900817</a:t>
                       </a:r>
                     </a:p>
                   </a:txBody>
@@ -24942,6 +24942,293 @@
                           <a:ea typeface="Helvetica Neue"/>
                           <a:sym typeface="Helvetica Neue"/>
                         </a:rPr>
+                        <a:t>SR 17018</a:t>
+                      </a:r>
+                    </a:p>
+                  </a:txBody>
+                  <a:tcPr anchor="ctr" marB="63500" marT="63500" marR="0" marL="0">
+                    <a:lnL algn="ctr" cmpd="sng" cap="flat" w="0">
+                      <a:noFill/>
+                      <a:prstDash val="solid"/>
+                    </a:lnL>
+                    <a:lnR algn="ctr" cmpd="sng" cap="flat" w="0">
+                      <a:noFill/>
+                      <a:prstDash val="solid"/>
+                    </a:lnR>
+                    <a:lnT algn="ctr" cmpd="sng" cap="flat" w="0">
+                      <a:noFill/>
+                      <a:prstDash val="solid"/>
+                    </a:lnT>
+                    <a:lnB algn="ctr" cmpd="sng" cap="flat" w="0">
+                      <a:noFill/>
+                      <a:prstDash val="solid"/>
+                    </a:lnB>
+                    <a:solidFill>
+                      <a:srgbClr val="FFFFFF">
+                        <a:alpha val="0"/>
+                      </a:srgbClr>
+                    </a:solidFill>
+                  </a:tcPr>
+                </a:tc>
+                <a:tc>
+                  <a:txBody>
+                    <a:bodyPr/>
+                    <a:lstStyle/>
+                    <a:p>
+                      <a:pPr algn="l" marL="63500" marR="63500">
+                        <a:lnSpc>
+                          <a:spcPct val="100000"/>
+                        </a:lnSpc>
+                        <a:spcBef>
+                          <a:spcPts val="500"/>
+                        </a:spcBef>
+                        <a:spcAft>
+                          <a:spcPts val="500"/>
+                        </a:spcAft>
+                        <a:buNone/>
+                      </a:pPr>
+                      <a:r>
+                        <a:rPr cap="none" sz="1200" i="0" b="0" u="none" strike="noStrike">
+                          <a:solidFill>
+                            <a:srgbClr val="5B6770">
+                              <a:alpha val="100000"/>
+                            </a:srgbClr>
+                          </a:solidFill>
+                          <a:latin typeface="Helvetica Neue"/>
+                          <a:cs typeface="Helvetica Neue"/>
+                          <a:ea typeface="Helvetica Neue"/>
+                          <a:sym typeface="Helvetica Neue"/>
+                        </a:rPr>
+                        <a:t>14 Sep 2026</a:t>
+                      </a:r>
+                    </a:p>
+                  </a:txBody>
+                  <a:tcPr anchor="ctr" marB="63500" marT="63500" marR="0" marL="0">
+                    <a:lnL algn="ctr" cmpd="sng" cap="flat" w="0">
+                      <a:noFill/>
+                      <a:prstDash val="solid"/>
+                    </a:lnL>
+                    <a:lnR algn="ctr" cmpd="sng" cap="flat" w="0">
+                      <a:noFill/>
+                      <a:prstDash val="solid"/>
+                    </a:lnR>
+                    <a:lnT algn="ctr" cmpd="sng" cap="flat" w="0">
+                      <a:noFill/>
+                      <a:prstDash val="solid"/>
+                    </a:lnT>
+                    <a:lnB algn="ctr" cmpd="sng" cap="flat" w="0">
+                      <a:noFill/>
+                      <a:prstDash val="solid"/>
+                    </a:lnB>
+                    <a:solidFill>
+                      <a:srgbClr val="FFFFFF">
+                        <a:alpha val="0"/>
+                      </a:srgbClr>
+                    </a:solidFill>
+                  </a:tcPr>
+                </a:tc>
+                <a:tc>
+                  <a:txBody>
+                    <a:bodyPr/>
+                    <a:lstStyle/>
+                    <a:p>
+                      <a:pPr algn="l" marL="63500" marR="63500">
+                        <a:lnSpc>
+                          <a:spcPct val="100000"/>
+                        </a:lnSpc>
+                        <a:spcBef>
+                          <a:spcPts val="500"/>
+                        </a:spcBef>
+                        <a:spcAft>
+                          <a:spcPts val="500"/>
+                        </a:spcAft>
+                        <a:buNone/>
+                      </a:pPr>
+                      <a:r>
+                        <a:rPr cap="none" sz="1200" i="0" b="0" u="none" strike="noStrike">
+                          <a:solidFill>
+                            <a:srgbClr val="5B6770">
+                              <a:alpha val="100000"/>
+                            </a:srgbClr>
+                          </a:solidFill>
+                          <a:latin typeface="Helvetica Neue"/>
+                          <a:cs typeface="Helvetica Neue"/>
+                          <a:ea typeface="Helvetica Neue"/>
+                          <a:sym typeface="Helvetica Neue"/>
+                        </a:rPr>
+                        <a:t>primary</a:t>
+                      </a:r>
+                    </a:p>
+                  </a:txBody>
+                  <a:tcPr anchor="ctr" marB="63500" marT="63500" marR="0" marL="0">
+                    <a:lnL algn="ctr" cmpd="sng" cap="flat" w="0">
+                      <a:noFill/>
+                      <a:prstDash val="solid"/>
+                    </a:lnL>
+                    <a:lnR algn="ctr" cmpd="sng" cap="flat" w="0">
+                      <a:noFill/>
+                      <a:prstDash val="solid"/>
+                    </a:lnR>
+                    <a:lnT algn="ctr" cmpd="sng" cap="flat" w="0">
+                      <a:noFill/>
+                      <a:prstDash val="solid"/>
+                    </a:lnT>
+                    <a:lnB algn="ctr" cmpd="sng" cap="flat" w="0">
+                      <a:noFill/>
+                      <a:prstDash val="solid"/>
+                    </a:lnB>
+                    <a:solidFill>
+                      <a:srgbClr val="FFFFFF">
+                        <a:alpha val="0"/>
+                      </a:srgbClr>
+                    </a:solidFill>
+                  </a:tcPr>
+                </a:tc>
+                <a:tc>
+                  <a:txBody>
+                    <a:bodyPr/>
+                    <a:lstStyle/>
+                    <a:p>
+                      <a:pPr algn="r" marL="63500" marR="63500">
+                        <a:lnSpc>
+                          <a:spcPct val="100000"/>
+                        </a:lnSpc>
+                        <a:spcBef>
+                          <a:spcPts val="500"/>
+                        </a:spcBef>
+                        <a:spcAft>
+                          <a:spcPts val="500"/>
+                        </a:spcAft>
+                        <a:buNone/>
+                      </a:pPr>
+                      <a:r>
+                        <a:rPr cap="none" sz="1200" i="0" b="0" u="none" strike="noStrike">
+                          <a:solidFill>
+                            <a:srgbClr val="5B6770">
+                              <a:alpha val="100000"/>
+                            </a:srgbClr>
+                          </a:solidFill>
+                          <a:latin typeface="Helvetica Neue"/>
+                          <a:cs typeface="Helvetica Neue"/>
+                          <a:ea typeface="Helvetica Neue"/>
+                          <a:sym typeface="Helvetica Neue"/>
+                        </a:rPr>
+                        <a:t>1</a:t>
+                      </a:r>
+                    </a:p>
+                  </a:txBody>
+                  <a:tcPr anchor="ctr" marB="63500" marT="63500" marR="0" marL="0">
+                    <a:lnL algn="ctr" cmpd="sng" cap="flat" w="0">
+                      <a:noFill/>
+                      <a:prstDash val="solid"/>
+                    </a:lnL>
+                    <a:lnR algn="ctr" cmpd="sng" cap="flat" w="0">
+                      <a:noFill/>
+                      <a:prstDash val="solid"/>
+                    </a:lnR>
+                    <a:lnT algn="ctr" cmpd="sng" cap="flat" w="0">
+                      <a:noFill/>
+                      <a:prstDash val="solid"/>
+                    </a:lnT>
+                    <a:lnB algn="ctr" cmpd="sng" cap="flat" w="0">
+                      <a:noFill/>
+                      <a:prstDash val="solid"/>
+                    </a:lnB>
+                    <a:solidFill>
+                      <a:srgbClr val="FFFFFF">
+                        <a:alpha val="0"/>
+                      </a:srgbClr>
+                    </a:solidFill>
+                  </a:tcPr>
+                </a:tc>
+                <a:tc>
+                  <a:txBody>
+                    <a:bodyPr/>
+                    <a:lstStyle/>
+                    <a:p>
+                      <a:pPr algn="l" marL="63500" marR="63500">
+                        <a:lnSpc>
+                          <a:spcPct val="100000"/>
+                        </a:lnSpc>
+                        <a:spcBef>
+                          <a:spcPts val="500"/>
+                        </a:spcBef>
+                        <a:spcAft>
+                          <a:spcPts val="500"/>
+                        </a:spcAft>
+                        <a:buNone/>
+                      </a:pPr>
+                      <a:r>
+                        <a:rPr cap="none" sz="1200" i="0" b="0" u="none" strike="noStrike">
+                          <a:solidFill>
+                            <a:srgbClr val="5B6770">
+                              <a:alpha val="100000"/>
+                            </a:srgbClr>
+                          </a:solidFill>
+                          <a:latin typeface="Helvetica Neue"/>
+                          <a:cs typeface="Helvetica Neue"/>
+                          <a:ea typeface="Helvetica Neue"/>
+                          <a:sym typeface="Helvetica Neue"/>
+                        </a:rPr>
+                        <a:t>604357</a:t>
+                      </a:r>
+                    </a:p>
+                  </a:txBody>
+                  <a:tcPr anchor="ctr" marB="63500" marT="63500" marR="0" marL="0">
+                    <a:lnL algn="ctr" cmpd="sng" cap="flat" w="0">
+                      <a:noFill/>
+                      <a:prstDash val="solid"/>
+                    </a:lnL>
+                    <a:lnR algn="ctr" cmpd="sng" cap="flat" w="0">
+                      <a:noFill/>
+                      <a:prstDash val="solid"/>
+                    </a:lnR>
+                    <a:lnT algn="ctr" cmpd="sng" cap="flat" w="0">
+                      <a:noFill/>
+                      <a:prstDash val="solid"/>
+                    </a:lnT>
+                    <a:lnB algn="ctr" cmpd="sng" cap="flat" w="0">
+                      <a:noFill/>
+                      <a:prstDash val="solid"/>
+                    </a:lnB>
+                    <a:solidFill>
+                      <a:srgbClr val="FFFFFF">
+                        <a:alpha val="0"/>
+                      </a:srgbClr>
+                    </a:solidFill>
+                  </a:tcPr>
+                </a:tc>
+              </a:tr>
+              <a:tr h="401320">
+                <a:tc>
+                  <a:txBody>
+                    <a:bodyPr/>
+                    <a:lstStyle/>
+                    <a:p>
+                      <a:pPr algn="l" marL="63500" marR="63500">
+                        <a:lnSpc>
+                          <a:spcPct val="100000"/>
+                        </a:lnSpc>
+                        <a:spcBef>
+                          <a:spcPts val="500"/>
+                        </a:spcBef>
+                        <a:spcAft>
+                          <a:spcPts val="500"/>
+                        </a:spcAft>
+                        <a:buNone/>
+                      </a:pPr>
+                      <a:r>
+                        <a:rPr cap="none" sz="1200" i="0" b="0" u="none" strike="noStrike">
+                          <a:solidFill>
+                            <a:srgbClr val="5B6770">
+                              <a:alpha val="100000"/>
+                            </a:srgbClr>
+                          </a:solidFill>
+                          <a:latin typeface="Helvetica Neue"/>
+                          <a:cs typeface="Helvetica Neue"/>
+                          <a:ea typeface="Helvetica Neue"/>
+                          <a:sym typeface="Helvetica Neue"/>
+                        </a:rPr>
                         <a:t>chlorphenamine</a:t>
                       </a:r>
                     </a:p>
@@ -24964,8 +25251,8 @@
                       <a:prstDash val="solid"/>
                     </a:lnB>
                     <a:solidFill>
-                      <a:srgbClr val="FFFFFF">
-                        <a:alpha val="0"/>
+                      <a:srgbClr val="F4F8FB">
+                        <a:alpha val="100000"/>
                       </a:srgbClr>
                     </a:solidFill>
                   </a:tcPr>
@@ -25021,8 +25308,8 @@
                       <a:prstDash val="solid"/>
                     </a:lnB>
                     <a:solidFill>
-                      <a:srgbClr val="FFFFFF">
-                        <a:alpha val="0"/>
+                      <a:srgbClr val="F4F8FB">
+                        <a:alpha val="100000"/>
                       </a:srgbClr>
                     </a:solidFill>
                   </a:tcPr>
@@ -25078,8 +25365,8 @@
                       <a:prstDash val="solid"/>
                     </a:lnB>
                     <a:solidFill>
-                      <a:srgbClr val="FFFFFF">
-                        <a:alpha val="0"/>
+                      <a:srgbClr val="F4F8FB">
+                        <a:alpha val="100000"/>
                       </a:srgbClr>
                     </a:solidFill>
                   </a:tcPr>
@@ -25135,8 +25422,8 @@
                       <a:prstDash val="solid"/>
                     </a:lnB>
                     <a:solidFill>
-                      <a:srgbClr val="FFFFFF">
-                        <a:alpha val="0"/>
+                      <a:srgbClr val="F4F8FB">
+                        <a:alpha val="100000"/>
                       </a:srgbClr>
                     </a:solidFill>
                   </a:tcPr>
@@ -25192,8 +25479,8 @@
                       <a:prstDash val="solid"/>
                     </a:lnB>
                     <a:solidFill>
-                      <a:srgbClr val="FFFFFF">
-                        <a:alpha val="0"/>
+                      <a:srgbClr val="F4F8FB">
+                        <a:alpha val="100000"/>
                       </a:srgbClr>
                     </a:solidFill>
                   </a:tcPr>
@@ -25251,8 +25538,8 @@
                       <a:prstDash val="solid"/>
                     </a:lnB>
                     <a:solidFill>
-                      <a:srgbClr val="F4F8FB">
-                        <a:alpha val="100000"/>
+                      <a:srgbClr val="FFFFFF">
+                        <a:alpha val="0"/>
                       </a:srgbClr>
                     </a:solidFill>
                   </a:tcPr>
@@ -25308,8 +25595,8 @@
                       <a:prstDash val="solid"/>
                     </a:lnB>
                     <a:solidFill>
-                      <a:srgbClr val="F4F8FB">
-                        <a:alpha val="100000"/>
+                      <a:srgbClr val="FFFFFF">
+                        <a:alpha val="0"/>
                       </a:srgbClr>
                     </a:solidFill>
                   </a:tcPr>
@@ -25365,8 +25652,8 @@
                       <a:prstDash val="solid"/>
                     </a:lnB>
                     <a:solidFill>
-                      <a:srgbClr val="F4F8FB">
-                        <a:alpha val="100000"/>
+                      <a:srgbClr val="FFFFFF">
+                        <a:alpha val="0"/>
                       </a:srgbClr>
                     </a:solidFill>
                   </a:tcPr>
@@ -25422,8 +25709,8 @@
                       <a:prstDash val="solid"/>
                     </a:lnB>
                     <a:solidFill>
-                      <a:srgbClr val="F4F8FB">
-                        <a:alpha val="100000"/>
+                      <a:srgbClr val="FFFFFF">
+                        <a:alpha val="0"/>
                       </a:srgbClr>
                     </a:solidFill>
                   </a:tcPr>
@@ -25479,8 +25766,8 @@
                       <a:prstDash val="solid"/>
                     </a:lnB>
                     <a:solidFill>
-                      <a:srgbClr val="F4F8FB">
-                        <a:alpha val="100000"/>
+                      <a:srgbClr val="FFFFFF">
+                        <a:alpha val="0"/>
                       </a:srgbClr>
                     </a:solidFill>
                   </a:tcPr>
@@ -25538,8 +25825,8 @@
                       <a:prstDash val="solid"/>
                     </a:lnB>
                     <a:solidFill>
-                      <a:srgbClr val="FFFFFF">
-                        <a:alpha val="0"/>
+                      <a:srgbClr val="F4F8FB">
+                        <a:alpha val="100000"/>
                       </a:srgbClr>
                     </a:solidFill>
                   </a:tcPr>
@@ -25595,8 +25882,8 @@
                       <a:prstDash val="solid"/>
                     </a:lnB>
                     <a:solidFill>
-                      <a:srgbClr val="FFFFFF">
-                        <a:alpha val="0"/>
+                      <a:srgbClr val="F4F8FB">
+                        <a:alpha val="100000"/>
                       </a:srgbClr>
                     </a:solidFill>
                   </a:tcPr>
@@ -25652,8 +25939,8 @@
                       <a:prstDash val="solid"/>
                     </a:lnB>
                     <a:solidFill>
-                      <a:srgbClr val="FFFFFF">
-                        <a:alpha val="0"/>
+                      <a:srgbClr val="F4F8FB">
+                        <a:alpha val="100000"/>
                       </a:srgbClr>
                     </a:solidFill>
                   </a:tcPr>
@@ -25709,8 +25996,8 @@
                       <a:prstDash val="solid"/>
                     </a:lnB>
                     <a:solidFill>
-                      <a:srgbClr val="FFFFFF">
-                        <a:alpha val="0"/>
+                      <a:srgbClr val="F4F8FB">
+                        <a:alpha val="100000"/>
                       </a:srgbClr>
                     </a:solidFill>
                   </a:tcPr>
@@ -25766,8 +26053,8 @@
                       <a:prstDash val="solid"/>
                     </a:lnB>
                     <a:solidFill>
-                      <a:srgbClr val="FFFFFF">
-                        <a:alpha val="0"/>
+                      <a:srgbClr val="F4F8FB">
+                        <a:alpha val="100000"/>
                       </a:srgbClr>
                     </a:solidFill>
                   </a:tcPr>
@@ -25825,8 +26112,8 @@
                       <a:prstDash val="solid"/>
                     </a:lnB>
                     <a:solidFill>
-                      <a:srgbClr val="F4F8FB">
-                        <a:alpha val="100000"/>
+                      <a:srgbClr val="FFFFFF">
+                        <a:alpha val="0"/>
                       </a:srgbClr>
                     </a:solidFill>
                   </a:tcPr>
@@ -25882,8 +26169,8 @@
                       <a:prstDash val="solid"/>
                     </a:lnB>
                     <a:solidFill>
-                      <a:srgbClr val="F4F8FB">
-                        <a:alpha val="100000"/>
+                      <a:srgbClr val="FFFFFF">
+                        <a:alpha val="0"/>
                       </a:srgbClr>
                     </a:solidFill>
                   </a:tcPr>
@@ -25939,8 +26226,8 @@
                       <a:prstDash val="solid"/>
                     </a:lnB>
                     <a:solidFill>
-                      <a:srgbClr val="F4F8FB">
-                        <a:alpha val="100000"/>
+                      <a:srgbClr val="FFFFFF">
+                        <a:alpha val="0"/>
                       </a:srgbClr>
                     </a:solidFill>
                   </a:tcPr>
@@ -25996,8 +26283,8 @@
                       <a:prstDash val="solid"/>
                     </a:lnB>
                     <a:solidFill>
-                      <a:srgbClr val="F4F8FB">
-                        <a:alpha val="100000"/>
+                      <a:srgbClr val="FFFFFF">
+                        <a:alpha val="0"/>
                       </a:srgbClr>
                     </a:solidFill>
                   </a:tcPr>
@@ -26053,8 +26340,8 @@
                       <a:prstDash val="solid"/>
                     </a:lnB>
                     <a:solidFill>
-                      <a:srgbClr val="F4F8FB">
-                        <a:alpha val="100000"/>
+                      <a:srgbClr val="FFFFFF">
+                        <a:alpha val="0"/>
                       </a:srgbClr>
                     </a:solidFill>
                   </a:tcPr>
@@ -26112,8 +26399,8 @@
                       <a:prstDash val="solid"/>
                     </a:lnB>
                     <a:solidFill>
-                      <a:srgbClr val="FFFFFF">
-                        <a:alpha val="0"/>
+                      <a:srgbClr val="F4F8FB">
+                        <a:alpha val="100000"/>
                       </a:srgbClr>
                     </a:solidFill>
                   </a:tcPr>
@@ -26169,8 +26456,8 @@
                       <a:prstDash val="solid"/>
                     </a:lnB>
                     <a:solidFill>
-                      <a:srgbClr val="FFFFFF">
-                        <a:alpha val="0"/>
+                      <a:srgbClr val="F4F8FB">
+                        <a:alpha val="100000"/>
                       </a:srgbClr>
                     </a:solidFill>
                   </a:tcPr>
@@ -26226,8 +26513,8 @@
                       <a:prstDash val="solid"/>
                     </a:lnB>
                     <a:solidFill>
-                      <a:srgbClr val="FFFFFF">
-                        <a:alpha val="0"/>
+                      <a:srgbClr val="F4F8FB">
+                        <a:alpha val="100000"/>
                       </a:srgbClr>
                     </a:solidFill>
                   </a:tcPr>
@@ -26283,8 +26570,8 @@
                       <a:prstDash val="solid"/>
                     </a:lnB>
                     <a:solidFill>
-                      <a:srgbClr val="FFFFFF">
-                        <a:alpha val="0"/>
+                      <a:srgbClr val="F4F8FB">
+                        <a:alpha val="100000"/>
                       </a:srgbClr>
                     </a:solidFill>
                   </a:tcPr>
@@ -26340,8 +26627,8 @@
                       <a:prstDash val="solid"/>
                     </a:lnB>
                     <a:solidFill>
-                      <a:srgbClr val="FFFFFF">
-                        <a:alpha val="0"/>
+                      <a:srgbClr val="F4F8FB">
+                        <a:alpha val="100000"/>
                       </a:srgbClr>
                     </a:solidFill>
                   </a:tcPr>
@@ -26399,8 +26686,8 @@
                       <a:prstDash val="solid"/>
                     </a:lnB>
                     <a:solidFill>
-                      <a:srgbClr val="F4F8FB">
-                        <a:alpha val="100000"/>
+                      <a:srgbClr val="FFFFFF">
+                        <a:alpha val="0"/>
                       </a:srgbClr>
                     </a:solidFill>
                   </a:tcPr>
@@ -26456,8 +26743,8 @@
                       <a:prstDash val="solid"/>
                     </a:lnB>
                     <a:solidFill>
-                      <a:srgbClr val="F4F8FB">
-                        <a:alpha val="100000"/>
+                      <a:srgbClr val="FFFFFF">
+                        <a:alpha val="0"/>
                       </a:srgbClr>
                     </a:solidFill>
                   </a:tcPr>
@@ -26513,8 +26800,8 @@
                       <a:prstDash val="solid"/>
                     </a:lnB>
                     <a:solidFill>
-                      <a:srgbClr val="F4F8FB">
-                        <a:alpha val="100000"/>
+                      <a:srgbClr val="FFFFFF">
+                        <a:alpha val="0"/>
                       </a:srgbClr>
                     </a:solidFill>
                   </a:tcPr>
@@ -26570,8 +26857,8 @@
                       <a:prstDash val="solid"/>
                     </a:lnB>
                     <a:solidFill>
-                      <a:srgbClr val="F4F8FB">
-                        <a:alpha val="100000"/>
+                      <a:srgbClr val="FFFFFF">
+                        <a:alpha val="0"/>
                       </a:srgbClr>
                     </a:solidFill>
                   </a:tcPr>
@@ -26627,8 +26914,8 @@
                       <a:prstDash val="solid"/>
                     </a:lnB>
                     <a:solidFill>
-                      <a:srgbClr val="F4F8FB">
-                        <a:alpha val="100000"/>
+                      <a:srgbClr val="FFFFFF">
+                        <a:alpha val="0"/>
                       </a:srgbClr>
                     </a:solidFill>
                   </a:tcPr>
@@ -26686,8 +26973,8 @@
                       <a:prstDash val="solid"/>
                     </a:lnB>
                     <a:solidFill>
-                      <a:srgbClr val="FFFFFF">
-                        <a:alpha val="0"/>
+                      <a:srgbClr val="F4F8FB">
+                        <a:alpha val="100000"/>
                       </a:srgbClr>
                     </a:solidFill>
                   </a:tcPr>
@@ -26743,8 +27030,8 @@
                       <a:prstDash val="solid"/>
                     </a:lnB>
                     <a:solidFill>
-                      <a:srgbClr val="FFFFFF">
-                        <a:alpha val="0"/>
+                      <a:srgbClr val="F4F8FB">
+                        <a:alpha val="100000"/>
                       </a:srgbClr>
                     </a:solidFill>
                   </a:tcPr>
@@ -26800,8 +27087,8 @@
                       <a:prstDash val="solid"/>
                     </a:lnB>
                     <a:solidFill>
-                      <a:srgbClr val="FFFFFF">
-                        <a:alpha val="0"/>
+                      <a:srgbClr val="F4F8FB">
+                        <a:alpha val="100000"/>
                       </a:srgbClr>
                     </a:solidFill>
                   </a:tcPr>
@@ -26857,8 +27144,8 @@
                       <a:prstDash val="solid"/>
                     </a:lnB>
                     <a:solidFill>
-                      <a:srgbClr val="FFFFFF">
-                        <a:alpha val="0"/>
+                      <a:srgbClr val="F4F8FB">
+                        <a:alpha val="100000"/>
                       </a:srgbClr>
                     </a:solidFill>
                   </a:tcPr>
@@ -26914,8 +27201,8 @@
                       <a:prstDash val="solid"/>
                     </a:lnB>
                     <a:solidFill>
-                      <a:srgbClr val="FFFFFF">
-                        <a:alpha val="0"/>
+                      <a:srgbClr val="F4F8FB">
+                        <a:alpha val="100000"/>
                       </a:srgbClr>
                     </a:solidFill>
                   </a:tcPr>
@@ -26973,8 +27260,8 @@
                       <a:prstDash val="solid"/>
                     </a:lnB>
                     <a:solidFill>
-                      <a:srgbClr val="F4F8FB">
-                        <a:alpha val="100000"/>
+                      <a:srgbClr val="FFFFFF">
+                        <a:alpha val="0"/>
                       </a:srgbClr>
                     </a:solidFill>
                   </a:tcPr>
@@ -27030,8 +27317,8 @@
                       <a:prstDash val="solid"/>
                     </a:lnB>
                     <a:solidFill>
-                      <a:srgbClr val="F4F8FB">
-                        <a:alpha val="100000"/>
+                      <a:srgbClr val="FFFFFF">
+                        <a:alpha val="0"/>
                       </a:srgbClr>
                     </a:solidFill>
                   </a:tcPr>
@@ -27087,8 +27374,8 @@
                       <a:prstDash val="solid"/>
                     </a:lnB>
                     <a:solidFill>
-                      <a:srgbClr val="F4F8FB">
-                        <a:alpha val="100000"/>
+                      <a:srgbClr val="FFFFFF">
+                        <a:alpha val="0"/>
                       </a:srgbClr>
                     </a:solidFill>
                   </a:tcPr>
@@ -27144,8 +27431,8 @@
                       <a:prstDash val="solid"/>
                     </a:lnB>
                     <a:solidFill>
-                      <a:srgbClr val="F4F8FB">
-                        <a:alpha val="100000"/>
+                      <a:srgbClr val="FFFFFF">
+                        <a:alpha val="0"/>
                       </a:srgbClr>
                     </a:solidFill>
                   </a:tcPr>
@@ -27201,8 +27488,8 @@
                       <a:prstDash val="solid"/>
                     </a:lnB>
                     <a:solidFill>
-                      <a:srgbClr val="F4F8FB">
-                        <a:alpha val="100000"/>
+                      <a:srgbClr val="FFFFFF">
+                        <a:alpha val="0"/>
                       </a:srgbClr>
                     </a:solidFill>
                   </a:tcPr>
@@ -27260,8 +27547,8 @@
                       <a:prstDash val="solid"/>
                     </a:lnB>
                     <a:solidFill>
-                      <a:srgbClr val="FFFFFF">
-                        <a:alpha val="0"/>
+                      <a:srgbClr val="F4F8FB">
+                        <a:alpha val="100000"/>
                       </a:srgbClr>
                     </a:solidFill>
                   </a:tcPr>
@@ -27317,8 +27604,8 @@
                       <a:prstDash val="solid"/>
                     </a:lnB>
                     <a:solidFill>
-                      <a:srgbClr val="FFFFFF">
-                        <a:alpha val="0"/>
+                      <a:srgbClr val="F4F8FB">
+                        <a:alpha val="100000"/>
                       </a:srgbClr>
                     </a:solidFill>
                   </a:tcPr>
@@ -27374,8 +27661,8 @@
                       <a:prstDash val="solid"/>
                     </a:lnB>
                     <a:solidFill>
-                      <a:srgbClr val="FFFFFF">
-                        <a:alpha val="0"/>
+                      <a:srgbClr val="F4F8FB">
+                        <a:alpha val="100000"/>
                       </a:srgbClr>
                     </a:solidFill>
                   </a:tcPr>
@@ -27431,8 +27718,8 @@
                       <a:prstDash val="solid"/>
                     </a:lnB>
                     <a:solidFill>
-                      <a:srgbClr val="FFFFFF">
-                        <a:alpha val="0"/>
+                      <a:srgbClr val="F4F8FB">
+                        <a:alpha val="100000"/>
                       </a:srgbClr>
                     </a:solidFill>
                   </a:tcPr>
@@ -27488,8 +27775,8 @@
                       <a:prstDash val="solid"/>
                     </a:lnB>
                     <a:solidFill>
-                      <a:srgbClr val="FFFFFF">
-                        <a:alpha val="0"/>
+                      <a:srgbClr val="F4F8FB">
+                        <a:alpha val="100000"/>
                       </a:srgbClr>
                     </a:solidFill>
                   </a:tcPr>
@@ -27547,8 +27834,8 @@
                       <a:prstDash val="solid"/>
                     </a:lnB>
                     <a:solidFill>
-                      <a:srgbClr val="F4F8FB">
-                        <a:alpha val="100000"/>
+                      <a:srgbClr val="FFFFFF">
+                        <a:alpha val="0"/>
                       </a:srgbClr>
                     </a:solidFill>
                   </a:tcPr>
@@ -27604,8 +27891,8 @@
                       <a:prstDash val="solid"/>
                     </a:lnB>
                     <a:solidFill>
-                      <a:srgbClr val="F4F8FB">
-                        <a:alpha val="100000"/>
+                      <a:srgbClr val="FFFFFF">
+                        <a:alpha val="0"/>
                       </a:srgbClr>
                     </a:solidFill>
                   </a:tcPr>
@@ -27661,8 +27948,8 @@
                       <a:prstDash val="solid"/>
                     </a:lnB>
                     <a:solidFill>
-                      <a:srgbClr val="F4F8FB">
-                        <a:alpha val="100000"/>
+                      <a:srgbClr val="FFFFFF">
+                        <a:alpha val="0"/>
                       </a:srgbClr>
                     </a:solidFill>
                   </a:tcPr>
@@ -27718,8 +28005,8 @@
                       <a:prstDash val="solid"/>
                     </a:lnB>
                     <a:solidFill>
-                      <a:srgbClr val="F4F8FB">
-                        <a:alpha val="100000"/>
+                      <a:srgbClr val="FFFFFF">
+                        <a:alpha val="0"/>
                       </a:srgbClr>
                     </a:solidFill>
                   </a:tcPr>
@@ -27775,14 +28062,14 @@
                       <a:prstDash val="solid"/>
                     </a:lnB>
                     <a:solidFill>
-                      <a:srgbClr val="F4F8FB">
-                        <a:alpha val="100000"/>
+                      <a:srgbClr val="FFFFFF">
+                        <a:alpha val="0"/>
                       </a:srgbClr>
                     </a:solidFill>
                   </a:tcPr>
                 </a:tc>
               </a:tr>
-              <a:tr h="401320">
+              <a:tr h="410845">
                 <a:tc>
                   <a:txBody>
                     <a:bodyPr/>
@@ -27829,13 +28116,17 @@
                       <a:noFill/>
                       <a:prstDash val="solid"/>
                     </a:lnT>
-                    <a:lnB algn="ctr" cmpd="sng" cap="flat" w="0">
-                      <a:noFill/>
+                    <a:lnB algn="ctr" cmpd="sng" cap="flat" w="19050">
+                      <a:solidFill>
+                        <a:srgbClr val="666666">
+                          <a:alpha val="100000"/>
+                        </a:srgbClr>
+                      </a:solidFill>
                       <a:prstDash val="solid"/>
                     </a:lnB>
                     <a:solidFill>
-                      <a:srgbClr val="FFFFFF">
-                        <a:alpha val="0"/>
+                      <a:srgbClr val="F4F8FB">
+                        <a:alpha val="100000"/>
                       </a:srgbClr>
                     </a:solidFill>
                   </a:tcPr>
@@ -27886,13 +28177,17 @@
                       <a:noFill/>
                       <a:prstDash val="solid"/>
                     </a:lnT>
-                    <a:lnB algn="ctr" cmpd="sng" cap="flat" w="0">
-                      <a:noFill/>
+                    <a:lnB algn="ctr" cmpd="sng" cap="flat" w="19050">
+                      <a:solidFill>
+                        <a:srgbClr val="666666">
+                          <a:alpha val="100000"/>
+                        </a:srgbClr>
+                      </a:solidFill>
                       <a:prstDash val="solid"/>
                     </a:lnB>
                     <a:solidFill>
-                      <a:srgbClr val="FFFFFF">
-                        <a:alpha val="0"/>
+                      <a:srgbClr val="F4F8FB">
+                        <a:alpha val="100000"/>
                       </a:srgbClr>
                     </a:solidFill>
                   </a:tcPr>
@@ -27943,13 +28238,17 @@
                       <a:noFill/>
                       <a:prstDash val="solid"/>
                     </a:lnT>
-                    <a:lnB algn="ctr" cmpd="sng" cap="flat" w="0">
-                      <a:noFill/>
+                    <a:lnB algn="ctr" cmpd="sng" cap="flat" w="19050">
+                      <a:solidFill>
+                        <a:srgbClr val="666666">
+                          <a:alpha val="100000"/>
+                        </a:srgbClr>
+                      </a:solidFill>
                       <a:prstDash val="solid"/>
                     </a:lnB>
                     <a:solidFill>
-                      <a:srgbClr val="FFFFFF">
-                        <a:alpha val="0"/>
+                      <a:srgbClr val="F4F8FB">
+                        <a:alpha val="100000"/>
                       </a:srgbClr>
                     </a:solidFill>
                   </a:tcPr>
@@ -28000,122 +28299,6 @@
                       <a:noFill/>
                       <a:prstDash val="solid"/>
                     </a:lnT>
-                    <a:lnB algn="ctr" cmpd="sng" cap="flat" w="0">
-                      <a:noFill/>
-                      <a:prstDash val="solid"/>
-                    </a:lnB>
-                    <a:solidFill>
-                      <a:srgbClr val="FFFFFF">
-                        <a:alpha val="0"/>
-                      </a:srgbClr>
-                    </a:solidFill>
-                  </a:tcPr>
-                </a:tc>
-                <a:tc>
-                  <a:txBody>
-                    <a:bodyPr/>
-                    <a:lstStyle/>
-                    <a:p>
-                      <a:pPr algn="l" marL="63500" marR="63500">
-                        <a:lnSpc>
-                          <a:spcPct val="100000"/>
-                        </a:lnSpc>
-                        <a:spcBef>
-                          <a:spcPts val="500"/>
-                        </a:spcBef>
-                        <a:spcAft>
-                          <a:spcPts val="500"/>
-                        </a:spcAft>
-                        <a:buNone/>
-                      </a:pPr>
-                      <a:r>
-                        <a:rPr cap="none" sz="1200" i="0" b="0" u="none" strike="noStrike">
-                          <a:solidFill>
-                            <a:srgbClr val="5B6770">
-                              <a:alpha val="100000"/>
-                            </a:srgbClr>
-                          </a:solidFill>
-                          <a:latin typeface="Helvetica Neue"/>
-                          <a:cs typeface="Helvetica Neue"/>
-                          <a:ea typeface="Helvetica Neue"/>
-                          <a:sym typeface="Helvetica Neue"/>
-                        </a:rPr>
-                        <a:t>900817</a:t>
-                      </a:r>
-                    </a:p>
-                  </a:txBody>
-                  <a:tcPr anchor="ctr" marB="63500" marT="63500" marR="0" marL="0">
-                    <a:lnL algn="ctr" cmpd="sng" cap="flat" w="0">
-                      <a:noFill/>
-                      <a:prstDash val="solid"/>
-                    </a:lnL>
-                    <a:lnR algn="ctr" cmpd="sng" cap="flat" w="0">
-                      <a:noFill/>
-                      <a:prstDash val="solid"/>
-                    </a:lnR>
-                    <a:lnT algn="ctr" cmpd="sng" cap="flat" w="0">
-                      <a:noFill/>
-                      <a:prstDash val="solid"/>
-                    </a:lnT>
-                    <a:lnB algn="ctr" cmpd="sng" cap="flat" w="0">
-                      <a:noFill/>
-                      <a:prstDash val="solid"/>
-                    </a:lnB>
-                    <a:solidFill>
-                      <a:srgbClr val="FFFFFF">
-                        <a:alpha val="0"/>
-                      </a:srgbClr>
-                    </a:solidFill>
-                  </a:tcPr>
-                </a:tc>
-              </a:tr>
-              <a:tr h="410845">
-                <a:tc>
-                  <a:txBody>
-                    <a:bodyPr/>
-                    <a:lstStyle/>
-                    <a:p>
-                      <a:pPr algn="l" marL="63500" marR="63500">
-                        <a:lnSpc>
-                          <a:spcPct val="100000"/>
-                        </a:lnSpc>
-                        <a:spcBef>
-                          <a:spcPts val="500"/>
-                        </a:spcBef>
-                        <a:spcAft>
-                          <a:spcPts val="500"/>
-                        </a:spcAft>
-                        <a:buNone/>
-                      </a:pPr>
-                      <a:r>
-                        <a:rPr cap="none" sz="1200" i="0" b="0" u="none" strike="noStrike">
-                          <a:solidFill>
-                            <a:srgbClr val="5B6770">
-                              <a:alpha val="100000"/>
-                            </a:srgbClr>
-                          </a:solidFill>
-                          <a:latin typeface="Helvetica Neue"/>
-                          <a:cs typeface="Helvetica Neue"/>
-                          <a:ea typeface="Helvetica Neue"/>
-                          <a:sym typeface="Helvetica Neue"/>
-                        </a:rPr>
-                        <a:t>2-fluoro-2-oxo-PCiPr</a:t>
-                      </a:r>
-                    </a:p>
-                  </a:txBody>
-                  <a:tcPr anchor="ctr" marB="63500" marT="63500" marR="0" marL="0">
-                    <a:lnL algn="ctr" cmpd="sng" cap="flat" w="0">
-                      <a:noFill/>
-                      <a:prstDash val="solid"/>
-                    </a:lnL>
-                    <a:lnR algn="ctr" cmpd="sng" cap="flat" w="0">
-                      <a:noFill/>
-                      <a:prstDash val="solid"/>
-                    </a:lnR>
-                    <a:lnT algn="ctr" cmpd="sng" cap="flat" w="0">
-                      <a:noFill/>
-                      <a:prstDash val="solid"/>
-                    </a:lnT>
                     <a:lnB algn="ctr" cmpd="sng" cap="flat" w="19050">
                       <a:solidFill>
                         <a:srgbClr val="666666">
@@ -28160,190 +28343,7 @@
                           <a:ea typeface="Helvetica Neue"/>
                           <a:sym typeface="Helvetica Neue"/>
                         </a:rPr>
-                        <a:t>16 Jun 2026</a:t>
-                      </a:r>
-                    </a:p>
-                  </a:txBody>
-                  <a:tcPr anchor="ctr" marB="63500" marT="63500" marR="0" marL="0">
-                    <a:lnL algn="ctr" cmpd="sng" cap="flat" w="0">
-                      <a:noFill/>
-                      <a:prstDash val="solid"/>
-                    </a:lnL>
-                    <a:lnR algn="ctr" cmpd="sng" cap="flat" w="0">
-                      <a:noFill/>
-                      <a:prstDash val="solid"/>
-                    </a:lnR>
-                    <a:lnT algn="ctr" cmpd="sng" cap="flat" w="0">
-                      <a:noFill/>
-                      <a:prstDash val="solid"/>
-                    </a:lnT>
-                    <a:lnB algn="ctr" cmpd="sng" cap="flat" w="19050">
-                      <a:solidFill>
-                        <a:srgbClr val="666666">
-                          <a:alpha val="100000"/>
-                        </a:srgbClr>
-                      </a:solidFill>
-                      <a:prstDash val="solid"/>
-                    </a:lnB>
-                    <a:solidFill>
-                      <a:srgbClr val="F4F8FB">
-                        <a:alpha val="100000"/>
-                      </a:srgbClr>
-                    </a:solidFill>
-                  </a:tcPr>
-                </a:tc>
-                <a:tc>
-                  <a:txBody>
-                    <a:bodyPr/>
-                    <a:lstStyle/>
-                    <a:p>
-                      <a:pPr algn="l" marL="63500" marR="63500">
-                        <a:lnSpc>
-                          <a:spcPct val="100000"/>
-                        </a:lnSpc>
-                        <a:spcBef>
-                          <a:spcPts val="500"/>
-                        </a:spcBef>
-                        <a:spcAft>
-                          <a:spcPts val="500"/>
-                        </a:spcAft>
-                        <a:buNone/>
-                      </a:pPr>
-                      <a:r>
-                        <a:rPr cap="none" sz="1200" i="0" b="0" u="none" strike="noStrike">
-                          <a:solidFill>
-                            <a:srgbClr val="5B6770">
-                              <a:alpha val="100000"/>
-                            </a:srgbClr>
-                          </a:solidFill>
-                          <a:latin typeface="Helvetica Neue"/>
-                          <a:cs typeface="Helvetica Neue"/>
-                          <a:ea typeface="Helvetica Neue"/>
-                          <a:sym typeface="Helvetica Neue"/>
-                        </a:rPr>
-                        <a:t>primary</a:t>
-                      </a:r>
-                    </a:p>
-                  </a:txBody>
-                  <a:tcPr anchor="ctr" marB="63500" marT="63500" marR="0" marL="0">
-                    <a:lnL algn="ctr" cmpd="sng" cap="flat" w="0">
-                      <a:noFill/>
-                      <a:prstDash val="solid"/>
-                    </a:lnL>
-                    <a:lnR algn="ctr" cmpd="sng" cap="flat" w="0">
-                      <a:noFill/>
-                      <a:prstDash val="solid"/>
-                    </a:lnR>
-                    <a:lnT algn="ctr" cmpd="sng" cap="flat" w="0">
-                      <a:noFill/>
-                      <a:prstDash val="solid"/>
-                    </a:lnT>
-                    <a:lnB algn="ctr" cmpd="sng" cap="flat" w="19050">
-                      <a:solidFill>
-                        <a:srgbClr val="666666">
-                          <a:alpha val="100000"/>
-                        </a:srgbClr>
-                      </a:solidFill>
-                      <a:prstDash val="solid"/>
-                    </a:lnB>
-                    <a:solidFill>
-                      <a:srgbClr val="F4F8FB">
-                        <a:alpha val="100000"/>
-                      </a:srgbClr>
-                    </a:solidFill>
-                  </a:tcPr>
-                </a:tc>
-                <a:tc>
-                  <a:txBody>
-                    <a:bodyPr/>
-                    <a:lstStyle/>
-                    <a:p>
-                      <a:pPr algn="r" marL="63500" marR="63500">
-                        <a:lnSpc>
-                          <a:spcPct val="100000"/>
-                        </a:lnSpc>
-                        <a:spcBef>
-                          <a:spcPts val="500"/>
-                        </a:spcBef>
-                        <a:spcAft>
-                          <a:spcPts val="500"/>
-                        </a:spcAft>
-                        <a:buNone/>
-                      </a:pPr>
-                      <a:r>
-                        <a:rPr cap="none" sz="1200" i="0" b="0" u="none" strike="noStrike">
-                          <a:solidFill>
-                            <a:srgbClr val="5B6770">
-                              <a:alpha val="100000"/>
-                            </a:srgbClr>
-                          </a:solidFill>
-                          <a:latin typeface="Helvetica Neue"/>
-                          <a:cs typeface="Helvetica Neue"/>
-                          <a:ea typeface="Helvetica Neue"/>
-                          <a:sym typeface="Helvetica Neue"/>
-                        </a:rPr>
-                        <a:t>1</a:t>
-                      </a:r>
-                    </a:p>
-                  </a:txBody>
-                  <a:tcPr anchor="ctr" marB="63500" marT="63500" marR="0" marL="0">
-                    <a:lnL algn="ctr" cmpd="sng" cap="flat" w="0">
-                      <a:noFill/>
-                      <a:prstDash val="solid"/>
-                    </a:lnL>
-                    <a:lnR algn="ctr" cmpd="sng" cap="flat" w="0">
-                      <a:noFill/>
-                      <a:prstDash val="solid"/>
-                    </a:lnR>
-                    <a:lnT algn="ctr" cmpd="sng" cap="flat" w="0">
-                      <a:noFill/>
-                      <a:prstDash val="solid"/>
-                    </a:lnT>
-                    <a:lnB algn="ctr" cmpd="sng" cap="flat" w="19050">
-                      <a:solidFill>
-                        <a:srgbClr val="666666">
-                          <a:alpha val="100000"/>
-                        </a:srgbClr>
-                      </a:solidFill>
-                      <a:prstDash val="solid"/>
-                    </a:lnB>
-                    <a:solidFill>
-                      <a:srgbClr val="F4F8FB">
-                        <a:alpha val="100000"/>
-                      </a:srgbClr>
-                    </a:solidFill>
-                  </a:tcPr>
-                </a:tc>
-                <a:tc>
-                  <a:txBody>
-                    <a:bodyPr/>
-                    <a:lstStyle/>
-                    <a:p>
-                      <a:pPr algn="l" marL="63500" marR="63500">
-                        <a:lnSpc>
-                          <a:spcPct val="100000"/>
-                        </a:lnSpc>
-                        <a:spcBef>
-                          <a:spcPts val="500"/>
-                        </a:spcBef>
-                        <a:spcAft>
-                          <a:spcPts val="500"/>
-                        </a:spcAft>
-                        <a:buNone/>
-                      </a:pPr>
-                      <a:r>
-                        <a:rPr cap="none" sz="1200" i="0" b="0" u="none" strike="noStrike">
-                          <a:solidFill>
-                            <a:srgbClr val="5B6770">
-                              <a:alpha val="100000"/>
-                            </a:srgbClr>
-                          </a:solidFill>
-                          <a:latin typeface="Helvetica Neue"/>
-                          <a:cs typeface="Helvetica Neue"/>
-                          <a:ea typeface="Helvetica Neue"/>
-                          <a:sym typeface="Helvetica Neue"/>
-                        </a:rPr>
-                        <a:t>603838</a:t>
+                        <a:t>900817</a:t>
                       </a:r>
                     </a:p>
                   </a:txBody>

</xml_diff>

<commit_message>
nightly deck: data through 2026-09-15
</commit_message>
<xml_diff>
--- a/docs/nc-drug-checking-latest.pptx
+++ b/docs/nc-drug-checking-latest.pptx
@@ -2418,7 +2418,7 @@
                 <a:ea typeface="Helvetica Neue"/>
                 <a:sym typeface="Helvetica Neue"/>
               </a:rPr>
-              <a:t>Generated Monday, September 14, 2026 · 10:18 AM ET UNC Street Drug Analysis Lab · OpioidData.org · results.streetsafe.supply Download as PowerPoint</a:t>
+              <a:t>Generated Tuesday, September 15, 2026 · 8:47 AM ET UNC Street Drug Analysis Lab · OpioidData.org · results.streetsafe.supply Download as PowerPoint</a:t>
             </a:r>
           </a:p>
         </p:txBody>
@@ -2713,7 +2713,7 @@
                 <a:ea typeface="Helvetica Neue"/>
                 <a:sym typeface="Helvetica Neue"/>
               </a:rPr>
-              <a:t>PLACEHOLDER · figs/stats.json January 2022 to Monday, September 14, 2026 N = 2,799 NC samples analyzed Mailed in from 86 harm reduction programs Collected across 58 counties 245 distinct substances detected to date Unique samples = n_distinct(sampleid) · substances from lab_detail.substance · includes samples with date_complete 26 Jan 2022 – 14 Sep 2026 r/build_nightly.R → figs/stats.json</a:t>
+              <a:t>PLACEHOLDER · figs/stats.json January 2022 to Monday, September 14, 2026 N = 2,802 NC samples analyzed Mailed in from 86 harm reduction programs Collected across 58 counties 245 distinct substances detected to date Unique samples = n_distinct(sampleid) · substances from lab_detail.substance · includes samples with date_complete 26 Jan 2022 – 14 Sep 2026 r/build_nightly.R → figs/stats.json</a:t>
             </a:r>
           </a:p>
         </p:txBody>
@@ -3184,7 +3184,7 @@
                 <a:ea typeface="Helvetica Neue"/>
                 <a:sym typeface="Helvetica Neue"/>
               </a:rPr>
-              <a:t>County = samplecounty · left: ≥1 completed analysis ever · right: unique samples per county (sqrt color scale) · all time: 26 Jan 2022 – 14 Sep 2026 · last 12 months: 14 Sep 2025 – 14 Sep 2026* · coverage reflects participation, not prevalence</a:t>
+              <a:t>County = samplecounty · left: ≥1 completed analysis ever · right: unique samples per county (sqrt color scale) · all time: 26 Jan 2022 – 14 Sep 2026 · last 12 months: 15 Sep 2025 – 14 Sep 2026* · coverage reflects participation, not prevalence</a:t>
             </a:r>
           </a:p>
         </p:txBody>
@@ -4323,7 +4323,7 @@
                 <a:ea typeface="Helvetica Neue"/>
                 <a:sym typeface="Helvetica Neue"/>
               </a:rPr>
-              <a:t>Samples with methamphetamine or cocaine detected (any abundance); samples in both classes appear on both slides · sensations semicolon lists parsed + sen_strength (own denominator) · consumed = 1 only · before: 26 Jan 2022 – 14 Sep 2025 · past 12 months: 14 Sep 2025 – 14 Sep 2026* · Δ in percentage points</a:t>
+              <a:t>Samples with methamphetamine or cocaine detected (any abundance); samples in both classes appear on both slides · sensations semicolon lists parsed + sen_strength (own denominator) · consumed = 1 only · before: 26 Jan 2022 – 14 Sep 2025 · past 12 months: 15 Sep 2025 – 14 Sep 2026* · Δ in percentage points</a:t>
             </a:r>
           </a:p>
         </p:txBody>
@@ -4742,7 +4742,7 @@
                 <a:ea typeface="Helvetica Neue"/>
                 <a:sym typeface="Helvetica Neue"/>
               </a:rPr>
-              <a:t>Samples with an opioid (fentanyl, heroin) or benzodiazepine detected (any abundance); samples in both classes appear on both slides · sensations semicolon lists parsed + sen_strength (own denominator) · consumed = 1 only · before: 26 Jan 2022 – 14 Sep 2025 · past 12 months: 14 Sep 2025 – 14 Sep 2026* · Δ in percentage points</a:t>
+              <a:t>Samples with an opioid (fentanyl, heroin) or benzodiazepine detected (any abundance); samples in both classes appear on both slides · sensations semicolon lists parsed + sen_strength (own denominator) · consumed = 1 only · before: 26 Jan 2022 – 14 Sep 2025 · past 12 months: 15 Sep 2025 – 14 Sep 2026* · Δ in percentage points</a:t>
             </a:r>
           </a:p>
         </p:txBody>
@@ -5855,7 +5855,7 @@
                 <a:ea typeface="Helvetica Neue"/>
                 <a:sym typeface="Helvetica Neue"/>
               </a:rPr>
-              <a:t>lab_detail.substance counts · solid = primary abundance, light = trace · standardized names (PubChem-linked) · window: date_complete 14 Sep 2025 – 14 Sep 2026* (trailing 12 months, current month partial)</a:t>
+              <a:t>lab_detail.substance counts · solid = primary abundance, light = trace · standardized names (PubChem-linked) · window: date_complete 15 Sep 2025 – 14 Sep 2026* (trailing 12 months, current month partial)</a:t>
             </a:r>
           </a:p>
         </p:txBody>
@@ -6053,7 +6053,7 @@
                 <a:ea typeface="Helvetica Neue"/>
                 <a:sym typeface="Helvetica Neue"/>
               </a:rPr>
-              <a:t>Distribution of substances detected per sample, both definitions shown side by side · window: date_complete 14 Sep 2025 – 14 Sep 2026* (trailing 12 months, current month partial)</a:t>
+              <a:t>Distribution of substances detected per sample, both definitions shown side by side · window: date_complete 15 Sep 2025 – 14 Sep 2026* (trailing 12 months, current month partial)</a:t>
             </a:r>
           </a:p>
         </p:txBody>
@@ -18626,7 +18626,7 @@
                           <a:ea typeface="Helvetica Neue"/>
                           <a:sym typeface="Helvetica Neue"/>
                         </a:rPr>
-                        <a:t>434</a:t>
+                        <a:t>436</a:t>
                       </a:r>
                     </a:p>
                   </a:txBody>
@@ -20821,7 +20821,7 @@
                           <a:ea typeface="Helvetica Neue"/>
                           <a:sym typeface="Helvetica Neue"/>
                         </a:rPr>
-                        <a:t>500</a:t>
+                        <a:t>502</a:t>
                       </a:r>
                     </a:p>
                   </a:txBody>

</xml_diff>

<commit_message>
nightly deck: data through 2026-09-16
</commit_message>
<xml_diff>
--- a/docs/nc-drug-checking-latest.pptx
+++ b/docs/nc-drug-checking-latest.pptx
@@ -2418,7 +2418,7 @@
                 <a:ea typeface="Helvetica Neue"/>
                 <a:sym typeface="Helvetica Neue"/>
               </a:rPr>
-              <a:t>Generated Tuesday, September 15, 2026 · 8:47 AM ET UNC Street Drug Analysis Lab · OpioidData.org · results.streetsafe.supply Download as PowerPoint</a:t>
+              <a:t>Generated Wednesday, September 16, 2026 · 8:42 AM ET UNC Street Drug Analysis Lab · OpioidData.org · results.streetsafe.supply Download as PowerPoint</a:t>
             </a:r>
           </a:p>
         </p:txBody>
@@ -3184,7 +3184,7 @@
                 <a:ea typeface="Helvetica Neue"/>
                 <a:sym typeface="Helvetica Neue"/>
               </a:rPr>
-              <a:t>County = samplecounty · left: ≥1 completed analysis ever · right: unique samples per county (sqrt color scale) · all time: 26 Jan 2022 – 14 Sep 2026 · last 12 months: 15 Sep 2025 – 14 Sep 2026* · coverage reflects participation, not prevalence</a:t>
+              <a:t>County = samplecounty · left: ≥1 completed analysis ever · right: unique samples per county (sqrt color scale) · all time: 26 Jan 2022 – 14 Sep 2026 · last 12 months: 16 Sep 2025 – 14 Sep 2026* · coverage reflects participation, not prevalence</a:t>
             </a:r>
           </a:p>
         </p:txBody>
@@ -4323,7 +4323,7 @@
                 <a:ea typeface="Helvetica Neue"/>
                 <a:sym typeface="Helvetica Neue"/>
               </a:rPr>
-              <a:t>Samples with methamphetamine or cocaine detected (any abundance); samples in both classes appear on both slides · sensations semicolon lists parsed + sen_strength (own denominator) · consumed = 1 only · before: 26 Jan 2022 – 14 Sep 2025 · past 12 months: 15 Sep 2025 – 14 Sep 2026* · Δ in percentage points</a:t>
+              <a:t>Samples with methamphetamine or cocaine detected (any abundance); samples in both classes appear on both slides · sensations semicolon lists parsed + sen_strength (own denominator) · consumed = 1 only · before: 26 Jan 2022 – 14 Sep 2025 · past 12 months: 16 Sep 2025 – 14 Sep 2026* · Δ in percentage points</a:t>
             </a:r>
           </a:p>
         </p:txBody>
@@ -4742,7 +4742,7 @@
                 <a:ea typeface="Helvetica Neue"/>
                 <a:sym typeface="Helvetica Neue"/>
               </a:rPr>
-              <a:t>Samples with an opioid (fentanyl, heroin) or benzodiazepine detected (any abundance); samples in both classes appear on both slides · sensations semicolon lists parsed + sen_strength (own denominator) · consumed = 1 only · before: 26 Jan 2022 – 14 Sep 2025 · past 12 months: 15 Sep 2025 – 14 Sep 2026* · Δ in percentage points</a:t>
+              <a:t>Samples with an opioid (fentanyl, heroin) or benzodiazepine detected (any abundance); samples in both classes appear on both slides · sensations semicolon lists parsed + sen_strength (own denominator) · consumed = 1 only · before: 26 Jan 2022 – 14 Sep 2025 · past 12 months: 16 Sep 2025 – 14 Sep 2026* · Δ in percentage points</a:t>
             </a:r>
           </a:p>
         </p:txBody>
@@ -5855,7 +5855,7 @@
                 <a:ea typeface="Helvetica Neue"/>
                 <a:sym typeface="Helvetica Neue"/>
               </a:rPr>
-              <a:t>lab_detail.substance counts · solid = primary abundance, light = trace · standardized names (PubChem-linked) · window: date_complete 15 Sep 2025 – 14 Sep 2026* (trailing 12 months, current month partial)</a:t>
+              <a:t>lab_detail.substance counts · solid = primary abundance, light = trace · standardized names (PubChem-linked) · window: date_complete 16 Sep 2025 – 14 Sep 2026* (trailing 12 months, current month partial)</a:t>
             </a:r>
           </a:p>
         </p:txBody>
@@ -6053,7 +6053,7 @@
                 <a:ea typeface="Helvetica Neue"/>
                 <a:sym typeface="Helvetica Neue"/>
               </a:rPr>
-              <a:t>Distribution of substances detected per sample, both definitions shown side by side · window: date_complete 15 Sep 2025 – 14 Sep 2026* (trailing 12 months, current month partial)</a:t>
+              <a:t>Distribution of substances detected per sample, both definitions shown side by side · window: date_complete 16 Sep 2025 – 14 Sep 2026* (trailing 12 months, current month partial)</a:t>
             </a:r>
           </a:p>
         </p:txBody>

</xml_diff>

<commit_message>
nightly deck: data through 2026-09-17
</commit_message>
<xml_diff>
--- a/docs/nc-drug-checking-latest.pptx
+++ b/docs/nc-drug-checking-latest.pptx
@@ -2418,7 +2418,7 @@
                 <a:ea typeface="Helvetica Neue"/>
                 <a:sym typeface="Helvetica Neue"/>
               </a:rPr>
-              <a:t>Generated Wednesday, September 16, 2026 · 8:42 AM ET UNC Street Drug Analysis Lab · OpioidData.org · results.streetsafe.supply Download as PowerPoint</a:t>
+              <a:t>Generated Thursday, September 17, 2026 · 8:41 AM ET UNC Street Drug Analysis Lab · OpioidData.org · results.streetsafe.supply Download as PowerPoint</a:t>
             </a:r>
           </a:p>
         </p:txBody>
@@ -2713,7 +2713,7 @@
                 <a:ea typeface="Helvetica Neue"/>
                 <a:sym typeface="Helvetica Neue"/>
               </a:rPr>
-              <a:t>PLACEHOLDER · figs/stats.json January 2022 to Monday, September 14, 2026 N = 2,802 NC samples analyzed Mailed in from 86 harm reduction programs Collected across 58 counties 245 distinct substances detected to date Unique samples = n_distinct(sampleid) · substances from lab_detail.substance · includes samples with date_complete 26 Jan 2022 – 14 Sep 2026 r/build_nightly.R → figs/stats.json</a:t>
+              <a:t>PLACEHOLDER · figs/stats.json January 2022 to Wednesday, September 16, 2026 N = 2,814 NC samples analyzed Mailed in from 86 harm reduction programs Collected across 59 counties 245 distinct substances detected to date Unique samples = n_distinct(sampleid) · substances from lab_detail.substance · includes samples with date_complete 26 Jan 2022 – 16 Sep 2026 r/build_nightly.R → figs/stats.json</a:t>
             </a:r>
           </a:p>
         </p:txBody>
@@ -2762,7 +2762,7 @@
                 <a:ea typeface="Helvetica Neue"/>
                 <a:sym typeface="Helvetica Neue"/>
               </a:rPr>
-              <a:t>Unique samples = n_distinct(sampleid) · substances from lab_detail.substance · includes samples with date_complete 26 Jan 2022 – 14 Sep 2026</a:t>
+              <a:t>Unique samples = n_distinct(sampleid) · substances from lab_detail.substance · includes samples with date_complete 26 Jan 2022 – 16 Sep 2026</a:t>
             </a:r>
           </a:p>
         </p:txBody>
@@ -3184,7 +3184,7 @@
                 <a:ea typeface="Helvetica Neue"/>
                 <a:sym typeface="Helvetica Neue"/>
               </a:rPr>
-              <a:t>County = samplecounty · left: ≥1 completed analysis ever · right: unique samples per county (sqrt color scale) · all time: 26 Jan 2022 – 14 Sep 2026 · last 12 months: 16 Sep 2025 – 14 Sep 2026* · coverage reflects participation, not prevalence</a:t>
+              <a:t>County = samplecounty · left: ≥1 completed analysis ever · right: unique samples per county (sqrt color scale) · all time: 26 Jan 2022 – 16 Sep 2026 · last 12 months: 17 Sep 2025 – 16 Sep 2026* · coverage reflects participation, not prevalence</a:t>
             </a:r>
           </a:p>
         </p:txBody>
@@ -3505,7 +3505,7 @@
                 <a:ea typeface="Helvetica Neue"/>
                 <a:sym typeface="Helvetica Neue"/>
               </a:rPr>
-              <a:t>expectedsubstance (verbatim card write-in, semicolon lists split) · derived flags: expect_opioid, expect_fentanyl, expect_meth, expect_cocaine, expect_stimulant… · includes samples with date_complete 26 Jan 2022 – 14 Sep 2026 · data table: Appendix A2</a:t>
+              <a:t>expectedsubstance (verbatim card write-in, semicolon lists split) · derived flags: expect_opioid, expect_fentanyl, expect_meth, expect_cocaine, expect_stimulant… · includes samples with date_complete 26 Jan 2022 – 16 Sep 2026 · data table: Appendix A2</a:t>
             </a:r>
           </a:p>
         </p:txBody>
@@ -3703,7 +3703,7 @@
                 <a:ea typeface="Helvetica Neue"/>
                 <a:sym typeface="Helvetica Neue"/>
               </a:rPr>
-              <a:t>Numerator uses lab_*_any (primary or trace) among samples with expect_* = 1 · includes samples with date_complete 26 Jan 2022 – 14 Sep 2026 · data table: Appendix A3</a:t>
+              <a:t>Numerator uses lab_*_any (primary or trace) among samples with expect_* = 1 · includes samples with date_complete 26 Jan 2022 – 16 Sep 2026 · data table: Appendix A3</a:t>
             </a:r>
           </a:p>
         </p:txBody>
@@ -3901,7 +3901,7 @@
                 <a:ea typeface="Helvetica Neue"/>
                 <a:sym typeface="Helvetica Neue"/>
               </a:rPr>
-              <a:t>sensations (circled on card, semicolon lists split) · post-consumption samples only (consumed = 1) · includes samples with date_complete 26 Jan 2022 – 14 Sep 2026</a:t>
+              <a:t>sensations (circled on card, semicolon lists split) · post-consumption samples only (consumed = 1) · includes samples with date_complete 26 Jan 2022 – 16 Sep 2026</a:t>
             </a:r>
           </a:p>
         </p:txBody>
@@ -4125,7 +4125,7 @@
                 <a:ea typeface="Helvetica Neue"/>
                 <a:sym typeface="Helvetica Neue"/>
               </a:rPr>
-              <a:t>sensations semicolon lists parsed per report · consumed = 1 only · denominator: consumed samples with lab_*_any = 1 · includes samples with date_complete 26 Jan 2022 – 14 Sep 2026</a:t>
+              <a:t>sensations semicolon lists parsed per report · consumed = 1 only · denominator: consumed samples with lab_*_any = 1 · includes samples with date_complete 26 Jan 2022 – 16 Sep 2026</a:t>
             </a:r>
           </a:p>
         </p:txBody>
@@ -4323,7 +4323,7 @@
                 <a:ea typeface="Helvetica Neue"/>
                 <a:sym typeface="Helvetica Neue"/>
               </a:rPr>
-              <a:t>Samples with methamphetamine or cocaine detected (any abundance); samples in both classes appear on both slides · sensations semicolon lists parsed + sen_strength (own denominator) · consumed = 1 only · before: 26 Jan 2022 – 14 Sep 2025 · past 12 months: 16 Sep 2025 – 14 Sep 2026* · Δ in percentage points</a:t>
+              <a:t>Samples with methamphetamine or cocaine detected (any abundance); samples in both classes appear on both slides · sensations semicolon lists parsed + sen_strength (own denominator) · consumed = 1 only · before: 26 Jan 2022 – 16 Sep 2025 · past 12 months: 17 Sep 2025 – 16 Sep 2026* · Δ in percentage points</a:t>
             </a:r>
           </a:p>
         </p:txBody>
@@ -4742,7 +4742,7 @@
                 <a:ea typeface="Helvetica Neue"/>
                 <a:sym typeface="Helvetica Neue"/>
               </a:rPr>
-              <a:t>Samples with an opioid (fentanyl, heroin) or benzodiazepine detected (any abundance); samples in both classes appear on both slides · sensations semicolon lists parsed + sen_strength (own denominator) · consumed = 1 only · before: 26 Jan 2022 – 14 Sep 2025 · past 12 months: 16 Sep 2025 – 14 Sep 2026* · Δ in percentage points</a:t>
+              <a:t>Samples with an opioid (fentanyl, heroin) or benzodiazepine detected (any abundance); samples in both classes appear on both slides · sensations semicolon lists parsed + sen_strength (own denominator) · consumed = 1 only · before: 26 Jan 2022 – 16 Sep 2025 · past 12 months: 17 Sep 2025 – 16 Sep 2026* · Δ in percentage points</a:t>
             </a:r>
           </a:p>
         </p:txBody>
@@ -5138,7 +5138,7 @@
                 <a:ea typeface="Helvetica Neue"/>
                 <a:sym typeface="Helvetica Neue"/>
               </a:rPr>
-              <a:t>color, texture (card v3+, semicolon lists split) · derived: bright_color excludes white/tan/brown family — orange bar above · includes samples with date_complete 26 Jan 2022 – 14 Sep 2026</a:t>
+              <a:t>color, texture (card v3+, semicolon lists split) · derived: bright_color excludes white/tan/brown family — orange bar above · includes samples with date_complete 26 Jan 2022 – 16 Sep 2026</a:t>
             </a:r>
           </a:p>
         </p:txBody>
@@ -5459,7 +5459,7 @@
                 <a:ea typeface="Helvetica Neue"/>
                 <a:sym typeface="Helvetica Neue"/>
               </a:rPr>
-              <a:t>Distribution of substances detected per sample, both definitions shown side by side · includes samples with date_complete 26 Jan 2022 – 14 Sep 2026</a:t>
+              <a:t>Distribution of substances detected per sample, both definitions shown side by side · includes samples with date_complete 26 Jan 2022 – 16 Sep 2026</a:t>
             </a:r>
           </a:p>
         </p:txBody>
@@ -5657,7 +5657,7 @@
                 <a:ea typeface="Helvetica Neue"/>
                 <a:sym typeface="Helvetica Neue"/>
               </a:rPr>
-              <a:t>lab_detail.substance counts · solid = primary abundance, light = trace · standardized names (PubChem-linked) · includes samples with date_complete 26 Jan 2022 – 14 Sep 2026</a:t>
+              <a:t>lab_detail.substance counts · solid = primary abundance, light = trace · standardized names (PubChem-linked) · includes samples with date_complete 26 Jan 2022 – 16 Sep 2026</a:t>
             </a:r>
           </a:p>
         </p:txBody>
@@ -5855,7 +5855,7 @@
                 <a:ea typeface="Helvetica Neue"/>
                 <a:sym typeface="Helvetica Neue"/>
               </a:rPr>
-              <a:t>lab_detail.substance counts · solid = primary abundance, light = trace · standardized names (PubChem-linked) · window: date_complete 16 Sep 2025 – 14 Sep 2026* (trailing 12 months, current month partial)</a:t>
+              <a:t>lab_detail.substance counts · solid = primary abundance, light = trace · standardized names (PubChem-linked) · window: date_complete 17 Sep 2025 – 16 Sep 2026* (trailing 12 months, current month partial)</a:t>
             </a:r>
           </a:p>
         </p:txBody>
@@ -6053,7 +6053,7 @@
                 <a:ea typeface="Helvetica Neue"/>
                 <a:sym typeface="Helvetica Neue"/>
               </a:rPr>
-              <a:t>Distribution of substances detected per sample, both definitions shown side by side · window: date_complete 16 Sep 2025 – 14 Sep 2026* (trailing 12 months, current month partial)</a:t>
+              <a:t>Distribution of substances detected per sample, both definitions shown side by side · window: date_complete 17 Sep 2025 – 16 Sep 2026* (trailing 12 months, current month partial)</a:t>
             </a:r>
           </a:p>
         </p:txBody>
@@ -13229,7 +13229,7 @@
                           <a:ea typeface="Helvetica Neue"/>
                           <a:sym typeface="Helvetica Neue"/>
                         </a:rPr>
-                        <a:t>2</a:t>
+                        <a:t>3</a:t>
                       </a:r>
                     </a:p>
                   </a:txBody>
@@ -18510,7 +18510,7 @@
                           <a:ea typeface="Helvetica Neue"/>
                           <a:sym typeface="Helvetica Neue"/>
                         </a:rPr>
-                        <a:t>1,433</a:t>
+                        <a:t>1,438</a:t>
                       </a:r>
                     </a:p>
                   </a:txBody>
@@ -18626,7 +18626,7 @@
                           <a:ea typeface="Helvetica Neue"/>
                           <a:sym typeface="Helvetica Neue"/>
                         </a:rPr>
-                        <a:t>436</a:t>
+                        <a:t>438</a:t>
                       </a:r>
                     </a:p>
                   </a:txBody>
@@ -19322,7 +19322,7 @@
                           <a:ea typeface="Helvetica Neue"/>
                           <a:sym typeface="Helvetica Neue"/>
                         </a:rPr>
-                        <a:t>57</a:t>
+                        <a:t>58</a:t>
                       </a:r>
                     </a:p>
                   </a:txBody>
@@ -19554,7 +19554,7 @@
                           <a:ea typeface="Helvetica Neue"/>
                           <a:sym typeface="Helvetica Neue"/>
                         </a:rPr>
-                        <a:t>52</a:t>
+                        <a:t>54</a:t>
                       </a:r>
                     </a:p>
                   </a:txBody>
@@ -20591,7 +20591,7 @@
                           <a:ea typeface="Helvetica Neue"/>
                           <a:sym typeface="Helvetica Neue"/>
                         </a:rPr>
-                        <a:t>1,645</a:t>
+                        <a:t>1,655</a:t>
                       </a:r>
                     </a:p>
                   </a:txBody>
@@ -20821,7 +20821,7 @@
                           <a:ea typeface="Helvetica Neue"/>
                           <a:sym typeface="Helvetica Neue"/>
                         </a:rPr>
-                        <a:t>502</a:t>
+                        <a:t>506</a:t>
                       </a:r>
                     </a:p>
                   </a:txBody>
@@ -21515,7 +21515,7 @@
                           <a:ea typeface="Helvetica Neue"/>
                           <a:sym typeface="Helvetica Neue"/>
                         </a:rPr>
-                        <a:t>358</a:t>
+                        <a:t>359</a:t>
                       </a:r>
                     </a:p>
                   </a:txBody>
@@ -27122,7 +27122,7 @@
                           <a:ea typeface="Helvetica Neue"/>
                           <a:sym typeface="Helvetica Neue"/>
                         </a:rPr>
-                        <a:t>2</a:t>
+                        <a:t>3</a:t>
                       </a:r>
                     </a:p>
                   </a:txBody>

</xml_diff>

<commit_message>
nightly deck: data through 2026-09-18
</commit_message>
<xml_diff>
--- a/docs/nc-drug-checking-latest.pptx
+++ b/docs/nc-drug-checking-latest.pptx
@@ -2418,7 +2418,7 @@
                 <a:ea typeface="Helvetica Neue"/>
                 <a:sym typeface="Helvetica Neue"/>
               </a:rPr>
-              <a:t>Generated Thursday, September 17, 2026 · 8:41 AM ET UNC Street Drug Analysis Lab · OpioidData.org · results.streetsafe.supply Download as PowerPoint</a:t>
+              <a:t>Generated Friday, September 18, 2026 · 8:19 AM ET UNC Street Drug Analysis Lab · OpioidData.org · results.streetsafe.supply Download as PowerPoint</a:t>
             </a:r>
           </a:p>
         </p:txBody>
@@ -2713,7 +2713,7 @@
                 <a:ea typeface="Helvetica Neue"/>
                 <a:sym typeface="Helvetica Neue"/>
               </a:rPr>
-              <a:t>PLACEHOLDER · figs/stats.json January 2022 to Wednesday, September 16, 2026 N = 2,814 NC samples analyzed Mailed in from 86 harm reduction programs Collected across 59 counties 245 distinct substances detected to date Unique samples = n_distinct(sampleid) · substances from lab_detail.substance · includes samples with date_complete 26 Jan 2022 – 16 Sep 2026 r/build_nightly.R → figs/stats.json</a:t>
+              <a:t>PLACEHOLDER · figs/stats.json January 2022 to Thursday, September 17, 2026 N = 2,833 NC samples analyzed Mailed in from 86 harm reduction programs Collected across 59 counties 245 distinct substances detected to date Unique samples = n_distinct(sampleid) · substances from lab_detail.substance · includes samples with date_complete 26 Jan 2022 – 17 Sep 2026 r/build_nightly.R → figs/stats.json</a:t>
             </a:r>
           </a:p>
         </p:txBody>
@@ -2762,7 +2762,7 @@
                 <a:ea typeface="Helvetica Neue"/>
                 <a:sym typeface="Helvetica Neue"/>
               </a:rPr>
-              <a:t>Unique samples = n_distinct(sampleid) · substances from lab_detail.substance · includes samples with date_complete 26 Jan 2022 – 16 Sep 2026</a:t>
+              <a:t>Unique samples = n_distinct(sampleid) · substances from lab_detail.substance · includes samples with date_complete 26 Jan 2022 – 17 Sep 2026</a:t>
             </a:r>
           </a:p>
         </p:txBody>
@@ -3184,7 +3184,7 @@
                 <a:ea typeface="Helvetica Neue"/>
                 <a:sym typeface="Helvetica Neue"/>
               </a:rPr>
-              <a:t>County = samplecounty · left: ≥1 completed analysis ever · right: unique samples per county (sqrt color scale) · all time: 26 Jan 2022 – 16 Sep 2026 · last 12 months: 17 Sep 2025 – 16 Sep 2026* · coverage reflects participation, not prevalence</a:t>
+              <a:t>County = samplecounty · left: ≥1 completed analysis ever · right: unique samples per county (sqrt color scale) · all time: 26 Jan 2022 – 17 Sep 2026 · last 12 months: 18 Sep 2025 – 17 Sep 2026* · coverage reflects participation, not prevalence</a:t>
             </a:r>
           </a:p>
         </p:txBody>
@@ -3505,7 +3505,7 @@
                 <a:ea typeface="Helvetica Neue"/>
                 <a:sym typeface="Helvetica Neue"/>
               </a:rPr>
-              <a:t>expectedsubstance (verbatim card write-in, semicolon lists split) · derived flags: expect_opioid, expect_fentanyl, expect_meth, expect_cocaine, expect_stimulant… · includes samples with date_complete 26 Jan 2022 – 16 Sep 2026 · data table: Appendix A2</a:t>
+              <a:t>expectedsubstance (verbatim card write-in, semicolon lists split) · derived flags: expect_opioid, expect_fentanyl, expect_meth, expect_cocaine, expect_stimulant… · includes samples with date_complete 26 Jan 2022 – 17 Sep 2026 · data table: Appendix A2</a:t>
             </a:r>
           </a:p>
         </p:txBody>
@@ -3703,7 +3703,7 @@
                 <a:ea typeface="Helvetica Neue"/>
                 <a:sym typeface="Helvetica Neue"/>
               </a:rPr>
-              <a:t>Numerator uses lab_*_any (primary or trace) among samples with expect_* = 1 · includes samples with date_complete 26 Jan 2022 – 16 Sep 2026 · data table: Appendix A3</a:t>
+              <a:t>Numerator uses lab_*_any (primary or trace) among samples with expect_* = 1 · includes samples with date_complete 26 Jan 2022 – 17 Sep 2026 · data table: Appendix A3</a:t>
             </a:r>
           </a:p>
         </p:txBody>
@@ -3901,7 +3901,7 @@
                 <a:ea typeface="Helvetica Neue"/>
                 <a:sym typeface="Helvetica Neue"/>
               </a:rPr>
-              <a:t>sensations (circled on card, semicolon lists split) · post-consumption samples only (consumed = 1) · includes samples with date_complete 26 Jan 2022 – 16 Sep 2026</a:t>
+              <a:t>sensations (circled on card, semicolon lists split) · post-consumption samples only (consumed = 1) · includes samples with date_complete 26 Jan 2022 – 17 Sep 2026</a:t>
             </a:r>
           </a:p>
         </p:txBody>
@@ -4125,7 +4125,7 @@
                 <a:ea typeface="Helvetica Neue"/>
                 <a:sym typeface="Helvetica Neue"/>
               </a:rPr>
-              <a:t>sensations semicolon lists parsed per report · consumed = 1 only · denominator: consumed samples with lab_*_any = 1 · includes samples with date_complete 26 Jan 2022 – 16 Sep 2026</a:t>
+              <a:t>sensations semicolon lists parsed per report · consumed = 1 only · denominator: consumed samples with lab_*_any = 1 · includes samples with date_complete 26 Jan 2022 – 17 Sep 2026</a:t>
             </a:r>
           </a:p>
         </p:txBody>
@@ -4323,7 +4323,7 @@
                 <a:ea typeface="Helvetica Neue"/>
                 <a:sym typeface="Helvetica Neue"/>
               </a:rPr>
-              <a:t>Samples with methamphetamine or cocaine detected (any abundance); samples in both classes appear on both slides · sensations semicolon lists parsed + sen_strength (own denominator) · consumed = 1 only · before: 26 Jan 2022 – 16 Sep 2025 · past 12 months: 17 Sep 2025 – 16 Sep 2026* · Δ in percentage points</a:t>
+              <a:t>Samples with methamphetamine or cocaine detected (any abundance); samples in both classes appear on both slides · sensations semicolon lists parsed + sen_strength (own denominator) · consumed = 1 only · before: 26 Jan 2022 – 17 Sep 2025 · past 12 months: 18 Sep 2025 – 17 Sep 2026* · Δ in percentage points</a:t>
             </a:r>
           </a:p>
         </p:txBody>
@@ -4742,7 +4742,7 @@
                 <a:ea typeface="Helvetica Neue"/>
                 <a:sym typeface="Helvetica Neue"/>
               </a:rPr>
-              <a:t>Samples with an opioid (fentanyl, heroin) or benzodiazepine detected (any abundance); samples in both classes appear on both slides · sensations semicolon lists parsed + sen_strength (own denominator) · consumed = 1 only · before: 26 Jan 2022 – 16 Sep 2025 · past 12 months: 17 Sep 2025 – 16 Sep 2026* · Δ in percentage points</a:t>
+              <a:t>Samples with an opioid (fentanyl, heroin) or benzodiazepine detected (any abundance); samples in both classes appear on both slides · sensations semicolon lists parsed + sen_strength (own denominator) · consumed = 1 only · before: 26 Jan 2022 – 17 Sep 2025 · past 12 months: 18 Sep 2025 – 17 Sep 2026* · Δ in percentage points</a:t>
             </a:r>
           </a:p>
         </p:txBody>
@@ -5138,7 +5138,7 @@
                 <a:ea typeface="Helvetica Neue"/>
                 <a:sym typeface="Helvetica Neue"/>
               </a:rPr>
-              <a:t>color, texture (card v3+, semicolon lists split) · derived: bright_color excludes white/tan/brown family — orange bar above · includes samples with date_complete 26 Jan 2022 – 16 Sep 2026</a:t>
+              <a:t>color, texture (card v3+, semicolon lists split) · derived: bright_color excludes white/tan/brown family — orange bar above · includes samples with date_complete 26 Jan 2022 – 17 Sep 2026</a:t>
             </a:r>
           </a:p>
         </p:txBody>
@@ -5459,7 +5459,7 @@
                 <a:ea typeface="Helvetica Neue"/>
                 <a:sym typeface="Helvetica Neue"/>
               </a:rPr>
-              <a:t>Distribution of substances detected per sample, both definitions shown side by side · includes samples with date_complete 26 Jan 2022 – 16 Sep 2026</a:t>
+              <a:t>Distribution of substances detected per sample, both definitions shown side by side · includes samples with date_complete 26 Jan 2022 – 17 Sep 2026</a:t>
             </a:r>
           </a:p>
         </p:txBody>
@@ -5657,7 +5657,7 @@
                 <a:ea typeface="Helvetica Neue"/>
                 <a:sym typeface="Helvetica Neue"/>
               </a:rPr>
-              <a:t>lab_detail.substance counts · solid = primary abundance, light = trace · standardized names (PubChem-linked) · includes samples with date_complete 26 Jan 2022 – 16 Sep 2026</a:t>
+              <a:t>lab_detail.substance counts · solid = primary abundance, light = trace · standardized names (PubChem-linked) · includes samples with date_complete 26 Jan 2022 – 17 Sep 2026</a:t>
             </a:r>
           </a:p>
         </p:txBody>
@@ -5855,7 +5855,7 @@
                 <a:ea typeface="Helvetica Neue"/>
                 <a:sym typeface="Helvetica Neue"/>
               </a:rPr>
-              <a:t>lab_detail.substance counts · solid = primary abundance, light = trace · standardized names (PubChem-linked) · window: date_complete 17 Sep 2025 – 16 Sep 2026* (trailing 12 months, current month partial)</a:t>
+              <a:t>lab_detail.substance counts · solid = primary abundance, light = trace · standardized names (PubChem-linked) · window: date_complete 18 Sep 2025 – 17 Sep 2026* (trailing 12 months, current month partial)</a:t>
             </a:r>
           </a:p>
         </p:txBody>
@@ -6053,7 +6053,7 @@
                 <a:ea typeface="Helvetica Neue"/>
                 <a:sym typeface="Helvetica Neue"/>
               </a:rPr>
-              <a:t>Distribution of substances detected per sample, both definitions shown side by side · window: date_complete 17 Sep 2025 – 16 Sep 2026* (trailing 12 months, current month partial)</a:t>
+              <a:t>Distribution of substances detected per sample, both definitions shown side by side · window: date_complete 18 Sep 2025 – 17 Sep 2026* (trailing 12 months, current month partial)</a:t>
             </a:r>
           </a:p>
         </p:txBody>
@@ -18510,7 +18510,7 @@
                           <a:ea typeface="Helvetica Neue"/>
                           <a:sym typeface="Helvetica Neue"/>
                         </a:rPr>
-                        <a:t>1,438</a:t>
+                        <a:t>1,454</a:t>
                       </a:r>
                     </a:p>
                   </a:txBody>
@@ -19554,7 +19554,7 @@
                           <a:ea typeface="Helvetica Neue"/>
                           <a:sym typeface="Helvetica Neue"/>
                         </a:rPr>
-                        <a:t>54</a:t>
+                        <a:t>55</a:t>
                       </a:r>
                     </a:p>
                   </a:txBody>
@@ -20591,7 +20591,7 @@
                           <a:ea typeface="Helvetica Neue"/>
                           <a:sym typeface="Helvetica Neue"/>
                         </a:rPr>
-                        <a:t>1,655</a:t>
+                        <a:t>1,674</a:t>
                       </a:r>
                     </a:p>
                   </a:txBody>
@@ -20821,7 +20821,7 @@
                           <a:ea typeface="Helvetica Neue"/>
                           <a:sym typeface="Helvetica Neue"/>
                         </a:rPr>
-                        <a:t>506</a:t>
+                        <a:t>507</a:t>
                       </a:r>
                     </a:p>
                   </a:txBody>

</xml_diff>

<commit_message>
nightly deck: data through 2026-09-19
</commit_message>
<xml_diff>
--- a/docs/nc-drug-checking-latest.pptx
+++ b/docs/nc-drug-checking-latest.pptx
@@ -2418,7 +2418,7 @@
                 <a:ea typeface="Helvetica Neue"/>
                 <a:sym typeface="Helvetica Neue"/>
               </a:rPr>
-              <a:t>Generated Friday, September 18, 2026 · 8:19 AM ET UNC Street Drug Analysis Lab · OpioidData.org · results.streetsafe.supply Download as PowerPoint</a:t>
+              <a:t>Generated Saturday, September 19, 2026 · 8:01 AM ET UNC Street Drug Analysis Lab · OpioidData.org · results.streetsafe.supply Download as PowerPoint</a:t>
             </a:r>
           </a:p>
         </p:txBody>
@@ -2713,7 +2713,7 @@
                 <a:ea typeface="Helvetica Neue"/>
                 <a:sym typeface="Helvetica Neue"/>
               </a:rPr>
-              <a:t>PLACEHOLDER · figs/stats.json January 2022 to Thursday, September 17, 2026 N = 2,833 NC samples analyzed Mailed in from 86 harm reduction programs Collected across 59 counties 245 distinct substances detected to date Unique samples = n_distinct(sampleid) · substances from lab_detail.substance · includes samples with date_complete 26 Jan 2022 – 17 Sep 2026 r/build_nightly.R → figs/stats.json</a:t>
+              <a:t>PLACEHOLDER · figs/stats.json January 2022 to Friday, September 18, 2026 N = 2,860 NC samples analyzed Mailed in from 86 harm reduction programs Collected across 59 counties 247 distinct substances detected to date Unique samples = n_distinct(sampleid) · substances from lab_detail.substance · includes samples with date_complete 26 Jan 2022 – 18 Sep 2026 r/build_nightly.R → figs/stats.json</a:t>
             </a:r>
           </a:p>
         </p:txBody>
@@ -2762,7 +2762,7 @@
                 <a:ea typeface="Helvetica Neue"/>
                 <a:sym typeface="Helvetica Neue"/>
               </a:rPr>
-              <a:t>Unique samples = n_distinct(sampleid) · substances from lab_detail.substance · includes samples with date_complete 26 Jan 2022 – 17 Sep 2026</a:t>
+              <a:t>Unique samples = n_distinct(sampleid) · substances from lab_detail.substance · includes samples with date_complete 26 Jan 2022 – 18 Sep 2026</a:t>
             </a:r>
           </a:p>
         </p:txBody>
@@ -3184,7 +3184,7 @@
                 <a:ea typeface="Helvetica Neue"/>
                 <a:sym typeface="Helvetica Neue"/>
               </a:rPr>
-              <a:t>County = samplecounty · left: ≥1 completed analysis ever · right: unique samples per county (sqrt color scale) · all time: 26 Jan 2022 – 17 Sep 2026 · last 12 months: 18 Sep 2025 – 17 Sep 2026* · coverage reflects participation, not prevalence</a:t>
+              <a:t>County = samplecounty · left: ≥1 completed analysis ever · right: unique samples per county (sqrt color scale) · all time: 26 Jan 2022 – 18 Sep 2026 · last 12 months: 19 Sep 2025 – 18 Sep 2026* · coverage reflects participation, not prevalence</a:t>
             </a:r>
           </a:p>
         </p:txBody>
@@ -3505,7 +3505,7 @@
                 <a:ea typeface="Helvetica Neue"/>
                 <a:sym typeface="Helvetica Neue"/>
               </a:rPr>
-              <a:t>expectedsubstance (verbatim card write-in, semicolon lists split) · derived flags: expect_opioid, expect_fentanyl, expect_meth, expect_cocaine, expect_stimulant… · includes samples with date_complete 26 Jan 2022 – 17 Sep 2026 · data table: Appendix A2</a:t>
+              <a:t>expectedsubstance (verbatim card write-in, semicolon lists split) · derived flags: expect_opioid, expect_fentanyl, expect_meth, expect_cocaine, expect_stimulant… · includes samples with date_complete 26 Jan 2022 – 18 Sep 2026 · data table: Appendix A2</a:t>
             </a:r>
           </a:p>
         </p:txBody>
@@ -3703,7 +3703,7 @@
                 <a:ea typeface="Helvetica Neue"/>
                 <a:sym typeface="Helvetica Neue"/>
               </a:rPr>
-              <a:t>Numerator uses lab_*_any (primary or trace) among samples with expect_* = 1 · includes samples with date_complete 26 Jan 2022 – 17 Sep 2026 · data table: Appendix A3</a:t>
+              <a:t>Numerator uses lab_*_any (primary or trace) among samples with expect_* = 1 · includes samples with date_complete 26 Jan 2022 – 18 Sep 2026 · data table: Appendix A3</a:t>
             </a:r>
           </a:p>
         </p:txBody>
@@ -3901,7 +3901,7 @@
                 <a:ea typeface="Helvetica Neue"/>
                 <a:sym typeface="Helvetica Neue"/>
               </a:rPr>
-              <a:t>sensations (circled on card, semicolon lists split) · post-consumption samples only (consumed = 1) · includes samples with date_complete 26 Jan 2022 – 17 Sep 2026</a:t>
+              <a:t>sensations (circled on card, semicolon lists split) · post-consumption samples only (consumed = 1) · includes samples with date_complete 26 Jan 2022 – 18 Sep 2026</a:t>
             </a:r>
           </a:p>
         </p:txBody>
@@ -4125,7 +4125,7 @@
                 <a:ea typeface="Helvetica Neue"/>
                 <a:sym typeface="Helvetica Neue"/>
               </a:rPr>
-              <a:t>sensations semicolon lists parsed per report · consumed = 1 only · denominator: consumed samples with lab_*_any = 1 · includes samples with date_complete 26 Jan 2022 – 17 Sep 2026</a:t>
+              <a:t>sensations semicolon lists parsed per report · consumed = 1 only · denominator: consumed samples with lab_*_any = 1 · includes samples with date_complete 26 Jan 2022 – 18 Sep 2026</a:t>
             </a:r>
           </a:p>
         </p:txBody>
@@ -4323,7 +4323,7 @@
                 <a:ea typeface="Helvetica Neue"/>
                 <a:sym typeface="Helvetica Neue"/>
               </a:rPr>
-              <a:t>Samples with methamphetamine or cocaine detected (any abundance); samples in both classes appear on both slides · sensations semicolon lists parsed + sen_strength (own denominator) · consumed = 1 only · before: 26 Jan 2022 – 17 Sep 2025 · past 12 months: 18 Sep 2025 – 17 Sep 2026* · Δ in percentage points</a:t>
+              <a:t>Samples with methamphetamine or cocaine detected (any abundance); samples in both classes appear on both slides · sensations semicolon lists parsed + sen_strength (own denominator) · consumed = 1 only · before: 26 Jan 2022 – 18 Sep 2025 · past 12 months: 19 Sep 2025 – 18 Sep 2026* · Δ in percentage points</a:t>
             </a:r>
           </a:p>
         </p:txBody>
@@ -4742,7 +4742,7 @@
                 <a:ea typeface="Helvetica Neue"/>
                 <a:sym typeface="Helvetica Neue"/>
               </a:rPr>
-              <a:t>Samples with an opioid (fentanyl, heroin) or benzodiazepine detected (any abundance); samples in both classes appear on both slides · sensations semicolon lists parsed + sen_strength (own denominator) · consumed = 1 only · before: 26 Jan 2022 – 17 Sep 2025 · past 12 months: 18 Sep 2025 – 17 Sep 2026* · Δ in percentage points</a:t>
+              <a:t>Samples with an opioid (fentanyl, heroin) or benzodiazepine detected (any abundance); samples in both classes appear on both slides · sensations semicolon lists parsed + sen_strength (own denominator) · consumed = 1 only · before: 26 Jan 2022 – 18 Sep 2025 · past 12 months: 19 Sep 2025 – 18 Sep 2026* · Δ in percentage points</a:t>
             </a:r>
           </a:p>
         </p:txBody>
@@ -5138,7 +5138,7 @@
                 <a:ea typeface="Helvetica Neue"/>
                 <a:sym typeface="Helvetica Neue"/>
               </a:rPr>
-              <a:t>color, texture (card v3+, semicolon lists split) · derived: bright_color excludes white/tan/brown family — orange bar above · includes samples with date_complete 26 Jan 2022 – 17 Sep 2026</a:t>
+              <a:t>color, texture (card v3+, semicolon lists split) · derived: bright_color excludes white/tan/brown family — orange bar above · includes samples with date_complete 26 Jan 2022 – 18 Sep 2026</a:t>
             </a:r>
           </a:p>
         </p:txBody>
@@ -5459,7 +5459,7 @@
                 <a:ea typeface="Helvetica Neue"/>
                 <a:sym typeface="Helvetica Neue"/>
               </a:rPr>
-              <a:t>Distribution of substances detected per sample, both definitions shown side by side · includes samples with date_complete 26 Jan 2022 – 17 Sep 2026</a:t>
+              <a:t>Distribution of substances detected per sample, both definitions shown side by side · includes samples with date_complete 26 Jan 2022 – 18 Sep 2026</a:t>
             </a:r>
           </a:p>
         </p:txBody>
@@ -5657,7 +5657,7 @@
                 <a:ea typeface="Helvetica Neue"/>
                 <a:sym typeface="Helvetica Neue"/>
               </a:rPr>
-              <a:t>lab_detail.substance counts · solid = primary abundance, light = trace · standardized names (PubChem-linked) · includes samples with date_complete 26 Jan 2022 – 17 Sep 2026</a:t>
+              <a:t>lab_detail.substance counts · solid = primary abundance, light = trace · standardized names (PubChem-linked) · includes samples with date_complete 26 Jan 2022 – 18 Sep 2026</a:t>
             </a:r>
           </a:p>
         </p:txBody>
@@ -5855,7 +5855,7 @@
                 <a:ea typeface="Helvetica Neue"/>
                 <a:sym typeface="Helvetica Neue"/>
               </a:rPr>
-              <a:t>lab_detail.substance counts · solid = primary abundance, light = trace · standardized names (PubChem-linked) · window: date_complete 18 Sep 2025 – 17 Sep 2026* (trailing 12 months, current month partial)</a:t>
+              <a:t>lab_detail.substance counts · solid = primary abundance, light = trace · standardized names (PubChem-linked) · window: date_complete 19 Sep 2025 – 18 Sep 2026* (trailing 12 months, current month partial)</a:t>
             </a:r>
           </a:p>
         </p:txBody>
@@ -6053,7 +6053,7 @@
                 <a:ea typeface="Helvetica Neue"/>
                 <a:sym typeface="Helvetica Neue"/>
               </a:rPr>
-              <a:t>Distribution of substances detected per sample, both definitions shown side by side · window: date_complete 18 Sep 2025 – 17 Sep 2026* (trailing 12 months, current month partial)</a:t>
+              <a:t>Distribution of substances detected per sample, both definitions shown side by side · window: date_complete 19 Sep 2025 – 18 Sep 2026* (trailing 12 months, current month partial)</a:t>
             </a:r>
           </a:p>
         </p:txBody>
@@ -11049,6 +11049,580 @@
                           <a:ea typeface="Helvetica Neue"/>
                           <a:sym typeface="Helvetica Neue"/>
                         </a:rPr>
+                        <a:t>naphazoline</a:t>
+                      </a:r>
+                    </a:p>
+                  </a:txBody>
+                  <a:tcPr anchor="ctr" marB="63500" marT="63500" marR="0" marL="0">
+                    <a:lnL algn="ctr" cmpd="sng" cap="flat" w="0">
+                      <a:noFill/>
+                      <a:prstDash val="solid"/>
+                    </a:lnL>
+                    <a:lnR algn="ctr" cmpd="sng" cap="flat" w="0">
+                      <a:noFill/>
+                      <a:prstDash val="solid"/>
+                    </a:lnR>
+                    <a:lnT algn="ctr" cmpd="sng" cap="flat" w="0">
+                      <a:noFill/>
+                      <a:prstDash val="solid"/>
+                    </a:lnT>
+                    <a:lnB algn="ctr" cmpd="sng" cap="flat" w="0">
+                      <a:noFill/>
+                      <a:prstDash val="solid"/>
+                    </a:lnB>
+                    <a:solidFill>
+                      <a:srgbClr val="FFFFFF">
+                        <a:alpha val="0"/>
+                      </a:srgbClr>
+                    </a:solidFill>
+                  </a:tcPr>
+                </a:tc>
+                <a:tc>
+                  <a:txBody>
+                    <a:bodyPr/>
+                    <a:lstStyle/>
+                    <a:p>
+                      <a:pPr algn="l" marL="63500" marR="63500">
+                        <a:lnSpc>
+                          <a:spcPct val="100000"/>
+                        </a:lnSpc>
+                        <a:spcBef>
+                          <a:spcPts val="500"/>
+                        </a:spcBef>
+                        <a:spcAft>
+                          <a:spcPts val="500"/>
+                        </a:spcAft>
+                        <a:buNone/>
+                      </a:pPr>
+                      <a:r>
+                        <a:rPr cap="none" sz="1200" i="0" b="0" u="none" strike="noStrike">
+                          <a:solidFill>
+                            <a:srgbClr val="5B6770">
+                              <a:alpha val="100000"/>
+                            </a:srgbClr>
+                          </a:solidFill>
+                          <a:latin typeface="Helvetica Neue"/>
+                          <a:cs typeface="Helvetica Neue"/>
+                          <a:ea typeface="Helvetica Neue"/>
+                          <a:sym typeface="Helvetica Neue"/>
+                        </a:rPr>
+                        <a:t>18 Sep 2026</a:t>
+                      </a:r>
+                    </a:p>
+                  </a:txBody>
+                  <a:tcPr anchor="ctr" marB="63500" marT="63500" marR="0" marL="0">
+                    <a:lnL algn="ctr" cmpd="sng" cap="flat" w="0">
+                      <a:noFill/>
+                      <a:prstDash val="solid"/>
+                    </a:lnL>
+                    <a:lnR algn="ctr" cmpd="sng" cap="flat" w="0">
+                      <a:noFill/>
+                      <a:prstDash val="solid"/>
+                    </a:lnR>
+                    <a:lnT algn="ctr" cmpd="sng" cap="flat" w="0">
+                      <a:noFill/>
+                      <a:prstDash val="solid"/>
+                    </a:lnT>
+                    <a:lnB algn="ctr" cmpd="sng" cap="flat" w="0">
+                      <a:noFill/>
+                      <a:prstDash val="solid"/>
+                    </a:lnB>
+                    <a:solidFill>
+                      <a:srgbClr val="FFFFFF">
+                        <a:alpha val="0"/>
+                      </a:srgbClr>
+                    </a:solidFill>
+                  </a:tcPr>
+                </a:tc>
+                <a:tc>
+                  <a:txBody>
+                    <a:bodyPr/>
+                    <a:lstStyle/>
+                    <a:p>
+                      <a:pPr algn="l" marL="63500" marR="63500">
+                        <a:lnSpc>
+                          <a:spcPct val="100000"/>
+                        </a:lnSpc>
+                        <a:spcBef>
+                          <a:spcPts val="500"/>
+                        </a:spcBef>
+                        <a:spcAft>
+                          <a:spcPts val="500"/>
+                        </a:spcAft>
+                        <a:buNone/>
+                      </a:pPr>
+                      <a:r>
+                        <a:rPr cap="none" sz="1200" i="0" b="0" u="none" strike="noStrike">
+                          <a:solidFill>
+                            <a:srgbClr val="5B6770">
+                              <a:alpha val="100000"/>
+                            </a:srgbClr>
+                          </a:solidFill>
+                          <a:latin typeface="Helvetica Neue"/>
+                          <a:cs typeface="Helvetica Neue"/>
+                          <a:ea typeface="Helvetica Neue"/>
+                          <a:sym typeface="Helvetica Neue"/>
+                        </a:rPr>
+                        <a:t>primary</a:t>
+                      </a:r>
+                    </a:p>
+                  </a:txBody>
+                  <a:tcPr anchor="ctr" marB="63500" marT="63500" marR="0" marL="0">
+                    <a:lnL algn="ctr" cmpd="sng" cap="flat" w="0">
+                      <a:noFill/>
+                      <a:prstDash val="solid"/>
+                    </a:lnL>
+                    <a:lnR algn="ctr" cmpd="sng" cap="flat" w="0">
+                      <a:noFill/>
+                      <a:prstDash val="solid"/>
+                    </a:lnR>
+                    <a:lnT algn="ctr" cmpd="sng" cap="flat" w="0">
+                      <a:noFill/>
+                      <a:prstDash val="solid"/>
+                    </a:lnT>
+                    <a:lnB algn="ctr" cmpd="sng" cap="flat" w="0">
+                      <a:noFill/>
+                      <a:prstDash val="solid"/>
+                    </a:lnB>
+                    <a:solidFill>
+                      <a:srgbClr val="FFFFFF">
+                        <a:alpha val="0"/>
+                      </a:srgbClr>
+                    </a:solidFill>
+                  </a:tcPr>
+                </a:tc>
+                <a:tc>
+                  <a:txBody>
+                    <a:bodyPr/>
+                    <a:lstStyle/>
+                    <a:p>
+                      <a:pPr algn="r" marL="63500" marR="63500">
+                        <a:lnSpc>
+                          <a:spcPct val="100000"/>
+                        </a:lnSpc>
+                        <a:spcBef>
+                          <a:spcPts val="500"/>
+                        </a:spcBef>
+                        <a:spcAft>
+                          <a:spcPts val="500"/>
+                        </a:spcAft>
+                        <a:buNone/>
+                      </a:pPr>
+                      <a:r>
+                        <a:rPr cap="none" sz="1200" i="0" b="0" u="none" strike="noStrike">
+                          <a:solidFill>
+                            <a:srgbClr val="5B6770">
+                              <a:alpha val="100000"/>
+                            </a:srgbClr>
+                          </a:solidFill>
+                          <a:latin typeface="Helvetica Neue"/>
+                          <a:cs typeface="Helvetica Neue"/>
+                          <a:ea typeface="Helvetica Neue"/>
+                          <a:sym typeface="Helvetica Neue"/>
+                        </a:rPr>
+                        <a:t>1</a:t>
+                      </a:r>
+                    </a:p>
+                  </a:txBody>
+                  <a:tcPr anchor="ctr" marB="63500" marT="63500" marR="0" marL="0">
+                    <a:lnL algn="ctr" cmpd="sng" cap="flat" w="0">
+                      <a:noFill/>
+                      <a:prstDash val="solid"/>
+                    </a:lnL>
+                    <a:lnR algn="ctr" cmpd="sng" cap="flat" w="0">
+                      <a:noFill/>
+                      <a:prstDash val="solid"/>
+                    </a:lnR>
+                    <a:lnT algn="ctr" cmpd="sng" cap="flat" w="0">
+                      <a:noFill/>
+                      <a:prstDash val="solid"/>
+                    </a:lnT>
+                    <a:lnB algn="ctr" cmpd="sng" cap="flat" w="0">
+                      <a:noFill/>
+                      <a:prstDash val="solid"/>
+                    </a:lnB>
+                    <a:solidFill>
+                      <a:srgbClr val="FFFFFF">
+                        <a:alpha val="0"/>
+                      </a:srgbClr>
+                    </a:solidFill>
+                  </a:tcPr>
+                </a:tc>
+                <a:tc>
+                  <a:txBody>
+                    <a:bodyPr/>
+                    <a:lstStyle/>
+                    <a:p>
+                      <a:pPr algn="l" marL="63500" marR="63500">
+                        <a:lnSpc>
+                          <a:spcPct val="100000"/>
+                        </a:lnSpc>
+                        <a:spcBef>
+                          <a:spcPts val="500"/>
+                        </a:spcBef>
+                        <a:spcAft>
+                          <a:spcPts val="500"/>
+                        </a:spcAft>
+                        <a:buNone/>
+                      </a:pPr>
+                      <a:r>
+                        <a:rPr cap="none" sz="1200" i="0" b="0" u="none" strike="noStrike">
+                          <a:solidFill>
+                            <a:srgbClr val="5B6770">
+                              <a:alpha val="100000"/>
+                            </a:srgbClr>
+                          </a:solidFill>
+                          <a:latin typeface="Helvetica Neue"/>
+                          <a:cs typeface="Helvetica Neue"/>
+                          <a:ea typeface="Helvetica Neue"/>
+                          <a:sym typeface="Helvetica Neue"/>
+                        </a:rPr>
+                        <a:t>821737</a:t>
+                      </a:r>
+                    </a:p>
+                  </a:txBody>
+                  <a:tcPr anchor="ctr" marB="63500" marT="63500" marR="0" marL="0">
+                    <a:lnL algn="ctr" cmpd="sng" cap="flat" w="0">
+                      <a:noFill/>
+                      <a:prstDash val="solid"/>
+                    </a:lnL>
+                    <a:lnR algn="ctr" cmpd="sng" cap="flat" w="0">
+                      <a:noFill/>
+                      <a:prstDash val="solid"/>
+                    </a:lnR>
+                    <a:lnT algn="ctr" cmpd="sng" cap="flat" w="0">
+                      <a:noFill/>
+                      <a:prstDash val="solid"/>
+                    </a:lnT>
+                    <a:lnB algn="ctr" cmpd="sng" cap="flat" w="0">
+                      <a:noFill/>
+                      <a:prstDash val="solid"/>
+                    </a:lnB>
+                    <a:solidFill>
+                      <a:srgbClr val="FFFFFF">
+                        <a:alpha val="0"/>
+                      </a:srgbClr>
+                    </a:solidFill>
+                  </a:tcPr>
+                </a:tc>
+              </a:tr>
+              <a:tr h="401320">
+                <a:tc>
+                  <a:txBody>
+                    <a:bodyPr/>
+                    <a:lstStyle/>
+                    <a:p>
+                      <a:pPr algn="l" marL="63500" marR="63500">
+                        <a:lnSpc>
+                          <a:spcPct val="100000"/>
+                        </a:lnSpc>
+                        <a:spcBef>
+                          <a:spcPts val="500"/>
+                        </a:spcBef>
+                        <a:spcAft>
+                          <a:spcPts val="500"/>
+                        </a:spcAft>
+                        <a:buNone/>
+                      </a:pPr>
+                      <a:r>
+                        <a:rPr cap="none" sz="1200" i="0" b="0" u="none" strike="noStrike">
+                          <a:solidFill>
+                            <a:srgbClr val="5B6770">
+                              <a:alpha val="100000"/>
+                            </a:srgbClr>
+                          </a:solidFill>
+                          <a:latin typeface="Helvetica Neue"/>
+                          <a:cs typeface="Helvetica Neue"/>
+                          <a:ea typeface="Helvetica Neue"/>
+                          <a:sym typeface="Helvetica Neue"/>
+                        </a:rPr>
+                        <a:t>pending nitazene</a:t>
+                      </a:r>
+                    </a:p>
+                  </a:txBody>
+                  <a:tcPr anchor="ctr" marB="63500" marT="63500" marR="0" marL="0">
+                    <a:lnL algn="ctr" cmpd="sng" cap="flat" w="0">
+                      <a:noFill/>
+                      <a:prstDash val="solid"/>
+                    </a:lnL>
+                    <a:lnR algn="ctr" cmpd="sng" cap="flat" w="0">
+                      <a:noFill/>
+                      <a:prstDash val="solid"/>
+                    </a:lnR>
+                    <a:lnT algn="ctr" cmpd="sng" cap="flat" w="0">
+                      <a:noFill/>
+                      <a:prstDash val="solid"/>
+                    </a:lnT>
+                    <a:lnB algn="ctr" cmpd="sng" cap="flat" w="0">
+                      <a:noFill/>
+                      <a:prstDash val="solid"/>
+                    </a:lnB>
+                    <a:solidFill>
+                      <a:srgbClr val="F4F8FB">
+                        <a:alpha val="100000"/>
+                      </a:srgbClr>
+                    </a:solidFill>
+                  </a:tcPr>
+                </a:tc>
+                <a:tc>
+                  <a:txBody>
+                    <a:bodyPr/>
+                    <a:lstStyle/>
+                    <a:p>
+                      <a:pPr algn="l" marL="63500" marR="63500">
+                        <a:lnSpc>
+                          <a:spcPct val="100000"/>
+                        </a:lnSpc>
+                        <a:spcBef>
+                          <a:spcPts val="500"/>
+                        </a:spcBef>
+                        <a:spcAft>
+                          <a:spcPts val="500"/>
+                        </a:spcAft>
+                        <a:buNone/>
+                      </a:pPr>
+                      <a:r>
+                        <a:rPr cap="none" sz="1200" i="0" b="0" u="none" strike="noStrike">
+                          <a:solidFill>
+                            <a:srgbClr val="5B6770">
+                              <a:alpha val="100000"/>
+                            </a:srgbClr>
+                          </a:solidFill>
+                          <a:latin typeface="Helvetica Neue"/>
+                          <a:cs typeface="Helvetica Neue"/>
+                          <a:ea typeface="Helvetica Neue"/>
+                          <a:sym typeface="Helvetica Neue"/>
+                        </a:rPr>
+                        <a:t>18 Sep 2026</a:t>
+                      </a:r>
+                    </a:p>
+                  </a:txBody>
+                  <a:tcPr anchor="ctr" marB="63500" marT="63500" marR="0" marL="0">
+                    <a:lnL algn="ctr" cmpd="sng" cap="flat" w="0">
+                      <a:noFill/>
+                      <a:prstDash val="solid"/>
+                    </a:lnL>
+                    <a:lnR algn="ctr" cmpd="sng" cap="flat" w="0">
+                      <a:noFill/>
+                      <a:prstDash val="solid"/>
+                    </a:lnR>
+                    <a:lnT algn="ctr" cmpd="sng" cap="flat" w="0">
+                      <a:noFill/>
+                      <a:prstDash val="solid"/>
+                    </a:lnT>
+                    <a:lnB algn="ctr" cmpd="sng" cap="flat" w="0">
+                      <a:noFill/>
+                      <a:prstDash val="solid"/>
+                    </a:lnB>
+                    <a:solidFill>
+                      <a:srgbClr val="F4F8FB">
+                        <a:alpha val="100000"/>
+                      </a:srgbClr>
+                    </a:solidFill>
+                  </a:tcPr>
+                </a:tc>
+                <a:tc>
+                  <a:txBody>
+                    <a:bodyPr/>
+                    <a:lstStyle/>
+                    <a:p>
+                      <a:pPr algn="l" marL="63500" marR="63500">
+                        <a:lnSpc>
+                          <a:spcPct val="100000"/>
+                        </a:lnSpc>
+                        <a:spcBef>
+                          <a:spcPts val="500"/>
+                        </a:spcBef>
+                        <a:spcAft>
+                          <a:spcPts val="500"/>
+                        </a:spcAft>
+                        <a:buNone/>
+                      </a:pPr>
+                      <a:r>
+                        <a:rPr cap="none" sz="1200" i="0" b="0" u="none" strike="noStrike">
+                          <a:solidFill>
+                            <a:srgbClr val="5B6770">
+                              <a:alpha val="100000"/>
+                            </a:srgbClr>
+                          </a:solidFill>
+                          <a:latin typeface="Helvetica Neue"/>
+                          <a:cs typeface="Helvetica Neue"/>
+                          <a:ea typeface="Helvetica Neue"/>
+                          <a:sym typeface="Helvetica Neue"/>
+                        </a:rPr>
+                        <a:t>primary</a:t>
+                      </a:r>
+                    </a:p>
+                  </a:txBody>
+                  <a:tcPr anchor="ctr" marB="63500" marT="63500" marR="0" marL="0">
+                    <a:lnL algn="ctr" cmpd="sng" cap="flat" w="0">
+                      <a:noFill/>
+                      <a:prstDash val="solid"/>
+                    </a:lnL>
+                    <a:lnR algn="ctr" cmpd="sng" cap="flat" w="0">
+                      <a:noFill/>
+                      <a:prstDash val="solid"/>
+                    </a:lnR>
+                    <a:lnT algn="ctr" cmpd="sng" cap="flat" w="0">
+                      <a:noFill/>
+                      <a:prstDash val="solid"/>
+                    </a:lnT>
+                    <a:lnB algn="ctr" cmpd="sng" cap="flat" w="0">
+                      <a:noFill/>
+                      <a:prstDash val="solid"/>
+                    </a:lnB>
+                    <a:solidFill>
+                      <a:srgbClr val="F4F8FB">
+                        <a:alpha val="100000"/>
+                      </a:srgbClr>
+                    </a:solidFill>
+                  </a:tcPr>
+                </a:tc>
+                <a:tc>
+                  <a:txBody>
+                    <a:bodyPr/>
+                    <a:lstStyle/>
+                    <a:p>
+                      <a:pPr algn="r" marL="63500" marR="63500">
+                        <a:lnSpc>
+                          <a:spcPct val="100000"/>
+                        </a:lnSpc>
+                        <a:spcBef>
+                          <a:spcPts val="500"/>
+                        </a:spcBef>
+                        <a:spcAft>
+                          <a:spcPts val="500"/>
+                        </a:spcAft>
+                        <a:buNone/>
+                      </a:pPr>
+                      <a:r>
+                        <a:rPr cap="none" sz="1200" i="0" b="0" u="none" strike="noStrike">
+                          <a:solidFill>
+                            <a:srgbClr val="5B6770">
+                              <a:alpha val="100000"/>
+                            </a:srgbClr>
+                          </a:solidFill>
+                          <a:latin typeface="Helvetica Neue"/>
+                          <a:cs typeface="Helvetica Neue"/>
+                          <a:ea typeface="Helvetica Neue"/>
+                          <a:sym typeface="Helvetica Neue"/>
+                        </a:rPr>
+                        <a:t>3</a:t>
+                      </a:r>
+                    </a:p>
+                  </a:txBody>
+                  <a:tcPr anchor="ctr" marB="63500" marT="63500" marR="0" marL="0">
+                    <a:lnL algn="ctr" cmpd="sng" cap="flat" w="0">
+                      <a:noFill/>
+                      <a:prstDash val="solid"/>
+                    </a:lnL>
+                    <a:lnR algn="ctr" cmpd="sng" cap="flat" w="0">
+                      <a:noFill/>
+                      <a:prstDash val="solid"/>
+                    </a:lnR>
+                    <a:lnT algn="ctr" cmpd="sng" cap="flat" w="0">
+                      <a:noFill/>
+                      <a:prstDash val="solid"/>
+                    </a:lnT>
+                    <a:lnB algn="ctr" cmpd="sng" cap="flat" w="0">
+                      <a:noFill/>
+                      <a:prstDash val="solid"/>
+                    </a:lnB>
+                    <a:solidFill>
+                      <a:srgbClr val="F4F8FB">
+                        <a:alpha val="100000"/>
+                      </a:srgbClr>
+                    </a:solidFill>
+                  </a:tcPr>
+                </a:tc>
+                <a:tc>
+                  <a:txBody>
+                    <a:bodyPr/>
+                    <a:lstStyle/>
+                    <a:p>
+                      <a:pPr algn="l" marL="63500" marR="63500">
+                        <a:lnSpc>
+                          <a:spcPct val="100000"/>
+                        </a:lnSpc>
+                        <a:spcBef>
+                          <a:spcPts val="500"/>
+                        </a:spcBef>
+                        <a:spcAft>
+                          <a:spcPts val="500"/>
+                        </a:spcAft>
+                        <a:buNone/>
+                      </a:pPr>
+                      <a:r>
+                        <a:rPr cap="none" sz="1200" i="0" b="0" u="none" strike="noStrike">
+                          <a:solidFill>
+                            <a:srgbClr val="5B6770">
+                              <a:alpha val="100000"/>
+                            </a:srgbClr>
+                          </a:solidFill>
+                          <a:latin typeface="Helvetica Neue"/>
+                          <a:cs typeface="Helvetica Neue"/>
+                          <a:ea typeface="Helvetica Neue"/>
+                          <a:sym typeface="Helvetica Neue"/>
+                        </a:rPr>
+                        <a:t>901255</a:t>
+                      </a:r>
+                    </a:p>
+                  </a:txBody>
+                  <a:tcPr anchor="ctr" marB="63500" marT="63500" marR="0" marL="0">
+                    <a:lnL algn="ctr" cmpd="sng" cap="flat" w="0">
+                      <a:noFill/>
+                      <a:prstDash val="solid"/>
+                    </a:lnL>
+                    <a:lnR algn="ctr" cmpd="sng" cap="flat" w="0">
+                      <a:noFill/>
+                      <a:prstDash val="solid"/>
+                    </a:lnR>
+                    <a:lnT algn="ctr" cmpd="sng" cap="flat" w="0">
+                      <a:noFill/>
+                      <a:prstDash val="solid"/>
+                    </a:lnT>
+                    <a:lnB algn="ctr" cmpd="sng" cap="flat" w="0">
+                      <a:noFill/>
+                      <a:prstDash val="solid"/>
+                    </a:lnB>
+                    <a:solidFill>
+                      <a:srgbClr val="F4F8FB">
+                        <a:alpha val="100000"/>
+                      </a:srgbClr>
+                    </a:solidFill>
+                  </a:tcPr>
+                </a:tc>
+              </a:tr>
+              <a:tr h="401320">
+                <a:tc>
+                  <a:txBody>
+                    <a:bodyPr/>
+                    <a:lstStyle/>
+                    <a:p>
+                      <a:pPr algn="l" marL="63500" marR="63500">
+                        <a:lnSpc>
+                          <a:spcPct val="100000"/>
+                        </a:lnSpc>
+                        <a:spcBef>
+                          <a:spcPts val="500"/>
+                        </a:spcBef>
+                        <a:spcAft>
+                          <a:spcPts val="500"/>
+                        </a:spcAft>
+                        <a:buNone/>
+                      </a:pPr>
+                      <a:r>
+                        <a:rPr cap="none" sz="1200" i="0" b="0" u="none" strike="noStrike">
+                          <a:solidFill>
+                            <a:srgbClr val="5B6770">
+                              <a:alpha val="100000"/>
+                            </a:srgbClr>
+                          </a:solidFill>
+                          <a:latin typeface="Helvetica Neue"/>
+                          <a:cs typeface="Helvetica Neue"/>
+                          <a:ea typeface="Helvetica Neue"/>
+                          <a:sym typeface="Helvetica Neue"/>
+                        </a:rPr>
                         <a:t>SR 17018</a:t>
                       </a:r>
                     </a:p>
@@ -13602,7 +14176,7 @@
                   </a:tcPr>
                 </a:tc>
               </a:tr>
-              <a:tr h="401320">
+              <a:tr h="410845">
                 <a:tc>
                   <a:txBody>
                     <a:bodyPr/>
@@ -13649,8 +14223,12 @@
                       <a:noFill/>
                       <a:prstDash val="solid"/>
                     </a:lnT>
-                    <a:lnB algn="ctr" cmpd="sng" cap="flat" w="0">
-                      <a:noFill/>
+                    <a:lnB algn="ctr" cmpd="sng" cap="flat" w="19050">
+                      <a:solidFill>
+                        <a:srgbClr val="666666">
+                          <a:alpha val="100000"/>
+                        </a:srgbClr>
+                      </a:solidFill>
                       <a:prstDash val="solid"/>
                     </a:lnB>
                     <a:solidFill>
@@ -13706,8 +14284,12 @@
                       <a:noFill/>
                       <a:prstDash val="solid"/>
                     </a:lnT>
-                    <a:lnB algn="ctr" cmpd="sng" cap="flat" w="0">
-                      <a:noFill/>
+                    <a:lnB algn="ctr" cmpd="sng" cap="flat" w="19050">
+                      <a:solidFill>
+                        <a:srgbClr val="666666">
+                          <a:alpha val="100000"/>
+                        </a:srgbClr>
+                      </a:solidFill>
                       <a:prstDash val="solid"/>
                     </a:lnB>
                     <a:solidFill>
@@ -13763,8 +14345,12 @@
                       <a:noFill/>
                       <a:prstDash val="solid"/>
                     </a:lnT>
-                    <a:lnB algn="ctr" cmpd="sng" cap="flat" w="0">
-                      <a:noFill/>
+                    <a:lnB algn="ctr" cmpd="sng" cap="flat" w="19050">
+                      <a:solidFill>
+                        <a:srgbClr val="666666">
+                          <a:alpha val="100000"/>
+                        </a:srgbClr>
+                      </a:solidFill>
                       <a:prstDash val="solid"/>
                     </a:lnB>
                     <a:solidFill>
@@ -13820,8 +14406,12 @@
                       <a:noFill/>
                       <a:prstDash val="solid"/>
                     </a:lnT>
-                    <a:lnB algn="ctr" cmpd="sng" cap="flat" w="0">
-                      <a:noFill/>
+                    <a:lnB algn="ctr" cmpd="sng" cap="flat" w="19050">
+                      <a:solidFill>
+                        <a:srgbClr val="666666">
+                          <a:alpha val="100000"/>
+                        </a:srgbClr>
+                      </a:solidFill>
                       <a:prstDash val="solid"/>
                     </a:lnB>
                     <a:solidFill>
@@ -13861,596 +14451,6 @@
                           <a:sym typeface="Helvetica Neue"/>
                         </a:rPr>
                         <a:t>603217</a:t>
-                      </a:r>
-                    </a:p>
-                  </a:txBody>
-                  <a:tcPr anchor="ctr" marB="63500" marT="63500" marR="0" marL="0">
-                    <a:lnL algn="ctr" cmpd="sng" cap="flat" w="0">
-                      <a:noFill/>
-                      <a:prstDash val="solid"/>
-                    </a:lnL>
-                    <a:lnR algn="ctr" cmpd="sng" cap="flat" w="0">
-                      <a:noFill/>
-                      <a:prstDash val="solid"/>
-                    </a:lnR>
-                    <a:lnT algn="ctr" cmpd="sng" cap="flat" w="0">
-                      <a:noFill/>
-                      <a:prstDash val="solid"/>
-                    </a:lnT>
-                    <a:lnB algn="ctr" cmpd="sng" cap="flat" w="0">
-                      <a:noFill/>
-                      <a:prstDash val="solid"/>
-                    </a:lnB>
-                    <a:solidFill>
-                      <a:srgbClr val="F4F8FB">
-                        <a:alpha val="100000"/>
-                      </a:srgbClr>
-                    </a:solidFill>
-                  </a:tcPr>
-                </a:tc>
-              </a:tr>
-              <a:tr h="401320">
-                <a:tc>
-                  <a:txBody>
-                    <a:bodyPr/>
-                    <a:lstStyle/>
-                    <a:p>
-                      <a:pPr algn="l" marL="63500" marR="63500">
-                        <a:lnSpc>
-                          <a:spcPct val="100000"/>
-                        </a:lnSpc>
-                        <a:spcBef>
-                          <a:spcPts val="500"/>
-                        </a:spcBef>
-                        <a:spcAft>
-                          <a:spcPts val="500"/>
-                        </a:spcAft>
-                        <a:buNone/>
-                      </a:pPr>
-                      <a:r>
-                        <a:rPr cap="none" sz="1200" i="0" b="0" u="none" strike="noStrike">
-                          <a:solidFill>
-                            <a:srgbClr val="5B6770">
-                              <a:alpha val="100000"/>
-                            </a:srgbClr>
-                          </a:solidFill>
-                          <a:latin typeface="Helvetica Neue"/>
-                          <a:cs typeface="Helvetica Neue"/>
-                          <a:ea typeface="Helvetica Neue"/>
-                          <a:sym typeface="Helvetica Neue"/>
-                        </a:rPr>
-                        <a:t>MDMB-4en-PINACA</a:t>
-                      </a:r>
-                    </a:p>
-                  </a:txBody>
-                  <a:tcPr anchor="ctr" marB="63500" marT="63500" marR="0" marL="0">
-                    <a:lnL algn="ctr" cmpd="sng" cap="flat" w="0">
-                      <a:noFill/>
-                      <a:prstDash val="solid"/>
-                    </a:lnL>
-                    <a:lnR algn="ctr" cmpd="sng" cap="flat" w="0">
-                      <a:noFill/>
-                      <a:prstDash val="solid"/>
-                    </a:lnR>
-                    <a:lnT algn="ctr" cmpd="sng" cap="flat" w="0">
-                      <a:noFill/>
-                      <a:prstDash val="solid"/>
-                    </a:lnT>
-                    <a:lnB algn="ctr" cmpd="sng" cap="flat" w="0">
-                      <a:noFill/>
-                      <a:prstDash val="solid"/>
-                    </a:lnB>
-                    <a:solidFill>
-                      <a:srgbClr val="FFFFFF">
-                        <a:alpha val="0"/>
-                      </a:srgbClr>
-                    </a:solidFill>
-                  </a:tcPr>
-                </a:tc>
-                <a:tc>
-                  <a:txBody>
-                    <a:bodyPr/>
-                    <a:lstStyle/>
-                    <a:p>
-                      <a:pPr algn="l" marL="63500" marR="63500">
-                        <a:lnSpc>
-                          <a:spcPct val="100000"/>
-                        </a:lnSpc>
-                        <a:spcBef>
-                          <a:spcPts val="500"/>
-                        </a:spcBef>
-                        <a:spcAft>
-                          <a:spcPts val="500"/>
-                        </a:spcAft>
-                        <a:buNone/>
-                      </a:pPr>
-                      <a:r>
-                        <a:rPr cap="none" sz="1200" i="0" b="0" u="none" strike="noStrike">
-                          <a:solidFill>
-                            <a:srgbClr val="5B6770">
-                              <a:alpha val="100000"/>
-                            </a:srgbClr>
-                          </a:solidFill>
-                          <a:latin typeface="Helvetica Neue"/>
-                          <a:cs typeface="Helvetica Neue"/>
-                          <a:ea typeface="Helvetica Neue"/>
-                          <a:sym typeface="Helvetica Neue"/>
-                        </a:rPr>
-                        <a:t>10 Jul 2026</a:t>
-                      </a:r>
-                    </a:p>
-                  </a:txBody>
-                  <a:tcPr anchor="ctr" marB="63500" marT="63500" marR="0" marL="0">
-                    <a:lnL algn="ctr" cmpd="sng" cap="flat" w="0">
-                      <a:noFill/>
-                      <a:prstDash val="solid"/>
-                    </a:lnL>
-                    <a:lnR algn="ctr" cmpd="sng" cap="flat" w="0">
-                      <a:noFill/>
-                      <a:prstDash val="solid"/>
-                    </a:lnR>
-                    <a:lnT algn="ctr" cmpd="sng" cap="flat" w="0">
-                      <a:noFill/>
-                      <a:prstDash val="solid"/>
-                    </a:lnT>
-                    <a:lnB algn="ctr" cmpd="sng" cap="flat" w="0">
-                      <a:noFill/>
-                      <a:prstDash val="solid"/>
-                    </a:lnB>
-                    <a:solidFill>
-                      <a:srgbClr val="FFFFFF">
-                        <a:alpha val="0"/>
-                      </a:srgbClr>
-                    </a:solidFill>
-                  </a:tcPr>
-                </a:tc>
-                <a:tc>
-                  <a:txBody>
-                    <a:bodyPr/>
-                    <a:lstStyle/>
-                    <a:p>
-                      <a:pPr algn="l" marL="63500" marR="63500">
-                        <a:lnSpc>
-                          <a:spcPct val="100000"/>
-                        </a:lnSpc>
-                        <a:spcBef>
-                          <a:spcPts val="500"/>
-                        </a:spcBef>
-                        <a:spcAft>
-                          <a:spcPts val="500"/>
-                        </a:spcAft>
-                        <a:buNone/>
-                      </a:pPr>
-                      <a:r>
-                        <a:rPr cap="none" sz="1200" i="0" b="0" u="none" strike="noStrike">
-                          <a:solidFill>
-                            <a:srgbClr val="5B6770">
-                              <a:alpha val="100000"/>
-                            </a:srgbClr>
-                          </a:solidFill>
-                          <a:latin typeface="Helvetica Neue"/>
-                          <a:cs typeface="Helvetica Neue"/>
-                          <a:ea typeface="Helvetica Neue"/>
-                          <a:sym typeface="Helvetica Neue"/>
-                        </a:rPr>
-                        <a:t>primary</a:t>
-                      </a:r>
-                    </a:p>
-                  </a:txBody>
-                  <a:tcPr anchor="ctr" marB="63500" marT="63500" marR="0" marL="0">
-                    <a:lnL algn="ctr" cmpd="sng" cap="flat" w="0">
-                      <a:noFill/>
-                      <a:prstDash val="solid"/>
-                    </a:lnL>
-                    <a:lnR algn="ctr" cmpd="sng" cap="flat" w="0">
-                      <a:noFill/>
-                      <a:prstDash val="solid"/>
-                    </a:lnR>
-                    <a:lnT algn="ctr" cmpd="sng" cap="flat" w="0">
-                      <a:noFill/>
-                      <a:prstDash val="solid"/>
-                    </a:lnT>
-                    <a:lnB algn="ctr" cmpd="sng" cap="flat" w="0">
-                      <a:noFill/>
-                      <a:prstDash val="solid"/>
-                    </a:lnB>
-                    <a:solidFill>
-                      <a:srgbClr val="FFFFFF">
-                        <a:alpha val="0"/>
-                      </a:srgbClr>
-                    </a:solidFill>
-                  </a:tcPr>
-                </a:tc>
-                <a:tc>
-                  <a:txBody>
-                    <a:bodyPr/>
-                    <a:lstStyle/>
-                    <a:p>
-                      <a:pPr algn="r" marL="63500" marR="63500">
-                        <a:lnSpc>
-                          <a:spcPct val="100000"/>
-                        </a:lnSpc>
-                        <a:spcBef>
-                          <a:spcPts val="500"/>
-                        </a:spcBef>
-                        <a:spcAft>
-                          <a:spcPts val="500"/>
-                        </a:spcAft>
-                        <a:buNone/>
-                      </a:pPr>
-                      <a:r>
-                        <a:rPr cap="none" sz="1200" i="0" b="0" u="none" strike="noStrike">
-                          <a:solidFill>
-                            <a:srgbClr val="5B6770">
-                              <a:alpha val="100000"/>
-                            </a:srgbClr>
-                          </a:solidFill>
-                          <a:latin typeface="Helvetica Neue"/>
-                          <a:cs typeface="Helvetica Neue"/>
-                          <a:ea typeface="Helvetica Neue"/>
-                          <a:sym typeface="Helvetica Neue"/>
-                        </a:rPr>
-                        <a:t>1</a:t>
-                      </a:r>
-                    </a:p>
-                  </a:txBody>
-                  <a:tcPr anchor="ctr" marB="63500" marT="63500" marR="0" marL="0">
-                    <a:lnL algn="ctr" cmpd="sng" cap="flat" w="0">
-                      <a:noFill/>
-                      <a:prstDash val="solid"/>
-                    </a:lnL>
-                    <a:lnR algn="ctr" cmpd="sng" cap="flat" w="0">
-                      <a:noFill/>
-                      <a:prstDash val="solid"/>
-                    </a:lnR>
-                    <a:lnT algn="ctr" cmpd="sng" cap="flat" w="0">
-                      <a:noFill/>
-                      <a:prstDash val="solid"/>
-                    </a:lnT>
-                    <a:lnB algn="ctr" cmpd="sng" cap="flat" w="0">
-                      <a:noFill/>
-                      <a:prstDash val="solid"/>
-                    </a:lnB>
-                    <a:solidFill>
-                      <a:srgbClr val="FFFFFF">
-                        <a:alpha val="0"/>
-                      </a:srgbClr>
-                    </a:solidFill>
-                  </a:tcPr>
-                </a:tc>
-                <a:tc>
-                  <a:txBody>
-                    <a:bodyPr/>
-                    <a:lstStyle/>
-                    <a:p>
-                      <a:pPr algn="l" marL="63500" marR="63500">
-                        <a:lnSpc>
-                          <a:spcPct val="100000"/>
-                        </a:lnSpc>
-                        <a:spcBef>
-                          <a:spcPts val="500"/>
-                        </a:spcBef>
-                        <a:spcAft>
-                          <a:spcPts val="500"/>
-                        </a:spcAft>
-                        <a:buNone/>
-                      </a:pPr>
-                      <a:r>
-                        <a:rPr cap="none" sz="1200" i="0" b="0" u="none" strike="noStrike">
-                          <a:solidFill>
-                            <a:srgbClr val="5B6770">
-                              <a:alpha val="100000"/>
-                            </a:srgbClr>
-                          </a:solidFill>
-                          <a:latin typeface="Helvetica Neue"/>
-                          <a:cs typeface="Helvetica Neue"/>
-                          <a:ea typeface="Helvetica Neue"/>
-                          <a:sym typeface="Helvetica Neue"/>
-                        </a:rPr>
-                        <a:t>605414</a:t>
-                      </a:r>
-                    </a:p>
-                  </a:txBody>
-                  <a:tcPr anchor="ctr" marB="63500" marT="63500" marR="0" marL="0">
-                    <a:lnL algn="ctr" cmpd="sng" cap="flat" w="0">
-                      <a:noFill/>
-                      <a:prstDash val="solid"/>
-                    </a:lnL>
-                    <a:lnR algn="ctr" cmpd="sng" cap="flat" w="0">
-                      <a:noFill/>
-                      <a:prstDash val="solid"/>
-                    </a:lnR>
-                    <a:lnT algn="ctr" cmpd="sng" cap="flat" w="0">
-                      <a:noFill/>
-                      <a:prstDash val="solid"/>
-                    </a:lnT>
-                    <a:lnB algn="ctr" cmpd="sng" cap="flat" w="0">
-                      <a:noFill/>
-                      <a:prstDash val="solid"/>
-                    </a:lnB>
-                    <a:solidFill>
-                      <a:srgbClr val="FFFFFF">
-                        <a:alpha val="0"/>
-                      </a:srgbClr>
-                    </a:solidFill>
-                  </a:tcPr>
-                </a:tc>
-              </a:tr>
-              <a:tr h="410845">
-                <a:tc>
-                  <a:txBody>
-                    <a:bodyPr/>
-                    <a:lstStyle/>
-                    <a:p>
-                      <a:pPr algn="l" marL="63500" marR="63500">
-                        <a:lnSpc>
-                          <a:spcPct val="100000"/>
-                        </a:lnSpc>
-                        <a:spcBef>
-                          <a:spcPts val="500"/>
-                        </a:spcBef>
-                        <a:spcAft>
-                          <a:spcPts val="500"/>
-                        </a:spcAft>
-                        <a:buNone/>
-                      </a:pPr>
-                      <a:r>
-                        <a:rPr cap="none" sz="1200" i="0" b="0" u="none" strike="noStrike">
-                          <a:solidFill>
-                            <a:srgbClr val="5B6770">
-                              <a:alpha val="100000"/>
-                            </a:srgbClr>
-                          </a:solidFill>
-                          <a:latin typeface="Helvetica Neue"/>
-                          <a:cs typeface="Helvetica Neue"/>
-                          <a:ea typeface="Helvetica Neue"/>
-                          <a:sym typeface="Helvetica Neue"/>
-                        </a:rPr>
-                        <a:t>triacetin</a:t>
-                      </a:r>
-                    </a:p>
-                  </a:txBody>
-                  <a:tcPr anchor="ctr" marB="63500" marT="63500" marR="0" marL="0">
-                    <a:lnL algn="ctr" cmpd="sng" cap="flat" w="0">
-                      <a:noFill/>
-                      <a:prstDash val="solid"/>
-                    </a:lnL>
-                    <a:lnR algn="ctr" cmpd="sng" cap="flat" w="0">
-                      <a:noFill/>
-                      <a:prstDash val="solid"/>
-                    </a:lnR>
-                    <a:lnT algn="ctr" cmpd="sng" cap="flat" w="0">
-                      <a:noFill/>
-                      <a:prstDash val="solid"/>
-                    </a:lnT>
-                    <a:lnB algn="ctr" cmpd="sng" cap="flat" w="19050">
-                      <a:solidFill>
-                        <a:srgbClr val="666666">
-                          <a:alpha val="100000"/>
-                        </a:srgbClr>
-                      </a:solidFill>
-                      <a:prstDash val="solid"/>
-                    </a:lnB>
-                    <a:solidFill>
-                      <a:srgbClr val="F4F8FB">
-                        <a:alpha val="100000"/>
-                      </a:srgbClr>
-                    </a:solidFill>
-                  </a:tcPr>
-                </a:tc>
-                <a:tc>
-                  <a:txBody>
-                    <a:bodyPr/>
-                    <a:lstStyle/>
-                    <a:p>
-                      <a:pPr algn="l" marL="63500" marR="63500">
-                        <a:lnSpc>
-                          <a:spcPct val="100000"/>
-                        </a:lnSpc>
-                        <a:spcBef>
-                          <a:spcPts val="500"/>
-                        </a:spcBef>
-                        <a:spcAft>
-                          <a:spcPts val="500"/>
-                        </a:spcAft>
-                        <a:buNone/>
-                      </a:pPr>
-                      <a:r>
-                        <a:rPr cap="none" sz="1200" i="0" b="0" u="none" strike="noStrike">
-                          <a:solidFill>
-                            <a:srgbClr val="5B6770">
-                              <a:alpha val="100000"/>
-                            </a:srgbClr>
-                          </a:solidFill>
-                          <a:latin typeface="Helvetica Neue"/>
-                          <a:cs typeface="Helvetica Neue"/>
-                          <a:ea typeface="Helvetica Neue"/>
-                          <a:sym typeface="Helvetica Neue"/>
-                        </a:rPr>
-                        <a:t>25 Jun 2026</a:t>
-                      </a:r>
-                    </a:p>
-                  </a:txBody>
-                  <a:tcPr anchor="ctr" marB="63500" marT="63500" marR="0" marL="0">
-                    <a:lnL algn="ctr" cmpd="sng" cap="flat" w="0">
-                      <a:noFill/>
-                      <a:prstDash val="solid"/>
-                    </a:lnL>
-                    <a:lnR algn="ctr" cmpd="sng" cap="flat" w="0">
-                      <a:noFill/>
-                      <a:prstDash val="solid"/>
-                    </a:lnR>
-                    <a:lnT algn="ctr" cmpd="sng" cap="flat" w="0">
-                      <a:noFill/>
-                      <a:prstDash val="solid"/>
-                    </a:lnT>
-                    <a:lnB algn="ctr" cmpd="sng" cap="flat" w="19050">
-                      <a:solidFill>
-                        <a:srgbClr val="666666">
-                          <a:alpha val="100000"/>
-                        </a:srgbClr>
-                      </a:solidFill>
-                      <a:prstDash val="solid"/>
-                    </a:lnB>
-                    <a:solidFill>
-                      <a:srgbClr val="F4F8FB">
-                        <a:alpha val="100000"/>
-                      </a:srgbClr>
-                    </a:solidFill>
-                  </a:tcPr>
-                </a:tc>
-                <a:tc>
-                  <a:txBody>
-                    <a:bodyPr/>
-                    <a:lstStyle/>
-                    <a:p>
-                      <a:pPr algn="l" marL="63500" marR="63500">
-                        <a:lnSpc>
-                          <a:spcPct val="100000"/>
-                        </a:lnSpc>
-                        <a:spcBef>
-                          <a:spcPts val="500"/>
-                        </a:spcBef>
-                        <a:spcAft>
-                          <a:spcPts val="500"/>
-                        </a:spcAft>
-                        <a:buNone/>
-                      </a:pPr>
-                      <a:r>
-                        <a:rPr cap="none" sz="1200" i="0" b="0" u="none" strike="noStrike">
-                          <a:solidFill>
-                            <a:srgbClr val="5B6770">
-                              <a:alpha val="100000"/>
-                            </a:srgbClr>
-                          </a:solidFill>
-                          <a:latin typeface="Helvetica Neue"/>
-                          <a:cs typeface="Helvetica Neue"/>
-                          <a:ea typeface="Helvetica Neue"/>
-                          <a:sym typeface="Helvetica Neue"/>
-                        </a:rPr>
-                        <a:t>primary</a:t>
-                      </a:r>
-                    </a:p>
-                  </a:txBody>
-                  <a:tcPr anchor="ctr" marB="63500" marT="63500" marR="0" marL="0">
-                    <a:lnL algn="ctr" cmpd="sng" cap="flat" w="0">
-                      <a:noFill/>
-                      <a:prstDash val="solid"/>
-                    </a:lnL>
-                    <a:lnR algn="ctr" cmpd="sng" cap="flat" w="0">
-                      <a:noFill/>
-                      <a:prstDash val="solid"/>
-                    </a:lnR>
-                    <a:lnT algn="ctr" cmpd="sng" cap="flat" w="0">
-                      <a:noFill/>
-                      <a:prstDash val="solid"/>
-                    </a:lnT>
-                    <a:lnB algn="ctr" cmpd="sng" cap="flat" w="19050">
-                      <a:solidFill>
-                        <a:srgbClr val="666666">
-                          <a:alpha val="100000"/>
-                        </a:srgbClr>
-                      </a:solidFill>
-                      <a:prstDash val="solid"/>
-                    </a:lnB>
-                    <a:solidFill>
-                      <a:srgbClr val="F4F8FB">
-                        <a:alpha val="100000"/>
-                      </a:srgbClr>
-                    </a:solidFill>
-                  </a:tcPr>
-                </a:tc>
-                <a:tc>
-                  <a:txBody>
-                    <a:bodyPr/>
-                    <a:lstStyle/>
-                    <a:p>
-                      <a:pPr algn="r" marL="63500" marR="63500">
-                        <a:lnSpc>
-                          <a:spcPct val="100000"/>
-                        </a:lnSpc>
-                        <a:spcBef>
-                          <a:spcPts val="500"/>
-                        </a:spcBef>
-                        <a:spcAft>
-                          <a:spcPts val="500"/>
-                        </a:spcAft>
-                        <a:buNone/>
-                      </a:pPr>
-                      <a:r>
-                        <a:rPr cap="none" sz="1200" i="0" b="0" u="none" strike="noStrike">
-                          <a:solidFill>
-                            <a:srgbClr val="5B6770">
-                              <a:alpha val="100000"/>
-                            </a:srgbClr>
-                          </a:solidFill>
-                          <a:latin typeface="Helvetica Neue"/>
-                          <a:cs typeface="Helvetica Neue"/>
-                          <a:ea typeface="Helvetica Neue"/>
-                          <a:sym typeface="Helvetica Neue"/>
-                        </a:rPr>
-                        <a:t>20</a:t>
-                      </a:r>
-                    </a:p>
-                  </a:txBody>
-                  <a:tcPr anchor="ctr" marB="63500" marT="63500" marR="0" marL="0">
-                    <a:lnL algn="ctr" cmpd="sng" cap="flat" w="0">
-                      <a:noFill/>
-                      <a:prstDash val="solid"/>
-                    </a:lnL>
-                    <a:lnR algn="ctr" cmpd="sng" cap="flat" w="0">
-                      <a:noFill/>
-                      <a:prstDash val="solid"/>
-                    </a:lnR>
-                    <a:lnT algn="ctr" cmpd="sng" cap="flat" w="0">
-                      <a:noFill/>
-                      <a:prstDash val="solid"/>
-                    </a:lnT>
-                    <a:lnB algn="ctr" cmpd="sng" cap="flat" w="19050">
-                      <a:solidFill>
-                        <a:srgbClr val="666666">
-                          <a:alpha val="100000"/>
-                        </a:srgbClr>
-                      </a:solidFill>
-                      <a:prstDash val="solid"/>
-                    </a:lnB>
-                    <a:solidFill>
-                      <a:srgbClr val="F4F8FB">
-                        <a:alpha val="100000"/>
-                      </a:srgbClr>
-                    </a:solidFill>
-                  </a:tcPr>
-                </a:tc>
-                <a:tc>
-                  <a:txBody>
-                    <a:bodyPr/>
-                    <a:lstStyle/>
-                    <a:p>
-                      <a:pPr algn="l" marL="63500" marR="63500">
-                        <a:lnSpc>
-                          <a:spcPct val="100000"/>
-                        </a:lnSpc>
-                        <a:spcBef>
-                          <a:spcPts val="500"/>
-                        </a:spcBef>
-                        <a:spcAft>
-                          <a:spcPts val="500"/>
-                        </a:spcAft>
-                        <a:buNone/>
-                      </a:pPr>
-                      <a:r>
-                        <a:rPr cap="none" sz="1200" i="0" b="0" u="none" strike="noStrike">
-                          <a:solidFill>
-                            <a:srgbClr val="5B6770">
-                              <a:alpha val="100000"/>
-                            </a:srgbClr>
-                          </a:solidFill>
-                          <a:latin typeface="Helvetica Neue"/>
-                          <a:cs typeface="Helvetica Neue"/>
-                          <a:ea typeface="Helvetica Neue"/>
-                          <a:sym typeface="Helvetica Neue"/>
-                        </a:rPr>
-                        <a:t>900817</a:t>
                       </a:r>
                     </a:p>
                   </a:txBody>
@@ -18510,7 +18510,7 @@
                           <a:ea typeface="Helvetica Neue"/>
                           <a:sym typeface="Helvetica Neue"/>
                         </a:rPr>
-                        <a:t>1,454</a:t>
+                        <a:t>1,469</a:t>
                       </a:r>
                     </a:p>
                   </a:txBody>
@@ -18626,7 +18626,7 @@
                           <a:ea typeface="Helvetica Neue"/>
                           <a:sym typeface="Helvetica Neue"/>
                         </a:rPr>
-                        <a:t>438</a:t>
+                        <a:t>439</a:t>
                       </a:r>
                     </a:p>
                   </a:txBody>
@@ -18742,7 +18742,7 @@
                           <a:ea typeface="Helvetica Neue"/>
                           <a:sym typeface="Helvetica Neue"/>
                         </a:rPr>
-                        <a:t>302</a:t>
+                        <a:t>303</a:t>
                       </a:r>
                     </a:p>
                   </a:txBody>
@@ -18974,7 +18974,7 @@
                           <a:ea typeface="Helvetica Neue"/>
                           <a:sym typeface="Helvetica Neue"/>
                         </a:rPr>
-                        <a:t>157</a:t>
+                        <a:t>159</a:t>
                       </a:r>
                     </a:p>
                   </a:txBody>
@@ -19322,7 +19322,7 @@
                           <a:ea typeface="Helvetica Neue"/>
                           <a:sym typeface="Helvetica Neue"/>
                         </a:rPr>
-                        <a:t>58</a:t>
+                        <a:t>61</a:t>
                       </a:r>
                     </a:p>
                   </a:txBody>
@@ -19346,6 +19346,122 @@
                     <a:solidFill>
                       <a:srgbClr val="F4F8FB">
                         <a:alpha val="100000"/>
+                      </a:srgbClr>
+                    </a:solidFill>
+                  </a:tcPr>
+                </a:tc>
+              </a:tr>
+              <a:tr h="401320">
+                <a:tc>
+                  <a:txBody>
+                    <a:bodyPr/>
+                    <a:lstStyle/>
+                    <a:p>
+                      <a:pPr algn="l" marL="63500" marR="63500">
+                        <a:lnSpc>
+                          <a:spcPct val="100000"/>
+                        </a:lnSpc>
+                        <a:spcBef>
+                          <a:spcPts val="500"/>
+                        </a:spcBef>
+                        <a:spcAft>
+                          <a:spcPts val="500"/>
+                        </a:spcAft>
+                        <a:buNone/>
+                      </a:pPr>
+                      <a:r>
+                        <a:rPr cap="none" sz="1200" i="0" b="0" u="none" strike="noStrike">
+                          <a:solidFill>
+                            <a:srgbClr val="5B6770">
+                              <a:alpha val="100000"/>
+                            </a:srgbClr>
+                          </a:solidFill>
+                          <a:latin typeface="Helvetica Neue"/>
+                          <a:cs typeface="Helvetica Neue"/>
+                          <a:ea typeface="Helvetica Neue"/>
+                          <a:sym typeface="Helvetica Neue"/>
+                        </a:rPr>
+                        <a:t>fentanyl, methamphetamine</a:t>
+                      </a:r>
+                    </a:p>
+                  </a:txBody>
+                  <a:tcPr anchor="ctr" marB="63500" marT="63500" marR="0" marL="0">
+                    <a:lnL algn="ctr" cmpd="sng" cap="flat" w="0">
+                      <a:noFill/>
+                      <a:prstDash val="solid"/>
+                    </a:lnL>
+                    <a:lnR algn="ctr" cmpd="sng" cap="flat" w="0">
+                      <a:noFill/>
+                      <a:prstDash val="solid"/>
+                    </a:lnR>
+                    <a:lnT algn="ctr" cmpd="sng" cap="flat" w="0">
+                      <a:noFill/>
+                      <a:prstDash val="solid"/>
+                    </a:lnT>
+                    <a:lnB algn="ctr" cmpd="sng" cap="flat" w="0">
+                      <a:noFill/>
+                      <a:prstDash val="solid"/>
+                    </a:lnB>
+                    <a:solidFill>
+                      <a:srgbClr val="FFFFFF">
+                        <a:alpha val="0"/>
+                      </a:srgbClr>
+                    </a:solidFill>
+                  </a:tcPr>
+                </a:tc>
+                <a:tc>
+                  <a:txBody>
+                    <a:bodyPr/>
+                    <a:lstStyle/>
+                    <a:p>
+                      <a:pPr algn="l" marL="63500" marR="63500">
+                        <a:lnSpc>
+                          <a:spcPct val="100000"/>
+                        </a:lnSpc>
+                        <a:spcBef>
+                          <a:spcPts val="500"/>
+                        </a:spcBef>
+                        <a:spcAft>
+                          <a:spcPts val="500"/>
+                        </a:spcAft>
+                        <a:buNone/>
+                      </a:pPr>
+                      <a:r>
+                        <a:rPr cap="none" sz="1200" i="0" b="0" u="none" strike="noStrike">
+                          <a:solidFill>
+                            <a:srgbClr val="5B6770">
+                              <a:alpha val="100000"/>
+                            </a:srgbClr>
+                          </a:solidFill>
+                          <a:latin typeface="Helvetica Neue"/>
+                          <a:cs typeface="Helvetica Neue"/>
+                          <a:ea typeface="Helvetica Neue"/>
+                          <a:sym typeface="Helvetica Neue"/>
+                        </a:rPr>
+                        <a:t>57</a:t>
+                      </a:r>
+                    </a:p>
+                  </a:txBody>
+                  <a:tcPr anchor="ctr" marB="63500" marT="63500" marR="0" marL="0">
+                    <a:lnL algn="ctr" cmpd="sng" cap="flat" w="0">
+                      <a:noFill/>
+                      <a:prstDash val="solid"/>
+                    </a:lnL>
+                    <a:lnR algn="ctr" cmpd="sng" cap="flat" w="0">
+                      <a:noFill/>
+                      <a:prstDash val="solid"/>
+                    </a:lnR>
+                    <a:lnT algn="ctr" cmpd="sng" cap="flat" w="0">
+                      <a:noFill/>
+                      <a:prstDash val="solid"/>
+                    </a:lnT>
+                    <a:lnB algn="ctr" cmpd="sng" cap="flat" w="0">
+                      <a:noFill/>
+                      <a:prstDash val="solid"/>
+                    </a:lnB>
+                    <a:solidFill>
+                      <a:srgbClr val="FFFFFF">
+                        <a:alpha val="0"/>
                       </a:srgbClr>
                     </a:solidFill>
                   </a:tcPr>
@@ -19403,8 +19519,8 @@
                       <a:prstDash val="solid"/>
                     </a:lnB>
                     <a:solidFill>
-                      <a:srgbClr val="FFFFFF">
-                        <a:alpha val="0"/>
+                      <a:srgbClr val="F4F8FB">
+                        <a:alpha val="100000"/>
                       </a:srgbClr>
                     </a:solidFill>
                   </a:tcPr>
@@ -19460,122 +19576,6 @@
                       <a:prstDash val="solid"/>
                     </a:lnB>
                     <a:solidFill>
-                      <a:srgbClr val="FFFFFF">
-                        <a:alpha val="0"/>
-                      </a:srgbClr>
-                    </a:solidFill>
-                  </a:tcPr>
-                </a:tc>
-              </a:tr>
-              <a:tr h="401320">
-                <a:tc>
-                  <a:txBody>
-                    <a:bodyPr/>
-                    <a:lstStyle/>
-                    <a:p>
-                      <a:pPr algn="l" marL="63500" marR="63500">
-                        <a:lnSpc>
-                          <a:spcPct val="100000"/>
-                        </a:lnSpc>
-                        <a:spcBef>
-                          <a:spcPts val="500"/>
-                        </a:spcBef>
-                        <a:spcAft>
-                          <a:spcPts val="500"/>
-                        </a:spcAft>
-                        <a:buNone/>
-                      </a:pPr>
-                      <a:r>
-                        <a:rPr cap="none" sz="1200" i="0" b="0" u="none" strike="noStrike">
-                          <a:solidFill>
-                            <a:srgbClr val="5B6770">
-                              <a:alpha val="100000"/>
-                            </a:srgbClr>
-                          </a:solidFill>
-                          <a:latin typeface="Helvetica Neue"/>
-                          <a:cs typeface="Helvetica Neue"/>
-                          <a:ea typeface="Helvetica Neue"/>
-                          <a:sym typeface="Helvetica Neue"/>
-                        </a:rPr>
-                        <a:t>fentanyl, methamphetamine</a:t>
-                      </a:r>
-                    </a:p>
-                  </a:txBody>
-                  <a:tcPr anchor="ctr" marB="63500" marT="63500" marR="0" marL="0">
-                    <a:lnL algn="ctr" cmpd="sng" cap="flat" w="0">
-                      <a:noFill/>
-                      <a:prstDash val="solid"/>
-                    </a:lnL>
-                    <a:lnR algn="ctr" cmpd="sng" cap="flat" w="0">
-                      <a:noFill/>
-                      <a:prstDash val="solid"/>
-                    </a:lnR>
-                    <a:lnT algn="ctr" cmpd="sng" cap="flat" w="0">
-                      <a:noFill/>
-                      <a:prstDash val="solid"/>
-                    </a:lnT>
-                    <a:lnB algn="ctr" cmpd="sng" cap="flat" w="0">
-                      <a:noFill/>
-                      <a:prstDash val="solid"/>
-                    </a:lnB>
-                    <a:solidFill>
-                      <a:srgbClr val="F4F8FB">
-                        <a:alpha val="100000"/>
-                      </a:srgbClr>
-                    </a:solidFill>
-                  </a:tcPr>
-                </a:tc>
-                <a:tc>
-                  <a:txBody>
-                    <a:bodyPr/>
-                    <a:lstStyle/>
-                    <a:p>
-                      <a:pPr algn="l" marL="63500" marR="63500">
-                        <a:lnSpc>
-                          <a:spcPct val="100000"/>
-                        </a:lnSpc>
-                        <a:spcBef>
-                          <a:spcPts val="500"/>
-                        </a:spcBef>
-                        <a:spcAft>
-                          <a:spcPts val="500"/>
-                        </a:spcAft>
-                        <a:buNone/>
-                      </a:pPr>
-                      <a:r>
-                        <a:rPr cap="none" sz="1200" i="0" b="0" u="none" strike="noStrike">
-                          <a:solidFill>
-                            <a:srgbClr val="5B6770">
-                              <a:alpha val="100000"/>
-                            </a:srgbClr>
-                          </a:solidFill>
-                          <a:latin typeface="Helvetica Neue"/>
-                          <a:cs typeface="Helvetica Neue"/>
-                          <a:ea typeface="Helvetica Neue"/>
-                          <a:sym typeface="Helvetica Neue"/>
-                        </a:rPr>
-                        <a:t>55</a:t>
-                      </a:r>
-                    </a:p>
-                  </a:txBody>
-                  <a:tcPr anchor="ctr" marB="63500" marT="63500" marR="0" marL="0">
-                    <a:lnL algn="ctr" cmpd="sng" cap="flat" w="0">
-                      <a:noFill/>
-                      <a:prstDash val="solid"/>
-                    </a:lnL>
-                    <a:lnR algn="ctr" cmpd="sng" cap="flat" w="0">
-                      <a:noFill/>
-                      <a:prstDash val="solid"/>
-                    </a:lnR>
-                    <a:lnT algn="ctr" cmpd="sng" cap="flat" w="0">
-                      <a:noFill/>
-                      <a:prstDash val="solid"/>
-                    </a:lnT>
-                    <a:lnB algn="ctr" cmpd="sng" cap="flat" w="0">
-                      <a:noFill/>
-                      <a:prstDash val="solid"/>
-                    </a:lnB>
-                    <a:solidFill>
                       <a:srgbClr val="F4F8FB">
                         <a:alpha val="100000"/>
                       </a:srgbClr>
@@ -19729,7 +19729,7 @@
                           <a:ea typeface="Helvetica Neue"/>
                           <a:sym typeface="Helvetica Neue"/>
                         </a:rPr>
-                        <a:t>crack</a:t>
+                        <a:t>heroin, fentanyl</a:t>
                       </a:r>
                     </a:p>
                   </a:txBody>
@@ -19790,7 +19790,7 @@
                           <a:ea typeface="Helvetica Neue"/>
                           <a:sym typeface="Helvetica Neue"/>
                         </a:rPr>
-                        <a:t>30</a:t>
+                        <a:t>31</a:t>
                       </a:r>
                     </a:p>
                   </a:txBody>
@@ -20591,7 +20591,7 @@
                           <a:ea typeface="Helvetica Neue"/>
                           <a:sym typeface="Helvetica Neue"/>
                         </a:rPr>
-                        <a:t>1,674</a:t>
+                        <a:t>1,697</a:t>
                       </a:r>
                     </a:p>
                   </a:txBody>
@@ -20821,7 +20821,7 @@
                           <a:ea typeface="Helvetica Neue"/>
                           <a:sym typeface="Helvetica Neue"/>
                         </a:rPr>
-                        <a:t>507</a:t>
+                        <a:t>510</a:t>
                       </a:r>
                     </a:p>
                   </a:txBody>
@@ -20878,7 +20878,7 @@
                           <a:ea typeface="Helvetica Neue"/>
                           <a:sym typeface="Helvetica Neue"/>
                         </a:rPr>
-                        <a:t>91%</a:t>
+                        <a:t>90%</a:t>
                       </a:r>
                     </a:p>
                   </a:txBody>
@@ -21051,7 +21051,7 @@
                           <a:ea typeface="Helvetica Neue"/>
                           <a:sym typeface="Helvetica Neue"/>
                         </a:rPr>
-                        <a:t>140</a:t>
+                        <a:t>141</a:t>
                       </a:r>
                     </a:p>
                   </a:txBody>
@@ -21515,7 +21515,7 @@
                           <a:ea typeface="Helvetica Neue"/>
                           <a:sym typeface="Helvetica Neue"/>
                         </a:rPr>
-                        <a:t>359</a:t>
+                        <a:t>362</a:t>
                       </a:r>
                     </a:p>
                   </a:txBody>
@@ -21576,7 +21576,7 @@
                           <a:ea typeface="Helvetica Neue"/>
                           <a:sym typeface="Helvetica Neue"/>
                         </a:rPr>
-                        <a:t>52%</a:t>
+                        <a:t>51%</a:t>
                       </a:r>
                     </a:p>
                   </a:txBody>
@@ -24942,6 +24942,580 @@
                           <a:ea typeface="Helvetica Neue"/>
                           <a:sym typeface="Helvetica Neue"/>
                         </a:rPr>
+                        <a:t>naphazoline</a:t>
+                      </a:r>
+                    </a:p>
+                  </a:txBody>
+                  <a:tcPr anchor="ctr" marB="63500" marT="63500" marR="0" marL="0">
+                    <a:lnL algn="ctr" cmpd="sng" cap="flat" w="0">
+                      <a:noFill/>
+                      <a:prstDash val="solid"/>
+                    </a:lnL>
+                    <a:lnR algn="ctr" cmpd="sng" cap="flat" w="0">
+                      <a:noFill/>
+                      <a:prstDash val="solid"/>
+                    </a:lnR>
+                    <a:lnT algn="ctr" cmpd="sng" cap="flat" w="0">
+                      <a:noFill/>
+                      <a:prstDash val="solid"/>
+                    </a:lnT>
+                    <a:lnB algn="ctr" cmpd="sng" cap="flat" w="0">
+                      <a:noFill/>
+                      <a:prstDash val="solid"/>
+                    </a:lnB>
+                    <a:solidFill>
+                      <a:srgbClr val="FFFFFF">
+                        <a:alpha val="0"/>
+                      </a:srgbClr>
+                    </a:solidFill>
+                  </a:tcPr>
+                </a:tc>
+                <a:tc>
+                  <a:txBody>
+                    <a:bodyPr/>
+                    <a:lstStyle/>
+                    <a:p>
+                      <a:pPr algn="l" marL="63500" marR="63500">
+                        <a:lnSpc>
+                          <a:spcPct val="100000"/>
+                        </a:lnSpc>
+                        <a:spcBef>
+                          <a:spcPts val="500"/>
+                        </a:spcBef>
+                        <a:spcAft>
+                          <a:spcPts val="500"/>
+                        </a:spcAft>
+                        <a:buNone/>
+                      </a:pPr>
+                      <a:r>
+                        <a:rPr cap="none" sz="1200" i="0" b="0" u="none" strike="noStrike">
+                          <a:solidFill>
+                            <a:srgbClr val="5B6770">
+                              <a:alpha val="100000"/>
+                            </a:srgbClr>
+                          </a:solidFill>
+                          <a:latin typeface="Helvetica Neue"/>
+                          <a:cs typeface="Helvetica Neue"/>
+                          <a:ea typeface="Helvetica Neue"/>
+                          <a:sym typeface="Helvetica Neue"/>
+                        </a:rPr>
+                        <a:t>18 Sep 2026</a:t>
+                      </a:r>
+                    </a:p>
+                  </a:txBody>
+                  <a:tcPr anchor="ctr" marB="63500" marT="63500" marR="0" marL="0">
+                    <a:lnL algn="ctr" cmpd="sng" cap="flat" w="0">
+                      <a:noFill/>
+                      <a:prstDash val="solid"/>
+                    </a:lnL>
+                    <a:lnR algn="ctr" cmpd="sng" cap="flat" w="0">
+                      <a:noFill/>
+                      <a:prstDash val="solid"/>
+                    </a:lnR>
+                    <a:lnT algn="ctr" cmpd="sng" cap="flat" w="0">
+                      <a:noFill/>
+                      <a:prstDash val="solid"/>
+                    </a:lnT>
+                    <a:lnB algn="ctr" cmpd="sng" cap="flat" w="0">
+                      <a:noFill/>
+                      <a:prstDash val="solid"/>
+                    </a:lnB>
+                    <a:solidFill>
+                      <a:srgbClr val="FFFFFF">
+                        <a:alpha val="0"/>
+                      </a:srgbClr>
+                    </a:solidFill>
+                  </a:tcPr>
+                </a:tc>
+                <a:tc>
+                  <a:txBody>
+                    <a:bodyPr/>
+                    <a:lstStyle/>
+                    <a:p>
+                      <a:pPr algn="l" marL="63500" marR="63500">
+                        <a:lnSpc>
+                          <a:spcPct val="100000"/>
+                        </a:lnSpc>
+                        <a:spcBef>
+                          <a:spcPts val="500"/>
+                        </a:spcBef>
+                        <a:spcAft>
+                          <a:spcPts val="500"/>
+                        </a:spcAft>
+                        <a:buNone/>
+                      </a:pPr>
+                      <a:r>
+                        <a:rPr cap="none" sz="1200" i="0" b="0" u="none" strike="noStrike">
+                          <a:solidFill>
+                            <a:srgbClr val="5B6770">
+                              <a:alpha val="100000"/>
+                            </a:srgbClr>
+                          </a:solidFill>
+                          <a:latin typeface="Helvetica Neue"/>
+                          <a:cs typeface="Helvetica Neue"/>
+                          <a:ea typeface="Helvetica Neue"/>
+                          <a:sym typeface="Helvetica Neue"/>
+                        </a:rPr>
+                        <a:t>primary</a:t>
+                      </a:r>
+                    </a:p>
+                  </a:txBody>
+                  <a:tcPr anchor="ctr" marB="63500" marT="63500" marR="0" marL="0">
+                    <a:lnL algn="ctr" cmpd="sng" cap="flat" w="0">
+                      <a:noFill/>
+                      <a:prstDash val="solid"/>
+                    </a:lnL>
+                    <a:lnR algn="ctr" cmpd="sng" cap="flat" w="0">
+                      <a:noFill/>
+                      <a:prstDash val="solid"/>
+                    </a:lnR>
+                    <a:lnT algn="ctr" cmpd="sng" cap="flat" w="0">
+                      <a:noFill/>
+                      <a:prstDash val="solid"/>
+                    </a:lnT>
+                    <a:lnB algn="ctr" cmpd="sng" cap="flat" w="0">
+                      <a:noFill/>
+                      <a:prstDash val="solid"/>
+                    </a:lnB>
+                    <a:solidFill>
+                      <a:srgbClr val="FFFFFF">
+                        <a:alpha val="0"/>
+                      </a:srgbClr>
+                    </a:solidFill>
+                  </a:tcPr>
+                </a:tc>
+                <a:tc>
+                  <a:txBody>
+                    <a:bodyPr/>
+                    <a:lstStyle/>
+                    <a:p>
+                      <a:pPr algn="r" marL="63500" marR="63500">
+                        <a:lnSpc>
+                          <a:spcPct val="100000"/>
+                        </a:lnSpc>
+                        <a:spcBef>
+                          <a:spcPts val="500"/>
+                        </a:spcBef>
+                        <a:spcAft>
+                          <a:spcPts val="500"/>
+                        </a:spcAft>
+                        <a:buNone/>
+                      </a:pPr>
+                      <a:r>
+                        <a:rPr cap="none" sz="1200" i="0" b="0" u="none" strike="noStrike">
+                          <a:solidFill>
+                            <a:srgbClr val="5B6770">
+                              <a:alpha val="100000"/>
+                            </a:srgbClr>
+                          </a:solidFill>
+                          <a:latin typeface="Helvetica Neue"/>
+                          <a:cs typeface="Helvetica Neue"/>
+                          <a:ea typeface="Helvetica Neue"/>
+                          <a:sym typeface="Helvetica Neue"/>
+                        </a:rPr>
+                        <a:t>1</a:t>
+                      </a:r>
+                    </a:p>
+                  </a:txBody>
+                  <a:tcPr anchor="ctr" marB="63500" marT="63500" marR="0" marL="0">
+                    <a:lnL algn="ctr" cmpd="sng" cap="flat" w="0">
+                      <a:noFill/>
+                      <a:prstDash val="solid"/>
+                    </a:lnL>
+                    <a:lnR algn="ctr" cmpd="sng" cap="flat" w="0">
+                      <a:noFill/>
+                      <a:prstDash val="solid"/>
+                    </a:lnR>
+                    <a:lnT algn="ctr" cmpd="sng" cap="flat" w="0">
+                      <a:noFill/>
+                      <a:prstDash val="solid"/>
+                    </a:lnT>
+                    <a:lnB algn="ctr" cmpd="sng" cap="flat" w="0">
+                      <a:noFill/>
+                      <a:prstDash val="solid"/>
+                    </a:lnB>
+                    <a:solidFill>
+                      <a:srgbClr val="FFFFFF">
+                        <a:alpha val="0"/>
+                      </a:srgbClr>
+                    </a:solidFill>
+                  </a:tcPr>
+                </a:tc>
+                <a:tc>
+                  <a:txBody>
+                    <a:bodyPr/>
+                    <a:lstStyle/>
+                    <a:p>
+                      <a:pPr algn="l" marL="63500" marR="63500">
+                        <a:lnSpc>
+                          <a:spcPct val="100000"/>
+                        </a:lnSpc>
+                        <a:spcBef>
+                          <a:spcPts val="500"/>
+                        </a:spcBef>
+                        <a:spcAft>
+                          <a:spcPts val="500"/>
+                        </a:spcAft>
+                        <a:buNone/>
+                      </a:pPr>
+                      <a:r>
+                        <a:rPr cap="none" sz="1200" i="0" b="0" u="none" strike="noStrike">
+                          <a:solidFill>
+                            <a:srgbClr val="5B6770">
+                              <a:alpha val="100000"/>
+                            </a:srgbClr>
+                          </a:solidFill>
+                          <a:latin typeface="Helvetica Neue"/>
+                          <a:cs typeface="Helvetica Neue"/>
+                          <a:ea typeface="Helvetica Neue"/>
+                          <a:sym typeface="Helvetica Neue"/>
+                        </a:rPr>
+                        <a:t>821737</a:t>
+                      </a:r>
+                    </a:p>
+                  </a:txBody>
+                  <a:tcPr anchor="ctr" marB="63500" marT="63500" marR="0" marL="0">
+                    <a:lnL algn="ctr" cmpd="sng" cap="flat" w="0">
+                      <a:noFill/>
+                      <a:prstDash val="solid"/>
+                    </a:lnL>
+                    <a:lnR algn="ctr" cmpd="sng" cap="flat" w="0">
+                      <a:noFill/>
+                      <a:prstDash val="solid"/>
+                    </a:lnR>
+                    <a:lnT algn="ctr" cmpd="sng" cap="flat" w="0">
+                      <a:noFill/>
+                      <a:prstDash val="solid"/>
+                    </a:lnT>
+                    <a:lnB algn="ctr" cmpd="sng" cap="flat" w="0">
+                      <a:noFill/>
+                      <a:prstDash val="solid"/>
+                    </a:lnB>
+                    <a:solidFill>
+                      <a:srgbClr val="FFFFFF">
+                        <a:alpha val="0"/>
+                      </a:srgbClr>
+                    </a:solidFill>
+                  </a:tcPr>
+                </a:tc>
+              </a:tr>
+              <a:tr h="401320">
+                <a:tc>
+                  <a:txBody>
+                    <a:bodyPr/>
+                    <a:lstStyle/>
+                    <a:p>
+                      <a:pPr algn="l" marL="63500" marR="63500">
+                        <a:lnSpc>
+                          <a:spcPct val="100000"/>
+                        </a:lnSpc>
+                        <a:spcBef>
+                          <a:spcPts val="500"/>
+                        </a:spcBef>
+                        <a:spcAft>
+                          <a:spcPts val="500"/>
+                        </a:spcAft>
+                        <a:buNone/>
+                      </a:pPr>
+                      <a:r>
+                        <a:rPr cap="none" sz="1200" i="0" b="0" u="none" strike="noStrike">
+                          <a:solidFill>
+                            <a:srgbClr val="5B6770">
+                              <a:alpha val="100000"/>
+                            </a:srgbClr>
+                          </a:solidFill>
+                          <a:latin typeface="Helvetica Neue"/>
+                          <a:cs typeface="Helvetica Neue"/>
+                          <a:ea typeface="Helvetica Neue"/>
+                          <a:sym typeface="Helvetica Neue"/>
+                        </a:rPr>
+                        <a:t>pending nitazene</a:t>
+                      </a:r>
+                    </a:p>
+                  </a:txBody>
+                  <a:tcPr anchor="ctr" marB="63500" marT="63500" marR="0" marL="0">
+                    <a:lnL algn="ctr" cmpd="sng" cap="flat" w="0">
+                      <a:noFill/>
+                      <a:prstDash val="solid"/>
+                    </a:lnL>
+                    <a:lnR algn="ctr" cmpd="sng" cap="flat" w="0">
+                      <a:noFill/>
+                      <a:prstDash val="solid"/>
+                    </a:lnR>
+                    <a:lnT algn="ctr" cmpd="sng" cap="flat" w="0">
+                      <a:noFill/>
+                      <a:prstDash val="solid"/>
+                    </a:lnT>
+                    <a:lnB algn="ctr" cmpd="sng" cap="flat" w="0">
+                      <a:noFill/>
+                      <a:prstDash val="solid"/>
+                    </a:lnB>
+                    <a:solidFill>
+                      <a:srgbClr val="F4F8FB">
+                        <a:alpha val="100000"/>
+                      </a:srgbClr>
+                    </a:solidFill>
+                  </a:tcPr>
+                </a:tc>
+                <a:tc>
+                  <a:txBody>
+                    <a:bodyPr/>
+                    <a:lstStyle/>
+                    <a:p>
+                      <a:pPr algn="l" marL="63500" marR="63500">
+                        <a:lnSpc>
+                          <a:spcPct val="100000"/>
+                        </a:lnSpc>
+                        <a:spcBef>
+                          <a:spcPts val="500"/>
+                        </a:spcBef>
+                        <a:spcAft>
+                          <a:spcPts val="500"/>
+                        </a:spcAft>
+                        <a:buNone/>
+                      </a:pPr>
+                      <a:r>
+                        <a:rPr cap="none" sz="1200" i="0" b="0" u="none" strike="noStrike">
+                          <a:solidFill>
+                            <a:srgbClr val="5B6770">
+                              <a:alpha val="100000"/>
+                            </a:srgbClr>
+                          </a:solidFill>
+                          <a:latin typeface="Helvetica Neue"/>
+                          <a:cs typeface="Helvetica Neue"/>
+                          <a:ea typeface="Helvetica Neue"/>
+                          <a:sym typeface="Helvetica Neue"/>
+                        </a:rPr>
+                        <a:t>18 Sep 2026</a:t>
+                      </a:r>
+                    </a:p>
+                  </a:txBody>
+                  <a:tcPr anchor="ctr" marB="63500" marT="63500" marR="0" marL="0">
+                    <a:lnL algn="ctr" cmpd="sng" cap="flat" w="0">
+                      <a:noFill/>
+                      <a:prstDash val="solid"/>
+                    </a:lnL>
+                    <a:lnR algn="ctr" cmpd="sng" cap="flat" w="0">
+                      <a:noFill/>
+                      <a:prstDash val="solid"/>
+                    </a:lnR>
+                    <a:lnT algn="ctr" cmpd="sng" cap="flat" w="0">
+                      <a:noFill/>
+                      <a:prstDash val="solid"/>
+                    </a:lnT>
+                    <a:lnB algn="ctr" cmpd="sng" cap="flat" w="0">
+                      <a:noFill/>
+                      <a:prstDash val="solid"/>
+                    </a:lnB>
+                    <a:solidFill>
+                      <a:srgbClr val="F4F8FB">
+                        <a:alpha val="100000"/>
+                      </a:srgbClr>
+                    </a:solidFill>
+                  </a:tcPr>
+                </a:tc>
+                <a:tc>
+                  <a:txBody>
+                    <a:bodyPr/>
+                    <a:lstStyle/>
+                    <a:p>
+                      <a:pPr algn="l" marL="63500" marR="63500">
+                        <a:lnSpc>
+                          <a:spcPct val="100000"/>
+                        </a:lnSpc>
+                        <a:spcBef>
+                          <a:spcPts val="500"/>
+                        </a:spcBef>
+                        <a:spcAft>
+                          <a:spcPts val="500"/>
+                        </a:spcAft>
+                        <a:buNone/>
+                      </a:pPr>
+                      <a:r>
+                        <a:rPr cap="none" sz="1200" i="0" b="0" u="none" strike="noStrike">
+                          <a:solidFill>
+                            <a:srgbClr val="5B6770">
+                              <a:alpha val="100000"/>
+                            </a:srgbClr>
+                          </a:solidFill>
+                          <a:latin typeface="Helvetica Neue"/>
+                          <a:cs typeface="Helvetica Neue"/>
+                          <a:ea typeface="Helvetica Neue"/>
+                          <a:sym typeface="Helvetica Neue"/>
+                        </a:rPr>
+                        <a:t>primary</a:t>
+                      </a:r>
+                    </a:p>
+                  </a:txBody>
+                  <a:tcPr anchor="ctr" marB="63500" marT="63500" marR="0" marL="0">
+                    <a:lnL algn="ctr" cmpd="sng" cap="flat" w="0">
+                      <a:noFill/>
+                      <a:prstDash val="solid"/>
+                    </a:lnL>
+                    <a:lnR algn="ctr" cmpd="sng" cap="flat" w="0">
+                      <a:noFill/>
+                      <a:prstDash val="solid"/>
+                    </a:lnR>
+                    <a:lnT algn="ctr" cmpd="sng" cap="flat" w="0">
+                      <a:noFill/>
+                      <a:prstDash val="solid"/>
+                    </a:lnT>
+                    <a:lnB algn="ctr" cmpd="sng" cap="flat" w="0">
+                      <a:noFill/>
+                      <a:prstDash val="solid"/>
+                    </a:lnB>
+                    <a:solidFill>
+                      <a:srgbClr val="F4F8FB">
+                        <a:alpha val="100000"/>
+                      </a:srgbClr>
+                    </a:solidFill>
+                  </a:tcPr>
+                </a:tc>
+                <a:tc>
+                  <a:txBody>
+                    <a:bodyPr/>
+                    <a:lstStyle/>
+                    <a:p>
+                      <a:pPr algn="r" marL="63500" marR="63500">
+                        <a:lnSpc>
+                          <a:spcPct val="100000"/>
+                        </a:lnSpc>
+                        <a:spcBef>
+                          <a:spcPts val="500"/>
+                        </a:spcBef>
+                        <a:spcAft>
+                          <a:spcPts val="500"/>
+                        </a:spcAft>
+                        <a:buNone/>
+                      </a:pPr>
+                      <a:r>
+                        <a:rPr cap="none" sz="1200" i="0" b="0" u="none" strike="noStrike">
+                          <a:solidFill>
+                            <a:srgbClr val="5B6770">
+                              <a:alpha val="100000"/>
+                            </a:srgbClr>
+                          </a:solidFill>
+                          <a:latin typeface="Helvetica Neue"/>
+                          <a:cs typeface="Helvetica Neue"/>
+                          <a:ea typeface="Helvetica Neue"/>
+                          <a:sym typeface="Helvetica Neue"/>
+                        </a:rPr>
+                        <a:t>3</a:t>
+                      </a:r>
+                    </a:p>
+                  </a:txBody>
+                  <a:tcPr anchor="ctr" marB="63500" marT="63500" marR="0" marL="0">
+                    <a:lnL algn="ctr" cmpd="sng" cap="flat" w="0">
+                      <a:noFill/>
+                      <a:prstDash val="solid"/>
+                    </a:lnL>
+                    <a:lnR algn="ctr" cmpd="sng" cap="flat" w="0">
+                      <a:noFill/>
+                      <a:prstDash val="solid"/>
+                    </a:lnR>
+                    <a:lnT algn="ctr" cmpd="sng" cap="flat" w="0">
+                      <a:noFill/>
+                      <a:prstDash val="solid"/>
+                    </a:lnT>
+                    <a:lnB algn="ctr" cmpd="sng" cap="flat" w="0">
+                      <a:noFill/>
+                      <a:prstDash val="solid"/>
+                    </a:lnB>
+                    <a:solidFill>
+                      <a:srgbClr val="F4F8FB">
+                        <a:alpha val="100000"/>
+                      </a:srgbClr>
+                    </a:solidFill>
+                  </a:tcPr>
+                </a:tc>
+                <a:tc>
+                  <a:txBody>
+                    <a:bodyPr/>
+                    <a:lstStyle/>
+                    <a:p>
+                      <a:pPr algn="l" marL="63500" marR="63500">
+                        <a:lnSpc>
+                          <a:spcPct val="100000"/>
+                        </a:lnSpc>
+                        <a:spcBef>
+                          <a:spcPts val="500"/>
+                        </a:spcBef>
+                        <a:spcAft>
+                          <a:spcPts val="500"/>
+                        </a:spcAft>
+                        <a:buNone/>
+                      </a:pPr>
+                      <a:r>
+                        <a:rPr cap="none" sz="1200" i="0" b="0" u="none" strike="noStrike">
+                          <a:solidFill>
+                            <a:srgbClr val="5B6770">
+                              <a:alpha val="100000"/>
+                            </a:srgbClr>
+                          </a:solidFill>
+                          <a:latin typeface="Helvetica Neue"/>
+                          <a:cs typeface="Helvetica Neue"/>
+                          <a:ea typeface="Helvetica Neue"/>
+                          <a:sym typeface="Helvetica Neue"/>
+                        </a:rPr>
+                        <a:t>901255</a:t>
+                      </a:r>
+                    </a:p>
+                  </a:txBody>
+                  <a:tcPr anchor="ctr" marB="63500" marT="63500" marR="0" marL="0">
+                    <a:lnL algn="ctr" cmpd="sng" cap="flat" w="0">
+                      <a:noFill/>
+                      <a:prstDash val="solid"/>
+                    </a:lnL>
+                    <a:lnR algn="ctr" cmpd="sng" cap="flat" w="0">
+                      <a:noFill/>
+                      <a:prstDash val="solid"/>
+                    </a:lnR>
+                    <a:lnT algn="ctr" cmpd="sng" cap="flat" w="0">
+                      <a:noFill/>
+                      <a:prstDash val="solid"/>
+                    </a:lnT>
+                    <a:lnB algn="ctr" cmpd="sng" cap="flat" w="0">
+                      <a:noFill/>
+                      <a:prstDash val="solid"/>
+                    </a:lnB>
+                    <a:solidFill>
+                      <a:srgbClr val="F4F8FB">
+                        <a:alpha val="100000"/>
+                      </a:srgbClr>
+                    </a:solidFill>
+                  </a:tcPr>
+                </a:tc>
+              </a:tr>
+              <a:tr h="401320">
+                <a:tc>
+                  <a:txBody>
+                    <a:bodyPr/>
+                    <a:lstStyle/>
+                    <a:p>
+                      <a:pPr algn="l" marL="63500" marR="63500">
+                        <a:lnSpc>
+                          <a:spcPct val="100000"/>
+                        </a:lnSpc>
+                        <a:spcBef>
+                          <a:spcPts val="500"/>
+                        </a:spcBef>
+                        <a:spcAft>
+                          <a:spcPts val="500"/>
+                        </a:spcAft>
+                        <a:buNone/>
+                      </a:pPr>
+                      <a:r>
+                        <a:rPr cap="none" sz="1200" i="0" b="0" u="none" strike="noStrike">
+                          <a:solidFill>
+                            <a:srgbClr val="5B6770">
+                              <a:alpha val="100000"/>
+                            </a:srgbClr>
+                          </a:solidFill>
+                          <a:latin typeface="Helvetica Neue"/>
+                          <a:cs typeface="Helvetica Neue"/>
+                          <a:ea typeface="Helvetica Neue"/>
+                          <a:sym typeface="Helvetica Neue"/>
+                        </a:rPr>
                         <a:t>SR 17018</a:t>
                       </a:r>
                     </a:p>
@@ -27495,7 +28069,7 @@
                   </a:tcPr>
                 </a:tc>
               </a:tr>
-              <a:tr h="401320">
+              <a:tr h="410845">
                 <a:tc>
                   <a:txBody>
                     <a:bodyPr/>
@@ -27542,8 +28116,12 @@
                       <a:noFill/>
                       <a:prstDash val="solid"/>
                     </a:lnT>
-                    <a:lnB algn="ctr" cmpd="sng" cap="flat" w="0">
-                      <a:noFill/>
+                    <a:lnB algn="ctr" cmpd="sng" cap="flat" w="19050">
+                      <a:solidFill>
+                        <a:srgbClr val="666666">
+                          <a:alpha val="100000"/>
+                        </a:srgbClr>
+                      </a:solidFill>
                       <a:prstDash val="solid"/>
                     </a:lnB>
                     <a:solidFill>
@@ -27599,8 +28177,12 @@
                       <a:noFill/>
                       <a:prstDash val="solid"/>
                     </a:lnT>
-                    <a:lnB algn="ctr" cmpd="sng" cap="flat" w="0">
-                      <a:noFill/>
+                    <a:lnB algn="ctr" cmpd="sng" cap="flat" w="19050">
+                      <a:solidFill>
+                        <a:srgbClr val="666666">
+                          <a:alpha val="100000"/>
+                        </a:srgbClr>
+                      </a:solidFill>
                       <a:prstDash val="solid"/>
                     </a:lnB>
                     <a:solidFill>
@@ -27656,8 +28238,12 @@
                       <a:noFill/>
                       <a:prstDash val="solid"/>
                     </a:lnT>
-                    <a:lnB algn="ctr" cmpd="sng" cap="flat" w="0">
-                      <a:noFill/>
+                    <a:lnB algn="ctr" cmpd="sng" cap="flat" w="19050">
+                      <a:solidFill>
+                        <a:srgbClr val="666666">
+                          <a:alpha val="100000"/>
+                        </a:srgbClr>
+                      </a:solidFill>
                       <a:prstDash val="solid"/>
                     </a:lnB>
                     <a:solidFill>
@@ -27713,8 +28299,12 @@
                       <a:noFill/>
                       <a:prstDash val="solid"/>
                     </a:lnT>
-                    <a:lnB algn="ctr" cmpd="sng" cap="flat" w="0">
-                      <a:noFill/>
+                    <a:lnB algn="ctr" cmpd="sng" cap="flat" w="19050">
+                      <a:solidFill>
+                        <a:srgbClr val="666666">
+                          <a:alpha val="100000"/>
+                        </a:srgbClr>
+                      </a:solidFill>
                       <a:prstDash val="solid"/>
                     </a:lnB>
                     <a:solidFill>
@@ -27754,596 +28344,6 @@
                           <a:sym typeface="Helvetica Neue"/>
                         </a:rPr>
                         <a:t>603217</a:t>
-                      </a:r>
-                    </a:p>
-                  </a:txBody>
-                  <a:tcPr anchor="ctr" marB="63500" marT="63500" marR="0" marL="0">
-                    <a:lnL algn="ctr" cmpd="sng" cap="flat" w="0">
-                      <a:noFill/>
-                      <a:prstDash val="solid"/>
-                    </a:lnL>
-                    <a:lnR algn="ctr" cmpd="sng" cap="flat" w="0">
-                      <a:noFill/>
-                      <a:prstDash val="solid"/>
-                    </a:lnR>
-                    <a:lnT algn="ctr" cmpd="sng" cap="flat" w="0">
-                      <a:noFill/>
-                      <a:prstDash val="solid"/>
-                    </a:lnT>
-                    <a:lnB algn="ctr" cmpd="sng" cap="flat" w="0">
-                      <a:noFill/>
-                      <a:prstDash val="solid"/>
-                    </a:lnB>
-                    <a:solidFill>
-                      <a:srgbClr val="F4F8FB">
-                        <a:alpha val="100000"/>
-                      </a:srgbClr>
-                    </a:solidFill>
-                  </a:tcPr>
-                </a:tc>
-              </a:tr>
-              <a:tr h="401320">
-                <a:tc>
-                  <a:txBody>
-                    <a:bodyPr/>
-                    <a:lstStyle/>
-                    <a:p>
-                      <a:pPr algn="l" marL="63500" marR="63500">
-                        <a:lnSpc>
-                          <a:spcPct val="100000"/>
-                        </a:lnSpc>
-                        <a:spcBef>
-                          <a:spcPts val="500"/>
-                        </a:spcBef>
-                        <a:spcAft>
-                          <a:spcPts val="500"/>
-                        </a:spcAft>
-                        <a:buNone/>
-                      </a:pPr>
-                      <a:r>
-                        <a:rPr cap="none" sz="1200" i="0" b="0" u="none" strike="noStrike">
-                          <a:solidFill>
-                            <a:srgbClr val="5B6770">
-                              <a:alpha val="100000"/>
-                            </a:srgbClr>
-                          </a:solidFill>
-                          <a:latin typeface="Helvetica Neue"/>
-                          <a:cs typeface="Helvetica Neue"/>
-                          <a:ea typeface="Helvetica Neue"/>
-                          <a:sym typeface="Helvetica Neue"/>
-                        </a:rPr>
-                        <a:t>MDMB-4en-PINACA</a:t>
-                      </a:r>
-                    </a:p>
-                  </a:txBody>
-                  <a:tcPr anchor="ctr" marB="63500" marT="63500" marR="0" marL="0">
-                    <a:lnL algn="ctr" cmpd="sng" cap="flat" w="0">
-                      <a:noFill/>
-                      <a:prstDash val="solid"/>
-                    </a:lnL>
-                    <a:lnR algn="ctr" cmpd="sng" cap="flat" w="0">
-                      <a:noFill/>
-                      <a:prstDash val="solid"/>
-                    </a:lnR>
-                    <a:lnT algn="ctr" cmpd="sng" cap="flat" w="0">
-                      <a:noFill/>
-                      <a:prstDash val="solid"/>
-                    </a:lnT>
-                    <a:lnB algn="ctr" cmpd="sng" cap="flat" w="0">
-                      <a:noFill/>
-                      <a:prstDash val="solid"/>
-                    </a:lnB>
-                    <a:solidFill>
-                      <a:srgbClr val="FFFFFF">
-                        <a:alpha val="0"/>
-                      </a:srgbClr>
-                    </a:solidFill>
-                  </a:tcPr>
-                </a:tc>
-                <a:tc>
-                  <a:txBody>
-                    <a:bodyPr/>
-                    <a:lstStyle/>
-                    <a:p>
-                      <a:pPr algn="l" marL="63500" marR="63500">
-                        <a:lnSpc>
-                          <a:spcPct val="100000"/>
-                        </a:lnSpc>
-                        <a:spcBef>
-                          <a:spcPts val="500"/>
-                        </a:spcBef>
-                        <a:spcAft>
-                          <a:spcPts val="500"/>
-                        </a:spcAft>
-                        <a:buNone/>
-                      </a:pPr>
-                      <a:r>
-                        <a:rPr cap="none" sz="1200" i="0" b="0" u="none" strike="noStrike">
-                          <a:solidFill>
-                            <a:srgbClr val="5B6770">
-                              <a:alpha val="100000"/>
-                            </a:srgbClr>
-                          </a:solidFill>
-                          <a:latin typeface="Helvetica Neue"/>
-                          <a:cs typeface="Helvetica Neue"/>
-                          <a:ea typeface="Helvetica Neue"/>
-                          <a:sym typeface="Helvetica Neue"/>
-                        </a:rPr>
-                        <a:t>10 Jul 2026</a:t>
-                      </a:r>
-                    </a:p>
-                  </a:txBody>
-                  <a:tcPr anchor="ctr" marB="63500" marT="63500" marR="0" marL="0">
-                    <a:lnL algn="ctr" cmpd="sng" cap="flat" w="0">
-                      <a:noFill/>
-                      <a:prstDash val="solid"/>
-                    </a:lnL>
-                    <a:lnR algn="ctr" cmpd="sng" cap="flat" w="0">
-                      <a:noFill/>
-                      <a:prstDash val="solid"/>
-                    </a:lnR>
-                    <a:lnT algn="ctr" cmpd="sng" cap="flat" w="0">
-                      <a:noFill/>
-                      <a:prstDash val="solid"/>
-                    </a:lnT>
-                    <a:lnB algn="ctr" cmpd="sng" cap="flat" w="0">
-                      <a:noFill/>
-                      <a:prstDash val="solid"/>
-                    </a:lnB>
-                    <a:solidFill>
-                      <a:srgbClr val="FFFFFF">
-                        <a:alpha val="0"/>
-                      </a:srgbClr>
-                    </a:solidFill>
-                  </a:tcPr>
-                </a:tc>
-                <a:tc>
-                  <a:txBody>
-                    <a:bodyPr/>
-                    <a:lstStyle/>
-                    <a:p>
-                      <a:pPr algn="l" marL="63500" marR="63500">
-                        <a:lnSpc>
-                          <a:spcPct val="100000"/>
-                        </a:lnSpc>
-                        <a:spcBef>
-                          <a:spcPts val="500"/>
-                        </a:spcBef>
-                        <a:spcAft>
-                          <a:spcPts val="500"/>
-                        </a:spcAft>
-                        <a:buNone/>
-                      </a:pPr>
-                      <a:r>
-                        <a:rPr cap="none" sz="1200" i="0" b="0" u="none" strike="noStrike">
-                          <a:solidFill>
-                            <a:srgbClr val="5B6770">
-                              <a:alpha val="100000"/>
-                            </a:srgbClr>
-                          </a:solidFill>
-                          <a:latin typeface="Helvetica Neue"/>
-                          <a:cs typeface="Helvetica Neue"/>
-                          <a:ea typeface="Helvetica Neue"/>
-                          <a:sym typeface="Helvetica Neue"/>
-                        </a:rPr>
-                        <a:t>primary</a:t>
-                      </a:r>
-                    </a:p>
-                  </a:txBody>
-                  <a:tcPr anchor="ctr" marB="63500" marT="63500" marR="0" marL="0">
-                    <a:lnL algn="ctr" cmpd="sng" cap="flat" w="0">
-                      <a:noFill/>
-                      <a:prstDash val="solid"/>
-                    </a:lnL>
-                    <a:lnR algn="ctr" cmpd="sng" cap="flat" w="0">
-                      <a:noFill/>
-                      <a:prstDash val="solid"/>
-                    </a:lnR>
-                    <a:lnT algn="ctr" cmpd="sng" cap="flat" w="0">
-                      <a:noFill/>
-                      <a:prstDash val="solid"/>
-                    </a:lnT>
-                    <a:lnB algn="ctr" cmpd="sng" cap="flat" w="0">
-                      <a:noFill/>
-                      <a:prstDash val="solid"/>
-                    </a:lnB>
-                    <a:solidFill>
-                      <a:srgbClr val="FFFFFF">
-                        <a:alpha val="0"/>
-                      </a:srgbClr>
-                    </a:solidFill>
-                  </a:tcPr>
-                </a:tc>
-                <a:tc>
-                  <a:txBody>
-                    <a:bodyPr/>
-                    <a:lstStyle/>
-                    <a:p>
-                      <a:pPr algn="r" marL="63500" marR="63500">
-                        <a:lnSpc>
-                          <a:spcPct val="100000"/>
-                        </a:lnSpc>
-                        <a:spcBef>
-                          <a:spcPts val="500"/>
-                        </a:spcBef>
-                        <a:spcAft>
-                          <a:spcPts val="500"/>
-                        </a:spcAft>
-                        <a:buNone/>
-                      </a:pPr>
-                      <a:r>
-                        <a:rPr cap="none" sz="1200" i="0" b="0" u="none" strike="noStrike">
-                          <a:solidFill>
-                            <a:srgbClr val="5B6770">
-                              <a:alpha val="100000"/>
-                            </a:srgbClr>
-                          </a:solidFill>
-                          <a:latin typeface="Helvetica Neue"/>
-                          <a:cs typeface="Helvetica Neue"/>
-                          <a:ea typeface="Helvetica Neue"/>
-                          <a:sym typeface="Helvetica Neue"/>
-                        </a:rPr>
-                        <a:t>1</a:t>
-                      </a:r>
-                    </a:p>
-                  </a:txBody>
-                  <a:tcPr anchor="ctr" marB="63500" marT="63500" marR="0" marL="0">
-                    <a:lnL algn="ctr" cmpd="sng" cap="flat" w="0">
-                      <a:noFill/>
-                      <a:prstDash val="solid"/>
-                    </a:lnL>
-                    <a:lnR algn="ctr" cmpd="sng" cap="flat" w="0">
-                      <a:noFill/>
-                      <a:prstDash val="solid"/>
-                    </a:lnR>
-                    <a:lnT algn="ctr" cmpd="sng" cap="flat" w="0">
-                      <a:noFill/>
-                      <a:prstDash val="solid"/>
-                    </a:lnT>
-                    <a:lnB algn="ctr" cmpd="sng" cap="flat" w="0">
-                      <a:noFill/>
-                      <a:prstDash val="solid"/>
-                    </a:lnB>
-                    <a:solidFill>
-                      <a:srgbClr val="FFFFFF">
-                        <a:alpha val="0"/>
-                      </a:srgbClr>
-                    </a:solidFill>
-                  </a:tcPr>
-                </a:tc>
-                <a:tc>
-                  <a:txBody>
-                    <a:bodyPr/>
-                    <a:lstStyle/>
-                    <a:p>
-                      <a:pPr algn="l" marL="63500" marR="63500">
-                        <a:lnSpc>
-                          <a:spcPct val="100000"/>
-                        </a:lnSpc>
-                        <a:spcBef>
-                          <a:spcPts val="500"/>
-                        </a:spcBef>
-                        <a:spcAft>
-                          <a:spcPts val="500"/>
-                        </a:spcAft>
-                        <a:buNone/>
-                      </a:pPr>
-                      <a:r>
-                        <a:rPr cap="none" sz="1200" i="0" b="0" u="none" strike="noStrike">
-                          <a:solidFill>
-                            <a:srgbClr val="5B6770">
-                              <a:alpha val="100000"/>
-                            </a:srgbClr>
-                          </a:solidFill>
-                          <a:latin typeface="Helvetica Neue"/>
-                          <a:cs typeface="Helvetica Neue"/>
-                          <a:ea typeface="Helvetica Neue"/>
-                          <a:sym typeface="Helvetica Neue"/>
-                        </a:rPr>
-                        <a:t>605414</a:t>
-                      </a:r>
-                    </a:p>
-                  </a:txBody>
-                  <a:tcPr anchor="ctr" marB="63500" marT="63500" marR="0" marL="0">
-                    <a:lnL algn="ctr" cmpd="sng" cap="flat" w="0">
-                      <a:noFill/>
-                      <a:prstDash val="solid"/>
-                    </a:lnL>
-                    <a:lnR algn="ctr" cmpd="sng" cap="flat" w="0">
-                      <a:noFill/>
-                      <a:prstDash val="solid"/>
-                    </a:lnR>
-                    <a:lnT algn="ctr" cmpd="sng" cap="flat" w="0">
-                      <a:noFill/>
-                      <a:prstDash val="solid"/>
-                    </a:lnT>
-                    <a:lnB algn="ctr" cmpd="sng" cap="flat" w="0">
-                      <a:noFill/>
-                      <a:prstDash val="solid"/>
-                    </a:lnB>
-                    <a:solidFill>
-                      <a:srgbClr val="FFFFFF">
-                        <a:alpha val="0"/>
-                      </a:srgbClr>
-                    </a:solidFill>
-                  </a:tcPr>
-                </a:tc>
-              </a:tr>
-              <a:tr h="410845">
-                <a:tc>
-                  <a:txBody>
-                    <a:bodyPr/>
-                    <a:lstStyle/>
-                    <a:p>
-                      <a:pPr algn="l" marL="63500" marR="63500">
-                        <a:lnSpc>
-                          <a:spcPct val="100000"/>
-                        </a:lnSpc>
-                        <a:spcBef>
-                          <a:spcPts val="500"/>
-                        </a:spcBef>
-                        <a:spcAft>
-                          <a:spcPts val="500"/>
-                        </a:spcAft>
-                        <a:buNone/>
-                      </a:pPr>
-                      <a:r>
-                        <a:rPr cap="none" sz="1200" i="0" b="0" u="none" strike="noStrike">
-                          <a:solidFill>
-                            <a:srgbClr val="5B6770">
-                              <a:alpha val="100000"/>
-                            </a:srgbClr>
-                          </a:solidFill>
-                          <a:latin typeface="Helvetica Neue"/>
-                          <a:cs typeface="Helvetica Neue"/>
-                          <a:ea typeface="Helvetica Neue"/>
-                          <a:sym typeface="Helvetica Neue"/>
-                        </a:rPr>
-                        <a:t>triacetin</a:t>
-                      </a:r>
-                    </a:p>
-                  </a:txBody>
-                  <a:tcPr anchor="ctr" marB="63500" marT="63500" marR="0" marL="0">
-                    <a:lnL algn="ctr" cmpd="sng" cap="flat" w="0">
-                      <a:noFill/>
-                      <a:prstDash val="solid"/>
-                    </a:lnL>
-                    <a:lnR algn="ctr" cmpd="sng" cap="flat" w="0">
-                      <a:noFill/>
-                      <a:prstDash val="solid"/>
-                    </a:lnR>
-                    <a:lnT algn="ctr" cmpd="sng" cap="flat" w="0">
-                      <a:noFill/>
-                      <a:prstDash val="solid"/>
-                    </a:lnT>
-                    <a:lnB algn="ctr" cmpd="sng" cap="flat" w="19050">
-                      <a:solidFill>
-                        <a:srgbClr val="666666">
-                          <a:alpha val="100000"/>
-                        </a:srgbClr>
-                      </a:solidFill>
-                      <a:prstDash val="solid"/>
-                    </a:lnB>
-                    <a:solidFill>
-                      <a:srgbClr val="F4F8FB">
-                        <a:alpha val="100000"/>
-                      </a:srgbClr>
-                    </a:solidFill>
-                  </a:tcPr>
-                </a:tc>
-                <a:tc>
-                  <a:txBody>
-                    <a:bodyPr/>
-                    <a:lstStyle/>
-                    <a:p>
-                      <a:pPr algn="l" marL="63500" marR="63500">
-                        <a:lnSpc>
-                          <a:spcPct val="100000"/>
-                        </a:lnSpc>
-                        <a:spcBef>
-                          <a:spcPts val="500"/>
-                        </a:spcBef>
-                        <a:spcAft>
-                          <a:spcPts val="500"/>
-                        </a:spcAft>
-                        <a:buNone/>
-                      </a:pPr>
-                      <a:r>
-                        <a:rPr cap="none" sz="1200" i="0" b="0" u="none" strike="noStrike">
-                          <a:solidFill>
-                            <a:srgbClr val="5B6770">
-                              <a:alpha val="100000"/>
-                            </a:srgbClr>
-                          </a:solidFill>
-                          <a:latin typeface="Helvetica Neue"/>
-                          <a:cs typeface="Helvetica Neue"/>
-                          <a:ea typeface="Helvetica Neue"/>
-                          <a:sym typeface="Helvetica Neue"/>
-                        </a:rPr>
-                        <a:t>25 Jun 2026</a:t>
-                      </a:r>
-                    </a:p>
-                  </a:txBody>
-                  <a:tcPr anchor="ctr" marB="63500" marT="63500" marR="0" marL="0">
-                    <a:lnL algn="ctr" cmpd="sng" cap="flat" w="0">
-                      <a:noFill/>
-                      <a:prstDash val="solid"/>
-                    </a:lnL>
-                    <a:lnR algn="ctr" cmpd="sng" cap="flat" w="0">
-                      <a:noFill/>
-                      <a:prstDash val="solid"/>
-                    </a:lnR>
-                    <a:lnT algn="ctr" cmpd="sng" cap="flat" w="0">
-                      <a:noFill/>
-                      <a:prstDash val="solid"/>
-                    </a:lnT>
-                    <a:lnB algn="ctr" cmpd="sng" cap="flat" w="19050">
-                      <a:solidFill>
-                        <a:srgbClr val="666666">
-                          <a:alpha val="100000"/>
-                        </a:srgbClr>
-                      </a:solidFill>
-                      <a:prstDash val="solid"/>
-                    </a:lnB>
-                    <a:solidFill>
-                      <a:srgbClr val="F4F8FB">
-                        <a:alpha val="100000"/>
-                      </a:srgbClr>
-                    </a:solidFill>
-                  </a:tcPr>
-                </a:tc>
-                <a:tc>
-                  <a:txBody>
-                    <a:bodyPr/>
-                    <a:lstStyle/>
-                    <a:p>
-                      <a:pPr algn="l" marL="63500" marR="63500">
-                        <a:lnSpc>
-                          <a:spcPct val="100000"/>
-                        </a:lnSpc>
-                        <a:spcBef>
-                          <a:spcPts val="500"/>
-                        </a:spcBef>
-                        <a:spcAft>
-                          <a:spcPts val="500"/>
-                        </a:spcAft>
-                        <a:buNone/>
-                      </a:pPr>
-                      <a:r>
-                        <a:rPr cap="none" sz="1200" i="0" b="0" u="none" strike="noStrike">
-                          <a:solidFill>
-                            <a:srgbClr val="5B6770">
-                              <a:alpha val="100000"/>
-                            </a:srgbClr>
-                          </a:solidFill>
-                          <a:latin typeface="Helvetica Neue"/>
-                          <a:cs typeface="Helvetica Neue"/>
-                          <a:ea typeface="Helvetica Neue"/>
-                          <a:sym typeface="Helvetica Neue"/>
-                        </a:rPr>
-                        <a:t>primary</a:t>
-                      </a:r>
-                    </a:p>
-                  </a:txBody>
-                  <a:tcPr anchor="ctr" marB="63500" marT="63500" marR="0" marL="0">
-                    <a:lnL algn="ctr" cmpd="sng" cap="flat" w="0">
-                      <a:noFill/>
-                      <a:prstDash val="solid"/>
-                    </a:lnL>
-                    <a:lnR algn="ctr" cmpd="sng" cap="flat" w="0">
-                      <a:noFill/>
-                      <a:prstDash val="solid"/>
-                    </a:lnR>
-                    <a:lnT algn="ctr" cmpd="sng" cap="flat" w="0">
-                      <a:noFill/>
-                      <a:prstDash val="solid"/>
-                    </a:lnT>
-                    <a:lnB algn="ctr" cmpd="sng" cap="flat" w="19050">
-                      <a:solidFill>
-                        <a:srgbClr val="666666">
-                          <a:alpha val="100000"/>
-                        </a:srgbClr>
-                      </a:solidFill>
-                      <a:prstDash val="solid"/>
-                    </a:lnB>
-                    <a:solidFill>
-                      <a:srgbClr val="F4F8FB">
-                        <a:alpha val="100000"/>
-                      </a:srgbClr>
-                    </a:solidFill>
-                  </a:tcPr>
-                </a:tc>
-                <a:tc>
-                  <a:txBody>
-                    <a:bodyPr/>
-                    <a:lstStyle/>
-                    <a:p>
-                      <a:pPr algn="r" marL="63500" marR="63500">
-                        <a:lnSpc>
-                          <a:spcPct val="100000"/>
-                        </a:lnSpc>
-                        <a:spcBef>
-                          <a:spcPts val="500"/>
-                        </a:spcBef>
-                        <a:spcAft>
-                          <a:spcPts val="500"/>
-                        </a:spcAft>
-                        <a:buNone/>
-                      </a:pPr>
-                      <a:r>
-                        <a:rPr cap="none" sz="1200" i="0" b="0" u="none" strike="noStrike">
-                          <a:solidFill>
-                            <a:srgbClr val="5B6770">
-                              <a:alpha val="100000"/>
-                            </a:srgbClr>
-                          </a:solidFill>
-                          <a:latin typeface="Helvetica Neue"/>
-                          <a:cs typeface="Helvetica Neue"/>
-                          <a:ea typeface="Helvetica Neue"/>
-                          <a:sym typeface="Helvetica Neue"/>
-                        </a:rPr>
-                        <a:t>20</a:t>
-                      </a:r>
-                    </a:p>
-                  </a:txBody>
-                  <a:tcPr anchor="ctr" marB="63500" marT="63500" marR="0" marL="0">
-                    <a:lnL algn="ctr" cmpd="sng" cap="flat" w="0">
-                      <a:noFill/>
-                      <a:prstDash val="solid"/>
-                    </a:lnL>
-                    <a:lnR algn="ctr" cmpd="sng" cap="flat" w="0">
-                      <a:noFill/>
-                      <a:prstDash val="solid"/>
-                    </a:lnR>
-                    <a:lnT algn="ctr" cmpd="sng" cap="flat" w="0">
-                      <a:noFill/>
-                      <a:prstDash val="solid"/>
-                    </a:lnT>
-                    <a:lnB algn="ctr" cmpd="sng" cap="flat" w="19050">
-                      <a:solidFill>
-                        <a:srgbClr val="666666">
-                          <a:alpha val="100000"/>
-                        </a:srgbClr>
-                      </a:solidFill>
-                      <a:prstDash val="solid"/>
-                    </a:lnB>
-                    <a:solidFill>
-                      <a:srgbClr val="F4F8FB">
-                        <a:alpha val="100000"/>
-                      </a:srgbClr>
-                    </a:solidFill>
-                  </a:tcPr>
-                </a:tc>
-                <a:tc>
-                  <a:txBody>
-                    <a:bodyPr/>
-                    <a:lstStyle/>
-                    <a:p>
-                      <a:pPr algn="l" marL="63500" marR="63500">
-                        <a:lnSpc>
-                          <a:spcPct val="100000"/>
-                        </a:lnSpc>
-                        <a:spcBef>
-                          <a:spcPts val="500"/>
-                        </a:spcBef>
-                        <a:spcAft>
-                          <a:spcPts val="500"/>
-                        </a:spcAft>
-                        <a:buNone/>
-                      </a:pPr>
-                      <a:r>
-                        <a:rPr cap="none" sz="1200" i="0" b="0" u="none" strike="noStrike">
-                          <a:solidFill>
-                            <a:srgbClr val="5B6770">
-                              <a:alpha val="100000"/>
-                            </a:srgbClr>
-                          </a:solidFill>
-                          <a:latin typeface="Helvetica Neue"/>
-                          <a:cs typeface="Helvetica Neue"/>
-                          <a:ea typeface="Helvetica Neue"/>
-                          <a:sym typeface="Helvetica Neue"/>
-                        </a:rPr>
-                        <a:t>900817</a:t>
                       </a:r>
                     </a:p>
                   </a:txBody>

</xml_diff>

<commit_message>
nightly deck: data through 2026-09-20
</commit_message>
<xml_diff>
--- a/docs/nc-drug-checking-latest.pptx
+++ b/docs/nc-drug-checking-latest.pptx
@@ -2418,7 +2418,7 @@
                 <a:ea typeface="Helvetica Neue"/>
                 <a:sym typeface="Helvetica Neue"/>
               </a:rPr>
-              <a:t>Generated Saturday, September 19, 2026 · 8:01 AM ET UNC Street Drug Analysis Lab · OpioidData.org · results.streetsafe.supply Download as PowerPoint</a:t>
+              <a:t>Generated Sunday, September 20, 2026 · 8:33 AM ET UNC Street Drug Analysis Lab · OpioidData.org · results.streetsafe.supply Download as PowerPoint</a:t>
             </a:r>
           </a:p>
         </p:txBody>
@@ -3184,7 +3184,7 @@
                 <a:ea typeface="Helvetica Neue"/>
                 <a:sym typeface="Helvetica Neue"/>
               </a:rPr>
-              <a:t>County = samplecounty · left: ≥1 completed analysis ever · right: unique samples per county (sqrt color scale) · all time: 26 Jan 2022 – 18 Sep 2026 · last 12 months: 19 Sep 2025 – 18 Sep 2026* · coverage reflects participation, not prevalence</a:t>
+              <a:t>County = samplecounty · left: ≥1 completed analysis ever · right: unique samples per county (sqrt color scale) · all time: 26 Jan 2022 – 18 Sep 2026 · last 12 months: 20 Sep 2025 – 18 Sep 2026* · coverage reflects participation, not prevalence</a:t>
             </a:r>
           </a:p>
         </p:txBody>
@@ -4323,7 +4323,7 @@
                 <a:ea typeface="Helvetica Neue"/>
                 <a:sym typeface="Helvetica Neue"/>
               </a:rPr>
-              <a:t>Samples with methamphetamine or cocaine detected (any abundance); samples in both classes appear on both slides · sensations semicolon lists parsed + sen_strength (own denominator) · consumed = 1 only · before: 26 Jan 2022 – 18 Sep 2025 · past 12 months: 19 Sep 2025 – 18 Sep 2026* · Δ in percentage points</a:t>
+              <a:t>Samples with methamphetamine or cocaine detected (any abundance); samples in both classes appear on both slides · sensations semicolon lists parsed + sen_strength (own denominator) · consumed = 1 only · before: 26 Jan 2022 – 18 Sep 2025 · past 12 months: 20 Sep 2025 – 18 Sep 2026* · Δ in percentage points</a:t>
             </a:r>
           </a:p>
         </p:txBody>
@@ -4742,7 +4742,7 @@
                 <a:ea typeface="Helvetica Neue"/>
                 <a:sym typeface="Helvetica Neue"/>
               </a:rPr>
-              <a:t>Samples with an opioid (fentanyl, heroin) or benzodiazepine detected (any abundance); samples in both classes appear on both slides · sensations semicolon lists parsed + sen_strength (own denominator) · consumed = 1 only · before: 26 Jan 2022 – 18 Sep 2025 · past 12 months: 19 Sep 2025 – 18 Sep 2026* · Δ in percentage points</a:t>
+              <a:t>Samples with an opioid (fentanyl, heroin) or benzodiazepine detected (any abundance); samples in both classes appear on both slides · sensations semicolon lists parsed + sen_strength (own denominator) · consumed = 1 only · before: 26 Jan 2022 – 18 Sep 2025 · past 12 months: 20 Sep 2025 – 18 Sep 2026* · Δ in percentage points</a:t>
             </a:r>
           </a:p>
         </p:txBody>
@@ -5855,7 +5855,7 @@
                 <a:ea typeface="Helvetica Neue"/>
                 <a:sym typeface="Helvetica Neue"/>
               </a:rPr>
-              <a:t>lab_detail.substance counts · solid = primary abundance, light = trace · standardized names (PubChem-linked) · window: date_complete 19 Sep 2025 – 18 Sep 2026* (trailing 12 months, current month partial)</a:t>
+              <a:t>lab_detail.substance counts · solid = primary abundance, light = trace · standardized names (PubChem-linked) · window: date_complete 20 Sep 2025 – 18 Sep 2026* (trailing 12 months, current month partial)</a:t>
             </a:r>
           </a:p>
         </p:txBody>
@@ -6053,7 +6053,7 @@
                 <a:ea typeface="Helvetica Neue"/>
                 <a:sym typeface="Helvetica Neue"/>
               </a:rPr>
-              <a:t>Distribution of substances detected per sample, both definitions shown side by side · window: date_complete 19 Sep 2025 – 18 Sep 2026* (trailing 12 months, current month partial)</a:t>
+              <a:t>Distribution of substances detected per sample, both definitions shown side by side · window: date_complete 20 Sep 2025 – 18 Sep 2026* (trailing 12 months, current month partial)</a:t>
             </a:r>
           </a:p>
         </p:txBody>

</xml_diff>

<commit_message>
nightly deck: data through 2026-09-21
</commit_message>
<xml_diff>
--- a/docs/nc-drug-checking-latest.pptx
+++ b/docs/nc-drug-checking-latest.pptx
@@ -2418,7 +2418,7 @@
                 <a:ea typeface="Helvetica Neue"/>
                 <a:sym typeface="Helvetica Neue"/>
               </a:rPr>
-              <a:t>Generated Sunday, September 20, 2026 · 8:33 AM ET UNC Street Drug Analysis Lab · OpioidData.org · results.streetsafe.supply Download as PowerPoint</a:t>
+              <a:t>Generated Monday, September 21, 2026 · 10:25 AM ET UNC Street Drug Analysis Lab · OpioidData.org · results.streetsafe.supply Download as PowerPoint</a:t>
             </a:r>
           </a:p>
         </p:txBody>
@@ -2713,7 +2713,7 @@
                 <a:ea typeface="Helvetica Neue"/>
                 <a:sym typeface="Helvetica Neue"/>
               </a:rPr>
-              <a:t>PLACEHOLDER · figs/stats.json January 2022 to Friday, September 18, 2026 N = 2,860 NC samples analyzed Mailed in from 86 harm reduction programs Collected across 59 counties 247 distinct substances detected to date Unique samples = n_distinct(sampleid) · substances from lab_detail.substance · includes samples with date_complete 26 Jan 2022 – 18 Sep 2026 r/build_nightly.R → figs/stats.json</a:t>
+              <a:t>PLACEHOLDER · figs/stats.json January 2022 to Monday, September 21, 2026 N = 2,863 NC samples analyzed Mailed in from 86 harm reduction programs Collected across 59 counties 247 distinct substances detected to date Unique samples = n_distinct(sampleid) · substances from lab_detail.substance · includes samples with date_complete 26 Jan 2022 – 21 Sep 2026 r/build_nightly.R → figs/stats.json</a:t>
             </a:r>
           </a:p>
         </p:txBody>
@@ -2762,7 +2762,7 @@
                 <a:ea typeface="Helvetica Neue"/>
                 <a:sym typeface="Helvetica Neue"/>
               </a:rPr>
-              <a:t>Unique samples = n_distinct(sampleid) · substances from lab_detail.substance · includes samples with date_complete 26 Jan 2022 – 18 Sep 2026</a:t>
+              <a:t>Unique samples = n_distinct(sampleid) · substances from lab_detail.substance · includes samples with date_complete 26 Jan 2022 – 21 Sep 2026</a:t>
             </a:r>
           </a:p>
         </p:txBody>
@@ -3184,7 +3184,7 @@
                 <a:ea typeface="Helvetica Neue"/>
                 <a:sym typeface="Helvetica Neue"/>
               </a:rPr>
-              <a:t>County = samplecounty · left: ≥1 completed analysis ever · right: unique samples per county (sqrt color scale) · all time: 26 Jan 2022 – 18 Sep 2026 · last 12 months: 20 Sep 2025 – 18 Sep 2026* · coverage reflects participation, not prevalence</a:t>
+              <a:t>County = samplecounty · left: ≥1 completed analysis ever · right: unique samples per county (sqrt color scale) · all time: 26 Jan 2022 – 21 Sep 2026 · last 12 months: 21 Sep 2025 – 21 Sep 2026* · coverage reflects participation, not prevalence</a:t>
             </a:r>
           </a:p>
         </p:txBody>
@@ -3505,7 +3505,7 @@
                 <a:ea typeface="Helvetica Neue"/>
                 <a:sym typeface="Helvetica Neue"/>
               </a:rPr>
-              <a:t>expectedsubstance (verbatim card write-in, semicolon lists split) · derived flags: expect_opioid, expect_fentanyl, expect_meth, expect_cocaine, expect_stimulant… · includes samples with date_complete 26 Jan 2022 – 18 Sep 2026 · data table: Appendix A2</a:t>
+              <a:t>expectedsubstance (verbatim card write-in, semicolon lists split) · derived flags: expect_opioid, expect_fentanyl, expect_meth, expect_cocaine, expect_stimulant… · includes samples with date_complete 26 Jan 2022 – 21 Sep 2026 · data table: Appendix A2</a:t>
             </a:r>
           </a:p>
         </p:txBody>
@@ -3703,7 +3703,7 @@
                 <a:ea typeface="Helvetica Neue"/>
                 <a:sym typeface="Helvetica Neue"/>
               </a:rPr>
-              <a:t>Numerator uses lab_*_any (primary or trace) among samples with expect_* = 1 · includes samples with date_complete 26 Jan 2022 – 18 Sep 2026 · data table: Appendix A3</a:t>
+              <a:t>Numerator uses lab_*_any (primary or trace) among samples with expect_* = 1 · includes samples with date_complete 26 Jan 2022 – 21 Sep 2026 · data table: Appendix A3</a:t>
             </a:r>
           </a:p>
         </p:txBody>
@@ -3901,7 +3901,7 @@
                 <a:ea typeface="Helvetica Neue"/>
                 <a:sym typeface="Helvetica Neue"/>
               </a:rPr>
-              <a:t>sensations (circled on card, semicolon lists split) · post-consumption samples only (consumed = 1) · includes samples with date_complete 26 Jan 2022 – 18 Sep 2026</a:t>
+              <a:t>sensations (circled on card, semicolon lists split) · post-consumption samples only (consumed = 1) · includes samples with date_complete 26 Jan 2022 – 21 Sep 2026</a:t>
             </a:r>
           </a:p>
         </p:txBody>
@@ -4125,7 +4125,7 @@
                 <a:ea typeface="Helvetica Neue"/>
                 <a:sym typeface="Helvetica Neue"/>
               </a:rPr>
-              <a:t>sensations semicolon lists parsed per report · consumed = 1 only · denominator: consumed samples with lab_*_any = 1 · includes samples with date_complete 26 Jan 2022 – 18 Sep 2026</a:t>
+              <a:t>sensations semicolon lists parsed per report · consumed = 1 only · denominator: consumed samples with lab_*_any = 1 · includes samples with date_complete 26 Jan 2022 – 21 Sep 2026</a:t>
             </a:r>
           </a:p>
         </p:txBody>
@@ -4323,7 +4323,7 @@
                 <a:ea typeface="Helvetica Neue"/>
                 <a:sym typeface="Helvetica Neue"/>
               </a:rPr>
-              <a:t>Samples with methamphetamine or cocaine detected (any abundance); samples in both classes appear on both slides · sensations semicolon lists parsed + sen_strength (own denominator) · consumed = 1 only · before: 26 Jan 2022 – 18 Sep 2025 · past 12 months: 20 Sep 2025 – 18 Sep 2026* · Δ in percentage points</a:t>
+              <a:t>Samples with methamphetamine or cocaine detected (any abundance); samples in both classes appear on both slides · sensations semicolon lists parsed + sen_strength (own denominator) · consumed = 1 only · before: 26 Jan 2022 – 21 Sep 2025 · past 12 months: 21 Sep 2025 – 21 Sep 2026* · Δ in percentage points</a:t>
             </a:r>
           </a:p>
         </p:txBody>
@@ -4742,7 +4742,7 @@
                 <a:ea typeface="Helvetica Neue"/>
                 <a:sym typeface="Helvetica Neue"/>
               </a:rPr>
-              <a:t>Samples with an opioid (fentanyl, heroin) or benzodiazepine detected (any abundance); samples in both classes appear on both slides · sensations semicolon lists parsed + sen_strength (own denominator) · consumed = 1 only · before: 26 Jan 2022 – 18 Sep 2025 · past 12 months: 20 Sep 2025 – 18 Sep 2026* · Δ in percentage points</a:t>
+              <a:t>Samples with an opioid (fentanyl, heroin) or benzodiazepine detected (any abundance); samples in both classes appear on both slides · sensations semicolon lists parsed + sen_strength (own denominator) · consumed = 1 only · before: 26 Jan 2022 – 21 Sep 2025 · past 12 months: 21 Sep 2025 – 21 Sep 2026* · Δ in percentage points</a:t>
             </a:r>
           </a:p>
         </p:txBody>
@@ -5138,7 +5138,7 @@
                 <a:ea typeface="Helvetica Neue"/>
                 <a:sym typeface="Helvetica Neue"/>
               </a:rPr>
-              <a:t>color, texture (card v3+, semicolon lists split) · derived: bright_color excludes white/tan/brown family — orange bar above · includes samples with date_complete 26 Jan 2022 – 18 Sep 2026</a:t>
+              <a:t>color, texture (card v3+, semicolon lists split) · derived: bright_color excludes white/tan/brown family — orange bar above · includes samples with date_complete 26 Jan 2022 – 21 Sep 2026</a:t>
             </a:r>
           </a:p>
         </p:txBody>
@@ -5459,7 +5459,7 @@
                 <a:ea typeface="Helvetica Neue"/>
                 <a:sym typeface="Helvetica Neue"/>
               </a:rPr>
-              <a:t>Distribution of substances detected per sample, both definitions shown side by side · includes samples with date_complete 26 Jan 2022 – 18 Sep 2026</a:t>
+              <a:t>Distribution of substances detected per sample, both definitions shown side by side · includes samples with date_complete 26 Jan 2022 – 21 Sep 2026</a:t>
             </a:r>
           </a:p>
         </p:txBody>
@@ -5657,7 +5657,7 @@
                 <a:ea typeface="Helvetica Neue"/>
                 <a:sym typeface="Helvetica Neue"/>
               </a:rPr>
-              <a:t>lab_detail.substance counts · solid = primary abundance, light = trace · standardized names (PubChem-linked) · includes samples with date_complete 26 Jan 2022 – 18 Sep 2026</a:t>
+              <a:t>lab_detail.substance counts · solid = primary abundance, light = trace · standardized names (PubChem-linked) · includes samples with date_complete 26 Jan 2022 – 21 Sep 2026</a:t>
             </a:r>
           </a:p>
         </p:txBody>
@@ -5855,7 +5855,7 @@
                 <a:ea typeface="Helvetica Neue"/>
                 <a:sym typeface="Helvetica Neue"/>
               </a:rPr>
-              <a:t>lab_detail.substance counts · solid = primary abundance, light = trace · standardized names (PubChem-linked) · window: date_complete 20 Sep 2025 – 18 Sep 2026* (trailing 12 months, current month partial)</a:t>
+              <a:t>lab_detail.substance counts · solid = primary abundance, light = trace · standardized names (PubChem-linked) · window: date_complete 21 Sep 2025 – 21 Sep 2026* (trailing 12 months, current month partial)</a:t>
             </a:r>
           </a:p>
         </p:txBody>
@@ -6053,7 +6053,7 @@
                 <a:ea typeface="Helvetica Neue"/>
                 <a:sym typeface="Helvetica Neue"/>
               </a:rPr>
-              <a:t>Distribution of substances detected per sample, both definitions shown side by side · window: date_complete 20 Sep 2025 – 18 Sep 2026* (trailing 12 months, current month partial)</a:t>
+              <a:t>Distribution of substances detected per sample, both definitions shown side by side · window: date_complete 21 Sep 2025 – 21 Sep 2026* (trailing 12 months, current month partial)</a:t>
             </a:r>
           </a:p>
         </p:txBody>
@@ -18510,7 +18510,7 @@
                           <a:ea typeface="Helvetica Neue"/>
                           <a:sym typeface="Helvetica Neue"/>
                         </a:rPr>
-                        <a:t>1,469</a:t>
+                        <a:t>1,471</a:t>
                       </a:r>
                     </a:p>
                   </a:txBody>
@@ -20591,7 +20591,7 @@
                           <a:ea typeface="Helvetica Neue"/>
                           <a:sym typeface="Helvetica Neue"/>
                         </a:rPr>
-                        <a:t>1,697</a:t>
+                        <a:t>1,700</a:t>
                       </a:r>
                     </a:p>
                   </a:txBody>

</xml_diff>

<commit_message>
nightly deck: data through 2026-09-22
</commit_message>
<xml_diff>
--- a/docs/nc-drug-checking-latest.pptx
+++ b/docs/nc-drug-checking-latest.pptx
@@ -2418,7 +2418,7 @@
                 <a:ea typeface="Helvetica Neue"/>
                 <a:sym typeface="Helvetica Neue"/>
               </a:rPr>
-              <a:t>Generated Monday, September 21, 2026 · 10:25 AM ET UNC Street Drug Analysis Lab · OpioidData.org · results.streetsafe.supply Download as PowerPoint</a:t>
+              <a:t>Generated Tuesday, September 22, 2026 · 8:44 AM ET UNC Street Drug Analysis Lab · OpioidData.org · results.streetsafe.supply Download as PowerPoint</a:t>
             </a:r>
           </a:p>
         </p:txBody>
@@ -3184,7 +3184,7 @@
                 <a:ea typeface="Helvetica Neue"/>
                 <a:sym typeface="Helvetica Neue"/>
               </a:rPr>
-              <a:t>County = samplecounty · left: ≥1 completed analysis ever · right: unique samples per county (sqrt color scale) · all time: 26 Jan 2022 – 21 Sep 2026 · last 12 months: 21 Sep 2025 – 21 Sep 2026* · coverage reflects participation, not prevalence</a:t>
+              <a:t>County = samplecounty · left: ≥1 completed analysis ever · right: unique samples per county (sqrt color scale) · all time: 26 Jan 2022 – 21 Sep 2026 · last 12 months: 22 Sep 2025 – 21 Sep 2026* · coverage reflects participation, not prevalence</a:t>
             </a:r>
           </a:p>
         </p:txBody>
@@ -4323,7 +4323,7 @@
                 <a:ea typeface="Helvetica Neue"/>
                 <a:sym typeface="Helvetica Neue"/>
               </a:rPr>
-              <a:t>Samples with methamphetamine or cocaine detected (any abundance); samples in both classes appear on both slides · sensations semicolon lists parsed + sen_strength (own denominator) · consumed = 1 only · before: 26 Jan 2022 – 21 Sep 2025 · past 12 months: 21 Sep 2025 – 21 Sep 2026* · Δ in percentage points</a:t>
+              <a:t>Samples with methamphetamine or cocaine detected (any abundance); samples in both classes appear on both slides · sensations semicolon lists parsed + sen_strength (own denominator) · consumed = 1 only · before: 26 Jan 2022 – 21 Sep 2025 · past 12 months: 22 Sep 2025 – 21 Sep 2026* · Δ in percentage points</a:t>
             </a:r>
           </a:p>
         </p:txBody>
@@ -4742,7 +4742,7 @@
                 <a:ea typeface="Helvetica Neue"/>
                 <a:sym typeface="Helvetica Neue"/>
               </a:rPr>
-              <a:t>Samples with an opioid (fentanyl, heroin) or benzodiazepine detected (any abundance); samples in both classes appear on both slides · sensations semicolon lists parsed + sen_strength (own denominator) · consumed = 1 only · before: 26 Jan 2022 – 21 Sep 2025 · past 12 months: 21 Sep 2025 – 21 Sep 2026* · Δ in percentage points</a:t>
+              <a:t>Samples with an opioid (fentanyl, heroin) or benzodiazepine detected (any abundance); samples in both classes appear on both slides · sensations semicolon lists parsed + sen_strength (own denominator) · consumed = 1 only · before: 26 Jan 2022 – 21 Sep 2025 · past 12 months: 22 Sep 2025 – 21 Sep 2026* · Δ in percentage points</a:t>
             </a:r>
           </a:p>
         </p:txBody>
@@ -5855,7 +5855,7 @@
                 <a:ea typeface="Helvetica Neue"/>
                 <a:sym typeface="Helvetica Neue"/>
               </a:rPr>
-              <a:t>lab_detail.substance counts · solid = primary abundance, light = trace · standardized names (PubChem-linked) · window: date_complete 21 Sep 2025 – 21 Sep 2026* (trailing 12 months, current month partial)</a:t>
+              <a:t>lab_detail.substance counts · solid = primary abundance, light = trace · standardized names (PubChem-linked) · window: date_complete 22 Sep 2025 – 21 Sep 2026* (trailing 12 months, current month partial)</a:t>
             </a:r>
           </a:p>
         </p:txBody>
@@ -6053,7 +6053,7 @@
                 <a:ea typeface="Helvetica Neue"/>
                 <a:sym typeface="Helvetica Neue"/>
               </a:rPr>
-              <a:t>Distribution of substances detected per sample, both definitions shown side by side · window: date_complete 21 Sep 2025 – 21 Sep 2026* (trailing 12 months, current month partial)</a:t>
+              <a:t>Distribution of substances detected per sample, both definitions shown side by side · window: date_complete 22 Sep 2025 – 21 Sep 2026* (trailing 12 months, current month partial)</a:t>
             </a:r>
           </a:p>
         </p:txBody>

</xml_diff>

<commit_message>
nightly deck: data through 2026-09-23
</commit_message>
<xml_diff>
--- a/docs/nc-drug-checking-latest.pptx
+++ b/docs/nc-drug-checking-latest.pptx
@@ -2418,7 +2418,7 @@
                 <a:ea typeface="Helvetica Neue"/>
                 <a:sym typeface="Helvetica Neue"/>
               </a:rPr>
-              <a:t>Generated Tuesday, September 22, 2026 · 8:44 AM ET UNC Street Drug Analysis Lab · OpioidData.org · results.streetsafe.supply Download as PowerPoint</a:t>
+              <a:t>Generated Wednesday, September 23, 2026 · 8:52 AM ET UNC Street Drug Analysis Lab · OpioidData.org · results.streetsafe.supply Download as PowerPoint</a:t>
             </a:r>
           </a:p>
         </p:txBody>
@@ -2713,7 +2713,7 @@
                 <a:ea typeface="Helvetica Neue"/>
                 <a:sym typeface="Helvetica Neue"/>
               </a:rPr>
-              <a:t>PLACEHOLDER · figs/stats.json January 2022 to Monday, September 21, 2026 N = 2,863 NC samples analyzed Mailed in from 86 harm reduction programs Collected across 59 counties 247 distinct substances detected to date Unique samples = n_distinct(sampleid) · substances from lab_detail.substance · includes samples with date_complete 26 Jan 2022 – 21 Sep 2026 r/build_nightly.R → figs/stats.json</a:t>
+              <a:t>PLACEHOLDER · figs/stats.json January 2022 to Tuesday, September 22, 2026 N = 2,873 NC samples analyzed Mailed in from 86 harm reduction programs Collected across 59 counties 247 distinct substances detected to date Unique samples = n_distinct(sampleid) · substances from lab_detail.substance · includes samples with date_complete 26 Jan 2022 – 22 Sep 2026 r/build_nightly.R → figs/stats.json</a:t>
             </a:r>
           </a:p>
         </p:txBody>
@@ -2762,7 +2762,7 @@
                 <a:ea typeface="Helvetica Neue"/>
                 <a:sym typeface="Helvetica Neue"/>
               </a:rPr>
-              <a:t>Unique samples = n_distinct(sampleid) · substances from lab_detail.substance · includes samples with date_complete 26 Jan 2022 – 21 Sep 2026</a:t>
+              <a:t>Unique samples = n_distinct(sampleid) · substances from lab_detail.substance · includes samples with date_complete 26 Jan 2022 – 22 Sep 2026</a:t>
             </a:r>
           </a:p>
         </p:txBody>
@@ -3184,7 +3184,7 @@
                 <a:ea typeface="Helvetica Neue"/>
                 <a:sym typeface="Helvetica Neue"/>
               </a:rPr>
-              <a:t>County = samplecounty · left: ≥1 completed analysis ever · right: unique samples per county (sqrt color scale) · all time: 26 Jan 2022 – 21 Sep 2026 · last 12 months: 22 Sep 2025 – 21 Sep 2026* · coverage reflects participation, not prevalence</a:t>
+              <a:t>County = samplecounty · left: ≥1 completed analysis ever · right: unique samples per county (sqrt color scale) · all time: 26 Jan 2022 – 22 Sep 2026 · last 12 months: 23 Sep 2025 – 22 Sep 2026* · coverage reflects participation, not prevalence</a:t>
             </a:r>
           </a:p>
         </p:txBody>
@@ -3505,7 +3505,7 @@
                 <a:ea typeface="Helvetica Neue"/>
                 <a:sym typeface="Helvetica Neue"/>
               </a:rPr>
-              <a:t>expectedsubstance (verbatim card write-in, semicolon lists split) · derived flags: expect_opioid, expect_fentanyl, expect_meth, expect_cocaine, expect_stimulant… · includes samples with date_complete 26 Jan 2022 – 21 Sep 2026 · data table: Appendix A2</a:t>
+              <a:t>expectedsubstance (verbatim card write-in, semicolon lists split) · derived flags: expect_opioid, expect_fentanyl, expect_meth, expect_cocaine, expect_stimulant… · includes samples with date_complete 26 Jan 2022 – 22 Sep 2026 · data table: Appendix A2</a:t>
             </a:r>
           </a:p>
         </p:txBody>
@@ -3703,7 +3703,7 @@
                 <a:ea typeface="Helvetica Neue"/>
                 <a:sym typeface="Helvetica Neue"/>
               </a:rPr>
-              <a:t>Numerator uses lab_*_any (primary or trace) among samples with expect_* = 1 · includes samples with date_complete 26 Jan 2022 – 21 Sep 2026 · data table: Appendix A3</a:t>
+              <a:t>Numerator uses lab_*_any (primary or trace) among samples with expect_* = 1 · includes samples with date_complete 26 Jan 2022 – 22 Sep 2026 · data table: Appendix A3</a:t>
             </a:r>
           </a:p>
         </p:txBody>
@@ -3901,7 +3901,7 @@
                 <a:ea typeface="Helvetica Neue"/>
                 <a:sym typeface="Helvetica Neue"/>
               </a:rPr>
-              <a:t>sensations (circled on card, semicolon lists split) · post-consumption samples only (consumed = 1) · includes samples with date_complete 26 Jan 2022 – 21 Sep 2026</a:t>
+              <a:t>sensations (circled on card, semicolon lists split) · post-consumption samples only (consumed = 1) · includes samples with date_complete 26 Jan 2022 – 22 Sep 2026</a:t>
             </a:r>
           </a:p>
         </p:txBody>
@@ -4125,7 +4125,7 @@
                 <a:ea typeface="Helvetica Neue"/>
                 <a:sym typeface="Helvetica Neue"/>
               </a:rPr>
-              <a:t>sensations semicolon lists parsed per report · consumed = 1 only · denominator: consumed samples with lab_*_any = 1 · includes samples with date_complete 26 Jan 2022 – 21 Sep 2026</a:t>
+              <a:t>sensations semicolon lists parsed per report · consumed = 1 only · denominator: consumed samples with lab_*_any = 1 · includes samples with date_complete 26 Jan 2022 – 22 Sep 2026</a:t>
             </a:r>
           </a:p>
         </p:txBody>
@@ -4323,7 +4323,7 @@
                 <a:ea typeface="Helvetica Neue"/>
                 <a:sym typeface="Helvetica Neue"/>
               </a:rPr>
-              <a:t>Samples with methamphetamine or cocaine detected (any abundance); samples in both classes appear on both slides · sensations semicolon lists parsed + sen_strength (own denominator) · consumed = 1 only · before: 26 Jan 2022 – 21 Sep 2025 · past 12 months: 22 Sep 2025 – 21 Sep 2026* · Δ in percentage points</a:t>
+              <a:t>Samples with methamphetamine or cocaine detected (any abundance); samples in both classes appear on both slides · sensations semicolon lists parsed + sen_strength (own denominator) · consumed = 1 only · before: 26 Jan 2022 – 22 Sep 2025 · past 12 months: 23 Sep 2025 – 22 Sep 2026* · Δ in percentage points</a:t>
             </a:r>
           </a:p>
         </p:txBody>
@@ -4742,7 +4742,7 @@
                 <a:ea typeface="Helvetica Neue"/>
                 <a:sym typeface="Helvetica Neue"/>
               </a:rPr>
-              <a:t>Samples with an opioid (fentanyl, heroin) or benzodiazepine detected (any abundance); samples in both classes appear on both slides · sensations semicolon lists parsed + sen_strength (own denominator) · consumed = 1 only · before: 26 Jan 2022 – 21 Sep 2025 · past 12 months: 22 Sep 2025 – 21 Sep 2026* · Δ in percentage points</a:t>
+              <a:t>Samples with an opioid (fentanyl, heroin) or benzodiazepine detected (any abundance); samples in both classes appear on both slides · sensations semicolon lists parsed + sen_strength (own denominator) · consumed = 1 only · before: 26 Jan 2022 – 22 Sep 2025 · past 12 months: 23 Sep 2025 – 22 Sep 2026* · Δ in percentage points</a:t>
             </a:r>
           </a:p>
         </p:txBody>
@@ -5138,7 +5138,7 @@
                 <a:ea typeface="Helvetica Neue"/>
                 <a:sym typeface="Helvetica Neue"/>
               </a:rPr>
-              <a:t>color, texture (card v3+, semicolon lists split) · derived: bright_color excludes white/tan/brown family — orange bar above · includes samples with date_complete 26 Jan 2022 – 21 Sep 2026</a:t>
+              <a:t>color, texture (card v3+, semicolon lists split) · derived: bright_color excludes white/tan/brown family — orange bar above · includes samples with date_complete 26 Jan 2022 – 22 Sep 2026</a:t>
             </a:r>
           </a:p>
         </p:txBody>
@@ -5459,7 +5459,7 @@
                 <a:ea typeface="Helvetica Neue"/>
                 <a:sym typeface="Helvetica Neue"/>
               </a:rPr>
-              <a:t>Distribution of substances detected per sample, both definitions shown side by side · includes samples with date_complete 26 Jan 2022 – 21 Sep 2026</a:t>
+              <a:t>Distribution of substances detected per sample, both definitions shown side by side · includes samples with date_complete 26 Jan 2022 – 22 Sep 2026</a:t>
             </a:r>
           </a:p>
         </p:txBody>
@@ -5657,7 +5657,7 @@
                 <a:ea typeface="Helvetica Neue"/>
                 <a:sym typeface="Helvetica Neue"/>
               </a:rPr>
-              <a:t>lab_detail.substance counts · solid = primary abundance, light = trace · standardized names (PubChem-linked) · includes samples with date_complete 26 Jan 2022 – 21 Sep 2026</a:t>
+              <a:t>lab_detail.substance counts · solid = primary abundance, light = trace · standardized names (PubChem-linked) · includes samples with date_complete 26 Jan 2022 – 22 Sep 2026</a:t>
             </a:r>
           </a:p>
         </p:txBody>
@@ -5855,7 +5855,7 @@
                 <a:ea typeface="Helvetica Neue"/>
                 <a:sym typeface="Helvetica Neue"/>
               </a:rPr>
-              <a:t>lab_detail.substance counts · solid = primary abundance, light = trace · standardized names (PubChem-linked) · window: date_complete 22 Sep 2025 – 21 Sep 2026* (trailing 12 months, current month partial)</a:t>
+              <a:t>lab_detail.substance counts · solid = primary abundance, light = trace · standardized names (PubChem-linked) · window: date_complete 23 Sep 2025 – 22 Sep 2026* (trailing 12 months, current month partial)</a:t>
             </a:r>
           </a:p>
         </p:txBody>
@@ -6053,7 +6053,7 @@
                 <a:ea typeface="Helvetica Neue"/>
                 <a:sym typeface="Helvetica Neue"/>
               </a:rPr>
-              <a:t>Distribution of substances detected per sample, both definitions shown side by side · window: date_complete 22 Sep 2025 – 21 Sep 2026* (trailing 12 months, current month partial)</a:t>
+              <a:t>Distribution of substances detected per sample, both definitions shown side by side · window: date_complete 23 Sep 2025 – 22 Sep 2026* (trailing 12 months, current month partial)</a:t>
             </a:r>
           </a:p>
         </p:txBody>
@@ -18510,7 +18510,7 @@
                           <a:ea typeface="Helvetica Neue"/>
                           <a:sym typeface="Helvetica Neue"/>
                         </a:rPr>
-                        <a:t>1,471</a:t>
+                        <a:t>1,474</a:t>
                       </a:r>
                     </a:p>
                   </a:txBody>
@@ -18626,7 +18626,7 @@
                           <a:ea typeface="Helvetica Neue"/>
                           <a:sym typeface="Helvetica Neue"/>
                         </a:rPr>
-                        <a:t>439</a:t>
+                        <a:t>443</a:t>
                       </a:r>
                     </a:p>
                   </a:txBody>
@@ -20591,7 +20591,7 @@
                           <a:ea typeface="Helvetica Neue"/>
                           <a:sym typeface="Helvetica Neue"/>
                         </a:rPr>
-                        <a:t>1,700</a:t>
+                        <a:t>1,703</a:t>
                       </a:r>
                     </a:p>
                   </a:txBody>
@@ -20821,7 +20821,7 @@
                           <a:ea typeface="Helvetica Neue"/>
                           <a:sym typeface="Helvetica Neue"/>
                         </a:rPr>
-                        <a:t>510</a:t>
+                        <a:t>514</a:t>
                       </a:r>
                     </a:p>
                   </a:txBody>

</xml_diff>

<commit_message>
nightly deck: data through 2026-09-24
</commit_message>
<xml_diff>
--- a/docs/nc-drug-checking-latest.pptx
+++ b/docs/nc-drug-checking-latest.pptx
@@ -2418,7 +2418,7 @@
                 <a:ea typeface="Helvetica Neue"/>
                 <a:sym typeface="Helvetica Neue"/>
               </a:rPr>
-              <a:t>Generated Wednesday, September 23, 2026 · 8:52 AM ET UNC Street Drug Analysis Lab · OpioidData.org · results.streetsafe.supply Download as PowerPoint</a:t>
+              <a:t>Generated Thursday, September 24, 2026 · 8:49 AM ET UNC Street Drug Analysis Lab · OpioidData.org · results.streetsafe.supply Download as PowerPoint</a:t>
             </a:r>
           </a:p>
         </p:txBody>
@@ -3184,7 +3184,7 @@
                 <a:ea typeface="Helvetica Neue"/>
                 <a:sym typeface="Helvetica Neue"/>
               </a:rPr>
-              <a:t>County = samplecounty · left: ≥1 completed analysis ever · right: unique samples per county (sqrt color scale) · all time: 26 Jan 2022 – 22 Sep 2026 · last 12 months: 23 Sep 2025 – 22 Sep 2026* · coverage reflects participation, not prevalence</a:t>
+              <a:t>County = samplecounty · left: ≥1 completed analysis ever · right: unique samples per county (sqrt color scale) · all time: 26 Jan 2022 – 22 Sep 2026 · last 12 months: 24 Sep 2025 – 22 Sep 2026* · coverage reflects participation, not prevalence</a:t>
             </a:r>
           </a:p>
         </p:txBody>
@@ -4323,7 +4323,7 @@
                 <a:ea typeface="Helvetica Neue"/>
                 <a:sym typeface="Helvetica Neue"/>
               </a:rPr>
-              <a:t>Samples with methamphetamine or cocaine detected (any abundance); samples in both classes appear on both slides · sensations semicolon lists parsed + sen_strength (own denominator) · consumed = 1 only · before: 26 Jan 2022 – 22 Sep 2025 · past 12 months: 23 Sep 2025 – 22 Sep 2026* · Δ in percentage points</a:t>
+              <a:t>Samples with methamphetamine or cocaine detected (any abundance); samples in both classes appear on both slides · sensations semicolon lists parsed + sen_strength (own denominator) · consumed = 1 only · before: 26 Jan 2022 – 22 Sep 2025 · past 12 months: 24 Sep 2025 – 22 Sep 2026* · Δ in percentage points</a:t>
             </a:r>
           </a:p>
         </p:txBody>
@@ -4742,7 +4742,7 @@
                 <a:ea typeface="Helvetica Neue"/>
                 <a:sym typeface="Helvetica Neue"/>
               </a:rPr>
-              <a:t>Samples with an opioid (fentanyl, heroin) or benzodiazepine detected (any abundance); samples in both classes appear on both slides · sensations semicolon lists parsed + sen_strength (own denominator) · consumed = 1 only · before: 26 Jan 2022 – 22 Sep 2025 · past 12 months: 23 Sep 2025 – 22 Sep 2026* · Δ in percentage points</a:t>
+              <a:t>Samples with an opioid (fentanyl, heroin) or benzodiazepine detected (any abundance); samples in both classes appear on both slides · sensations semicolon lists parsed + sen_strength (own denominator) · consumed = 1 only · before: 26 Jan 2022 – 22 Sep 2025 · past 12 months: 24 Sep 2025 – 22 Sep 2026* · Δ in percentage points</a:t>
             </a:r>
           </a:p>
         </p:txBody>
@@ -5855,7 +5855,7 @@
                 <a:ea typeface="Helvetica Neue"/>
                 <a:sym typeface="Helvetica Neue"/>
               </a:rPr>
-              <a:t>lab_detail.substance counts · solid = primary abundance, light = trace · standardized names (PubChem-linked) · window: date_complete 23 Sep 2025 – 22 Sep 2026* (trailing 12 months, current month partial)</a:t>
+              <a:t>lab_detail.substance counts · solid = primary abundance, light = trace · standardized names (PubChem-linked) · window: date_complete 24 Sep 2025 – 22 Sep 2026* (trailing 12 months, current month partial)</a:t>
             </a:r>
           </a:p>
         </p:txBody>
@@ -6053,7 +6053,7 @@
                 <a:ea typeface="Helvetica Neue"/>
                 <a:sym typeface="Helvetica Neue"/>
               </a:rPr>
-              <a:t>Distribution of substances detected per sample, both definitions shown side by side · window: date_complete 23 Sep 2025 – 22 Sep 2026* (trailing 12 months, current month partial)</a:t>
+              <a:t>Distribution of substances detected per sample, both definitions shown side by side · window: date_complete 24 Sep 2025 – 22 Sep 2026* (trailing 12 months, current month partial)</a:t>
             </a:r>
           </a:p>
         </p:txBody>

</xml_diff>

<commit_message>
nightly deck: data through 2026-09-25
</commit_message>
<xml_diff>
--- a/docs/nc-drug-checking-latest.pptx
+++ b/docs/nc-drug-checking-latest.pptx
@@ -2418,7 +2418,7 @@
                 <a:ea typeface="Helvetica Neue"/>
                 <a:sym typeface="Helvetica Neue"/>
               </a:rPr>
-              <a:t>Generated Thursday, September 24, 2026 · 8:49 AM ET UNC Street Drug Analysis Lab · OpioidData.org · results.streetsafe.supply Download as PowerPoint</a:t>
+              <a:t>Generated Friday, September 25, 2026 · 8:52 AM ET UNC Street Drug Analysis Lab · OpioidData.org · results.streetsafe.supply Download as PowerPoint</a:t>
             </a:r>
           </a:p>
         </p:txBody>
@@ -2713,7 +2713,7 @@
                 <a:ea typeface="Helvetica Neue"/>
                 <a:sym typeface="Helvetica Neue"/>
               </a:rPr>
-              <a:t>PLACEHOLDER · figs/stats.json January 2022 to Tuesday, September 22, 2026 N = 2,873 NC samples analyzed Mailed in from 86 harm reduction programs Collected across 59 counties 247 distinct substances detected to date Unique samples = n_distinct(sampleid) · substances from lab_detail.substance · includes samples with date_complete 26 Jan 2022 – 22 Sep 2026 r/build_nightly.R → figs/stats.json</a:t>
+              <a:t>PLACEHOLDER · figs/stats.json January 2022 to Thursday, September 24, 2026 N = 2,888 NC samples analyzed Mailed in from 86 harm reduction programs Collected across 59 counties 247 distinct substances detected to date Unique samples = n_distinct(sampleid) · substances from lab_detail.substance · includes samples with date_complete 26 Jan 2022 – 24 Sep 2026 r/build_nightly.R → figs/stats.json</a:t>
             </a:r>
           </a:p>
         </p:txBody>
@@ -2762,7 +2762,7 @@
                 <a:ea typeface="Helvetica Neue"/>
                 <a:sym typeface="Helvetica Neue"/>
               </a:rPr>
-              <a:t>Unique samples = n_distinct(sampleid) · substances from lab_detail.substance · includes samples with date_complete 26 Jan 2022 – 22 Sep 2026</a:t>
+              <a:t>Unique samples = n_distinct(sampleid) · substances from lab_detail.substance · includes samples with date_complete 26 Jan 2022 – 24 Sep 2026</a:t>
             </a:r>
           </a:p>
         </p:txBody>
@@ -3184,7 +3184,7 @@
                 <a:ea typeface="Helvetica Neue"/>
                 <a:sym typeface="Helvetica Neue"/>
               </a:rPr>
-              <a:t>County = samplecounty · left: ≥1 completed analysis ever · right: unique samples per county (sqrt color scale) · all time: 26 Jan 2022 – 22 Sep 2026 · last 12 months: 24 Sep 2025 – 22 Sep 2026* · coverage reflects participation, not prevalence</a:t>
+              <a:t>County = samplecounty · left: ≥1 completed analysis ever · right: unique samples per county (sqrt color scale) · all time: 26 Jan 2022 – 24 Sep 2026 · last 12 months: 25 Sep 2025 – 24 Sep 2026* · coverage reflects participation, not prevalence</a:t>
             </a:r>
           </a:p>
         </p:txBody>
@@ -3505,7 +3505,7 @@
                 <a:ea typeface="Helvetica Neue"/>
                 <a:sym typeface="Helvetica Neue"/>
               </a:rPr>
-              <a:t>expectedsubstance (verbatim card write-in, semicolon lists split) · derived flags: expect_opioid, expect_fentanyl, expect_meth, expect_cocaine, expect_stimulant… · includes samples with date_complete 26 Jan 2022 – 22 Sep 2026 · data table: Appendix A2</a:t>
+              <a:t>expectedsubstance (verbatim card write-in, semicolon lists split) · derived flags: expect_opioid, expect_fentanyl, expect_meth, expect_cocaine, expect_stimulant… · includes samples with date_complete 26 Jan 2022 – 24 Sep 2026 · data table: Appendix A2</a:t>
             </a:r>
           </a:p>
         </p:txBody>
@@ -3703,7 +3703,7 @@
                 <a:ea typeface="Helvetica Neue"/>
                 <a:sym typeface="Helvetica Neue"/>
               </a:rPr>
-              <a:t>Numerator uses lab_*_any (primary or trace) among samples with expect_* = 1 · includes samples with date_complete 26 Jan 2022 – 22 Sep 2026 · data table: Appendix A3</a:t>
+              <a:t>Numerator uses lab_*_any (primary or trace) among samples with expect_* = 1 · includes samples with date_complete 26 Jan 2022 – 24 Sep 2026 · data table: Appendix A3</a:t>
             </a:r>
           </a:p>
         </p:txBody>
@@ -3901,7 +3901,7 @@
                 <a:ea typeface="Helvetica Neue"/>
                 <a:sym typeface="Helvetica Neue"/>
               </a:rPr>
-              <a:t>sensations (circled on card, semicolon lists split) · post-consumption samples only (consumed = 1) · includes samples with date_complete 26 Jan 2022 – 22 Sep 2026</a:t>
+              <a:t>sensations (circled on card, semicolon lists split) · post-consumption samples only (consumed = 1) · includes samples with date_complete 26 Jan 2022 – 24 Sep 2026</a:t>
             </a:r>
           </a:p>
         </p:txBody>
@@ -4125,7 +4125,7 @@
                 <a:ea typeface="Helvetica Neue"/>
                 <a:sym typeface="Helvetica Neue"/>
               </a:rPr>
-              <a:t>sensations semicolon lists parsed per report · consumed = 1 only · denominator: consumed samples with lab_*_any = 1 · includes samples with date_complete 26 Jan 2022 – 22 Sep 2026</a:t>
+              <a:t>sensations semicolon lists parsed per report · consumed = 1 only · denominator: consumed samples with lab_*_any = 1 · includes samples with date_complete 26 Jan 2022 – 24 Sep 2026</a:t>
             </a:r>
           </a:p>
         </p:txBody>
@@ -4323,7 +4323,7 @@
                 <a:ea typeface="Helvetica Neue"/>
                 <a:sym typeface="Helvetica Neue"/>
               </a:rPr>
-              <a:t>Samples with methamphetamine or cocaine detected (any abundance); samples in both classes appear on both slides · sensations semicolon lists parsed + sen_strength (own denominator) · consumed = 1 only · before: 26 Jan 2022 – 22 Sep 2025 · past 12 months: 24 Sep 2025 – 22 Sep 2026* · Δ in percentage points</a:t>
+              <a:t>Samples with methamphetamine or cocaine detected (any abundance); samples in both classes appear on both slides · sensations semicolon lists parsed + sen_strength (own denominator) · consumed = 1 only · before: 26 Jan 2022 – 24 Sep 2025 · past 12 months: 25 Sep 2025 – 24 Sep 2026* · Δ in percentage points</a:t>
             </a:r>
           </a:p>
         </p:txBody>
@@ -4742,7 +4742,7 @@
                 <a:ea typeface="Helvetica Neue"/>
                 <a:sym typeface="Helvetica Neue"/>
               </a:rPr>
-              <a:t>Samples with an opioid (fentanyl, heroin) or benzodiazepine detected (any abundance); samples in both classes appear on both slides · sensations semicolon lists parsed + sen_strength (own denominator) · consumed = 1 only · before: 26 Jan 2022 – 22 Sep 2025 · past 12 months: 24 Sep 2025 – 22 Sep 2026* · Δ in percentage points</a:t>
+              <a:t>Samples with an opioid (fentanyl, heroin) or benzodiazepine detected (any abundance); samples in both classes appear on both slides · sensations semicolon lists parsed + sen_strength (own denominator) · consumed = 1 only · before: 26 Jan 2022 – 24 Sep 2025 · past 12 months: 25 Sep 2025 – 24 Sep 2026* · Δ in percentage points</a:t>
             </a:r>
           </a:p>
         </p:txBody>
@@ -5138,7 +5138,7 @@
                 <a:ea typeface="Helvetica Neue"/>
                 <a:sym typeface="Helvetica Neue"/>
               </a:rPr>
-              <a:t>color, texture (card v3+, semicolon lists split) · derived: bright_color excludes white/tan/brown family — orange bar above · includes samples with date_complete 26 Jan 2022 – 22 Sep 2026</a:t>
+              <a:t>color, texture (card v3+, semicolon lists split) · derived: bright_color excludes white/tan/brown family — orange bar above · includes samples with date_complete 26 Jan 2022 – 24 Sep 2026</a:t>
             </a:r>
           </a:p>
         </p:txBody>
@@ -5459,7 +5459,7 @@
                 <a:ea typeface="Helvetica Neue"/>
                 <a:sym typeface="Helvetica Neue"/>
               </a:rPr>
-              <a:t>Distribution of substances detected per sample, both definitions shown side by side · includes samples with date_complete 26 Jan 2022 – 22 Sep 2026</a:t>
+              <a:t>Distribution of substances detected per sample, both definitions shown side by side · includes samples with date_complete 26 Jan 2022 – 24 Sep 2026</a:t>
             </a:r>
           </a:p>
         </p:txBody>
@@ -5657,7 +5657,7 @@
                 <a:ea typeface="Helvetica Neue"/>
                 <a:sym typeface="Helvetica Neue"/>
               </a:rPr>
-              <a:t>lab_detail.substance counts · solid = primary abundance, light = trace · standardized names (PubChem-linked) · includes samples with date_complete 26 Jan 2022 – 22 Sep 2026</a:t>
+              <a:t>lab_detail.substance counts · solid = primary abundance, light = trace · standardized names (PubChem-linked) · includes samples with date_complete 26 Jan 2022 – 24 Sep 2026</a:t>
             </a:r>
           </a:p>
         </p:txBody>
@@ -5855,7 +5855,7 @@
                 <a:ea typeface="Helvetica Neue"/>
                 <a:sym typeface="Helvetica Neue"/>
               </a:rPr>
-              <a:t>lab_detail.substance counts · solid = primary abundance, light = trace · standardized names (PubChem-linked) · window: date_complete 24 Sep 2025 – 22 Sep 2026* (trailing 12 months, current month partial)</a:t>
+              <a:t>lab_detail.substance counts · solid = primary abundance, light = trace · standardized names (PubChem-linked) · window: date_complete 25 Sep 2025 – 24 Sep 2026* (trailing 12 months, current month partial)</a:t>
             </a:r>
           </a:p>
         </p:txBody>
@@ -6053,7 +6053,7 @@
                 <a:ea typeface="Helvetica Neue"/>
                 <a:sym typeface="Helvetica Neue"/>
               </a:rPr>
-              <a:t>Distribution of substances detected per sample, both definitions shown side by side · window: date_complete 24 Sep 2025 – 22 Sep 2026* (trailing 12 months, current month partial)</a:t>
+              <a:t>Distribution of substances detected per sample, both definitions shown side by side · window: date_complete 25 Sep 2025 – 24 Sep 2026* (trailing 12 months, current month partial)</a:t>
             </a:r>
           </a:p>
         </p:txBody>
@@ -18510,7 +18510,7 @@
                           <a:ea typeface="Helvetica Neue"/>
                           <a:sym typeface="Helvetica Neue"/>
                         </a:rPr>
-                        <a:t>1,474</a:t>
+                        <a:t>1,478</a:t>
                       </a:r>
                     </a:p>
                   </a:txBody>
@@ -18626,7 +18626,7 @@
                           <a:ea typeface="Helvetica Neue"/>
                           <a:sym typeface="Helvetica Neue"/>
                         </a:rPr>
-                        <a:t>443</a:t>
+                        <a:t>448</a:t>
                       </a:r>
                     </a:p>
                   </a:txBody>
@@ -18974,7 +18974,7 @@
                           <a:ea typeface="Helvetica Neue"/>
                           <a:sym typeface="Helvetica Neue"/>
                         </a:rPr>
-                        <a:t>159</a:t>
+                        <a:t>160</a:t>
                       </a:r>
                     </a:p>
                   </a:txBody>
@@ -19322,7 +19322,7 @@
                           <a:ea typeface="Helvetica Neue"/>
                           <a:sym typeface="Helvetica Neue"/>
                         </a:rPr>
-                        <a:t>61</a:t>
+                        <a:t>63</a:t>
                       </a:r>
                     </a:p>
                   </a:txBody>
@@ -19438,7 +19438,7 @@
                           <a:ea typeface="Helvetica Neue"/>
                           <a:sym typeface="Helvetica Neue"/>
                         </a:rPr>
-                        <a:t>57</a:t>
+                        <a:t>58</a:t>
                       </a:r>
                     </a:p>
                   </a:txBody>
@@ -20591,7 +20591,7 @@
                           <a:ea typeface="Helvetica Neue"/>
                           <a:sym typeface="Helvetica Neue"/>
                         </a:rPr>
-                        <a:t>1,703</a:t>
+                        <a:t>1,711</a:t>
                       </a:r>
                     </a:p>
                   </a:txBody>
@@ -20821,7 +20821,7 @@
                           <a:ea typeface="Helvetica Neue"/>
                           <a:sym typeface="Helvetica Neue"/>
                         </a:rPr>
-                        <a:t>514</a:t>
+                        <a:t>521</a:t>
                       </a:r>
                     </a:p>
                   </a:txBody>
@@ -21515,7 +21515,7 @@
                           <a:ea typeface="Helvetica Neue"/>
                           <a:sym typeface="Helvetica Neue"/>
                         </a:rPr>
-                        <a:t>362</a:t>
+                        <a:t>365</a:t>
                       </a:r>
                     </a:p>
                   </a:txBody>

</xml_diff>

<commit_message>
nightly deck: data through 2026-09-26
</commit_message>
<xml_diff>
--- a/docs/nc-drug-checking-latest.pptx
+++ b/docs/nc-drug-checking-latest.pptx
@@ -2418,7 +2418,7 @@
                 <a:ea typeface="Helvetica Neue"/>
                 <a:sym typeface="Helvetica Neue"/>
               </a:rPr>
-              <a:t>Generated Friday, September 25, 2026 · 8:52 AM ET UNC Street Drug Analysis Lab · OpioidData.org · results.streetsafe.supply Download as PowerPoint</a:t>
+              <a:t>Generated Saturday, September 26, 2026 · 8:20 AM ET UNC Street Drug Analysis Lab · OpioidData.org · results.streetsafe.supply Download as PowerPoint</a:t>
             </a:r>
           </a:p>
         </p:txBody>
@@ -2713,7 +2713,7 @@
                 <a:ea typeface="Helvetica Neue"/>
                 <a:sym typeface="Helvetica Neue"/>
               </a:rPr>
-              <a:t>PLACEHOLDER · figs/stats.json January 2022 to Thursday, September 24, 2026 N = 2,888 NC samples analyzed Mailed in from 86 harm reduction programs Collected across 59 counties 247 distinct substances detected to date Unique samples = n_distinct(sampleid) · substances from lab_detail.substance · includes samples with date_complete 26 Jan 2022 – 24 Sep 2026 r/build_nightly.R → figs/stats.json</a:t>
+              <a:t>PLACEHOLDER · figs/stats.json January 2022 to Friday, September 25, 2026 N = 2,913 NC samples analyzed Mailed in from 86 harm reduction programs Collected across 59 counties 247 distinct substances detected to date Unique samples = n_distinct(sampleid) · substances from lab_detail.substance · includes samples with date_complete 26 Jan 2022 – 25 Sep 2026 r/build_nightly.R → figs/stats.json</a:t>
             </a:r>
           </a:p>
         </p:txBody>
@@ -2762,7 +2762,7 @@
                 <a:ea typeface="Helvetica Neue"/>
                 <a:sym typeface="Helvetica Neue"/>
               </a:rPr>
-              <a:t>Unique samples = n_distinct(sampleid) · substances from lab_detail.substance · includes samples with date_complete 26 Jan 2022 – 24 Sep 2026</a:t>
+              <a:t>Unique samples = n_distinct(sampleid) · substances from lab_detail.substance · includes samples with date_complete 26 Jan 2022 – 25 Sep 2026</a:t>
             </a:r>
           </a:p>
         </p:txBody>
@@ -3184,7 +3184,7 @@
                 <a:ea typeface="Helvetica Neue"/>
                 <a:sym typeface="Helvetica Neue"/>
               </a:rPr>
-              <a:t>County = samplecounty · left: ≥1 completed analysis ever · right: unique samples per county (sqrt color scale) · all time: 26 Jan 2022 – 24 Sep 2026 · last 12 months: 25 Sep 2025 – 24 Sep 2026* · coverage reflects participation, not prevalence</a:t>
+              <a:t>County = samplecounty · left: ≥1 completed analysis ever · right: unique samples per county (sqrt color scale) · all time: 26 Jan 2022 – 25 Sep 2026 · last 12 months: 26 Sep 2025 – 25 Sep 2026* · coverage reflects participation, not prevalence</a:t>
             </a:r>
           </a:p>
         </p:txBody>
@@ -3505,7 +3505,7 @@
                 <a:ea typeface="Helvetica Neue"/>
                 <a:sym typeface="Helvetica Neue"/>
               </a:rPr>
-              <a:t>expectedsubstance (verbatim card write-in, semicolon lists split) · derived flags: expect_opioid, expect_fentanyl, expect_meth, expect_cocaine, expect_stimulant… · includes samples with date_complete 26 Jan 2022 – 24 Sep 2026 · data table: Appendix A2</a:t>
+              <a:t>expectedsubstance (verbatim card write-in, semicolon lists split) · derived flags: expect_opioid, expect_fentanyl, expect_meth, expect_cocaine, expect_stimulant… · includes samples with date_complete 26 Jan 2022 – 25 Sep 2026 · data table: Appendix A2</a:t>
             </a:r>
           </a:p>
         </p:txBody>
@@ -3703,7 +3703,7 @@
                 <a:ea typeface="Helvetica Neue"/>
                 <a:sym typeface="Helvetica Neue"/>
               </a:rPr>
-              <a:t>Numerator uses lab_*_any (primary or trace) among samples with expect_* = 1 · includes samples with date_complete 26 Jan 2022 – 24 Sep 2026 · data table: Appendix A3</a:t>
+              <a:t>Numerator uses lab_*_any (primary or trace) among samples with expect_* = 1 · includes samples with date_complete 26 Jan 2022 – 25 Sep 2026 · data table: Appendix A3</a:t>
             </a:r>
           </a:p>
         </p:txBody>
@@ -3901,7 +3901,7 @@
                 <a:ea typeface="Helvetica Neue"/>
                 <a:sym typeface="Helvetica Neue"/>
               </a:rPr>
-              <a:t>sensations (circled on card, semicolon lists split) · post-consumption samples only (consumed = 1) · includes samples with date_complete 26 Jan 2022 – 24 Sep 2026</a:t>
+              <a:t>sensations (circled on card, semicolon lists split) · post-consumption samples only (consumed = 1) · includes samples with date_complete 26 Jan 2022 – 25 Sep 2026</a:t>
             </a:r>
           </a:p>
         </p:txBody>
@@ -4125,7 +4125,7 @@
                 <a:ea typeface="Helvetica Neue"/>
                 <a:sym typeface="Helvetica Neue"/>
               </a:rPr>
-              <a:t>sensations semicolon lists parsed per report · consumed = 1 only · denominator: consumed samples with lab_*_any = 1 · includes samples with date_complete 26 Jan 2022 – 24 Sep 2026</a:t>
+              <a:t>sensations semicolon lists parsed per report · consumed = 1 only · denominator: consumed samples with lab_*_any = 1 · includes samples with date_complete 26 Jan 2022 – 25 Sep 2026</a:t>
             </a:r>
           </a:p>
         </p:txBody>
@@ -4323,7 +4323,7 @@
                 <a:ea typeface="Helvetica Neue"/>
                 <a:sym typeface="Helvetica Neue"/>
               </a:rPr>
-              <a:t>Samples with methamphetamine or cocaine detected (any abundance); samples in both classes appear on both slides · sensations semicolon lists parsed + sen_strength (own denominator) · consumed = 1 only · before: 26 Jan 2022 – 24 Sep 2025 · past 12 months: 25 Sep 2025 – 24 Sep 2026* · Δ in percentage points</a:t>
+              <a:t>Samples with methamphetamine or cocaine detected (any abundance); samples in both classes appear on both slides · sensations semicolon lists parsed + sen_strength (own denominator) · consumed = 1 only · before: 26 Jan 2022 – 25 Sep 2025 · past 12 months: 26 Sep 2025 – 25 Sep 2026* · Δ in percentage points</a:t>
             </a:r>
           </a:p>
         </p:txBody>
@@ -4742,7 +4742,7 @@
                 <a:ea typeface="Helvetica Neue"/>
                 <a:sym typeface="Helvetica Neue"/>
               </a:rPr>
-              <a:t>Samples with an opioid (fentanyl, heroin) or benzodiazepine detected (any abundance); samples in both classes appear on both slides · sensations semicolon lists parsed + sen_strength (own denominator) · consumed = 1 only · before: 26 Jan 2022 – 24 Sep 2025 · past 12 months: 25 Sep 2025 – 24 Sep 2026* · Δ in percentage points</a:t>
+              <a:t>Samples with an opioid (fentanyl, heroin) or benzodiazepine detected (any abundance); samples in both classes appear on both slides · sensations semicolon lists parsed + sen_strength (own denominator) · consumed = 1 only · before: 26 Jan 2022 – 25 Sep 2025 · past 12 months: 26 Sep 2025 – 25 Sep 2026* · Δ in percentage points</a:t>
             </a:r>
           </a:p>
         </p:txBody>
@@ -5138,7 +5138,7 @@
                 <a:ea typeface="Helvetica Neue"/>
                 <a:sym typeface="Helvetica Neue"/>
               </a:rPr>
-              <a:t>color, texture (card v3+, semicolon lists split) · derived: bright_color excludes white/tan/brown family — orange bar above · includes samples with date_complete 26 Jan 2022 – 24 Sep 2026</a:t>
+              <a:t>color, texture (card v3+, semicolon lists split) · derived: bright_color excludes white/tan/brown family — orange bar above · includes samples with date_complete 26 Jan 2022 – 25 Sep 2026</a:t>
             </a:r>
           </a:p>
         </p:txBody>
@@ -5459,7 +5459,7 @@
                 <a:ea typeface="Helvetica Neue"/>
                 <a:sym typeface="Helvetica Neue"/>
               </a:rPr>
-              <a:t>Distribution of substances detected per sample, both definitions shown side by side · includes samples with date_complete 26 Jan 2022 – 24 Sep 2026</a:t>
+              <a:t>Distribution of substances detected per sample, both definitions shown side by side · includes samples with date_complete 26 Jan 2022 – 25 Sep 2026</a:t>
             </a:r>
           </a:p>
         </p:txBody>
@@ -5657,7 +5657,7 @@
                 <a:ea typeface="Helvetica Neue"/>
                 <a:sym typeface="Helvetica Neue"/>
               </a:rPr>
-              <a:t>lab_detail.substance counts · solid = primary abundance, light = trace · standardized names (PubChem-linked) · includes samples with date_complete 26 Jan 2022 – 24 Sep 2026</a:t>
+              <a:t>lab_detail.substance counts · solid = primary abundance, light = trace · standardized names (PubChem-linked) · includes samples with date_complete 26 Jan 2022 – 25 Sep 2026</a:t>
             </a:r>
           </a:p>
         </p:txBody>
@@ -5855,7 +5855,7 @@
                 <a:ea typeface="Helvetica Neue"/>
                 <a:sym typeface="Helvetica Neue"/>
               </a:rPr>
-              <a:t>lab_detail.substance counts · solid = primary abundance, light = trace · standardized names (PubChem-linked) · window: date_complete 25 Sep 2025 – 24 Sep 2026* (trailing 12 months, current month partial)</a:t>
+              <a:t>lab_detail.substance counts · solid = primary abundance, light = trace · standardized names (PubChem-linked) · window: date_complete 26 Sep 2025 – 25 Sep 2026* (trailing 12 months, current month partial)</a:t>
             </a:r>
           </a:p>
         </p:txBody>
@@ -6053,7 +6053,7 @@
                 <a:ea typeface="Helvetica Neue"/>
                 <a:sym typeface="Helvetica Neue"/>
               </a:rPr>
-              <a:t>Distribution of substances detected per sample, both definitions shown side by side · window: date_complete 25 Sep 2025 – 24 Sep 2026* (trailing 12 months, current month partial)</a:t>
+              <a:t>Distribution of substances detected per sample, both definitions shown side by side · window: date_complete 26 Sep 2025 – 25 Sep 2026* (trailing 12 months, current month partial)</a:t>
             </a:r>
           </a:p>
         </p:txBody>
@@ -18510,7 +18510,7 @@
                           <a:ea typeface="Helvetica Neue"/>
                           <a:sym typeface="Helvetica Neue"/>
                         </a:rPr>
-                        <a:t>1,478</a:t>
+                        <a:t>1,499</a:t>
                       </a:r>
                     </a:p>
                   </a:txBody>
@@ -18974,7 +18974,7 @@
                           <a:ea typeface="Helvetica Neue"/>
                           <a:sym typeface="Helvetica Neue"/>
                         </a:rPr>
-                        <a:t>160</a:t>
+                        <a:t>162</a:t>
                       </a:r>
                     </a:p>
                   </a:txBody>
@@ -19438,7 +19438,7 @@
                           <a:ea typeface="Helvetica Neue"/>
                           <a:sym typeface="Helvetica Neue"/>
                         </a:rPr>
-                        <a:t>58</a:t>
+                        <a:t>59</a:t>
                       </a:r>
                     </a:p>
                   </a:txBody>
@@ -20591,7 +20591,7 @@
                           <a:ea typeface="Helvetica Neue"/>
                           <a:sym typeface="Helvetica Neue"/>
                         </a:rPr>
-                        <a:t>1,711</a:t>
+                        <a:t>1,734</a:t>
                       </a:r>
                     </a:p>
                   </a:txBody>
@@ -20821,7 +20821,7 @@
                           <a:ea typeface="Helvetica Neue"/>
                           <a:sym typeface="Helvetica Neue"/>
                         </a:rPr>
-                        <a:t>521</a:t>
+                        <a:t>522</a:t>
                       </a:r>
                     </a:p>
                   </a:txBody>
@@ -21051,7 +21051,7 @@
                           <a:ea typeface="Helvetica Neue"/>
                           <a:sym typeface="Helvetica Neue"/>
                         </a:rPr>
-                        <a:t>141</a:t>
+                        <a:t>142</a:t>
                       </a:r>
                     </a:p>
                   </a:txBody>

</xml_diff>

<commit_message>
nightly deck: data through 2026-09-27
</commit_message>
<xml_diff>
--- a/docs/nc-drug-checking-latest.pptx
+++ b/docs/nc-drug-checking-latest.pptx
@@ -2418,7 +2418,7 @@
                 <a:ea typeface="Helvetica Neue"/>
                 <a:sym typeface="Helvetica Neue"/>
               </a:rPr>
-              <a:t>Generated Saturday, September 26, 2026 · 8:20 AM ET UNC Street Drug Analysis Lab · OpioidData.org · results.streetsafe.supply Download as PowerPoint</a:t>
+              <a:t>Generated Sunday, September 27, 2026 · 9:11 AM ET UNC Street Drug Analysis Lab · OpioidData.org · results.streetsafe.supply Download as PowerPoint</a:t>
             </a:r>
           </a:p>
         </p:txBody>
@@ -3184,7 +3184,7 @@
                 <a:ea typeface="Helvetica Neue"/>
                 <a:sym typeface="Helvetica Neue"/>
               </a:rPr>
-              <a:t>County = samplecounty · left: ≥1 completed analysis ever · right: unique samples per county (sqrt color scale) · all time: 26 Jan 2022 – 25 Sep 2026 · last 12 months: 26 Sep 2025 – 25 Sep 2026* · coverage reflects participation, not prevalence</a:t>
+              <a:t>County = samplecounty · left: ≥1 completed analysis ever · right: unique samples per county (sqrt color scale) · all time: 26 Jan 2022 – 25 Sep 2026 · last 12 months: 27 Sep 2025 – 25 Sep 2026* · coverage reflects participation, not prevalence</a:t>
             </a:r>
           </a:p>
         </p:txBody>
@@ -4323,7 +4323,7 @@
                 <a:ea typeface="Helvetica Neue"/>
                 <a:sym typeface="Helvetica Neue"/>
               </a:rPr>
-              <a:t>Samples with methamphetamine or cocaine detected (any abundance); samples in both classes appear on both slides · sensations semicolon lists parsed + sen_strength (own denominator) · consumed = 1 only · before: 26 Jan 2022 – 25 Sep 2025 · past 12 months: 26 Sep 2025 – 25 Sep 2026* · Δ in percentage points</a:t>
+              <a:t>Samples with methamphetamine or cocaine detected (any abundance); samples in both classes appear on both slides · sensations semicolon lists parsed + sen_strength (own denominator) · consumed = 1 only · before: 26 Jan 2022 – 25 Sep 2025 · past 12 months: 27 Sep 2025 – 25 Sep 2026* · Δ in percentage points</a:t>
             </a:r>
           </a:p>
         </p:txBody>
@@ -4742,7 +4742,7 @@
                 <a:ea typeface="Helvetica Neue"/>
                 <a:sym typeface="Helvetica Neue"/>
               </a:rPr>
-              <a:t>Samples with an opioid (fentanyl, heroin) or benzodiazepine detected (any abundance); samples in both classes appear on both slides · sensations semicolon lists parsed + sen_strength (own denominator) · consumed = 1 only · before: 26 Jan 2022 – 25 Sep 2025 · past 12 months: 26 Sep 2025 – 25 Sep 2026* · Δ in percentage points</a:t>
+              <a:t>Samples with an opioid (fentanyl, heroin) or benzodiazepine detected (any abundance); samples in both classes appear on both slides · sensations semicolon lists parsed + sen_strength (own denominator) · consumed = 1 only · before: 26 Jan 2022 – 25 Sep 2025 · past 12 months: 27 Sep 2025 – 25 Sep 2026* · Δ in percentage points</a:t>
             </a:r>
           </a:p>
         </p:txBody>
@@ -5855,7 +5855,7 @@
                 <a:ea typeface="Helvetica Neue"/>
                 <a:sym typeface="Helvetica Neue"/>
               </a:rPr>
-              <a:t>lab_detail.substance counts · solid = primary abundance, light = trace · standardized names (PubChem-linked) · window: date_complete 26 Sep 2025 – 25 Sep 2026* (trailing 12 months, current month partial)</a:t>
+              <a:t>lab_detail.substance counts · solid = primary abundance, light = trace · standardized names (PubChem-linked) · window: date_complete 27 Sep 2025 – 25 Sep 2026* (trailing 12 months, current month partial)</a:t>
             </a:r>
           </a:p>
         </p:txBody>
@@ -6053,7 +6053,7 @@
                 <a:ea typeface="Helvetica Neue"/>
                 <a:sym typeface="Helvetica Neue"/>
               </a:rPr>
-              <a:t>Distribution of substances detected per sample, both definitions shown side by side · window: date_complete 26 Sep 2025 – 25 Sep 2026* (trailing 12 months, current month partial)</a:t>
+              <a:t>Distribution of substances detected per sample, both definitions shown side by side · window: date_complete 27 Sep 2025 – 25 Sep 2026* (trailing 12 months, current month partial)</a:t>
             </a:r>
           </a:p>
         </p:txBody>

</xml_diff>

<commit_message>
nightly deck: data through 2026-09-28
</commit_message>
<xml_diff>
--- a/docs/nc-drug-checking-latest.pptx
+++ b/docs/nc-drug-checking-latest.pptx
@@ -2418,7 +2418,7 @@
                 <a:ea typeface="Helvetica Neue"/>
                 <a:sym typeface="Helvetica Neue"/>
               </a:rPr>
-              <a:t>Generated Sunday, September 27, 2026 · 9:11 AM ET UNC Street Drug Analysis Lab · OpioidData.org · results.streetsafe.supply Download as PowerPoint</a:t>
+              <a:t>Generated Monday, September 28, 2026 · 11:43 AM ET UNC Street Drug Analysis Lab · OpioidData.org · results.streetsafe.supply Download as PowerPoint</a:t>
             </a:r>
           </a:p>
         </p:txBody>
@@ -3184,7 +3184,7 @@
                 <a:ea typeface="Helvetica Neue"/>
                 <a:sym typeface="Helvetica Neue"/>
               </a:rPr>
-              <a:t>County = samplecounty · left: ≥1 completed analysis ever · right: unique samples per county (sqrt color scale) · all time: 26 Jan 2022 – 25 Sep 2026 · last 12 months: 27 Sep 2025 – 25 Sep 2026* · coverage reflects participation, not prevalence</a:t>
+              <a:t>County = samplecounty · left: ≥1 completed analysis ever · right: unique samples per county (sqrt color scale) · all time: 26 Jan 2022 – 25 Sep 2026 · last 12 months: 28 Sep 2025 – 25 Sep 2026* · coverage reflects participation, not prevalence</a:t>
             </a:r>
           </a:p>
         </p:txBody>
@@ -4323,7 +4323,7 @@
                 <a:ea typeface="Helvetica Neue"/>
                 <a:sym typeface="Helvetica Neue"/>
               </a:rPr>
-              <a:t>Samples with methamphetamine or cocaine detected (any abundance); samples in both classes appear on both slides · sensations semicolon lists parsed + sen_strength (own denominator) · consumed = 1 only · before: 26 Jan 2022 – 25 Sep 2025 · past 12 months: 27 Sep 2025 – 25 Sep 2026* · Δ in percentage points</a:t>
+              <a:t>Samples with methamphetamine or cocaine detected (any abundance); samples in both classes appear on both slides · sensations semicolon lists parsed + sen_strength (own denominator) · consumed = 1 only · before: 26 Jan 2022 – 25 Sep 2025 · past 12 months: 28 Sep 2025 – 25 Sep 2026* · Δ in percentage points</a:t>
             </a:r>
           </a:p>
         </p:txBody>
@@ -4742,7 +4742,7 @@
                 <a:ea typeface="Helvetica Neue"/>
                 <a:sym typeface="Helvetica Neue"/>
               </a:rPr>
-              <a:t>Samples with an opioid (fentanyl, heroin) or benzodiazepine detected (any abundance); samples in both classes appear on both slides · sensations semicolon lists parsed + sen_strength (own denominator) · consumed = 1 only · before: 26 Jan 2022 – 25 Sep 2025 · past 12 months: 27 Sep 2025 – 25 Sep 2026* · Δ in percentage points</a:t>
+              <a:t>Samples with an opioid (fentanyl, heroin) or benzodiazepine detected (any abundance); samples in both classes appear on both slides · sensations semicolon lists parsed + sen_strength (own denominator) · consumed = 1 only · before: 26 Jan 2022 – 25 Sep 2025 · past 12 months: 28 Sep 2025 – 25 Sep 2026* · Δ in percentage points</a:t>
             </a:r>
           </a:p>
         </p:txBody>
@@ -5855,7 +5855,7 @@
                 <a:ea typeface="Helvetica Neue"/>
                 <a:sym typeface="Helvetica Neue"/>
               </a:rPr>
-              <a:t>lab_detail.substance counts · solid = primary abundance, light = trace · standardized names (PubChem-linked) · window: date_complete 27 Sep 2025 – 25 Sep 2026* (trailing 12 months, current month partial)</a:t>
+              <a:t>lab_detail.substance counts · solid = primary abundance, light = trace · standardized names (PubChem-linked) · window: date_complete 28 Sep 2025 – 25 Sep 2026* (trailing 12 months, current month partial)</a:t>
             </a:r>
           </a:p>
         </p:txBody>
@@ -6053,7 +6053,7 @@
                 <a:ea typeface="Helvetica Neue"/>
                 <a:sym typeface="Helvetica Neue"/>
               </a:rPr>
-              <a:t>Distribution of substances detected per sample, both definitions shown side by side · window: date_complete 27 Sep 2025 – 25 Sep 2026* (trailing 12 months, current month partial)</a:t>
+              <a:t>Distribution of substances detected per sample, both definitions shown side by side · window: date_complete 28 Sep 2025 – 25 Sep 2026* (trailing 12 months, current month partial)</a:t>
             </a:r>
           </a:p>
         </p:txBody>

</xml_diff>

<commit_message>
nightly deck: data through 2026-09-29
</commit_message>
<xml_diff>
--- a/docs/nc-drug-checking-latest.pptx
+++ b/docs/nc-drug-checking-latest.pptx
@@ -2418,7 +2418,7 @@
                 <a:ea typeface="Helvetica Neue"/>
                 <a:sym typeface="Helvetica Neue"/>
               </a:rPr>
-              <a:t>Generated Monday, September 28, 2026 · 11:43 AM ET UNC Street Drug Analysis Lab · OpioidData.org · results.streetsafe.supply Download as PowerPoint</a:t>
+              <a:t>Generated Tuesday, September 29, 2026 · 10:11 AM ET UNC Street Drug Analysis Lab · OpioidData.org · results.streetsafe.supply Download as PowerPoint</a:t>
             </a:r>
           </a:p>
         </p:txBody>
@@ -3184,7 +3184,7 @@
                 <a:ea typeface="Helvetica Neue"/>
                 <a:sym typeface="Helvetica Neue"/>
               </a:rPr>
-              <a:t>County = samplecounty · left: ≥1 completed analysis ever · right: unique samples per county (sqrt color scale) · all time: 26 Jan 2022 – 25 Sep 2026 · last 12 months: 28 Sep 2025 – 25 Sep 2026* · coverage reflects participation, not prevalence</a:t>
+              <a:t>County = samplecounty · left: ≥1 completed analysis ever · right: unique samples per county (sqrt color scale) · all time: 26 Jan 2022 – 25 Sep 2026 · last 12 months: 29 Sep 2025 – 25 Sep 2026* · coverage reflects participation, not prevalence</a:t>
             </a:r>
           </a:p>
         </p:txBody>
@@ -4323,7 +4323,7 @@
                 <a:ea typeface="Helvetica Neue"/>
                 <a:sym typeface="Helvetica Neue"/>
               </a:rPr>
-              <a:t>Samples with methamphetamine or cocaine detected (any abundance); samples in both classes appear on both slides · sensations semicolon lists parsed + sen_strength (own denominator) · consumed = 1 only · before: 26 Jan 2022 – 25 Sep 2025 · past 12 months: 28 Sep 2025 – 25 Sep 2026* · Δ in percentage points</a:t>
+              <a:t>Samples with methamphetamine or cocaine detected (any abundance); samples in both classes appear on both slides · sensations semicolon lists parsed + sen_strength (own denominator) · consumed = 1 only · before: 26 Jan 2022 – 25 Sep 2025 · past 12 months: 29 Sep 2025 – 25 Sep 2026* · Δ in percentage points</a:t>
             </a:r>
           </a:p>
         </p:txBody>
@@ -4742,7 +4742,7 @@
                 <a:ea typeface="Helvetica Neue"/>
                 <a:sym typeface="Helvetica Neue"/>
               </a:rPr>
-              <a:t>Samples with an opioid (fentanyl, heroin) or benzodiazepine detected (any abundance); samples in both classes appear on both slides · sensations semicolon lists parsed + sen_strength (own denominator) · consumed = 1 only · before: 26 Jan 2022 – 25 Sep 2025 · past 12 months: 28 Sep 2025 – 25 Sep 2026* · Δ in percentage points</a:t>
+              <a:t>Samples with an opioid (fentanyl, heroin) or benzodiazepine detected (any abundance); samples in both classes appear on both slides · sensations semicolon lists parsed + sen_strength (own denominator) · consumed = 1 only · before: 26 Jan 2022 – 25 Sep 2025 · past 12 months: 29 Sep 2025 – 25 Sep 2026* · Δ in percentage points</a:t>
             </a:r>
           </a:p>
         </p:txBody>
@@ -5855,7 +5855,7 @@
                 <a:ea typeface="Helvetica Neue"/>
                 <a:sym typeface="Helvetica Neue"/>
               </a:rPr>
-              <a:t>lab_detail.substance counts · solid = primary abundance, light = trace · standardized names (PubChem-linked) · window: date_complete 28 Sep 2025 – 25 Sep 2026* (trailing 12 months, current month partial)</a:t>
+              <a:t>lab_detail.substance counts · solid = primary abundance, light = trace · standardized names (PubChem-linked) · window: date_complete 29 Sep 2025 – 25 Sep 2026* (trailing 12 months, current month partial)</a:t>
             </a:r>
           </a:p>
         </p:txBody>
@@ -6053,7 +6053,7 @@
                 <a:ea typeface="Helvetica Neue"/>
                 <a:sym typeface="Helvetica Neue"/>
               </a:rPr>
-              <a:t>Distribution of substances detected per sample, both definitions shown side by side · window: date_complete 28 Sep 2025 – 25 Sep 2026* (trailing 12 months, current month partial)</a:t>
+              <a:t>Distribution of substances detected per sample, both definitions shown side by side · window: date_complete 29 Sep 2025 – 25 Sep 2026* (trailing 12 months, current month partial)</a:t>
             </a:r>
           </a:p>
         </p:txBody>

</xml_diff>

<commit_message>
nightly deck: data through 2026-10-01
</commit_message>
<xml_diff>
--- a/docs/nc-drug-checking-latest.pptx
+++ b/docs/nc-drug-checking-latest.pptx
@@ -2418,7 +2418,7 @@
                 <a:ea typeface="Helvetica Neue"/>
                 <a:sym typeface="Helvetica Neue"/>
               </a:rPr>
-              <a:t>Generated Wednesday, September 30, 2026 · 10:01 AM ET UNC Street Drug Analysis Lab · OpioidData.org · results.streetsafe.supply Download as PowerPoint</a:t>
+              <a:t>Generated Thursday, October 01, 2026 · 10:39 AM ET UNC Street Drug Analysis Lab · OpioidData.org · results.streetsafe.supply Download as PowerPoint</a:t>
             </a:r>
           </a:p>
         </p:txBody>
@@ -2713,7 +2713,7 @@
                 <a:ea typeface="Helvetica Neue"/>
                 <a:sym typeface="Helvetica Neue"/>
               </a:rPr>
-              <a:t>PLACEHOLDER · figs/stats.json January 2022 to Tuesday, September 29, 2026 N = 2,920 NC samples analyzed Mailed in from 86 harm reduction programs Collected across 59 counties 247 distinct substances detected to date Unique samples = n_distinct(sampleid) · substances from lab_detail.substance · includes samples with date_complete 26 Jan 2022 – 29 Sep 2026 r/build_nightly.R → figs/stats.json</a:t>
+              <a:t>PLACEHOLDER · figs/stats.json January 2022 to Wednesday, September 30, 2026 N = 2,929 NC samples analyzed Mailed in from 86 harm reduction programs Collected across 59 counties 247 distinct substances detected to date Unique samples = n_distinct(sampleid) · substances from lab_detail.substance · includes samples with date_complete 26 Jan 2022 – 30 Sep 2026 r/build_nightly.R → figs/stats.json</a:t>
             </a:r>
           </a:p>
         </p:txBody>
@@ -2762,7 +2762,7 @@
                 <a:ea typeface="Helvetica Neue"/>
                 <a:sym typeface="Helvetica Neue"/>
               </a:rPr>
-              <a:t>Unique samples = n_distinct(sampleid) · substances from lab_detail.substance · includes samples with date_complete 26 Jan 2022 – 29 Sep 2026</a:t>
+              <a:t>Unique samples = n_distinct(sampleid) · substances from lab_detail.substance · includes samples with date_complete 26 Jan 2022 – 30 Sep 2026</a:t>
             </a:r>
           </a:p>
         </p:txBody>
@@ -3184,7 +3184,7 @@
                 <a:ea typeface="Helvetica Neue"/>
                 <a:sym typeface="Helvetica Neue"/>
               </a:rPr>
-              <a:t>County = samplecounty · left: ≥1 completed analysis ever · right: unique samples per county (sqrt color scale) · all time: 26 Jan 2022 – 29 Sep 2026 · last 12 months: 30 Sep 2025 – 29 Sep 2026* · coverage reflects participation, not prevalence</a:t>
+              <a:t>County = samplecounty · left: ≥1 completed analysis ever · right: unique samples per county (sqrt color scale) · all time: 26 Jan 2022 – 30 Sep 2026 · last 12 months: 01 Oct 2025 – 30 Sep 2026* · coverage reflects participation, not prevalence</a:t>
             </a:r>
           </a:p>
         </p:txBody>
@@ -3505,7 +3505,7 @@
                 <a:ea typeface="Helvetica Neue"/>
                 <a:sym typeface="Helvetica Neue"/>
               </a:rPr>
-              <a:t>expectedsubstance (verbatim card write-in, semicolon lists split) · derived flags: expect_opioid, expect_fentanyl, expect_meth, expect_cocaine, expect_stimulant… · includes samples with date_complete 26 Jan 2022 – 29 Sep 2026 · data table: Appendix A2</a:t>
+              <a:t>expectedsubstance (verbatim card write-in, semicolon lists split) · derived flags: expect_opioid, expect_fentanyl, expect_meth, expect_cocaine, expect_stimulant… · includes samples with date_complete 26 Jan 2022 – 30 Sep 2026 · data table: Appendix A2</a:t>
             </a:r>
           </a:p>
         </p:txBody>
@@ -3703,7 +3703,7 @@
                 <a:ea typeface="Helvetica Neue"/>
                 <a:sym typeface="Helvetica Neue"/>
               </a:rPr>
-              <a:t>Numerator uses lab_*_any (primary or trace) among samples with expect_* = 1 · includes samples with date_complete 26 Jan 2022 – 29 Sep 2026 · data table: Appendix A3</a:t>
+              <a:t>Numerator uses lab_*_any (primary or trace) among samples with expect_* = 1 · includes samples with date_complete 26 Jan 2022 – 30 Sep 2026 · data table: Appendix A3</a:t>
             </a:r>
           </a:p>
         </p:txBody>
@@ -3901,7 +3901,7 @@
                 <a:ea typeface="Helvetica Neue"/>
                 <a:sym typeface="Helvetica Neue"/>
               </a:rPr>
-              <a:t>sensations (circled on card, semicolon lists split) · post-consumption samples only (consumed = 1) · includes samples with date_complete 26 Jan 2022 – 29 Sep 2026</a:t>
+              <a:t>sensations (circled on card, semicolon lists split) · post-consumption samples only (consumed = 1) · includes samples with date_complete 26 Jan 2022 – 30 Sep 2026</a:t>
             </a:r>
           </a:p>
         </p:txBody>
@@ -4125,7 +4125,7 @@
                 <a:ea typeface="Helvetica Neue"/>
                 <a:sym typeface="Helvetica Neue"/>
               </a:rPr>
-              <a:t>sensations semicolon lists parsed per report · consumed = 1 only · denominator: consumed samples with lab_*_any = 1 · includes samples with date_complete 26 Jan 2022 – 29 Sep 2026</a:t>
+              <a:t>sensations semicolon lists parsed per report · consumed = 1 only · denominator: consumed samples with lab_*_any = 1 · includes samples with date_complete 26 Jan 2022 – 30 Sep 2026</a:t>
             </a:r>
           </a:p>
         </p:txBody>
@@ -4323,7 +4323,7 @@
                 <a:ea typeface="Helvetica Neue"/>
                 <a:sym typeface="Helvetica Neue"/>
               </a:rPr>
-              <a:t>Samples with methamphetamine or cocaine detected (any abundance); samples in both classes appear on both slides · sensations semicolon lists parsed + sen_strength (own denominator) · consumed = 1 only · before: 26 Jan 2022 – 29 Sep 2025 · past 12 months: 30 Sep 2025 – 29 Sep 2026* · Δ in percentage points</a:t>
+              <a:t>Samples with methamphetamine or cocaine detected (any abundance); samples in both classes appear on both slides · sensations semicolon lists parsed + sen_strength (own denominator) · consumed = 1 only · before: 26 Jan 2022 – 30 Sep 2025 · past 12 months: 01 Oct 2025 – 30 Sep 2026* · Δ in percentage points</a:t>
             </a:r>
           </a:p>
         </p:txBody>
@@ -4742,7 +4742,7 @@
                 <a:ea typeface="Helvetica Neue"/>
                 <a:sym typeface="Helvetica Neue"/>
               </a:rPr>
-              <a:t>Samples with an opioid (fentanyl, heroin) or benzodiazepine detected (any abundance); samples in both classes appear on both slides · sensations semicolon lists parsed + sen_strength (own denominator) · consumed = 1 only · before: 26 Jan 2022 – 29 Sep 2025 · past 12 months: 30 Sep 2025 – 29 Sep 2026* · Δ in percentage points</a:t>
+              <a:t>Samples with an opioid (fentanyl, heroin) or benzodiazepine detected (any abundance); samples in both classes appear on both slides · sensations semicolon lists parsed + sen_strength (own denominator) · consumed = 1 only · before: 26 Jan 2022 – 30 Sep 2025 · past 12 months: 01 Oct 2025 – 30 Sep 2026* · Δ in percentage points</a:t>
             </a:r>
           </a:p>
         </p:txBody>
@@ -5138,7 +5138,7 @@
                 <a:ea typeface="Helvetica Neue"/>
                 <a:sym typeface="Helvetica Neue"/>
               </a:rPr>
-              <a:t>color, texture (card v3+, semicolon lists split) · derived: bright_color excludes white/tan/brown family — orange bar above · includes samples with date_complete 26 Jan 2022 – 29 Sep 2026</a:t>
+              <a:t>color, texture (card v3+, semicolon lists split) · derived: bright_color excludes white/tan/brown family — orange bar above · includes samples with date_complete 26 Jan 2022 – 30 Sep 2026</a:t>
             </a:r>
           </a:p>
         </p:txBody>
@@ -5459,7 +5459,7 @@
                 <a:ea typeface="Helvetica Neue"/>
                 <a:sym typeface="Helvetica Neue"/>
               </a:rPr>
-              <a:t>Distribution of substances detected per sample, both definitions shown side by side · includes samples with date_complete 26 Jan 2022 – 29 Sep 2026</a:t>
+              <a:t>Distribution of substances detected per sample, both definitions shown side by side · includes samples with date_complete 26 Jan 2022 – 30 Sep 2026</a:t>
             </a:r>
           </a:p>
         </p:txBody>
@@ -5657,7 +5657,7 @@
                 <a:ea typeface="Helvetica Neue"/>
                 <a:sym typeface="Helvetica Neue"/>
               </a:rPr>
-              <a:t>lab_detail.substance counts · solid = primary abundance, light = trace · standardized names (PubChem-linked) · includes samples with date_complete 26 Jan 2022 – 29 Sep 2026</a:t>
+              <a:t>lab_detail.substance counts · solid = primary abundance, light = trace · standardized names (PubChem-linked) · includes samples with date_complete 26 Jan 2022 – 30 Sep 2026</a:t>
             </a:r>
           </a:p>
         </p:txBody>
@@ -5855,7 +5855,7 @@
                 <a:ea typeface="Helvetica Neue"/>
                 <a:sym typeface="Helvetica Neue"/>
               </a:rPr>
-              <a:t>lab_detail.substance counts · solid = primary abundance, light = trace · standardized names (PubChem-linked) · window: date_complete 30 Sep 2025 – 29 Sep 2026* (trailing 12 months, current month partial)</a:t>
+              <a:t>lab_detail.substance counts · solid = primary abundance, light = trace · standardized names (PubChem-linked) · window: date_complete 01 Oct 2025 – 30 Sep 2026* (trailing 12 months, current month partial)</a:t>
             </a:r>
           </a:p>
         </p:txBody>
@@ -6053,7 +6053,7 @@
                 <a:ea typeface="Helvetica Neue"/>
                 <a:sym typeface="Helvetica Neue"/>
               </a:rPr>
-              <a:t>Distribution of substances detected per sample, both definitions shown side by side · window: date_complete 30 Sep 2025 – 29 Sep 2026* (trailing 12 months, current month partial)</a:t>
+              <a:t>Distribution of substances detected per sample, both definitions shown side by side · window: date_complete 01 Oct 2025 – 30 Sep 2026* (trailing 12 months, current month partial)</a:t>
             </a:r>
           </a:p>
         </p:txBody>
@@ -9571,7 +9571,7 @@
                 <a:ea typeface="Helvetica Neue"/>
                 <a:sym typeface="Helvetica Neue"/>
               </a:rPr>
-              <a:t>Fentanyl by Region, UNC Street Drug Analysis Lab (Drug Checking) Data: 2026Q2</a:t>
+              <a:t>Fentanyl by Region, UNC Street Drug Analysis Lab (Drug Checking) Data: 2026Q3</a:t>
             </a:r>
           </a:p>
         </p:txBody>
@@ -9672,7 +9672,7 @@
                 <a:ea typeface="Helvetica Neue"/>
                 <a:sym typeface="Helvetica Neue"/>
               </a:rPr>
-              <a:t>Fentanyl-positive (any abundance) per 1,000 samples completed in the region, 2026Q2</a:t>
+              <a:t>Fentanyl-positive (any abundance) per 1,000 samples completed in the region, 2026Q3</a:t>
             </a:r>
           </a:p>
         </p:txBody>
@@ -9746,7 +9746,7 @@
                 <a:ea typeface="Helvetica Neue"/>
                 <a:sym typeface="Helvetica Neue"/>
               </a:rPr>
-              <a:t>Xylazine by Region, UNC Street Drug Analysis Lab (Drug Checking) Data: 2026Q2</a:t>
+              <a:t>Xylazine by Region, UNC Street Drug Analysis Lab (Drug Checking) Data: 2026Q3</a:t>
             </a:r>
           </a:p>
         </p:txBody>
@@ -9847,7 +9847,7 @@
                 <a:ea typeface="Helvetica Neue"/>
                 <a:sym typeface="Helvetica Neue"/>
               </a:rPr>
-              <a:t>Xylazine-positive (any abundance) per 1,000 samples completed in the region, 2026Q2</a:t>
+              <a:t>Xylazine-positive (any abundance) per 1,000 samples completed in the region, 2026Q3</a:t>
             </a:r>
           </a:p>
         </p:txBody>
@@ -9921,7 +9921,7 @@
                 <a:ea typeface="Helvetica Neue"/>
                 <a:sym typeface="Helvetica Neue"/>
               </a:rPr>
-              <a:t>Methamphetamine by Region, UNC Street Drug Analysis Lab (Drug Checking) Data: 2026Q2</a:t>
+              <a:t>Methamphetamine by Region, UNC Street Drug Analysis Lab (Drug Checking) Data: 2026Q3</a:t>
             </a:r>
           </a:p>
         </p:txBody>
@@ -10022,7 +10022,7 @@
                 <a:ea typeface="Helvetica Neue"/>
                 <a:sym typeface="Helvetica Neue"/>
               </a:rPr>
-              <a:t>Methamphetamine-positive (any abundance) per 1,000 samples completed in the region, 2026Q2</a:t>
+              <a:t>Methamphetamine-positive (any abundance) per 1,000 samples completed in the region, 2026Q3</a:t>
             </a:r>
           </a:p>
         </p:txBody>
@@ -10096,7 +10096,7 @@
                 <a:ea typeface="Helvetica Neue"/>
                 <a:sym typeface="Helvetica Neue"/>
               </a:rPr>
-              <a:t>Cocaine by Region, UNC Street Drug Analysis Lab (Drug Checking) Data: 2026Q2</a:t>
+              <a:t>Cocaine by Region, UNC Street Drug Analysis Lab (Drug Checking) Data: 2026Q3</a:t>
             </a:r>
           </a:p>
         </p:txBody>
@@ -10197,7 +10197,7 @@
                 <a:ea typeface="Helvetica Neue"/>
                 <a:sym typeface="Helvetica Neue"/>
               </a:rPr>
-              <a:t>Cocaine-positive (any abundance) per 1,000 samples completed in the region, 2026Q2</a:t>
+              <a:t>Cocaine-positive (any abundance) per 1,000 samples completed in the region, 2026Q3</a:t>
             </a:r>
           </a:p>
         </p:txBody>
@@ -18510,7 +18510,7 @@
                           <a:ea typeface="Helvetica Neue"/>
                           <a:sym typeface="Helvetica Neue"/>
                         </a:rPr>
-                        <a:t>1,504</a:t>
+                        <a:t>1,505</a:t>
                       </a:r>
                     </a:p>
                   </a:txBody>
@@ -18626,7 +18626,7 @@
                           <a:ea typeface="Helvetica Neue"/>
                           <a:sym typeface="Helvetica Neue"/>
                         </a:rPr>
-                        <a:t>448</a:t>
+                        <a:t>450</a:t>
                       </a:r>
                     </a:p>
                   </a:txBody>
@@ -18742,7 +18742,7 @@
                           <a:ea typeface="Helvetica Neue"/>
                           <a:sym typeface="Helvetica Neue"/>
                         </a:rPr>
-                        <a:t>303</a:t>
+                        <a:t>304</a:t>
                       </a:r>
                     </a:p>
                   </a:txBody>
@@ -19206,7 +19206,7 @@
                           <a:ea typeface="Helvetica Neue"/>
                           <a:sym typeface="Helvetica Neue"/>
                         </a:rPr>
-                        <a:t>79</a:t>
+                        <a:t>80</a:t>
                       </a:r>
                     </a:p>
                   </a:txBody>
@@ -19322,7 +19322,7 @@
                           <a:ea typeface="Helvetica Neue"/>
                           <a:sym typeface="Helvetica Neue"/>
                         </a:rPr>
-                        <a:t>64</a:t>
+                        <a:t>65</a:t>
                       </a:r>
                     </a:p>
                   </a:txBody>
@@ -19438,7 +19438,7 @@
                           <a:ea typeface="Helvetica Neue"/>
                           <a:sym typeface="Helvetica Neue"/>
                         </a:rPr>
-                        <a:t>59</a:t>
+                        <a:t>61</a:t>
                       </a:r>
                     </a:p>
                   </a:txBody>
@@ -20591,7 +20591,7 @@
                           <a:ea typeface="Helvetica Neue"/>
                           <a:sym typeface="Helvetica Neue"/>
                         </a:rPr>
-                        <a:t>1,740</a:t>
+                        <a:t>1,744</a:t>
                       </a:r>
                     </a:p>
                   </a:txBody>
@@ -20821,7 +20821,7 @@
                           <a:ea typeface="Helvetica Neue"/>
                           <a:sym typeface="Helvetica Neue"/>
                         </a:rPr>
-                        <a:t>522</a:t>
+                        <a:t>526</a:t>
                       </a:r>
                     </a:p>
                   </a:txBody>
@@ -21515,7 +21515,7 @@
                           <a:ea typeface="Helvetica Neue"/>
                           <a:sym typeface="Helvetica Neue"/>
                         </a:rPr>
-                        <a:t>366</a:t>
+                        <a:t>367</a:t>
                       </a:r>
                     </a:p>
                   </a:txBody>
@@ -22151,7 +22151,7 @@
                           <a:ea typeface="Helvetica Neue"/>
                           <a:sym typeface="Helvetica Neue"/>
                         </a:rPr>
-                        <a:t>100 / month</a:t>
+                        <a:t>152 / month</a:t>
                       </a:r>
                     </a:p>
                   </a:txBody>
@@ -22208,7 +22208,7 @@
                           <a:ea typeface="Helvetica Neue"/>
                           <a:sym typeface="Helvetica Neue"/>
                         </a:rPr>
-                        <a:t>-40%</a:t>
+                        <a:t>+52%</a:t>
                       </a:r>
                     </a:p>
                   </a:txBody>
@@ -22324,7 +22324,7 @@
                           <a:ea typeface="Helvetica Neue"/>
                           <a:sym typeface="Helvetica Neue"/>
                         </a:rPr>
-                        <a:t>720</a:t>
+                        <a:t>711</a:t>
                       </a:r>
                     </a:p>
                   </a:txBody>
@@ -22381,7 +22381,7 @@
                           <a:ea typeface="Helvetica Neue"/>
                           <a:sym typeface="Helvetica Neue"/>
                         </a:rPr>
-                        <a:t>+8%</a:t>
+                        <a:t>-1%</a:t>
                       </a:r>
                     </a:p>
                   </a:txBody>
@@ -22497,7 +22497,7 @@
                           <a:ea typeface="Helvetica Neue"/>
                           <a:sym typeface="Helvetica Neue"/>
                         </a:rPr>
-                        <a:t>720</a:t>
+                        <a:t>691</a:t>
                       </a:r>
                     </a:p>
                   </a:txBody>
@@ -22554,7 +22554,7 @@
                           <a:ea typeface="Helvetica Neue"/>
                           <a:sym typeface="Helvetica Neue"/>
                         </a:rPr>
-                        <a:t>+19%</a:t>
+                        <a:t>-4%</a:t>
                       </a:r>
                     </a:p>
                   </a:txBody>
@@ -22670,7 +22670,7 @@
                           <a:ea typeface="Helvetica Neue"/>
                           <a:sym typeface="Helvetica Neue"/>
                         </a:rPr>
-                        <a:t>40</a:t>
+                        <a:t>66</a:t>
                       </a:r>
                     </a:p>
                   </a:txBody>
@@ -22727,7 +22727,7 @@
                           <a:ea typeface="Helvetica Neue"/>
                           <a:sym typeface="Helvetica Neue"/>
                         </a:rPr>
-                        <a:t>-33%</a:t>
+                        <a:t>+64%</a:t>
                       </a:r>
                     </a:p>
                   </a:txBody>
@@ -22843,7 +22843,7 @@
                           <a:ea typeface="Helvetica Neue"/>
                           <a:sym typeface="Helvetica Neue"/>
                         </a:rPr>
-                        <a:t>50</a:t>
+                        <a:t>79</a:t>
                       </a:r>
                     </a:p>
                   </a:txBody>
@@ -22900,7 +22900,7 @@
                           <a:ea typeface="Helvetica Neue"/>
                           <a:sym typeface="Helvetica Neue"/>
                         </a:rPr>
-                        <a:t>-44%</a:t>
+                        <a:t>+58%</a:t>
                       </a:r>
                     </a:p>
                   </a:txBody>
@@ -23020,7 +23020,7 @@
                           <a:ea typeface="Helvetica Neue"/>
                           <a:sym typeface="Helvetica Neue"/>
                         </a:rPr>
-                        <a:t>420</a:t>
+                        <a:t>408</a:t>
                       </a:r>
                     </a:p>
                   </a:txBody>
@@ -23081,7 +23081,7 @@
                           <a:ea typeface="Helvetica Neue"/>
                           <a:sym typeface="Helvetica Neue"/>
                         </a:rPr>
-                        <a:t>+46%</a:t>
+                        <a:t>-3%</a:t>
                       </a:r>
                     </a:p>
                   </a:txBody>
@@ -23423,7 +23423,7 @@
                           <a:ea typeface="Helvetica Neue"/>
                           <a:sym typeface="Helvetica Neue"/>
                         </a:rPr>
-                        <a:t>110</a:t>
+                        <a:t>105</a:t>
                       </a:r>
                     </a:p>
                   </a:txBody>
@@ -23480,7 +23480,7 @@
                           <a:ea typeface="Helvetica Neue"/>
                           <a:sym typeface="Helvetica Neue"/>
                         </a:rPr>
-                        <a:t>+8%</a:t>
+                        <a:t>-4%</a:t>
                       </a:r>
                     </a:p>
                   </a:txBody>
@@ -23769,7 +23769,7 @@
                           <a:ea typeface="Helvetica Neue"/>
                           <a:sym typeface="Helvetica Neue"/>
                         </a:rPr>
-                        <a:t>0</a:t>
+                        <a:t>20</a:t>
                       </a:r>
                     </a:p>
                   </a:txBody>
@@ -24115,7 +24115,7 @@
                           <a:ea typeface="Helvetica Neue"/>
                           <a:sym typeface="Helvetica Neue"/>
                         </a:rPr>
-                        <a:t>30</a:t>
+                        <a:t>26</a:t>
                       </a:r>
                     </a:p>
                   </a:txBody>
@@ -24172,7 +24172,7 @@
                           <a:ea typeface="Helvetica Neue"/>
                           <a:sym typeface="Helvetica Neue"/>
                         </a:rPr>
-                        <a:t>+67%</a:t>
+                        <a:t>-12%</a:t>
                       </a:r>
                     </a:p>
                   </a:txBody>
@@ -24292,7 +24292,7 @@
                           <a:ea typeface="Helvetica Neue"/>
                           <a:sym typeface="Helvetica Neue"/>
                         </a:rPr>
-                        <a:t>47</a:t>
+                        <a:t>31</a:t>
                       </a:r>
                     </a:p>
                   </a:txBody>
@@ -24353,7 +24353,7 @@
                           <a:ea typeface="Helvetica Neue"/>
                           <a:sym typeface="Helvetica Neue"/>
                         </a:rPr>
-                        <a:t>-8%</a:t>
+                        <a:t>-34%</a:t>
                       </a:r>
                     </a:p>
                   </a:txBody>

</xml_diff>

<commit_message>
nightly deck: data through 2026-10-02
</commit_message>
<xml_diff>
--- a/docs/nc-drug-checking-latest.pptx
+++ b/docs/nc-drug-checking-latest.pptx
@@ -2418,7 +2418,7 @@
                 <a:ea typeface="Helvetica Neue"/>
                 <a:sym typeface="Helvetica Neue"/>
               </a:rPr>
-              <a:t>Generated Thursday, October 01, 2026 · 10:39 AM ET UNC Street Drug Analysis Lab · OpioidData.org · results.streetsafe.supply Download as PowerPoint</a:t>
+              <a:t>Generated Friday, October 02, 2026 · 10:00 AM ET UNC Street Drug Analysis Lab · OpioidData.org · results.streetsafe.supply Download as PowerPoint</a:t>
             </a:r>
           </a:p>
         </p:txBody>
@@ -2713,7 +2713,7 @@
                 <a:ea typeface="Helvetica Neue"/>
                 <a:sym typeface="Helvetica Neue"/>
               </a:rPr>
-              <a:t>PLACEHOLDER · figs/stats.json January 2022 to Wednesday, September 30, 2026 N = 2,929 NC samples analyzed Mailed in from 86 harm reduction programs Collected across 59 counties 247 distinct substances detected to date Unique samples = n_distinct(sampleid) · substances from lab_detail.substance · includes samples with date_complete 26 Jan 2022 – 30 Sep 2026 r/build_nightly.R → figs/stats.json</a:t>
+              <a:t>PLACEHOLDER · figs/stats.json January 2022 to Thursday, October 01, 2026 N = 2,930 NC samples analyzed Mailed in from 86 harm reduction programs Collected across 59 counties 247 distinct substances detected to date Unique samples = n_distinct(sampleid) · substances from lab_detail.substance · includes samples with date_complete 26 Jan 2022 – 01 Oct 2026 r/build_nightly.R → figs/stats.json</a:t>
             </a:r>
           </a:p>
         </p:txBody>
@@ -2762,7 +2762,7 @@
                 <a:ea typeface="Helvetica Neue"/>
                 <a:sym typeface="Helvetica Neue"/>
               </a:rPr>
-              <a:t>Unique samples = n_distinct(sampleid) · substances from lab_detail.substance · includes samples with date_complete 26 Jan 2022 – 30 Sep 2026</a:t>
+              <a:t>Unique samples = n_distinct(sampleid) · substances from lab_detail.substance · includes samples with date_complete 26 Jan 2022 – 01 Oct 2026</a:t>
             </a:r>
           </a:p>
         </p:txBody>
@@ -3184,7 +3184,7 @@
                 <a:ea typeface="Helvetica Neue"/>
                 <a:sym typeface="Helvetica Neue"/>
               </a:rPr>
-              <a:t>County = samplecounty · left: ≥1 completed analysis ever · right: unique samples per county (sqrt color scale) · all time: 26 Jan 2022 – 30 Sep 2026 · last 12 months: 01 Oct 2025 – 30 Sep 2026* · coverage reflects participation, not prevalence</a:t>
+              <a:t>County = samplecounty · left: ≥1 completed analysis ever · right: unique samples per county (sqrt color scale) · all time: 26 Jan 2022 – 01 Oct 2026 · last 12 months: 02 Oct 2025 – 01 Oct 2026* · coverage reflects participation, not prevalence</a:t>
             </a:r>
           </a:p>
         </p:txBody>
@@ -3505,7 +3505,7 @@
                 <a:ea typeface="Helvetica Neue"/>
                 <a:sym typeface="Helvetica Neue"/>
               </a:rPr>
-              <a:t>expectedsubstance (verbatim card write-in, semicolon lists split) · derived flags: expect_opioid, expect_fentanyl, expect_meth, expect_cocaine, expect_stimulant… · includes samples with date_complete 26 Jan 2022 – 30 Sep 2026 · data table: Appendix A2</a:t>
+              <a:t>expectedsubstance (verbatim card write-in, semicolon lists split) · derived flags: expect_opioid, expect_fentanyl, expect_meth, expect_cocaine, expect_stimulant… · includes samples with date_complete 26 Jan 2022 – 01 Oct 2026 · data table: Appendix A2</a:t>
             </a:r>
           </a:p>
         </p:txBody>
@@ -3703,7 +3703,7 @@
                 <a:ea typeface="Helvetica Neue"/>
                 <a:sym typeface="Helvetica Neue"/>
               </a:rPr>
-              <a:t>Numerator uses lab_*_any (primary or trace) among samples with expect_* = 1 · includes samples with date_complete 26 Jan 2022 – 30 Sep 2026 · data table: Appendix A3</a:t>
+              <a:t>Numerator uses lab_*_any (primary or trace) among samples with expect_* = 1 · includes samples with date_complete 26 Jan 2022 – 01 Oct 2026 · data table: Appendix A3</a:t>
             </a:r>
           </a:p>
         </p:txBody>
@@ -3901,7 +3901,7 @@
                 <a:ea typeface="Helvetica Neue"/>
                 <a:sym typeface="Helvetica Neue"/>
               </a:rPr>
-              <a:t>sensations (circled on card, semicolon lists split) · post-consumption samples only (consumed = 1) · includes samples with date_complete 26 Jan 2022 – 30 Sep 2026</a:t>
+              <a:t>sensations (circled on card, semicolon lists split) · post-consumption samples only (consumed = 1) · includes samples with date_complete 26 Jan 2022 – 01 Oct 2026</a:t>
             </a:r>
           </a:p>
         </p:txBody>
@@ -4125,7 +4125,7 @@
                 <a:ea typeface="Helvetica Neue"/>
                 <a:sym typeface="Helvetica Neue"/>
               </a:rPr>
-              <a:t>sensations semicolon lists parsed per report · consumed = 1 only · denominator: consumed samples with lab_*_any = 1 · includes samples with date_complete 26 Jan 2022 – 30 Sep 2026</a:t>
+              <a:t>sensations semicolon lists parsed per report · consumed = 1 only · denominator: consumed samples with lab_*_any = 1 · includes samples with date_complete 26 Jan 2022 – 01 Oct 2026</a:t>
             </a:r>
           </a:p>
         </p:txBody>
@@ -4323,7 +4323,7 @@
                 <a:ea typeface="Helvetica Neue"/>
                 <a:sym typeface="Helvetica Neue"/>
               </a:rPr>
-              <a:t>Samples with methamphetamine or cocaine detected (any abundance); samples in both classes appear on both slides · sensations semicolon lists parsed + sen_strength (own denominator) · consumed = 1 only · before: 26 Jan 2022 – 30 Sep 2025 · past 12 months: 01 Oct 2025 – 30 Sep 2026* · Δ in percentage points</a:t>
+              <a:t>Samples with methamphetamine or cocaine detected (any abundance); samples in both classes appear on both slides · sensations semicolon lists parsed + sen_strength (own denominator) · consumed = 1 only · before: 26 Jan 2022 – 01 Oct 2025 · past 12 months: 02 Oct 2025 – 01 Oct 2026* · Δ in percentage points</a:t>
             </a:r>
           </a:p>
         </p:txBody>
@@ -4742,7 +4742,7 @@
                 <a:ea typeface="Helvetica Neue"/>
                 <a:sym typeface="Helvetica Neue"/>
               </a:rPr>
-              <a:t>Samples with an opioid (fentanyl, heroin) or benzodiazepine detected (any abundance); samples in both classes appear on both slides · sensations semicolon lists parsed + sen_strength (own denominator) · consumed = 1 only · before: 26 Jan 2022 – 30 Sep 2025 · past 12 months: 01 Oct 2025 – 30 Sep 2026* · Δ in percentage points</a:t>
+              <a:t>Samples with an opioid (fentanyl, heroin) or benzodiazepine detected (any abundance); samples in both classes appear on both slides · sensations semicolon lists parsed + sen_strength (own denominator) · consumed = 1 only · before: 26 Jan 2022 – 01 Oct 2025 · past 12 months: 02 Oct 2025 – 01 Oct 2026* · Δ in percentage points</a:t>
             </a:r>
           </a:p>
         </p:txBody>
@@ -5138,7 +5138,7 @@
                 <a:ea typeface="Helvetica Neue"/>
                 <a:sym typeface="Helvetica Neue"/>
               </a:rPr>
-              <a:t>color, texture (card v3+, semicolon lists split) · derived: bright_color excludes white/tan/brown family — orange bar above · includes samples with date_complete 26 Jan 2022 – 30 Sep 2026</a:t>
+              <a:t>color, texture (card v3+, semicolon lists split) · derived: bright_color excludes white/tan/brown family — orange bar above · includes samples with date_complete 26 Jan 2022 – 01 Oct 2026</a:t>
             </a:r>
           </a:p>
         </p:txBody>
@@ -5459,7 +5459,7 @@
                 <a:ea typeface="Helvetica Neue"/>
                 <a:sym typeface="Helvetica Neue"/>
               </a:rPr>
-              <a:t>Distribution of substances detected per sample, both definitions shown side by side · includes samples with date_complete 26 Jan 2022 – 30 Sep 2026</a:t>
+              <a:t>Distribution of substances detected per sample, both definitions shown side by side · includes samples with date_complete 26 Jan 2022 – 01 Oct 2026</a:t>
             </a:r>
           </a:p>
         </p:txBody>
@@ -5657,7 +5657,7 @@
                 <a:ea typeface="Helvetica Neue"/>
                 <a:sym typeface="Helvetica Neue"/>
               </a:rPr>
-              <a:t>lab_detail.substance counts · solid = primary abundance, light = trace · standardized names (PubChem-linked) · includes samples with date_complete 26 Jan 2022 – 30 Sep 2026</a:t>
+              <a:t>lab_detail.substance counts · solid = primary abundance, light = trace · standardized names (PubChem-linked) · includes samples with date_complete 26 Jan 2022 – 01 Oct 2026</a:t>
             </a:r>
           </a:p>
         </p:txBody>
@@ -5855,7 +5855,7 @@
                 <a:ea typeface="Helvetica Neue"/>
                 <a:sym typeface="Helvetica Neue"/>
               </a:rPr>
-              <a:t>lab_detail.substance counts · solid = primary abundance, light = trace · standardized names (PubChem-linked) · window: date_complete 01 Oct 2025 – 30 Sep 2026* (trailing 12 months, current month partial)</a:t>
+              <a:t>lab_detail.substance counts · solid = primary abundance, light = trace · standardized names (PubChem-linked) · window: date_complete 02 Oct 2025 – 01 Oct 2026* (trailing 12 months, current month partial)</a:t>
             </a:r>
           </a:p>
         </p:txBody>
@@ -6053,7 +6053,7 @@
                 <a:ea typeface="Helvetica Neue"/>
                 <a:sym typeface="Helvetica Neue"/>
               </a:rPr>
-              <a:t>Distribution of substances detected per sample, both definitions shown side by side · window: date_complete 01 Oct 2025 – 30 Sep 2026* (trailing 12 months, current month partial)</a:t>
+              <a:t>Distribution of substances detected per sample, both definitions shown side by side · window: date_complete 02 Oct 2025 – 01 Oct 2026* (trailing 12 months, current month partial)</a:t>
             </a:r>
           </a:p>
         </p:txBody>
@@ -8944,7 +8944,7 @@
                 <a:ea typeface="Helvetica Neue"/>
                 <a:sym typeface="Helvetica Neue"/>
               </a:rPr>
-              <a:t>Fentanyl-Positive Samples, UNC Street Drug Analysis Lab (Drug Checking) Data: Sep 2026*</a:t>
+              <a:t>Fentanyl-Positive Samples, UNC Street Drug Analysis Lab (Drug Checking) Data: Oct 2026*</a:t>
             </a:r>
           </a:p>
         </p:txBody>
@@ -9070,7 +9070,7 @@
                 <a:ea typeface="Helvetica Neue"/>
                 <a:sym typeface="Helvetica Neue"/>
               </a:rPr>
-              <a:t>Xylazine-Positive Samples, UNC Street Drug Analysis Lab (Drug Checking) Data: Sep 2026*</a:t>
+              <a:t>Xylazine-Positive Samples, UNC Street Drug Analysis Lab (Drug Checking) Data: Oct 2026*</a:t>
             </a:r>
           </a:p>
         </p:txBody>
@@ -9196,7 +9196,7 @@
                 <a:ea typeface="Helvetica Neue"/>
                 <a:sym typeface="Helvetica Neue"/>
               </a:rPr>
-              <a:t>Methamphetamine-Positive Samples, UNC Street Drug Analysis Lab (Drug Checking) Data: Sep 2026*</a:t>
+              <a:t>Methamphetamine-Positive Samples, UNC Street Drug Analysis Lab (Drug Checking) Data: Oct 2026*</a:t>
             </a:r>
           </a:p>
         </p:txBody>
@@ -9322,7 +9322,7 @@
                 <a:ea typeface="Helvetica Neue"/>
                 <a:sym typeface="Helvetica Neue"/>
               </a:rPr>
-              <a:t>Cocaine-Positive Samples, UNC Street Drug Analysis Lab (Drug Checking) Data: Sep 2026*</a:t>
+              <a:t>Cocaine-Positive Samples, UNC Street Drug Analysis Lab (Drug Checking) Data: Oct 2026*</a:t>
             </a:r>
           </a:p>
         </p:txBody>

</xml_diff>

<commit_message>
nightly deck: data through 2026-10-03
</commit_message>
<xml_diff>
--- a/docs/nc-drug-checking-latest.pptx
+++ b/docs/nc-drug-checking-latest.pptx
@@ -2418,7 +2418,7 @@
                 <a:ea typeface="Helvetica Neue"/>
                 <a:sym typeface="Helvetica Neue"/>
               </a:rPr>
-              <a:t>Generated Friday, October 02, 2026 · 10:00 AM ET UNC Street Drug Analysis Lab · OpioidData.org · results.streetsafe.supply Download as PowerPoint</a:t>
+              <a:t>Generated Saturday, October 03, 2026 · 8:40 AM ET UNC Street Drug Analysis Lab · OpioidData.org · results.streetsafe.supply Download as PowerPoint</a:t>
             </a:r>
           </a:p>
         </p:txBody>
@@ -3184,7 +3184,7 @@
                 <a:ea typeface="Helvetica Neue"/>
                 <a:sym typeface="Helvetica Neue"/>
               </a:rPr>
-              <a:t>County = samplecounty · left: ≥1 completed analysis ever · right: unique samples per county (sqrt color scale) · all time: 26 Jan 2022 – 01 Oct 2026 · last 12 months: 02 Oct 2025 – 01 Oct 2026* · coverage reflects participation, not prevalence</a:t>
+              <a:t>County = samplecounty · left: ≥1 completed analysis ever · right: unique samples per county (sqrt color scale) · all time: 26 Jan 2022 – 01 Oct 2026 · last 12 months: 03 Oct 2025 – 01 Oct 2026* · coverage reflects participation, not prevalence</a:t>
             </a:r>
           </a:p>
         </p:txBody>
@@ -4323,7 +4323,7 @@
                 <a:ea typeface="Helvetica Neue"/>
                 <a:sym typeface="Helvetica Neue"/>
               </a:rPr>
-              <a:t>Samples with methamphetamine or cocaine detected (any abundance); samples in both classes appear on both slides · sensations semicolon lists parsed + sen_strength (own denominator) · consumed = 1 only · before: 26 Jan 2022 – 01 Oct 2025 · past 12 months: 02 Oct 2025 – 01 Oct 2026* · Δ in percentage points</a:t>
+              <a:t>Samples with methamphetamine or cocaine detected (any abundance); samples in both classes appear on both slides · sensations semicolon lists parsed + sen_strength (own denominator) · consumed = 1 only · before: 26 Jan 2022 – 01 Oct 2025 · past 12 months: 03 Oct 2025 – 01 Oct 2026* · Δ in percentage points</a:t>
             </a:r>
           </a:p>
         </p:txBody>
@@ -4742,7 +4742,7 @@
                 <a:ea typeface="Helvetica Neue"/>
                 <a:sym typeface="Helvetica Neue"/>
               </a:rPr>
-              <a:t>Samples with an opioid (fentanyl, heroin) or benzodiazepine detected (any abundance); samples in both classes appear on both slides · sensations semicolon lists parsed + sen_strength (own denominator) · consumed = 1 only · before: 26 Jan 2022 – 01 Oct 2025 · past 12 months: 02 Oct 2025 – 01 Oct 2026* · Δ in percentage points</a:t>
+              <a:t>Samples with an opioid (fentanyl, heroin) or benzodiazepine detected (any abundance); samples in both classes appear on both slides · sensations semicolon lists parsed + sen_strength (own denominator) · consumed = 1 only · before: 26 Jan 2022 – 01 Oct 2025 · past 12 months: 03 Oct 2025 – 01 Oct 2026* · Δ in percentage points</a:t>
             </a:r>
           </a:p>
         </p:txBody>
@@ -5855,7 +5855,7 @@
                 <a:ea typeface="Helvetica Neue"/>
                 <a:sym typeface="Helvetica Neue"/>
               </a:rPr>
-              <a:t>lab_detail.substance counts · solid = primary abundance, light = trace · standardized names (PubChem-linked) · window: date_complete 02 Oct 2025 – 01 Oct 2026* (trailing 12 months, current month partial)</a:t>
+              <a:t>lab_detail.substance counts · solid = primary abundance, light = trace · standardized names (PubChem-linked) · window: date_complete 03 Oct 2025 – 01 Oct 2026* (trailing 12 months, current month partial)</a:t>
             </a:r>
           </a:p>
         </p:txBody>
@@ -6053,7 +6053,7 @@
                 <a:ea typeface="Helvetica Neue"/>
                 <a:sym typeface="Helvetica Neue"/>
               </a:rPr>
-              <a:t>Distribution of substances detected per sample, both definitions shown side by side · window: date_complete 02 Oct 2025 – 01 Oct 2026* (trailing 12 months, current month partial)</a:t>
+              <a:t>Distribution of substances detected per sample, both definitions shown side by side · window: date_complete 03 Oct 2025 – 01 Oct 2026* (trailing 12 months, current month partial)</a:t>
             </a:r>
           </a:p>
         </p:txBody>

</xml_diff>

<commit_message>
nightly deck: data through 2026-10-04
</commit_message>
<xml_diff>
--- a/docs/nc-drug-checking-latest.pptx
+++ b/docs/nc-drug-checking-latest.pptx
@@ -2418,7 +2418,7 @@
                 <a:ea typeface="Helvetica Neue"/>
                 <a:sym typeface="Helvetica Neue"/>
               </a:rPr>
-              <a:t>Generated Saturday, October 03, 2026 · 8:40 AM ET UNC Street Drug Analysis Lab · OpioidData.org · results.streetsafe.supply Download as PowerPoint</a:t>
+              <a:t>Generated Sunday, October 04, 2026 · 9:22 AM ET UNC Street Drug Analysis Lab · OpioidData.org · results.streetsafe.supply Download as PowerPoint</a:t>
             </a:r>
           </a:p>
         </p:txBody>
@@ -2713,7 +2713,7 @@
                 <a:ea typeface="Helvetica Neue"/>
                 <a:sym typeface="Helvetica Neue"/>
               </a:rPr>
-              <a:t>PLACEHOLDER · figs/stats.json January 2022 to Thursday, October 01, 2026 N = 2,930 NC samples analyzed Mailed in from 86 harm reduction programs Collected across 59 counties 247 distinct substances detected to date Unique samples = n_distinct(sampleid) · substances from lab_detail.substance · includes samples with date_complete 26 Jan 2022 – 01 Oct 2026 r/build_nightly.R → figs/stats.json</a:t>
+              <a:t>PLACEHOLDER · figs/stats.json January 2022 to Friday, October 02, 2026 N = 2,940 NC samples analyzed Mailed in from 86 harm reduction programs Collected across 59 counties 247 distinct substances detected to date Unique samples = n_distinct(sampleid) · substances from lab_detail.substance · includes samples with date_complete 26 Jan 2022 – 02 Oct 2026 r/build_nightly.R → figs/stats.json</a:t>
             </a:r>
           </a:p>
         </p:txBody>
@@ -2762,7 +2762,7 @@
                 <a:ea typeface="Helvetica Neue"/>
                 <a:sym typeface="Helvetica Neue"/>
               </a:rPr>
-              <a:t>Unique samples = n_distinct(sampleid) · substances from lab_detail.substance · includes samples with date_complete 26 Jan 2022 – 01 Oct 2026</a:t>
+              <a:t>Unique samples = n_distinct(sampleid) · substances from lab_detail.substance · includes samples with date_complete 26 Jan 2022 – 02 Oct 2026</a:t>
             </a:r>
           </a:p>
         </p:txBody>
@@ -3184,7 +3184,7 @@
                 <a:ea typeface="Helvetica Neue"/>
                 <a:sym typeface="Helvetica Neue"/>
               </a:rPr>
-              <a:t>County = samplecounty · left: ≥1 completed analysis ever · right: unique samples per county (sqrt color scale) · all time: 26 Jan 2022 – 01 Oct 2026 · last 12 months: 03 Oct 2025 – 01 Oct 2026* · coverage reflects participation, not prevalence</a:t>
+              <a:t>County = samplecounty · left: ≥1 completed analysis ever · right: unique samples per county (sqrt color scale) · all time: 26 Jan 2022 – 02 Oct 2026 · last 12 months: 04 Oct 2025 – 02 Oct 2026* · coverage reflects participation, not prevalence</a:t>
             </a:r>
           </a:p>
         </p:txBody>
@@ -3505,7 +3505,7 @@
                 <a:ea typeface="Helvetica Neue"/>
                 <a:sym typeface="Helvetica Neue"/>
               </a:rPr>
-              <a:t>expectedsubstance (verbatim card write-in, semicolon lists split) · derived flags: expect_opioid, expect_fentanyl, expect_meth, expect_cocaine, expect_stimulant… · includes samples with date_complete 26 Jan 2022 – 01 Oct 2026 · data table: Appendix A2</a:t>
+              <a:t>expectedsubstance (verbatim card write-in, semicolon lists split) · derived flags: expect_opioid, expect_fentanyl, expect_meth, expect_cocaine, expect_stimulant… · includes samples with date_complete 26 Jan 2022 – 02 Oct 2026 · data table: Appendix A2</a:t>
             </a:r>
           </a:p>
         </p:txBody>
@@ -3703,7 +3703,7 @@
                 <a:ea typeface="Helvetica Neue"/>
                 <a:sym typeface="Helvetica Neue"/>
               </a:rPr>
-              <a:t>Numerator uses lab_*_any (primary or trace) among samples with expect_* = 1 · includes samples with date_complete 26 Jan 2022 – 01 Oct 2026 · data table: Appendix A3</a:t>
+              <a:t>Numerator uses lab_*_any (primary or trace) among samples with expect_* = 1 · includes samples with date_complete 26 Jan 2022 – 02 Oct 2026 · data table: Appendix A3</a:t>
             </a:r>
           </a:p>
         </p:txBody>
@@ -3901,7 +3901,7 @@
                 <a:ea typeface="Helvetica Neue"/>
                 <a:sym typeface="Helvetica Neue"/>
               </a:rPr>
-              <a:t>sensations (circled on card, semicolon lists split) · post-consumption samples only (consumed = 1) · includes samples with date_complete 26 Jan 2022 – 01 Oct 2026</a:t>
+              <a:t>sensations (circled on card, semicolon lists split) · post-consumption samples only (consumed = 1) · includes samples with date_complete 26 Jan 2022 – 02 Oct 2026</a:t>
             </a:r>
           </a:p>
         </p:txBody>
@@ -4125,7 +4125,7 @@
                 <a:ea typeface="Helvetica Neue"/>
                 <a:sym typeface="Helvetica Neue"/>
               </a:rPr>
-              <a:t>sensations semicolon lists parsed per report · consumed = 1 only · denominator: consumed samples with lab_*_any = 1 · includes samples with date_complete 26 Jan 2022 – 01 Oct 2026</a:t>
+              <a:t>sensations semicolon lists parsed per report · consumed = 1 only · denominator: consumed samples with lab_*_any = 1 · includes samples with date_complete 26 Jan 2022 – 02 Oct 2026</a:t>
             </a:r>
           </a:p>
         </p:txBody>
@@ -4323,7 +4323,7 @@
                 <a:ea typeface="Helvetica Neue"/>
                 <a:sym typeface="Helvetica Neue"/>
               </a:rPr>
-              <a:t>Samples with methamphetamine or cocaine detected (any abundance); samples in both classes appear on both slides · sensations semicolon lists parsed + sen_strength (own denominator) · consumed = 1 only · before: 26 Jan 2022 – 01 Oct 2025 · past 12 months: 03 Oct 2025 – 01 Oct 2026* · Δ in percentage points</a:t>
+              <a:t>Samples with methamphetamine or cocaine detected (any abundance); samples in both classes appear on both slides · sensations semicolon lists parsed + sen_strength (own denominator) · consumed = 1 only · before: 26 Jan 2022 – 02 Oct 2025 · past 12 months: 04 Oct 2025 – 02 Oct 2026* · Δ in percentage points</a:t>
             </a:r>
           </a:p>
         </p:txBody>
@@ -4742,7 +4742,7 @@
                 <a:ea typeface="Helvetica Neue"/>
                 <a:sym typeface="Helvetica Neue"/>
               </a:rPr>
-              <a:t>Samples with an opioid (fentanyl, heroin) or benzodiazepine detected (any abundance); samples in both classes appear on both slides · sensations semicolon lists parsed + sen_strength (own denominator) · consumed = 1 only · before: 26 Jan 2022 – 01 Oct 2025 · past 12 months: 03 Oct 2025 – 01 Oct 2026* · Δ in percentage points</a:t>
+              <a:t>Samples with an opioid (fentanyl, heroin) or benzodiazepine detected (any abundance); samples in both classes appear on both slides · sensations semicolon lists parsed + sen_strength (own denominator) · consumed = 1 only · before: 26 Jan 2022 – 02 Oct 2025 · past 12 months: 04 Oct 2025 – 02 Oct 2026* · Δ in percentage points</a:t>
             </a:r>
           </a:p>
         </p:txBody>
@@ -5138,7 +5138,7 @@
                 <a:ea typeface="Helvetica Neue"/>
                 <a:sym typeface="Helvetica Neue"/>
               </a:rPr>
-              <a:t>color, texture (card v3+, semicolon lists split) · derived: bright_color excludes white/tan/brown family — orange bar above · includes samples with date_complete 26 Jan 2022 – 01 Oct 2026</a:t>
+              <a:t>color, texture (card v3+, semicolon lists split) · derived: bright_color excludes white/tan/brown family — orange bar above · includes samples with date_complete 26 Jan 2022 – 02 Oct 2026</a:t>
             </a:r>
           </a:p>
         </p:txBody>
@@ -5459,7 +5459,7 @@
                 <a:ea typeface="Helvetica Neue"/>
                 <a:sym typeface="Helvetica Neue"/>
               </a:rPr>
-              <a:t>Distribution of substances detected per sample, both definitions shown side by side · includes samples with date_complete 26 Jan 2022 – 01 Oct 2026</a:t>
+              <a:t>Distribution of substances detected per sample, both definitions shown side by side · includes samples with date_complete 26 Jan 2022 – 02 Oct 2026</a:t>
             </a:r>
           </a:p>
         </p:txBody>
@@ -5657,7 +5657,7 @@
                 <a:ea typeface="Helvetica Neue"/>
                 <a:sym typeface="Helvetica Neue"/>
               </a:rPr>
-              <a:t>lab_detail.substance counts · solid = primary abundance, light = trace · standardized names (PubChem-linked) · includes samples with date_complete 26 Jan 2022 – 01 Oct 2026</a:t>
+              <a:t>lab_detail.substance counts · solid = primary abundance, light = trace · standardized names (PubChem-linked) · includes samples with date_complete 26 Jan 2022 – 02 Oct 2026</a:t>
             </a:r>
           </a:p>
         </p:txBody>
@@ -5855,7 +5855,7 @@
                 <a:ea typeface="Helvetica Neue"/>
                 <a:sym typeface="Helvetica Neue"/>
               </a:rPr>
-              <a:t>lab_detail.substance counts · solid = primary abundance, light = trace · standardized names (PubChem-linked) · window: date_complete 03 Oct 2025 – 01 Oct 2026* (trailing 12 months, current month partial)</a:t>
+              <a:t>lab_detail.substance counts · solid = primary abundance, light = trace · standardized names (PubChem-linked) · window: date_complete 04 Oct 2025 – 02 Oct 2026* (trailing 12 months, current month partial)</a:t>
             </a:r>
           </a:p>
         </p:txBody>
@@ -6053,7 +6053,7 @@
                 <a:ea typeface="Helvetica Neue"/>
                 <a:sym typeface="Helvetica Neue"/>
               </a:rPr>
-              <a:t>Distribution of substances detected per sample, both definitions shown side by side · window: date_complete 03 Oct 2025 – 01 Oct 2026* (trailing 12 months, current month partial)</a:t>
+              <a:t>Distribution of substances detected per sample, both definitions shown side by side · window: date_complete 04 Oct 2025 – 02 Oct 2026* (trailing 12 months, current month partial)</a:t>
             </a:r>
           </a:p>
         </p:txBody>
@@ -18510,7 +18510,7 @@
                           <a:ea typeface="Helvetica Neue"/>
                           <a:sym typeface="Helvetica Neue"/>
                         </a:rPr>
-                        <a:t>1,505</a:t>
+                        <a:t>1,513</a:t>
                       </a:r>
                     </a:p>
                   </a:txBody>
@@ -18626,7 +18626,7 @@
                           <a:ea typeface="Helvetica Neue"/>
                           <a:sym typeface="Helvetica Neue"/>
                         </a:rPr>
-                        <a:t>450</a:t>
+                        <a:t>451</a:t>
                       </a:r>
                     </a:p>
                   </a:txBody>
@@ -18974,7 +18974,7 @@
                           <a:ea typeface="Helvetica Neue"/>
                           <a:sym typeface="Helvetica Neue"/>
                         </a:rPr>
-                        <a:t>162</a:t>
+                        <a:t>163</a:t>
                       </a:r>
                     </a:p>
                   </a:txBody>
@@ -20591,7 +20591,7 @@
                           <a:ea typeface="Helvetica Neue"/>
                           <a:sym typeface="Helvetica Neue"/>
                         </a:rPr>
-                        <a:t>1,744</a:t>
+                        <a:t>1,752</a:t>
                       </a:r>
                     </a:p>
                   </a:txBody>
@@ -20821,7 +20821,7 @@
                           <a:ea typeface="Helvetica Neue"/>
                           <a:sym typeface="Helvetica Neue"/>
                         </a:rPr>
-                        <a:t>526</a:t>
+                        <a:t>527</a:t>
                       </a:r>
                     </a:p>
                   </a:txBody>
@@ -22151,7 +22151,7 @@
                           <a:ea typeface="Helvetica Neue"/>
                           <a:sym typeface="Helvetica Neue"/>
                         </a:rPr>
-                        <a:t>152 / month</a:t>
+                        <a:t>153 / month</a:t>
                       </a:r>
                     </a:p>
                   </a:txBody>
@@ -22208,7 +22208,7 @@
                           <a:ea typeface="Helvetica Neue"/>
                           <a:sym typeface="Helvetica Neue"/>
                         </a:rPr>
-                        <a:t>+52%</a:t>
+                        <a:t>+53%</a:t>
                       </a:r>
                     </a:p>
                   </a:txBody>
@@ -22324,7 +22324,7 @@
                           <a:ea typeface="Helvetica Neue"/>
                           <a:sym typeface="Helvetica Neue"/>
                         </a:rPr>
-                        <a:t>711</a:t>
+                        <a:t>706</a:t>
                       </a:r>
                     </a:p>
                   </a:txBody>
@@ -22381,7 +22381,7 @@
                           <a:ea typeface="Helvetica Neue"/>
                           <a:sym typeface="Helvetica Neue"/>
                         </a:rPr>
-                        <a:t>-1%</a:t>
+                        <a:t>-2%</a:t>
                       </a:r>
                     </a:p>
                   </a:txBody>
@@ -22497,7 +22497,7 @@
                           <a:ea typeface="Helvetica Neue"/>
                           <a:sym typeface="Helvetica Neue"/>
                         </a:rPr>
-                        <a:t>691</a:t>
+                        <a:t>686</a:t>
                       </a:r>
                     </a:p>
                   </a:txBody>
@@ -22554,7 +22554,7 @@
                           <a:ea typeface="Helvetica Neue"/>
                           <a:sym typeface="Helvetica Neue"/>
                         </a:rPr>
-                        <a:t>-4%</a:t>
+                        <a:t>-5%</a:t>
                       </a:r>
                     </a:p>
                   </a:txBody>
@@ -22670,7 +22670,7 @@
                           <a:ea typeface="Helvetica Neue"/>
                           <a:sym typeface="Helvetica Neue"/>
                         </a:rPr>
-                        <a:t>66</a:t>
+                        <a:t>65</a:t>
                       </a:r>
                     </a:p>
                   </a:txBody>
@@ -22727,7 +22727,7 @@
                           <a:ea typeface="Helvetica Neue"/>
                           <a:sym typeface="Helvetica Neue"/>
                         </a:rPr>
-                        <a:t>+64%</a:t>
+                        <a:t>+63%</a:t>
                       </a:r>
                     </a:p>
                   </a:txBody>
@@ -22843,7 +22843,7 @@
                           <a:ea typeface="Helvetica Neue"/>
                           <a:sym typeface="Helvetica Neue"/>
                         </a:rPr>
-                        <a:t>79</a:t>
+                        <a:t>78</a:t>
                       </a:r>
                     </a:p>
                   </a:txBody>
@@ -22900,7 +22900,7 @@
                           <a:ea typeface="Helvetica Neue"/>
                           <a:sym typeface="Helvetica Neue"/>
                         </a:rPr>
-                        <a:t>+58%</a:t>
+                        <a:t>+57%</a:t>
                       </a:r>
                     </a:p>
                   </a:txBody>
@@ -23020,7 +23020,7 @@
                           <a:ea typeface="Helvetica Neue"/>
                           <a:sym typeface="Helvetica Neue"/>
                         </a:rPr>
-                        <a:t>408</a:t>
+                        <a:t>405</a:t>
                       </a:r>
                     </a:p>
                   </a:txBody>
@@ -23081,7 +23081,7 @@
                           <a:ea typeface="Helvetica Neue"/>
                           <a:sym typeface="Helvetica Neue"/>
                         </a:rPr>
-                        <a:t>-3%</a:t>
+                        <a:t>-4%</a:t>
                       </a:r>
                     </a:p>
                   </a:txBody>
@@ -23480,7 +23480,7 @@
                           <a:ea typeface="Helvetica Neue"/>
                           <a:sym typeface="Helvetica Neue"/>
                         </a:rPr>
-                        <a:t>-4%</a:t>
+                        <a:t>-5%</a:t>
                       </a:r>
                     </a:p>
                   </a:txBody>
@@ -24172,7 +24172,7 @@
                           <a:ea typeface="Helvetica Neue"/>
                           <a:sym typeface="Helvetica Neue"/>
                         </a:rPr>
-                        <a:t>-12%</a:t>
+                        <a:t>-13%</a:t>
                       </a:r>
                     </a:p>
                   </a:txBody>
@@ -24292,7 +24292,7 @@
                           <a:ea typeface="Helvetica Neue"/>
                           <a:sym typeface="Helvetica Neue"/>
                         </a:rPr>
-                        <a:t>31</a:t>
+                        <a:t>30</a:t>
                       </a:r>
                     </a:p>
                   </a:txBody>
@@ -24353,7 +24353,7 @@
                           <a:ea typeface="Helvetica Neue"/>
                           <a:sym typeface="Helvetica Neue"/>
                         </a:rPr>
-                        <a:t>-34%</a:t>
+                        <a:t>-35%</a:t>
                       </a:r>
                     </a:p>
                   </a:txBody>

</xml_diff>

<commit_message>
nightly deck: data through 2026-10-05
</commit_message>
<xml_diff>
--- a/docs/nc-drug-checking-latest.pptx
+++ b/docs/nc-drug-checking-latest.pptx
@@ -2418,7 +2418,7 @@
                 <a:ea typeface="Helvetica Neue"/>
                 <a:sym typeface="Helvetica Neue"/>
               </a:rPr>
-              <a:t>Generated Sunday, October 04, 2026 · 9:22 AM ET UNC Street Drug Analysis Lab · OpioidData.org · results.streetsafe.supply Download as PowerPoint</a:t>
+              <a:t>Generated Monday, October 05, 2026 · 12:16 PM ET UNC Street Drug Analysis Lab · OpioidData.org · results.streetsafe.supply Download as PowerPoint</a:t>
             </a:r>
           </a:p>
         </p:txBody>
@@ -2713,7 +2713,7 @@
                 <a:ea typeface="Helvetica Neue"/>
                 <a:sym typeface="Helvetica Neue"/>
               </a:rPr>
-              <a:t>PLACEHOLDER · figs/stats.json January 2022 to Friday, October 02, 2026 N = 2,940 NC samples analyzed Mailed in from 86 harm reduction programs Collected across 59 counties 247 distinct substances detected to date Unique samples = n_distinct(sampleid) · substances from lab_detail.substance · includes samples with date_complete 26 Jan 2022 – 02 Oct 2026 r/build_nightly.R → figs/stats.json</a:t>
+              <a:t>PLACEHOLDER · figs/stats.json January 2022 to Monday, October 05, 2026 N = 2,942 NC samples analyzed Mailed in from 86 harm reduction programs Collected across 59 counties 249 distinct substances detected to date Unique samples = n_distinct(sampleid) · substances from lab_detail.substance · includes samples with date_complete 26 Jan 2022 – 05 Oct 2026 r/build_nightly.R → figs/stats.json</a:t>
             </a:r>
           </a:p>
         </p:txBody>
@@ -2762,7 +2762,7 @@
                 <a:ea typeface="Helvetica Neue"/>
                 <a:sym typeface="Helvetica Neue"/>
               </a:rPr>
-              <a:t>Unique samples = n_distinct(sampleid) · substances from lab_detail.substance · includes samples with date_complete 26 Jan 2022 – 02 Oct 2026</a:t>
+              <a:t>Unique samples = n_distinct(sampleid) · substances from lab_detail.substance · includes samples with date_complete 26 Jan 2022 – 05 Oct 2026</a:t>
             </a:r>
           </a:p>
         </p:txBody>
@@ -3184,7 +3184,7 @@
                 <a:ea typeface="Helvetica Neue"/>
                 <a:sym typeface="Helvetica Neue"/>
               </a:rPr>
-              <a:t>County = samplecounty · left: ≥1 completed analysis ever · right: unique samples per county (sqrt color scale) · all time: 26 Jan 2022 – 02 Oct 2026 · last 12 months: 04 Oct 2025 – 02 Oct 2026* · coverage reflects participation, not prevalence</a:t>
+              <a:t>County = samplecounty · left: ≥1 completed analysis ever · right: unique samples per county (sqrt color scale) · all time: 26 Jan 2022 – 05 Oct 2026 · last 12 months: 05 Oct 2025 – 05 Oct 2026* · coverage reflects participation, not prevalence</a:t>
             </a:r>
           </a:p>
         </p:txBody>
@@ -3505,7 +3505,7 @@
                 <a:ea typeface="Helvetica Neue"/>
                 <a:sym typeface="Helvetica Neue"/>
               </a:rPr>
-              <a:t>expectedsubstance (verbatim card write-in, semicolon lists split) · derived flags: expect_opioid, expect_fentanyl, expect_meth, expect_cocaine, expect_stimulant… · includes samples with date_complete 26 Jan 2022 – 02 Oct 2026 · data table: Appendix A2</a:t>
+              <a:t>expectedsubstance (verbatim card write-in, semicolon lists split) · derived flags: expect_opioid, expect_fentanyl, expect_meth, expect_cocaine, expect_stimulant… · includes samples with date_complete 26 Jan 2022 – 05 Oct 2026 · data table: Appendix A2</a:t>
             </a:r>
           </a:p>
         </p:txBody>
@@ -3703,7 +3703,7 @@
                 <a:ea typeface="Helvetica Neue"/>
                 <a:sym typeface="Helvetica Neue"/>
               </a:rPr>
-              <a:t>Numerator uses lab_*_any (primary or trace) among samples with expect_* = 1 · includes samples with date_complete 26 Jan 2022 – 02 Oct 2026 · data table: Appendix A3</a:t>
+              <a:t>Numerator uses lab_*_any (primary or trace) among samples with expect_* = 1 · includes samples with date_complete 26 Jan 2022 – 05 Oct 2026 · data table: Appendix A3</a:t>
             </a:r>
           </a:p>
         </p:txBody>
@@ -3901,7 +3901,7 @@
                 <a:ea typeface="Helvetica Neue"/>
                 <a:sym typeface="Helvetica Neue"/>
               </a:rPr>
-              <a:t>sensations (circled on card, semicolon lists split) · post-consumption samples only (consumed = 1) · includes samples with date_complete 26 Jan 2022 – 02 Oct 2026</a:t>
+              <a:t>sensations (circled on card, semicolon lists split) · post-consumption samples only (consumed = 1) · includes samples with date_complete 26 Jan 2022 – 05 Oct 2026</a:t>
             </a:r>
           </a:p>
         </p:txBody>
@@ -4125,7 +4125,7 @@
                 <a:ea typeface="Helvetica Neue"/>
                 <a:sym typeface="Helvetica Neue"/>
               </a:rPr>
-              <a:t>sensations semicolon lists parsed per report · consumed = 1 only · denominator: consumed samples with lab_*_any = 1 · includes samples with date_complete 26 Jan 2022 – 02 Oct 2026</a:t>
+              <a:t>sensations semicolon lists parsed per report · consumed = 1 only · denominator: consumed samples with lab_*_any = 1 · includes samples with date_complete 26 Jan 2022 – 05 Oct 2026</a:t>
             </a:r>
           </a:p>
         </p:txBody>
@@ -4323,7 +4323,7 @@
                 <a:ea typeface="Helvetica Neue"/>
                 <a:sym typeface="Helvetica Neue"/>
               </a:rPr>
-              <a:t>Samples with methamphetamine or cocaine detected (any abundance); samples in both classes appear on both slides · sensations semicolon lists parsed + sen_strength (own denominator) · consumed = 1 only · before: 26 Jan 2022 – 02 Oct 2025 · past 12 months: 04 Oct 2025 – 02 Oct 2026* · Δ in percentage points</a:t>
+              <a:t>Samples with methamphetamine or cocaine detected (any abundance); samples in both classes appear on both slides · sensations semicolon lists parsed + sen_strength (own denominator) · consumed = 1 only · before: 26 Jan 2022 – 05 Oct 2025 · past 12 months: 05 Oct 2025 – 05 Oct 2026* · Δ in percentage points</a:t>
             </a:r>
           </a:p>
         </p:txBody>
@@ -4742,7 +4742,7 @@
                 <a:ea typeface="Helvetica Neue"/>
                 <a:sym typeface="Helvetica Neue"/>
               </a:rPr>
-              <a:t>Samples with an opioid (fentanyl, heroin) or benzodiazepine detected (any abundance); samples in both classes appear on both slides · sensations semicolon lists parsed + sen_strength (own denominator) · consumed = 1 only · before: 26 Jan 2022 – 02 Oct 2025 · past 12 months: 04 Oct 2025 – 02 Oct 2026* · Δ in percentage points</a:t>
+              <a:t>Samples with an opioid (fentanyl, heroin) or benzodiazepine detected (any abundance); samples in both classes appear on both slides · sensations semicolon lists parsed + sen_strength (own denominator) · consumed = 1 only · before: 26 Jan 2022 – 05 Oct 2025 · past 12 months: 05 Oct 2025 – 05 Oct 2026* · Δ in percentage points</a:t>
             </a:r>
           </a:p>
         </p:txBody>
@@ -5138,7 +5138,7 @@
                 <a:ea typeface="Helvetica Neue"/>
                 <a:sym typeface="Helvetica Neue"/>
               </a:rPr>
-              <a:t>color, texture (card v3+, semicolon lists split) · derived: bright_color excludes white/tan/brown family — orange bar above · includes samples with date_complete 26 Jan 2022 – 02 Oct 2026</a:t>
+              <a:t>color, texture (card v3+, semicolon lists split) · derived: bright_color excludes white/tan/brown family — orange bar above · includes samples with date_complete 26 Jan 2022 – 05 Oct 2026</a:t>
             </a:r>
           </a:p>
         </p:txBody>
@@ -5459,7 +5459,7 @@
                 <a:ea typeface="Helvetica Neue"/>
                 <a:sym typeface="Helvetica Neue"/>
               </a:rPr>
-              <a:t>Distribution of substances detected per sample, both definitions shown side by side · includes samples with date_complete 26 Jan 2022 – 02 Oct 2026</a:t>
+              <a:t>Distribution of substances detected per sample, both definitions shown side by side · includes samples with date_complete 26 Jan 2022 – 05 Oct 2026</a:t>
             </a:r>
           </a:p>
         </p:txBody>
@@ -5657,7 +5657,7 @@
                 <a:ea typeface="Helvetica Neue"/>
                 <a:sym typeface="Helvetica Neue"/>
               </a:rPr>
-              <a:t>lab_detail.substance counts · solid = primary abundance, light = trace · standardized names (PubChem-linked) · includes samples with date_complete 26 Jan 2022 – 02 Oct 2026</a:t>
+              <a:t>lab_detail.substance counts · solid = primary abundance, light = trace · standardized names (PubChem-linked) · includes samples with date_complete 26 Jan 2022 – 05 Oct 2026</a:t>
             </a:r>
           </a:p>
         </p:txBody>
@@ -5855,7 +5855,7 @@
                 <a:ea typeface="Helvetica Neue"/>
                 <a:sym typeface="Helvetica Neue"/>
               </a:rPr>
-              <a:t>lab_detail.substance counts · solid = primary abundance, light = trace · standardized names (PubChem-linked) · window: date_complete 04 Oct 2025 – 02 Oct 2026* (trailing 12 months, current month partial)</a:t>
+              <a:t>lab_detail.substance counts · solid = primary abundance, light = trace · standardized names (PubChem-linked) · window: date_complete 05 Oct 2025 – 05 Oct 2026* (trailing 12 months, current month partial)</a:t>
             </a:r>
           </a:p>
         </p:txBody>
@@ -6053,7 +6053,7 @@
                 <a:ea typeface="Helvetica Neue"/>
                 <a:sym typeface="Helvetica Neue"/>
               </a:rPr>
-              <a:t>Distribution of substances detected per sample, both definitions shown side by side · window: date_complete 04 Oct 2025 – 02 Oct 2026* (trailing 12 months, current month partial)</a:t>
+              <a:t>Distribution of substances detected per sample, both definitions shown side by side · window: date_complete 05 Oct 2025 – 05 Oct 2026* (trailing 12 months, current month partial)</a:t>
             </a:r>
           </a:p>
         </p:txBody>
@@ -10686,7 +10686,7 @@
             <a:tbl>
               <a:tblPr/>
               <a:tblGrid>
-                <a:gridCol w="2462983"/>
+                <a:gridCol w="2106837"/>
                 <a:gridCol w="1237011"/>
                 <a:gridCol w="1218929"/>
                 <a:gridCol w="1186187"/>
@@ -11049,6 +11049,580 @@
                           <a:ea typeface="Helvetica Neue"/>
                           <a:sym typeface="Helvetica Neue"/>
                         </a:rPr>
+                        <a:t>cannabigerol</a:t>
+                      </a:r>
+                    </a:p>
+                  </a:txBody>
+                  <a:tcPr anchor="ctr" marB="63500" marT="63500" marR="0" marL="0">
+                    <a:lnL algn="ctr" cmpd="sng" cap="flat" w="0">
+                      <a:noFill/>
+                      <a:prstDash val="solid"/>
+                    </a:lnL>
+                    <a:lnR algn="ctr" cmpd="sng" cap="flat" w="0">
+                      <a:noFill/>
+                      <a:prstDash val="solid"/>
+                    </a:lnR>
+                    <a:lnT algn="ctr" cmpd="sng" cap="flat" w="0">
+                      <a:noFill/>
+                      <a:prstDash val="solid"/>
+                    </a:lnT>
+                    <a:lnB algn="ctr" cmpd="sng" cap="flat" w="0">
+                      <a:noFill/>
+                      <a:prstDash val="solid"/>
+                    </a:lnB>
+                    <a:solidFill>
+                      <a:srgbClr val="FFFFFF">
+                        <a:alpha val="0"/>
+                      </a:srgbClr>
+                    </a:solidFill>
+                  </a:tcPr>
+                </a:tc>
+                <a:tc>
+                  <a:txBody>
+                    <a:bodyPr/>
+                    <a:lstStyle/>
+                    <a:p>
+                      <a:pPr algn="l" marL="63500" marR="63500">
+                        <a:lnSpc>
+                          <a:spcPct val="100000"/>
+                        </a:lnSpc>
+                        <a:spcBef>
+                          <a:spcPts val="500"/>
+                        </a:spcBef>
+                        <a:spcAft>
+                          <a:spcPts val="500"/>
+                        </a:spcAft>
+                        <a:buNone/>
+                      </a:pPr>
+                      <a:r>
+                        <a:rPr cap="none" sz="1200" i="0" b="0" u="none" strike="noStrike">
+                          <a:solidFill>
+                            <a:srgbClr val="5B6770">
+                              <a:alpha val="100000"/>
+                            </a:srgbClr>
+                          </a:solidFill>
+                          <a:latin typeface="Helvetica Neue"/>
+                          <a:cs typeface="Helvetica Neue"/>
+                          <a:ea typeface="Helvetica Neue"/>
+                          <a:sym typeface="Helvetica Neue"/>
+                        </a:rPr>
+                        <a:t>05 Oct 2026</a:t>
+                      </a:r>
+                    </a:p>
+                  </a:txBody>
+                  <a:tcPr anchor="ctr" marB="63500" marT="63500" marR="0" marL="0">
+                    <a:lnL algn="ctr" cmpd="sng" cap="flat" w="0">
+                      <a:noFill/>
+                      <a:prstDash val="solid"/>
+                    </a:lnL>
+                    <a:lnR algn="ctr" cmpd="sng" cap="flat" w="0">
+                      <a:noFill/>
+                      <a:prstDash val="solid"/>
+                    </a:lnR>
+                    <a:lnT algn="ctr" cmpd="sng" cap="flat" w="0">
+                      <a:noFill/>
+                      <a:prstDash val="solid"/>
+                    </a:lnT>
+                    <a:lnB algn="ctr" cmpd="sng" cap="flat" w="0">
+                      <a:noFill/>
+                      <a:prstDash val="solid"/>
+                    </a:lnB>
+                    <a:solidFill>
+                      <a:srgbClr val="FFFFFF">
+                        <a:alpha val="0"/>
+                      </a:srgbClr>
+                    </a:solidFill>
+                  </a:tcPr>
+                </a:tc>
+                <a:tc>
+                  <a:txBody>
+                    <a:bodyPr/>
+                    <a:lstStyle/>
+                    <a:p>
+                      <a:pPr algn="l" marL="63500" marR="63500">
+                        <a:lnSpc>
+                          <a:spcPct val="100000"/>
+                        </a:lnSpc>
+                        <a:spcBef>
+                          <a:spcPts val="500"/>
+                        </a:spcBef>
+                        <a:spcAft>
+                          <a:spcPts val="500"/>
+                        </a:spcAft>
+                        <a:buNone/>
+                      </a:pPr>
+                      <a:r>
+                        <a:rPr cap="none" sz="1200" i="0" b="0" u="none" strike="noStrike">
+                          <a:solidFill>
+                            <a:srgbClr val="5B6770">
+                              <a:alpha val="100000"/>
+                            </a:srgbClr>
+                          </a:solidFill>
+                          <a:latin typeface="Helvetica Neue"/>
+                          <a:cs typeface="Helvetica Neue"/>
+                          <a:ea typeface="Helvetica Neue"/>
+                          <a:sym typeface="Helvetica Neue"/>
+                        </a:rPr>
+                        <a:t>primary</a:t>
+                      </a:r>
+                    </a:p>
+                  </a:txBody>
+                  <a:tcPr anchor="ctr" marB="63500" marT="63500" marR="0" marL="0">
+                    <a:lnL algn="ctr" cmpd="sng" cap="flat" w="0">
+                      <a:noFill/>
+                      <a:prstDash val="solid"/>
+                    </a:lnL>
+                    <a:lnR algn="ctr" cmpd="sng" cap="flat" w="0">
+                      <a:noFill/>
+                      <a:prstDash val="solid"/>
+                    </a:lnR>
+                    <a:lnT algn="ctr" cmpd="sng" cap="flat" w="0">
+                      <a:noFill/>
+                      <a:prstDash val="solid"/>
+                    </a:lnT>
+                    <a:lnB algn="ctr" cmpd="sng" cap="flat" w="0">
+                      <a:noFill/>
+                      <a:prstDash val="solid"/>
+                    </a:lnB>
+                    <a:solidFill>
+                      <a:srgbClr val="FFFFFF">
+                        <a:alpha val="0"/>
+                      </a:srgbClr>
+                    </a:solidFill>
+                  </a:tcPr>
+                </a:tc>
+                <a:tc>
+                  <a:txBody>
+                    <a:bodyPr/>
+                    <a:lstStyle/>
+                    <a:p>
+                      <a:pPr algn="r" marL="63500" marR="63500">
+                        <a:lnSpc>
+                          <a:spcPct val="100000"/>
+                        </a:lnSpc>
+                        <a:spcBef>
+                          <a:spcPts val="500"/>
+                        </a:spcBef>
+                        <a:spcAft>
+                          <a:spcPts val="500"/>
+                        </a:spcAft>
+                        <a:buNone/>
+                      </a:pPr>
+                      <a:r>
+                        <a:rPr cap="none" sz="1200" i="0" b="0" u="none" strike="noStrike">
+                          <a:solidFill>
+                            <a:srgbClr val="5B6770">
+                              <a:alpha val="100000"/>
+                            </a:srgbClr>
+                          </a:solidFill>
+                          <a:latin typeface="Helvetica Neue"/>
+                          <a:cs typeface="Helvetica Neue"/>
+                          <a:ea typeface="Helvetica Neue"/>
+                          <a:sym typeface="Helvetica Neue"/>
+                        </a:rPr>
+                        <a:t>1</a:t>
+                      </a:r>
+                    </a:p>
+                  </a:txBody>
+                  <a:tcPr anchor="ctr" marB="63500" marT="63500" marR="0" marL="0">
+                    <a:lnL algn="ctr" cmpd="sng" cap="flat" w="0">
+                      <a:noFill/>
+                      <a:prstDash val="solid"/>
+                    </a:lnL>
+                    <a:lnR algn="ctr" cmpd="sng" cap="flat" w="0">
+                      <a:noFill/>
+                      <a:prstDash val="solid"/>
+                    </a:lnR>
+                    <a:lnT algn="ctr" cmpd="sng" cap="flat" w="0">
+                      <a:noFill/>
+                      <a:prstDash val="solid"/>
+                    </a:lnT>
+                    <a:lnB algn="ctr" cmpd="sng" cap="flat" w="0">
+                      <a:noFill/>
+                      <a:prstDash val="solid"/>
+                    </a:lnB>
+                    <a:solidFill>
+                      <a:srgbClr val="FFFFFF">
+                        <a:alpha val="0"/>
+                      </a:srgbClr>
+                    </a:solidFill>
+                  </a:tcPr>
+                </a:tc>
+                <a:tc>
+                  <a:txBody>
+                    <a:bodyPr/>
+                    <a:lstStyle/>
+                    <a:p>
+                      <a:pPr algn="l" marL="63500" marR="63500">
+                        <a:lnSpc>
+                          <a:spcPct val="100000"/>
+                        </a:lnSpc>
+                        <a:spcBef>
+                          <a:spcPts val="500"/>
+                        </a:spcBef>
+                        <a:spcAft>
+                          <a:spcPts val="500"/>
+                        </a:spcAft>
+                        <a:buNone/>
+                      </a:pPr>
+                      <a:r>
+                        <a:rPr cap="none" sz="1200" i="0" b="0" u="none" strike="noStrike">
+                          <a:solidFill>
+                            <a:srgbClr val="5B6770">
+                              <a:alpha val="100000"/>
+                            </a:srgbClr>
+                          </a:solidFill>
+                          <a:latin typeface="Helvetica Neue"/>
+                          <a:cs typeface="Helvetica Neue"/>
+                          <a:ea typeface="Helvetica Neue"/>
+                          <a:sym typeface="Helvetica Neue"/>
+                        </a:rPr>
+                        <a:t>605975</a:t>
+                      </a:r>
+                    </a:p>
+                  </a:txBody>
+                  <a:tcPr anchor="ctr" marB="63500" marT="63500" marR="0" marL="0">
+                    <a:lnL algn="ctr" cmpd="sng" cap="flat" w="0">
+                      <a:noFill/>
+                      <a:prstDash val="solid"/>
+                    </a:lnL>
+                    <a:lnR algn="ctr" cmpd="sng" cap="flat" w="0">
+                      <a:noFill/>
+                      <a:prstDash val="solid"/>
+                    </a:lnR>
+                    <a:lnT algn="ctr" cmpd="sng" cap="flat" w="0">
+                      <a:noFill/>
+                      <a:prstDash val="solid"/>
+                    </a:lnT>
+                    <a:lnB algn="ctr" cmpd="sng" cap="flat" w="0">
+                      <a:noFill/>
+                      <a:prstDash val="solid"/>
+                    </a:lnB>
+                    <a:solidFill>
+                      <a:srgbClr val="FFFFFF">
+                        <a:alpha val="0"/>
+                      </a:srgbClr>
+                    </a:solidFill>
+                  </a:tcPr>
+                </a:tc>
+              </a:tr>
+              <a:tr h="401320">
+                <a:tc>
+                  <a:txBody>
+                    <a:bodyPr/>
+                    <a:lstStyle/>
+                    <a:p>
+                      <a:pPr algn="l" marL="63500" marR="63500">
+                        <a:lnSpc>
+                          <a:spcPct val="100000"/>
+                        </a:lnSpc>
+                        <a:spcBef>
+                          <a:spcPts val="500"/>
+                        </a:spcBef>
+                        <a:spcAft>
+                          <a:spcPts val="500"/>
+                        </a:spcAft>
+                        <a:buNone/>
+                      </a:pPr>
+                      <a:r>
+                        <a:rPr cap="none" sz="1200" i="0" b="0" u="none" strike="noStrike">
+                          <a:solidFill>
+                            <a:srgbClr val="5B6770">
+                              <a:alpha val="100000"/>
+                            </a:srgbClr>
+                          </a:solidFill>
+                          <a:latin typeface="Helvetica Neue"/>
+                          <a:cs typeface="Helvetica Neue"/>
+                          <a:ea typeface="Helvetica Neue"/>
+                          <a:sym typeface="Helvetica Neue"/>
+                        </a:rPr>
+                        <a:t>delta-4(8)-iso-THC</a:t>
+                      </a:r>
+                    </a:p>
+                  </a:txBody>
+                  <a:tcPr anchor="ctr" marB="63500" marT="63500" marR="0" marL="0">
+                    <a:lnL algn="ctr" cmpd="sng" cap="flat" w="0">
+                      <a:noFill/>
+                      <a:prstDash val="solid"/>
+                    </a:lnL>
+                    <a:lnR algn="ctr" cmpd="sng" cap="flat" w="0">
+                      <a:noFill/>
+                      <a:prstDash val="solid"/>
+                    </a:lnR>
+                    <a:lnT algn="ctr" cmpd="sng" cap="flat" w="0">
+                      <a:noFill/>
+                      <a:prstDash val="solid"/>
+                    </a:lnT>
+                    <a:lnB algn="ctr" cmpd="sng" cap="flat" w="0">
+                      <a:noFill/>
+                      <a:prstDash val="solid"/>
+                    </a:lnB>
+                    <a:solidFill>
+                      <a:srgbClr val="F4F8FB">
+                        <a:alpha val="100000"/>
+                      </a:srgbClr>
+                    </a:solidFill>
+                  </a:tcPr>
+                </a:tc>
+                <a:tc>
+                  <a:txBody>
+                    <a:bodyPr/>
+                    <a:lstStyle/>
+                    <a:p>
+                      <a:pPr algn="l" marL="63500" marR="63500">
+                        <a:lnSpc>
+                          <a:spcPct val="100000"/>
+                        </a:lnSpc>
+                        <a:spcBef>
+                          <a:spcPts val="500"/>
+                        </a:spcBef>
+                        <a:spcAft>
+                          <a:spcPts val="500"/>
+                        </a:spcAft>
+                        <a:buNone/>
+                      </a:pPr>
+                      <a:r>
+                        <a:rPr cap="none" sz="1200" i="0" b="0" u="none" strike="noStrike">
+                          <a:solidFill>
+                            <a:srgbClr val="5B6770">
+                              <a:alpha val="100000"/>
+                            </a:srgbClr>
+                          </a:solidFill>
+                          <a:latin typeface="Helvetica Neue"/>
+                          <a:cs typeface="Helvetica Neue"/>
+                          <a:ea typeface="Helvetica Neue"/>
+                          <a:sym typeface="Helvetica Neue"/>
+                        </a:rPr>
+                        <a:t>05 Oct 2026</a:t>
+                      </a:r>
+                    </a:p>
+                  </a:txBody>
+                  <a:tcPr anchor="ctr" marB="63500" marT="63500" marR="0" marL="0">
+                    <a:lnL algn="ctr" cmpd="sng" cap="flat" w="0">
+                      <a:noFill/>
+                      <a:prstDash val="solid"/>
+                    </a:lnL>
+                    <a:lnR algn="ctr" cmpd="sng" cap="flat" w="0">
+                      <a:noFill/>
+                      <a:prstDash val="solid"/>
+                    </a:lnR>
+                    <a:lnT algn="ctr" cmpd="sng" cap="flat" w="0">
+                      <a:noFill/>
+                      <a:prstDash val="solid"/>
+                    </a:lnT>
+                    <a:lnB algn="ctr" cmpd="sng" cap="flat" w="0">
+                      <a:noFill/>
+                      <a:prstDash val="solid"/>
+                    </a:lnB>
+                    <a:solidFill>
+                      <a:srgbClr val="F4F8FB">
+                        <a:alpha val="100000"/>
+                      </a:srgbClr>
+                    </a:solidFill>
+                  </a:tcPr>
+                </a:tc>
+                <a:tc>
+                  <a:txBody>
+                    <a:bodyPr/>
+                    <a:lstStyle/>
+                    <a:p>
+                      <a:pPr algn="l" marL="63500" marR="63500">
+                        <a:lnSpc>
+                          <a:spcPct val="100000"/>
+                        </a:lnSpc>
+                        <a:spcBef>
+                          <a:spcPts val="500"/>
+                        </a:spcBef>
+                        <a:spcAft>
+                          <a:spcPts val="500"/>
+                        </a:spcAft>
+                        <a:buNone/>
+                      </a:pPr>
+                      <a:r>
+                        <a:rPr cap="none" sz="1200" i="0" b="0" u="none" strike="noStrike">
+                          <a:solidFill>
+                            <a:srgbClr val="5B6770">
+                              <a:alpha val="100000"/>
+                            </a:srgbClr>
+                          </a:solidFill>
+                          <a:latin typeface="Helvetica Neue"/>
+                          <a:cs typeface="Helvetica Neue"/>
+                          <a:ea typeface="Helvetica Neue"/>
+                          <a:sym typeface="Helvetica Neue"/>
+                        </a:rPr>
+                        <a:t>primary</a:t>
+                      </a:r>
+                    </a:p>
+                  </a:txBody>
+                  <a:tcPr anchor="ctr" marB="63500" marT="63500" marR="0" marL="0">
+                    <a:lnL algn="ctr" cmpd="sng" cap="flat" w="0">
+                      <a:noFill/>
+                      <a:prstDash val="solid"/>
+                    </a:lnL>
+                    <a:lnR algn="ctr" cmpd="sng" cap="flat" w="0">
+                      <a:noFill/>
+                      <a:prstDash val="solid"/>
+                    </a:lnR>
+                    <a:lnT algn="ctr" cmpd="sng" cap="flat" w="0">
+                      <a:noFill/>
+                      <a:prstDash val="solid"/>
+                    </a:lnT>
+                    <a:lnB algn="ctr" cmpd="sng" cap="flat" w="0">
+                      <a:noFill/>
+                      <a:prstDash val="solid"/>
+                    </a:lnB>
+                    <a:solidFill>
+                      <a:srgbClr val="F4F8FB">
+                        <a:alpha val="100000"/>
+                      </a:srgbClr>
+                    </a:solidFill>
+                  </a:tcPr>
+                </a:tc>
+                <a:tc>
+                  <a:txBody>
+                    <a:bodyPr/>
+                    <a:lstStyle/>
+                    <a:p>
+                      <a:pPr algn="r" marL="63500" marR="63500">
+                        <a:lnSpc>
+                          <a:spcPct val="100000"/>
+                        </a:lnSpc>
+                        <a:spcBef>
+                          <a:spcPts val="500"/>
+                        </a:spcBef>
+                        <a:spcAft>
+                          <a:spcPts val="500"/>
+                        </a:spcAft>
+                        <a:buNone/>
+                      </a:pPr>
+                      <a:r>
+                        <a:rPr cap="none" sz="1200" i="0" b="0" u="none" strike="noStrike">
+                          <a:solidFill>
+                            <a:srgbClr val="5B6770">
+                              <a:alpha val="100000"/>
+                            </a:srgbClr>
+                          </a:solidFill>
+                          <a:latin typeface="Helvetica Neue"/>
+                          <a:cs typeface="Helvetica Neue"/>
+                          <a:ea typeface="Helvetica Neue"/>
+                          <a:sym typeface="Helvetica Neue"/>
+                        </a:rPr>
+                        <a:t>1</a:t>
+                      </a:r>
+                    </a:p>
+                  </a:txBody>
+                  <a:tcPr anchor="ctr" marB="63500" marT="63500" marR="0" marL="0">
+                    <a:lnL algn="ctr" cmpd="sng" cap="flat" w="0">
+                      <a:noFill/>
+                      <a:prstDash val="solid"/>
+                    </a:lnL>
+                    <a:lnR algn="ctr" cmpd="sng" cap="flat" w="0">
+                      <a:noFill/>
+                      <a:prstDash val="solid"/>
+                    </a:lnR>
+                    <a:lnT algn="ctr" cmpd="sng" cap="flat" w="0">
+                      <a:noFill/>
+                      <a:prstDash val="solid"/>
+                    </a:lnT>
+                    <a:lnB algn="ctr" cmpd="sng" cap="flat" w="0">
+                      <a:noFill/>
+                      <a:prstDash val="solid"/>
+                    </a:lnB>
+                    <a:solidFill>
+                      <a:srgbClr val="F4F8FB">
+                        <a:alpha val="100000"/>
+                      </a:srgbClr>
+                    </a:solidFill>
+                  </a:tcPr>
+                </a:tc>
+                <a:tc>
+                  <a:txBody>
+                    <a:bodyPr/>
+                    <a:lstStyle/>
+                    <a:p>
+                      <a:pPr algn="l" marL="63500" marR="63500">
+                        <a:lnSpc>
+                          <a:spcPct val="100000"/>
+                        </a:lnSpc>
+                        <a:spcBef>
+                          <a:spcPts val="500"/>
+                        </a:spcBef>
+                        <a:spcAft>
+                          <a:spcPts val="500"/>
+                        </a:spcAft>
+                        <a:buNone/>
+                      </a:pPr>
+                      <a:r>
+                        <a:rPr cap="none" sz="1200" i="0" b="0" u="none" strike="noStrike">
+                          <a:solidFill>
+                            <a:srgbClr val="5B6770">
+                              <a:alpha val="100000"/>
+                            </a:srgbClr>
+                          </a:solidFill>
+                          <a:latin typeface="Helvetica Neue"/>
+                          <a:cs typeface="Helvetica Neue"/>
+                          <a:ea typeface="Helvetica Neue"/>
+                          <a:sym typeface="Helvetica Neue"/>
+                        </a:rPr>
+                        <a:t>605975</a:t>
+                      </a:r>
+                    </a:p>
+                  </a:txBody>
+                  <a:tcPr anchor="ctr" marB="63500" marT="63500" marR="0" marL="0">
+                    <a:lnL algn="ctr" cmpd="sng" cap="flat" w="0">
+                      <a:noFill/>
+                      <a:prstDash val="solid"/>
+                    </a:lnL>
+                    <a:lnR algn="ctr" cmpd="sng" cap="flat" w="0">
+                      <a:noFill/>
+                      <a:prstDash val="solid"/>
+                    </a:lnR>
+                    <a:lnT algn="ctr" cmpd="sng" cap="flat" w="0">
+                      <a:noFill/>
+                      <a:prstDash val="solid"/>
+                    </a:lnT>
+                    <a:lnB algn="ctr" cmpd="sng" cap="flat" w="0">
+                      <a:noFill/>
+                      <a:prstDash val="solid"/>
+                    </a:lnB>
+                    <a:solidFill>
+                      <a:srgbClr val="F4F8FB">
+                        <a:alpha val="100000"/>
+                      </a:srgbClr>
+                    </a:solidFill>
+                  </a:tcPr>
+                </a:tc>
+              </a:tr>
+              <a:tr h="401320">
+                <a:tc>
+                  <a:txBody>
+                    <a:bodyPr/>
+                    <a:lstStyle/>
+                    <a:p>
+                      <a:pPr algn="l" marL="63500" marR="63500">
+                        <a:lnSpc>
+                          <a:spcPct val="100000"/>
+                        </a:lnSpc>
+                        <a:spcBef>
+                          <a:spcPts val="500"/>
+                        </a:spcBef>
+                        <a:spcAft>
+                          <a:spcPts val="500"/>
+                        </a:spcAft>
+                        <a:buNone/>
+                      </a:pPr>
+                      <a:r>
+                        <a:rPr cap="none" sz="1200" i="0" b="0" u="none" strike="noStrike">
+                          <a:solidFill>
+                            <a:srgbClr val="5B6770">
+                              <a:alpha val="100000"/>
+                            </a:srgbClr>
+                          </a:solidFill>
+                          <a:latin typeface="Helvetica Neue"/>
+                          <a:cs typeface="Helvetica Neue"/>
+                          <a:ea typeface="Helvetica Neue"/>
+                          <a:sym typeface="Helvetica Neue"/>
+                        </a:rPr>
                         <a:t>naphazoline</a:t>
                       </a:r>
                     </a:p>
@@ -13602,7 +14176,7 @@
                   </a:tcPr>
                 </a:tc>
               </a:tr>
-              <a:tr h="401320">
+              <a:tr h="410845">
                 <a:tc>
                   <a:txBody>
                     <a:bodyPr/>
@@ -13649,8 +14223,12 @@
                       <a:noFill/>
                       <a:prstDash val="solid"/>
                     </a:lnT>
-                    <a:lnB algn="ctr" cmpd="sng" cap="flat" w="0">
-                      <a:noFill/>
+                    <a:lnB algn="ctr" cmpd="sng" cap="flat" w="19050">
+                      <a:solidFill>
+                        <a:srgbClr val="666666">
+                          <a:alpha val="100000"/>
+                        </a:srgbClr>
+                      </a:solidFill>
                       <a:prstDash val="solid"/>
                     </a:lnB>
                     <a:solidFill>
@@ -13706,8 +14284,12 @@
                       <a:noFill/>
                       <a:prstDash val="solid"/>
                     </a:lnT>
-                    <a:lnB algn="ctr" cmpd="sng" cap="flat" w="0">
-                      <a:noFill/>
+                    <a:lnB algn="ctr" cmpd="sng" cap="flat" w="19050">
+                      <a:solidFill>
+                        <a:srgbClr val="666666">
+                          <a:alpha val="100000"/>
+                        </a:srgbClr>
+                      </a:solidFill>
                       <a:prstDash val="solid"/>
                     </a:lnB>
                     <a:solidFill>
@@ -13763,8 +14345,12 @@
                       <a:noFill/>
                       <a:prstDash val="solid"/>
                     </a:lnT>
-                    <a:lnB algn="ctr" cmpd="sng" cap="flat" w="0">
-                      <a:noFill/>
+                    <a:lnB algn="ctr" cmpd="sng" cap="flat" w="19050">
+                      <a:solidFill>
+                        <a:srgbClr val="666666">
+                          <a:alpha val="100000"/>
+                        </a:srgbClr>
+                      </a:solidFill>
                       <a:prstDash val="solid"/>
                     </a:lnB>
                     <a:solidFill>
@@ -13820,8 +14406,12 @@
                       <a:noFill/>
                       <a:prstDash val="solid"/>
                     </a:lnT>
-                    <a:lnB algn="ctr" cmpd="sng" cap="flat" w="0">
-                      <a:noFill/>
+                    <a:lnB algn="ctr" cmpd="sng" cap="flat" w="19050">
+                      <a:solidFill>
+                        <a:srgbClr val="666666">
+                          <a:alpha val="100000"/>
+                        </a:srgbClr>
+                      </a:solidFill>
                       <a:prstDash val="solid"/>
                     </a:lnB>
                     <a:solidFill>
@@ -13861,596 +14451,6 @@
                           <a:sym typeface="Helvetica Neue"/>
                         </a:rPr>
                         <a:t>900889</a:t>
-                      </a:r>
-                    </a:p>
-                  </a:txBody>
-                  <a:tcPr anchor="ctr" marB="63500" marT="63500" marR="0" marL="0">
-                    <a:lnL algn="ctr" cmpd="sng" cap="flat" w="0">
-                      <a:noFill/>
-                      <a:prstDash val="solid"/>
-                    </a:lnL>
-                    <a:lnR algn="ctr" cmpd="sng" cap="flat" w="0">
-                      <a:noFill/>
-                      <a:prstDash val="solid"/>
-                    </a:lnR>
-                    <a:lnT algn="ctr" cmpd="sng" cap="flat" w="0">
-                      <a:noFill/>
-                      <a:prstDash val="solid"/>
-                    </a:lnT>
-                    <a:lnB algn="ctr" cmpd="sng" cap="flat" w="0">
-                      <a:noFill/>
-                      <a:prstDash val="solid"/>
-                    </a:lnB>
-                    <a:solidFill>
-                      <a:srgbClr val="F4F8FB">
-                        <a:alpha val="100000"/>
-                      </a:srgbClr>
-                    </a:solidFill>
-                  </a:tcPr>
-                </a:tc>
-              </a:tr>
-              <a:tr h="401320">
-                <a:tc>
-                  <a:txBody>
-                    <a:bodyPr/>
-                    <a:lstStyle/>
-                    <a:p>
-                      <a:pPr algn="l" marL="63500" marR="63500">
-                        <a:lnSpc>
-                          <a:spcPct val="100000"/>
-                        </a:lnSpc>
-                        <a:spcBef>
-                          <a:spcPts val="500"/>
-                        </a:spcBef>
-                        <a:spcAft>
-                          <a:spcPts val="500"/>
-                        </a:spcAft>
-                        <a:buNone/>
-                      </a:pPr>
-                      <a:r>
-                        <a:rPr cap="none" sz="1200" i="0" b="0" u="none" strike="noStrike">
-                          <a:solidFill>
-                            <a:srgbClr val="5B6770">
-                              <a:alpha val="100000"/>
-                            </a:srgbClr>
-                          </a:solidFill>
-                          <a:latin typeface="Helvetica Neue"/>
-                          <a:cs typeface="Helvetica Neue"/>
-                          <a:ea typeface="Helvetica Neue"/>
-                          <a:sym typeface="Helvetica Neue"/>
-                        </a:rPr>
-                        <a:t>fentanyl methylene homolog</a:t>
-                      </a:r>
-                    </a:p>
-                  </a:txBody>
-                  <a:tcPr anchor="ctr" marB="63500" marT="63500" marR="0" marL="0">
-                    <a:lnL algn="ctr" cmpd="sng" cap="flat" w="0">
-                      <a:noFill/>
-                      <a:prstDash val="solid"/>
-                    </a:lnL>
-                    <a:lnR algn="ctr" cmpd="sng" cap="flat" w="0">
-                      <a:noFill/>
-                      <a:prstDash val="solid"/>
-                    </a:lnR>
-                    <a:lnT algn="ctr" cmpd="sng" cap="flat" w="0">
-                      <a:noFill/>
-                      <a:prstDash val="solid"/>
-                    </a:lnT>
-                    <a:lnB algn="ctr" cmpd="sng" cap="flat" w="0">
-                      <a:noFill/>
-                      <a:prstDash val="solid"/>
-                    </a:lnB>
-                    <a:solidFill>
-                      <a:srgbClr val="FFFFFF">
-                        <a:alpha val="0"/>
-                      </a:srgbClr>
-                    </a:solidFill>
-                  </a:tcPr>
-                </a:tc>
-                <a:tc>
-                  <a:txBody>
-                    <a:bodyPr/>
-                    <a:lstStyle/>
-                    <a:p>
-                      <a:pPr algn="l" marL="63500" marR="63500">
-                        <a:lnSpc>
-                          <a:spcPct val="100000"/>
-                        </a:lnSpc>
-                        <a:spcBef>
-                          <a:spcPts val="500"/>
-                        </a:spcBef>
-                        <a:spcAft>
-                          <a:spcPts val="500"/>
-                        </a:spcAft>
-                        <a:buNone/>
-                      </a:pPr>
-                      <a:r>
-                        <a:rPr cap="none" sz="1200" i="0" b="0" u="none" strike="noStrike">
-                          <a:solidFill>
-                            <a:srgbClr val="5B6770">
-                              <a:alpha val="100000"/>
-                            </a:srgbClr>
-                          </a:solidFill>
-                          <a:latin typeface="Helvetica Neue"/>
-                          <a:cs typeface="Helvetica Neue"/>
-                          <a:ea typeface="Helvetica Neue"/>
-                          <a:sym typeface="Helvetica Neue"/>
-                        </a:rPr>
-                        <a:t>16 Jul 2026</a:t>
-                      </a:r>
-                    </a:p>
-                  </a:txBody>
-                  <a:tcPr anchor="ctr" marB="63500" marT="63500" marR="0" marL="0">
-                    <a:lnL algn="ctr" cmpd="sng" cap="flat" w="0">
-                      <a:noFill/>
-                      <a:prstDash val="solid"/>
-                    </a:lnL>
-                    <a:lnR algn="ctr" cmpd="sng" cap="flat" w="0">
-                      <a:noFill/>
-                      <a:prstDash val="solid"/>
-                    </a:lnR>
-                    <a:lnT algn="ctr" cmpd="sng" cap="flat" w="0">
-                      <a:noFill/>
-                      <a:prstDash val="solid"/>
-                    </a:lnT>
-                    <a:lnB algn="ctr" cmpd="sng" cap="flat" w="0">
-                      <a:noFill/>
-                      <a:prstDash val="solid"/>
-                    </a:lnB>
-                    <a:solidFill>
-                      <a:srgbClr val="FFFFFF">
-                        <a:alpha val="0"/>
-                      </a:srgbClr>
-                    </a:solidFill>
-                  </a:tcPr>
-                </a:tc>
-                <a:tc>
-                  <a:txBody>
-                    <a:bodyPr/>
-                    <a:lstStyle/>
-                    <a:p>
-                      <a:pPr algn="l" marL="63500" marR="63500">
-                        <a:lnSpc>
-                          <a:spcPct val="100000"/>
-                        </a:lnSpc>
-                        <a:spcBef>
-                          <a:spcPts val="500"/>
-                        </a:spcBef>
-                        <a:spcAft>
-                          <a:spcPts val="500"/>
-                        </a:spcAft>
-                        <a:buNone/>
-                      </a:pPr>
-                      <a:r>
-                        <a:rPr cap="none" sz="1200" i="0" b="0" u="none" strike="noStrike">
-                          <a:solidFill>
-                            <a:srgbClr val="5B6770">
-                              <a:alpha val="100000"/>
-                            </a:srgbClr>
-                          </a:solidFill>
-                          <a:latin typeface="Helvetica Neue"/>
-                          <a:cs typeface="Helvetica Neue"/>
-                          <a:ea typeface="Helvetica Neue"/>
-                          <a:sym typeface="Helvetica Neue"/>
-                        </a:rPr>
-                        <a:t>trace</a:t>
-                      </a:r>
-                    </a:p>
-                  </a:txBody>
-                  <a:tcPr anchor="ctr" marB="63500" marT="63500" marR="0" marL="0">
-                    <a:lnL algn="ctr" cmpd="sng" cap="flat" w="0">
-                      <a:noFill/>
-                      <a:prstDash val="solid"/>
-                    </a:lnL>
-                    <a:lnR algn="ctr" cmpd="sng" cap="flat" w="0">
-                      <a:noFill/>
-                      <a:prstDash val="solid"/>
-                    </a:lnR>
-                    <a:lnT algn="ctr" cmpd="sng" cap="flat" w="0">
-                      <a:noFill/>
-                      <a:prstDash val="solid"/>
-                    </a:lnT>
-                    <a:lnB algn="ctr" cmpd="sng" cap="flat" w="0">
-                      <a:noFill/>
-                      <a:prstDash val="solid"/>
-                    </a:lnB>
-                    <a:solidFill>
-                      <a:srgbClr val="FFFFFF">
-                        <a:alpha val="0"/>
-                      </a:srgbClr>
-                    </a:solidFill>
-                  </a:tcPr>
-                </a:tc>
-                <a:tc>
-                  <a:txBody>
-                    <a:bodyPr/>
-                    <a:lstStyle/>
-                    <a:p>
-                      <a:pPr algn="r" marL="63500" marR="63500">
-                        <a:lnSpc>
-                          <a:spcPct val="100000"/>
-                        </a:lnSpc>
-                        <a:spcBef>
-                          <a:spcPts val="500"/>
-                        </a:spcBef>
-                        <a:spcAft>
-                          <a:spcPts val="500"/>
-                        </a:spcAft>
-                        <a:buNone/>
-                      </a:pPr>
-                      <a:r>
-                        <a:rPr cap="none" sz="1200" i="0" b="0" u="none" strike="noStrike">
-                          <a:solidFill>
-                            <a:srgbClr val="5B6770">
-                              <a:alpha val="100000"/>
-                            </a:srgbClr>
-                          </a:solidFill>
-                          <a:latin typeface="Helvetica Neue"/>
-                          <a:cs typeface="Helvetica Neue"/>
-                          <a:ea typeface="Helvetica Neue"/>
-                          <a:sym typeface="Helvetica Neue"/>
-                        </a:rPr>
-                        <a:t>1</a:t>
-                      </a:r>
-                    </a:p>
-                  </a:txBody>
-                  <a:tcPr anchor="ctr" marB="63500" marT="63500" marR="0" marL="0">
-                    <a:lnL algn="ctr" cmpd="sng" cap="flat" w="0">
-                      <a:noFill/>
-                      <a:prstDash val="solid"/>
-                    </a:lnL>
-                    <a:lnR algn="ctr" cmpd="sng" cap="flat" w="0">
-                      <a:noFill/>
-                      <a:prstDash val="solid"/>
-                    </a:lnR>
-                    <a:lnT algn="ctr" cmpd="sng" cap="flat" w="0">
-                      <a:noFill/>
-                      <a:prstDash val="solid"/>
-                    </a:lnT>
-                    <a:lnB algn="ctr" cmpd="sng" cap="flat" w="0">
-                      <a:noFill/>
-                      <a:prstDash val="solid"/>
-                    </a:lnB>
-                    <a:solidFill>
-                      <a:srgbClr val="FFFFFF">
-                        <a:alpha val="0"/>
-                      </a:srgbClr>
-                    </a:solidFill>
-                  </a:tcPr>
-                </a:tc>
-                <a:tc>
-                  <a:txBody>
-                    <a:bodyPr/>
-                    <a:lstStyle/>
-                    <a:p>
-                      <a:pPr algn="l" marL="63500" marR="63500">
-                        <a:lnSpc>
-                          <a:spcPct val="100000"/>
-                        </a:lnSpc>
-                        <a:spcBef>
-                          <a:spcPts val="500"/>
-                        </a:spcBef>
-                        <a:spcAft>
-                          <a:spcPts val="500"/>
-                        </a:spcAft>
-                        <a:buNone/>
-                      </a:pPr>
-                      <a:r>
-                        <a:rPr cap="none" sz="1200" i="0" b="0" u="none" strike="noStrike">
-                          <a:solidFill>
-                            <a:srgbClr val="5B6770">
-                              <a:alpha val="100000"/>
-                            </a:srgbClr>
-                          </a:solidFill>
-                          <a:latin typeface="Helvetica Neue"/>
-                          <a:cs typeface="Helvetica Neue"/>
-                          <a:ea typeface="Helvetica Neue"/>
-                          <a:sym typeface="Helvetica Neue"/>
-                        </a:rPr>
-                        <a:t>900796</a:t>
-                      </a:r>
-                    </a:p>
-                  </a:txBody>
-                  <a:tcPr anchor="ctr" marB="63500" marT="63500" marR="0" marL="0">
-                    <a:lnL algn="ctr" cmpd="sng" cap="flat" w="0">
-                      <a:noFill/>
-                      <a:prstDash val="solid"/>
-                    </a:lnL>
-                    <a:lnR algn="ctr" cmpd="sng" cap="flat" w="0">
-                      <a:noFill/>
-                      <a:prstDash val="solid"/>
-                    </a:lnR>
-                    <a:lnT algn="ctr" cmpd="sng" cap="flat" w="0">
-                      <a:noFill/>
-                      <a:prstDash val="solid"/>
-                    </a:lnT>
-                    <a:lnB algn="ctr" cmpd="sng" cap="flat" w="0">
-                      <a:noFill/>
-                      <a:prstDash val="solid"/>
-                    </a:lnB>
-                    <a:solidFill>
-                      <a:srgbClr val="FFFFFF">
-                        <a:alpha val="0"/>
-                      </a:srgbClr>
-                    </a:solidFill>
-                  </a:tcPr>
-                </a:tc>
-              </a:tr>
-              <a:tr h="410845">
-                <a:tc>
-                  <a:txBody>
-                    <a:bodyPr/>
-                    <a:lstStyle/>
-                    <a:p>
-                      <a:pPr algn="l" marL="63500" marR="63500">
-                        <a:lnSpc>
-                          <a:spcPct val="100000"/>
-                        </a:lnSpc>
-                        <a:spcBef>
-                          <a:spcPts val="500"/>
-                        </a:spcBef>
-                        <a:spcAft>
-                          <a:spcPts val="500"/>
-                        </a:spcAft>
-                        <a:buNone/>
-                      </a:pPr>
-                      <a:r>
-                        <a:rPr cap="none" sz="1200" i="0" b="0" u="none" strike="noStrike">
-                          <a:solidFill>
-                            <a:srgbClr val="5B6770">
-                              <a:alpha val="100000"/>
-                            </a:srgbClr>
-                          </a:solidFill>
-                          <a:latin typeface="Helvetica Neue"/>
-                          <a:cs typeface="Helvetica Neue"/>
-                          <a:ea typeface="Helvetica Neue"/>
-                          <a:sym typeface="Helvetica Neue"/>
-                        </a:rPr>
-                        <a:t>retatrutide</a:t>
-                      </a:r>
-                    </a:p>
-                  </a:txBody>
-                  <a:tcPr anchor="ctr" marB="63500" marT="63500" marR="0" marL="0">
-                    <a:lnL algn="ctr" cmpd="sng" cap="flat" w="0">
-                      <a:noFill/>
-                      <a:prstDash val="solid"/>
-                    </a:lnL>
-                    <a:lnR algn="ctr" cmpd="sng" cap="flat" w="0">
-                      <a:noFill/>
-                      <a:prstDash val="solid"/>
-                    </a:lnR>
-                    <a:lnT algn="ctr" cmpd="sng" cap="flat" w="0">
-                      <a:noFill/>
-                      <a:prstDash val="solid"/>
-                    </a:lnT>
-                    <a:lnB algn="ctr" cmpd="sng" cap="flat" w="19050">
-                      <a:solidFill>
-                        <a:srgbClr val="666666">
-                          <a:alpha val="100000"/>
-                        </a:srgbClr>
-                      </a:solidFill>
-                      <a:prstDash val="solid"/>
-                    </a:lnB>
-                    <a:solidFill>
-                      <a:srgbClr val="F4F8FB">
-                        <a:alpha val="100000"/>
-                      </a:srgbClr>
-                    </a:solidFill>
-                  </a:tcPr>
-                </a:tc>
-                <a:tc>
-                  <a:txBody>
-                    <a:bodyPr/>
-                    <a:lstStyle/>
-                    <a:p>
-                      <a:pPr algn="l" marL="63500" marR="63500">
-                        <a:lnSpc>
-                          <a:spcPct val="100000"/>
-                        </a:lnSpc>
-                        <a:spcBef>
-                          <a:spcPts val="500"/>
-                        </a:spcBef>
-                        <a:spcAft>
-                          <a:spcPts val="500"/>
-                        </a:spcAft>
-                        <a:buNone/>
-                      </a:pPr>
-                      <a:r>
-                        <a:rPr cap="none" sz="1200" i="0" b="0" u="none" strike="noStrike">
-                          <a:solidFill>
-                            <a:srgbClr val="5B6770">
-                              <a:alpha val="100000"/>
-                            </a:srgbClr>
-                          </a:solidFill>
-                          <a:latin typeface="Helvetica Neue"/>
-                          <a:cs typeface="Helvetica Neue"/>
-                          <a:ea typeface="Helvetica Neue"/>
-                          <a:sym typeface="Helvetica Neue"/>
-                        </a:rPr>
-                        <a:t>13 Jul 2026</a:t>
-                      </a:r>
-                    </a:p>
-                  </a:txBody>
-                  <a:tcPr anchor="ctr" marB="63500" marT="63500" marR="0" marL="0">
-                    <a:lnL algn="ctr" cmpd="sng" cap="flat" w="0">
-                      <a:noFill/>
-                      <a:prstDash val="solid"/>
-                    </a:lnL>
-                    <a:lnR algn="ctr" cmpd="sng" cap="flat" w="0">
-                      <a:noFill/>
-                      <a:prstDash val="solid"/>
-                    </a:lnR>
-                    <a:lnT algn="ctr" cmpd="sng" cap="flat" w="0">
-                      <a:noFill/>
-                      <a:prstDash val="solid"/>
-                    </a:lnT>
-                    <a:lnB algn="ctr" cmpd="sng" cap="flat" w="19050">
-                      <a:solidFill>
-                        <a:srgbClr val="666666">
-                          <a:alpha val="100000"/>
-                        </a:srgbClr>
-                      </a:solidFill>
-                      <a:prstDash val="solid"/>
-                    </a:lnB>
-                    <a:solidFill>
-                      <a:srgbClr val="F4F8FB">
-                        <a:alpha val="100000"/>
-                      </a:srgbClr>
-                    </a:solidFill>
-                  </a:tcPr>
-                </a:tc>
-                <a:tc>
-                  <a:txBody>
-                    <a:bodyPr/>
-                    <a:lstStyle/>
-                    <a:p>
-                      <a:pPr algn="l" marL="63500" marR="63500">
-                        <a:lnSpc>
-                          <a:spcPct val="100000"/>
-                        </a:lnSpc>
-                        <a:spcBef>
-                          <a:spcPts val="500"/>
-                        </a:spcBef>
-                        <a:spcAft>
-                          <a:spcPts val="500"/>
-                        </a:spcAft>
-                        <a:buNone/>
-                      </a:pPr>
-                      <a:r>
-                        <a:rPr cap="none" sz="1200" i="0" b="0" u="none" strike="noStrike">
-                          <a:solidFill>
-                            <a:srgbClr val="5B6770">
-                              <a:alpha val="100000"/>
-                            </a:srgbClr>
-                          </a:solidFill>
-                          <a:latin typeface="Helvetica Neue"/>
-                          <a:cs typeface="Helvetica Neue"/>
-                          <a:ea typeface="Helvetica Neue"/>
-                          <a:sym typeface="Helvetica Neue"/>
-                        </a:rPr>
-                        <a:t>primary</a:t>
-                      </a:r>
-                    </a:p>
-                  </a:txBody>
-                  <a:tcPr anchor="ctr" marB="63500" marT="63500" marR="0" marL="0">
-                    <a:lnL algn="ctr" cmpd="sng" cap="flat" w="0">
-                      <a:noFill/>
-                      <a:prstDash val="solid"/>
-                    </a:lnL>
-                    <a:lnR algn="ctr" cmpd="sng" cap="flat" w="0">
-                      <a:noFill/>
-                      <a:prstDash val="solid"/>
-                    </a:lnR>
-                    <a:lnT algn="ctr" cmpd="sng" cap="flat" w="0">
-                      <a:noFill/>
-                      <a:prstDash val="solid"/>
-                    </a:lnT>
-                    <a:lnB algn="ctr" cmpd="sng" cap="flat" w="19050">
-                      <a:solidFill>
-                        <a:srgbClr val="666666">
-                          <a:alpha val="100000"/>
-                        </a:srgbClr>
-                      </a:solidFill>
-                      <a:prstDash val="solid"/>
-                    </a:lnB>
-                    <a:solidFill>
-                      <a:srgbClr val="F4F8FB">
-                        <a:alpha val="100000"/>
-                      </a:srgbClr>
-                    </a:solidFill>
-                  </a:tcPr>
-                </a:tc>
-                <a:tc>
-                  <a:txBody>
-                    <a:bodyPr/>
-                    <a:lstStyle/>
-                    <a:p>
-                      <a:pPr algn="r" marL="63500" marR="63500">
-                        <a:lnSpc>
-                          <a:spcPct val="100000"/>
-                        </a:lnSpc>
-                        <a:spcBef>
-                          <a:spcPts val="500"/>
-                        </a:spcBef>
-                        <a:spcAft>
-                          <a:spcPts val="500"/>
-                        </a:spcAft>
-                        <a:buNone/>
-                      </a:pPr>
-                      <a:r>
-                        <a:rPr cap="none" sz="1200" i="0" b="0" u="none" strike="noStrike">
-                          <a:solidFill>
-                            <a:srgbClr val="5B6770">
-                              <a:alpha val="100000"/>
-                            </a:srgbClr>
-                          </a:solidFill>
-                          <a:latin typeface="Helvetica Neue"/>
-                          <a:cs typeface="Helvetica Neue"/>
-                          <a:ea typeface="Helvetica Neue"/>
-                          <a:sym typeface="Helvetica Neue"/>
-                        </a:rPr>
-                        <a:t>1</a:t>
-                      </a:r>
-                    </a:p>
-                  </a:txBody>
-                  <a:tcPr anchor="ctr" marB="63500" marT="63500" marR="0" marL="0">
-                    <a:lnL algn="ctr" cmpd="sng" cap="flat" w="0">
-                      <a:noFill/>
-                      <a:prstDash val="solid"/>
-                    </a:lnL>
-                    <a:lnR algn="ctr" cmpd="sng" cap="flat" w="0">
-                      <a:noFill/>
-                      <a:prstDash val="solid"/>
-                    </a:lnR>
-                    <a:lnT algn="ctr" cmpd="sng" cap="flat" w="0">
-                      <a:noFill/>
-                      <a:prstDash val="solid"/>
-                    </a:lnT>
-                    <a:lnB algn="ctr" cmpd="sng" cap="flat" w="19050">
-                      <a:solidFill>
-                        <a:srgbClr val="666666">
-                          <a:alpha val="100000"/>
-                        </a:srgbClr>
-                      </a:solidFill>
-                      <a:prstDash val="solid"/>
-                    </a:lnB>
-                    <a:solidFill>
-                      <a:srgbClr val="F4F8FB">
-                        <a:alpha val="100000"/>
-                      </a:srgbClr>
-                    </a:solidFill>
-                  </a:tcPr>
-                </a:tc>
-                <a:tc>
-                  <a:txBody>
-                    <a:bodyPr/>
-                    <a:lstStyle/>
-                    <a:p>
-                      <a:pPr algn="l" marL="63500" marR="63500">
-                        <a:lnSpc>
-                          <a:spcPct val="100000"/>
-                        </a:lnSpc>
-                        <a:spcBef>
-                          <a:spcPts val="500"/>
-                        </a:spcBef>
-                        <a:spcAft>
-                          <a:spcPts val="500"/>
-                        </a:spcAft>
-                        <a:buNone/>
-                      </a:pPr>
-                      <a:r>
-                        <a:rPr cap="none" sz="1200" i="0" b="0" u="none" strike="noStrike">
-                          <a:solidFill>
-                            <a:srgbClr val="5B6770">
-                              <a:alpha val="100000"/>
-                            </a:srgbClr>
-                          </a:solidFill>
-                          <a:latin typeface="Helvetica Neue"/>
-                          <a:cs typeface="Helvetica Neue"/>
-                          <a:ea typeface="Helvetica Neue"/>
-                          <a:sym typeface="Helvetica Neue"/>
-                        </a:rPr>
-                        <a:t>603217</a:t>
                       </a:r>
                     </a:p>
                   </a:txBody>
@@ -20591,7 +20591,7 @@
                           <a:ea typeface="Helvetica Neue"/>
                           <a:sym typeface="Helvetica Neue"/>
                         </a:rPr>
-                        <a:t>1,752</a:t>
+                        <a:t>1,753</a:t>
                       </a:r>
                     </a:p>
                   </a:txBody>
@@ -24579,7 +24579,7 @@
             <a:tbl>
               <a:tblPr/>
               <a:tblGrid>
-                <a:gridCol w="2462983"/>
+                <a:gridCol w="2106837"/>
                 <a:gridCol w="1237011"/>
                 <a:gridCol w="1218929"/>
                 <a:gridCol w="1186187"/>
@@ -24942,6 +24942,580 @@
                           <a:ea typeface="Helvetica Neue"/>
                           <a:sym typeface="Helvetica Neue"/>
                         </a:rPr>
+                        <a:t>cannabigerol</a:t>
+                      </a:r>
+                    </a:p>
+                  </a:txBody>
+                  <a:tcPr anchor="ctr" marB="63500" marT="63500" marR="0" marL="0">
+                    <a:lnL algn="ctr" cmpd="sng" cap="flat" w="0">
+                      <a:noFill/>
+                      <a:prstDash val="solid"/>
+                    </a:lnL>
+                    <a:lnR algn="ctr" cmpd="sng" cap="flat" w="0">
+                      <a:noFill/>
+                      <a:prstDash val="solid"/>
+                    </a:lnR>
+                    <a:lnT algn="ctr" cmpd="sng" cap="flat" w="0">
+                      <a:noFill/>
+                      <a:prstDash val="solid"/>
+                    </a:lnT>
+                    <a:lnB algn="ctr" cmpd="sng" cap="flat" w="0">
+                      <a:noFill/>
+                      <a:prstDash val="solid"/>
+                    </a:lnB>
+                    <a:solidFill>
+                      <a:srgbClr val="FFFFFF">
+                        <a:alpha val="0"/>
+                      </a:srgbClr>
+                    </a:solidFill>
+                  </a:tcPr>
+                </a:tc>
+                <a:tc>
+                  <a:txBody>
+                    <a:bodyPr/>
+                    <a:lstStyle/>
+                    <a:p>
+                      <a:pPr algn="l" marL="63500" marR="63500">
+                        <a:lnSpc>
+                          <a:spcPct val="100000"/>
+                        </a:lnSpc>
+                        <a:spcBef>
+                          <a:spcPts val="500"/>
+                        </a:spcBef>
+                        <a:spcAft>
+                          <a:spcPts val="500"/>
+                        </a:spcAft>
+                        <a:buNone/>
+                      </a:pPr>
+                      <a:r>
+                        <a:rPr cap="none" sz="1200" i="0" b="0" u="none" strike="noStrike">
+                          <a:solidFill>
+                            <a:srgbClr val="5B6770">
+                              <a:alpha val="100000"/>
+                            </a:srgbClr>
+                          </a:solidFill>
+                          <a:latin typeface="Helvetica Neue"/>
+                          <a:cs typeface="Helvetica Neue"/>
+                          <a:ea typeface="Helvetica Neue"/>
+                          <a:sym typeface="Helvetica Neue"/>
+                        </a:rPr>
+                        <a:t>05 Oct 2026</a:t>
+                      </a:r>
+                    </a:p>
+                  </a:txBody>
+                  <a:tcPr anchor="ctr" marB="63500" marT="63500" marR="0" marL="0">
+                    <a:lnL algn="ctr" cmpd="sng" cap="flat" w="0">
+                      <a:noFill/>
+                      <a:prstDash val="solid"/>
+                    </a:lnL>
+                    <a:lnR algn="ctr" cmpd="sng" cap="flat" w="0">
+                      <a:noFill/>
+                      <a:prstDash val="solid"/>
+                    </a:lnR>
+                    <a:lnT algn="ctr" cmpd="sng" cap="flat" w="0">
+                      <a:noFill/>
+                      <a:prstDash val="solid"/>
+                    </a:lnT>
+                    <a:lnB algn="ctr" cmpd="sng" cap="flat" w="0">
+                      <a:noFill/>
+                      <a:prstDash val="solid"/>
+                    </a:lnB>
+                    <a:solidFill>
+                      <a:srgbClr val="FFFFFF">
+                        <a:alpha val="0"/>
+                      </a:srgbClr>
+                    </a:solidFill>
+                  </a:tcPr>
+                </a:tc>
+                <a:tc>
+                  <a:txBody>
+                    <a:bodyPr/>
+                    <a:lstStyle/>
+                    <a:p>
+                      <a:pPr algn="l" marL="63500" marR="63500">
+                        <a:lnSpc>
+                          <a:spcPct val="100000"/>
+                        </a:lnSpc>
+                        <a:spcBef>
+                          <a:spcPts val="500"/>
+                        </a:spcBef>
+                        <a:spcAft>
+                          <a:spcPts val="500"/>
+                        </a:spcAft>
+                        <a:buNone/>
+                      </a:pPr>
+                      <a:r>
+                        <a:rPr cap="none" sz="1200" i="0" b="0" u="none" strike="noStrike">
+                          <a:solidFill>
+                            <a:srgbClr val="5B6770">
+                              <a:alpha val="100000"/>
+                            </a:srgbClr>
+                          </a:solidFill>
+                          <a:latin typeface="Helvetica Neue"/>
+                          <a:cs typeface="Helvetica Neue"/>
+                          <a:ea typeface="Helvetica Neue"/>
+                          <a:sym typeface="Helvetica Neue"/>
+                        </a:rPr>
+                        <a:t>primary</a:t>
+                      </a:r>
+                    </a:p>
+                  </a:txBody>
+                  <a:tcPr anchor="ctr" marB="63500" marT="63500" marR="0" marL="0">
+                    <a:lnL algn="ctr" cmpd="sng" cap="flat" w="0">
+                      <a:noFill/>
+                      <a:prstDash val="solid"/>
+                    </a:lnL>
+                    <a:lnR algn="ctr" cmpd="sng" cap="flat" w="0">
+                      <a:noFill/>
+                      <a:prstDash val="solid"/>
+                    </a:lnR>
+                    <a:lnT algn="ctr" cmpd="sng" cap="flat" w="0">
+                      <a:noFill/>
+                      <a:prstDash val="solid"/>
+                    </a:lnT>
+                    <a:lnB algn="ctr" cmpd="sng" cap="flat" w="0">
+                      <a:noFill/>
+                      <a:prstDash val="solid"/>
+                    </a:lnB>
+                    <a:solidFill>
+                      <a:srgbClr val="FFFFFF">
+                        <a:alpha val="0"/>
+                      </a:srgbClr>
+                    </a:solidFill>
+                  </a:tcPr>
+                </a:tc>
+                <a:tc>
+                  <a:txBody>
+                    <a:bodyPr/>
+                    <a:lstStyle/>
+                    <a:p>
+                      <a:pPr algn="r" marL="63500" marR="63500">
+                        <a:lnSpc>
+                          <a:spcPct val="100000"/>
+                        </a:lnSpc>
+                        <a:spcBef>
+                          <a:spcPts val="500"/>
+                        </a:spcBef>
+                        <a:spcAft>
+                          <a:spcPts val="500"/>
+                        </a:spcAft>
+                        <a:buNone/>
+                      </a:pPr>
+                      <a:r>
+                        <a:rPr cap="none" sz="1200" i="0" b="0" u="none" strike="noStrike">
+                          <a:solidFill>
+                            <a:srgbClr val="5B6770">
+                              <a:alpha val="100000"/>
+                            </a:srgbClr>
+                          </a:solidFill>
+                          <a:latin typeface="Helvetica Neue"/>
+                          <a:cs typeface="Helvetica Neue"/>
+                          <a:ea typeface="Helvetica Neue"/>
+                          <a:sym typeface="Helvetica Neue"/>
+                        </a:rPr>
+                        <a:t>1</a:t>
+                      </a:r>
+                    </a:p>
+                  </a:txBody>
+                  <a:tcPr anchor="ctr" marB="63500" marT="63500" marR="0" marL="0">
+                    <a:lnL algn="ctr" cmpd="sng" cap="flat" w="0">
+                      <a:noFill/>
+                      <a:prstDash val="solid"/>
+                    </a:lnL>
+                    <a:lnR algn="ctr" cmpd="sng" cap="flat" w="0">
+                      <a:noFill/>
+                      <a:prstDash val="solid"/>
+                    </a:lnR>
+                    <a:lnT algn="ctr" cmpd="sng" cap="flat" w="0">
+                      <a:noFill/>
+                      <a:prstDash val="solid"/>
+                    </a:lnT>
+                    <a:lnB algn="ctr" cmpd="sng" cap="flat" w="0">
+                      <a:noFill/>
+                      <a:prstDash val="solid"/>
+                    </a:lnB>
+                    <a:solidFill>
+                      <a:srgbClr val="FFFFFF">
+                        <a:alpha val="0"/>
+                      </a:srgbClr>
+                    </a:solidFill>
+                  </a:tcPr>
+                </a:tc>
+                <a:tc>
+                  <a:txBody>
+                    <a:bodyPr/>
+                    <a:lstStyle/>
+                    <a:p>
+                      <a:pPr algn="l" marL="63500" marR="63500">
+                        <a:lnSpc>
+                          <a:spcPct val="100000"/>
+                        </a:lnSpc>
+                        <a:spcBef>
+                          <a:spcPts val="500"/>
+                        </a:spcBef>
+                        <a:spcAft>
+                          <a:spcPts val="500"/>
+                        </a:spcAft>
+                        <a:buNone/>
+                      </a:pPr>
+                      <a:r>
+                        <a:rPr cap="none" sz="1200" i="0" b="0" u="none" strike="noStrike">
+                          <a:solidFill>
+                            <a:srgbClr val="5B6770">
+                              <a:alpha val="100000"/>
+                            </a:srgbClr>
+                          </a:solidFill>
+                          <a:latin typeface="Helvetica Neue"/>
+                          <a:cs typeface="Helvetica Neue"/>
+                          <a:ea typeface="Helvetica Neue"/>
+                          <a:sym typeface="Helvetica Neue"/>
+                        </a:rPr>
+                        <a:t>605975</a:t>
+                      </a:r>
+                    </a:p>
+                  </a:txBody>
+                  <a:tcPr anchor="ctr" marB="63500" marT="63500" marR="0" marL="0">
+                    <a:lnL algn="ctr" cmpd="sng" cap="flat" w="0">
+                      <a:noFill/>
+                      <a:prstDash val="solid"/>
+                    </a:lnL>
+                    <a:lnR algn="ctr" cmpd="sng" cap="flat" w="0">
+                      <a:noFill/>
+                      <a:prstDash val="solid"/>
+                    </a:lnR>
+                    <a:lnT algn="ctr" cmpd="sng" cap="flat" w="0">
+                      <a:noFill/>
+                      <a:prstDash val="solid"/>
+                    </a:lnT>
+                    <a:lnB algn="ctr" cmpd="sng" cap="flat" w="0">
+                      <a:noFill/>
+                      <a:prstDash val="solid"/>
+                    </a:lnB>
+                    <a:solidFill>
+                      <a:srgbClr val="FFFFFF">
+                        <a:alpha val="0"/>
+                      </a:srgbClr>
+                    </a:solidFill>
+                  </a:tcPr>
+                </a:tc>
+              </a:tr>
+              <a:tr h="401320">
+                <a:tc>
+                  <a:txBody>
+                    <a:bodyPr/>
+                    <a:lstStyle/>
+                    <a:p>
+                      <a:pPr algn="l" marL="63500" marR="63500">
+                        <a:lnSpc>
+                          <a:spcPct val="100000"/>
+                        </a:lnSpc>
+                        <a:spcBef>
+                          <a:spcPts val="500"/>
+                        </a:spcBef>
+                        <a:spcAft>
+                          <a:spcPts val="500"/>
+                        </a:spcAft>
+                        <a:buNone/>
+                      </a:pPr>
+                      <a:r>
+                        <a:rPr cap="none" sz="1200" i="0" b="0" u="none" strike="noStrike">
+                          <a:solidFill>
+                            <a:srgbClr val="5B6770">
+                              <a:alpha val="100000"/>
+                            </a:srgbClr>
+                          </a:solidFill>
+                          <a:latin typeface="Helvetica Neue"/>
+                          <a:cs typeface="Helvetica Neue"/>
+                          <a:ea typeface="Helvetica Neue"/>
+                          <a:sym typeface="Helvetica Neue"/>
+                        </a:rPr>
+                        <a:t>delta-4(8)-iso-THC</a:t>
+                      </a:r>
+                    </a:p>
+                  </a:txBody>
+                  <a:tcPr anchor="ctr" marB="63500" marT="63500" marR="0" marL="0">
+                    <a:lnL algn="ctr" cmpd="sng" cap="flat" w="0">
+                      <a:noFill/>
+                      <a:prstDash val="solid"/>
+                    </a:lnL>
+                    <a:lnR algn="ctr" cmpd="sng" cap="flat" w="0">
+                      <a:noFill/>
+                      <a:prstDash val="solid"/>
+                    </a:lnR>
+                    <a:lnT algn="ctr" cmpd="sng" cap="flat" w="0">
+                      <a:noFill/>
+                      <a:prstDash val="solid"/>
+                    </a:lnT>
+                    <a:lnB algn="ctr" cmpd="sng" cap="flat" w="0">
+                      <a:noFill/>
+                      <a:prstDash val="solid"/>
+                    </a:lnB>
+                    <a:solidFill>
+                      <a:srgbClr val="F4F8FB">
+                        <a:alpha val="100000"/>
+                      </a:srgbClr>
+                    </a:solidFill>
+                  </a:tcPr>
+                </a:tc>
+                <a:tc>
+                  <a:txBody>
+                    <a:bodyPr/>
+                    <a:lstStyle/>
+                    <a:p>
+                      <a:pPr algn="l" marL="63500" marR="63500">
+                        <a:lnSpc>
+                          <a:spcPct val="100000"/>
+                        </a:lnSpc>
+                        <a:spcBef>
+                          <a:spcPts val="500"/>
+                        </a:spcBef>
+                        <a:spcAft>
+                          <a:spcPts val="500"/>
+                        </a:spcAft>
+                        <a:buNone/>
+                      </a:pPr>
+                      <a:r>
+                        <a:rPr cap="none" sz="1200" i="0" b="0" u="none" strike="noStrike">
+                          <a:solidFill>
+                            <a:srgbClr val="5B6770">
+                              <a:alpha val="100000"/>
+                            </a:srgbClr>
+                          </a:solidFill>
+                          <a:latin typeface="Helvetica Neue"/>
+                          <a:cs typeface="Helvetica Neue"/>
+                          <a:ea typeface="Helvetica Neue"/>
+                          <a:sym typeface="Helvetica Neue"/>
+                        </a:rPr>
+                        <a:t>05 Oct 2026</a:t>
+                      </a:r>
+                    </a:p>
+                  </a:txBody>
+                  <a:tcPr anchor="ctr" marB="63500" marT="63500" marR="0" marL="0">
+                    <a:lnL algn="ctr" cmpd="sng" cap="flat" w="0">
+                      <a:noFill/>
+                      <a:prstDash val="solid"/>
+                    </a:lnL>
+                    <a:lnR algn="ctr" cmpd="sng" cap="flat" w="0">
+                      <a:noFill/>
+                      <a:prstDash val="solid"/>
+                    </a:lnR>
+                    <a:lnT algn="ctr" cmpd="sng" cap="flat" w="0">
+                      <a:noFill/>
+                      <a:prstDash val="solid"/>
+                    </a:lnT>
+                    <a:lnB algn="ctr" cmpd="sng" cap="flat" w="0">
+                      <a:noFill/>
+                      <a:prstDash val="solid"/>
+                    </a:lnB>
+                    <a:solidFill>
+                      <a:srgbClr val="F4F8FB">
+                        <a:alpha val="100000"/>
+                      </a:srgbClr>
+                    </a:solidFill>
+                  </a:tcPr>
+                </a:tc>
+                <a:tc>
+                  <a:txBody>
+                    <a:bodyPr/>
+                    <a:lstStyle/>
+                    <a:p>
+                      <a:pPr algn="l" marL="63500" marR="63500">
+                        <a:lnSpc>
+                          <a:spcPct val="100000"/>
+                        </a:lnSpc>
+                        <a:spcBef>
+                          <a:spcPts val="500"/>
+                        </a:spcBef>
+                        <a:spcAft>
+                          <a:spcPts val="500"/>
+                        </a:spcAft>
+                        <a:buNone/>
+                      </a:pPr>
+                      <a:r>
+                        <a:rPr cap="none" sz="1200" i="0" b="0" u="none" strike="noStrike">
+                          <a:solidFill>
+                            <a:srgbClr val="5B6770">
+                              <a:alpha val="100000"/>
+                            </a:srgbClr>
+                          </a:solidFill>
+                          <a:latin typeface="Helvetica Neue"/>
+                          <a:cs typeface="Helvetica Neue"/>
+                          <a:ea typeface="Helvetica Neue"/>
+                          <a:sym typeface="Helvetica Neue"/>
+                        </a:rPr>
+                        <a:t>primary</a:t>
+                      </a:r>
+                    </a:p>
+                  </a:txBody>
+                  <a:tcPr anchor="ctr" marB="63500" marT="63500" marR="0" marL="0">
+                    <a:lnL algn="ctr" cmpd="sng" cap="flat" w="0">
+                      <a:noFill/>
+                      <a:prstDash val="solid"/>
+                    </a:lnL>
+                    <a:lnR algn="ctr" cmpd="sng" cap="flat" w="0">
+                      <a:noFill/>
+                      <a:prstDash val="solid"/>
+                    </a:lnR>
+                    <a:lnT algn="ctr" cmpd="sng" cap="flat" w="0">
+                      <a:noFill/>
+                      <a:prstDash val="solid"/>
+                    </a:lnT>
+                    <a:lnB algn="ctr" cmpd="sng" cap="flat" w="0">
+                      <a:noFill/>
+                      <a:prstDash val="solid"/>
+                    </a:lnB>
+                    <a:solidFill>
+                      <a:srgbClr val="F4F8FB">
+                        <a:alpha val="100000"/>
+                      </a:srgbClr>
+                    </a:solidFill>
+                  </a:tcPr>
+                </a:tc>
+                <a:tc>
+                  <a:txBody>
+                    <a:bodyPr/>
+                    <a:lstStyle/>
+                    <a:p>
+                      <a:pPr algn="r" marL="63500" marR="63500">
+                        <a:lnSpc>
+                          <a:spcPct val="100000"/>
+                        </a:lnSpc>
+                        <a:spcBef>
+                          <a:spcPts val="500"/>
+                        </a:spcBef>
+                        <a:spcAft>
+                          <a:spcPts val="500"/>
+                        </a:spcAft>
+                        <a:buNone/>
+                      </a:pPr>
+                      <a:r>
+                        <a:rPr cap="none" sz="1200" i="0" b="0" u="none" strike="noStrike">
+                          <a:solidFill>
+                            <a:srgbClr val="5B6770">
+                              <a:alpha val="100000"/>
+                            </a:srgbClr>
+                          </a:solidFill>
+                          <a:latin typeface="Helvetica Neue"/>
+                          <a:cs typeface="Helvetica Neue"/>
+                          <a:ea typeface="Helvetica Neue"/>
+                          <a:sym typeface="Helvetica Neue"/>
+                        </a:rPr>
+                        <a:t>1</a:t>
+                      </a:r>
+                    </a:p>
+                  </a:txBody>
+                  <a:tcPr anchor="ctr" marB="63500" marT="63500" marR="0" marL="0">
+                    <a:lnL algn="ctr" cmpd="sng" cap="flat" w="0">
+                      <a:noFill/>
+                      <a:prstDash val="solid"/>
+                    </a:lnL>
+                    <a:lnR algn="ctr" cmpd="sng" cap="flat" w="0">
+                      <a:noFill/>
+                      <a:prstDash val="solid"/>
+                    </a:lnR>
+                    <a:lnT algn="ctr" cmpd="sng" cap="flat" w="0">
+                      <a:noFill/>
+                      <a:prstDash val="solid"/>
+                    </a:lnT>
+                    <a:lnB algn="ctr" cmpd="sng" cap="flat" w="0">
+                      <a:noFill/>
+                      <a:prstDash val="solid"/>
+                    </a:lnB>
+                    <a:solidFill>
+                      <a:srgbClr val="F4F8FB">
+                        <a:alpha val="100000"/>
+                      </a:srgbClr>
+                    </a:solidFill>
+                  </a:tcPr>
+                </a:tc>
+                <a:tc>
+                  <a:txBody>
+                    <a:bodyPr/>
+                    <a:lstStyle/>
+                    <a:p>
+                      <a:pPr algn="l" marL="63500" marR="63500">
+                        <a:lnSpc>
+                          <a:spcPct val="100000"/>
+                        </a:lnSpc>
+                        <a:spcBef>
+                          <a:spcPts val="500"/>
+                        </a:spcBef>
+                        <a:spcAft>
+                          <a:spcPts val="500"/>
+                        </a:spcAft>
+                        <a:buNone/>
+                      </a:pPr>
+                      <a:r>
+                        <a:rPr cap="none" sz="1200" i="0" b="0" u="none" strike="noStrike">
+                          <a:solidFill>
+                            <a:srgbClr val="5B6770">
+                              <a:alpha val="100000"/>
+                            </a:srgbClr>
+                          </a:solidFill>
+                          <a:latin typeface="Helvetica Neue"/>
+                          <a:cs typeface="Helvetica Neue"/>
+                          <a:ea typeface="Helvetica Neue"/>
+                          <a:sym typeface="Helvetica Neue"/>
+                        </a:rPr>
+                        <a:t>605975</a:t>
+                      </a:r>
+                    </a:p>
+                  </a:txBody>
+                  <a:tcPr anchor="ctr" marB="63500" marT="63500" marR="0" marL="0">
+                    <a:lnL algn="ctr" cmpd="sng" cap="flat" w="0">
+                      <a:noFill/>
+                      <a:prstDash val="solid"/>
+                    </a:lnL>
+                    <a:lnR algn="ctr" cmpd="sng" cap="flat" w="0">
+                      <a:noFill/>
+                      <a:prstDash val="solid"/>
+                    </a:lnR>
+                    <a:lnT algn="ctr" cmpd="sng" cap="flat" w="0">
+                      <a:noFill/>
+                      <a:prstDash val="solid"/>
+                    </a:lnT>
+                    <a:lnB algn="ctr" cmpd="sng" cap="flat" w="0">
+                      <a:noFill/>
+                      <a:prstDash val="solid"/>
+                    </a:lnB>
+                    <a:solidFill>
+                      <a:srgbClr val="F4F8FB">
+                        <a:alpha val="100000"/>
+                      </a:srgbClr>
+                    </a:solidFill>
+                  </a:tcPr>
+                </a:tc>
+              </a:tr>
+              <a:tr h="401320">
+                <a:tc>
+                  <a:txBody>
+                    <a:bodyPr/>
+                    <a:lstStyle/>
+                    <a:p>
+                      <a:pPr algn="l" marL="63500" marR="63500">
+                        <a:lnSpc>
+                          <a:spcPct val="100000"/>
+                        </a:lnSpc>
+                        <a:spcBef>
+                          <a:spcPts val="500"/>
+                        </a:spcBef>
+                        <a:spcAft>
+                          <a:spcPts val="500"/>
+                        </a:spcAft>
+                        <a:buNone/>
+                      </a:pPr>
+                      <a:r>
+                        <a:rPr cap="none" sz="1200" i="0" b="0" u="none" strike="noStrike">
+                          <a:solidFill>
+                            <a:srgbClr val="5B6770">
+                              <a:alpha val="100000"/>
+                            </a:srgbClr>
+                          </a:solidFill>
+                          <a:latin typeface="Helvetica Neue"/>
+                          <a:cs typeface="Helvetica Neue"/>
+                          <a:ea typeface="Helvetica Neue"/>
+                          <a:sym typeface="Helvetica Neue"/>
+                        </a:rPr>
                         <a:t>naphazoline</a:t>
                       </a:r>
                     </a:p>
@@ -27495,7 +28069,7 @@
                   </a:tcPr>
                 </a:tc>
               </a:tr>
-              <a:tr h="401320">
+              <a:tr h="410845">
                 <a:tc>
                   <a:txBody>
                     <a:bodyPr/>
@@ -27542,8 +28116,12 @@
                       <a:noFill/>
                       <a:prstDash val="solid"/>
                     </a:lnT>
-                    <a:lnB algn="ctr" cmpd="sng" cap="flat" w="0">
-                      <a:noFill/>
+                    <a:lnB algn="ctr" cmpd="sng" cap="flat" w="19050">
+                      <a:solidFill>
+                        <a:srgbClr val="666666">
+                          <a:alpha val="100000"/>
+                        </a:srgbClr>
+                      </a:solidFill>
                       <a:prstDash val="solid"/>
                     </a:lnB>
                     <a:solidFill>
@@ -27599,8 +28177,12 @@
                       <a:noFill/>
                       <a:prstDash val="solid"/>
                     </a:lnT>
-                    <a:lnB algn="ctr" cmpd="sng" cap="flat" w="0">
-                      <a:noFill/>
+                    <a:lnB algn="ctr" cmpd="sng" cap="flat" w="19050">
+                      <a:solidFill>
+                        <a:srgbClr val="666666">
+                          <a:alpha val="100000"/>
+                        </a:srgbClr>
+                      </a:solidFill>
                       <a:prstDash val="solid"/>
                     </a:lnB>
                     <a:solidFill>
@@ -27656,8 +28238,12 @@
                       <a:noFill/>
                       <a:prstDash val="solid"/>
                     </a:lnT>
-                    <a:lnB algn="ctr" cmpd="sng" cap="flat" w="0">
-                      <a:noFill/>
+                    <a:lnB algn="ctr" cmpd="sng" cap="flat" w="19050">
+                      <a:solidFill>
+                        <a:srgbClr val="666666">
+                          <a:alpha val="100000"/>
+                        </a:srgbClr>
+                      </a:solidFill>
                       <a:prstDash val="solid"/>
                     </a:lnB>
                     <a:solidFill>
@@ -27713,8 +28299,12 @@
                       <a:noFill/>
                       <a:prstDash val="solid"/>
                     </a:lnT>
-                    <a:lnB algn="ctr" cmpd="sng" cap="flat" w="0">
-                      <a:noFill/>
+                    <a:lnB algn="ctr" cmpd="sng" cap="flat" w="19050">
+                      <a:solidFill>
+                        <a:srgbClr val="666666">
+                          <a:alpha val="100000"/>
+                        </a:srgbClr>
+                      </a:solidFill>
                       <a:prstDash val="solid"/>
                     </a:lnB>
                     <a:solidFill>
@@ -27754,596 +28344,6 @@
                           <a:sym typeface="Helvetica Neue"/>
                         </a:rPr>
                         <a:t>900889</a:t>
-                      </a:r>
-                    </a:p>
-                  </a:txBody>
-                  <a:tcPr anchor="ctr" marB="63500" marT="63500" marR="0" marL="0">
-                    <a:lnL algn="ctr" cmpd="sng" cap="flat" w="0">
-                      <a:noFill/>
-                      <a:prstDash val="solid"/>
-                    </a:lnL>
-                    <a:lnR algn="ctr" cmpd="sng" cap="flat" w="0">
-                      <a:noFill/>
-                      <a:prstDash val="solid"/>
-                    </a:lnR>
-                    <a:lnT algn="ctr" cmpd="sng" cap="flat" w="0">
-                      <a:noFill/>
-                      <a:prstDash val="solid"/>
-                    </a:lnT>
-                    <a:lnB algn="ctr" cmpd="sng" cap="flat" w="0">
-                      <a:noFill/>
-                      <a:prstDash val="solid"/>
-                    </a:lnB>
-                    <a:solidFill>
-                      <a:srgbClr val="F4F8FB">
-                        <a:alpha val="100000"/>
-                      </a:srgbClr>
-                    </a:solidFill>
-                  </a:tcPr>
-                </a:tc>
-              </a:tr>
-              <a:tr h="401320">
-                <a:tc>
-                  <a:txBody>
-                    <a:bodyPr/>
-                    <a:lstStyle/>
-                    <a:p>
-                      <a:pPr algn="l" marL="63500" marR="63500">
-                        <a:lnSpc>
-                          <a:spcPct val="100000"/>
-                        </a:lnSpc>
-                        <a:spcBef>
-                          <a:spcPts val="500"/>
-                        </a:spcBef>
-                        <a:spcAft>
-                          <a:spcPts val="500"/>
-                        </a:spcAft>
-                        <a:buNone/>
-                      </a:pPr>
-                      <a:r>
-                        <a:rPr cap="none" sz="1200" i="0" b="0" u="none" strike="noStrike">
-                          <a:solidFill>
-                            <a:srgbClr val="5B6770">
-                              <a:alpha val="100000"/>
-                            </a:srgbClr>
-                          </a:solidFill>
-                          <a:latin typeface="Helvetica Neue"/>
-                          <a:cs typeface="Helvetica Neue"/>
-                          <a:ea typeface="Helvetica Neue"/>
-                          <a:sym typeface="Helvetica Neue"/>
-                        </a:rPr>
-                        <a:t>fentanyl methylene homolog</a:t>
-                      </a:r>
-                    </a:p>
-                  </a:txBody>
-                  <a:tcPr anchor="ctr" marB="63500" marT="63500" marR="0" marL="0">
-                    <a:lnL algn="ctr" cmpd="sng" cap="flat" w="0">
-                      <a:noFill/>
-                      <a:prstDash val="solid"/>
-                    </a:lnL>
-                    <a:lnR algn="ctr" cmpd="sng" cap="flat" w="0">
-                      <a:noFill/>
-                      <a:prstDash val="solid"/>
-                    </a:lnR>
-                    <a:lnT algn="ctr" cmpd="sng" cap="flat" w="0">
-                      <a:noFill/>
-                      <a:prstDash val="solid"/>
-                    </a:lnT>
-                    <a:lnB algn="ctr" cmpd="sng" cap="flat" w="0">
-                      <a:noFill/>
-                      <a:prstDash val="solid"/>
-                    </a:lnB>
-                    <a:solidFill>
-                      <a:srgbClr val="FFFFFF">
-                        <a:alpha val="0"/>
-                      </a:srgbClr>
-                    </a:solidFill>
-                  </a:tcPr>
-                </a:tc>
-                <a:tc>
-                  <a:txBody>
-                    <a:bodyPr/>
-                    <a:lstStyle/>
-                    <a:p>
-                      <a:pPr algn="l" marL="63500" marR="63500">
-                        <a:lnSpc>
-                          <a:spcPct val="100000"/>
-                        </a:lnSpc>
-                        <a:spcBef>
-                          <a:spcPts val="500"/>
-                        </a:spcBef>
-                        <a:spcAft>
-                          <a:spcPts val="500"/>
-                        </a:spcAft>
-                        <a:buNone/>
-                      </a:pPr>
-                      <a:r>
-                        <a:rPr cap="none" sz="1200" i="0" b="0" u="none" strike="noStrike">
-                          <a:solidFill>
-                            <a:srgbClr val="5B6770">
-                              <a:alpha val="100000"/>
-                            </a:srgbClr>
-                          </a:solidFill>
-                          <a:latin typeface="Helvetica Neue"/>
-                          <a:cs typeface="Helvetica Neue"/>
-                          <a:ea typeface="Helvetica Neue"/>
-                          <a:sym typeface="Helvetica Neue"/>
-                        </a:rPr>
-                        <a:t>16 Jul 2026</a:t>
-                      </a:r>
-                    </a:p>
-                  </a:txBody>
-                  <a:tcPr anchor="ctr" marB="63500" marT="63500" marR="0" marL="0">
-                    <a:lnL algn="ctr" cmpd="sng" cap="flat" w="0">
-                      <a:noFill/>
-                      <a:prstDash val="solid"/>
-                    </a:lnL>
-                    <a:lnR algn="ctr" cmpd="sng" cap="flat" w="0">
-                      <a:noFill/>
-                      <a:prstDash val="solid"/>
-                    </a:lnR>
-                    <a:lnT algn="ctr" cmpd="sng" cap="flat" w="0">
-                      <a:noFill/>
-                      <a:prstDash val="solid"/>
-                    </a:lnT>
-                    <a:lnB algn="ctr" cmpd="sng" cap="flat" w="0">
-                      <a:noFill/>
-                      <a:prstDash val="solid"/>
-                    </a:lnB>
-                    <a:solidFill>
-                      <a:srgbClr val="FFFFFF">
-                        <a:alpha val="0"/>
-                      </a:srgbClr>
-                    </a:solidFill>
-                  </a:tcPr>
-                </a:tc>
-                <a:tc>
-                  <a:txBody>
-                    <a:bodyPr/>
-                    <a:lstStyle/>
-                    <a:p>
-                      <a:pPr algn="l" marL="63500" marR="63500">
-                        <a:lnSpc>
-                          <a:spcPct val="100000"/>
-                        </a:lnSpc>
-                        <a:spcBef>
-                          <a:spcPts val="500"/>
-                        </a:spcBef>
-                        <a:spcAft>
-                          <a:spcPts val="500"/>
-                        </a:spcAft>
-                        <a:buNone/>
-                      </a:pPr>
-                      <a:r>
-                        <a:rPr cap="none" sz="1200" i="0" b="0" u="none" strike="noStrike">
-                          <a:solidFill>
-                            <a:srgbClr val="5B6770">
-                              <a:alpha val="100000"/>
-                            </a:srgbClr>
-                          </a:solidFill>
-                          <a:latin typeface="Helvetica Neue"/>
-                          <a:cs typeface="Helvetica Neue"/>
-                          <a:ea typeface="Helvetica Neue"/>
-                          <a:sym typeface="Helvetica Neue"/>
-                        </a:rPr>
-                        <a:t>trace</a:t>
-                      </a:r>
-                    </a:p>
-                  </a:txBody>
-                  <a:tcPr anchor="ctr" marB="63500" marT="63500" marR="0" marL="0">
-                    <a:lnL algn="ctr" cmpd="sng" cap="flat" w="0">
-                      <a:noFill/>
-                      <a:prstDash val="solid"/>
-                    </a:lnL>
-                    <a:lnR algn="ctr" cmpd="sng" cap="flat" w="0">
-                      <a:noFill/>
-                      <a:prstDash val="solid"/>
-                    </a:lnR>
-                    <a:lnT algn="ctr" cmpd="sng" cap="flat" w="0">
-                      <a:noFill/>
-                      <a:prstDash val="solid"/>
-                    </a:lnT>
-                    <a:lnB algn="ctr" cmpd="sng" cap="flat" w="0">
-                      <a:noFill/>
-                      <a:prstDash val="solid"/>
-                    </a:lnB>
-                    <a:solidFill>
-                      <a:srgbClr val="FFFFFF">
-                        <a:alpha val="0"/>
-                      </a:srgbClr>
-                    </a:solidFill>
-                  </a:tcPr>
-                </a:tc>
-                <a:tc>
-                  <a:txBody>
-                    <a:bodyPr/>
-                    <a:lstStyle/>
-                    <a:p>
-                      <a:pPr algn="r" marL="63500" marR="63500">
-                        <a:lnSpc>
-                          <a:spcPct val="100000"/>
-                        </a:lnSpc>
-                        <a:spcBef>
-                          <a:spcPts val="500"/>
-                        </a:spcBef>
-                        <a:spcAft>
-                          <a:spcPts val="500"/>
-                        </a:spcAft>
-                        <a:buNone/>
-                      </a:pPr>
-                      <a:r>
-                        <a:rPr cap="none" sz="1200" i="0" b="0" u="none" strike="noStrike">
-                          <a:solidFill>
-                            <a:srgbClr val="5B6770">
-                              <a:alpha val="100000"/>
-                            </a:srgbClr>
-                          </a:solidFill>
-                          <a:latin typeface="Helvetica Neue"/>
-                          <a:cs typeface="Helvetica Neue"/>
-                          <a:ea typeface="Helvetica Neue"/>
-                          <a:sym typeface="Helvetica Neue"/>
-                        </a:rPr>
-                        <a:t>1</a:t>
-                      </a:r>
-                    </a:p>
-                  </a:txBody>
-                  <a:tcPr anchor="ctr" marB="63500" marT="63500" marR="0" marL="0">
-                    <a:lnL algn="ctr" cmpd="sng" cap="flat" w="0">
-                      <a:noFill/>
-                      <a:prstDash val="solid"/>
-                    </a:lnL>
-                    <a:lnR algn="ctr" cmpd="sng" cap="flat" w="0">
-                      <a:noFill/>
-                      <a:prstDash val="solid"/>
-                    </a:lnR>
-                    <a:lnT algn="ctr" cmpd="sng" cap="flat" w="0">
-                      <a:noFill/>
-                      <a:prstDash val="solid"/>
-                    </a:lnT>
-                    <a:lnB algn="ctr" cmpd="sng" cap="flat" w="0">
-                      <a:noFill/>
-                      <a:prstDash val="solid"/>
-                    </a:lnB>
-                    <a:solidFill>
-                      <a:srgbClr val="FFFFFF">
-                        <a:alpha val="0"/>
-                      </a:srgbClr>
-                    </a:solidFill>
-                  </a:tcPr>
-                </a:tc>
-                <a:tc>
-                  <a:txBody>
-                    <a:bodyPr/>
-                    <a:lstStyle/>
-                    <a:p>
-                      <a:pPr algn="l" marL="63500" marR="63500">
-                        <a:lnSpc>
-                          <a:spcPct val="100000"/>
-                        </a:lnSpc>
-                        <a:spcBef>
-                          <a:spcPts val="500"/>
-                        </a:spcBef>
-                        <a:spcAft>
-                          <a:spcPts val="500"/>
-                        </a:spcAft>
-                        <a:buNone/>
-                      </a:pPr>
-                      <a:r>
-                        <a:rPr cap="none" sz="1200" i="0" b="0" u="none" strike="noStrike">
-                          <a:solidFill>
-                            <a:srgbClr val="5B6770">
-                              <a:alpha val="100000"/>
-                            </a:srgbClr>
-                          </a:solidFill>
-                          <a:latin typeface="Helvetica Neue"/>
-                          <a:cs typeface="Helvetica Neue"/>
-                          <a:ea typeface="Helvetica Neue"/>
-                          <a:sym typeface="Helvetica Neue"/>
-                        </a:rPr>
-                        <a:t>900796</a:t>
-                      </a:r>
-                    </a:p>
-                  </a:txBody>
-                  <a:tcPr anchor="ctr" marB="63500" marT="63500" marR="0" marL="0">
-                    <a:lnL algn="ctr" cmpd="sng" cap="flat" w="0">
-                      <a:noFill/>
-                      <a:prstDash val="solid"/>
-                    </a:lnL>
-                    <a:lnR algn="ctr" cmpd="sng" cap="flat" w="0">
-                      <a:noFill/>
-                      <a:prstDash val="solid"/>
-                    </a:lnR>
-                    <a:lnT algn="ctr" cmpd="sng" cap="flat" w="0">
-                      <a:noFill/>
-                      <a:prstDash val="solid"/>
-                    </a:lnT>
-                    <a:lnB algn="ctr" cmpd="sng" cap="flat" w="0">
-                      <a:noFill/>
-                      <a:prstDash val="solid"/>
-                    </a:lnB>
-                    <a:solidFill>
-                      <a:srgbClr val="FFFFFF">
-                        <a:alpha val="0"/>
-                      </a:srgbClr>
-                    </a:solidFill>
-                  </a:tcPr>
-                </a:tc>
-              </a:tr>
-              <a:tr h="410845">
-                <a:tc>
-                  <a:txBody>
-                    <a:bodyPr/>
-                    <a:lstStyle/>
-                    <a:p>
-                      <a:pPr algn="l" marL="63500" marR="63500">
-                        <a:lnSpc>
-                          <a:spcPct val="100000"/>
-                        </a:lnSpc>
-                        <a:spcBef>
-                          <a:spcPts val="500"/>
-                        </a:spcBef>
-                        <a:spcAft>
-                          <a:spcPts val="500"/>
-                        </a:spcAft>
-                        <a:buNone/>
-                      </a:pPr>
-                      <a:r>
-                        <a:rPr cap="none" sz="1200" i="0" b="0" u="none" strike="noStrike">
-                          <a:solidFill>
-                            <a:srgbClr val="5B6770">
-                              <a:alpha val="100000"/>
-                            </a:srgbClr>
-                          </a:solidFill>
-                          <a:latin typeface="Helvetica Neue"/>
-                          <a:cs typeface="Helvetica Neue"/>
-                          <a:ea typeface="Helvetica Neue"/>
-                          <a:sym typeface="Helvetica Neue"/>
-                        </a:rPr>
-                        <a:t>retatrutide</a:t>
-                      </a:r>
-                    </a:p>
-                  </a:txBody>
-                  <a:tcPr anchor="ctr" marB="63500" marT="63500" marR="0" marL="0">
-                    <a:lnL algn="ctr" cmpd="sng" cap="flat" w="0">
-                      <a:noFill/>
-                      <a:prstDash val="solid"/>
-                    </a:lnL>
-                    <a:lnR algn="ctr" cmpd="sng" cap="flat" w="0">
-                      <a:noFill/>
-                      <a:prstDash val="solid"/>
-                    </a:lnR>
-                    <a:lnT algn="ctr" cmpd="sng" cap="flat" w="0">
-                      <a:noFill/>
-                      <a:prstDash val="solid"/>
-                    </a:lnT>
-                    <a:lnB algn="ctr" cmpd="sng" cap="flat" w="19050">
-                      <a:solidFill>
-                        <a:srgbClr val="666666">
-                          <a:alpha val="100000"/>
-                        </a:srgbClr>
-                      </a:solidFill>
-                      <a:prstDash val="solid"/>
-                    </a:lnB>
-                    <a:solidFill>
-                      <a:srgbClr val="F4F8FB">
-                        <a:alpha val="100000"/>
-                      </a:srgbClr>
-                    </a:solidFill>
-                  </a:tcPr>
-                </a:tc>
-                <a:tc>
-                  <a:txBody>
-                    <a:bodyPr/>
-                    <a:lstStyle/>
-                    <a:p>
-                      <a:pPr algn="l" marL="63500" marR="63500">
-                        <a:lnSpc>
-                          <a:spcPct val="100000"/>
-                        </a:lnSpc>
-                        <a:spcBef>
-                          <a:spcPts val="500"/>
-                        </a:spcBef>
-                        <a:spcAft>
-                          <a:spcPts val="500"/>
-                        </a:spcAft>
-                        <a:buNone/>
-                      </a:pPr>
-                      <a:r>
-                        <a:rPr cap="none" sz="1200" i="0" b="0" u="none" strike="noStrike">
-                          <a:solidFill>
-                            <a:srgbClr val="5B6770">
-                              <a:alpha val="100000"/>
-                            </a:srgbClr>
-                          </a:solidFill>
-                          <a:latin typeface="Helvetica Neue"/>
-                          <a:cs typeface="Helvetica Neue"/>
-                          <a:ea typeface="Helvetica Neue"/>
-                          <a:sym typeface="Helvetica Neue"/>
-                        </a:rPr>
-                        <a:t>13 Jul 2026</a:t>
-                      </a:r>
-                    </a:p>
-                  </a:txBody>
-                  <a:tcPr anchor="ctr" marB="63500" marT="63500" marR="0" marL="0">
-                    <a:lnL algn="ctr" cmpd="sng" cap="flat" w="0">
-                      <a:noFill/>
-                      <a:prstDash val="solid"/>
-                    </a:lnL>
-                    <a:lnR algn="ctr" cmpd="sng" cap="flat" w="0">
-                      <a:noFill/>
-                      <a:prstDash val="solid"/>
-                    </a:lnR>
-                    <a:lnT algn="ctr" cmpd="sng" cap="flat" w="0">
-                      <a:noFill/>
-                      <a:prstDash val="solid"/>
-                    </a:lnT>
-                    <a:lnB algn="ctr" cmpd="sng" cap="flat" w="19050">
-                      <a:solidFill>
-                        <a:srgbClr val="666666">
-                          <a:alpha val="100000"/>
-                        </a:srgbClr>
-                      </a:solidFill>
-                      <a:prstDash val="solid"/>
-                    </a:lnB>
-                    <a:solidFill>
-                      <a:srgbClr val="F4F8FB">
-                        <a:alpha val="100000"/>
-                      </a:srgbClr>
-                    </a:solidFill>
-                  </a:tcPr>
-                </a:tc>
-                <a:tc>
-                  <a:txBody>
-                    <a:bodyPr/>
-                    <a:lstStyle/>
-                    <a:p>
-                      <a:pPr algn="l" marL="63500" marR="63500">
-                        <a:lnSpc>
-                          <a:spcPct val="100000"/>
-                        </a:lnSpc>
-                        <a:spcBef>
-                          <a:spcPts val="500"/>
-                        </a:spcBef>
-                        <a:spcAft>
-                          <a:spcPts val="500"/>
-                        </a:spcAft>
-                        <a:buNone/>
-                      </a:pPr>
-                      <a:r>
-                        <a:rPr cap="none" sz="1200" i="0" b="0" u="none" strike="noStrike">
-                          <a:solidFill>
-                            <a:srgbClr val="5B6770">
-                              <a:alpha val="100000"/>
-                            </a:srgbClr>
-                          </a:solidFill>
-                          <a:latin typeface="Helvetica Neue"/>
-                          <a:cs typeface="Helvetica Neue"/>
-                          <a:ea typeface="Helvetica Neue"/>
-                          <a:sym typeface="Helvetica Neue"/>
-                        </a:rPr>
-                        <a:t>primary</a:t>
-                      </a:r>
-                    </a:p>
-                  </a:txBody>
-                  <a:tcPr anchor="ctr" marB="63500" marT="63500" marR="0" marL="0">
-                    <a:lnL algn="ctr" cmpd="sng" cap="flat" w="0">
-                      <a:noFill/>
-                      <a:prstDash val="solid"/>
-                    </a:lnL>
-                    <a:lnR algn="ctr" cmpd="sng" cap="flat" w="0">
-                      <a:noFill/>
-                      <a:prstDash val="solid"/>
-                    </a:lnR>
-                    <a:lnT algn="ctr" cmpd="sng" cap="flat" w="0">
-                      <a:noFill/>
-                      <a:prstDash val="solid"/>
-                    </a:lnT>
-                    <a:lnB algn="ctr" cmpd="sng" cap="flat" w="19050">
-                      <a:solidFill>
-                        <a:srgbClr val="666666">
-                          <a:alpha val="100000"/>
-                        </a:srgbClr>
-                      </a:solidFill>
-                      <a:prstDash val="solid"/>
-                    </a:lnB>
-                    <a:solidFill>
-                      <a:srgbClr val="F4F8FB">
-                        <a:alpha val="100000"/>
-                      </a:srgbClr>
-                    </a:solidFill>
-                  </a:tcPr>
-                </a:tc>
-                <a:tc>
-                  <a:txBody>
-                    <a:bodyPr/>
-                    <a:lstStyle/>
-                    <a:p>
-                      <a:pPr algn="r" marL="63500" marR="63500">
-                        <a:lnSpc>
-                          <a:spcPct val="100000"/>
-                        </a:lnSpc>
-                        <a:spcBef>
-                          <a:spcPts val="500"/>
-                        </a:spcBef>
-                        <a:spcAft>
-                          <a:spcPts val="500"/>
-                        </a:spcAft>
-                        <a:buNone/>
-                      </a:pPr>
-                      <a:r>
-                        <a:rPr cap="none" sz="1200" i="0" b="0" u="none" strike="noStrike">
-                          <a:solidFill>
-                            <a:srgbClr val="5B6770">
-                              <a:alpha val="100000"/>
-                            </a:srgbClr>
-                          </a:solidFill>
-                          <a:latin typeface="Helvetica Neue"/>
-                          <a:cs typeface="Helvetica Neue"/>
-                          <a:ea typeface="Helvetica Neue"/>
-                          <a:sym typeface="Helvetica Neue"/>
-                        </a:rPr>
-                        <a:t>1</a:t>
-                      </a:r>
-                    </a:p>
-                  </a:txBody>
-                  <a:tcPr anchor="ctr" marB="63500" marT="63500" marR="0" marL="0">
-                    <a:lnL algn="ctr" cmpd="sng" cap="flat" w="0">
-                      <a:noFill/>
-                      <a:prstDash val="solid"/>
-                    </a:lnL>
-                    <a:lnR algn="ctr" cmpd="sng" cap="flat" w="0">
-                      <a:noFill/>
-                      <a:prstDash val="solid"/>
-                    </a:lnR>
-                    <a:lnT algn="ctr" cmpd="sng" cap="flat" w="0">
-                      <a:noFill/>
-                      <a:prstDash val="solid"/>
-                    </a:lnT>
-                    <a:lnB algn="ctr" cmpd="sng" cap="flat" w="19050">
-                      <a:solidFill>
-                        <a:srgbClr val="666666">
-                          <a:alpha val="100000"/>
-                        </a:srgbClr>
-                      </a:solidFill>
-                      <a:prstDash val="solid"/>
-                    </a:lnB>
-                    <a:solidFill>
-                      <a:srgbClr val="F4F8FB">
-                        <a:alpha val="100000"/>
-                      </a:srgbClr>
-                    </a:solidFill>
-                  </a:tcPr>
-                </a:tc>
-                <a:tc>
-                  <a:txBody>
-                    <a:bodyPr/>
-                    <a:lstStyle/>
-                    <a:p>
-                      <a:pPr algn="l" marL="63500" marR="63500">
-                        <a:lnSpc>
-                          <a:spcPct val="100000"/>
-                        </a:lnSpc>
-                        <a:spcBef>
-                          <a:spcPts val="500"/>
-                        </a:spcBef>
-                        <a:spcAft>
-                          <a:spcPts val="500"/>
-                        </a:spcAft>
-                        <a:buNone/>
-                      </a:pPr>
-                      <a:r>
-                        <a:rPr cap="none" sz="1200" i="0" b="0" u="none" strike="noStrike">
-                          <a:solidFill>
-                            <a:srgbClr val="5B6770">
-                              <a:alpha val="100000"/>
-                            </a:srgbClr>
-                          </a:solidFill>
-                          <a:latin typeface="Helvetica Neue"/>
-                          <a:cs typeface="Helvetica Neue"/>
-                          <a:ea typeface="Helvetica Neue"/>
-                          <a:sym typeface="Helvetica Neue"/>
-                        </a:rPr>
-                        <a:t>603217</a:t>
                       </a:r>
                     </a:p>
                   </a:txBody>

</xml_diff>

<commit_message>
nightly deck: data through 2026-10-06
</commit_message>
<xml_diff>
--- a/docs/nc-drug-checking-latest.pptx
+++ b/docs/nc-drug-checking-latest.pptx
@@ -2418,7 +2418,7 @@
                 <a:ea typeface="Helvetica Neue"/>
                 <a:sym typeface="Helvetica Neue"/>
               </a:rPr>
-              <a:t>Generated Monday, October 05, 2026 · 12:16 PM ET UNC Street Drug Analysis Lab · OpioidData.org · results.streetsafe.supply Download as PowerPoint</a:t>
+              <a:t>Generated Tuesday, October 06, 2026 · 10:19 AM ET UNC Street Drug Analysis Lab · OpioidData.org · results.streetsafe.supply Download as PowerPoint</a:t>
             </a:r>
           </a:p>
         </p:txBody>
@@ -3184,7 +3184,7 @@
                 <a:ea typeface="Helvetica Neue"/>
                 <a:sym typeface="Helvetica Neue"/>
               </a:rPr>
-              <a:t>County = samplecounty · left: ≥1 completed analysis ever · right: unique samples per county (sqrt color scale) · all time: 26 Jan 2022 – 05 Oct 2026 · last 12 months: 05 Oct 2025 – 05 Oct 2026* · coverage reflects participation, not prevalence</a:t>
+              <a:t>County = samplecounty · left: ≥1 completed analysis ever · right: unique samples per county (sqrt color scale) · all time: 26 Jan 2022 – 05 Oct 2026 · last 12 months: 06 Oct 2025 – 05 Oct 2026* · coverage reflects participation, not prevalence</a:t>
             </a:r>
           </a:p>
         </p:txBody>
@@ -4323,7 +4323,7 @@
                 <a:ea typeface="Helvetica Neue"/>
                 <a:sym typeface="Helvetica Neue"/>
               </a:rPr>
-              <a:t>Samples with methamphetamine or cocaine detected (any abundance); samples in both classes appear on both slides · sensations semicolon lists parsed + sen_strength (own denominator) · consumed = 1 only · before: 26 Jan 2022 – 05 Oct 2025 · past 12 months: 05 Oct 2025 – 05 Oct 2026* · Δ in percentage points</a:t>
+              <a:t>Samples with methamphetamine or cocaine detected (any abundance); samples in both classes appear on both slides · sensations semicolon lists parsed + sen_strength (own denominator) · consumed = 1 only · before: 26 Jan 2022 – 05 Oct 2025 · past 12 months: 06 Oct 2025 – 05 Oct 2026* · Δ in percentage points</a:t>
             </a:r>
           </a:p>
         </p:txBody>
@@ -4742,7 +4742,7 @@
                 <a:ea typeface="Helvetica Neue"/>
                 <a:sym typeface="Helvetica Neue"/>
               </a:rPr>
-              <a:t>Samples with an opioid (fentanyl, heroin) or benzodiazepine detected (any abundance); samples in both classes appear on both slides · sensations semicolon lists parsed + sen_strength (own denominator) · consumed = 1 only · before: 26 Jan 2022 – 05 Oct 2025 · past 12 months: 05 Oct 2025 – 05 Oct 2026* · Δ in percentage points</a:t>
+              <a:t>Samples with an opioid (fentanyl, heroin) or benzodiazepine detected (any abundance); samples in both classes appear on both slides · sensations semicolon lists parsed + sen_strength (own denominator) · consumed = 1 only · before: 26 Jan 2022 – 05 Oct 2025 · past 12 months: 06 Oct 2025 – 05 Oct 2026* · Δ in percentage points</a:t>
             </a:r>
           </a:p>
         </p:txBody>
@@ -5855,7 +5855,7 @@
                 <a:ea typeface="Helvetica Neue"/>
                 <a:sym typeface="Helvetica Neue"/>
               </a:rPr>
-              <a:t>lab_detail.substance counts · solid = primary abundance, light = trace · standardized names (PubChem-linked) · window: date_complete 05 Oct 2025 – 05 Oct 2026* (trailing 12 months, current month partial)</a:t>
+              <a:t>lab_detail.substance counts · solid = primary abundance, light = trace · standardized names (PubChem-linked) · window: date_complete 06 Oct 2025 – 05 Oct 2026* (trailing 12 months, current month partial)</a:t>
             </a:r>
           </a:p>
         </p:txBody>
@@ -6053,7 +6053,7 @@
                 <a:ea typeface="Helvetica Neue"/>
                 <a:sym typeface="Helvetica Neue"/>
               </a:rPr>
-              <a:t>Distribution of substances detected per sample, both definitions shown side by side · window: date_complete 05 Oct 2025 – 05 Oct 2026* (trailing 12 months, current month partial)</a:t>
+              <a:t>Distribution of substances detected per sample, both definitions shown side by side · window: date_complete 06 Oct 2025 – 05 Oct 2026* (trailing 12 months, current month partial)</a:t>
             </a:r>
           </a:p>
         </p:txBody>

</xml_diff>

<commit_message>
nightly deck: data through 2026-10-08
</commit_message>
<xml_diff>
--- a/docs/nc-drug-checking-latest.pptx
+++ b/docs/nc-drug-checking-latest.pptx
@@ -2418,7 +2418,7 @@
                 <a:ea typeface="Helvetica Neue"/>
                 <a:sym typeface="Helvetica Neue"/>
               </a:rPr>
-              <a:t>Generated Wednesday, October 07, 2026 · 10:38 AM ET UNC Street Drug Analysis Lab · OpioidData.org · results.streetsafe.supply Download as PowerPoint</a:t>
+              <a:t>Generated Thursday, October 08, 2026 · 10:45 AM ET UNC Street Drug Analysis Lab · OpioidData.org · results.streetsafe.supply Download as PowerPoint</a:t>
             </a:r>
           </a:p>
         </p:txBody>
@@ -2713,7 +2713,7 @@
                 <a:ea typeface="Helvetica Neue"/>
                 <a:sym typeface="Helvetica Neue"/>
               </a:rPr>
-              <a:t>PLACEHOLDER · figs/stats.json January 2022 to Tuesday, October 06, 2026 N = 2,944 NC samples analyzed Mailed in from 86 harm reduction programs Collected across 59 counties 248 distinct substances detected to date Unique samples = n_distinct(sampleid) · substances from lab_detail.substance · includes samples with date_complete 26 Jan 2022 – 06 Oct 2026 r/build_nightly.R → figs/stats.json</a:t>
+              <a:t>PLACEHOLDER · figs/stats.json January 2022 to Wednesday, October 07, 2026 N = 2,947 NC samples analyzed Mailed in from 86 harm reduction programs Collected across 59 counties 249 distinct substances detected to date Unique samples = n_distinct(sampleid) · substances from lab_detail.substance · includes samples with date_complete 26 Jan 2022 – 07 Oct 2026 r/build_nightly.R → figs/stats.json</a:t>
             </a:r>
           </a:p>
         </p:txBody>
@@ -2762,7 +2762,7 @@
                 <a:ea typeface="Helvetica Neue"/>
                 <a:sym typeface="Helvetica Neue"/>
               </a:rPr>
-              <a:t>Unique samples = n_distinct(sampleid) · substances from lab_detail.substance · includes samples with date_complete 26 Jan 2022 – 06 Oct 2026</a:t>
+              <a:t>Unique samples = n_distinct(sampleid) · substances from lab_detail.substance · includes samples with date_complete 26 Jan 2022 – 07 Oct 2026</a:t>
             </a:r>
           </a:p>
         </p:txBody>
@@ -3184,7 +3184,7 @@
                 <a:ea typeface="Helvetica Neue"/>
                 <a:sym typeface="Helvetica Neue"/>
               </a:rPr>
-              <a:t>County = samplecounty · left: ≥1 completed analysis ever · right: unique samples per county (sqrt color scale) · all time: 26 Jan 2022 – 06 Oct 2026 · last 12 months: 07 Oct 2025 – 06 Oct 2026* · coverage reflects participation, not prevalence</a:t>
+              <a:t>County = samplecounty · left: ≥1 completed analysis ever · right: unique samples per county (sqrt color scale) · all time: 26 Jan 2022 – 07 Oct 2026 · last 12 months: 08 Oct 2025 – 07 Oct 2026* · coverage reflects participation, not prevalence</a:t>
             </a:r>
           </a:p>
         </p:txBody>
@@ -3505,7 +3505,7 @@
                 <a:ea typeface="Helvetica Neue"/>
                 <a:sym typeface="Helvetica Neue"/>
               </a:rPr>
-              <a:t>expectedsubstance (verbatim card write-in, semicolon lists split) · derived flags: expect_opioid, expect_fentanyl, expect_meth, expect_cocaine, expect_stimulant… · includes samples with date_complete 26 Jan 2022 – 06 Oct 2026 · data table: Appendix A2</a:t>
+              <a:t>expectedsubstance (verbatim card write-in, semicolon lists split) · derived flags: expect_opioid, expect_fentanyl, expect_meth, expect_cocaine, expect_stimulant… · includes samples with date_complete 26 Jan 2022 – 07 Oct 2026 · data table: Appendix A2</a:t>
             </a:r>
           </a:p>
         </p:txBody>
@@ -3703,7 +3703,7 @@
                 <a:ea typeface="Helvetica Neue"/>
                 <a:sym typeface="Helvetica Neue"/>
               </a:rPr>
-              <a:t>Numerator uses lab_*_any (primary or trace) among samples with expect_* = 1 · includes samples with date_complete 26 Jan 2022 – 06 Oct 2026 · data table: Appendix A3</a:t>
+              <a:t>Numerator uses lab_*_any (primary or trace) among samples with expect_* = 1 · includes samples with date_complete 26 Jan 2022 – 07 Oct 2026 · data table: Appendix A3</a:t>
             </a:r>
           </a:p>
         </p:txBody>
@@ -3901,7 +3901,7 @@
                 <a:ea typeface="Helvetica Neue"/>
                 <a:sym typeface="Helvetica Neue"/>
               </a:rPr>
-              <a:t>sensations (circled on card, semicolon lists split) · post-consumption samples only (consumed = 1) · includes samples with date_complete 26 Jan 2022 – 06 Oct 2026</a:t>
+              <a:t>sensations (circled on card, semicolon lists split) · post-consumption samples only (consumed = 1) · includes samples with date_complete 26 Jan 2022 – 07 Oct 2026</a:t>
             </a:r>
           </a:p>
         </p:txBody>
@@ -4125,7 +4125,7 @@
                 <a:ea typeface="Helvetica Neue"/>
                 <a:sym typeface="Helvetica Neue"/>
               </a:rPr>
-              <a:t>sensations semicolon lists parsed per report · consumed = 1 only · denominator: consumed samples with lab_*_any = 1 · includes samples with date_complete 26 Jan 2022 – 06 Oct 2026</a:t>
+              <a:t>sensations semicolon lists parsed per report · consumed = 1 only · denominator: consumed samples with lab_*_any = 1 · includes samples with date_complete 26 Jan 2022 – 07 Oct 2026</a:t>
             </a:r>
           </a:p>
         </p:txBody>
@@ -4323,7 +4323,7 @@
                 <a:ea typeface="Helvetica Neue"/>
                 <a:sym typeface="Helvetica Neue"/>
               </a:rPr>
-              <a:t>Samples with methamphetamine or cocaine detected (any abundance); samples in both classes appear on both slides · sensations semicolon lists parsed + sen_strength (own denominator) · consumed = 1 only · before: 26 Jan 2022 – 06 Oct 2025 · past 12 months: 07 Oct 2025 – 06 Oct 2026* · Δ in percentage points</a:t>
+              <a:t>Samples with methamphetamine or cocaine detected (any abundance); samples in both classes appear on both slides · sensations semicolon lists parsed + sen_strength (own denominator) · consumed = 1 only · before: 26 Jan 2022 – 07 Oct 2025 · past 12 months: 08 Oct 2025 – 07 Oct 2026* · Δ in percentage points</a:t>
             </a:r>
           </a:p>
         </p:txBody>
@@ -4742,7 +4742,7 @@
                 <a:ea typeface="Helvetica Neue"/>
                 <a:sym typeface="Helvetica Neue"/>
               </a:rPr>
-              <a:t>Samples with an opioid (fentanyl, heroin) or benzodiazepine detected (any abundance); samples in both classes appear on both slides · sensations semicolon lists parsed + sen_strength (own denominator) · consumed = 1 only · before: 26 Jan 2022 – 06 Oct 2025 · past 12 months: 07 Oct 2025 – 06 Oct 2026* · Δ in percentage points</a:t>
+              <a:t>Samples with an opioid (fentanyl, heroin) or benzodiazepine detected (any abundance); samples in both classes appear on both slides · sensations semicolon lists parsed + sen_strength (own denominator) · consumed = 1 only · before: 26 Jan 2022 – 07 Oct 2025 · past 12 months: 08 Oct 2025 – 07 Oct 2026* · Δ in percentage points</a:t>
             </a:r>
           </a:p>
         </p:txBody>
@@ -5138,7 +5138,7 @@
                 <a:ea typeface="Helvetica Neue"/>
                 <a:sym typeface="Helvetica Neue"/>
               </a:rPr>
-              <a:t>color, texture (card v3+, semicolon lists split) · derived: bright_color excludes white/tan/brown family — orange bar above · includes samples with date_complete 26 Jan 2022 – 06 Oct 2026</a:t>
+              <a:t>color, texture (card v3+, semicolon lists split) · derived: bright_color excludes white/tan/brown family — orange bar above · includes samples with date_complete 26 Jan 2022 – 07 Oct 2026</a:t>
             </a:r>
           </a:p>
         </p:txBody>
@@ -5459,7 +5459,7 @@
                 <a:ea typeface="Helvetica Neue"/>
                 <a:sym typeface="Helvetica Neue"/>
               </a:rPr>
-              <a:t>Distribution of substances detected per sample, both definitions shown side by side · includes samples with date_complete 26 Jan 2022 – 06 Oct 2026</a:t>
+              <a:t>Distribution of substances detected per sample, both definitions shown side by side · includes samples with date_complete 26 Jan 2022 – 07 Oct 2026</a:t>
             </a:r>
           </a:p>
         </p:txBody>
@@ -5657,7 +5657,7 @@
                 <a:ea typeface="Helvetica Neue"/>
                 <a:sym typeface="Helvetica Neue"/>
               </a:rPr>
-              <a:t>lab_detail.substance counts · solid = primary abundance, light = trace · standardized names (PubChem-linked) · includes samples with date_complete 26 Jan 2022 – 06 Oct 2026</a:t>
+              <a:t>lab_detail.substance counts · solid = primary abundance, light = trace · standardized names (PubChem-linked) · includes samples with date_complete 26 Jan 2022 – 07 Oct 2026</a:t>
             </a:r>
           </a:p>
         </p:txBody>
@@ -5855,7 +5855,7 @@
                 <a:ea typeface="Helvetica Neue"/>
                 <a:sym typeface="Helvetica Neue"/>
               </a:rPr>
-              <a:t>lab_detail.substance counts · solid = primary abundance, light = trace · standardized names (PubChem-linked) · window: date_complete 07 Oct 2025 – 06 Oct 2026* (trailing 12 months, current month partial)</a:t>
+              <a:t>lab_detail.substance counts · solid = primary abundance, light = trace · standardized names (PubChem-linked) · window: date_complete 08 Oct 2025 – 07 Oct 2026* (trailing 12 months, current month partial)</a:t>
             </a:r>
           </a:p>
         </p:txBody>
@@ -6053,7 +6053,7 @@
                 <a:ea typeface="Helvetica Neue"/>
                 <a:sym typeface="Helvetica Neue"/>
               </a:rPr>
-              <a:t>Distribution of substances detected per sample, both definitions shown side by side · window: date_complete 07 Oct 2025 – 06 Oct 2026* (trailing 12 months, current month partial)</a:t>
+              <a:t>Distribution of substances detected per sample, both definitions shown side by side · window: date_complete 08 Oct 2025 – 07 Oct 2026* (trailing 12 months, current month partial)</a:t>
             </a:r>
           </a:p>
         </p:txBody>
@@ -10686,7 +10686,7 @@
             <a:tbl>
               <a:tblPr/>
               <a:tblGrid>
-                <a:gridCol w="2462983"/>
+                <a:gridCol w="3434608"/>
                 <a:gridCol w="1237011"/>
                 <a:gridCol w="1218929"/>
                 <a:gridCol w="1186187"/>
@@ -11049,6 +11049,293 @@
                           <a:ea typeface="Helvetica Neue"/>
                           <a:sym typeface="Helvetica Neue"/>
                         </a:rPr>
+                        <a:t>dihydro-7-hydroxy mitragynine (MGM-15)</a:t>
+                      </a:r>
+                    </a:p>
+                  </a:txBody>
+                  <a:tcPr anchor="ctr" marB="63500" marT="63500" marR="0" marL="0">
+                    <a:lnL algn="ctr" cmpd="sng" cap="flat" w="0">
+                      <a:noFill/>
+                      <a:prstDash val="solid"/>
+                    </a:lnL>
+                    <a:lnR algn="ctr" cmpd="sng" cap="flat" w="0">
+                      <a:noFill/>
+                      <a:prstDash val="solid"/>
+                    </a:lnR>
+                    <a:lnT algn="ctr" cmpd="sng" cap="flat" w="0">
+                      <a:noFill/>
+                      <a:prstDash val="solid"/>
+                    </a:lnT>
+                    <a:lnB algn="ctr" cmpd="sng" cap="flat" w="0">
+                      <a:noFill/>
+                      <a:prstDash val="solid"/>
+                    </a:lnB>
+                    <a:solidFill>
+                      <a:srgbClr val="FFFFFF">
+                        <a:alpha val="0"/>
+                      </a:srgbClr>
+                    </a:solidFill>
+                  </a:tcPr>
+                </a:tc>
+                <a:tc>
+                  <a:txBody>
+                    <a:bodyPr/>
+                    <a:lstStyle/>
+                    <a:p>
+                      <a:pPr algn="l" marL="63500" marR="63500">
+                        <a:lnSpc>
+                          <a:spcPct val="100000"/>
+                        </a:lnSpc>
+                        <a:spcBef>
+                          <a:spcPts val="500"/>
+                        </a:spcBef>
+                        <a:spcAft>
+                          <a:spcPts val="500"/>
+                        </a:spcAft>
+                        <a:buNone/>
+                      </a:pPr>
+                      <a:r>
+                        <a:rPr cap="none" sz="1200" i="0" b="0" u="none" strike="noStrike">
+                          <a:solidFill>
+                            <a:srgbClr val="5B6770">
+                              <a:alpha val="100000"/>
+                            </a:srgbClr>
+                          </a:solidFill>
+                          <a:latin typeface="Helvetica Neue"/>
+                          <a:cs typeface="Helvetica Neue"/>
+                          <a:ea typeface="Helvetica Neue"/>
+                          <a:sym typeface="Helvetica Neue"/>
+                        </a:rPr>
+                        <a:t>06 Oct 2026</a:t>
+                      </a:r>
+                    </a:p>
+                  </a:txBody>
+                  <a:tcPr anchor="ctr" marB="63500" marT="63500" marR="0" marL="0">
+                    <a:lnL algn="ctr" cmpd="sng" cap="flat" w="0">
+                      <a:noFill/>
+                      <a:prstDash val="solid"/>
+                    </a:lnL>
+                    <a:lnR algn="ctr" cmpd="sng" cap="flat" w="0">
+                      <a:noFill/>
+                      <a:prstDash val="solid"/>
+                    </a:lnR>
+                    <a:lnT algn="ctr" cmpd="sng" cap="flat" w="0">
+                      <a:noFill/>
+                      <a:prstDash val="solid"/>
+                    </a:lnT>
+                    <a:lnB algn="ctr" cmpd="sng" cap="flat" w="0">
+                      <a:noFill/>
+                      <a:prstDash val="solid"/>
+                    </a:lnB>
+                    <a:solidFill>
+                      <a:srgbClr val="FFFFFF">
+                        <a:alpha val="0"/>
+                      </a:srgbClr>
+                    </a:solidFill>
+                  </a:tcPr>
+                </a:tc>
+                <a:tc>
+                  <a:txBody>
+                    <a:bodyPr/>
+                    <a:lstStyle/>
+                    <a:p>
+                      <a:pPr algn="l" marL="63500" marR="63500">
+                        <a:lnSpc>
+                          <a:spcPct val="100000"/>
+                        </a:lnSpc>
+                        <a:spcBef>
+                          <a:spcPts val="500"/>
+                        </a:spcBef>
+                        <a:spcAft>
+                          <a:spcPts val="500"/>
+                        </a:spcAft>
+                        <a:buNone/>
+                      </a:pPr>
+                      <a:r>
+                        <a:rPr cap="none" sz="1200" i="0" b="0" u="none" strike="noStrike">
+                          <a:solidFill>
+                            <a:srgbClr val="5B6770">
+                              <a:alpha val="100000"/>
+                            </a:srgbClr>
+                          </a:solidFill>
+                          <a:latin typeface="Helvetica Neue"/>
+                          <a:cs typeface="Helvetica Neue"/>
+                          <a:ea typeface="Helvetica Neue"/>
+                          <a:sym typeface="Helvetica Neue"/>
+                        </a:rPr>
+                        <a:t>primary</a:t>
+                      </a:r>
+                    </a:p>
+                  </a:txBody>
+                  <a:tcPr anchor="ctr" marB="63500" marT="63500" marR="0" marL="0">
+                    <a:lnL algn="ctr" cmpd="sng" cap="flat" w="0">
+                      <a:noFill/>
+                      <a:prstDash val="solid"/>
+                    </a:lnL>
+                    <a:lnR algn="ctr" cmpd="sng" cap="flat" w="0">
+                      <a:noFill/>
+                      <a:prstDash val="solid"/>
+                    </a:lnR>
+                    <a:lnT algn="ctr" cmpd="sng" cap="flat" w="0">
+                      <a:noFill/>
+                      <a:prstDash val="solid"/>
+                    </a:lnT>
+                    <a:lnB algn="ctr" cmpd="sng" cap="flat" w="0">
+                      <a:noFill/>
+                      <a:prstDash val="solid"/>
+                    </a:lnB>
+                    <a:solidFill>
+                      <a:srgbClr val="FFFFFF">
+                        <a:alpha val="0"/>
+                      </a:srgbClr>
+                    </a:solidFill>
+                  </a:tcPr>
+                </a:tc>
+                <a:tc>
+                  <a:txBody>
+                    <a:bodyPr/>
+                    <a:lstStyle/>
+                    <a:p>
+                      <a:pPr algn="r" marL="63500" marR="63500">
+                        <a:lnSpc>
+                          <a:spcPct val="100000"/>
+                        </a:lnSpc>
+                        <a:spcBef>
+                          <a:spcPts val="500"/>
+                        </a:spcBef>
+                        <a:spcAft>
+                          <a:spcPts val="500"/>
+                        </a:spcAft>
+                        <a:buNone/>
+                      </a:pPr>
+                      <a:r>
+                        <a:rPr cap="none" sz="1200" i="0" b="0" u="none" strike="noStrike">
+                          <a:solidFill>
+                            <a:srgbClr val="5B6770">
+                              <a:alpha val="100000"/>
+                            </a:srgbClr>
+                          </a:solidFill>
+                          <a:latin typeface="Helvetica Neue"/>
+                          <a:cs typeface="Helvetica Neue"/>
+                          <a:ea typeface="Helvetica Neue"/>
+                          <a:sym typeface="Helvetica Neue"/>
+                        </a:rPr>
+                        <a:t>1</a:t>
+                      </a:r>
+                    </a:p>
+                  </a:txBody>
+                  <a:tcPr anchor="ctr" marB="63500" marT="63500" marR="0" marL="0">
+                    <a:lnL algn="ctr" cmpd="sng" cap="flat" w="0">
+                      <a:noFill/>
+                      <a:prstDash val="solid"/>
+                    </a:lnL>
+                    <a:lnR algn="ctr" cmpd="sng" cap="flat" w="0">
+                      <a:noFill/>
+                      <a:prstDash val="solid"/>
+                    </a:lnR>
+                    <a:lnT algn="ctr" cmpd="sng" cap="flat" w="0">
+                      <a:noFill/>
+                      <a:prstDash val="solid"/>
+                    </a:lnT>
+                    <a:lnB algn="ctr" cmpd="sng" cap="flat" w="0">
+                      <a:noFill/>
+                      <a:prstDash val="solid"/>
+                    </a:lnB>
+                    <a:solidFill>
+                      <a:srgbClr val="FFFFFF">
+                        <a:alpha val="0"/>
+                      </a:srgbClr>
+                    </a:solidFill>
+                  </a:tcPr>
+                </a:tc>
+                <a:tc>
+                  <a:txBody>
+                    <a:bodyPr/>
+                    <a:lstStyle/>
+                    <a:p>
+                      <a:pPr algn="l" marL="63500" marR="63500">
+                        <a:lnSpc>
+                          <a:spcPct val="100000"/>
+                        </a:lnSpc>
+                        <a:spcBef>
+                          <a:spcPts val="500"/>
+                        </a:spcBef>
+                        <a:spcAft>
+                          <a:spcPts val="500"/>
+                        </a:spcAft>
+                        <a:buNone/>
+                      </a:pPr>
+                      <a:r>
+                        <a:rPr cap="none" sz="1200" i="0" b="0" u="none" strike="noStrike">
+                          <a:solidFill>
+                            <a:srgbClr val="5B6770">
+                              <a:alpha val="100000"/>
+                            </a:srgbClr>
+                          </a:solidFill>
+                          <a:latin typeface="Helvetica Neue"/>
+                          <a:cs typeface="Helvetica Neue"/>
+                          <a:ea typeface="Helvetica Neue"/>
+                          <a:sym typeface="Helvetica Neue"/>
+                        </a:rPr>
+                        <a:t>605865</a:t>
+                      </a:r>
+                    </a:p>
+                  </a:txBody>
+                  <a:tcPr anchor="ctr" marB="63500" marT="63500" marR="0" marL="0">
+                    <a:lnL algn="ctr" cmpd="sng" cap="flat" w="0">
+                      <a:noFill/>
+                      <a:prstDash val="solid"/>
+                    </a:lnL>
+                    <a:lnR algn="ctr" cmpd="sng" cap="flat" w="0">
+                      <a:noFill/>
+                      <a:prstDash val="solid"/>
+                    </a:lnR>
+                    <a:lnT algn="ctr" cmpd="sng" cap="flat" w="0">
+                      <a:noFill/>
+                      <a:prstDash val="solid"/>
+                    </a:lnT>
+                    <a:lnB algn="ctr" cmpd="sng" cap="flat" w="0">
+                      <a:noFill/>
+                      <a:prstDash val="solid"/>
+                    </a:lnB>
+                    <a:solidFill>
+                      <a:srgbClr val="FFFFFF">
+                        <a:alpha val="0"/>
+                      </a:srgbClr>
+                    </a:solidFill>
+                  </a:tcPr>
+                </a:tc>
+              </a:tr>
+              <a:tr h="401320">
+                <a:tc>
+                  <a:txBody>
+                    <a:bodyPr/>
+                    <a:lstStyle/>
+                    <a:p>
+                      <a:pPr algn="l" marL="63500" marR="63500">
+                        <a:lnSpc>
+                          <a:spcPct val="100000"/>
+                        </a:lnSpc>
+                        <a:spcBef>
+                          <a:spcPts val="500"/>
+                        </a:spcBef>
+                        <a:spcAft>
+                          <a:spcPts val="500"/>
+                        </a:spcAft>
+                        <a:buNone/>
+                      </a:pPr>
+                      <a:r>
+                        <a:rPr cap="none" sz="1200" i="0" b="0" u="none" strike="noStrike">
+                          <a:solidFill>
+                            <a:srgbClr val="5B6770">
+                              <a:alpha val="100000"/>
+                            </a:srgbClr>
+                          </a:solidFill>
+                          <a:latin typeface="Helvetica Neue"/>
+                          <a:cs typeface="Helvetica Neue"/>
+                          <a:ea typeface="Helvetica Neue"/>
+                          <a:sym typeface="Helvetica Neue"/>
+                        </a:rPr>
                         <a:t>cannabigerol</a:t>
                       </a:r>
                     </a:p>
@@ -11071,8 +11358,8 @@
                       <a:prstDash val="solid"/>
                     </a:lnB>
                     <a:solidFill>
-                      <a:srgbClr val="FFFFFF">
-                        <a:alpha val="0"/>
+                      <a:srgbClr val="F4F8FB">
+                        <a:alpha val="100000"/>
                       </a:srgbClr>
                     </a:solidFill>
                   </a:tcPr>
@@ -11128,8 +11415,8 @@
                       <a:prstDash val="solid"/>
                     </a:lnB>
                     <a:solidFill>
-                      <a:srgbClr val="FFFFFF">
-                        <a:alpha val="0"/>
+                      <a:srgbClr val="F4F8FB">
+                        <a:alpha val="100000"/>
                       </a:srgbClr>
                     </a:solidFill>
                   </a:tcPr>
@@ -11185,8 +11472,8 @@
                       <a:prstDash val="solid"/>
                     </a:lnB>
                     <a:solidFill>
-                      <a:srgbClr val="FFFFFF">
-                        <a:alpha val="0"/>
+                      <a:srgbClr val="F4F8FB">
+                        <a:alpha val="100000"/>
                       </a:srgbClr>
                     </a:solidFill>
                   </a:tcPr>
@@ -11242,8 +11529,8 @@
                       <a:prstDash val="solid"/>
                     </a:lnB>
                     <a:solidFill>
-                      <a:srgbClr val="FFFFFF">
-                        <a:alpha val="0"/>
+                      <a:srgbClr val="F4F8FB">
+                        <a:alpha val="100000"/>
                       </a:srgbClr>
                     </a:solidFill>
                   </a:tcPr>
@@ -11299,8 +11586,8 @@
                       <a:prstDash val="solid"/>
                     </a:lnB>
                     <a:solidFill>
-                      <a:srgbClr val="FFFFFF">
-                        <a:alpha val="0"/>
+                      <a:srgbClr val="F4F8FB">
+                        <a:alpha val="100000"/>
                       </a:srgbClr>
                     </a:solidFill>
                   </a:tcPr>
@@ -11358,8 +11645,8 @@
                       <a:prstDash val="solid"/>
                     </a:lnB>
                     <a:solidFill>
-                      <a:srgbClr val="F4F8FB">
-                        <a:alpha val="100000"/>
+                      <a:srgbClr val="FFFFFF">
+                        <a:alpha val="0"/>
                       </a:srgbClr>
                     </a:solidFill>
                   </a:tcPr>
@@ -11415,8 +11702,8 @@
                       <a:prstDash val="solid"/>
                     </a:lnB>
                     <a:solidFill>
-                      <a:srgbClr val="F4F8FB">
-                        <a:alpha val="100000"/>
+                      <a:srgbClr val="FFFFFF">
+                        <a:alpha val="0"/>
                       </a:srgbClr>
                     </a:solidFill>
                   </a:tcPr>
@@ -11472,8 +11759,8 @@
                       <a:prstDash val="solid"/>
                     </a:lnB>
                     <a:solidFill>
-                      <a:srgbClr val="F4F8FB">
-                        <a:alpha val="100000"/>
+                      <a:srgbClr val="FFFFFF">
+                        <a:alpha val="0"/>
                       </a:srgbClr>
                     </a:solidFill>
                   </a:tcPr>
@@ -11529,8 +11816,8 @@
                       <a:prstDash val="solid"/>
                     </a:lnB>
                     <a:solidFill>
-                      <a:srgbClr val="F4F8FB">
-                        <a:alpha val="100000"/>
+                      <a:srgbClr val="FFFFFF">
+                        <a:alpha val="0"/>
                       </a:srgbClr>
                     </a:solidFill>
                   </a:tcPr>
@@ -11586,8 +11873,8 @@
                       <a:prstDash val="solid"/>
                     </a:lnB>
                     <a:solidFill>
-                      <a:srgbClr val="F4F8FB">
-                        <a:alpha val="100000"/>
+                      <a:srgbClr val="FFFFFF">
+                        <a:alpha val="0"/>
                       </a:srgbClr>
                     </a:solidFill>
                   </a:tcPr>
@@ -11645,8 +11932,8 @@
                       <a:prstDash val="solid"/>
                     </a:lnB>
                     <a:solidFill>
-                      <a:srgbClr val="FFFFFF">
-                        <a:alpha val="0"/>
+                      <a:srgbClr val="F4F8FB">
+                        <a:alpha val="100000"/>
                       </a:srgbClr>
                     </a:solidFill>
                   </a:tcPr>
@@ -11702,8 +11989,8 @@
                       <a:prstDash val="solid"/>
                     </a:lnB>
                     <a:solidFill>
-                      <a:srgbClr val="FFFFFF">
-                        <a:alpha val="0"/>
+                      <a:srgbClr val="F4F8FB">
+                        <a:alpha val="100000"/>
                       </a:srgbClr>
                     </a:solidFill>
                   </a:tcPr>
@@ -11759,8 +12046,8 @@
                       <a:prstDash val="solid"/>
                     </a:lnB>
                     <a:solidFill>
-                      <a:srgbClr val="FFFFFF">
-                        <a:alpha val="0"/>
+                      <a:srgbClr val="F4F8FB">
+                        <a:alpha val="100000"/>
                       </a:srgbClr>
                     </a:solidFill>
                   </a:tcPr>
@@ -11816,8 +12103,8 @@
                       <a:prstDash val="solid"/>
                     </a:lnB>
                     <a:solidFill>
-                      <a:srgbClr val="FFFFFF">
-                        <a:alpha val="0"/>
+                      <a:srgbClr val="F4F8FB">
+                        <a:alpha val="100000"/>
                       </a:srgbClr>
                     </a:solidFill>
                   </a:tcPr>
@@ -11873,8 +12160,8 @@
                       <a:prstDash val="solid"/>
                     </a:lnB>
                     <a:solidFill>
-                      <a:srgbClr val="FFFFFF">
-                        <a:alpha val="0"/>
+                      <a:srgbClr val="F4F8FB">
+                        <a:alpha val="100000"/>
                       </a:srgbClr>
                     </a:solidFill>
                   </a:tcPr>
@@ -11932,8 +12219,8 @@
                       <a:prstDash val="solid"/>
                     </a:lnB>
                     <a:solidFill>
-                      <a:srgbClr val="F4F8FB">
-                        <a:alpha val="100000"/>
+                      <a:srgbClr val="FFFFFF">
+                        <a:alpha val="0"/>
                       </a:srgbClr>
                     </a:solidFill>
                   </a:tcPr>
@@ -11989,8 +12276,8 @@
                       <a:prstDash val="solid"/>
                     </a:lnB>
                     <a:solidFill>
-                      <a:srgbClr val="F4F8FB">
-                        <a:alpha val="100000"/>
+                      <a:srgbClr val="FFFFFF">
+                        <a:alpha val="0"/>
                       </a:srgbClr>
                     </a:solidFill>
                   </a:tcPr>
@@ -12046,8 +12333,8 @@
                       <a:prstDash val="solid"/>
                     </a:lnB>
                     <a:solidFill>
-                      <a:srgbClr val="F4F8FB">
-                        <a:alpha val="100000"/>
+                      <a:srgbClr val="FFFFFF">
+                        <a:alpha val="0"/>
                       </a:srgbClr>
                     </a:solidFill>
                   </a:tcPr>
@@ -12103,8 +12390,8 @@
                       <a:prstDash val="solid"/>
                     </a:lnB>
                     <a:solidFill>
-                      <a:srgbClr val="F4F8FB">
-                        <a:alpha val="100000"/>
+                      <a:srgbClr val="FFFFFF">
+                        <a:alpha val="0"/>
                       </a:srgbClr>
                     </a:solidFill>
                   </a:tcPr>
@@ -12160,8 +12447,8 @@
                       <a:prstDash val="solid"/>
                     </a:lnB>
                     <a:solidFill>
-                      <a:srgbClr val="F4F8FB">
-                        <a:alpha val="100000"/>
+                      <a:srgbClr val="FFFFFF">
+                        <a:alpha val="0"/>
                       </a:srgbClr>
                     </a:solidFill>
                   </a:tcPr>
@@ -12219,8 +12506,8 @@
                       <a:prstDash val="solid"/>
                     </a:lnB>
                     <a:solidFill>
-                      <a:srgbClr val="FFFFFF">
-                        <a:alpha val="0"/>
+                      <a:srgbClr val="F4F8FB">
+                        <a:alpha val="100000"/>
                       </a:srgbClr>
                     </a:solidFill>
                   </a:tcPr>
@@ -12276,8 +12563,8 @@
                       <a:prstDash val="solid"/>
                     </a:lnB>
                     <a:solidFill>
-                      <a:srgbClr val="FFFFFF">
-                        <a:alpha val="0"/>
+                      <a:srgbClr val="F4F8FB">
+                        <a:alpha val="100000"/>
                       </a:srgbClr>
                     </a:solidFill>
                   </a:tcPr>
@@ -12333,8 +12620,8 @@
                       <a:prstDash val="solid"/>
                     </a:lnB>
                     <a:solidFill>
-                      <a:srgbClr val="FFFFFF">
-                        <a:alpha val="0"/>
+                      <a:srgbClr val="F4F8FB">
+                        <a:alpha val="100000"/>
                       </a:srgbClr>
                     </a:solidFill>
                   </a:tcPr>
@@ -12390,8 +12677,8 @@
                       <a:prstDash val="solid"/>
                     </a:lnB>
                     <a:solidFill>
-                      <a:srgbClr val="FFFFFF">
-                        <a:alpha val="0"/>
+                      <a:srgbClr val="F4F8FB">
+                        <a:alpha val="100000"/>
                       </a:srgbClr>
                     </a:solidFill>
                   </a:tcPr>
@@ -12447,8 +12734,8 @@
                       <a:prstDash val="solid"/>
                     </a:lnB>
                     <a:solidFill>
-                      <a:srgbClr val="FFFFFF">
-                        <a:alpha val="0"/>
+                      <a:srgbClr val="F4F8FB">
+                        <a:alpha val="100000"/>
                       </a:srgbClr>
                     </a:solidFill>
                   </a:tcPr>
@@ -12506,8 +12793,8 @@
                       <a:prstDash val="solid"/>
                     </a:lnB>
                     <a:solidFill>
-                      <a:srgbClr val="F4F8FB">
-                        <a:alpha val="100000"/>
+                      <a:srgbClr val="FFFFFF">
+                        <a:alpha val="0"/>
                       </a:srgbClr>
                     </a:solidFill>
                   </a:tcPr>
@@ -12563,8 +12850,8 @@
                       <a:prstDash val="solid"/>
                     </a:lnB>
                     <a:solidFill>
-                      <a:srgbClr val="F4F8FB">
-                        <a:alpha val="100000"/>
+                      <a:srgbClr val="FFFFFF">
+                        <a:alpha val="0"/>
                       </a:srgbClr>
                     </a:solidFill>
                   </a:tcPr>
@@ -12620,8 +12907,8 @@
                       <a:prstDash val="solid"/>
                     </a:lnB>
                     <a:solidFill>
-                      <a:srgbClr val="F4F8FB">
-                        <a:alpha val="100000"/>
+                      <a:srgbClr val="FFFFFF">
+                        <a:alpha val="0"/>
                       </a:srgbClr>
                     </a:solidFill>
                   </a:tcPr>
@@ -12677,8 +12964,8 @@
                       <a:prstDash val="solid"/>
                     </a:lnB>
                     <a:solidFill>
-                      <a:srgbClr val="F4F8FB">
-                        <a:alpha val="100000"/>
+                      <a:srgbClr val="FFFFFF">
+                        <a:alpha val="0"/>
                       </a:srgbClr>
                     </a:solidFill>
                   </a:tcPr>
@@ -12734,8 +13021,8 @@
                       <a:prstDash val="solid"/>
                     </a:lnB>
                     <a:solidFill>
-                      <a:srgbClr val="F4F8FB">
-                        <a:alpha val="100000"/>
+                      <a:srgbClr val="FFFFFF">
+                        <a:alpha val="0"/>
                       </a:srgbClr>
                     </a:solidFill>
                   </a:tcPr>
@@ -12793,8 +13080,8 @@
                       <a:prstDash val="solid"/>
                     </a:lnB>
                     <a:solidFill>
-                      <a:srgbClr val="FFFFFF">
-                        <a:alpha val="0"/>
+                      <a:srgbClr val="F4F8FB">
+                        <a:alpha val="100000"/>
                       </a:srgbClr>
                     </a:solidFill>
                   </a:tcPr>
@@ -12850,8 +13137,8 @@
                       <a:prstDash val="solid"/>
                     </a:lnB>
                     <a:solidFill>
-                      <a:srgbClr val="FFFFFF">
-                        <a:alpha val="0"/>
+                      <a:srgbClr val="F4F8FB">
+                        <a:alpha val="100000"/>
                       </a:srgbClr>
                     </a:solidFill>
                   </a:tcPr>
@@ -12907,8 +13194,8 @@
                       <a:prstDash val="solid"/>
                     </a:lnB>
                     <a:solidFill>
-                      <a:srgbClr val="FFFFFF">
-                        <a:alpha val="0"/>
+                      <a:srgbClr val="F4F8FB">
+                        <a:alpha val="100000"/>
                       </a:srgbClr>
                     </a:solidFill>
                   </a:tcPr>
@@ -12964,8 +13251,8 @@
                       <a:prstDash val="solid"/>
                     </a:lnB>
                     <a:solidFill>
-                      <a:srgbClr val="FFFFFF">
-                        <a:alpha val="0"/>
+                      <a:srgbClr val="F4F8FB">
+                        <a:alpha val="100000"/>
                       </a:srgbClr>
                     </a:solidFill>
                   </a:tcPr>
@@ -13021,8 +13308,8 @@
                       <a:prstDash val="solid"/>
                     </a:lnB>
                     <a:solidFill>
-                      <a:srgbClr val="FFFFFF">
-                        <a:alpha val="0"/>
+                      <a:srgbClr val="F4F8FB">
+                        <a:alpha val="100000"/>
                       </a:srgbClr>
                     </a:solidFill>
                   </a:tcPr>
@@ -13080,8 +13367,8 @@
                       <a:prstDash val="solid"/>
                     </a:lnB>
                     <a:solidFill>
-                      <a:srgbClr val="F4F8FB">
-                        <a:alpha val="100000"/>
+                      <a:srgbClr val="FFFFFF">
+                        <a:alpha val="0"/>
                       </a:srgbClr>
                     </a:solidFill>
                   </a:tcPr>
@@ -13137,8 +13424,8 @@
                       <a:prstDash val="solid"/>
                     </a:lnB>
                     <a:solidFill>
-                      <a:srgbClr val="F4F8FB">
-                        <a:alpha val="100000"/>
+                      <a:srgbClr val="FFFFFF">
+                        <a:alpha val="0"/>
                       </a:srgbClr>
                     </a:solidFill>
                   </a:tcPr>
@@ -13194,8 +13481,8 @@
                       <a:prstDash val="solid"/>
                     </a:lnB>
                     <a:solidFill>
-                      <a:srgbClr val="F4F8FB">
-                        <a:alpha val="100000"/>
+                      <a:srgbClr val="FFFFFF">
+                        <a:alpha val="0"/>
                       </a:srgbClr>
                     </a:solidFill>
                   </a:tcPr>
@@ -13251,8 +13538,8 @@
                       <a:prstDash val="solid"/>
                     </a:lnB>
                     <a:solidFill>
-                      <a:srgbClr val="F4F8FB">
-                        <a:alpha val="100000"/>
+                      <a:srgbClr val="FFFFFF">
+                        <a:alpha val="0"/>
                       </a:srgbClr>
                     </a:solidFill>
                   </a:tcPr>
@@ -13308,8 +13595,8 @@
                       <a:prstDash val="solid"/>
                     </a:lnB>
                     <a:solidFill>
-                      <a:srgbClr val="F4F8FB">
-                        <a:alpha val="100000"/>
+                      <a:srgbClr val="FFFFFF">
+                        <a:alpha val="0"/>
                       </a:srgbClr>
                     </a:solidFill>
                   </a:tcPr>
@@ -13367,8 +13654,8 @@
                       <a:prstDash val="solid"/>
                     </a:lnB>
                     <a:solidFill>
-                      <a:srgbClr val="FFFFFF">
-                        <a:alpha val="0"/>
+                      <a:srgbClr val="F4F8FB">
+                        <a:alpha val="100000"/>
                       </a:srgbClr>
                     </a:solidFill>
                   </a:tcPr>
@@ -13424,8 +13711,8 @@
                       <a:prstDash val="solid"/>
                     </a:lnB>
                     <a:solidFill>
-                      <a:srgbClr val="FFFFFF">
-                        <a:alpha val="0"/>
+                      <a:srgbClr val="F4F8FB">
+                        <a:alpha val="100000"/>
                       </a:srgbClr>
                     </a:solidFill>
                   </a:tcPr>
@@ -13481,8 +13768,8 @@
                       <a:prstDash val="solid"/>
                     </a:lnB>
                     <a:solidFill>
-                      <a:srgbClr val="FFFFFF">
-                        <a:alpha val="0"/>
+                      <a:srgbClr val="F4F8FB">
+                        <a:alpha val="100000"/>
                       </a:srgbClr>
                     </a:solidFill>
                   </a:tcPr>
@@ -13538,8 +13825,8 @@
                       <a:prstDash val="solid"/>
                     </a:lnB>
                     <a:solidFill>
-                      <a:srgbClr val="FFFFFF">
-                        <a:alpha val="0"/>
+                      <a:srgbClr val="F4F8FB">
+                        <a:alpha val="100000"/>
                       </a:srgbClr>
                     </a:solidFill>
                   </a:tcPr>
@@ -13595,8 +13882,8 @@
                       <a:prstDash val="solid"/>
                     </a:lnB>
                     <a:solidFill>
-                      <a:srgbClr val="FFFFFF">
-                        <a:alpha val="0"/>
+                      <a:srgbClr val="F4F8FB">
+                        <a:alpha val="100000"/>
                       </a:srgbClr>
                     </a:solidFill>
                   </a:tcPr>
@@ -13654,8 +13941,8 @@
                       <a:prstDash val="solid"/>
                     </a:lnB>
                     <a:solidFill>
-                      <a:srgbClr val="F4F8FB">
-                        <a:alpha val="100000"/>
+                      <a:srgbClr val="FFFFFF">
+                        <a:alpha val="0"/>
                       </a:srgbClr>
                     </a:solidFill>
                   </a:tcPr>
@@ -13711,8 +13998,8 @@
                       <a:prstDash val="solid"/>
                     </a:lnB>
                     <a:solidFill>
-                      <a:srgbClr val="F4F8FB">
-                        <a:alpha val="100000"/>
+                      <a:srgbClr val="FFFFFF">
+                        <a:alpha val="0"/>
                       </a:srgbClr>
                     </a:solidFill>
                   </a:tcPr>
@@ -13768,8 +14055,8 @@
                       <a:prstDash val="solid"/>
                     </a:lnB>
                     <a:solidFill>
-                      <a:srgbClr val="F4F8FB">
-                        <a:alpha val="100000"/>
+                      <a:srgbClr val="FFFFFF">
+                        <a:alpha val="0"/>
                       </a:srgbClr>
                     </a:solidFill>
                   </a:tcPr>
@@ -13825,8 +14112,8 @@
                       <a:prstDash val="solid"/>
                     </a:lnB>
                     <a:solidFill>
-                      <a:srgbClr val="F4F8FB">
-                        <a:alpha val="100000"/>
+                      <a:srgbClr val="FFFFFF">
+                        <a:alpha val="0"/>
                       </a:srgbClr>
                     </a:solidFill>
                   </a:tcPr>
@@ -13882,14 +14169,14 @@
                       <a:prstDash val="solid"/>
                     </a:lnB>
                     <a:solidFill>
-                      <a:srgbClr val="F4F8FB">
-                        <a:alpha val="100000"/>
+                      <a:srgbClr val="FFFFFF">
+                        <a:alpha val="0"/>
                       </a:srgbClr>
                     </a:solidFill>
                   </a:tcPr>
                 </a:tc>
               </a:tr>
-              <a:tr h="401320">
+              <a:tr h="410845">
                 <a:tc>
                   <a:txBody>
                     <a:bodyPr/>
@@ -13936,13 +14223,17 @@
                       <a:noFill/>
                       <a:prstDash val="solid"/>
                     </a:lnT>
-                    <a:lnB algn="ctr" cmpd="sng" cap="flat" w="0">
-                      <a:noFill/>
+                    <a:lnB algn="ctr" cmpd="sng" cap="flat" w="19050">
+                      <a:solidFill>
+                        <a:srgbClr val="666666">
+                          <a:alpha val="100000"/>
+                        </a:srgbClr>
+                      </a:solidFill>
                       <a:prstDash val="solid"/>
                     </a:lnB>
                     <a:solidFill>
-                      <a:srgbClr val="FFFFFF">
-                        <a:alpha val="0"/>
+                      <a:srgbClr val="F4F8FB">
+                        <a:alpha val="100000"/>
                       </a:srgbClr>
                     </a:solidFill>
                   </a:tcPr>
@@ -13993,13 +14284,17 @@
                       <a:noFill/>
                       <a:prstDash val="solid"/>
                     </a:lnT>
-                    <a:lnB algn="ctr" cmpd="sng" cap="flat" w="0">
-                      <a:noFill/>
+                    <a:lnB algn="ctr" cmpd="sng" cap="flat" w="19050">
+                      <a:solidFill>
+                        <a:srgbClr val="666666">
+                          <a:alpha val="100000"/>
+                        </a:srgbClr>
+                      </a:solidFill>
                       <a:prstDash val="solid"/>
                     </a:lnB>
                     <a:solidFill>
-                      <a:srgbClr val="FFFFFF">
-                        <a:alpha val="0"/>
+                      <a:srgbClr val="F4F8FB">
+                        <a:alpha val="100000"/>
                       </a:srgbClr>
                     </a:solidFill>
                   </a:tcPr>
@@ -14050,13 +14345,17 @@
                       <a:noFill/>
                       <a:prstDash val="solid"/>
                     </a:lnT>
-                    <a:lnB algn="ctr" cmpd="sng" cap="flat" w="0">
-                      <a:noFill/>
+                    <a:lnB algn="ctr" cmpd="sng" cap="flat" w="19050">
+                      <a:solidFill>
+                        <a:srgbClr val="666666">
+                          <a:alpha val="100000"/>
+                        </a:srgbClr>
+                      </a:solidFill>
                       <a:prstDash val="solid"/>
                     </a:lnB>
                     <a:solidFill>
-                      <a:srgbClr val="FFFFFF">
-                        <a:alpha val="0"/>
+                      <a:srgbClr val="F4F8FB">
+                        <a:alpha val="100000"/>
                       </a:srgbClr>
                     </a:solidFill>
                   </a:tcPr>
@@ -14107,122 +14406,6 @@
                       <a:noFill/>
                       <a:prstDash val="solid"/>
                     </a:lnT>
-                    <a:lnB algn="ctr" cmpd="sng" cap="flat" w="0">
-                      <a:noFill/>
-                      <a:prstDash val="solid"/>
-                    </a:lnB>
-                    <a:solidFill>
-                      <a:srgbClr val="FFFFFF">
-                        <a:alpha val="0"/>
-                      </a:srgbClr>
-                    </a:solidFill>
-                  </a:tcPr>
-                </a:tc>
-                <a:tc>
-                  <a:txBody>
-                    <a:bodyPr/>
-                    <a:lstStyle/>
-                    <a:p>
-                      <a:pPr algn="l" marL="63500" marR="63500">
-                        <a:lnSpc>
-                          <a:spcPct val="100000"/>
-                        </a:lnSpc>
-                        <a:spcBef>
-                          <a:spcPts val="500"/>
-                        </a:spcBef>
-                        <a:spcAft>
-                          <a:spcPts val="500"/>
-                        </a:spcAft>
-                        <a:buNone/>
-                      </a:pPr>
-                      <a:r>
-                        <a:rPr cap="none" sz="1200" i="0" b="0" u="none" strike="noStrike">
-                          <a:solidFill>
-                            <a:srgbClr val="5B6770">
-                              <a:alpha val="100000"/>
-                            </a:srgbClr>
-                          </a:solidFill>
-                          <a:latin typeface="Helvetica Neue"/>
-                          <a:cs typeface="Helvetica Neue"/>
-                          <a:ea typeface="Helvetica Neue"/>
-                          <a:sym typeface="Helvetica Neue"/>
-                        </a:rPr>
-                        <a:t>900889</a:t>
-                      </a:r>
-                    </a:p>
-                  </a:txBody>
-                  <a:tcPr anchor="ctr" marB="63500" marT="63500" marR="0" marL="0">
-                    <a:lnL algn="ctr" cmpd="sng" cap="flat" w="0">
-                      <a:noFill/>
-                      <a:prstDash val="solid"/>
-                    </a:lnL>
-                    <a:lnR algn="ctr" cmpd="sng" cap="flat" w="0">
-                      <a:noFill/>
-                      <a:prstDash val="solid"/>
-                    </a:lnR>
-                    <a:lnT algn="ctr" cmpd="sng" cap="flat" w="0">
-                      <a:noFill/>
-                      <a:prstDash val="solid"/>
-                    </a:lnT>
-                    <a:lnB algn="ctr" cmpd="sng" cap="flat" w="0">
-                      <a:noFill/>
-                      <a:prstDash val="solid"/>
-                    </a:lnB>
-                    <a:solidFill>
-                      <a:srgbClr val="FFFFFF">
-                        <a:alpha val="0"/>
-                      </a:srgbClr>
-                    </a:solidFill>
-                  </a:tcPr>
-                </a:tc>
-              </a:tr>
-              <a:tr h="410845">
-                <a:tc>
-                  <a:txBody>
-                    <a:bodyPr/>
-                    <a:lstStyle/>
-                    <a:p>
-                      <a:pPr algn="l" marL="63500" marR="63500">
-                        <a:lnSpc>
-                          <a:spcPct val="100000"/>
-                        </a:lnSpc>
-                        <a:spcBef>
-                          <a:spcPts val="500"/>
-                        </a:spcBef>
-                        <a:spcAft>
-                          <a:spcPts val="500"/>
-                        </a:spcAft>
-                        <a:buNone/>
-                      </a:pPr>
-                      <a:r>
-                        <a:rPr cap="none" sz="1200" i="0" b="0" u="none" strike="noStrike">
-                          <a:solidFill>
-                            <a:srgbClr val="5B6770">
-                              <a:alpha val="100000"/>
-                            </a:srgbClr>
-                          </a:solidFill>
-                          <a:latin typeface="Helvetica Neue"/>
-                          <a:cs typeface="Helvetica Neue"/>
-                          <a:ea typeface="Helvetica Neue"/>
-                          <a:sym typeface="Helvetica Neue"/>
-                        </a:rPr>
-                        <a:t>fentanyl methylene homolog</a:t>
-                      </a:r>
-                    </a:p>
-                  </a:txBody>
-                  <a:tcPr anchor="ctr" marB="63500" marT="63500" marR="0" marL="0">
-                    <a:lnL algn="ctr" cmpd="sng" cap="flat" w="0">
-                      <a:noFill/>
-                      <a:prstDash val="solid"/>
-                    </a:lnL>
-                    <a:lnR algn="ctr" cmpd="sng" cap="flat" w="0">
-                      <a:noFill/>
-                      <a:prstDash val="solid"/>
-                    </a:lnR>
-                    <a:lnT algn="ctr" cmpd="sng" cap="flat" w="0">
-                      <a:noFill/>
-                      <a:prstDash val="solid"/>
-                    </a:lnT>
                     <a:lnB algn="ctr" cmpd="sng" cap="flat" w="19050">
                       <a:solidFill>
                         <a:srgbClr val="666666">
@@ -14267,190 +14450,7 @@
                           <a:ea typeface="Helvetica Neue"/>
                           <a:sym typeface="Helvetica Neue"/>
                         </a:rPr>
-                        <a:t>16 Jul 2026</a:t>
-                      </a:r>
-                    </a:p>
-                  </a:txBody>
-                  <a:tcPr anchor="ctr" marB="63500" marT="63500" marR="0" marL="0">
-                    <a:lnL algn="ctr" cmpd="sng" cap="flat" w="0">
-                      <a:noFill/>
-                      <a:prstDash val="solid"/>
-                    </a:lnL>
-                    <a:lnR algn="ctr" cmpd="sng" cap="flat" w="0">
-                      <a:noFill/>
-                      <a:prstDash val="solid"/>
-                    </a:lnR>
-                    <a:lnT algn="ctr" cmpd="sng" cap="flat" w="0">
-                      <a:noFill/>
-                      <a:prstDash val="solid"/>
-                    </a:lnT>
-                    <a:lnB algn="ctr" cmpd="sng" cap="flat" w="19050">
-                      <a:solidFill>
-                        <a:srgbClr val="666666">
-                          <a:alpha val="100000"/>
-                        </a:srgbClr>
-                      </a:solidFill>
-                      <a:prstDash val="solid"/>
-                    </a:lnB>
-                    <a:solidFill>
-                      <a:srgbClr val="F4F8FB">
-                        <a:alpha val="100000"/>
-                      </a:srgbClr>
-                    </a:solidFill>
-                  </a:tcPr>
-                </a:tc>
-                <a:tc>
-                  <a:txBody>
-                    <a:bodyPr/>
-                    <a:lstStyle/>
-                    <a:p>
-                      <a:pPr algn="l" marL="63500" marR="63500">
-                        <a:lnSpc>
-                          <a:spcPct val="100000"/>
-                        </a:lnSpc>
-                        <a:spcBef>
-                          <a:spcPts val="500"/>
-                        </a:spcBef>
-                        <a:spcAft>
-                          <a:spcPts val="500"/>
-                        </a:spcAft>
-                        <a:buNone/>
-                      </a:pPr>
-                      <a:r>
-                        <a:rPr cap="none" sz="1200" i="0" b="0" u="none" strike="noStrike">
-                          <a:solidFill>
-                            <a:srgbClr val="5B6770">
-                              <a:alpha val="100000"/>
-                            </a:srgbClr>
-                          </a:solidFill>
-                          <a:latin typeface="Helvetica Neue"/>
-                          <a:cs typeface="Helvetica Neue"/>
-                          <a:ea typeface="Helvetica Neue"/>
-                          <a:sym typeface="Helvetica Neue"/>
-                        </a:rPr>
-                        <a:t>trace</a:t>
-                      </a:r>
-                    </a:p>
-                  </a:txBody>
-                  <a:tcPr anchor="ctr" marB="63500" marT="63500" marR="0" marL="0">
-                    <a:lnL algn="ctr" cmpd="sng" cap="flat" w="0">
-                      <a:noFill/>
-                      <a:prstDash val="solid"/>
-                    </a:lnL>
-                    <a:lnR algn="ctr" cmpd="sng" cap="flat" w="0">
-                      <a:noFill/>
-                      <a:prstDash val="solid"/>
-                    </a:lnR>
-                    <a:lnT algn="ctr" cmpd="sng" cap="flat" w="0">
-                      <a:noFill/>
-                      <a:prstDash val="solid"/>
-                    </a:lnT>
-                    <a:lnB algn="ctr" cmpd="sng" cap="flat" w="19050">
-                      <a:solidFill>
-                        <a:srgbClr val="666666">
-                          <a:alpha val="100000"/>
-                        </a:srgbClr>
-                      </a:solidFill>
-                      <a:prstDash val="solid"/>
-                    </a:lnB>
-                    <a:solidFill>
-                      <a:srgbClr val="F4F8FB">
-                        <a:alpha val="100000"/>
-                      </a:srgbClr>
-                    </a:solidFill>
-                  </a:tcPr>
-                </a:tc>
-                <a:tc>
-                  <a:txBody>
-                    <a:bodyPr/>
-                    <a:lstStyle/>
-                    <a:p>
-                      <a:pPr algn="r" marL="63500" marR="63500">
-                        <a:lnSpc>
-                          <a:spcPct val="100000"/>
-                        </a:lnSpc>
-                        <a:spcBef>
-                          <a:spcPts val="500"/>
-                        </a:spcBef>
-                        <a:spcAft>
-                          <a:spcPts val="500"/>
-                        </a:spcAft>
-                        <a:buNone/>
-                      </a:pPr>
-                      <a:r>
-                        <a:rPr cap="none" sz="1200" i="0" b="0" u="none" strike="noStrike">
-                          <a:solidFill>
-                            <a:srgbClr val="5B6770">
-                              <a:alpha val="100000"/>
-                            </a:srgbClr>
-                          </a:solidFill>
-                          <a:latin typeface="Helvetica Neue"/>
-                          <a:cs typeface="Helvetica Neue"/>
-                          <a:ea typeface="Helvetica Neue"/>
-                          <a:sym typeface="Helvetica Neue"/>
-                        </a:rPr>
-                        <a:t>1</a:t>
-                      </a:r>
-                    </a:p>
-                  </a:txBody>
-                  <a:tcPr anchor="ctr" marB="63500" marT="63500" marR="0" marL="0">
-                    <a:lnL algn="ctr" cmpd="sng" cap="flat" w="0">
-                      <a:noFill/>
-                      <a:prstDash val="solid"/>
-                    </a:lnL>
-                    <a:lnR algn="ctr" cmpd="sng" cap="flat" w="0">
-                      <a:noFill/>
-                      <a:prstDash val="solid"/>
-                    </a:lnR>
-                    <a:lnT algn="ctr" cmpd="sng" cap="flat" w="0">
-                      <a:noFill/>
-                      <a:prstDash val="solid"/>
-                    </a:lnT>
-                    <a:lnB algn="ctr" cmpd="sng" cap="flat" w="19050">
-                      <a:solidFill>
-                        <a:srgbClr val="666666">
-                          <a:alpha val="100000"/>
-                        </a:srgbClr>
-                      </a:solidFill>
-                      <a:prstDash val="solid"/>
-                    </a:lnB>
-                    <a:solidFill>
-                      <a:srgbClr val="F4F8FB">
-                        <a:alpha val="100000"/>
-                      </a:srgbClr>
-                    </a:solidFill>
-                  </a:tcPr>
-                </a:tc>
-                <a:tc>
-                  <a:txBody>
-                    <a:bodyPr/>
-                    <a:lstStyle/>
-                    <a:p>
-                      <a:pPr algn="l" marL="63500" marR="63500">
-                        <a:lnSpc>
-                          <a:spcPct val="100000"/>
-                        </a:lnSpc>
-                        <a:spcBef>
-                          <a:spcPts val="500"/>
-                        </a:spcBef>
-                        <a:spcAft>
-                          <a:spcPts val="500"/>
-                        </a:spcAft>
-                        <a:buNone/>
-                      </a:pPr>
-                      <a:r>
-                        <a:rPr cap="none" sz="1200" i="0" b="0" u="none" strike="noStrike">
-                          <a:solidFill>
-                            <a:srgbClr val="5B6770">
-                              <a:alpha val="100000"/>
-                            </a:srgbClr>
-                          </a:solidFill>
-                          <a:latin typeface="Helvetica Neue"/>
-                          <a:cs typeface="Helvetica Neue"/>
-                          <a:ea typeface="Helvetica Neue"/>
-                          <a:sym typeface="Helvetica Neue"/>
-                        </a:rPr>
-                        <a:t>900796</a:t>
+                        <a:t>900889</a:t>
                       </a:r>
                     </a:p>
                   </a:txBody>
@@ -18510,7 +18510,7 @@
                           <a:ea typeface="Helvetica Neue"/>
                           <a:sym typeface="Helvetica Neue"/>
                         </a:rPr>
-                        <a:t>1,513</a:t>
+                        <a:t>1,514</a:t>
                       </a:r>
                     </a:p>
                   </a:txBody>
@@ -18974,7 +18974,7 @@
                           <a:ea typeface="Helvetica Neue"/>
                           <a:sym typeface="Helvetica Neue"/>
                         </a:rPr>
-                        <a:t>163</a:t>
+                        <a:t>164</a:t>
                       </a:r>
                     </a:p>
                   </a:txBody>
@@ -19206,7 +19206,7 @@
                           <a:ea typeface="Helvetica Neue"/>
                           <a:sym typeface="Helvetica Neue"/>
                         </a:rPr>
-                        <a:t>81</a:t>
+                        <a:t>82</a:t>
                       </a:r>
                     </a:p>
                   </a:txBody>
@@ -20591,7 +20591,7 @@
                           <a:ea typeface="Helvetica Neue"/>
                           <a:sym typeface="Helvetica Neue"/>
                         </a:rPr>
-                        <a:t>1,753</a:t>
+                        <a:t>1,754</a:t>
                       </a:r>
                     </a:p>
                   </a:txBody>
@@ -24579,7 +24579,7 @@
             <a:tbl>
               <a:tblPr/>
               <a:tblGrid>
-                <a:gridCol w="2462983"/>
+                <a:gridCol w="3434608"/>
                 <a:gridCol w="1237011"/>
                 <a:gridCol w="1218929"/>
                 <a:gridCol w="1186187"/>
@@ -24942,6 +24942,293 @@
                           <a:ea typeface="Helvetica Neue"/>
                           <a:sym typeface="Helvetica Neue"/>
                         </a:rPr>
+                        <a:t>dihydro-7-hydroxy mitragynine (MGM-15)</a:t>
+                      </a:r>
+                    </a:p>
+                  </a:txBody>
+                  <a:tcPr anchor="ctr" marB="63500" marT="63500" marR="0" marL="0">
+                    <a:lnL algn="ctr" cmpd="sng" cap="flat" w="0">
+                      <a:noFill/>
+                      <a:prstDash val="solid"/>
+                    </a:lnL>
+                    <a:lnR algn="ctr" cmpd="sng" cap="flat" w="0">
+                      <a:noFill/>
+                      <a:prstDash val="solid"/>
+                    </a:lnR>
+                    <a:lnT algn="ctr" cmpd="sng" cap="flat" w="0">
+                      <a:noFill/>
+                      <a:prstDash val="solid"/>
+                    </a:lnT>
+                    <a:lnB algn="ctr" cmpd="sng" cap="flat" w="0">
+                      <a:noFill/>
+                      <a:prstDash val="solid"/>
+                    </a:lnB>
+                    <a:solidFill>
+                      <a:srgbClr val="FFFFFF">
+                        <a:alpha val="0"/>
+                      </a:srgbClr>
+                    </a:solidFill>
+                  </a:tcPr>
+                </a:tc>
+                <a:tc>
+                  <a:txBody>
+                    <a:bodyPr/>
+                    <a:lstStyle/>
+                    <a:p>
+                      <a:pPr algn="l" marL="63500" marR="63500">
+                        <a:lnSpc>
+                          <a:spcPct val="100000"/>
+                        </a:lnSpc>
+                        <a:spcBef>
+                          <a:spcPts val="500"/>
+                        </a:spcBef>
+                        <a:spcAft>
+                          <a:spcPts val="500"/>
+                        </a:spcAft>
+                        <a:buNone/>
+                      </a:pPr>
+                      <a:r>
+                        <a:rPr cap="none" sz="1200" i="0" b="0" u="none" strike="noStrike">
+                          <a:solidFill>
+                            <a:srgbClr val="5B6770">
+                              <a:alpha val="100000"/>
+                            </a:srgbClr>
+                          </a:solidFill>
+                          <a:latin typeface="Helvetica Neue"/>
+                          <a:cs typeface="Helvetica Neue"/>
+                          <a:ea typeface="Helvetica Neue"/>
+                          <a:sym typeface="Helvetica Neue"/>
+                        </a:rPr>
+                        <a:t>06 Oct 2026</a:t>
+                      </a:r>
+                    </a:p>
+                  </a:txBody>
+                  <a:tcPr anchor="ctr" marB="63500" marT="63500" marR="0" marL="0">
+                    <a:lnL algn="ctr" cmpd="sng" cap="flat" w="0">
+                      <a:noFill/>
+                      <a:prstDash val="solid"/>
+                    </a:lnL>
+                    <a:lnR algn="ctr" cmpd="sng" cap="flat" w="0">
+                      <a:noFill/>
+                      <a:prstDash val="solid"/>
+                    </a:lnR>
+                    <a:lnT algn="ctr" cmpd="sng" cap="flat" w="0">
+                      <a:noFill/>
+                      <a:prstDash val="solid"/>
+                    </a:lnT>
+                    <a:lnB algn="ctr" cmpd="sng" cap="flat" w="0">
+                      <a:noFill/>
+                      <a:prstDash val="solid"/>
+                    </a:lnB>
+                    <a:solidFill>
+                      <a:srgbClr val="FFFFFF">
+                        <a:alpha val="0"/>
+                      </a:srgbClr>
+                    </a:solidFill>
+                  </a:tcPr>
+                </a:tc>
+                <a:tc>
+                  <a:txBody>
+                    <a:bodyPr/>
+                    <a:lstStyle/>
+                    <a:p>
+                      <a:pPr algn="l" marL="63500" marR="63500">
+                        <a:lnSpc>
+                          <a:spcPct val="100000"/>
+                        </a:lnSpc>
+                        <a:spcBef>
+                          <a:spcPts val="500"/>
+                        </a:spcBef>
+                        <a:spcAft>
+                          <a:spcPts val="500"/>
+                        </a:spcAft>
+                        <a:buNone/>
+                      </a:pPr>
+                      <a:r>
+                        <a:rPr cap="none" sz="1200" i="0" b="0" u="none" strike="noStrike">
+                          <a:solidFill>
+                            <a:srgbClr val="5B6770">
+                              <a:alpha val="100000"/>
+                            </a:srgbClr>
+                          </a:solidFill>
+                          <a:latin typeface="Helvetica Neue"/>
+                          <a:cs typeface="Helvetica Neue"/>
+                          <a:ea typeface="Helvetica Neue"/>
+                          <a:sym typeface="Helvetica Neue"/>
+                        </a:rPr>
+                        <a:t>primary</a:t>
+                      </a:r>
+                    </a:p>
+                  </a:txBody>
+                  <a:tcPr anchor="ctr" marB="63500" marT="63500" marR="0" marL="0">
+                    <a:lnL algn="ctr" cmpd="sng" cap="flat" w="0">
+                      <a:noFill/>
+                      <a:prstDash val="solid"/>
+                    </a:lnL>
+                    <a:lnR algn="ctr" cmpd="sng" cap="flat" w="0">
+                      <a:noFill/>
+                      <a:prstDash val="solid"/>
+                    </a:lnR>
+                    <a:lnT algn="ctr" cmpd="sng" cap="flat" w="0">
+                      <a:noFill/>
+                      <a:prstDash val="solid"/>
+                    </a:lnT>
+                    <a:lnB algn="ctr" cmpd="sng" cap="flat" w="0">
+                      <a:noFill/>
+                      <a:prstDash val="solid"/>
+                    </a:lnB>
+                    <a:solidFill>
+                      <a:srgbClr val="FFFFFF">
+                        <a:alpha val="0"/>
+                      </a:srgbClr>
+                    </a:solidFill>
+                  </a:tcPr>
+                </a:tc>
+                <a:tc>
+                  <a:txBody>
+                    <a:bodyPr/>
+                    <a:lstStyle/>
+                    <a:p>
+                      <a:pPr algn="r" marL="63500" marR="63500">
+                        <a:lnSpc>
+                          <a:spcPct val="100000"/>
+                        </a:lnSpc>
+                        <a:spcBef>
+                          <a:spcPts val="500"/>
+                        </a:spcBef>
+                        <a:spcAft>
+                          <a:spcPts val="500"/>
+                        </a:spcAft>
+                        <a:buNone/>
+                      </a:pPr>
+                      <a:r>
+                        <a:rPr cap="none" sz="1200" i="0" b="0" u="none" strike="noStrike">
+                          <a:solidFill>
+                            <a:srgbClr val="5B6770">
+                              <a:alpha val="100000"/>
+                            </a:srgbClr>
+                          </a:solidFill>
+                          <a:latin typeface="Helvetica Neue"/>
+                          <a:cs typeface="Helvetica Neue"/>
+                          <a:ea typeface="Helvetica Neue"/>
+                          <a:sym typeface="Helvetica Neue"/>
+                        </a:rPr>
+                        <a:t>1</a:t>
+                      </a:r>
+                    </a:p>
+                  </a:txBody>
+                  <a:tcPr anchor="ctr" marB="63500" marT="63500" marR="0" marL="0">
+                    <a:lnL algn="ctr" cmpd="sng" cap="flat" w="0">
+                      <a:noFill/>
+                      <a:prstDash val="solid"/>
+                    </a:lnL>
+                    <a:lnR algn="ctr" cmpd="sng" cap="flat" w="0">
+                      <a:noFill/>
+                      <a:prstDash val="solid"/>
+                    </a:lnR>
+                    <a:lnT algn="ctr" cmpd="sng" cap="flat" w="0">
+                      <a:noFill/>
+                      <a:prstDash val="solid"/>
+                    </a:lnT>
+                    <a:lnB algn="ctr" cmpd="sng" cap="flat" w="0">
+                      <a:noFill/>
+                      <a:prstDash val="solid"/>
+                    </a:lnB>
+                    <a:solidFill>
+                      <a:srgbClr val="FFFFFF">
+                        <a:alpha val="0"/>
+                      </a:srgbClr>
+                    </a:solidFill>
+                  </a:tcPr>
+                </a:tc>
+                <a:tc>
+                  <a:txBody>
+                    <a:bodyPr/>
+                    <a:lstStyle/>
+                    <a:p>
+                      <a:pPr algn="l" marL="63500" marR="63500">
+                        <a:lnSpc>
+                          <a:spcPct val="100000"/>
+                        </a:lnSpc>
+                        <a:spcBef>
+                          <a:spcPts val="500"/>
+                        </a:spcBef>
+                        <a:spcAft>
+                          <a:spcPts val="500"/>
+                        </a:spcAft>
+                        <a:buNone/>
+                      </a:pPr>
+                      <a:r>
+                        <a:rPr cap="none" sz="1200" i="0" b="0" u="none" strike="noStrike">
+                          <a:solidFill>
+                            <a:srgbClr val="5B6770">
+                              <a:alpha val="100000"/>
+                            </a:srgbClr>
+                          </a:solidFill>
+                          <a:latin typeface="Helvetica Neue"/>
+                          <a:cs typeface="Helvetica Neue"/>
+                          <a:ea typeface="Helvetica Neue"/>
+                          <a:sym typeface="Helvetica Neue"/>
+                        </a:rPr>
+                        <a:t>605865</a:t>
+                      </a:r>
+                    </a:p>
+                  </a:txBody>
+                  <a:tcPr anchor="ctr" marB="63500" marT="63500" marR="0" marL="0">
+                    <a:lnL algn="ctr" cmpd="sng" cap="flat" w="0">
+                      <a:noFill/>
+                      <a:prstDash val="solid"/>
+                    </a:lnL>
+                    <a:lnR algn="ctr" cmpd="sng" cap="flat" w="0">
+                      <a:noFill/>
+                      <a:prstDash val="solid"/>
+                    </a:lnR>
+                    <a:lnT algn="ctr" cmpd="sng" cap="flat" w="0">
+                      <a:noFill/>
+                      <a:prstDash val="solid"/>
+                    </a:lnT>
+                    <a:lnB algn="ctr" cmpd="sng" cap="flat" w="0">
+                      <a:noFill/>
+                      <a:prstDash val="solid"/>
+                    </a:lnB>
+                    <a:solidFill>
+                      <a:srgbClr val="FFFFFF">
+                        <a:alpha val="0"/>
+                      </a:srgbClr>
+                    </a:solidFill>
+                  </a:tcPr>
+                </a:tc>
+              </a:tr>
+              <a:tr h="401320">
+                <a:tc>
+                  <a:txBody>
+                    <a:bodyPr/>
+                    <a:lstStyle/>
+                    <a:p>
+                      <a:pPr algn="l" marL="63500" marR="63500">
+                        <a:lnSpc>
+                          <a:spcPct val="100000"/>
+                        </a:lnSpc>
+                        <a:spcBef>
+                          <a:spcPts val="500"/>
+                        </a:spcBef>
+                        <a:spcAft>
+                          <a:spcPts val="500"/>
+                        </a:spcAft>
+                        <a:buNone/>
+                      </a:pPr>
+                      <a:r>
+                        <a:rPr cap="none" sz="1200" i="0" b="0" u="none" strike="noStrike">
+                          <a:solidFill>
+                            <a:srgbClr val="5B6770">
+                              <a:alpha val="100000"/>
+                            </a:srgbClr>
+                          </a:solidFill>
+                          <a:latin typeface="Helvetica Neue"/>
+                          <a:cs typeface="Helvetica Neue"/>
+                          <a:ea typeface="Helvetica Neue"/>
+                          <a:sym typeface="Helvetica Neue"/>
+                        </a:rPr>
                         <a:t>cannabigerol</a:t>
                       </a:r>
                     </a:p>
@@ -24964,8 +25251,8 @@
                       <a:prstDash val="solid"/>
                     </a:lnB>
                     <a:solidFill>
-                      <a:srgbClr val="FFFFFF">
-                        <a:alpha val="0"/>
+                      <a:srgbClr val="F4F8FB">
+                        <a:alpha val="100000"/>
                       </a:srgbClr>
                     </a:solidFill>
                   </a:tcPr>
@@ -25021,8 +25308,8 @@
                       <a:prstDash val="solid"/>
                     </a:lnB>
                     <a:solidFill>
-                      <a:srgbClr val="FFFFFF">
-                        <a:alpha val="0"/>
+                      <a:srgbClr val="F4F8FB">
+                        <a:alpha val="100000"/>
                       </a:srgbClr>
                     </a:solidFill>
                   </a:tcPr>
@@ -25078,8 +25365,8 @@
                       <a:prstDash val="solid"/>
                     </a:lnB>
                     <a:solidFill>
-                      <a:srgbClr val="FFFFFF">
-                        <a:alpha val="0"/>
+                      <a:srgbClr val="F4F8FB">
+                        <a:alpha val="100000"/>
                       </a:srgbClr>
                     </a:solidFill>
                   </a:tcPr>
@@ -25135,8 +25422,8 @@
                       <a:prstDash val="solid"/>
                     </a:lnB>
                     <a:solidFill>
-                      <a:srgbClr val="FFFFFF">
-                        <a:alpha val="0"/>
+                      <a:srgbClr val="F4F8FB">
+                        <a:alpha val="100000"/>
                       </a:srgbClr>
                     </a:solidFill>
                   </a:tcPr>
@@ -25192,8 +25479,8 @@
                       <a:prstDash val="solid"/>
                     </a:lnB>
                     <a:solidFill>
-                      <a:srgbClr val="FFFFFF">
-                        <a:alpha val="0"/>
+                      <a:srgbClr val="F4F8FB">
+                        <a:alpha val="100000"/>
                       </a:srgbClr>
                     </a:solidFill>
                   </a:tcPr>
@@ -25251,8 +25538,8 @@
                       <a:prstDash val="solid"/>
                     </a:lnB>
                     <a:solidFill>
-                      <a:srgbClr val="F4F8FB">
-                        <a:alpha val="100000"/>
+                      <a:srgbClr val="FFFFFF">
+                        <a:alpha val="0"/>
                       </a:srgbClr>
                     </a:solidFill>
                   </a:tcPr>
@@ -25308,8 +25595,8 @@
                       <a:prstDash val="solid"/>
                     </a:lnB>
                     <a:solidFill>
-                      <a:srgbClr val="F4F8FB">
-                        <a:alpha val="100000"/>
+                      <a:srgbClr val="FFFFFF">
+                        <a:alpha val="0"/>
                       </a:srgbClr>
                     </a:solidFill>
                   </a:tcPr>
@@ -25365,8 +25652,8 @@
                       <a:prstDash val="solid"/>
                     </a:lnB>
                     <a:solidFill>
-                      <a:srgbClr val="F4F8FB">
-                        <a:alpha val="100000"/>
+                      <a:srgbClr val="FFFFFF">
+                        <a:alpha val="0"/>
                       </a:srgbClr>
                     </a:solidFill>
                   </a:tcPr>
@@ -25422,8 +25709,8 @@
                       <a:prstDash val="solid"/>
                     </a:lnB>
                     <a:solidFill>
-                      <a:srgbClr val="F4F8FB">
-                        <a:alpha val="100000"/>
+                      <a:srgbClr val="FFFFFF">
+                        <a:alpha val="0"/>
                       </a:srgbClr>
                     </a:solidFill>
                   </a:tcPr>
@@ -25479,8 +25766,8 @@
                       <a:prstDash val="solid"/>
                     </a:lnB>
                     <a:solidFill>
-                      <a:srgbClr val="F4F8FB">
-                        <a:alpha val="100000"/>
+                      <a:srgbClr val="FFFFFF">
+                        <a:alpha val="0"/>
                       </a:srgbClr>
                     </a:solidFill>
                   </a:tcPr>
@@ -25538,8 +25825,8 @@
                       <a:prstDash val="solid"/>
                     </a:lnB>
                     <a:solidFill>
-                      <a:srgbClr val="FFFFFF">
-                        <a:alpha val="0"/>
+                      <a:srgbClr val="F4F8FB">
+                        <a:alpha val="100000"/>
                       </a:srgbClr>
                     </a:solidFill>
                   </a:tcPr>
@@ -25595,8 +25882,8 @@
                       <a:prstDash val="solid"/>
                     </a:lnB>
                     <a:solidFill>
-                      <a:srgbClr val="FFFFFF">
-                        <a:alpha val="0"/>
+                      <a:srgbClr val="F4F8FB">
+                        <a:alpha val="100000"/>
                       </a:srgbClr>
                     </a:solidFill>
                   </a:tcPr>
@@ -25652,8 +25939,8 @@
                       <a:prstDash val="solid"/>
                     </a:lnB>
                     <a:solidFill>
-                      <a:srgbClr val="FFFFFF">
-                        <a:alpha val="0"/>
+                      <a:srgbClr val="F4F8FB">
+                        <a:alpha val="100000"/>
                       </a:srgbClr>
                     </a:solidFill>
                   </a:tcPr>
@@ -25709,8 +25996,8 @@
                       <a:prstDash val="solid"/>
                     </a:lnB>
                     <a:solidFill>
-                      <a:srgbClr val="FFFFFF">
-                        <a:alpha val="0"/>
+                      <a:srgbClr val="F4F8FB">
+                        <a:alpha val="100000"/>
                       </a:srgbClr>
                     </a:solidFill>
                   </a:tcPr>
@@ -25766,8 +26053,8 @@
                       <a:prstDash val="solid"/>
                     </a:lnB>
                     <a:solidFill>
-                      <a:srgbClr val="FFFFFF">
-                        <a:alpha val="0"/>
+                      <a:srgbClr val="F4F8FB">
+                        <a:alpha val="100000"/>
                       </a:srgbClr>
                     </a:solidFill>
                   </a:tcPr>
@@ -25825,8 +26112,8 @@
                       <a:prstDash val="solid"/>
                     </a:lnB>
                     <a:solidFill>
-                      <a:srgbClr val="F4F8FB">
-                        <a:alpha val="100000"/>
+                      <a:srgbClr val="FFFFFF">
+                        <a:alpha val="0"/>
                       </a:srgbClr>
                     </a:solidFill>
                   </a:tcPr>
@@ -25882,8 +26169,8 @@
                       <a:prstDash val="solid"/>
                     </a:lnB>
                     <a:solidFill>
-                      <a:srgbClr val="F4F8FB">
-                        <a:alpha val="100000"/>
+                      <a:srgbClr val="FFFFFF">
+                        <a:alpha val="0"/>
                       </a:srgbClr>
                     </a:solidFill>
                   </a:tcPr>
@@ -25939,8 +26226,8 @@
                       <a:prstDash val="solid"/>
                     </a:lnB>
                     <a:solidFill>
-                      <a:srgbClr val="F4F8FB">
-                        <a:alpha val="100000"/>
+                      <a:srgbClr val="FFFFFF">
+                        <a:alpha val="0"/>
                       </a:srgbClr>
                     </a:solidFill>
                   </a:tcPr>
@@ -25996,8 +26283,8 @@
                       <a:prstDash val="solid"/>
                     </a:lnB>
                     <a:solidFill>
-                      <a:srgbClr val="F4F8FB">
-                        <a:alpha val="100000"/>
+                      <a:srgbClr val="FFFFFF">
+                        <a:alpha val="0"/>
                       </a:srgbClr>
                     </a:solidFill>
                   </a:tcPr>
@@ -26053,8 +26340,8 @@
                       <a:prstDash val="solid"/>
                     </a:lnB>
                     <a:solidFill>
-                      <a:srgbClr val="F4F8FB">
-                        <a:alpha val="100000"/>
+                      <a:srgbClr val="FFFFFF">
+                        <a:alpha val="0"/>
                       </a:srgbClr>
                     </a:solidFill>
                   </a:tcPr>
@@ -26112,8 +26399,8 @@
                       <a:prstDash val="solid"/>
                     </a:lnB>
                     <a:solidFill>
-                      <a:srgbClr val="FFFFFF">
-                        <a:alpha val="0"/>
+                      <a:srgbClr val="F4F8FB">
+                        <a:alpha val="100000"/>
                       </a:srgbClr>
                     </a:solidFill>
                   </a:tcPr>
@@ -26169,8 +26456,8 @@
                       <a:prstDash val="solid"/>
                     </a:lnB>
                     <a:solidFill>
-                      <a:srgbClr val="FFFFFF">
-                        <a:alpha val="0"/>
+                      <a:srgbClr val="F4F8FB">
+                        <a:alpha val="100000"/>
                       </a:srgbClr>
                     </a:solidFill>
                   </a:tcPr>
@@ -26226,8 +26513,8 @@
                       <a:prstDash val="solid"/>
                     </a:lnB>
                     <a:solidFill>
-                      <a:srgbClr val="FFFFFF">
-                        <a:alpha val="0"/>
+                      <a:srgbClr val="F4F8FB">
+                        <a:alpha val="100000"/>
                       </a:srgbClr>
                     </a:solidFill>
                   </a:tcPr>
@@ -26283,8 +26570,8 @@
                       <a:prstDash val="solid"/>
                     </a:lnB>
                     <a:solidFill>
-                      <a:srgbClr val="FFFFFF">
-                        <a:alpha val="0"/>
+                      <a:srgbClr val="F4F8FB">
+                        <a:alpha val="100000"/>
                       </a:srgbClr>
                     </a:solidFill>
                   </a:tcPr>
@@ -26340,8 +26627,8 @@
                       <a:prstDash val="solid"/>
                     </a:lnB>
                     <a:solidFill>
-                      <a:srgbClr val="FFFFFF">
-                        <a:alpha val="0"/>
+                      <a:srgbClr val="F4F8FB">
+                        <a:alpha val="100000"/>
                       </a:srgbClr>
                     </a:solidFill>
                   </a:tcPr>
@@ -26399,8 +26686,8 @@
                       <a:prstDash val="solid"/>
                     </a:lnB>
                     <a:solidFill>
-                      <a:srgbClr val="F4F8FB">
-                        <a:alpha val="100000"/>
+                      <a:srgbClr val="FFFFFF">
+                        <a:alpha val="0"/>
                       </a:srgbClr>
                     </a:solidFill>
                   </a:tcPr>
@@ -26456,8 +26743,8 @@
                       <a:prstDash val="solid"/>
                     </a:lnB>
                     <a:solidFill>
-                      <a:srgbClr val="F4F8FB">
-                        <a:alpha val="100000"/>
+                      <a:srgbClr val="FFFFFF">
+                        <a:alpha val="0"/>
                       </a:srgbClr>
                     </a:solidFill>
                   </a:tcPr>
@@ -26513,8 +26800,8 @@
                       <a:prstDash val="solid"/>
                     </a:lnB>
                     <a:solidFill>
-                      <a:srgbClr val="F4F8FB">
-                        <a:alpha val="100000"/>
+                      <a:srgbClr val="FFFFFF">
+                        <a:alpha val="0"/>
                       </a:srgbClr>
                     </a:solidFill>
                   </a:tcPr>
@@ -26570,8 +26857,8 @@
                       <a:prstDash val="solid"/>
                     </a:lnB>
                     <a:solidFill>
-                      <a:srgbClr val="F4F8FB">
-                        <a:alpha val="100000"/>
+                      <a:srgbClr val="FFFFFF">
+                        <a:alpha val="0"/>
                       </a:srgbClr>
                     </a:solidFill>
                   </a:tcPr>
@@ -26627,8 +26914,8 @@
                       <a:prstDash val="solid"/>
                     </a:lnB>
                     <a:solidFill>
-                      <a:srgbClr val="F4F8FB">
-                        <a:alpha val="100000"/>
+                      <a:srgbClr val="FFFFFF">
+                        <a:alpha val="0"/>
                       </a:srgbClr>
                     </a:solidFill>
                   </a:tcPr>
@@ -26686,8 +26973,8 @@
                       <a:prstDash val="solid"/>
                     </a:lnB>
                     <a:solidFill>
-                      <a:srgbClr val="FFFFFF">
-                        <a:alpha val="0"/>
+                      <a:srgbClr val="F4F8FB">
+                        <a:alpha val="100000"/>
                       </a:srgbClr>
                     </a:solidFill>
                   </a:tcPr>
@@ -26743,8 +27030,8 @@
                       <a:prstDash val="solid"/>
                     </a:lnB>
                     <a:solidFill>
-                      <a:srgbClr val="FFFFFF">
-                        <a:alpha val="0"/>
+                      <a:srgbClr val="F4F8FB">
+                        <a:alpha val="100000"/>
                       </a:srgbClr>
                     </a:solidFill>
                   </a:tcPr>
@@ -26800,8 +27087,8 @@
                       <a:prstDash val="solid"/>
                     </a:lnB>
                     <a:solidFill>
-                      <a:srgbClr val="FFFFFF">
-                        <a:alpha val="0"/>
+                      <a:srgbClr val="F4F8FB">
+                        <a:alpha val="100000"/>
                       </a:srgbClr>
                     </a:solidFill>
                   </a:tcPr>
@@ -26857,8 +27144,8 @@
                       <a:prstDash val="solid"/>
                     </a:lnB>
                     <a:solidFill>
-                      <a:srgbClr val="FFFFFF">
-                        <a:alpha val="0"/>
+                      <a:srgbClr val="F4F8FB">
+                        <a:alpha val="100000"/>
                       </a:srgbClr>
                     </a:solidFill>
                   </a:tcPr>
@@ -26914,8 +27201,8 @@
                       <a:prstDash val="solid"/>
                     </a:lnB>
                     <a:solidFill>
-                      <a:srgbClr val="FFFFFF">
-                        <a:alpha val="0"/>
+                      <a:srgbClr val="F4F8FB">
+                        <a:alpha val="100000"/>
                       </a:srgbClr>
                     </a:solidFill>
                   </a:tcPr>
@@ -26973,8 +27260,8 @@
                       <a:prstDash val="solid"/>
                     </a:lnB>
                     <a:solidFill>
-                      <a:srgbClr val="F4F8FB">
-                        <a:alpha val="100000"/>
+                      <a:srgbClr val="FFFFFF">
+                        <a:alpha val="0"/>
                       </a:srgbClr>
                     </a:solidFill>
                   </a:tcPr>
@@ -27030,8 +27317,8 @@
                       <a:prstDash val="solid"/>
                     </a:lnB>
                     <a:solidFill>
-                      <a:srgbClr val="F4F8FB">
-                        <a:alpha val="100000"/>
+                      <a:srgbClr val="FFFFFF">
+                        <a:alpha val="0"/>
                       </a:srgbClr>
                     </a:solidFill>
                   </a:tcPr>
@@ -27087,8 +27374,8 @@
                       <a:prstDash val="solid"/>
                     </a:lnB>
                     <a:solidFill>
-                      <a:srgbClr val="F4F8FB">
-                        <a:alpha val="100000"/>
+                      <a:srgbClr val="FFFFFF">
+                        <a:alpha val="0"/>
                       </a:srgbClr>
                     </a:solidFill>
                   </a:tcPr>
@@ -27144,8 +27431,8 @@
                       <a:prstDash val="solid"/>
                     </a:lnB>
                     <a:solidFill>
-                      <a:srgbClr val="F4F8FB">
-                        <a:alpha val="100000"/>
+                      <a:srgbClr val="FFFFFF">
+                        <a:alpha val="0"/>
                       </a:srgbClr>
                     </a:solidFill>
                   </a:tcPr>
@@ -27201,8 +27488,8 @@
                       <a:prstDash val="solid"/>
                     </a:lnB>
                     <a:solidFill>
-                      <a:srgbClr val="F4F8FB">
-                        <a:alpha val="100000"/>
+                      <a:srgbClr val="FFFFFF">
+                        <a:alpha val="0"/>
                       </a:srgbClr>
                     </a:solidFill>
                   </a:tcPr>
@@ -27260,8 +27547,8 @@
                       <a:prstDash val="solid"/>
                     </a:lnB>
                     <a:solidFill>
-                      <a:srgbClr val="FFFFFF">
-                        <a:alpha val="0"/>
+                      <a:srgbClr val="F4F8FB">
+                        <a:alpha val="100000"/>
                       </a:srgbClr>
                     </a:solidFill>
                   </a:tcPr>
@@ -27317,8 +27604,8 @@
                       <a:prstDash val="solid"/>
                     </a:lnB>
                     <a:solidFill>
-                      <a:srgbClr val="FFFFFF">
-                        <a:alpha val="0"/>
+                      <a:srgbClr val="F4F8FB">
+                        <a:alpha val="100000"/>
                       </a:srgbClr>
                     </a:solidFill>
                   </a:tcPr>
@@ -27374,8 +27661,8 @@
                       <a:prstDash val="solid"/>
                     </a:lnB>
                     <a:solidFill>
-                      <a:srgbClr val="FFFFFF">
-                        <a:alpha val="0"/>
+                      <a:srgbClr val="F4F8FB">
+                        <a:alpha val="100000"/>
                       </a:srgbClr>
                     </a:solidFill>
                   </a:tcPr>
@@ -27431,8 +27718,8 @@
                       <a:prstDash val="solid"/>
                     </a:lnB>
                     <a:solidFill>
-                      <a:srgbClr val="FFFFFF">
-                        <a:alpha val="0"/>
+                      <a:srgbClr val="F4F8FB">
+                        <a:alpha val="100000"/>
                       </a:srgbClr>
                     </a:solidFill>
                   </a:tcPr>
@@ -27488,8 +27775,8 @@
                       <a:prstDash val="solid"/>
                     </a:lnB>
                     <a:solidFill>
-                      <a:srgbClr val="FFFFFF">
-                        <a:alpha val="0"/>
+                      <a:srgbClr val="F4F8FB">
+                        <a:alpha val="100000"/>
                       </a:srgbClr>
                     </a:solidFill>
                   </a:tcPr>
@@ -27547,8 +27834,8 @@
                       <a:prstDash val="solid"/>
                     </a:lnB>
                     <a:solidFill>
-                      <a:srgbClr val="F4F8FB">
-                        <a:alpha val="100000"/>
+                      <a:srgbClr val="FFFFFF">
+                        <a:alpha val="0"/>
                       </a:srgbClr>
                     </a:solidFill>
                   </a:tcPr>
@@ -27604,8 +27891,8 @@
                       <a:prstDash val="solid"/>
                     </a:lnB>
                     <a:solidFill>
-                      <a:srgbClr val="F4F8FB">
-                        <a:alpha val="100000"/>
+                      <a:srgbClr val="FFFFFF">
+                        <a:alpha val="0"/>
                       </a:srgbClr>
                     </a:solidFill>
                   </a:tcPr>
@@ -27661,8 +27948,8 @@
                       <a:prstDash val="solid"/>
                     </a:lnB>
                     <a:solidFill>
-                      <a:srgbClr val="F4F8FB">
-                        <a:alpha val="100000"/>
+                      <a:srgbClr val="FFFFFF">
+                        <a:alpha val="0"/>
                       </a:srgbClr>
                     </a:solidFill>
                   </a:tcPr>
@@ -27718,8 +28005,8 @@
                       <a:prstDash val="solid"/>
                     </a:lnB>
                     <a:solidFill>
-                      <a:srgbClr val="F4F8FB">
-                        <a:alpha val="100000"/>
+                      <a:srgbClr val="FFFFFF">
+                        <a:alpha val="0"/>
                       </a:srgbClr>
                     </a:solidFill>
                   </a:tcPr>
@@ -27775,14 +28062,14 @@
                       <a:prstDash val="solid"/>
                     </a:lnB>
                     <a:solidFill>
-                      <a:srgbClr val="F4F8FB">
-                        <a:alpha val="100000"/>
+                      <a:srgbClr val="FFFFFF">
+                        <a:alpha val="0"/>
                       </a:srgbClr>
                     </a:solidFill>
                   </a:tcPr>
                 </a:tc>
               </a:tr>
-              <a:tr h="401320">
+              <a:tr h="410845">
                 <a:tc>
                   <a:txBody>
                     <a:bodyPr/>
@@ -27829,13 +28116,17 @@
                       <a:noFill/>
                       <a:prstDash val="solid"/>
                     </a:lnT>
-                    <a:lnB algn="ctr" cmpd="sng" cap="flat" w="0">
-                      <a:noFill/>
+                    <a:lnB algn="ctr" cmpd="sng" cap="flat" w="19050">
+                      <a:solidFill>
+                        <a:srgbClr val="666666">
+                          <a:alpha val="100000"/>
+                        </a:srgbClr>
+                      </a:solidFill>
                       <a:prstDash val="solid"/>
                     </a:lnB>
                     <a:solidFill>
-                      <a:srgbClr val="FFFFFF">
-                        <a:alpha val="0"/>
+                      <a:srgbClr val="F4F8FB">
+                        <a:alpha val="100000"/>
                       </a:srgbClr>
                     </a:solidFill>
                   </a:tcPr>
@@ -27886,13 +28177,17 @@
                       <a:noFill/>
                       <a:prstDash val="solid"/>
                     </a:lnT>
-                    <a:lnB algn="ctr" cmpd="sng" cap="flat" w="0">
-                      <a:noFill/>
+                    <a:lnB algn="ctr" cmpd="sng" cap="flat" w="19050">
+                      <a:solidFill>
+                        <a:srgbClr val="666666">
+                          <a:alpha val="100000"/>
+                        </a:srgbClr>
+                      </a:solidFill>
                       <a:prstDash val="solid"/>
                     </a:lnB>
                     <a:solidFill>
-                      <a:srgbClr val="FFFFFF">
-                        <a:alpha val="0"/>
+                      <a:srgbClr val="F4F8FB">
+                        <a:alpha val="100000"/>
                       </a:srgbClr>
                     </a:solidFill>
                   </a:tcPr>
@@ -27943,13 +28238,17 @@
                       <a:noFill/>
                       <a:prstDash val="solid"/>
                     </a:lnT>
-                    <a:lnB algn="ctr" cmpd="sng" cap="flat" w="0">
-                      <a:noFill/>
+                    <a:lnB algn="ctr" cmpd="sng" cap="flat" w="19050">
+                      <a:solidFill>
+                        <a:srgbClr val="666666">
+                          <a:alpha val="100000"/>
+                        </a:srgbClr>
+                      </a:solidFill>
                       <a:prstDash val="solid"/>
                     </a:lnB>
                     <a:solidFill>
-                      <a:srgbClr val="FFFFFF">
-                        <a:alpha val="0"/>
+                      <a:srgbClr val="F4F8FB">
+                        <a:alpha val="100000"/>
                       </a:srgbClr>
                     </a:solidFill>
                   </a:tcPr>
@@ -28000,122 +28299,6 @@
                       <a:noFill/>
                       <a:prstDash val="solid"/>
                     </a:lnT>
-                    <a:lnB algn="ctr" cmpd="sng" cap="flat" w="0">
-                      <a:noFill/>
-                      <a:prstDash val="solid"/>
-                    </a:lnB>
-                    <a:solidFill>
-                      <a:srgbClr val="FFFFFF">
-                        <a:alpha val="0"/>
-                      </a:srgbClr>
-                    </a:solidFill>
-                  </a:tcPr>
-                </a:tc>
-                <a:tc>
-                  <a:txBody>
-                    <a:bodyPr/>
-                    <a:lstStyle/>
-                    <a:p>
-                      <a:pPr algn="l" marL="63500" marR="63500">
-                        <a:lnSpc>
-                          <a:spcPct val="100000"/>
-                        </a:lnSpc>
-                        <a:spcBef>
-                          <a:spcPts val="500"/>
-                        </a:spcBef>
-                        <a:spcAft>
-                          <a:spcPts val="500"/>
-                        </a:spcAft>
-                        <a:buNone/>
-                      </a:pPr>
-                      <a:r>
-                        <a:rPr cap="none" sz="1200" i="0" b="0" u="none" strike="noStrike">
-                          <a:solidFill>
-                            <a:srgbClr val="5B6770">
-                              <a:alpha val="100000"/>
-                            </a:srgbClr>
-                          </a:solidFill>
-                          <a:latin typeface="Helvetica Neue"/>
-                          <a:cs typeface="Helvetica Neue"/>
-                          <a:ea typeface="Helvetica Neue"/>
-                          <a:sym typeface="Helvetica Neue"/>
-                        </a:rPr>
-                        <a:t>900889</a:t>
-                      </a:r>
-                    </a:p>
-                  </a:txBody>
-                  <a:tcPr anchor="ctr" marB="63500" marT="63500" marR="0" marL="0">
-                    <a:lnL algn="ctr" cmpd="sng" cap="flat" w="0">
-                      <a:noFill/>
-                      <a:prstDash val="solid"/>
-                    </a:lnL>
-                    <a:lnR algn="ctr" cmpd="sng" cap="flat" w="0">
-                      <a:noFill/>
-                      <a:prstDash val="solid"/>
-                    </a:lnR>
-                    <a:lnT algn="ctr" cmpd="sng" cap="flat" w="0">
-                      <a:noFill/>
-                      <a:prstDash val="solid"/>
-                    </a:lnT>
-                    <a:lnB algn="ctr" cmpd="sng" cap="flat" w="0">
-                      <a:noFill/>
-                      <a:prstDash val="solid"/>
-                    </a:lnB>
-                    <a:solidFill>
-                      <a:srgbClr val="FFFFFF">
-                        <a:alpha val="0"/>
-                      </a:srgbClr>
-                    </a:solidFill>
-                  </a:tcPr>
-                </a:tc>
-              </a:tr>
-              <a:tr h="410845">
-                <a:tc>
-                  <a:txBody>
-                    <a:bodyPr/>
-                    <a:lstStyle/>
-                    <a:p>
-                      <a:pPr algn="l" marL="63500" marR="63500">
-                        <a:lnSpc>
-                          <a:spcPct val="100000"/>
-                        </a:lnSpc>
-                        <a:spcBef>
-                          <a:spcPts val="500"/>
-                        </a:spcBef>
-                        <a:spcAft>
-                          <a:spcPts val="500"/>
-                        </a:spcAft>
-                        <a:buNone/>
-                      </a:pPr>
-                      <a:r>
-                        <a:rPr cap="none" sz="1200" i="0" b="0" u="none" strike="noStrike">
-                          <a:solidFill>
-                            <a:srgbClr val="5B6770">
-                              <a:alpha val="100000"/>
-                            </a:srgbClr>
-                          </a:solidFill>
-                          <a:latin typeface="Helvetica Neue"/>
-                          <a:cs typeface="Helvetica Neue"/>
-                          <a:ea typeface="Helvetica Neue"/>
-                          <a:sym typeface="Helvetica Neue"/>
-                        </a:rPr>
-                        <a:t>fentanyl methylene homolog</a:t>
-                      </a:r>
-                    </a:p>
-                  </a:txBody>
-                  <a:tcPr anchor="ctr" marB="63500" marT="63500" marR="0" marL="0">
-                    <a:lnL algn="ctr" cmpd="sng" cap="flat" w="0">
-                      <a:noFill/>
-                      <a:prstDash val="solid"/>
-                    </a:lnL>
-                    <a:lnR algn="ctr" cmpd="sng" cap="flat" w="0">
-                      <a:noFill/>
-                      <a:prstDash val="solid"/>
-                    </a:lnR>
-                    <a:lnT algn="ctr" cmpd="sng" cap="flat" w="0">
-                      <a:noFill/>
-                      <a:prstDash val="solid"/>
-                    </a:lnT>
                     <a:lnB algn="ctr" cmpd="sng" cap="flat" w="19050">
                       <a:solidFill>
                         <a:srgbClr val="666666">
@@ -28160,190 +28343,7 @@
                           <a:ea typeface="Helvetica Neue"/>
                           <a:sym typeface="Helvetica Neue"/>
                         </a:rPr>
-                        <a:t>16 Jul 2026</a:t>
-                      </a:r>
-                    </a:p>
-                  </a:txBody>
-                  <a:tcPr anchor="ctr" marB="63500" marT="63500" marR="0" marL="0">
-                    <a:lnL algn="ctr" cmpd="sng" cap="flat" w="0">
-                      <a:noFill/>
-                      <a:prstDash val="solid"/>
-                    </a:lnL>
-                    <a:lnR algn="ctr" cmpd="sng" cap="flat" w="0">
-                      <a:noFill/>
-                      <a:prstDash val="solid"/>
-                    </a:lnR>
-                    <a:lnT algn="ctr" cmpd="sng" cap="flat" w="0">
-                      <a:noFill/>
-                      <a:prstDash val="solid"/>
-                    </a:lnT>
-                    <a:lnB algn="ctr" cmpd="sng" cap="flat" w="19050">
-                      <a:solidFill>
-                        <a:srgbClr val="666666">
-                          <a:alpha val="100000"/>
-                        </a:srgbClr>
-                      </a:solidFill>
-                      <a:prstDash val="solid"/>
-                    </a:lnB>
-                    <a:solidFill>
-                      <a:srgbClr val="F4F8FB">
-                        <a:alpha val="100000"/>
-                      </a:srgbClr>
-                    </a:solidFill>
-                  </a:tcPr>
-                </a:tc>
-                <a:tc>
-                  <a:txBody>
-                    <a:bodyPr/>
-                    <a:lstStyle/>
-                    <a:p>
-                      <a:pPr algn="l" marL="63500" marR="63500">
-                        <a:lnSpc>
-                          <a:spcPct val="100000"/>
-                        </a:lnSpc>
-                        <a:spcBef>
-                          <a:spcPts val="500"/>
-                        </a:spcBef>
-                        <a:spcAft>
-                          <a:spcPts val="500"/>
-                        </a:spcAft>
-                        <a:buNone/>
-                      </a:pPr>
-                      <a:r>
-                        <a:rPr cap="none" sz="1200" i="0" b="0" u="none" strike="noStrike">
-                          <a:solidFill>
-                            <a:srgbClr val="5B6770">
-                              <a:alpha val="100000"/>
-                            </a:srgbClr>
-                          </a:solidFill>
-                          <a:latin typeface="Helvetica Neue"/>
-                          <a:cs typeface="Helvetica Neue"/>
-                          <a:ea typeface="Helvetica Neue"/>
-                          <a:sym typeface="Helvetica Neue"/>
-                        </a:rPr>
-                        <a:t>trace</a:t>
-                      </a:r>
-                    </a:p>
-                  </a:txBody>
-                  <a:tcPr anchor="ctr" marB="63500" marT="63500" marR="0" marL="0">
-                    <a:lnL algn="ctr" cmpd="sng" cap="flat" w="0">
-                      <a:noFill/>
-                      <a:prstDash val="solid"/>
-                    </a:lnL>
-                    <a:lnR algn="ctr" cmpd="sng" cap="flat" w="0">
-                      <a:noFill/>
-                      <a:prstDash val="solid"/>
-                    </a:lnR>
-                    <a:lnT algn="ctr" cmpd="sng" cap="flat" w="0">
-                      <a:noFill/>
-                      <a:prstDash val="solid"/>
-                    </a:lnT>
-                    <a:lnB algn="ctr" cmpd="sng" cap="flat" w="19050">
-                      <a:solidFill>
-                        <a:srgbClr val="666666">
-                          <a:alpha val="100000"/>
-                        </a:srgbClr>
-                      </a:solidFill>
-                      <a:prstDash val="solid"/>
-                    </a:lnB>
-                    <a:solidFill>
-                      <a:srgbClr val="F4F8FB">
-                        <a:alpha val="100000"/>
-                      </a:srgbClr>
-                    </a:solidFill>
-                  </a:tcPr>
-                </a:tc>
-                <a:tc>
-                  <a:txBody>
-                    <a:bodyPr/>
-                    <a:lstStyle/>
-                    <a:p>
-                      <a:pPr algn="r" marL="63500" marR="63500">
-                        <a:lnSpc>
-                          <a:spcPct val="100000"/>
-                        </a:lnSpc>
-                        <a:spcBef>
-                          <a:spcPts val="500"/>
-                        </a:spcBef>
-                        <a:spcAft>
-                          <a:spcPts val="500"/>
-                        </a:spcAft>
-                        <a:buNone/>
-                      </a:pPr>
-                      <a:r>
-                        <a:rPr cap="none" sz="1200" i="0" b="0" u="none" strike="noStrike">
-                          <a:solidFill>
-                            <a:srgbClr val="5B6770">
-                              <a:alpha val="100000"/>
-                            </a:srgbClr>
-                          </a:solidFill>
-                          <a:latin typeface="Helvetica Neue"/>
-                          <a:cs typeface="Helvetica Neue"/>
-                          <a:ea typeface="Helvetica Neue"/>
-                          <a:sym typeface="Helvetica Neue"/>
-                        </a:rPr>
-                        <a:t>1</a:t>
-                      </a:r>
-                    </a:p>
-                  </a:txBody>
-                  <a:tcPr anchor="ctr" marB="63500" marT="63500" marR="0" marL="0">
-                    <a:lnL algn="ctr" cmpd="sng" cap="flat" w="0">
-                      <a:noFill/>
-                      <a:prstDash val="solid"/>
-                    </a:lnL>
-                    <a:lnR algn="ctr" cmpd="sng" cap="flat" w="0">
-                      <a:noFill/>
-                      <a:prstDash val="solid"/>
-                    </a:lnR>
-                    <a:lnT algn="ctr" cmpd="sng" cap="flat" w="0">
-                      <a:noFill/>
-                      <a:prstDash val="solid"/>
-                    </a:lnT>
-                    <a:lnB algn="ctr" cmpd="sng" cap="flat" w="19050">
-                      <a:solidFill>
-                        <a:srgbClr val="666666">
-                          <a:alpha val="100000"/>
-                        </a:srgbClr>
-                      </a:solidFill>
-                      <a:prstDash val="solid"/>
-                    </a:lnB>
-                    <a:solidFill>
-                      <a:srgbClr val="F4F8FB">
-                        <a:alpha val="100000"/>
-                      </a:srgbClr>
-                    </a:solidFill>
-                  </a:tcPr>
-                </a:tc>
-                <a:tc>
-                  <a:txBody>
-                    <a:bodyPr/>
-                    <a:lstStyle/>
-                    <a:p>
-                      <a:pPr algn="l" marL="63500" marR="63500">
-                        <a:lnSpc>
-                          <a:spcPct val="100000"/>
-                        </a:lnSpc>
-                        <a:spcBef>
-                          <a:spcPts val="500"/>
-                        </a:spcBef>
-                        <a:spcAft>
-                          <a:spcPts val="500"/>
-                        </a:spcAft>
-                        <a:buNone/>
-                      </a:pPr>
-                      <a:r>
-                        <a:rPr cap="none" sz="1200" i="0" b="0" u="none" strike="noStrike">
-                          <a:solidFill>
-                            <a:srgbClr val="5B6770">
-                              <a:alpha val="100000"/>
-                            </a:srgbClr>
-                          </a:solidFill>
-                          <a:latin typeface="Helvetica Neue"/>
-                          <a:cs typeface="Helvetica Neue"/>
-                          <a:ea typeface="Helvetica Neue"/>
-                          <a:sym typeface="Helvetica Neue"/>
-                        </a:rPr>
-                        <a:t>900796</a:t>
+                        <a:t>900889</a:t>
                       </a:r>
                     </a:p>
                   </a:txBody>

</xml_diff>

<commit_message>
nightly deck: data through 2026-10-09
</commit_message>
<xml_diff>
--- a/docs/nc-drug-checking-latest.pptx
+++ b/docs/nc-drug-checking-latest.pptx
@@ -2418,7 +2418,7 @@
                 <a:ea typeface="Helvetica Neue"/>
                 <a:sym typeface="Helvetica Neue"/>
               </a:rPr>
-              <a:t>Generated Thursday, October 08, 2026 · 10:45 AM ET UNC Street Drug Analysis Lab · OpioidData.org · results.streetsafe.supply Download as PowerPoint</a:t>
+              <a:t>Generated Friday, October 09, 2026 · 10:28 AM ET UNC Street Drug Analysis Lab · OpioidData.org · results.streetsafe.supply Download as PowerPoint</a:t>
             </a:r>
           </a:p>
         </p:txBody>
@@ -2713,7 +2713,7 @@
                 <a:ea typeface="Helvetica Neue"/>
                 <a:sym typeface="Helvetica Neue"/>
               </a:rPr>
-              <a:t>PLACEHOLDER · figs/stats.json January 2022 to Wednesday, October 07, 2026 N = 2,947 NC samples analyzed Mailed in from 86 harm reduction programs Collected across 59 counties 249 distinct substances detected to date Unique samples = n_distinct(sampleid) · substances from lab_detail.substance · includes samples with date_complete 26 Jan 2022 – 07 Oct 2026 r/build_nightly.R → figs/stats.json</a:t>
+              <a:t>PLACEHOLDER · figs/stats.json January 2022 to Thursday, October 08, 2026 N = 2,955 NC samples analyzed Mailed in from 86 harm reduction programs Collected across 59 counties 249 distinct substances detected to date Unique samples = n_distinct(sampleid) · substances from lab_detail.substance · includes samples with date_complete 26 Jan 2022 – 08 Oct 2026 r/build_nightly.R → figs/stats.json</a:t>
             </a:r>
           </a:p>
         </p:txBody>
@@ -2762,7 +2762,7 @@
                 <a:ea typeface="Helvetica Neue"/>
                 <a:sym typeface="Helvetica Neue"/>
               </a:rPr>
-              <a:t>Unique samples = n_distinct(sampleid) · substances from lab_detail.substance · includes samples with date_complete 26 Jan 2022 – 07 Oct 2026</a:t>
+              <a:t>Unique samples = n_distinct(sampleid) · substances from lab_detail.substance · includes samples with date_complete 26 Jan 2022 – 08 Oct 2026</a:t>
             </a:r>
           </a:p>
         </p:txBody>
@@ -3184,7 +3184,7 @@
                 <a:ea typeface="Helvetica Neue"/>
                 <a:sym typeface="Helvetica Neue"/>
               </a:rPr>
-              <a:t>County = samplecounty · left: ≥1 completed analysis ever · right: unique samples per county (sqrt color scale) · all time: 26 Jan 2022 – 07 Oct 2026 · last 12 months: 08 Oct 2025 – 07 Oct 2026* · coverage reflects participation, not prevalence</a:t>
+              <a:t>County = samplecounty · left: ≥1 completed analysis ever · right: unique samples per county (sqrt color scale) · all time: 26 Jan 2022 – 08 Oct 2026 · last 12 months: 09 Oct 2025 – 08 Oct 2026* · coverage reflects participation, not prevalence</a:t>
             </a:r>
           </a:p>
         </p:txBody>
@@ -3505,7 +3505,7 @@
                 <a:ea typeface="Helvetica Neue"/>
                 <a:sym typeface="Helvetica Neue"/>
               </a:rPr>
-              <a:t>expectedsubstance (verbatim card write-in, semicolon lists split) · derived flags: expect_opioid, expect_fentanyl, expect_meth, expect_cocaine, expect_stimulant… · includes samples with date_complete 26 Jan 2022 – 07 Oct 2026 · data table: Appendix A2</a:t>
+              <a:t>expectedsubstance (verbatim card write-in, semicolon lists split) · derived flags: expect_opioid, expect_fentanyl, expect_meth, expect_cocaine, expect_stimulant… · includes samples with date_complete 26 Jan 2022 – 08 Oct 2026 · data table: Appendix A2</a:t>
             </a:r>
           </a:p>
         </p:txBody>
@@ -3703,7 +3703,7 @@
                 <a:ea typeface="Helvetica Neue"/>
                 <a:sym typeface="Helvetica Neue"/>
               </a:rPr>
-              <a:t>Numerator uses lab_*_any (primary or trace) among samples with expect_* = 1 · includes samples with date_complete 26 Jan 2022 – 07 Oct 2026 · data table: Appendix A3</a:t>
+              <a:t>Numerator uses lab_*_any (primary or trace) among samples with expect_* = 1 · includes samples with date_complete 26 Jan 2022 – 08 Oct 2026 · data table: Appendix A3</a:t>
             </a:r>
           </a:p>
         </p:txBody>
@@ -3901,7 +3901,7 @@
                 <a:ea typeface="Helvetica Neue"/>
                 <a:sym typeface="Helvetica Neue"/>
               </a:rPr>
-              <a:t>sensations (circled on card, semicolon lists split) · post-consumption samples only (consumed = 1) · includes samples with date_complete 26 Jan 2022 – 07 Oct 2026</a:t>
+              <a:t>sensations (circled on card, semicolon lists split) · post-consumption samples only (consumed = 1) · includes samples with date_complete 26 Jan 2022 – 08 Oct 2026</a:t>
             </a:r>
           </a:p>
         </p:txBody>
@@ -4125,7 +4125,7 @@
                 <a:ea typeface="Helvetica Neue"/>
                 <a:sym typeface="Helvetica Neue"/>
               </a:rPr>
-              <a:t>sensations semicolon lists parsed per report · consumed = 1 only · denominator: consumed samples with lab_*_any = 1 · includes samples with date_complete 26 Jan 2022 – 07 Oct 2026</a:t>
+              <a:t>sensations semicolon lists parsed per report · consumed = 1 only · denominator: consumed samples with lab_*_any = 1 · includes samples with date_complete 26 Jan 2022 – 08 Oct 2026</a:t>
             </a:r>
           </a:p>
         </p:txBody>
@@ -4323,7 +4323,7 @@
                 <a:ea typeface="Helvetica Neue"/>
                 <a:sym typeface="Helvetica Neue"/>
               </a:rPr>
-              <a:t>Samples with methamphetamine or cocaine detected (any abundance); samples in both classes appear on both slides · sensations semicolon lists parsed + sen_strength (own denominator) · consumed = 1 only · before: 26 Jan 2022 – 07 Oct 2025 · past 12 months: 08 Oct 2025 – 07 Oct 2026* · Δ in percentage points</a:t>
+              <a:t>Samples with methamphetamine or cocaine detected (any abundance); samples in both classes appear on both slides · sensations semicolon lists parsed + sen_strength (own denominator) · consumed = 1 only · before: 26 Jan 2022 – 08 Oct 2025 · past 12 months: 09 Oct 2025 – 08 Oct 2026* · Δ in percentage points</a:t>
             </a:r>
           </a:p>
         </p:txBody>
@@ -4742,7 +4742,7 @@
                 <a:ea typeface="Helvetica Neue"/>
                 <a:sym typeface="Helvetica Neue"/>
               </a:rPr>
-              <a:t>Samples with an opioid (fentanyl, heroin) or benzodiazepine detected (any abundance); samples in both classes appear on both slides · sensations semicolon lists parsed + sen_strength (own denominator) · consumed = 1 only · before: 26 Jan 2022 – 07 Oct 2025 · past 12 months: 08 Oct 2025 – 07 Oct 2026* · Δ in percentage points</a:t>
+              <a:t>Samples with an opioid (fentanyl, heroin) or benzodiazepine detected (any abundance); samples in both classes appear on both slides · sensations semicolon lists parsed + sen_strength (own denominator) · consumed = 1 only · before: 26 Jan 2022 – 08 Oct 2025 · past 12 months: 09 Oct 2025 – 08 Oct 2026* · Δ in percentage points</a:t>
             </a:r>
           </a:p>
         </p:txBody>
@@ -5138,7 +5138,7 @@
                 <a:ea typeface="Helvetica Neue"/>
                 <a:sym typeface="Helvetica Neue"/>
               </a:rPr>
-              <a:t>color, texture (card v3+, semicolon lists split) · derived: bright_color excludes white/tan/brown family — orange bar above · includes samples with date_complete 26 Jan 2022 – 07 Oct 2026</a:t>
+              <a:t>color, texture (card v3+, semicolon lists split) · derived: bright_color excludes white/tan/brown family — orange bar above · includes samples with date_complete 26 Jan 2022 – 08 Oct 2026</a:t>
             </a:r>
           </a:p>
         </p:txBody>
@@ -5459,7 +5459,7 @@
                 <a:ea typeface="Helvetica Neue"/>
                 <a:sym typeface="Helvetica Neue"/>
               </a:rPr>
-              <a:t>Distribution of substances detected per sample, both definitions shown side by side · includes samples with date_complete 26 Jan 2022 – 07 Oct 2026</a:t>
+              <a:t>Distribution of substances detected per sample, both definitions shown side by side · includes samples with date_complete 26 Jan 2022 – 08 Oct 2026</a:t>
             </a:r>
           </a:p>
         </p:txBody>
@@ -5657,7 +5657,7 @@
                 <a:ea typeface="Helvetica Neue"/>
                 <a:sym typeface="Helvetica Neue"/>
               </a:rPr>
-              <a:t>lab_detail.substance counts · solid = primary abundance, light = trace · standardized names (PubChem-linked) · includes samples with date_complete 26 Jan 2022 – 07 Oct 2026</a:t>
+              <a:t>lab_detail.substance counts · solid = primary abundance, light = trace · standardized names (PubChem-linked) · includes samples with date_complete 26 Jan 2022 – 08 Oct 2026</a:t>
             </a:r>
           </a:p>
         </p:txBody>
@@ -5855,7 +5855,7 @@
                 <a:ea typeface="Helvetica Neue"/>
                 <a:sym typeface="Helvetica Neue"/>
               </a:rPr>
-              <a:t>lab_detail.substance counts · solid = primary abundance, light = trace · standardized names (PubChem-linked) · window: date_complete 08 Oct 2025 – 07 Oct 2026* (trailing 12 months, current month partial)</a:t>
+              <a:t>lab_detail.substance counts · solid = primary abundance, light = trace · standardized names (PubChem-linked) · window: date_complete 09 Oct 2025 – 08 Oct 2026* (trailing 12 months, current month partial)</a:t>
             </a:r>
           </a:p>
         </p:txBody>
@@ -6053,7 +6053,7 @@
                 <a:ea typeface="Helvetica Neue"/>
                 <a:sym typeface="Helvetica Neue"/>
               </a:rPr>
-              <a:t>Distribution of substances detected per sample, both definitions shown side by side · window: date_complete 08 Oct 2025 – 07 Oct 2026* (trailing 12 months, current month partial)</a:t>
+              <a:t>Distribution of substances detected per sample, both definitions shown side by side · window: date_complete 09 Oct 2025 – 08 Oct 2026* (trailing 12 months, current month partial)</a:t>
             </a:r>
           </a:p>
         </p:txBody>
@@ -12081,7 +12081,7 @@
                           <a:ea typeface="Helvetica Neue"/>
                           <a:sym typeface="Helvetica Neue"/>
                         </a:rPr>
-                        <a:t>1</a:t>
+                        <a:t>2</a:t>
                       </a:r>
                     </a:p>
                   </a:txBody>
@@ -18510,7 +18510,7 @@
                           <a:ea typeface="Helvetica Neue"/>
                           <a:sym typeface="Helvetica Neue"/>
                         </a:rPr>
-                        <a:t>1,514</a:t>
+                        <a:t>1,519</a:t>
                       </a:r>
                     </a:p>
                   </a:txBody>
@@ -18974,7 +18974,7 @@
                           <a:ea typeface="Helvetica Neue"/>
                           <a:sym typeface="Helvetica Neue"/>
                         </a:rPr>
-                        <a:t>164</a:t>
+                        <a:t>165</a:t>
                       </a:r>
                     </a:p>
                   </a:txBody>
@@ -19322,7 +19322,7 @@
                           <a:ea typeface="Helvetica Neue"/>
                           <a:sym typeface="Helvetica Neue"/>
                         </a:rPr>
-                        <a:t>65</a:t>
+                        <a:t>66</a:t>
                       </a:r>
                     </a:p>
                   </a:txBody>
@@ -20591,7 +20591,7 @@
                           <a:ea typeface="Helvetica Neue"/>
                           <a:sym typeface="Helvetica Neue"/>
                         </a:rPr>
-                        <a:t>1,754</a:t>
+                        <a:t>1,761</a:t>
                       </a:r>
                     </a:p>
                   </a:txBody>
@@ -21515,7 +21515,7 @@
                           <a:ea typeface="Helvetica Neue"/>
                           <a:sym typeface="Helvetica Neue"/>
                         </a:rPr>
-                        <a:t>367</a:t>
+                        <a:t>369</a:t>
                       </a:r>
                     </a:p>
                   </a:txBody>
@@ -22151,7 +22151,7 @@
                           <a:ea typeface="Helvetica Neue"/>
                           <a:sym typeface="Helvetica Neue"/>
                         </a:rPr>
-                        <a:t>153 / month</a:t>
+                        <a:t>155 / month</a:t>
                       </a:r>
                     </a:p>
                   </a:txBody>
@@ -22208,7 +22208,7 @@
                           <a:ea typeface="Helvetica Neue"/>
                           <a:sym typeface="Helvetica Neue"/>
                         </a:rPr>
-                        <a:t>+53%</a:t>
+                        <a:t>+55%</a:t>
                       </a:r>
                     </a:p>
                   </a:txBody>
@@ -22324,7 +22324,7 @@
                           <a:ea typeface="Helvetica Neue"/>
                           <a:sym typeface="Helvetica Neue"/>
                         </a:rPr>
-                        <a:t>706</a:t>
+                        <a:t>710</a:t>
                       </a:r>
                     </a:p>
                   </a:txBody>
@@ -22381,7 +22381,7 @@
                           <a:ea typeface="Helvetica Neue"/>
                           <a:sym typeface="Helvetica Neue"/>
                         </a:rPr>
-                        <a:t>-2%</a:t>
+                        <a:t>-1%</a:t>
                       </a:r>
                     </a:p>
                   </a:txBody>
@@ -22497,7 +22497,7 @@
                           <a:ea typeface="Helvetica Neue"/>
                           <a:sym typeface="Helvetica Neue"/>
                         </a:rPr>
-                        <a:t>686</a:t>
+                        <a:t>690</a:t>
                       </a:r>
                     </a:p>
                   </a:txBody>
@@ -22554,7 +22554,7 @@
                           <a:ea typeface="Helvetica Neue"/>
                           <a:sym typeface="Helvetica Neue"/>
                         </a:rPr>
-                        <a:t>-5%</a:t>
+                        <a:t>-4%</a:t>
                       </a:r>
                     </a:p>
                   </a:txBody>
@@ -22727,7 +22727,7 @@
                           <a:ea typeface="Helvetica Neue"/>
                           <a:sym typeface="Helvetica Neue"/>
                         </a:rPr>
-                        <a:t>+63%</a:t>
+                        <a:t>+61%</a:t>
                       </a:r>
                     </a:p>
                   </a:txBody>
@@ -22843,7 +22843,7 @@
                           <a:ea typeface="Helvetica Neue"/>
                           <a:sym typeface="Helvetica Neue"/>
                         </a:rPr>
-                        <a:t>78</a:t>
+                        <a:t>77</a:t>
                       </a:r>
                     </a:p>
                   </a:txBody>
@@ -22900,7 +22900,7 @@
                           <a:ea typeface="Helvetica Neue"/>
                           <a:sym typeface="Helvetica Neue"/>
                         </a:rPr>
-                        <a:t>+57%</a:t>
+                        <a:t>+55%</a:t>
                       </a:r>
                     </a:p>
                   </a:txBody>
@@ -23020,7 +23020,7 @@
                           <a:ea typeface="Helvetica Neue"/>
                           <a:sym typeface="Helvetica Neue"/>
                         </a:rPr>
-                        <a:t>405</a:t>
+                        <a:t>406</a:t>
                       </a:r>
                     </a:p>
                   </a:txBody>
@@ -23081,7 +23081,7 @@
                           <a:ea typeface="Helvetica Neue"/>
                           <a:sym typeface="Helvetica Neue"/>
                         </a:rPr>
-                        <a:t>-4%</a:t>
+                        <a:t>-3%</a:t>
                       </a:r>
                     </a:p>
                   </a:txBody>
@@ -23423,7 +23423,7 @@
                           <a:ea typeface="Helvetica Neue"/>
                           <a:sym typeface="Helvetica Neue"/>
                         </a:rPr>
-                        <a:t>105</a:t>
+                        <a:t>103</a:t>
                       </a:r>
                     </a:p>
                   </a:txBody>
@@ -23480,7 +23480,7 @@
                           <a:ea typeface="Helvetica Neue"/>
                           <a:sym typeface="Helvetica Neue"/>
                         </a:rPr>
-                        <a:t>-5%</a:t>
+                        <a:t>-6%</a:t>
                       </a:r>
                     </a:p>
                   </a:txBody>
@@ -23769,7 +23769,7 @@
                           <a:ea typeface="Helvetica Neue"/>
                           <a:sym typeface="Helvetica Neue"/>
                         </a:rPr>
-                        <a:t>20</a:t>
+                        <a:t>19</a:t>
                       </a:r>
                     </a:p>
                   </a:txBody>
@@ -23942,7 +23942,7 @@
                           <a:ea typeface="Helvetica Neue"/>
                           <a:sym typeface="Helvetica Neue"/>
                         </a:rPr>
-                        <a:t>7</a:t>
+                        <a:t>6</a:t>
                       </a:r>
                     </a:p>
                   </a:txBody>
@@ -24172,7 +24172,7 @@
                           <a:ea typeface="Helvetica Neue"/>
                           <a:sym typeface="Helvetica Neue"/>
                         </a:rPr>
-                        <a:t>-13%</a:t>
+                        <a:t>-14%</a:t>
                       </a:r>
                     </a:p>
                   </a:txBody>
@@ -24353,7 +24353,7 @@
                           <a:ea typeface="Helvetica Neue"/>
                           <a:sym typeface="Helvetica Neue"/>
                         </a:rPr>
-                        <a:t>-35%</a:t>
+                        <a:t>-36%</a:t>
                       </a:r>
                     </a:p>
                   </a:txBody>
@@ -25974,7 +25974,7 @@
                           <a:ea typeface="Helvetica Neue"/>
                           <a:sym typeface="Helvetica Neue"/>
                         </a:rPr>
-                        <a:t>1</a:t>
+                        <a:t>2</a:t>
                       </a:r>
                     </a:p>
                   </a:txBody>

</xml_diff>

<commit_message>
nightly deck: data through 2026-10-10
</commit_message>
<xml_diff>
--- a/docs/nc-drug-checking-latest.pptx
+++ b/docs/nc-drug-checking-latest.pptx
@@ -2418,7 +2418,7 @@
                 <a:ea typeface="Helvetica Neue"/>
                 <a:sym typeface="Helvetica Neue"/>
               </a:rPr>
-              <a:t>Generated Friday, October 09, 2026 · 10:28 AM ET UNC Street Drug Analysis Lab · OpioidData.org · results.streetsafe.supply Download as PowerPoint</a:t>
+              <a:t>Generated Saturday, October 10, 2026 · 9:55 AM ET UNC Street Drug Analysis Lab · OpioidData.org · results.streetsafe.supply Download as PowerPoint</a:t>
             </a:r>
           </a:p>
         </p:txBody>
@@ -2713,7 +2713,7 @@
                 <a:ea typeface="Helvetica Neue"/>
                 <a:sym typeface="Helvetica Neue"/>
               </a:rPr>
-              <a:t>PLACEHOLDER · figs/stats.json January 2022 to Thursday, October 08, 2026 N = 2,955 NC samples analyzed Mailed in from 86 harm reduction programs Collected across 59 counties 249 distinct substances detected to date Unique samples = n_distinct(sampleid) · substances from lab_detail.substance · includes samples with date_complete 26 Jan 2022 – 08 Oct 2026 r/build_nightly.R → figs/stats.json</a:t>
+              <a:t>PLACEHOLDER · figs/stats.json January 2022 to Friday, October 09, 2026 N = 2,959 NC samples analyzed Mailed in from 86 harm reduction programs Collected across 59 counties 249 distinct substances detected to date Unique samples = n_distinct(sampleid) · substances from lab_detail.substance · includes samples with date_complete 26 Jan 2022 – 09 Oct 2026 r/build_nightly.R → figs/stats.json</a:t>
             </a:r>
           </a:p>
         </p:txBody>
@@ -2762,7 +2762,7 @@
                 <a:ea typeface="Helvetica Neue"/>
                 <a:sym typeface="Helvetica Neue"/>
               </a:rPr>
-              <a:t>Unique samples = n_distinct(sampleid) · substances from lab_detail.substance · includes samples with date_complete 26 Jan 2022 – 08 Oct 2026</a:t>
+              <a:t>Unique samples = n_distinct(sampleid) · substances from lab_detail.substance · includes samples with date_complete 26 Jan 2022 – 09 Oct 2026</a:t>
             </a:r>
           </a:p>
         </p:txBody>
@@ -3184,7 +3184,7 @@
                 <a:ea typeface="Helvetica Neue"/>
                 <a:sym typeface="Helvetica Neue"/>
               </a:rPr>
-              <a:t>County = samplecounty · left: ≥1 completed analysis ever · right: unique samples per county (sqrt color scale) · all time: 26 Jan 2022 – 08 Oct 2026 · last 12 months: 09 Oct 2025 – 08 Oct 2026* · coverage reflects participation, not prevalence</a:t>
+              <a:t>County = samplecounty · left: ≥1 completed analysis ever · right: unique samples per county (sqrt color scale) · all time: 26 Jan 2022 – 09 Oct 2026 · last 12 months: 10 Oct 2025 – 09 Oct 2026* · coverage reflects participation, not prevalence</a:t>
             </a:r>
           </a:p>
         </p:txBody>
@@ -3505,7 +3505,7 @@
                 <a:ea typeface="Helvetica Neue"/>
                 <a:sym typeface="Helvetica Neue"/>
               </a:rPr>
-              <a:t>expectedsubstance (verbatim card write-in, semicolon lists split) · derived flags: expect_opioid, expect_fentanyl, expect_meth, expect_cocaine, expect_stimulant… · includes samples with date_complete 26 Jan 2022 – 08 Oct 2026 · data table: Appendix A2</a:t>
+              <a:t>expectedsubstance (verbatim card write-in, semicolon lists split) · derived flags: expect_opioid, expect_fentanyl, expect_meth, expect_cocaine, expect_stimulant… · includes samples with date_complete 26 Jan 2022 – 09 Oct 2026 · data table: Appendix A2</a:t>
             </a:r>
           </a:p>
         </p:txBody>
@@ -3703,7 +3703,7 @@
                 <a:ea typeface="Helvetica Neue"/>
                 <a:sym typeface="Helvetica Neue"/>
               </a:rPr>
-              <a:t>Numerator uses lab_*_any (primary or trace) among samples with expect_* = 1 · includes samples with date_complete 26 Jan 2022 – 08 Oct 2026 · data table: Appendix A3</a:t>
+              <a:t>Numerator uses lab_*_any (primary or trace) among samples with expect_* = 1 · includes samples with date_complete 26 Jan 2022 – 09 Oct 2026 · data table: Appendix A3</a:t>
             </a:r>
           </a:p>
         </p:txBody>
@@ -3901,7 +3901,7 @@
                 <a:ea typeface="Helvetica Neue"/>
                 <a:sym typeface="Helvetica Neue"/>
               </a:rPr>
-              <a:t>sensations (circled on card, semicolon lists split) · post-consumption samples only (consumed = 1) · includes samples with date_complete 26 Jan 2022 – 08 Oct 2026</a:t>
+              <a:t>sensations (circled on card, semicolon lists split) · post-consumption samples only (consumed = 1) · includes samples with date_complete 26 Jan 2022 – 09 Oct 2026</a:t>
             </a:r>
           </a:p>
         </p:txBody>
@@ -4125,7 +4125,7 @@
                 <a:ea typeface="Helvetica Neue"/>
                 <a:sym typeface="Helvetica Neue"/>
               </a:rPr>
-              <a:t>sensations semicolon lists parsed per report · consumed = 1 only · denominator: consumed samples with lab_*_any = 1 · includes samples with date_complete 26 Jan 2022 – 08 Oct 2026</a:t>
+              <a:t>sensations semicolon lists parsed per report · consumed = 1 only · denominator: consumed samples with lab_*_any = 1 · includes samples with date_complete 26 Jan 2022 – 09 Oct 2026</a:t>
             </a:r>
           </a:p>
         </p:txBody>
@@ -4323,7 +4323,7 @@
                 <a:ea typeface="Helvetica Neue"/>
                 <a:sym typeface="Helvetica Neue"/>
               </a:rPr>
-              <a:t>Samples with methamphetamine or cocaine detected (any abundance); samples in both classes appear on both slides · sensations semicolon lists parsed + sen_strength (own denominator) · consumed = 1 only · before: 26 Jan 2022 – 08 Oct 2025 · past 12 months: 09 Oct 2025 – 08 Oct 2026* · Δ in percentage points</a:t>
+              <a:t>Samples with methamphetamine or cocaine detected (any abundance); samples in both classes appear on both slides · sensations semicolon lists parsed + sen_strength (own denominator) · consumed = 1 only · before: 26 Jan 2022 – 09 Oct 2025 · past 12 months: 10 Oct 2025 – 09 Oct 2026* · Δ in percentage points</a:t>
             </a:r>
           </a:p>
         </p:txBody>
@@ -4742,7 +4742,7 @@
                 <a:ea typeface="Helvetica Neue"/>
                 <a:sym typeface="Helvetica Neue"/>
               </a:rPr>
-              <a:t>Samples with an opioid (fentanyl, heroin) or benzodiazepine detected (any abundance); samples in both classes appear on both slides · sensations semicolon lists parsed + sen_strength (own denominator) · consumed = 1 only · before: 26 Jan 2022 – 08 Oct 2025 · past 12 months: 09 Oct 2025 – 08 Oct 2026* · Δ in percentage points</a:t>
+              <a:t>Samples with an opioid (fentanyl, heroin) or benzodiazepine detected (any abundance); samples in both classes appear on both slides · sensations semicolon lists parsed + sen_strength (own denominator) · consumed = 1 only · before: 26 Jan 2022 – 09 Oct 2025 · past 12 months: 10 Oct 2025 – 09 Oct 2026* · Δ in percentage points</a:t>
             </a:r>
           </a:p>
         </p:txBody>
@@ -5138,7 +5138,7 @@
                 <a:ea typeface="Helvetica Neue"/>
                 <a:sym typeface="Helvetica Neue"/>
               </a:rPr>
-              <a:t>color, texture (card v3+, semicolon lists split) · derived: bright_color excludes white/tan/brown family — orange bar above · includes samples with date_complete 26 Jan 2022 – 08 Oct 2026</a:t>
+              <a:t>color, texture (card v3+, semicolon lists split) · derived: bright_color excludes white/tan/brown family — orange bar above · includes samples with date_complete 26 Jan 2022 – 09 Oct 2026</a:t>
             </a:r>
           </a:p>
         </p:txBody>
@@ -5459,7 +5459,7 @@
                 <a:ea typeface="Helvetica Neue"/>
                 <a:sym typeface="Helvetica Neue"/>
               </a:rPr>
-              <a:t>Distribution of substances detected per sample, both definitions shown side by side · includes samples with date_complete 26 Jan 2022 – 08 Oct 2026</a:t>
+              <a:t>Distribution of substances detected per sample, both definitions shown side by side · includes samples with date_complete 26 Jan 2022 – 09 Oct 2026</a:t>
             </a:r>
           </a:p>
         </p:txBody>
@@ -5657,7 +5657,7 @@
                 <a:ea typeface="Helvetica Neue"/>
                 <a:sym typeface="Helvetica Neue"/>
               </a:rPr>
-              <a:t>lab_detail.substance counts · solid = primary abundance, light = trace · standardized names (PubChem-linked) · includes samples with date_complete 26 Jan 2022 – 08 Oct 2026</a:t>
+              <a:t>lab_detail.substance counts · solid = primary abundance, light = trace · standardized names (PubChem-linked) · includes samples with date_complete 26 Jan 2022 – 09 Oct 2026</a:t>
             </a:r>
           </a:p>
         </p:txBody>
@@ -5855,7 +5855,7 @@
                 <a:ea typeface="Helvetica Neue"/>
                 <a:sym typeface="Helvetica Neue"/>
               </a:rPr>
-              <a:t>lab_detail.substance counts · solid = primary abundance, light = trace · standardized names (PubChem-linked) · window: date_complete 09 Oct 2025 – 08 Oct 2026* (trailing 12 months, current month partial)</a:t>
+              <a:t>lab_detail.substance counts · solid = primary abundance, light = trace · standardized names (PubChem-linked) · window: date_complete 10 Oct 2025 – 09 Oct 2026* (trailing 12 months, current month partial)</a:t>
             </a:r>
           </a:p>
         </p:txBody>
@@ -6053,7 +6053,7 @@
                 <a:ea typeface="Helvetica Neue"/>
                 <a:sym typeface="Helvetica Neue"/>
               </a:rPr>
-              <a:t>Distribution of substances detected per sample, both definitions shown side by side · window: date_complete 09 Oct 2025 – 08 Oct 2026* (trailing 12 months, current month partial)</a:t>
+              <a:t>Distribution of substances detected per sample, both definitions shown side by side · window: date_complete 10 Oct 2025 – 09 Oct 2026* (trailing 12 months, current month partial)</a:t>
             </a:r>
           </a:p>
         </p:txBody>
@@ -18626,7 +18626,7 @@
                           <a:ea typeface="Helvetica Neue"/>
                           <a:sym typeface="Helvetica Neue"/>
                         </a:rPr>
-                        <a:t>452</a:t>
+                        <a:t>454</a:t>
                       </a:r>
                     </a:p>
                   </a:txBody>
@@ -19438,7 +19438,7 @@
                           <a:ea typeface="Helvetica Neue"/>
                           <a:sym typeface="Helvetica Neue"/>
                         </a:rPr>
-                        <a:t>61</a:t>
+                        <a:t>63</a:t>
                       </a:r>
                     </a:p>
                   </a:txBody>
@@ -20591,7 +20591,7 @@
                           <a:ea typeface="Helvetica Neue"/>
                           <a:sym typeface="Helvetica Neue"/>
                         </a:rPr>
-                        <a:t>1,761</a:t>
+                        <a:t>1,763</a:t>
                       </a:r>
                     </a:p>
                   </a:txBody>
@@ -20821,7 +20821,7 @@
                           <a:ea typeface="Helvetica Neue"/>
                           <a:sym typeface="Helvetica Neue"/>
                         </a:rPr>
-                        <a:t>528</a:t>
+                        <a:t>532</a:t>
                       </a:r>
                     </a:p>
                   </a:txBody>

</xml_diff>

<commit_message>
nightly deck: data through 2026-10-11
</commit_message>
<xml_diff>
--- a/docs/nc-drug-checking-latest.pptx
+++ b/docs/nc-drug-checking-latest.pptx
@@ -2418,7 +2418,7 @@
                 <a:ea typeface="Helvetica Neue"/>
                 <a:sym typeface="Helvetica Neue"/>
               </a:rPr>
-              <a:t>Generated Saturday, October 10, 2026 · 9:55 AM ET UNC Street Drug Analysis Lab · OpioidData.org · results.streetsafe.supply Download as PowerPoint</a:t>
+              <a:t>Generated Sunday, October 11, 2026 · 10:17 AM ET UNC Street Drug Analysis Lab · OpioidData.org · results.streetsafe.supply Download as PowerPoint</a:t>
             </a:r>
           </a:p>
         </p:txBody>
@@ -3184,7 +3184,7 @@
                 <a:ea typeface="Helvetica Neue"/>
                 <a:sym typeface="Helvetica Neue"/>
               </a:rPr>
-              <a:t>County = samplecounty · left: ≥1 completed analysis ever · right: unique samples per county (sqrt color scale) · all time: 26 Jan 2022 – 09 Oct 2026 · last 12 months: 10 Oct 2025 – 09 Oct 2026* · coverage reflects participation, not prevalence</a:t>
+              <a:t>County = samplecounty · left: ≥1 completed analysis ever · right: unique samples per county (sqrt color scale) · all time: 26 Jan 2022 – 09 Oct 2026 · last 12 months: 11 Oct 2025 – 09 Oct 2026* · coverage reflects participation, not prevalence</a:t>
             </a:r>
           </a:p>
         </p:txBody>
@@ -4323,7 +4323,7 @@
                 <a:ea typeface="Helvetica Neue"/>
                 <a:sym typeface="Helvetica Neue"/>
               </a:rPr>
-              <a:t>Samples with methamphetamine or cocaine detected (any abundance); samples in both classes appear on both slides · sensations semicolon lists parsed + sen_strength (own denominator) · consumed = 1 only · before: 26 Jan 2022 – 09 Oct 2025 · past 12 months: 10 Oct 2025 – 09 Oct 2026* · Δ in percentage points</a:t>
+              <a:t>Samples with methamphetamine or cocaine detected (any abundance); samples in both classes appear on both slides · sensations semicolon lists parsed + sen_strength (own denominator) · consumed = 1 only · before: 26 Jan 2022 – 09 Oct 2025 · past 12 months: 11 Oct 2025 – 09 Oct 2026* · Δ in percentage points</a:t>
             </a:r>
           </a:p>
         </p:txBody>
@@ -4742,7 +4742,7 @@
                 <a:ea typeface="Helvetica Neue"/>
                 <a:sym typeface="Helvetica Neue"/>
               </a:rPr>
-              <a:t>Samples with an opioid (fentanyl, heroin) or benzodiazepine detected (any abundance); samples in both classes appear on both slides · sensations semicolon lists parsed + sen_strength (own denominator) · consumed = 1 only · before: 26 Jan 2022 – 09 Oct 2025 · past 12 months: 10 Oct 2025 – 09 Oct 2026* · Δ in percentage points</a:t>
+              <a:t>Samples with an opioid (fentanyl, heroin) or benzodiazepine detected (any abundance); samples in both classes appear on both slides · sensations semicolon lists parsed + sen_strength (own denominator) · consumed = 1 only · before: 26 Jan 2022 – 09 Oct 2025 · past 12 months: 11 Oct 2025 – 09 Oct 2026* · Δ in percentage points</a:t>
             </a:r>
           </a:p>
         </p:txBody>
@@ -5855,7 +5855,7 @@
                 <a:ea typeface="Helvetica Neue"/>
                 <a:sym typeface="Helvetica Neue"/>
               </a:rPr>
-              <a:t>lab_detail.substance counts · solid = primary abundance, light = trace · standardized names (PubChem-linked) · window: date_complete 10 Oct 2025 – 09 Oct 2026* (trailing 12 months, current month partial)</a:t>
+              <a:t>lab_detail.substance counts · solid = primary abundance, light = trace · standardized names (PubChem-linked) · window: date_complete 11 Oct 2025 – 09 Oct 2026* (trailing 12 months, current month partial)</a:t>
             </a:r>
           </a:p>
         </p:txBody>
@@ -6053,7 +6053,7 @@
                 <a:ea typeface="Helvetica Neue"/>
                 <a:sym typeface="Helvetica Neue"/>
               </a:rPr>
-              <a:t>Distribution of substances detected per sample, both definitions shown side by side · window: date_complete 10 Oct 2025 – 09 Oct 2026* (trailing 12 months, current month partial)</a:t>
+              <a:t>Distribution of substances detected per sample, both definitions shown side by side · window: date_complete 11 Oct 2025 – 09 Oct 2026* (trailing 12 months, current month partial)</a:t>
             </a:r>
           </a:p>
         </p:txBody>

</xml_diff>

<commit_message>
nightly deck: data through 2026-10-12
</commit_message>
<xml_diff>
--- a/docs/nc-drug-checking-latest.pptx
+++ b/docs/nc-drug-checking-latest.pptx
@@ -2418,7 +2418,7 @@
                 <a:ea typeface="Helvetica Neue"/>
                 <a:sym typeface="Helvetica Neue"/>
               </a:rPr>
-              <a:t>Generated Sunday, October 11, 2026 · 10:17 AM ET UNC Street Drug Analysis Lab · OpioidData.org · results.streetsafe.supply Download as PowerPoint</a:t>
+              <a:t>Generated Monday, October 12, 2026 · 12:53 PM ET UNC Street Drug Analysis Lab · OpioidData.org · results.streetsafe.supply Download as PowerPoint</a:t>
             </a:r>
           </a:p>
         </p:txBody>
@@ -3184,7 +3184,7 @@
                 <a:ea typeface="Helvetica Neue"/>
                 <a:sym typeface="Helvetica Neue"/>
               </a:rPr>
-              <a:t>County = samplecounty · left: ≥1 completed analysis ever · right: unique samples per county (sqrt color scale) · all time: 26 Jan 2022 – 09 Oct 2026 · last 12 months: 11 Oct 2025 – 09 Oct 2026* · coverage reflects participation, not prevalence</a:t>
+              <a:t>County = samplecounty · left: ≥1 completed analysis ever · right: unique samples per county (sqrt color scale) · all time: 26 Jan 2022 – 09 Oct 2026 · last 12 months: 12 Oct 2025 – 09 Oct 2026* · coverage reflects participation, not prevalence</a:t>
             </a:r>
           </a:p>
         </p:txBody>
@@ -4323,7 +4323,7 @@
                 <a:ea typeface="Helvetica Neue"/>
                 <a:sym typeface="Helvetica Neue"/>
               </a:rPr>
-              <a:t>Samples with methamphetamine or cocaine detected (any abundance); samples in both classes appear on both slides · sensations semicolon lists parsed + sen_strength (own denominator) · consumed = 1 only · before: 26 Jan 2022 – 09 Oct 2025 · past 12 months: 11 Oct 2025 – 09 Oct 2026* · Δ in percentage points</a:t>
+              <a:t>Samples with methamphetamine or cocaine detected (any abundance); samples in both classes appear on both slides · sensations semicolon lists parsed + sen_strength (own denominator) · consumed = 1 only · before: 26 Jan 2022 – 09 Oct 2025 · past 12 months: 12 Oct 2025 – 09 Oct 2026* · Δ in percentage points</a:t>
             </a:r>
           </a:p>
         </p:txBody>
@@ -4742,7 +4742,7 @@
                 <a:ea typeface="Helvetica Neue"/>
                 <a:sym typeface="Helvetica Neue"/>
               </a:rPr>
-              <a:t>Samples with an opioid (fentanyl, heroin) or benzodiazepine detected (any abundance); samples in both classes appear on both slides · sensations semicolon lists parsed + sen_strength (own denominator) · consumed = 1 only · before: 26 Jan 2022 – 09 Oct 2025 · past 12 months: 11 Oct 2025 – 09 Oct 2026* · Δ in percentage points</a:t>
+              <a:t>Samples with an opioid (fentanyl, heroin) or benzodiazepine detected (any abundance); samples in both classes appear on both slides · sensations semicolon lists parsed + sen_strength (own denominator) · consumed = 1 only · before: 26 Jan 2022 – 09 Oct 2025 · past 12 months: 12 Oct 2025 – 09 Oct 2026* · Δ in percentage points</a:t>
             </a:r>
           </a:p>
         </p:txBody>
@@ -5855,7 +5855,7 @@
                 <a:ea typeface="Helvetica Neue"/>
                 <a:sym typeface="Helvetica Neue"/>
               </a:rPr>
-              <a:t>lab_detail.substance counts · solid = primary abundance, light = trace · standardized names (PubChem-linked) · window: date_complete 11 Oct 2025 – 09 Oct 2026* (trailing 12 months, current month partial)</a:t>
+              <a:t>lab_detail.substance counts · solid = primary abundance, light = trace · standardized names (PubChem-linked) · window: date_complete 12 Oct 2025 – 09 Oct 2026* (trailing 12 months, current month partial)</a:t>
             </a:r>
           </a:p>
         </p:txBody>
@@ -6053,7 +6053,7 @@
                 <a:ea typeface="Helvetica Neue"/>
                 <a:sym typeface="Helvetica Neue"/>
               </a:rPr>
-              <a:t>Distribution of substances detected per sample, both definitions shown side by side · window: date_complete 11 Oct 2025 – 09 Oct 2026* (trailing 12 months, current month partial)</a:t>
+              <a:t>Distribution of substances detected per sample, both definitions shown side by side · window: date_complete 12 Oct 2025 – 09 Oct 2026* (trailing 12 months, current month partial)</a:t>
             </a:r>
           </a:p>
         </p:txBody>

</xml_diff>

<commit_message>
nightly deck: data through 2026-10-13
</commit_message>
<xml_diff>
--- a/docs/nc-drug-checking-latest.pptx
+++ b/docs/nc-drug-checking-latest.pptx
@@ -2418,7 +2418,7 @@
                 <a:ea typeface="Helvetica Neue"/>
                 <a:sym typeface="Helvetica Neue"/>
               </a:rPr>
-              <a:t>Generated Monday, October 12, 2026 · 12:53 PM ET UNC Street Drug Analysis Lab · OpioidData.org · results.streetsafe.supply Download as PowerPoint</a:t>
+              <a:t>Generated Tuesday, October 13, 2026 · 11:11 AM ET UNC Street Drug Analysis Lab · OpioidData.org · results.streetsafe.supply Download as PowerPoint</a:t>
             </a:r>
           </a:p>
         </p:txBody>
@@ -3184,7 +3184,7 @@
                 <a:ea typeface="Helvetica Neue"/>
                 <a:sym typeface="Helvetica Neue"/>
               </a:rPr>
-              <a:t>County = samplecounty · left: ≥1 completed analysis ever · right: unique samples per county (sqrt color scale) · all time: 26 Jan 2022 – 09 Oct 2026 · last 12 months: 12 Oct 2025 – 09 Oct 2026* · coverage reflects participation, not prevalence</a:t>
+              <a:t>County = samplecounty · left: ≥1 completed analysis ever · right: unique samples per county (sqrt color scale) · all time: 26 Jan 2022 – 09 Oct 2026 · last 12 months: 13 Oct 2025 – 09 Oct 2026* · coverage reflects participation, not prevalence</a:t>
             </a:r>
           </a:p>
         </p:txBody>
@@ -4323,7 +4323,7 @@
                 <a:ea typeface="Helvetica Neue"/>
                 <a:sym typeface="Helvetica Neue"/>
               </a:rPr>
-              <a:t>Samples with methamphetamine or cocaine detected (any abundance); samples in both classes appear on both slides · sensations semicolon lists parsed + sen_strength (own denominator) · consumed = 1 only · before: 26 Jan 2022 – 09 Oct 2025 · past 12 months: 12 Oct 2025 – 09 Oct 2026* · Δ in percentage points</a:t>
+              <a:t>Samples with methamphetamine or cocaine detected (any abundance); samples in both classes appear on both slides · sensations semicolon lists parsed + sen_strength (own denominator) · consumed = 1 only · before: 26 Jan 2022 – 09 Oct 2025 · past 12 months: 13 Oct 2025 – 09 Oct 2026* · Δ in percentage points</a:t>
             </a:r>
           </a:p>
         </p:txBody>
@@ -4742,7 +4742,7 @@
                 <a:ea typeface="Helvetica Neue"/>
                 <a:sym typeface="Helvetica Neue"/>
               </a:rPr>
-              <a:t>Samples with an opioid (fentanyl, heroin) or benzodiazepine detected (any abundance); samples in both classes appear on both slides · sensations semicolon lists parsed + sen_strength (own denominator) · consumed = 1 only · before: 26 Jan 2022 – 09 Oct 2025 · past 12 months: 12 Oct 2025 – 09 Oct 2026* · Δ in percentage points</a:t>
+              <a:t>Samples with an opioid (fentanyl, heroin) or benzodiazepine detected (any abundance); samples in both classes appear on both slides · sensations semicolon lists parsed + sen_strength (own denominator) · consumed = 1 only · before: 26 Jan 2022 – 09 Oct 2025 · past 12 months: 13 Oct 2025 – 09 Oct 2026* · Δ in percentage points</a:t>
             </a:r>
           </a:p>
         </p:txBody>
@@ -5855,7 +5855,7 @@
                 <a:ea typeface="Helvetica Neue"/>
                 <a:sym typeface="Helvetica Neue"/>
               </a:rPr>
-              <a:t>lab_detail.substance counts · solid = primary abundance, light = trace · standardized names (PubChem-linked) · window: date_complete 12 Oct 2025 – 09 Oct 2026* (trailing 12 months, current month partial)</a:t>
+              <a:t>lab_detail.substance counts · solid = primary abundance, light = trace · standardized names (PubChem-linked) · window: date_complete 13 Oct 2025 – 09 Oct 2026* (trailing 12 months, current month partial)</a:t>
             </a:r>
           </a:p>
         </p:txBody>
@@ -6053,7 +6053,7 @@
                 <a:ea typeface="Helvetica Neue"/>
                 <a:sym typeface="Helvetica Neue"/>
               </a:rPr>
-              <a:t>Distribution of substances detected per sample, both definitions shown side by side · window: date_complete 12 Oct 2025 – 09 Oct 2026* (trailing 12 months, current month partial)</a:t>
+              <a:t>Distribution of substances detected per sample, both definitions shown side by side · window: date_complete 13 Oct 2025 – 09 Oct 2026* (trailing 12 months, current month partial)</a:t>
             </a:r>
           </a:p>
         </p:txBody>

</xml_diff>

<commit_message>
nightly deck: data through 2026-10-14
</commit_message>
<xml_diff>
--- a/docs/nc-drug-checking-latest.pptx
+++ b/docs/nc-drug-checking-latest.pptx
@@ -2418,7 +2418,7 @@
                 <a:ea typeface="Helvetica Neue"/>
                 <a:sym typeface="Helvetica Neue"/>
               </a:rPr>
-              <a:t>Generated Tuesday, October 13, 2026 · 11:11 AM ET UNC Street Drug Analysis Lab · OpioidData.org · results.streetsafe.supply Download as PowerPoint</a:t>
+              <a:t>Generated Wednesday, October 14, 2026 · 8:58 AM ET UNC Street Drug Analysis Lab · OpioidData.org · results.streetsafe.supply Download as PowerPoint</a:t>
             </a:r>
           </a:p>
         </p:txBody>
@@ -2713,7 +2713,7 @@
                 <a:ea typeface="Helvetica Neue"/>
                 <a:sym typeface="Helvetica Neue"/>
               </a:rPr>
-              <a:t>PLACEHOLDER · figs/stats.json January 2022 to Friday, October 09, 2026 N = 2,959 NC samples analyzed Mailed in from 86 harm reduction programs Collected across 59 counties 249 distinct substances detected to date Unique samples = n_distinct(sampleid) · substances from lab_detail.substance · includes samples with date_complete 26 Jan 2022 – 09 Oct 2026 r/build_nightly.R → figs/stats.json</a:t>
+              <a:t>PLACEHOLDER · figs/stats.json January 2022 to Tuesday, October 13, 2026 N = 2,982 NC samples analyzed Mailed in from 86 harm reduction programs Collected across 59 counties 249 distinct substances detected to date Unique samples = n_distinct(sampleid) · substances from lab_detail.substance · includes samples with date_complete 26 Jan 2022 – 13 Oct 2026 r/build_nightly.R → figs/stats.json</a:t>
             </a:r>
           </a:p>
         </p:txBody>
@@ -2762,7 +2762,7 @@
                 <a:ea typeface="Helvetica Neue"/>
                 <a:sym typeface="Helvetica Neue"/>
               </a:rPr>
-              <a:t>Unique samples = n_distinct(sampleid) · substances from lab_detail.substance · includes samples with date_complete 26 Jan 2022 – 09 Oct 2026</a:t>
+              <a:t>Unique samples = n_distinct(sampleid) · substances from lab_detail.substance · includes samples with date_complete 26 Jan 2022 – 13 Oct 2026</a:t>
             </a:r>
           </a:p>
         </p:txBody>
@@ -3184,7 +3184,7 @@
                 <a:ea typeface="Helvetica Neue"/>
                 <a:sym typeface="Helvetica Neue"/>
               </a:rPr>
-              <a:t>County = samplecounty · left: ≥1 completed analysis ever · right: unique samples per county (sqrt color scale) · all time: 26 Jan 2022 – 09 Oct 2026 · last 12 months: 13 Oct 2025 – 09 Oct 2026* · coverage reflects participation, not prevalence</a:t>
+              <a:t>County = samplecounty · left: ≥1 completed analysis ever · right: unique samples per county (sqrt color scale) · all time: 26 Jan 2022 – 13 Oct 2026 · last 12 months: 14 Oct 2025 – 13 Oct 2026* · coverage reflects participation, not prevalence</a:t>
             </a:r>
           </a:p>
         </p:txBody>
@@ -3505,7 +3505,7 @@
                 <a:ea typeface="Helvetica Neue"/>
                 <a:sym typeface="Helvetica Neue"/>
               </a:rPr>
-              <a:t>expectedsubstance (verbatim card write-in, semicolon lists split) · derived flags: expect_opioid, expect_fentanyl, expect_meth, expect_cocaine, expect_stimulant… · includes samples with date_complete 26 Jan 2022 – 09 Oct 2026 · data table: Appendix A2</a:t>
+              <a:t>expectedsubstance (verbatim card write-in, semicolon lists split) · derived flags: expect_opioid, expect_fentanyl, expect_meth, expect_cocaine, expect_stimulant… · includes samples with date_complete 26 Jan 2022 – 13 Oct 2026 · data table: Appendix A2</a:t>
             </a:r>
           </a:p>
         </p:txBody>
@@ -3703,7 +3703,7 @@
                 <a:ea typeface="Helvetica Neue"/>
                 <a:sym typeface="Helvetica Neue"/>
               </a:rPr>
-              <a:t>Numerator uses lab_*_any (primary or trace) among samples with expect_* = 1 · includes samples with date_complete 26 Jan 2022 – 09 Oct 2026 · data table: Appendix A3</a:t>
+              <a:t>Numerator uses lab_*_any (primary or trace) among samples with expect_* = 1 · includes samples with date_complete 26 Jan 2022 – 13 Oct 2026 · data table: Appendix A3</a:t>
             </a:r>
           </a:p>
         </p:txBody>
@@ -3901,7 +3901,7 @@
                 <a:ea typeface="Helvetica Neue"/>
                 <a:sym typeface="Helvetica Neue"/>
               </a:rPr>
-              <a:t>sensations (circled on card, semicolon lists split) · post-consumption samples only (consumed = 1) · includes samples with date_complete 26 Jan 2022 – 09 Oct 2026</a:t>
+              <a:t>sensations (circled on card, semicolon lists split) · post-consumption samples only (consumed = 1) · includes samples with date_complete 26 Jan 2022 – 13 Oct 2026</a:t>
             </a:r>
           </a:p>
         </p:txBody>
@@ -4125,7 +4125,7 @@
                 <a:ea typeface="Helvetica Neue"/>
                 <a:sym typeface="Helvetica Neue"/>
               </a:rPr>
-              <a:t>sensations semicolon lists parsed per report · consumed = 1 only · denominator: consumed samples with lab_*_any = 1 · includes samples with date_complete 26 Jan 2022 – 09 Oct 2026</a:t>
+              <a:t>sensations semicolon lists parsed per report · consumed = 1 only · denominator: consumed samples with lab_*_any = 1 · includes samples with date_complete 26 Jan 2022 – 13 Oct 2026</a:t>
             </a:r>
           </a:p>
         </p:txBody>
@@ -4323,7 +4323,7 @@
                 <a:ea typeface="Helvetica Neue"/>
                 <a:sym typeface="Helvetica Neue"/>
               </a:rPr>
-              <a:t>Samples with methamphetamine or cocaine detected (any abundance); samples in both classes appear on both slides · sensations semicolon lists parsed + sen_strength (own denominator) · consumed = 1 only · before: 26 Jan 2022 – 09 Oct 2025 · past 12 months: 13 Oct 2025 – 09 Oct 2026* · Δ in percentage points</a:t>
+              <a:t>Samples with methamphetamine or cocaine detected (any abundance); samples in both classes appear on both slides · sensations semicolon lists parsed + sen_strength (own denominator) · consumed = 1 only · before: 26 Jan 2022 – 13 Oct 2025 · past 12 months: 14 Oct 2025 – 13 Oct 2026* · Δ in percentage points</a:t>
             </a:r>
           </a:p>
         </p:txBody>
@@ -4742,7 +4742,7 @@
                 <a:ea typeface="Helvetica Neue"/>
                 <a:sym typeface="Helvetica Neue"/>
               </a:rPr>
-              <a:t>Samples with an opioid (fentanyl, heroin) or benzodiazepine detected (any abundance); samples in both classes appear on both slides · sensations semicolon lists parsed + sen_strength (own denominator) · consumed = 1 only · before: 26 Jan 2022 – 09 Oct 2025 · past 12 months: 13 Oct 2025 – 09 Oct 2026* · Δ in percentage points</a:t>
+              <a:t>Samples with an opioid (fentanyl, heroin) or benzodiazepine detected (any abundance); samples in both classes appear on both slides · sensations semicolon lists parsed + sen_strength (own denominator) · consumed = 1 only · before: 26 Jan 2022 – 13 Oct 2025 · past 12 months: 14 Oct 2025 – 13 Oct 2026* · Δ in percentage points</a:t>
             </a:r>
           </a:p>
         </p:txBody>
@@ -5138,7 +5138,7 @@
                 <a:ea typeface="Helvetica Neue"/>
                 <a:sym typeface="Helvetica Neue"/>
               </a:rPr>
-              <a:t>color, texture (card v3+, semicolon lists split) · derived: bright_color excludes white/tan/brown family — orange bar above · includes samples with date_complete 26 Jan 2022 – 09 Oct 2026</a:t>
+              <a:t>color, texture (card v3+, semicolon lists split) · derived: bright_color excludes white/tan/brown family — orange bar above · includes samples with date_complete 26 Jan 2022 – 13 Oct 2026</a:t>
             </a:r>
           </a:p>
         </p:txBody>
@@ -5459,7 +5459,7 @@
                 <a:ea typeface="Helvetica Neue"/>
                 <a:sym typeface="Helvetica Neue"/>
               </a:rPr>
-              <a:t>Distribution of substances detected per sample, both definitions shown side by side · includes samples with date_complete 26 Jan 2022 – 09 Oct 2026</a:t>
+              <a:t>Distribution of substances detected per sample, both definitions shown side by side · includes samples with date_complete 26 Jan 2022 – 13 Oct 2026</a:t>
             </a:r>
           </a:p>
         </p:txBody>
@@ -5657,7 +5657,7 @@
                 <a:ea typeface="Helvetica Neue"/>
                 <a:sym typeface="Helvetica Neue"/>
               </a:rPr>
-              <a:t>lab_detail.substance counts · solid = primary abundance, light = trace · standardized names (PubChem-linked) · includes samples with date_complete 26 Jan 2022 – 09 Oct 2026</a:t>
+              <a:t>lab_detail.substance counts · solid = primary abundance, light = trace · standardized names (PubChem-linked) · includes samples with date_complete 26 Jan 2022 – 13 Oct 2026</a:t>
             </a:r>
           </a:p>
         </p:txBody>
@@ -5855,7 +5855,7 @@
                 <a:ea typeface="Helvetica Neue"/>
                 <a:sym typeface="Helvetica Neue"/>
               </a:rPr>
-              <a:t>lab_detail.substance counts · solid = primary abundance, light = trace · standardized names (PubChem-linked) · window: date_complete 13 Oct 2025 – 09 Oct 2026* (trailing 12 months, current month partial)</a:t>
+              <a:t>lab_detail.substance counts · solid = primary abundance, light = trace · standardized names (PubChem-linked) · window: date_complete 14 Oct 2025 – 13 Oct 2026* (trailing 12 months, current month partial)</a:t>
             </a:r>
           </a:p>
         </p:txBody>
@@ -6053,7 +6053,7 @@
                 <a:ea typeface="Helvetica Neue"/>
                 <a:sym typeface="Helvetica Neue"/>
               </a:rPr>
-              <a:t>Distribution of substances detected per sample, both definitions shown side by side · window: date_complete 13 Oct 2025 – 09 Oct 2026* (trailing 12 months, current month partial)</a:t>
+              <a:t>Distribution of substances detected per sample, both definitions shown side by side · window: date_complete 14 Oct 2025 – 13 Oct 2026* (trailing 12 months, current month partial)</a:t>
             </a:r>
           </a:p>
         </p:txBody>
@@ -18510,7 +18510,7 @@
                           <a:ea typeface="Helvetica Neue"/>
                           <a:sym typeface="Helvetica Neue"/>
                         </a:rPr>
-                        <a:t>1,519</a:t>
+                        <a:t>1,539</a:t>
                       </a:r>
                     </a:p>
                   </a:txBody>
@@ -19322,7 +19322,7 @@
                           <a:ea typeface="Helvetica Neue"/>
                           <a:sym typeface="Helvetica Neue"/>
                         </a:rPr>
-                        <a:t>66</a:t>
+                        <a:t>68</a:t>
                       </a:r>
                     </a:p>
                   </a:txBody>
@@ -19438,7 +19438,7 @@
                           <a:ea typeface="Helvetica Neue"/>
                           <a:sym typeface="Helvetica Neue"/>
                         </a:rPr>
-                        <a:t>63</a:t>
+                        <a:t>64</a:t>
                       </a:r>
                     </a:p>
                   </a:txBody>
@@ -20591,7 +20591,7 @@
                           <a:ea typeface="Helvetica Neue"/>
                           <a:sym typeface="Helvetica Neue"/>
                         </a:rPr>
-                        <a:t>1,763</a:t>
+                        <a:t>1,786</a:t>
                       </a:r>
                     </a:p>
                   </a:txBody>
@@ -20821,7 +20821,7 @@
                           <a:ea typeface="Helvetica Neue"/>
                           <a:sym typeface="Helvetica Neue"/>
                         </a:rPr>
-                        <a:t>532</a:t>
+                        <a:t>533</a:t>
                       </a:r>
                     </a:p>
                   </a:txBody>
@@ -21515,7 +21515,7 @@
                           <a:ea typeface="Helvetica Neue"/>
                           <a:sym typeface="Helvetica Neue"/>
                         </a:rPr>
-                        <a:t>369</a:t>
+                        <a:t>371</a:t>
                       </a:r>
                     </a:p>
                   </a:txBody>
@@ -21576,7 +21576,7 @@
                           <a:ea typeface="Helvetica Neue"/>
                           <a:sym typeface="Helvetica Neue"/>
                         </a:rPr>
-                        <a:t>51%</a:t>
+                        <a:t>50%</a:t>
                       </a:r>
                     </a:p>
                   </a:txBody>

</xml_diff>

<commit_message>
nightly deck: data through 2026-10-15
</commit_message>
<xml_diff>
--- a/docs/nc-drug-checking-latest.pptx
+++ b/docs/nc-drug-checking-latest.pptx
@@ -2418,7 +2418,7 @@
                 <a:ea typeface="Helvetica Neue"/>
                 <a:sym typeface="Helvetica Neue"/>
               </a:rPr>
-              <a:t>Generated Wednesday, October 14, 2026 · 8:58 AM ET UNC Street Drug Analysis Lab · OpioidData.org · results.streetsafe.supply Download as PowerPoint</a:t>
+              <a:t>Generated Thursday, October 15, 2026 · 8:46 AM ET UNC Street Drug Analysis Lab · OpioidData.org · results.streetsafe.supply Download as PowerPoint</a:t>
             </a:r>
           </a:p>
         </p:txBody>
@@ -2713,7 +2713,7 @@
                 <a:ea typeface="Helvetica Neue"/>
                 <a:sym typeface="Helvetica Neue"/>
               </a:rPr>
-              <a:t>PLACEHOLDER · figs/stats.json January 2022 to Tuesday, October 13, 2026 N = 2,982 NC samples analyzed Mailed in from 86 harm reduction programs Collected across 59 counties 249 distinct substances detected to date Unique samples = n_distinct(sampleid) · substances from lab_detail.substance · includes samples with date_complete 26 Jan 2022 – 13 Oct 2026 r/build_nightly.R → figs/stats.json</a:t>
+              <a:t>PLACEHOLDER · figs/stats.json January 2022 to Wednesday, October 14, 2026 N = 2,983 NC samples analyzed Mailed in from 86 harm reduction programs Collected across 59 counties 250 distinct substances detected to date Unique samples = n_distinct(sampleid) · substances from lab_detail.substance · includes samples with date_complete 26 Jan 2022 – 14 Oct 2026 r/build_nightly.R → figs/stats.json</a:t>
             </a:r>
           </a:p>
         </p:txBody>
@@ -2762,7 +2762,7 @@
                 <a:ea typeface="Helvetica Neue"/>
                 <a:sym typeface="Helvetica Neue"/>
               </a:rPr>
-              <a:t>Unique samples = n_distinct(sampleid) · substances from lab_detail.substance · includes samples with date_complete 26 Jan 2022 – 13 Oct 2026</a:t>
+              <a:t>Unique samples = n_distinct(sampleid) · substances from lab_detail.substance · includes samples with date_complete 26 Jan 2022 – 14 Oct 2026</a:t>
             </a:r>
           </a:p>
         </p:txBody>
@@ -3184,7 +3184,7 @@
                 <a:ea typeface="Helvetica Neue"/>
                 <a:sym typeface="Helvetica Neue"/>
               </a:rPr>
-              <a:t>County = samplecounty · left: ≥1 completed analysis ever · right: unique samples per county (sqrt color scale) · all time: 26 Jan 2022 – 13 Oct 2026 · last 12 months: 14 Oct 2025 – 13 Oct 2026* · coverage reflects participation, not prevalence</a:t>
+              <a:t>County = samplecounty · left: ≥1 completed analysis ever · right: unique samples per county (sqrt color scale) · all time: 26 Jan 2022 – 14 Oct 2026 · last 12 months: 15 Oct 2025 – 14 Oct 2026* · coverage reflects participation, not prevalence</a:t>
             </a:r>
           </a:p>
         </p:txBody>
@@ -3505,7 +3505,7 @@
                 <a:ea typeface="Helvetica Neue"/>
                 <a:sym typeface="Helvetica Neue"/>
               </a:rPr>
-              <a:t>expectedsubstance (verbatim card write-in, semicolon lists split) · derived flags: expect_opioid, expect_fentanyl, expect_meth, expect_cocaine, expect_stimulant… · includes samples with date_complete 26 Jan 2022 – 13 Oct 2026 · data table: Appendix A2</a:t>
+              <a:t>expectedsubstance (verbatim card write-in, semicolon lists split) · derived flags: expect_opioid, expect_fentanyl, expect_meth, expect_cocaine, expect_stimulant… · includes samples with date_complete 26 Jan 2022 – 14 Oct 2026 · data table: Appendix A2</a:t>
             </a:r>
           </a:p>
         </p:txBody>
@@ -3703,7 +3703,7 @@
                 <a:ea typeface="Helvetica Neue"/>
                 <a:sym typeface="Helvetica Neue"/>
               </a:rPr>
-              <a:t>Numerator uses lab_*_any (primary or trace) among samples with expect_* = 1 · includes samples with date_complete 26 Jan 2022 – 13 Oct 2026 · data table: Appendix A3</a:t>
+              <a:t>Numerator uses lab_*_any (primary or trace) among samples with expect_* = 1 · includes samples with date_complete 26 Jan 2022 – 14 Oct 2026 · data table: Appendix A3</a:t>
             </a:r>
           </a:p>
         </p:txBody>
@@ -3901,7 +3901,7 @@
                 <a:ea typeface="Helvetica Neue"/>
                 <a:sym typeface="Helvetica Neue"/>
               </a:rPr>
-              <a:t>sensations (circled on card, semicolon lists split) · post-consumption samples only (consumed = 1) · includes samples with date_complete 26 Jan 2022 – 13 Oct 2026</a:t>
+              <a:t>sensations (circled on card, semicolon lists split) · post-consumption samples only (consumed = 1) · includes samples with date_complete 26 Jan 2022 – 14 Oct 2026</a:t>
             </a:r>
           </a:p>
         </p:txBody>
@@ -4125,7 +4125,7 @@
                 <a:ea typeface="Helvetica Neue"/>
                 <a:sym typeface="Helvetica Neue"/>
               </a:rPr>
-              <a:t>sensations semicolon lists parsed per report · consumed = 1 only · denominator: consumed samples with lab_*_any = 1 · includes samples with date_complete 26 Jan 2022 – 13 Oct 2026</a:t>
+              <a:t>sensations semicolon lists parsed per report · consumed = 1 only · denominator: consumed samples with lab_*_any = 1 · includes samples with date_complete 26 Jan 2022 – 14 Oct 2026</a:t>
             </a:r>
           </a:p>
         </p:txBody>
@@ -4323,7 +4323,7 @@
                 <a:ea typeface="Helvetica Neue"/>
                 <a:sym typeface="Helvetica Neue"/>
               </a:rPr>
-              <a:t>Samples with methamphetamine or cocaine detected (any abundance); samples in both classes appear on both slides · sensations semicolon lists parsed + sen_strength (own denominator) · consumed = 1 only · before: 26 Jan 2022 – 13 Oct 2025 · past 12 months: 14 Oct 2025 – 13 Oct 2026* · Δ in percentage points</a:t>
+              <a:t>Samples with methamphetamine or cocaine detected (any abundance); samples in both classes appear on both slides · sensations semicolon lists parsed + sen_strength (own denominator) · consumed = 1 only · before: 26 Jan 2022 – 14 Oct 2025 · past 12 months: 15 Oct 2025 – 14 Oct 2026* · Δ in percentage points</a:t>
             </a:r>
           </a:p>
         </p:txBody>
@@ -4742,7 +4742,7 @@
                 <a:ea typeface="Helvetica Neue"/>
                 <a:sym typeface="Helvetica Neue"/>
               </a:rPr>
-              <a:t>Samples with an opioid (fentanyl, heroin) or benzodiazepine detected (any abundance); samples in both classes appear on both slides · sensations semicolon lists parsed + sen_strength (own denominator) · consumed = 1 only · before: 26 Jan 2022 – 13 Oct 2025 · past 12 months: 14 Oct 2025 – 13 Oct 2026* · Δ in percentage points</a:t>
+              <a:t>Samples with an opioid (fentanyl, heroin) or benzodiazepine detected (any abundance); samples in both classes appear on both slides · sensations semicolon lists parsed + sen_strength (own denominator) · consumed = 1 only · before: 26 Jan 2022 – 14 Oct 2025 · past 12 months: 15 Oct 2025 – 14 Oct 2026* · Δ in percentage points</a:t>
             </a:r>
           </a:p>
         </p:txBody>
@@ -5138,7 +5138,7 @@
                 <a:ea typeface="Helvetica Neue"/>
                 <a:sym typeface="Helvetica Neue"/>
               </a:rPr>
-              <a:t>color, texture (card v3+, semicolon lists split) · derived: bright_color excludes white/tan/brown family — orange bar above · includes samples with date_complete 26 Jan 2022 – 13 Oct 2026</a:t>
+              <a:t>color, texture (card v3+, semicolon lists split) · derived: bright_color excludes white/tan/brown family — orange bar above · includes samples with date_complete 26 Jan 2022 – 14 Oct 2026</a:t>
             </a:r>
           </a:p>
         </p:txBody>
@@ -5459,7 +5459,7 @@
                 <a:ea typeface="Helvetica Neue"/>
                 <a:sym typeface="Helvetica Neue"/>
               </a:rPr>
-              <a:t>Distribution of substances detected per sample, both definitions shown side by side · includes samples with date_complete 26 Jan 2022 – 13 Oct 2026</a:t>
+              <a:t>Distribution of substances detected per sample, both definitions shown side by side · includes samples with date_complete 26 Jan 2022 – 14 Oct 2026</a:t>
             </a:r>
           </a:p>
         </p:txBody>
@@ -5657,7 +5657,7 @@
                 <a:ea typeface="Helvetica Neue"/>
                 <a:sym typeface="Helvetica Neue"/>
               </a:rPr>
-              <a:t>lab_detail.substance counts · solid = primary abundance, light = trace · standardized names (PubChem-linked) · includes samples with date_complete 26 Jan 2022 – 13 Oct 2026</a:t>
+              <a:t>lab_detail.substance counts · solid = primary abundance, light = trace · standardized names (PubChem-linked) · includes samples with date_complete 26 Jan 2022 – 14 Oct 2026</a:t>
             </a:r>
           </a:p>
         </p:txBody>
@@ -5855,7 +5855,7 @@
                 <a:ea typeface="Helvetica Neue"/>
                 <a:sym typeface="Helvetica Neue"/>
               </a:rPr>
-              <a:t>lab_detail.substance counts · solid = primary abundance, light = trace · standardized names (PubChem-linked) · window: date_complete 14 Oct 2025 – 13 Oct 2026* (trailing 12 months, current month partial)</a:t>
+              <a:t>lab_detail.substance counts · solid = primary abundance, light = trace · standardized names (PubChem-linked) · window: date_complete 15 Oct 2025 – 14 Oct 2026* (trailing 12 months, current month partial)</a:t>
             </a:r>
           </a:p>
         </p:txBody>
@@ -6053,7 +6053,7 @@
                 <a:ea typeface="Helvetica Neue"/>
                 <a:sym typeface="Helvetica Neue"/>
               </a:rPr>
-              <a:t>Distribution of substances detected per sample, both definitions shown side by side · window: date_complete 14 Oct 2025 – 13 Oct 2026* (trailing 12 months, current month partial)</a:t>
+              <a:t>Distribution of substances detected per sample, both definitions shown side by side · window: date_complete 15 Oct 2025 – 14 Oct 2026* (trailing 12 months, current month partial)</a:t>
             </a:r>
           </a:p>
         </p:txBody>
@@ -11049,6 +11049,293 @@
                           <a:ea typeface="Helvetica Neue"/>
                           <a:sym typeface="Helvetica Neue"/>
                         </a:rPr>
+                        <a:t>buspirone</a:t>
+                      </a:r>
+                    </a:p>
+                  </a:txBody>
+                  <a:tcPr anchor="ctr" marB="63500" marT="63500" marR="0" marL="0">
+                    <a:lnL algn="ctr" cmpd="sng" cap="flat" w="0">
+                      <a:noFill/>
+                      <a:prstDash val="solid"/>
+                    </a:lnL>
+                    <a:lnR algn="ctr" cmpd="sng" cap="flat" w="0">
+                      <a:noFill/>
+                      <a:prstDash val="solid"/>
+                    </a:lnR>
+                    <a:lnT algn="ctr" cmpd="sng" cap="flat" w="0">
+                      <a:noFill/>
+                      <a:prstDash val="solid"/>
+                    </a:lnT>
+                    <a:lnB algn="ctr" cmpd="sng" cap="flat" w="0">
+                      <a:noFill/>
+                      <a:prstDash val="solid"/>
+                    </a:lnB>
+                    <a:solidFill>
+                      <a:srgbClr val="FFFFFF">
+                        <a:alpha val="0"/>
+                      </a:srgbClr>
+                    </a:solidFill>
+                  </a:tcPr>
+                </a:tc>
+                <a:tc>
+                  <a:txBody>
+                    <a:bodyPr/>
+                    <a:lstStyle/>
+                    <a:p>
+                      <a:pPr algn="l" marL="63500" marR="63500">
+                        <a:lnSpc>
+                          <a:spcPct val="100000"/>
+                        </a:lnSpc>
+                        <a:spcBef>
+                          <a:spcPts val="500"/>
+                        </a:spcBef>
+                        <a:spcAft>
+                          <a:spcPts val="500"/>
+                        </a:spcAft>
+                        <a:buNone/>
+                      </a:pPr>
+                      <a:r>
+                        <a:rPr cap="none" sz="1200" i="0" b="0" u="none" strike="noStrike">
+                          <a:solidFill>
+                            <a:srgbClr val="5B6770">
+                              <a:alpha val="100000"/>
+                            </a:srgbClr>
+                          </a:solidFill>
+                          <a:latin typeface="Helvetica Neue"/>
+                          <a:cs typeface="Helvetica Neue"/>
+                          <a:ea typeface="Helvetica Neue"/>
+                          <a:sym typeface="Helvetica Neue"/>
+                        </a:rPr>
+                        <a:t>14 Oct 2026</a:t>
+                      </a:r>
+                    </a:p>
+                  </a:txBody>
+                  <a:tcPr anchor="ctr" marB="63500" marT="63500" marR="0" marL="0">
+                    <a:lnL algn="ctr" cmpd="sng" cap="flat" w="0">
+                      <a:noFill/>
+                      <a:prstDash val="solid"/>
+                    </a:lnL>
+                    <a:lnR algn="ctr" cmpd="sng" cap="flat" w="0">
+                      <a:noFill/>
+                      <a:prstDash val="solid"/>
+                    </a:lnR>
+                    <a:lnT algn="ctr" cmpd="sng" cap="flat" w="0">
+                      <a:noFill/>
+                      <a:prstDash val="solid"/>
+                    </a:lnT>
+                    <a:lnB algn="ctr" cmpd="sng" cap="flat" w="0">
+                      <a:noFill/>
+                      <a:prstDash val="solid"/>
+                    </a:lnB>
+                    <a:solidFill>
+                      <a:srgbClr val="FFFFFF">
+                        <a:alpha val="0"/>
+                      </a:srgbClr>
+                    </a:solidFill>
+                  </a:tcPr>
+                </a:tc>
+                <a:tc>
+                  <a:txBody>
+                    <a:bodyPr/>
+                    <a:lstStyle/>
+                    <a:p>
+                      <a:pPr algn="l" marL="63500" marR="63500">
+                        <a:lnSpc>
+                          <a:spcPct val="100000"/>
+                        </a:lnSpc>
+                        <a:spcBef>
+                          <a:spcPts val="500"/>
+                        </a:spcBef>
+                        <a:spcAft>
+                          <a:spcPts val="500"/>
+                        </a:spcAft>
+                        <a:buNone/>
+                      </a:pPr>
+                      <a:r>
+                        <a:rPr cap="none" sz="1200" i="0" b="0" u="none" strike="noStrike">
+                          <a:solidFill>
+                            <a:srgbClr val="5B6770">
+                              <a:alpha val="100000"/>
+                            </a:srgbClr>
+                          </a:solidFill>
+                          <a:latin typeface="Helvetica Neue"/>
+                          <a:cs typeface="Helvetica Neue"/>
+                          <a:ea typeface="Helvetica Neue"/>
+                          <a:sym typeface="Helvetica Neue"/>
+                        </a:rPr>
+                        <a:t>primary</a:t>
+                      </a:r>
+                    </a:p>
+                  </a:txBody>
+                  <a:tcPr anchor="ctr" marB="63500" marT="63500" marR="0" marL="0">
+                    <a:lnL algn="ctr" cmpd="sng" cap="flat" w="0">
+                      <a:noFill/>
+                      <a:prstDash val="solid"/>
+                    </a:lnL>
+                    <a:lnR algn="ctr" cmpd="sng" cap="flat" w="0">
+                      <a:noFill/>
+                      <a:prstDash val="solid"/>
+                    </a:lnR>
+                    <a:lnT algn="ctr" cmpd="sng" cap="flat" w="0">
+                      <a:noFill/>
+                      <a:prstDash val="solid"/>
+                    </a:lnT>
+                    <a:lnB algn="ctr" cmpd="sng" cap="flat" w="0">
+                      <a:noFill/>
+                      <a:prstDash val="solid"/>
+                    </a:lnB>
+                    <a:solidFill>
+                      <a:srgbClr val="FFFFFF">
+                        <a:alpha val="0"/>
+                      </a:srgbClr>
+                    </a:solidFill>
+                  </a:tcPr>
+                </a:tc>
+                <a:tc>
+                  <a:txBody>
+                    <a:bodyPr/>
+                    <a:lstStyle/>
+                    <a:p>
+                      <a:pPr algn="r" marL="63500" marR="63500">
+                        <a:lnSpc>
+                          <a:spcPct val="100000"/>
+                        </a:lnSpc>
+                        <a:spcBef>
+                          <a:spcPts val="500"/>
+                        </a:spcBef>
+                        <a:spcAft>
+                          <a:spcPts val="500"/>
+                        </a:spcAft>
+                        <a:buNone/>
+                      </a:pPr>
+                      <a:r>
+                        <a:rPr cap="none" sz="1200" i="0" b="0" u="none" strike="noStrike">
+                          <a:solidFill>
+                            <a:srgbClr val="5B6770">
+                              <a:alpha val="100000"/>
+                            </a:srgbClr>
+                          </a:solidFill>
+                          <a:latin typeface="Helvetica Neue"/>
+                          <a:cs typeface="Helvetica Neue"/>
+                          <a:ea typeface="Helvetica Neue"/>
+                          <a:sym typeface="Helvetica Neue"/>
+                        </a:rPr>
+                        <a:t>1</a:t>
+                      </a:r>
+                    </a:p>
+                  </a:txBody>
+                  <a:tcPr anchor="ctr" marB="63500" marT="63500" marR="0" marL="0">
+                    <a:lnL algn="ctr" cmpd="sng" cap="flat" w="0">
+                      <a:noFill/>
+                      <a:prstDash val="solid"/>
+                    </a:lnL>
+                    <a:lnR algn="ctr" cmpd="sng" cap="flat" w="0">
+                      <a:noFill/>
+                      <a:prstDash val="solid"/>
+                    </a:lnR>
+                    <a:lnT algn="ctr" cmpd="sng" cap="flat" w="0">
+                      <a:noFill/>
+                      <a:prstDash val="solid"/>
+                    </a:lnT>
+                    <a:lnB algn="ctr" cmpd="sng" cap="flat" w="0">
+                      <a:noFill/>
+                      <a:prstDash val="solid"/>
+                    </a:lnB>
+                    <a:solidFill>
+                      <a:srgbClr val="FFFFFF">
+                        <a:alpha val="0"/>
+                      </a:srgbClr>
+                    </a:solidFill>
+                  </a:tcPr>
+                </a:tc>
+                <a:tc>
+                  <a:txBody>
+                    <a:bodyPr/>
+                    <a:lstStyle/>
+                    <a:p>
+                      <a:pPr algn="l" marL="63500" marR="63500">
+                        <a:lnSpc>
+                          <a:spcPct val="100000"/>
+                        </a:lnSpc>
+                        <a:spcBef>
+                          <a:spcPts val="500"/>
+                        </a:spcBef>
+                        <a:spcAft>
+                          <a:spcPts val="500"/>
+                        </a:spcAft>
+                        <a:buNone/>
+                      </a:pPr>
+                      <a:r>
+                        <a:rPr cap="none" sz="1200" i="0" b="0" u="none" strike="noStrike">
+                          <a:solidFill>
+                            <a:srgbClr val="5B6770">
+                              <a:alpha val="100000"/>
+                            </a:srgbClr>
+                          </a:solidFill>
+                          <a:latin typeface="Helvetica Neue"/>
+                          <a:cs typeface="Helvetica Neue"/>
+                          <a:ea typeface="Helvetica Neue"/>
+                          <a:sym typeface="Helvetica Neue"/>
+                        </a:rPr>
+                        <a:t>604745</a:t>
+                      </a:r>
+                    </a:p>
+                  </a:txBody>
+                  <a:tcPr anchor="ctr" marB="63500" marT="63500" marR="0" marL="0">
+                    <a:lnL algn="ctr" cmpd="sng" cap="flat" w="0">
+                      <a:noFill/>
+                      <a:prstDash val="solid"/>
+                    </a:lnL>
+                    <a:lnR algn="ctr" cmpd="sng" cap="flat" w="0">
+                      <a:noFill/>
+                      <a:prstDash val="solid"/>
+                    </a:lnR>
+                    <a:lnT algn="ctr" cmpd="sng" cap="flat" w="0">
+                      <a:noFill/>
+                      <a:prstDash val="solid"/>
+                    </a:lnT>
+                    <a:lnB algn="ctr" cmpd="sng" cap="flat" w="0">
+                      <a:noFill/>
+                      <a:prstDash val="solid"/>
+                    </a:lnB>
+                    <a:solidFill>
+                      <a:srgbClr val="FFFFFF">
+                        <a:alpha val="0"/>
+                      </a:srgbClr>
+                    </a:solidFill>
+                  </a:tcPr>
+                </a:tc>
+              </a:tr>
+              <a:tr h="401320">
+                <a:tc>
+                  <a:txBody>
+                    <a:bodyPr/>
+                    <a:lstStyle/>
+                    <a:p>
+                      <a:pPr algn="l" marL="63500" marR="63500">
+                        <a:lnSpc>
+                          <a:spcPct val="100000"/>
+                        </a:lnSpc>
+                        <a:spcBef>
+                          <a:spcPts val="500"/>
+                        </a:spcBef>
+                        <a:spcAft>
+                          <a:spcPts val="500"/>
+                        </a:spcAft>
+                        <a:buNone/>
+                      </a:pPr>
+                      <a:r>
+                        <a:rPr cap="none" sz="1200" i="0" b="0" u="none" strike="noStrike">
+                          <a:solidFill>
+                            <a:srgbClr val="5B6770">
+                              <a:alpha val="100000"/>
+                            </a:srgbClr>
+                          </a:solidFill>
+                          <a:latin typeface="Helvetica Neue"/>
+                          <a:cs typeface="Helvetica Neue"/>
+                          <a:ea typeface="Helvetica Neue"/>
+                          <a:sym typeface="Helvetica Neue"/>
+                        </a:rPr>
                         <a:t>dihydro-7-hydroxy mitragynine (MGM-15)</a:t>
                       </a:r>
                     </a:p>
@@ -11071,8 +11358,8 @@
                       <a:prstDash val="solid"/>
                     </a:lnB>
                     <a:solidFill>
-                      <a:srgbClr val="FFFFFF">
-                        <a:alpha val="0"/>
+                      <a:srgbClr val="F4F8FB">
+                        <a:alpha val="100000"/>
                       </a:srgbClr>
                     </a:solidFill>
                   </a:tcPr>
@@ -11128,8 +11415,8 @@
                       <a:prstDash val="solid"/>
                     </a:lnB>
                     <a:solidFill>
-                      <a:srgbClr val="FFFFFF">
-                        <a:alpha val="0"/>
+                      <a:srgbClr val="F4F8FB">
+                        <a:alpha val="100000"/>
                       </a:srgbClr>
                     </a:solidFill>
                   </a:tcPr>
@@ -11185,8 +11472,8 @@
                       <a:prstDash val="solid"/>
                     </a:lnB>
                     <a:solidFill>
-                      <a:srgbClr val="FFFFFF">
-                        <a:alpha val="0"/>
+                      <a:srgbClr val="F4F8FB">
+                        <a:alpha val="100000"/>
                       </a:srgbClr>
                     </a:solidFill>
                   </a:tcPr>
@@ -11242,8 +11529,8 @@
                       <a:prstDash val="solid"/>
                     </a:lnB>
                     <a:solidFill>
-                      <a:srgbClr val="FFFFFF">
-                        <a:alpha val="0"/>
+                      <a:srgbClr val="F4F8FB">
+                        <a:alpha val="100000"/>
                       </a:srgbClr>
                     </a:solidFill>
                   </a:tcPr>
@@ -11299,8 +11586,8 @@
                       <a:prstDash val="solid"/>
                     </a:lnB>
                     <a:solidFill>
-                      <a:srgbClr val="FFFFFF">
-                        <a:alpha val="0"/>
+                      <a:srgbClr val="F4F8FB">
+                        <a:alpha val="100000"/>
                       </a:srgbClr>
                     </a:solidFill>
                   </a:tcPr>
@@ -11358,8 +11645,8 @@
                       <a:prstDash val="solid"/>
                     </a:lnB>
                     <a:solidFill>
-                      <a:srgbClr val="F4F8FB">
-                        <a:alpha val="100000"/>
+                      <a:srgbClr val="FFFFFF">
+                        <a:alpha val="0"/>
                       </a:srgbClr>
                     </a:solidFill>
                   </a:tcPr>
@@ -11415,8 +11702,8 @@
                       <a:prstDash val="solid"/>
                     </a:lnB>
                     <a:solidFill>
-                      <a:srgbClr val="F4F8FB">
-                        <a:alpha val="100000"/>
+                      <a:srgbClr val="FFFFFF">
+                        <a:alpha val="0"/>
                       </a:srgbClr>
                     </a:solidFill>
                   </a:tcPr>
@@ -11472,8 +11759,8 @@
                       <a:prstDash val="solid"/>
                     </a:lnB>
                     <a:solidFill>
-                      <a:srgbClr val="F4F8FB">
-                        <a:alpha val="100000"/>
+                      <a:srgbClr val="FFFFFF">
+                        <a:alpha val="0"/>
                       </a:srgbClr>
                     </a:solidFill>
                   </a:tcPr>
@@ -11529,8 +11816,8 @@
                       <a:prstDash val="solid"/>
                     </a:lnB>
                     <a:solidFill>
-                      <a:srgbClr val="F4F8FB">
-                        <a:alpha val="100000"/>
+                      <a:srgbClr val="FFFFFF">
+                        <a:alpha val="0"/>
                       </a:srgbClr>
                     </a:solidFill>
                   </a:tcPr>
@@ -11586,8 +11873,8 @@
                       <a:prstDash val="solid"/>
                     </a:lnB>
                     <a:solidFill>
-                      <a:srgbClr val="F4F8FB">
-                        <a:alpha val="100000"/>
+                      <a:srgbClr val="FFFFFF">
+                        <a:alpha val="0"/>
                       </a:srgbClr>
                     </a:solidFill>
                   </a:tcPr>
@@ -11645,8 +11932,8 @@
                       <a:prstDash val="solid"/>
                     </a:lnB>
                     <a:solidFill>
-                      <a:srgbClr val="FFFFFF">
-                        <a:alpha val="0"/>
+                      <a:srgbClr val="F4F8FB">
+                        <a:alpha val="100000"/>
                       </a:srgbClr>
                     </a:solidFill>
                   </a:tcPr>
@@ -11702,8 +11989,8 @@
                       <a:prstDash val="solid"/>
                     </a:lnB>
                     <a:solidFill>
-                      <a:srgbClr val="FFFFFF">
-                        <a:alpha val="0"/>
+                      <a:srgbClr val="F4F8FB">
+                        <a:alpha val="100000"/>
                       </a:srgbClr>
                     </a:solidFill>
                   </a:tcPr>
@@ -11759,8 +12046,8 @@
                       <a:prstDash val="solid"/>
                     </a:lnB>
                     <a:solidFill>
-                      <a:srgbClr val="FFFFFF">
-                        <a:alpha val="0"/>
+                      <a:srgbClr val="F4F8FB">
+                        <a:alpha val="100000"/>
                       </a:srgbClr>
                     </a:solidFill>
                   </a:tcPr>
@@ -11816,8 +12103,8 @@
                       <a:prstDash val="solid"/>
                     </a:lnB>
                     <a:solidFill>
-                      <a:srgbClr val="FFFFFF">
-                        <a:alpha val="0"/>
+                      <a:srgbClr val="F4F8FB">
+                        <a:alpha val="100000"/>
                       </a:srgbClr>
                     </a:solidFill>
                   </a:tcPr>
@@ -11873,8 +12160,8 @@
                       <a:prstDash val="solid"/>
                     </a:lnB>
                     <a:solidFill>
-                      <a:srgbClr val="FFFFFF">
-                        <a:alpha val="0"/>
+                      <a:srgbClr val="F4F8FB">
+                        <a:alpha val="100000"/>
                       </a:srgbClr>
                     </a:solidFill>
                   </a:tcPr>
@@ -11932,8 +12219,8 @@
                       <a:prstDash val="solid"/>
                     </a:lnB>
                     <a:solidFill>
-                      <a:srgbClr val="F4F8FB">
-                        <a:alpha val="100000"/>
+                      <a:srgbClr val="FFFFFF">
+                        <a:alpha val="0"/>
                       </a:srgbClr>
                     </a:solidFill>
                   </a:tcPr>
@@ -11989,8 +12276,8 @@
                       <a:prstDash val="solid"/>
                     </a:lnB>
                     <a:solidFill>
-                      <a:srgbClr val="F4F8FB">
-                        <a:alpha val="100000"/>
+                      <a:srgbClr val="FFFFFF">
+                        <a:alpha val="0"/>
                       </a:srgbClr>
                     </a:solidFill>
                   </a:tcPr>
@@ -12046,8 +12333,8 @@
                       <a:prstDash val="solid"/>
                     </a:lnB>
                     <a:solidFill>
-                      <a:srgbClr val="F4F8FB">
-                        <a:alpha val="100000"/>
+                      <a:srgbClr val="FFFFFF">
+                        <a:alpha val="0"/>
                       </a:srgbClr>
                     </a:solidFill>
                   </a:tcPr>
@@ -12103,8 +12390,8 @@
                       <a:prstDash val="solid"/>
                     </a:lnB>
                     <a:solidFill>
-                      <a:srgbClr val="F4F8FB">
-                        <a:alpha val="100000"/>
+                      <a:srgbClr val="FFFFFF">
+                        <a:alpha val="0"/>
                       </a:srgbClr>
                     </a:solidFill>
                   </a:tcPr>
@@ -12160,8 +12447,8 @@
                       <a:prstDash val="solid"/>
                     </a:lnB>
                     <a:solidFill>
-                      <a:srgbClr val="F4F8FB">
-                        <a:alpha val="100000"/>
+                      <a:srgbClr val="FFFFFF">
+                        <a:alpha val="0"/>
                       </a:srgbClr>
                     </a:solidFill>
                   </a:tcPr>
@@ -12219,8 +12506,8 @@
                       <a:prstDash val="solid"/>
                     </a:lnB>
                     <a:solidFill>
-                      <a:srgbClr val="FFFFFF">
-                        <a:alpha val="0"/>
+                      <a:srgbClr val="F4F8FB">
+                        <a:alpha val="100000"/>
                       </a:srgbClr>
                     </a:solidFill>
                   </a:tcPr>
@@ -12276,8 +12563,8 @@
                       <a:prstDash val="solid"/>
                     </a:lnB>
                     <a:solidFill>
-                      <a:srgbClr val="FFFFFF">
-                        <a:alpha val="0"/>
+                      <a:srgbClr val="F4F8FB">
+                        <a:alpha val="100000"/>
                       </a:srgbClr>
                     </a:solidFill>
                   </a:tcPr>
@@ -12333,8 +12620,8 @@
                       <a:prstDash val="solid"/>
                     </a:lnB>
                     <a:solidFill>
-                      <a:srgbClr val="FFFFFF">
-                        <a:alpha val="0"/>
+                      <a:srgbClr val="F4F8FB">
+                        <a:alpha val="100000"/>
                       </a:srgbClr>
                     </a:solidFill>
                   </a:tcPr>
@@ -12390,8 +12677,8 @@
                       <a:prstDash val="solid"/>
                     </a:lnB>
                     <a:solidFill>
-                      <a:srgbClr val="FFFFFF">
-                        <a:alpha val="0"/>
+                      <a:srgbClr val="F4F8FB">
+                        <a:alpha val="100000"/>
                       </a:srgbClr>
                     </a:solidFill>
                   </a:tcPr>
@@ -12447,8 +12734,8 @@
                       <a:prstDash val="solid"/>
                     </a:lnB>
                     <a:solidFill>
-                      <a:srgbClr val="FFFFFF">
-                        <a:alpha val="0"/>
+                      <a:srgbClr val="F4F8FB">
+                        <a:alpha val="100000"/>
                       </a:srgbClr>
                     </a:solidFill>
                   </a:tcPr>
@@ -12506,8 +12793,8 @@
                       <a:prstDash val="solid"/>
                     </a:lnB>
                     <a:solidFill>
-                      <a:srgbClr val="F4F8FB">
-                        <a:alpha val="100000"/>
+                      <a:srgbClr val="FFFFFF">
+                        <a:alpha val="0"/>
                       </a:srgbClr>
                     </a:solidFill>
                   </a:tcPr>
@@ -12563,8 +12850,8 @@
                       <a:prstDash val="solid"/>
                     </a:lnB>
                     <a:solidFill>
-                      <a:srgbClr val="F4F8FB">
-                        <a:alpha val="100000"/>
+                      <a:srgbClr val="FFFFFF">
+                        <a:alpha val="0"/>
                       </a:srgbClr>
                     </a:solidFill>
                   </a:tcPr>
@@ -12620,8 +12907,8 @@
                       <a:prstDash val="solid"/>
                     </a:lnB>
                     <a:solidFill>
-                      <a:srgbClr val="F4F8FB">
-                        <a:alpha val="100000"/>
+                      <a:srgbClr val="FFFFFF">
+                        <a:alpha val="0"/>
                       </a:srgbClr>
                     </a:solidFill>
                   </a:tcPr>
@@ -12677,8 +12964,8 @@
                       <a:prstDash val="solid"/>
                     </a:lnB>
                     <a:solidFill>
-                      <a:srgbClr val="F4F8FB">
-                        <a:alpha val="100000"/>
+                      <a:srgbClr val="FFFFFF">
+                        <a:alpha val="0"/>
                       </a:srgbClr>
                     </a:solidFill>
                   </a:tcPr>
@@ -12734,8 +13021,8 @@
                       <a:prstDash val="solid"/>
                     </a:lnB>
                     <a:solidFill>
-                      <a:srgbClr val="F4F8FB">
-                        <a:alpha val="100000"/>
+                      <a:srgbClr val="FFFFFF">
+                        <a:alpha val="0"/>
                       </a:srgbClr>
                     </a:solidFill>
                   </a:tcPr>
@@ -12793,8 +13080,8 @@
                       <a:prstDash val="solid"/>
                     </a:lnB>
                     <a:solidFill>
-                      <a:srgbClr val="FFFFFF">
-                        <a:alpha val="0"/>
+                      <a:srgbClr val="F4F8FB">
+                        <a:alpha val="100000"/>
                       </a:srgbClr>
                     </a:solidFill>
                   </a:tcPr>
@@ -12850,8 +13137,8 @@
                       <a:prstDash val="solid"/>
                     </a:lnB>
                     <a:solidFill>
-                      <a:srgbClr val="FFFFFF">
-                        <a:alpha val="0"/>
+                      <a:srgbClr val="F4F8FB">
+                        <a:alpha val="100000"/>
                       </a:srgbClr>
                     </a:solidFill>
                   </a:tcPr>
@@ -12907,8 +13194,8 @@
                       <a:prstDash val="solid"/>
                     </a:lnB>
                     <a:solidFill>
-                      <a:srgbClr val="FFFFFF">
-                        <a:alpha val="0"/>
+                      <a:srgbClr val="F4F8FB">
+                        <a:alpha val="100000"/>
                       </a:srgbClr>
                     </a:solidFill>
                   </a:tcPr>
@@ -12964,8 +13251,8 @@
                       <a:prstDash val="solid"/>
                     </a:lnB>
                     <a:solidFill>
-                      <a:srgbClr val="FFFFFF">
-                        <a:alpha val="0"/>
+                      <a:srgbClr val="F4F8FB">
+                        <a:alpha val="100000"/>
                       </a:srgbClr>
                     </a:solidFill>
                   </a:tcPr>
@@ -13021,8 +13308,8 @@
                       <a:prstDash val="solid"/>
                     </a:lnB>
                     <a:solidFill>
-                      <a:srgbClr val="FFFFFF">
-                        <a:alpha val="0"/>
+                      <a:srgbClr val="F4F8FB">
+                        <a:alpha val="100000"/>
                       </a:srgbClr>
                     </a:solidFill>
                   </a:tcPr>
@@ -13080,8 +13367,8 @@
                       <a:prstDash val="solid"/>
                     </a:lnB>
                     <a:solidFill>
-                      <a:srgbClr val="F4F8FB">
-                        <a:alpha val="100000"/>
+                      <a:srgbClr val="FFFFFF">
+                        <a:alpha val="0"/>
                       </a:srgbClr>
                     </a:solidFill>
                   </a:tcPr>
@@ -13137,8 +13424,8 @@
                       <a:prstDash val="solid"/>
                     </a:lnB>
                     <a:solidFill>
-                      <a:srgbClr val="F4F8FB">
-                        <a:alpha val="100000"/>
+                      <a:srgbClr val="FFFFFF">
+                        <a:alpha val="0"/>
                       </a:srgbClr>
                     </a:solidFill>
                   </a:tcPr>
@@ -13194,8 +13481,8 @@
                       <a:prstDash val="solid"/>
                     </a:lnB>
                     <a:solidFill>
-                      <a:srgbClr val="F4F8FB">
-                        <a:alpha val="100000"/>
+                      <a:srgbClr val="FFFFFF">
+                        <a:alpha val="0"/>
                       </a:srgbClr>
                     </a:solidFill>
                   </a:tcPr>
@@ -13251,8 +13538,8 @@
                       <a:prstDash val="solid"/>
                     </a:lnB>
                     <a:solidFill>
-                      <a:srgbClr val="F4F8FB">
-                        <a:alpha val="100000"/>
+                      <a:srgbClr val="FFFFFF">
+                        <a:alpha val="0"/>
                       </a:srgbClr>
                     </a:solidFill>
                   </a:tcPr>
@@ -13308,8 +13595,8 @@
                       <a:prstDash val="solid"/>
                     </a:lnB>
                     <a:solidFill>
-                      <a:srgbClr val="F4F8FB">
-                        <a:alpha val="100000"/>
+                      <a:srgbClr val="FFFFFF">
+                        <a:alpha val="0"/>
                       </a:srgbClr>
                     </a:solidFill>
                   </a:tcPr>
@@ -13367,8 +13654,8 @@
                       <a:prstDash val="solid"/>
                     </a:lnB>
                     <a:solidFill>
-                      <a:srgbClr val="FFFFFF">
-                        <a:alpha val="0"/>
+                      <a:srgbClr val="F4F8FB">
+                        <a:alpha val="100000"/>
                       </a:srgbClr>
                     </a:solidFill>
                   </a:tcPr>
@@ -13424,8 +13711,8 @@
                       <a:prstDash val="solid"/>
                     </a:lnB>
                     <a:solidFill>
-                      <a:srgbClr val="FFFFFF">
-                        <a:alpha val="0"/>
+                      <a:srgbClr val="F4F8FB">
+                        <a:alpha val="100000"/>
                       </a:srgbClr>
                     </a:solidFill>
                   </a:tcPr>
@@ -13481,8 +13768,8 @@
                       <a:prstDash val="solid"/>
                     </a:lnB>
                     <a:solidFill>
-                      <a:srgbClr val="FFFFFF">
-                        <a:alpha val="0"/>
+                      <a:srgbClr val="F4F8FB">
+                        <a:alpha val="100000"/>
                       </a:srgbClr>
                     </a:solidFill>
                   </a:tcPr>
@@ -13538,8 +13825,8 @@
                       <a:prstDash val="solid"/>
                     </a:lnB>
                     <a:solidFill>
-                      <a:srgbClr val="FFFFFF">
-                        <a:alpha val="0"/>
+                      <a:srgbClr val="F4F8FB">
+                        <a:alpha val="100000"/>
                       </a:srgbClr>
                     </a:solidFill>
                   </a:tcPr>
@@ -13595,8 +13882,8 @@
                       <a:prstDash val="solid"/>
                     </a:lnB>
                     <a:solidFill>
-                      <a:srgbClr val="FFFFFF">
-                        <a:alpha val="0"/>
+                      <a:srgbClr val="F4F8FB">
+                        <a:alpha val="100000"/>
                       </a:srgbClr>
                     </a:solidFill>
                   </a:tcPr>
@@ -13654,8 +13941,8 @@
                       <a:prstDash val="solid"/>
                     </a:lnB>
                     <a:solidFill>
-                      <a:srgbClr val="F4F8FB">
-                        <a:alpha val="100000"/>
+                      <a:srgbClr val="FFFFFF">
+                        <a:alpha val="0"/>
                       </a:srgbClr>
                     </a:solidFill>
                   </a:tcPr>
@@ -13711,8 +13998,8 @@
                       <a:prstDash val="solid"/>
                     </a:lnB>
                     <a:solidFill>
-                      <a:srgbClr val="F4F8FB">
-                        <a:alpha val="100000"/>
+                      <a:srgbClr val="FFFFFF">
+                        <a:alpha val="0"/>
                       </a:srgbClr>
                     </a:solidFill>
                   </a:tcPr>
@@ -13768,8 +14055,8 @@
                       <a:prstDash val="solid"/>
                     </a:lnB>
                     <a:solidFill>
-                      <a:srgbClr val="F4F8FB">
-                        <a:alpha val="100000"/>
+                      <a:srgbClr val="FFFFFF">
+                        <a:alpha val="0"/>
                       </a:srgbClr>
                     </a:solidFill>
                   </a:tcPr>
@@ -13825,8 +14112,8 @@
                       <a:prstDash val="solid"/>
                     </a:lnB>
                     <a:solidFill>
-                      <a:srgbClr val="F4F8FB">
-                        <a:alpha val="100000"/>
+                      <a:srgbClr val="FFFFFF">
+                        <a:alpha val="0"/>
                       </a:srgbClr>
                     </a:solidFill>
                   </a:tcPr>
@@ -13882,14 +14169,14 @@
                       <a:prstDash val="solid"/>
                     </a:lnB>
                     <a:solidFill>
-                      <a:srgbClr val="F4F8FB">
-                        <a:alpha val="100000"/>
+                      <a:srgbClr val="FFFFFF">
+                        <a:alpha val="0"/>
                       </a:srgbClr>
                     </a:solidFill>
                   </a:tcPr>
                 </a:tc>
               </a:tr>
-              <a:tr h="401320">
+              <a:tr h="410845">
                 <a:tc>
                   <a:txBody>
                     <a:bodyPr/>
@@ -13936,13 +14223,17 @@
                       <a:noFill/>
                       <a:prstDash val="solid"/>
                     </a:lnT>
-                    <a:lnB algn="ctr" cmpd="sng" cap="flat" w="0">
-                      <a:noFill/>
+                    <a:lnB algn="ctr" cmpd="sng" cap="flat" w="19050">
+                      <a:solidFill>
+                        <a:srgbClr val="666666">
+                          <a:alpha val="100000"/>
+                        </a:srgbClr>
+                      </a:solidFill>
                       <a:prstDash val="solid"/>
                     </a:lnB>
                     <a:solidFill>
-                      <a:srgbClr val="FFFFFF">
-                        <a:alpha val="0"/>
+                      <a:srgbClr val="F4F8FB">
+                        <a:alpha val="100000"/>
                       </a:srgbClr>
                     </a:solidFill>
                   </a:tcPr>
@@ -13993,13 +14284,17 @@
                       <a:noFill/>
                       <a:prstDash val="solid"/>
                     </a:lnT>
-                    <a:lnB algn="ctr" cmpd="sng" cap="flat" w="0">
-                      <a:noFill/>
+                    <a:lnB algn="ctr" cmpd="sng" cap="flat" w="19050">
+                      <a:solidFill>
+                        <a:srgbClr val="666666">
+                          <a:alpha val="100000"/>
+                        </a:srgbClr>
+                      </a:solidFill>
                       <a:prstDash val="solid"/>
                     </a:lnB>
                     <a:solidFill>
-                      <a:srgbClr val="FFFFFF">
-                        <a:alpha val="0"/>
+                      <a:srgbClr val="F4F8FB">
+                        <a:alpha val="100000"/>
                       </a:srgbClr>
                     </a:solidFill>
                   </a:tcPr>
@@ -14050,13 +14345,17 @@
                       <a:noFill/>
                       <a:prstDash val="solid"/>
                     </a:lnT>
-                    <a:lnB algn="ctr" cmpd="sng" cap="flat" w="0">
-                      <a:noFill/>
+                    <a:lnB algn="ctr" cmpd="sng" cap="flat" w="19050">
+                      <a:solidFill>
+                        <a:srgbClr val="666666">
+                          <a:alpha val="100000"/>
+                        </a:srgbClr>
+                      </a:solidFill>
                       <a:prstDash val="solid"/>
                     </a:lnB>
                     <a:solidFill>
-                      <a:srgbClr val="FFFFFF">
-                        <a:alpha val="0"/>
+                      <a:srgbClr val="F4F8FB">
+                        <a:alpha val="100000"/>
                       </a:srgbClr>
                     </a:solidFill>
                   </a:tcPr>
@@ -14107,122 +14406,6 @@
                       <a:noFill/>
                       <a:prstDash val="solid"/>
                     </a:lnT>
-                    <a:lnB algn="ctr" cmpd="sng" cap="flat" w="0">
-                      <a:noFill/>
-                      <a:prstDash val="solid"/>
-                    </a:lnB>
-                    <a:solidFill>
-                      <a:srgbClr val="FFFFFF">
-                        <a:alpha val="0"/>
-                      </a:srgbClr>
-                    </a:solidFill>
-                  </a:tcPr>
-                </a:tc>
-                <a:tc>
-                  <a:txBody>
-                    <a:bodyPr/>
-                    <a:lstStyle/>
-                    <a:p>
-                      <a:pPr algn="l" marL="63500" marR="63500">
-                        <a:lnSpc>
-                          <a:spcPct val="100000"/>
-                        </a:lnSpc>
-                        <a:spcBef>
-                          <a:spcPts val="500"/>
-                        </a:spcBef>
-                        <a:spcAft>
-                          <a:spcPts val="500"/>
-                        </a:spcAft>
-                        <a:buNone/>
-                      </a:pPr>
-                      <a:r>
-                        <a:rPr cap="none" sz="1200" i="0" b="0" u="none" strike="noStrike">
-                          <a:solidFill>
-                            <a:srgbClr val="5B6770">
-                              <a:alpha val="100000"/>
-                            </a:srgbClr>
-                          </a:solidFill>
-                          <a:latin typeface="Helvetica Neue"/>
-                          <a:cs typeface="Helvetica Neue"/>
-                          <a:ea typeface="Helvetica Neue"/>
-                          <a:sym typeface="Helvetica Neue"/>
-                        </a:rPr>
-                        <a:t>605809</a:t>
-                      </a:r>
-                    </a:p>
-                  </a:txBody>
-                  <a:tcPr anchor="ctr" marB="63500" marT="63500" marR="0" marL="0">
-                    <a:lnL algn="ctr" cmpd="sng" cap="flat" w="0">
-                      <a:noFill/>
-                      <a:prstDash val="solid"/>
-                    </a:lnL>
-                    <a:lnR algn="ctr" cmpd="sng" cap="flat" w="0">
-                      <a:noFill/>
-                      <a:prstDash val="solid"/>
-                    </a:lnR>
-                    <a:lnT algn="ctr" cmpd="sng" cap="flat" w="0">
-                      <a:noFill/>
-                      <a:prstDash val="solid"/>
-                    </a:lnT>
-                    <a:lnB algn="ctr" cmpd="sng" cap="flat" w="0">
-                      <a:noFill/>
-                      <a:prstDash val="solid"/>
-                    </a:lnB>
-                    <a:solidFill>
-                      <a:srgbClr val="FFFFFF">
-                        <a:alpha val="0"/>
-                      </a:srgbClr>
-                    </a:solidFill>
-                  </a:tcPr>
-                </a:tc>
-              </a:tr>
-              <a:tr h="410845">
-                <a:tc>
-                  <a:txBody>
-                    <a:bodyPr/>
-                    <a:lstStyle/>
-                    <a:p>
-                      <a:pPr algn="l" marL="63500" marR="63500">
-                        <a:lnSpc>
-                          <a:spcPct val="100000"/>
-                        </a:lnSpc>
-                        <a:spcBef>
-                          <a:spcPts val="500"/>
-                        </a:spcBef>
-                        <a:spcAft>
-                          <a:spcPts val="500"/>
-                        </a:spcAft>
-                        <a:buNone/>
-                      </a:pPr>
-                      <a:r>
-                        <a:rPr cap="none" sz="1200" i="0" b="0" u="none" strike="noStrike">
-                          <a:solidFill>
-                            <a:srgbClr val="5B6770">
-                              <a:alpha val="100000"/>
-                            </a:srgbClr>
-                          </a:solidFill>
-                          <a:latin typeface="Helvetica Neue"/>
-                          <a:cs typeface="Helvetica Neue"/>
-                          <a:ea typeface="Helvetica Neue"/>
-                          <a:sym typeface="Helvetica Neue"/>
-                        </a:rPr>
-                        <a:t>N-(2-phenylethyl)aniline</a:t>
-                      </a:r>
-                    </a:p>
-                  </a:txBody>
-                  <a:tcPr anchor="ctr" marB="63500" marT="63500" marR="0" marL="0">
-                    <a:lnL algn="ctr" cmpd="sng" cap="flat" w="0">
-                      <a:noFill/>
-                      <a:prstDash val="solid"/>
-                    </a:lnL>
-                    <a:lnR algn="ctr" cmpd="sng" cap="flat" w="0">
-                      <a:noFill/>
-                      <a:prstDash val="solid"/>
-                    </a:lnR>
-                    <a:lnT algn="ctr" cmpd="sng" cap="flat" w="0">
-                      <a:noFill/>
-                      <a:prstDash val="solid"/>
-                    </a:lnT>
                     <a:lnB algn="ctr" cmpd="sng" cap="flat" w="19050">
                       <a:solidFill>
                         <a:srgbClr val="666666">
@@ -14267,190 +14450,7 @@
                           <a:ea typeface="Helvetica Neue"/>
                           <a:sym typeface="Helvetica Neue"/>
                         </a:rPr>
-                        <a:t>17 Jul 2026</a:t>
-                      </a:r>
-                    </a:p>
-                  </a:txBody>
-                  <a:tcPr anchor="ctr" marB="63500" marT="63500" marR="0" marL="0">
-                    <a:lnL algn="ctr" cmpd="sng" cap="flat" w="0">
-                      <a:noFill/>
-                      <a:prstDash val="solid"/>
-                    </a:lnL>
-                    <a:lnR algn="ctr" cmpd="sng" cap="flat" w="0">
-                      <a:noFill/>
-                      <a:prstDash val="solid"/>
-                    </a:lnR>
-                    <a:lnT algn="ctr" cmpd="sng" cap="flat" w="0">
-                      <a:noFill/>
-                      <a:prstDash val="solid"/>
-                    </a:lnT>
-                    <a:lnB algn="ctr" cmpd="sng" cap="flat" w="19050">
-                      <a:solidFill>
-                        <a:srgbClr val="666666">
-                          <a:alpha val="100000"/>
-                        </a:srgbClr>
-                      </a:solidFill>
-                      <a:prstDash val="solid"/>
-                    </a:lnB>
-                    <a:solidFill>
-                      <a:srgbClr val="F4F8FB">
-                        <a:alpha val="100000"/>
-                      </a:srgbClr>
-                    </a:solidFill>
-                  </a:tcPr>
-                </a:tc>
-                <a:tc>
-                  <a:txBody>
-                    <a:bodyPr/>
-                    <a:lstStyle/>
-                    <a:p>
-                      <a:pPr algn="l" marL="63500" marR="63500">
-                        <a:lnSpc>
-                          <a:spcPct val="100000"/>
-                        </a:lnSpc>
-                        <a:spcBef>
-                          <a:spcPts val="500"/>
-                        </a:spcBef>
-                        <a:spcAft>
-                          <a:spcPts val="500"/>
-                        </a:spcAft>
-                        <a:buNone/>
-                      </a:pPr>
-                      <a:r>
-                        <a:rPr cap="none" sz="1200" i="0" b="0" u="none" strike="noStrike">
-                          <a:solidFill>
-                            <a:srgbClr val="5B6770">
-                              <a:alpha val="100000"/>
-                            </a:srgbClr>
-                          </a:solidFill>
-                          <a:latin typeface="Helvetica Neue"/>
-                          <a:cs typeface="Helvetica Neue"/>
-                          <a:ea typeface="Helvetica Neue"/>
-                          <a:sym typeface="Helvetica Neue"/>
-                        </a:rPr>
-                        <a:t>primary</a:t>
-                      </a:r>
-                    </a:p>
-                  </a:txBody>
-                  <a:tcPr anchor="ctr" marB="63500" marT="63500" marR="0" marL="0">
-                    <a:lnL algn="ctr" cmpd="sng" cap="flat" w="0">
-                      <a:noFill/>
-                      <a:prstDash val="solid"/>
-                    </a:lnL>
-                    <a:lnR algn="ctr" cmpd="sng" cap="flat" w="0">
-                      <a:noFill/>
-                      <a:prstDash val="solid"/>
-                    </a:lnR>
-                    <a:lnT algn="ctr" cmpd="sng" cap="flat" w="0">
-                      <a:noFill/>
-                      <a:prstDash val="solid"/>
-                    </a:lnT>
-                    <a:lnB algn="ctr" cmpd="sng" cap="flat" w="19050">
-                      <a:solidFill>
-                        <a:srgbClr val="666666">
-                          <a:alpha val="100000"/>
-                        </a:srgbClr>
-                      </a:solidFill>
-                      <a:prstDash val="solid"/>
-                    </a:lnB>
-                    <a:solidFill>
-                      <a:srgbClr val="F4F8FB">
-                        <a:alpha val="100000"/>
-                      </a:srgbClr>
-                    </a:solidFill>
-                  </a:tcPr>
-                </a:tc>
-                <a:tc>
-                  <a:txBody>
-                    <a:bodyPr/>
-                    <a:lstStyle/>
-                    <a:p>
-                      <a:pPr algn="r" marL="63500" marR="63500">
-                        <a:lnSpc>
-                          <a:spcPct val="100000"/>
-                        </a:lnSpc>
-                        <a:spcBef>
-                          <a:spcPts val="500"/>
-                        </a:spcBef>
-                        <a:spcAft>
-                          <a:spcPts val="500"/>
-                        </a:spcAft>
-                        <a:buNone/>
-                      </a:pPr>
-                      <a:r>
-                        <a:rPr cap="none" sz="1200" i="0" b="0" u="none" strike="noStrike">
-                          <a:solidFill>
-                            <a:srgbClr val="5B6770">
-                              <a:alpha val="100000"/>
-                            </a:srgbClr>
-                          </a:solidFill>
-                          <a:latin typeface="Helvetica Neue"/>
-                          <a:cs typeface="Helvetica Neue"/>
-                          <a:ea typeface="Helvetica Neue"/>
-                          <a:sym typeface="Helvetica Neue"/>
-                        </a:rPr>
-                        <a:t>4</a:t>
-                      </a:r>
-                    </a:p>
-                  </a:txBody>
-                  <a:tcPr anchor="ctr" marB="63500" marT="63500" marR="0" marL="0">
-                    <a:lnL algn="ctr" cmpd="sng" cap="flat" w="0">
-                      <a:noFill/>
-                      <a:prstDash val="solid"/>
-                    </a:lnL>
-                    <a:lnR algn="ctr" cmpd="sng" cap="flat" w="0">
-                      <a:noFill/>
-                      <a:prstDash val="solid"/>
-                    </a:lnR>
-                    <a:lnT algn="ctr" cmpd="sng" cap="flat" w="0">
-                      <a:noFill/>
-                      <a:prstDash val="solid"/>
-                    </a:lnT>
-                    <a:lnB algn="ctr" cmpd="sng" cap="flat" w="19050">
-                      <a:solidFill>
-                        <a:srgbClr val="666666">
-                          <a:alpha val="100000"/>
-                        </a:srgbClr>
-                      </a:solidFill>
-                      <a:prstDash val="solid"/>
-                    </a:lnB>
-                    <a:solidFill>
-                      <a:srgbClr val="F4F8FB">
-                        <a:alpha val="100000"/>
-                      </a:srgbClr>
-                    </a:solidFill>
-                  </a:tcPr>
-                </a:tc>
-                <a:tc>
-                  <a:txBody>
-                    <a:bodyPr/>
-                    <a:lstStyle/>
-                    <a:p>
-                      <a:pPr algn="l" marL="63500" marR="63500">
-                        <a:lnSpc>
-                          <a:spcPct val="100000"/>
-                        </a:lnSpc>
-                        <a:spcBef>
-                          <a:spcPts val="500"/>
-                        </a:spcBef>
-                        <a:spcAft>
-                          <a:spcPts val="500"/>
-                        </a:spcAft>
-                        <a:buNone/>
-                      </a:pPr>
-                      <a:r>
-                        <a:rPr cap="none" sz="1200" i="0" b="0" u="none" strike="noStrike">
-                          <a:solidFill>
-                            <a:srgbClr val="5B6770">
-                              <a:alpha val="100000"/>
-                            </a:srgbClr>
-                          </a:solidFill>
-                          <a:latin typeface="Helvetica Neue"/>
-                          <a:cs typeface="Helvetica Neue"/>
-                          <a:ea typeface="Helvetica Neue"/>
-                          <a:sym typeface="Helvetica Neue"/>
-                        </a:rPr>
-                        <a:t>900889</a:t>
+                        <a:t>605809</a:t>
                       </a:r>
                     </a:p>
                   </a:txBody>
@@ -19554,7 +19554,7 @@
                           <a:ea typeface="Helvetica Neue"/>
                           <a:sym typeface="Helvetica Neue"/>
                         </a:rPr>
-                        <a:t>56</a:t>
+                        <a:t>57</a:t>
                       </a:r>
                     </a:p>
                   </a:txBody>
@@ -21281,7 +21281,7 @@
                           <a:ea typeface="Helvetica Neue"/>
                           <a:sym typeface="Helvetica Neue"/>
                         </a:rPr>
-                        <a:t>69</a:t>
+                        <a:t>70</a:t>
                       </a:r>
                     </a:p>
                   </a:txBody>
@@ -24942,6 +24942,293 @@
                           <a:ea typeface="Helvetica Neue"/>
                           <a:sym typeface="Helvetica Neue"/>
                         </a:rPr>
+                        <a:t>buspirone</a:t>
+                      </a:r>
+                    </a:p>
+                  </a:txBody>
+                  <a:tcPr anchor="ctr" marB="63500" marT="63500" marR="0" marL="0">
+                    <a:lnL algn="ctr" cmpd="sng" cap="flat" w="0">
+                      <a:noFill/>
+                      <a:prstDash val="solid"/>
+                    </a:lnL>
+                    <a:lnR algn="ctr" cmpd="sng" cap="flat" w="0">
+                      <a:noFill/>
+                      <a:prstDash val="solid"/>
+                    </a:lnR>
+                    <a:lnT algn="ctr" cmpd="sng" cap="flat" w="0">
+                      <a:noFill/>
+                      <a:prstDash val="solid"/>
+                    </a:lnT>
+                    <a:lnB algn="ctr" cmpd="sng" cap="flat" w="0">
+                      <a:noFill/>
+                      <a:prstDash val="solid"/>
+                    </a:lnB>
+                    <a:solidFill>
+                      <a:srgbClr val="FFFFFF">
+                        <a:alpha val="0"/>
+                      </a:srgbClr>
+                    </a:solidFill>
+                  </a:tcPr>
+                </a:tc>
+                <a:tc>
+                  <a:txBody>
+                    <a:bodyPr/>
+                    <a:lstStyle/>
+                    <a:p>
+                      <a:pPr algn="l" marL="63500" marR="63500">
+                        <a:lnSpc>
+                          <a:spcPct val="100000"/>
+                        </a:lnSpc>
+                        <a:spcBef>
+                          <a:spcPts val="500"/>
+                        </a:spcBef>
+                        <a:spcAft>
+                          <a:spcPts val="500"/>
+                        </a:spcAft>
+                        <a:buNone/>
+                      </a:pPr>
+                      <a:r>
+                        <a:rPr cap="none" sz="1200" i="0" b="0" u="none" strike="noStrike">
+                          <a:solidFill>
+                            <a:srgbClr val="5B6770">
+                              <a:alpha val="100000"/>
+                            </a:srgbClr>
+                          </a:solidFill>
+                          <a:latin typeface="Helvetica Neue"/>
+                          <a:cs typeface="Helvetica Neue"/>
+                          <a:ea typeface="Helvetica Neue"/>
+                          <a:sym typeface="Helvetica Neue"/>
+                        </a:rPr>
+                        <a:t>14 Oct 2026</a:t>
+                      </a:r>
+                    </a:p>
+                  </a:txBody>
+                  <a:tcPr anchor="ctr" marB="63500" marT="63500" marR="0" marL="0">
+                    <a:lnL algn="ctr" cmpd="sng" cap="flat" w="0">
+                      <a:noFill/>
+                      <a:prstDash val="solid"/>
+                    </a:lnL>
+                    <a:lnR algn="ctr" cmpd="sng" cap="flat" w="0">
+                      <a:noFill/>
+                      <a:prstDash val="solid"/>
+                    </a:lnR>
+                    <a:lnT algn="ctr" cmpd="sng" cap="flat" w="0">
+                      <a:noFill/>
+                      <a:prstDash val="solid"/>
+                    </a:lnT>
+                    <a:lnB algn="ctr" cmpd="sng" cap="flat" w="0">
+                      <a:noFill/>
+                      <a:prstDash val="solid"/>
+                    </a:lnB>
+                    <a:solidFill>
+                      <a:srgbClr val="FFFFFF">
+                        <a:alpha val="0"/>
+                      </a:srgbClr>
+                    </a:solidFill>
+                  </a:tcPr>
+                </a:tc>
+                <a:tc>
+                  <a:txBody>
+                    <a:bodyPr/>
+                    <a:lstStyle/>
+                    <a:p>
+                      <a:pPr algn="l" marL="63500" marR="63500">
+                        <a:lnSpc>
+                          <a:spcPct val="100000"/>
+                        </a:lnSpc>
+                        <a:spcBef>
+                          <a:spcPts val="500"/>
+                        </a:spcBef>
+                        <a:spcAft>
+                          <a:spcPts val="500"/>
+                        </a:spcAft>
+                        <a:buNone/>
+                      </a:pPr>
+                      <a:r>
+                        <a:rPr cap="none" sz="1200" i="0" b="0" u="none" strike="noStrike">
+                          <a:solidFill>
+                            <a:srgbClr val="5B6770">
+                              <a:alpha val="100000"/>
+                            </a:srgbClr>
+                          </a:solidFill>
+                          <a:latin typeface="Helvetica Neue"/>
+                          <a:cs typeface="Helvetica Neue"/>
+                          <a:ea typeface="Helvetica Neue"/>
+                          <a:sym typeface="Helvetica Neue"/>
+                        </a:rPr>
+                        <a:t>primary</a:t>
+                      </a:r>
+                    </a:p>
+                  </a:txBody>
+                  <a:tcPr anchor="ctr" marB="63500" marT="63500" marR="0" marL="0">
+                    <a:lnL algn="ctr" cmpd="sng" cap="flat" w="0">
+                      <a:noFill/>
+                      <a:prstDash val="solid"/>
+                    </a:lnL>
+                    <a:lnR algn="ctr" cmpd="sng" cap="flat" w="0">
+                      <a:noFill/>
+                      <a:prstDash val="solid"/>
+                    </a:lnR>
+                    <a:lnT algn="ctr" cmpd="sng" cap="flat" w="0">
+                      <a:noFill/>
+                      <a:prstDash val="solid"/>
+                    </a:lnT>
+                    <a:lnB algn="ctr" cmpd="sng" cap="flat" w="0">
+                      <a:noFill/>
+                      <a:prstDash val="solid"/>
+                    </a:lnB>
+                    <a:solidFill>
+                      <a:srgbClr val="FFFFFF">
+                        <a:alpha val="0"/>
+                      </a:srgbClr>
+                    </a:solidFill>
+                  </a:tcPr>
+                </a:tc>
+                <a:tc>
+                  <a:txBody>
+                    <a:bodyPr/>
+                    <a:lstStyle/>
+                    <a:p>
+                      <a:pPr algn="r" marL="63500" marR="63500">
+                        <a:lnSpc>
+                          <a:spcPct val="100000"/>
+                        </a:lnSpc>
+                        <a:spcBef>
+                          <a:spcPts val="500"/>
+                        </a:spcBef>
+                        <a:spcAft>
+                          <a:spcPts val="500"/>
+                        </a:spcAft>
+                        <a:buNone/>
+                      </a:pPr>
+                      <a:r>
+                        <a:rPr cap="none" sz="1200" i="0" b="0" u="none" strike="noStrike">
+                          <a:solidFill>
+                            <a:srgbClr val="5B6770">
+                              <a:alpha val="100000"/>
+                            </a:srgbClr>
+                          </a:solidFill>
+                          <a:latin typeface="Helvetica Neue"/>
+                          <a:cs typeface="Helvetica Neue"/>
+                          <a:ea typeface="Helvetica Neue"/>
+                          <a:sym typeface="Helvetica Neue"/>
+                        </a:rPr>
+                        <a:t>1</a:t>
+                      </a:r>
+                    </a:p>
+                  </a:txBody>
+                  <a:tcPr anchor="ctr" marB="63500" marT="63500" marR="0" marL="0">
+                    <a:lnL algn="ctr" cmpd="sng" cap="flat" w="0">
+                      <a:noFill/>
+                      <a:prstDash val="solid"/>
+                    </a:lnL>
+                    <a:lnR algn="ctr" cmpd="sng" cap="flat" w="0">
+                      <a:noFill/>
+                      <a:prstDash val="solid"/>
+                    </a:lnR>
+                    <a:lnT algn="ctr" cmpd="sng" cap="flat" w="0">
+                      <a:noFill/>
+                      <a:prstDash val="solid"/>
+                    </a:lnT>
+                    <a:lnB algn="ctr" cmpd="sng" cap="flat" w="0">
+                      <a:noFill/>
+                      <a:prstDash val="solid"/>
+                    </a:lnB>
+                    <a:solidFill>
+                      <a:srgbClr val="FFFFFF">
+                        <a:alpha val="0"/>
+                      </a:srgbClr>
+                    </a:solidFill>
+                  </a:tcPr>
+                </a:tc>
+                <a:tc>
+                  <a:txBody>
+                    <a:bodyPr/>
+                    <a:lstStyle/>
+                    <a:p>
+                      <a:pPr algn="l" marL="63500" marR="63500">
+                        <a:lnSpc>
+                          <a:spcPct val="100000"/>
+                        </a:lnSpc>
+                        <a:spcBef>
+                          <a:spcPts val="500"/>
+                        </a:spcBef>
+                        <a:spcAft>
+                          <a:spcPts val="500"/>
+                        </a:spcAft>
+                        <a:buNone/>
+                      </a:pPr>
+                      <a:r>
+                        <a:rPr cap="none" sz="1200" i="0" b="0" u="none" strike="noStrike">
+                          <a:solidFill>
+                            <a:srgbClr val="5B6770">
+                              <a:alpha val="100000"/>
+                            </a:srgbClr>
+                          </a:solidFill>
+                          <a:latin typeface="Helvetica Neue"/>
+                          <a:cs typeface="Helvetica Neue"/>
+                          <a:ea typeface="Helvetica Neue"/>
+                          <a:sym typeface="Helvetica Neue"/>
+                        </a:rPr>
+                        <a:t>604745</a:t>
+                      </a:r>
+                    </a:p>
+                  </a:txBody>
+                  <a:tcPr anchor="ctr" marB="63500" marT="63500" marR="0" marL="0">
+                    <a:lnL algn="ctr" cmpd="sng" cap="flat" w="0">
+                      <a:noFill/>
+                      <a:prstDash val="solid"/>
+                    </a:lnL>
+                    <a:lnR algn="ctr" cmpd="sng" cap="flat" w="0">
+                      <a:noFill/>
+                      <a:prstDash val="solid"/>
+                    </a:lnR>
+                    <a:lnT algn="ctr" cmpd="sng" cap="flat" w="0">
+                      <a:noFill/>
+                      <a:prstDash val="solid"/>
+                    </a:lnT>
+                    <a:lnB algn="ctr" cmpd="sng" cap="flat" w="0">
+                      <a:noFill/>
+                      <a:prstDash val="solid"/>
+                    </a:lnB>
+                    <a:solidFill>
+                      <a:srgbClr val="FFFFFF">
+                        <a:alpha val="0"/>
+                      </a:srgbClr>
+                    </a:solidFill>
+                  </a:tcPr>
+                </a:tc>
+              </a:tr>
+              <a:tr h="401320">
+                <a:tc>
+                  <a:txBody>
+                    <a:bodyPr/>
+                    <a:lstStyle/>
+                    <a:p>
+                      <a:pPr algn="l" marL="63500" marR="63500">
+                        <a:lnSpc>
+                          <a:spcPct val="100000"/>
+                        </a:lnSpc>
+                        <a:spcBef>
+                          <a:spcPts val="500"/>
+                        </a:spcBef>
+                        <a:spcAft>
+                          <a:spcPts val="500"/>
+                        </a:spcAft>
+                        <a:buNone/>
+                      </a:pPr>
+                      <a:r>
+                        <a:rPr cap="none" sz="1200" i="0" b="0" u="none" strike="noStrike">
+                          <a:solidFill>
+                            <a:srgbClr val="5B6770">
+                              <a:alpha val="100000"/>
+                            </a:srgbClr>
+                          </a:solidFill>
+                          <a:latin typeface="Helvetica Neue"/>
+                          <a:cs typeface="Helvetica Neue"/>
+                          <a:ea typeface="Helvetica Neue"/>
+                          <a:sym typeface="Helvetica Neue"/>
+                        </a:rPr>
                         <a:t>dihydro-7-hydroxy mitragynine (MGM-15)</a:t>
                       </a:r>
                     </a:p>
@@ -24964,8 +25251,8 @@
                       <a:prstDash val="solid"/>
                     </a:lnB>
                     <a:solidFill>
-                      <a:srgbClr val="FFFFFF">
-                        <a:alpha val="0"/>
+                      <a:srgbClr val="F4F8FB">
+                        <a:alpha val="100000"/>
                       </a:srgbClr>
                     </a:solidFill>
                   </a:tcPr>
@@ -25021,8 +25308,8 @@
                       <a:prstDash val="solid"/>
                     </a:lnB>
                     <a:solidFill>
-                      <a:srgbClr val="FFFFFF">
-                        <a:alpha val="0"/>
+                      <a:srgbClr val="F4F8FB">
+                        <a:alpha val="100000"/>
                       </a:srgbClr>
                     </a:solidFill>
                   </a:tcPr>
@@ -25078,8 +25365,8 @@
                       <a:prstDash val="solid"/>
                     </a:lnB>
                     <a:solidFill>
-                      <a:srgbClr val="FFFFFF">
-                        <a:alpha val="0"/>
+                      <a:srgbClr val="F4F8FB">
+                        <a:alpha val="100000"/>
                       </a:srgbClr>
                     </a:solidFill>
                   </a:tcPr>
@@ -25135,8 +25422,8 @@
                       <a:prstDash val="solid"/>
                     </a:lnB>
                     <a:solidFill>
-                      <a:srgbClr val="FFFFFF">
-                        <a:alpha val="0"/>
+                      <a:srgbClr val="F4F8FB">
+                        <a:alpha val="100000"/>
                       </a:srgbClr>
                     </a:solidFill>
                   </a:tcPr>
@@ -25192,8 +25479,8 @@
                       <a:prstDash val="solid"/>
                     </a:lnB>
                     <a:solidFill>
-                      <a:srgbClr val="FFFFFF">
-                        <a:alpha val="0"/>
+                      <a:srgbClr val="F4F8FB">
+                        <a:alpha val="100000"/>
                       </a:srgbClr>
                     </a:solidFill>
                   </a:tcPr>
@@ -25251,8 +25538,8 @@
                       <a:prstDash val="solid"/>
                     </a:lnB>
                     <a:solidFill>
-                      <a:srgbClr val="F4F8FB">
-                        <a:alpha val="100000"/>
+                      <a:srgbClr val="FFFFFF">
+                        <a:alpha val="0"/>
                       </a:srgbClr>
                     </a:solidFill>
                   </a:tcPr>
@@ -25308,8 +25595,8 @@
                       <a:prstDash val="solid"/>
                     </a:lnB>
                     <a:solidFill>
-                      <a:srgbClr val="F4F8FB">
-                        <a:alpha val="100000"/>
+                      <a:srgbClr val="FFFFFF">
+                        <a:alpha val="0"/>
                       </a:srgbClr>
                     </a:solidFill>
                   </a:tcPr>
@@ -25365,8 +25652,8 @@
                       <a:prstDash val="solid"/>
                     </a:lnB>
                     <a:solidFill>
-                      <a:srgbClr val="F4F8FB">
-                        <a:alpha val="100000"/>
+                      <a:srgbClr val="FFFFFF">
+                        <a:alpha val="0"/>
                       </a:srgbClr>
                     </a:solidFill>
                   </a:tcPr>
@@ -25422,8 +25709,8 @@
                       <a:prstDash val="solid"/>
                     </a:lnB>
                     <a:solidFill>
-                      <a:srgbClr val="F4F8FB">
-                        <a:alpha val="100000"/>
+                      <a:srgbClr val="FFFFFF">
+                        <a:alpha val="0"/>
                       </a:srgbClr>
                     </a:solidFill>
                   </a:tcPr>
@@ -25479,8 +25766,8 @@
                       <a:prstDash val="solid"/>
                     </a:lnB>
                     <a:solidFill>
-                      <a:srgbClr val="F4F8FB">
-                        <a:alpha val="100000"/>
+                      <a:srgbClr val="FFFFFF">
+                        <a:alpha val="0"/>
                       </a:srgbClr>
                     </a:solidFill>
                   </a:tcPr>
@@ -25538,8 +25825,8 @@
                       <a:prstDash val="solid"/>
                     </a:lnB>
                     <a:solidFill>
-                      <a:srgbClr val="FFFFFF">
-                        <a:alpha val="0"/>
+                      <a:srgbClr val="F4F8FB">
+                        <a:alpha val="100000"/>
                       </a:srgbClr>
                     </a:solidFill>
                   </a:tcPr>
@@ -25595,8 +25882,8 @@
                       <a:prstDash val="solid"/>
                     </a:lnB>
                     <a:solidFill>
-                      <a:srgbClr val="FFFFFF">
-                        <a:alpha val="0"/>
+                      <a:srgbClr val="F4F8FB">
+                        <a:alpha val="100000"/>
                       </a:srgbClr>
                     </a:solidFill>
                   </a:tcPr>
@@ -25652,8 +25939,8 @@
                       <a:prstDash val="solid"/>
                     </a:lnB>
                     <a:solidFill>
-                      <a:srgbClr val="FFFFFF">
-                        <a:alpha val="0"/>
+                      <a:srgbClr val="F4F8FB">
+                        <a:alpha val="100000"/>
                       </a:srgbClr>
                     </a:solidFill>
                   </a:tcPr>
@@ -25709,8 +25996,8 @@
                       <a:prstDash val="solid"/>
                     </a:lnB>
                     <a:solidFill>
-                      <a:srgbClr val="FFFFFF">
-                        <a:alpha val="0"/>
+                      <a:srgbClr val="F4F8FB">
+                        <a:alpha val="100000"/>
                       </a:srgbClr>
                     </a:solidFill>
                   </a:tcPr>
@@ -25766,8 +26053,8 @@
                       <a:prstDash val="solid"/>
                     </a:lnB>
                     <a:solidFill>
-                      <a:srgbClr val="FFFFFF">
-                        <a:alpha val="0"/>
+                      <a:srgbClr val="F4F8FB">
+                        <a:alpha val="100000"/>
                       </a:srgbClr>
                     </a:solidFill>
                   </a:tcPr>
@@ -25825,8 +26112,8 @@
                       <a:prstDash val="solid"/>
                     </a:lnB>
                     <a:solidFill>
-                      <a:srgbClr val="F4F8FB">
-                        <a:alpha val="100000"/>
+                      <a:srgbClr val="FFFFFF">
+                        <a:alpha val="0"/>
                       </a:srgbClr>
                     </a:solidFill>
                   </a:tcPr>
@@ -25882,8 +26169,8 @@
                       <a:prstDash val="solid"/>
                     </a:lnB>
                     <a:solidFill>
-                      <a:srgbClr val="F4F8FB">
-                        <a:alpha val="100000"/>
+                      <a:srgbClr val="FFFFFF">
+                        <a:alpha val="0"/>
                       </a:srgbClr>
                     </a:solidFill>
                   </a:tcPr>
@@ -25939,8 +26226,8 @@
                       <a:prstDash val="solid"/>
                     </a:lnB>
                     <a:solidFill>
-                      <a:srgbClr val="F4F8FB">
-                        <a:alpha val="100000"/>
+                      <a:srgbClr val="FFFFFF">
+                        <a:alpha val="0"/>
                       </a:srgbClr>
                     </a:solidFill>
                   </a:tcPr>
@@ -25996,8 +26283,8 @@
                       <a:prstDash val="solid"/>
                     </a:lnB>
                     <a:solidFill>
-                      <a:srgbClr val="F4F8FB">
-                        <a:alpha val="100000"/>
+                      <a:srgbClr val="FFFFFF">
+                        <a:alpha val="0"/>
                       </a:srgbClr>
                     </a:solidFill>
                   </a:tcPr>
@@ -26053,8 +26340,8 @@
                       <a:prstDash val="solid"/>
                     </a:lnB>
                     <a:solidFill>
-                      <a:srgbClr val="F4F8FB">
-                        <a:alpha val="100000"/>
+                      <a:srgbClr val="FFFFFF">
+                        <a:alpha val="0"/>
                       </a:srgbClr>
                     </a:solidFill>
                   </a:tcPr>
@@ -26112,8 +26399,8 @@
                       <a:prstDash val="solid"/>
                     </a:lnB>
                     <a:solidFill>
-                      <a:srgbClr val="FFFFFF">
-                        <a:alpha val="0"/>
+                      <a:srgbClr val="F4F8FB">
+                        <a:alpha val="100000"/>
                       </a:srgbClr>
                     </a:solidFill>
                   </a:tcPr>
@@ -26169,8 +26456,8 @@
                       <a:prstDash val="solid"/>
                     </a:lnB>
                     <a:solidFill>
-                      <a:srgbClr val="FFFFFF">
-                        <a:alpha val="0"/>
+                      <a:srgbClr val="F4F8FB">
+                        <a:alpha val="100000"/>
                       </a:srgbClr>
                     </a:solidFill>
                   </a:tcPr>
@@ -26226,8 +26513,8 @@
                       <a:prstDash val="solid"/>
                     </a:lnB>
                     <a:solidFill>
-                      <a:srgbClr val="FFFFFF">
-                        <a:alpha val="0"/>
+                      <a:srgbClr val="F4F8FB">
+                        <a:alpha val="100000"/>
                       </a:srgbClr>
                     </a:solidFill>
                   </a:tcPr>
@@ -26283,8 +26570,8 @@
                       <a:prstDash val="solid"/>
                     </a:lnB>
                     <a:solidFill>
-                      <a:srgbClr val="FFFFFF">
-                        <a:alpha val="0"/>
+                      <a:srgbClr val="F4F8FB">
+                        <a:alpha val="100000"/>
                       </a:srgbClr>
                     </a:solidFill>
                   </a:tcPr>
@@ -26340,8 +26627,8 @@
                       <a:prstDash val="solid"/>
                     </a:lnB>
                     <a:solidFill>
-                      <a:srgbClr val="FFFFFF">
-                        <a:alpha val="0"/>
+                      <a:srgbClr val="F4F8FB">
+                        <a:alpha val="100000"/>
                       </a:srgbClr>
                     </a:solidFill>
                   </a:tcPr>
@@ -26399,8 +26686,8 @@
                       <a:prstDash val="solid"/>
                     </a:lnB>
                     <a:solidFill>
-                      <a:srgbClr val="F4F8FB">
-                        <a:alpha val="100000"/>
+                      <a:srgbClr val="FFFFFF">
+                        <a:alpha val="0"/>
                       </a:srgbClr>
                     </a:solidFill>
                   </a:tcPr>
@@ -26456,8 +26743,8 @@
                       <a:prstDash val="solid"/>
                     </a:lnB>
                     <a:solidFill>
-                      <a:srgbClr val="F4F8FB">
-                        <a:alpha val="100000"/>
+                      <a:srgbClr val="FFFFFF">
+                        <a:alpha val="0"/>
                       </a:srgbClr>
                     </a:solidFill>
                   </a:tcPr>
@@ -26513,8 +26800,8 @@
                       <a:prstDash val="solid"/>
                     </a:lnB>
                     <a:solidFill>
-                      <a:srgbClr val="F4F8FB">
-                        <a:alpha val="100000"/>
+                      <a:srgbClr val="FFFFFF">
+                        <a:alpha val="0"/>
                       </a:srgbClr>
                     </a:solidFill>
                   </a:tcPr>
@@ -26570,8 +26857,8 @@
                       <a:prstDash val="solid"/>
                     </a:lnB>
                     <a:solidFill>
-                      <a:srgbClr val="F4F8FB">
-                        <a:alpha val="100000"/>
+                      <a:srgbClr val="FFFFFF">
+                        <a:alpha val="0"/>
                       </a:srgbClr>
                     </a:solidFill>
                   </a:tcPr>
@@ -26627,8 +26914,8 @@
                       <a:prstDash val="solid"/>
                     </a:lnB>
                     <a:solidFill>
-                      <a:srgbClr val="F4F8FB">
-                        <a:alpha val="100000"/>
+                      <a:srgbClr val="FFFFFF">
+                        <a:alpha val="0"/>
                       </a:srgbClr>
                     </a:solidFill>
                   </a:tcPr>
@@ -26686,8 +26973,8 @@
                       <a:prstDash val="solid"/>
                     </a:lnB>
                     <a:solidFill>
-                      <a:srgbClr val="FFFFFF">
-                        <a:alpha val="0"/>
+                      <a:srgbClr val="F4F8FB">
+                        <a:alpha val="100000"/>
                       </a:srgbClr>
                     </a:solidFill>
                   </a:tcPr>
@@ -26743,8 +27030,8 @@
                       <a:prstDash val="solid"/>
                     </a:lnB>
                     <a:solidFill>
-                      <a:srgbClr val="FFFFFF">
-                        <a:alpha val="0"/>
+                      <a:srgbClr val="F4F8FB">
+                        <a:alpha val="100000"/>
                       </a:srgbClr>
                     </a:solidFill>
                   </a:tcPr>
@@ -26800,8 +27087,8 @@
                       <a:prstDash val="solid"/>
                     </a:lnB>
                     <a:solidFill>
-                      <a:srgbClr val="FFFFFF">
-                        <a:alpha val="0"/>
+                      <a:srgbClr val="F4F8FB">
+                        <a:alpha val="100000"/>
                       </a:srgbClr>
                     </a:solidFill>
                   </a:tcPr>
@@ -26857,8 +27144,8 @@
                       <a:prstDash val="solid"/>
                     </a:lnB>
                     <a:solidFill>
-                      <a:srgbClr val="FFFFFF">
-                        <a:alpha val="0"/>
+                      <a:srgbClr val="F4F8FB">
+                        <a:alpha val="100000"/>
                       </a:srgbClr>
                     </a:solidFill>
                   </a:tcPr>
@@ -26914,8 +27201,8 @@
                       <a:prstDash val="solid"/>
                     </a:lnB>
                     <a:solidFill>
-                      <a:srgbClr val="FFFFFF">
-                        <a:alpha val="0"/>
+                      <a:srgbClr val="F4F8FB">
+                        <a:alpha val="100000"/>
                       </a:srgbClr>
                     </a:solidFill>
                   </a:tcPr>
@@ -26973,8 +27260,8 @@
                       <a:prstDash val="solid"/>
                     </a:lnB>
                     <a:solidFill>
-                      <a:srgbClr val="F4F8FB">
-                        <a:alpha val="100000"/>
+                      <a:srgbClr val="FFFFFF">
+                        <a:alpha val="0"/>
                       </a:srgbClr>
                     </a:solidFill>
                   </a:tcPr>
@@ -27030,8 +27317,8 @@
                       <a:prstDash val="solid"/>
                     </a:lnB>
                     <a:solidFill>
-                      <a:srgbClr val="F4F8FB">
-                        <a:alpha val="100000"/>
+                      <a:srgbClr val="FFFFFF">
+                        <a:alpha val="0"/>
                       </a:srgbClr>
                     </a:solidFill>
                   </a:tcPr>
@@ -27087,8 +27374,8 @@
                       <a:prstDash val="solid"/>
                     </a:lnB>
                     <a:solidFill>
-                      <a:srgbClr val="F4F8FB">
-                        <a:alpha val="100000"/>
+                      <a:srgbClr val="FFFFFF">
+                        <a:alpha val="0"/>
                       </a:srgbClr>
                     </a:solidFill>
                   </a:tcPr>
@@ -27144,8 +27431,8 @@
                       <a:prstDash val="solid"/>
                     </a:lnB>
                     <a:solidFill>
-                      <a:srgbClr val="F4F8FB">
-                        <a:alpha val="100000"/>
+                      <a:srgbClr val="FFFFFF">
+                        <a:alpha val="0"/>
                       </a:srgbClr>
                     </a:solidFill>
                   </a:tcPr>
@@ -27201,8 +27488,8 @@
                       <a:prstDash val="solid"/>
                     </a:lnB>
                     <a:solidFill>
-                      <a:srgbClr val="F4F8FB">
-                        <a:alpha val="100000"/>
+                      <a:srgbClr val="FFFFFF">
+                        <a:alpha val="0"/>
                       </a:srgbClr>
                     </a:solidFill>
                   </a:tcPr>
@@ -27260,8 +27547,8 @@
                       <a:prstDash val="solid"/>
                     </a:lnB>
                     <a:solidFill>
-                      <a:srgbClr val="FFFFFF">
-                        <a:alpha val="0"/>
+                      <a:srgbClr val="F4F8FB">
+                        <a:alpha val="100000"/>
                       </a:srgbClr>
                     </a:solidFill>
                   </a:tcPr>
@@ -27317,8 +27604,8 @@
                       <a:prstDash val="solid"/>
                     </a:lnB>
                     <a:solidFill>
-                      <a:srgbClr val="FFFFFF">
-                        <a:alpha val="0"/>
+                      <a:srgbClr val="F4F8FB">
+                        <a:alpha val="100000"/>
                       </a:srgbClr>
                     </a:solidFill>
                   </a:tcPr>
@@ -27374,8 +27661,8 @@
                       <a:prstDash val="solid"/>
                     </a:lnB>
                     <a:solidFill>
-                      <a:srgbClr val="FFFFFF">
-                        <a:alpha val="0"/>
+                      <a:srgbClr val="F4F8FB">
+                        <a:alpha val="100000"/>
                       </a:srgbClr>
                     </a:solidFill>
                   </a:tcPr>
@@ -27431,8 +27718,8 @@
                       <a:prstDash val="solid"/>
                     </a:lnB>
                     <a:solidFill>
-                      <a:srgbClr val="FFFFFF">
-                        <a:alpha val="0"/>
+                      <a:srgbClr val="F4F8FB">
+                        <a:alpha val="100000"/>
                       </a:srgbClr>
                     </a:solidFill>
                   </a:tcPr>
@@ -27488,8 +27775,8 @@
                       <a:prstDash val="solid"/>
                     </a:lnB>
                     <a:solidFill>
-                      <a:srgbClr val="FFFFFF">
-                        <a:alpha val="0"/>
+                      <a:srgbClr val="F4F8FB">
+                        <a:alpha val="100000"/>
                       </a:srgbClr>
                     </a:solidFill>
                   </a:tcPr>
@@ -27547,8 +27834,8 @@
                       <a:prstDash val="solid"/>
                     </a:lnB>
                     <a:solidFill>
-                      <a:srgbClr val="F4F8FB">
-                        <a:alpha val="100000"/>
+                      <a:srgbClr val="FFFFFF">
+                        <a:alpha val="0"/>
                       </a:srgbClr>
                     </a:solidFill>
                   </a:tcPr>
@@ -27604,8 +27891,8 @@
                       <a:prstDash val="solid"/>
                     </a:lnB>
                     <a:solidFill>
-                      <a:srgbClr val="F4F8FB">
-                        <a:alpha val="100000"/>
+                      <a:srgbClr val="FFFFFF">
+                        <a:alpha val="0"/>
                       </a:srgbClr>
                     </a:solidFill>
                   </a:tcPr>
@@ -27661,8 +27948,8 @@
                       <a:prstDash val="solid"/>
                     </a:lnB>
                     <a:solidFill>
-                      <a:srgbClr val="F4F8FB">
-                        <a:alpha val="100000"/>
+                      <a:srgbClr val="FFFFFF">
+                        <a:alpha val="0"/>
                       </a:srgbClr>
                     </a:solidFill>
                   </a:tcPr>
@@ -27718,8 +28005,8 @@
                       <a:prstDash val="solid"/>
                     </a:lnB>
                     <a:solidFill>
-                      <a:srgbClr val="F4F8FB">
-                        <a:alpha val="100000"/>
+                      <a:srgbClr val="FFFFFF">
+                        <a:alpha val="0"/>
                       </a:srgbClr>
                     </a:solidFill>
                   </a:tcPr>
@@ -27775,14 +28062,14 @@
                       <a:prstDash val="solid"/>
                     </a:lnB>
                     <a:solidFill>
-                      <a:srgbClr val="F4F8FB">
-                        <a:alpha val="100000"/>
+                      <a:srgbClr val="FFFFFF">
+                        <a:alpha val="0"/>
                       </a:srgbClr>
                     </a:solidFill>
                   </a:tcPr>
                 </a:tc>
               </a:tr>
-              <a:tr h="401320">
+              <a:tr h="410845">
                 <a:tc>
                   <a:txBody>
                     <a:bodyPr/>
@@ -27829,13 +28116,17 @@
                       <a:noFill/>
                       <a:prstDash val="solid"/>
                     </a:lnT>
-                    <a:lnB algn="ctr" cmpd="sng" cap="flat" w="0">
-                      <a:noFill/>
+                    <a:lnB algn="ctr" cmpd="sng" cap="flat" w="19050">
+                      <a:solidFill>
+                        <a:srgbClr val="666666">
+                          <a:alpha val="100000"/>
+                        </a:srgbClr>
+                      </a:solidFill>
                       <a:prstDash val="solid"/>
                     </a:lnB>
                     <a:solidFill>
-                      <a:srgbClr val="FFFFFF">
-                        <a:alpha val="0"/>
+                      <a:srgbClr val="F4F8FB">
+                        <a:alpha val="100000"/>
                       </a:srgbClr>
                     </a:solidFill>
                   </a:tcPr>
@@ -27886,13 +28177,17 @@
                       <a:noFill/>
                       <a:prstDash val="solid"/>
                     </a:lnT>
-                    <a:lnB algn="ctr" cmpd="sng" cap="flat" w="0">
-                      <a:noFill/>
+                    <a:lnB algn="ctr" cmpd="sng" cap="flat" w="19050">
+                      <a:solidFill>
+                        <a:srgbClr val="666666">
+                          <a:alpha val="100000"/>
+                        </a:srgbClr>
+                      </a:solidFill>
                       <a:prstDash val="solid"/>
                     </a:lnB>
                     <a:solidFill>
-                      <a:srgbClr val="FFFFFF">
-                        <a:alpha val="0"/>
+                      <a:srgbClr val="F4F8FB">
+                        <a:alpha val="100000"/>
                       </a:srgbClr>
                     </a:solidFill>
                   </a:tcPr>
@@ -27943,13 +28238,17 @@
                       <a:noFill/>
                       <a:prstDash val="solid"/>
                     </a:lnT>
-                    <a:lnB algn="ctr" cmpd="sng" cap="flat" w="0">
-                      <a:noFill/>
+                    <a:lnB algn="ctr" cmpd="sng" cap="flat" w="19050">
+                      <a:solidFill>
+                        <a:srgbClr val="666666">
+                          <a:alpha val="100000"/>
+                        </a:srgbClr>
+                      </a:solidFill>
                       <a:prstDash val="solid"/>
                     </a:lnB>
                     <a:solidFill>
-                      <a:srgbClr val="FFFFFF">
-                        <a:alpha val="0"/>
+                      <a:srgbClr val="F4F8FB">
+                        <a:alpha val="100000"/>
                       </a:srgbClr>
                     </a:solidFill>
                   </a:tcPr>
@@ -28000,122 +28299,6 @@
                       <a:noFill/>
                       <a:prstDash val="solid"/>
                     </a:lnT>
-                    <a:lnB algn="ctr" cmpd="sng" cap="flat" w="0">
-                      <a:noFill/>
-                      <a:prstDash val="solid"/>
-                    </a:lnB>
-                    <a:solidFill>
-                      <a:srgbClr val="FFFFFF">
-                        <a:alpha val="0"/>
-                      </a:srgbClr>
-                    </a:solidFill>
-                  </a:tcPr>
-                </a:tc>
-                <a:tc>
-                  <a:txBody>
-                    <a:bodyPr/>
-                    <a:lstStyle/>
-                    <a:p>
-                      <a:pPr algn="l" marL="63500" marR="63500">
-                        <a:lnSpc>
-                          <a:spcPct val="100000"/>
-                        </a:lnSpc>
-                        <a:spcBef>
-                          <a:spcPts val="500"/>
-                        </a:spcBef>
-                        <a:spcAft>
-                          <a:spcPts val="500"/>
-                        </a:spcAft>
-                        <a:buNone/>
-                      </a:pPr>
-                      <a:r>
-                        <a:rPr cap="none" sz="1200" i="0" b="0" u="none" strike="noStrike">
-                          <a:solidFill>
-                            <a:srgbClr val="5B6770">
-                              <a:alpha val="100000"/>
-                            </a:srgbClr>
-                          </a:solidFill>
-                          <a:latin typeface="Helvetica Neue"/>
-                          <a:cs typeface="Helvetica Neue"/>
-                          <a:ea typeface="Helvetica Neue"/>
-                          <a:sym typeface="Helvetica Neue"/>
-                        </a:rPr>
-                        <a:t>605809</a:t>
-                      </a:r>
-                    </a:p>
-                  </a:txBody>
-                  <a:tcPr anchor="ctr" marB="63500" marT="63500" marR="0" marL="0">
-                    <a:lnL algn="ctr" cmpd="sng" cap="flat" w="0">
-                      <a:noFill/>
-                      <a:prstDash val="solid"/>
-                    </a:lnL>
-                    <a:lnR algn="ctr" cmpd="sng" cap="flat" w="0">
-                      <a:noFill/>
-                      <a:prstDash val="solid"/>
-                    </a:lnR>
-                    <a:lnT algn="ctr" cmpd="sng" cap="flat" w="0">
-                      <a:noFill/>
-                      <a:prstDash val="solid"/>
-                    </a:lnT>
-                    <a:lnB algn="ctr" cmpd="sng" cap="flat" w="0">
-                      <a:noFill/>
-                      <a:prstDash val="solid"/>
-                    </a:lnB>
-                    <a:solidFill>
-                      <a:srgbClr val="FFFFFF">
-                        <a:alpha val="0"/>
-                      </a:srgbClr>
-                    </a:solidFill>
-                  </a:tcPr>
-                </a:tc>
-              </a:tr>
-              <a:tr h="410845">
-                <a:tc>
-                  <a:txBody>
-                    <a:bodyPr/>
-                    <a:lstStyle/>
-                    <a:p>
-                      <a:pPr algn="l" marL="63500" marR="63500">
-                        <a:lnSpc>
-                          <a:spcPct val="100000"/>
-                        </a:lnSpc>
-                        <a:spcBef>
-                          <a:spcPts val="500"/>
-                        </a:spcBef>
-                        <a:spcAft>
-                          <a:spcPts val="500"/>
-                        </a:spcAft>
-                        <a:buNone/>
-                      </a:pPr>
-                      <a:r>
-                        <a:rPr cap="none" sz="1200" i="0" b="0" u="none" strike="noStrike">
-                          <a:solidFill>
-                            <a:srgbClr val="5B6770">
-                              <a:alpha val="100000"/>
-                            </a:srgbClr>
-                          </a:solidFill>
-                          <a:latin typeface="Helvetica Neue"/>
-                          <a:cs typeface="Helvetica Neue"/>
-                          <a:ea typeface="Helvetica Neue"/>
-                          <a:sym typeface="Helvetica Neue"/>
-                        </a:rPr>
-                        <a:t>N-(2-phenylethyl)aniline</a:t>
-                      </a:r>
-                    </a:p>
-                  </a:txBody>
-                  <a:tcPr anchor="ctr" marB="63500" marT="63500" marR="0" marL="0">
-                    <a:lnL algn="ctr" cmpd="sng" cap="flat" w="0">
-                      <a:noFill/>
-                      <a:prstDash val="solid"/>
-                    </a:lnL>
-                    <a:lnR algn="ctr" cmpd="sng" cap="flat" w="0">
-                      <a:noFill/>
-                      <a:prstDash val="solid"/>
-                    </a:lnR>
-                    <a:lnT algn="ctr" cmpd="sng" cap="flat" w="0">
-                      <a:noFill/>
-                      <a:prstDash val="solid"/>
-                    </a:lnT>
                     <a:lnB algn="ctr" cmpd="sng" cap="flat" w="19050">
                       <a:solidFill>
                         <a:srgbClr val="666666">
@@ -28160,190 +28343,7 @@
                           <a:ea typeface="Helvetica Neue"/>
                           <a:sym typeface="Helvetica Neue"/>
                         </a:rPr>
-                        <a:t>17 Jul 2026</a:t>
-                      </a:r>
-                    </a:p>
-                  </a:txBody>
-                  <a:tcPr anchor="ctr" marB="63500" marT="63500" marR="0" marL="0">
-                    <a:lnL algn="ctr" cmpd="sng" cap="flat" w="0">
-                      <a:noFill/>
-                      <a:prstDash val="solid"/>
-                    </a:lnL>
-                    <a:lnR algn="ctr" cmpd="sng" cap="flat" w="0">
-                      <a:noFill/>
-                      <a:prstDash val="solid"/>
-                    </a:lnR>
-                    <a:lnT algn="ctr" cmpd="sng" cap="flat" w="0">
-                      <a:noFill/>
-                      <a:prstDash val="solid"/>
-                    </a:lnT>
-                    <a:lnB algn="ctr" cmpd="sng" cap="flat" w="19050">
-                      <a:solidFill>
-                        <a:srgbClr val="666666">
-                          <a:alpha val="100000"/>
-                        </a:srgbClr>
-                      </a:solidFill>
-                      <a:prstDash val="solid"/>
-                    </a:lnB>
-                    <a:solidFill>
-                      <a:srgbClr val="F4F8FB">
-                        <a:alpha val="100000"/>
-                      </a:srgbClr>
-                    </a:solidFill>
-                  </a:tcPr>
-                </a:tc>
-                <a:tc>
-                  <a:txBody>
-                    <a:bodyPr/>
-                    <a:lstStyle/>
-                    <a:p>
-                      <a:pPr algn="l" marL="63500" marR="63500">
-                        <a:lnSpc>
-                          <a:spcPct val="100000"/>
-                        </a:lnSpc>
-                        <a:spcBef>
-                          <a:spcPts val="500"/>
-                        </a:spcBef>
-                        <a:spcAft>
-                          <a:spcPts val="500"/>
-                        </a:spcAft>
-                        <a:buNone/>
-                      </a:pPr>
-                      <a:r>
-                        <a:rPr cap="none" sz="1200" i="0" b="0" u="none" strike="noStrike">
-                          <a:solidFill>
-                            <a:srgbClr val="5B6770">
-                              <a:alpha val="100000"/>
-                            </a:srgbClr>
-                          </a:solidFill>
-                          <a:latin typeface="Helvetica Neue"/>
-                          <a:cs typeface="Helvetica Neue"/>
-                          <a:ea typeface="Helvetica Neue"/>
-                          <a:sym typeface="Helvetica Neue"/>
-                        </a:rPr>
-                        <a:t>primary</a:t>
-                      </a:r>
-                    </a:p>
-                  </a:txBody>
-                  <a:tcPr anchor="ctr" marB="63500" marT="63500" marR="0" marL="0">
-                    <a:lnL algn="ctr" cmpd="sng" cap="flat" w="0">
-                      <a:noFill/>
-                      <a:prstDash val="solid"/>
-                    </a:lnL>
-                    <a:lnR algn="ctr" cmpd="sng" cap="flat" w="0">
-                      <a:noFill/>
-                      <a:prstDash val="solid"/>
-                    </a:lnR>
-                    <a:lnT algn="ctr" cmpd="sng" cap="flat" w="0">
-                      <a:noFill/>
-                      <a:prstDash val="solid"/>
-                    </a:lnT>
-                    <a:lnB algn="ctr" cmpd="sng" cap="flat" w="19050">
-                      <a:solidFill>
-                        <a:srgbClr val="666666">
-                          <a:alpha val="100000"/>
-                        </a:srgbClr>
-                      </a:solidFill>
-                      <a:prstDash val="solid"/>
-                    </a:lnB>
-                    <a:solidFill>
-                      <a:srgbClr val="F4F8FB">
-                        <a:alpha val="100000"/>
-                      </a:srgbClr>
-                    </a:solidFill>
-                  </a:tcPr>
-                </a:tc>
-                <a:tc>
-                  <a:txBody>
-                    <a:bodyPr/>
-                    <a:lstStyle/>
-                    <a:p>
-                      <a:pPr algn="r" marL="63500" marR="63500">
-                        <a:lnSpc>
-                          <a:spcPct val="100000"/>
-                        </a:lnSpc>
-                        <a:spcBef>
-                          <a:spcPts val="500"/>
-                        </a:spcBef>
-                        <a:spcAft>
-                          <a:spcPts val="500"/>
-                        </a:spcAft>
-                        <a:buNone/>
-                      </a:pPr>
-                      <a:r>
-                        <a:rPr cap="none" sz="1200" i="0" b="0" u="none" strike="noStrike">
-                          <a:solidFill>
-                            <a:srgbClr val="5B6770">
-                              <a:alpha val="100000"/>
-                            </a:srgbClr>
-                          </a:solidFill>
-                          <a:latin typeface="Helvetica Neue"/>
-                          <a:cs typeface="Helvetica Neue"/>
-                          <a:ea typeface="Helvetica Neue"/>
-                          <a:sym typeface="Helvetica Neue"/>
-                        </a:rPr>
-                        <a:t>4</a:t>
-                      </a:r>
-                    </a:p>
-                  </a:txBody>
-                  <a:tcPr anchor="ctr" marB="63500" marT="63500" marR="0" marL="0">
-                    <a:lnL algn="ctr" cmpd="sng" cap="flat" w="0">
-                      <a:noFill/>
-                      <a:prstDash val="solid"/>
-                    </a:lnL>
-                    <a:lnR algn="ctr" cmpd="sng" cap="flat" w="0">
-                      <a:noFill/>
-                      <a:prstDash val="solid"/>
-                    </a:lnR>
-                    <a:lnT algn="ctr" cmpd="sng" cap="flat" w="0">
-                      <a:noFill/>
-                      <a:prstDash val="solid"/>
-                    </a:lnT>
-                    <a:lnB algn="ctr" cmpd="sng" cap="flat" w="19050">
-                      <a:solidFill>
-                        <a:srgbClr val="666666">
-                          <a:alpha val="100000"/>
-                        </a:srgbClr>
-                      </a:solidFill>
-                      <a:prstDash val="solid"/>
-                    </a:lnB>
-                    <a:solidFill>
-                      <a:srgbClr val="F4F8FB">
-                        <a:alpha val="100000"/>
-                      </a:srgbClr>
-                    </a:solidFill>
-                  </a:tcPr>
-                </a:tc>
-                <a:tc>
-                  <a:txBody>
-                    <a:bodyPr/>
-                    <a:lstStyle/>
-                    <a:p>
-                      <a:pPr algn="l" marL="63500" marR="63500">
-                        <a:lnSpc>
-                          <a:spcPct val="100000"/>
-                        </a:lnSpc>
-                        <a:spcBef>
-                          <a:spcPts val="500"/>
-                        </a:spcBef>
-                        <a:spcAft>
-                          <a:spcPts val="500"/>
-                        </a:spcAft>
-                        <a:buNone/>
-                      </a:pPr>
-                      <a:r>
-                        <a:rPr cap="none" sz="1200" i="0" b="0" u="none" strike="noStrike">
-                          <a:solidFill>
-                            <a:srgbClr val="5B6770">
-                              <a:alpha val="100000"/>
-                            </a:srgbClr>
-                          </a:solidFill>
-                          <a:latin typeface="Helvetica Neue"/>
-                          <a:cs typeface="Helvetica Neue"/>
-                          <a:ea typeface="Helvetica Neue"/>
-                          <a:sym typeface="Helvetica Neue"/>
-                        </a:rPr>
-                        <a:t>900889</a:t>
+                        <a:t>605809</a:t>
                       </a:r>
                     </a:p>
                   </a:txBody>

</xml_diff>

<commit_message>
nightly deck: data through 2026-10-16
</commit_message>
<xml_diff>
--- a/docs/nc-drug-checking-latest.pptx
+++ b/docs/nc-drug-checking-latest.pptx
@@ -2418,7 +2418,7 @@
                 <a:ea typeface="Helvetica Neue"/>
                 <a:sym typeface="Helvetica Neue"/>
               </a:rPr>
-              <a:t>Generated Thursday, October 15, 2026 · 8:46 AM ET UNC Street Drug Analysis Lab · OpioidData.org · results.streetsafe.supply Download as PowerPoint</a:t>
+              <a:t>Generated Friday, October 16, 2026 · 8:37 AM ET UNC Street Drug Analysis Lab · OpioidData.org · results.streetsafe.supply Download as PowerPoint</a:t>
             </a:r>
           </a:p>
         </p:txBody>
@@ -3184,7 +3184,7 @@
                 <a:ea typeface="Helvetica Neue"/>
                 <a:sym typeface="Helvetica Neue"/>
               </a:rPr>
-              <a:t>County = samplecounty · left: ≥1 completed analysis ever · right: unique samples per county (sqrt color scale) · all time: 26 Jan 2022 – 14 Oct 2026 · last 12 months: 15 Oct 2025 – 14 Oct 2026* · coverage reflects participation, not prevalence</a:t>
+              <a:t>County = samplecounty · left: ≥1 completed analysis ever · right: unique samples per county (sqrt color scale) · all time: 26 Jan 2022 – 14 Oct 2026 · last 12 months: 16 Oct 2025 – 14 Oct 2026* · coverage reflects participation, not prevalence</a:t>
             </a:r>
           </a:p>
         </p:txBody>
@@ -4323,7 +4323,7 @@
                 <a:ea typeface="Helvetica Neue"/>
                 <a:sym typeface="Helvetica Neue"/>
               </a:rPr>
-              <a:t>Samples with methamphetamine or cocaine detected (any abundance); samples in both classes appear on both slides · sensations semicolon lists parsed + sen_strength (own denominator) · consumed = 1 only · before: 26 Jan 2022 – 14 Oct 2025 · past 12 months: 15 Oct 2025 – 14 Oct 2026* · Δ in percentage points</a:t>
+              <a:t>Samples with methamphetamine or cocaine detected (any abundance); samples in both classes appear on both slides · sensations semicolon lists parsed + sen_strength (own denominator) · consumed = 1 only · before: 26 Jan 2022 – 14 Oct 2025 · past 12 months: 16 Oct 2025 – 14 Oct 2026* · Δ in percentage points</a:t>
             </a:r>
           </a:p>
         </p:txBody>
@@ -4742,7 +4742,7 @@
                 <a:ea typeface="Helvetica Neue"/>
                 <a:sym typeface="Helvetica Neue"/>
               </a:rPr>
-              <a:t>Samples with an opioid (fentanyl, heroin) or benzodiazepine detected (any abundance); samples in both classes appear on both slides · sensations semicolon lists parsed + sen_strength (own denominator) · consumed = 1 only · before: 26 Jan 2022 – 14 Oct 2025 · past 12 months: 15 Oct 2025 – 14 Oct 2026* · Δ in percentage points</a:t>
+              <a:t>Samples with an opioid (fentanyl, heroin) or benzodiazepine detected (any abundance); samples in both classes appear on both slides · sensations semicolon lists parsed + sen_strength (own denominator) · consumed = 1 only · before: 26 Jan 2022 – 14 Oct 2025 · past 12 months: 16 Oct 2025 – 14 Oct 2026* · Δ in percentage points</a:t>
             </a:r>
           </a:p>
         </p:txBody>
@@ -5855,7 +5855,7 @@
                 <a:ea typeface="Helvetica Neue"/>
                 <a:sym typeface="Helvetica Neue"/>
               </a:rPr>
-              <a:t>lab_detail.substance counts · solid = primary abundance, light = trace · standardized names (PubChem-linked) · window: date_complete 15 Oct 2025 – 14 Oct 2026* (trailing 12 months, current month partial)</a:t>
+              <a:t>lab_detail.substance counts · solid = primary abundance, light = trace · standardized names (PubChem-linked) · window: date_complete 16 Oct 2025 – 14 Oct 2026* (trailing 12 months, current month partial)</a:t>
             </a:r>
           </a:p>
         </p:txBody>
@@ -6053,7 +6053,7 @@
                 <a:ea typeface="Helvetica Neue"/>
                 <a:sym typeface="Helvetica Neue"/>
               </a:rPr>
-              <a:t>Distribution of substances detected per sample, both definitions shown side by side · window: date_complete 15 Oct 2025 – 14 Oct 2026* (trailing 12 months, current month partial)</a:t>
+              <a:t>Distribution of substances detected per sample, both definitions shown side by side · window: date_complete 16 Oct 2025 – 14 Oct 2026* (trailing 12 months, current month partial)</a:t>
             </a:r>
           </a:p>
         </p:txBody>

</xml_diff>

<commit_message>
nightly deck: data through 2026-10-17
</commit_message>
<xml_diff>
--- a/docs/nc-drug-checking-latest.pptx
+++ b/docs/nc-drug-checking-latest.pptx
@@ -2418,7 +2418,7 @@
                 <a:ea typeface="Helvetica Neue"/>
                 <a:sym typeface="Helvetica Neue"/>
               </a:rPr>
-              <a:t>Generated Friday, October 16, 2026 · 8:37 AM ET UNC Street Drug Analysis Lab · OpioidData.org · results.streetsafe.supply Download as PowerPoint</a:t>
+              <a:t>Generated Saturday, October 17, 2026 · 7:42 AM ET UNC Street Drug Analysis Lab · OpioidData.org · results.streetsafe.supply Download as PowerPoint</a:t>
             </a:r>
           </a:p>
         </p:txBody>
@@ -2713,7 +2713,7 @@
                 <a:ea typeface="Helvetica Neue"/>
                 <a:sym typeface="Helvetica Neue"/>
               </a:rPr>
-              <a:t>PLACEHOLDER · figs/stats.json January 2022 to Wednesday, October 14, 2026 N = 2,983 NC samples analyzed Mailed in from 86 harm reduction programs Collected across 59 counties 250 distinct substances detected to date Unique samples = n_distinct(sampleid) · substances from lab_detail.substance · includes samples with date_complete 26 Jan 2022 – 14 Oct 2026 r/build_nightly.R → figs/stats.json</a:t>
+              <a:t>PLACEHOLDER · figs/stats.json January 2022 to Friday, October 16, 2026 N = 2,987 NC samples analyzed Mailed in from 86 harm reduction programs Collected across 59 counties 251 distinct substances detected to date Unique samples = n_distinct(sampleid) · substances from lab_detail.substance · includes samples with date_complete 26 Jan 2022 – 16 Oct 2026 r/build_nightly.R → figs/stats.json</a:t>
             </a:r>
           </a:p>
         </p:txBody>
@@ -2762,7 +2762,7 @@
                 <a:ea typeface="Helvetica Neue"/>
                 <a:sym typeface="Helvetica Neue"/>
               </a:rPr>
-              <a:t>Unique samples = n_distinct(sampleid) · substances from lab_detail.substance · includes samples with date_complete 26 Jan 2022 – 14 Oct 2026</a:t>
+              <a:t>Unique samples = n_distinct(sampleid) · substances from lab_detail.substance · includes samples with date_complete 26 Jan 2022 – 16 Oct 2026</a:t>
             </a:r>
           </a:p>
         </p:txBody>
@@ -3184,7 +3184,7 @@
                 <a:ea typeface="Helvetica Neue"/>
                 <a:sym typeface="Helvetica Neue"/>
               </a:rPr>
-              <a:t>County = samplecounty · left: ≥1 completed analysis ever · right: unique samples per county (sqrt color scale) · all time: 26 Jan 2022 – 14 Oct 2026 · last 12 months: 16 Oct 2025 – 14 Oct 2026* · coverage reflects participation, not prevalence</a:t>
+              <a:t>County = samplecounty · left: ≥1 completed analysis ever · right: unique samples per county (sqrt color scale) · all time: 26 Jan 2022 – 16 Oct 2026 · last 12 months: 17 Oct 2025 – 16 Oct 2026* · coverage reflects participation, not prevalence</a:t>
             </a:r>
           </a:p>
         </p:txBody>
@@ -3505,7 +3505,7 @@
                 <a:ea typeface="Helvetica Neue"/>
                 <a:sym typeface="Helvetica Neue"/>
               </a:rPr>
-              <a:t>expectedsubstance (verbatim card write-in, semicolon lists split) · derived flags: expect_opioid, expect_fentanyl, expect_meth, expect_cocaine, expect_stimulant… · includes samples with date_complete 26 Jan 2022 – 14 Oct 2026 · data table: Appendix A2</a:t>
+              <a:t>expectedsubstance (verbatim card write-in, semicolon lists split) · derived flags: expect_opioid, expect_fentanyl, expect_meth, expect_cocaine, expect_stimulant… · includes samples with date_complete 26 Jan 2022 – 16 Oct 2026 · data table: Appendix A2</a:t>
             </a:r>
           </a:p>
         </p:txBody>
@@ -3703,7 +3703,7 @@
                 <a:ea typeface="Helvetica Neue"/>
                 <a:sym typeface="Helvetica Neue"/>
               </a:rPr>
-              <a:t>Numerator uses lab_*_any (primary or trace) among samples with expect_* = 1 · includes samples with date_complete 26 Jan 2022 – 14 Oct 2026 · data table: Appendix A3</a:t>
+              <a:t>Numerator uses lab_*_any (primary or trace) among samples with expect_* = 1 · includes samples with date_complete 26 Jan 2022 – 16 Oct 2026 · data table: Appendix A3</a:t>
             </a:r>
           </a:p>
         </p:txBody>
@@ -3901,7 +3901,7 @@
                 <a:ea typeface="Helvetica Neue"/>
                 <a:sym typeface="Helvetica Neue"/>
               </a:rPr>
-              <a:t>sensations (circled on card, semicolon lists split) · post-consumption samples only (consumed = 1) · includes samples with date_complete 26 Jan 2022 – 14 Oct 2026</a:t>
+              <a:t>sensations (circled on card, semicolon lists split) · post-consumption samples only (consumed = 1) · includes samples with date_complete 26 Jan 2022 – 16 Oct 2026</a:t>
             </a:r>
           </a:p>
         </p:txBody>
@@ -4125,7 +4125,7 @@
                 <a:ea typeface="Helvetica Neue"/>
                 <a:sym typeface="Helvetica Neue"/>
               </a:rPr>
-              <a:t>sensations semicolon lists parsed per report · consumed = 1 only · denominator: consumed samples with lab_*_any = 1 · includes samples with date_complete 26 Jan 2022 – 14 Oct 2026</a:t>
+              <a:t>sensations semicolon lists parsed per report · consumed = 1 only · denominator: consumed samples with lab_*_any = 1 · includes samples with date_complete 26 Jan 2022 – 16 Oct 2026</a:t>
             </a:r>
           </a:p>
         </p:txBody>
@@ -4323,7 +4323,7 @@
                 <a:ea typeface="Helvetica Neue"/>
                 <a:sym typeface="Helvetica Neue"/>
               </a:rPr>
-              <a:t>Samples with methamphetamine or cocaine detected (any abundance); samples in both classes appear on both slides · sensations semicolon lists parsed + sen_strength (own denominator) · consumed = 1 only · before: 26 Jan 2022 – 14 Oct 2025 · past 12 months: 16 Oct 2025 – 14 Oct 2026* · Δ in percentage points</a:t>
+              <a:t>Samples with methamphetamine or cocaine detected (any abundance); samples in both classes appear on both slides · sensations semicolon lists parsed + sen_strength (own denominator) · consumed = 1 only · before: 26 Jan 2022 – 16 Oct 2025 · past 12 months: 17 Oct 2025 – 16 Oct 2026* · Δ in percentage points</a:t>
             </a:r>
           </a:p>
         </p:txBody>
@@ -4742,7 +4742,7 @@
                 <a:ea typeface="Helvetica Neue"/>
                 <a:sym typeface="Helvetica Neue"/>
               </a:rPr>
-              <a:t>Samples with an opioid (fentanyl, heroin) or benzodiazepine detected (any abundance); samples in both classes appear on both slides · sensations semicolon lists parsed + sen_strength (own denominator) · consumed = 1 only · before: 26 Jan 2022 – 14 Oct 2025 · past 12 months: 16 Oct 2025 – 14 Oct 2026* · Δ in percentage points</a:t>
+              <a:t>Samples with an opioid (fentanyl, heroin) or benzodiazepine detected (any abundance); samples in both classes appear on both slides · sensations semicolon lists parsed + sen_strength (own denominator) · consumed = 1 only · before: 26 Jan 2022 – 16 Oct 2025 · past 12 months: 17 Oct 2025 – 16 Oct 2026* · Δ in percentage points</a:t>
             </a:r>
           </a:p>
         </p:txBody>
@@ -5138,7 +5138,7 @@
                 <a:ea typeface="Helvetica Neue"/>
                 <a:sym typeface="Helvetica Neue"/>
               </a:rPr>
-              <a:t>color, texture (card v3+, semicolon lists split) · derived: bright_color excludes white/tan/brown family — orange bar above · includes samples with date_complete 26 Jan 2022 – 14 Oct 2026</a:t>
+              <a:t>color, texture (card v3+, semicolon lists split) · derived: bright_color excludes white/tan/brown family — orange bar above · includes samples with date_complete 26 Jan 2022 – 16 Oct 2026</a:t>
             </a:r>
           </a:p>
         </p:txBody>
@@ -5459,7 +5459,7 @@
                 <a:ea typeface="Helvetica Neue"/>
                 <a:sym typeface="Helvetica Neue"/>
               </a:rPr>
-              <a:t>Distribution of substances detected per sample, both definitions shown side by side · includes samples with date_complete 26 Jan 2022 – 14 Oct 2026</a:t>
+              <a:t>Distribution of substances detected per sample, both definitions shown side by side · includes samples with date_complete 26 Jan 2022 – 16 Oct 2026</a:t>
             </a:r>
           </a:p>
         </p:txBody>
@@ -5657,7 +5657,7 @@
                 <a:ea typeface="Helvetica Neue"/>
                 <a:sym typeface="Helvetica Neue"/>
               </a:rPr>
-              <a:t>lab_detail.substance counts · solid = primary abundance, light = trace · standardized names (PubChem-linked) · includes samples with date_complete 26 Jan 2022 – 14 Oct 2026</a:t>
+              <a:t>lab_detail.substance counts · solid = primary abundance, light = trace · standardized names (PubChem-linked) · includes samples with date_complete 26 Jan 2022 – 16 Oct 2026</a:t>
             </a:r>
           </a:p>
         </p:txBody>
@@ -5855,7 +5855,7 @@
                 <a:ea typeface="Helvetica Neue"/>
                 <a:sym typeface="Helvetica Neue"/>
               </a:rPr>
-              <a:t>lab_detail.substance counts · solid = primary abundance, light = trace · standardized names (PubChem-linked) · window: date_complete 16 Oct 2025 – 14 Oct 2026* (trailing 12 months, current month partial)</a:t>
+              <a:t>lab_detail.substance counts · solid = primary abundance, light = trace · standardized names (PubChem-linked) · window: date_complete 17 Oct 2025 – 16 Oct 2026* (trailing 12 months, current month partial)</a:t>
             </a:r>
           </a:p>
         </p:txBody>
@@ -6053,7 +6053,7 @@
                 <a:ea typeface="Helvetica Neue"/>
                 <a:sym typeface="Helvetica Neue"/>
               </a:rPr>
-              <a:t>Distribution of substances detected per sample, both definitions shown side by side · window: date_complete 16 Oct 2025 – 14 Oct 2026* (trailing 12 months, current month partial)</a:t>
+              <a:t>Distribution of substances detected per sample, both definitions shown side by side · window: date_complete 17 Oct 2025 – 16 Oct 2026* (trailing 12 months, current month partial)</a:t>
             </a:r>
           </a:p>
         </p:txBody>
@@ -11049,6 +11049,293 @@
                           <a:ea typeface="Helvetica Neue"/>
                           <a:sym typeface="Helvetica Neue"/>
                         </a:rPr>
+                        <a:t>clonidine</a:t>
+                      </a:r>
+                    </a:p>
+                  </a:txBody>
+                  <a:tcPr anchor="ctr" marB="63500" marT="63500" marR="0" marL="0">
+                    <a:lnL algn="ctr" cmpd="sng" cap="flat" w="0">
+                      <a:noFill/>
+                      <a:prstDash val="solid"/>
+                    </a:lnL>
+                    <a:lnR algn="ctr" cmpd="sng" cap="flat" w="0">
+                      <a:noFill/>
+                      <a:prstDash val="solid"/>
+                    </a:lnR>
+                    <a:lnT algn="ctr" cmpd="sng" cap="flat" w="0">
+                      <a:noFill/>
+                      <a:prstDash val="solid"/>
+                    </a:lnT>
+                    <a:lnB algn="ctr" cmpd="sng" cap="flat" w="0">
+                      <a:noFill/>
+                      <a:prstDash val="solid"/>
+                    </a:lnB>
+                    <a:solidFill>
+                      <a:srgbClr val="FFFFFF">
+                        <a:alpha val="0"/>
+                      </a:srgbClr>
+                    </a:solidFill>
+                  </a:tcPr>
+                </a:tc>
+                <a:tc>
+                  <a:txBody>
+                    <a:bodyPr/>
+                    <a:lstStyle/>
+                    <a:p>
+                      <a:pPr algn="l" marL="63500" marR="63500">
+                        <a:lnSpc>
+                          <a:spcPct val="100000"/>
+                        </a:lnSpc>
+                        <a:spcBef>
+                          <a:spcPts val="500"/>
+                        </a:spcBef>
+                        <a:spcAft>
+                          <a:spcPts val="500"/>
+                        </a:spcAft>
+                        <a:buNone/>
+                      </a:pPr>
+                      <a:r>
+                        <a:rPr cap="none" sz="1200" i="0" b="0" u="none" strike="noStrike">
+                          <a:solidFill>
+                            <a:srgbClr val="5B6770">
+                              <a:alpha val="100000"/>
+                            </a:srgbClr>
+                          </a:solidFill>
+                          <a:latin typeface="Helvetica Neue"/>
+                          <a:cs typeface="Helvetica Neue"/>
+                          <a:ea typeface="Helvetica Neue"/>
+                          <a:sym typeface="Helvetica Neue"/>
+                        </a:rPr>
+                        <a:t>16 Oct 2026</a:t>
+                      </a:r>
+                    </a:p>
+                  </a:txBody>
+                  <a:tcPr anchor="ctr" marB="63500" marT="63500" marR="0" marL="0">
+                    <a:lnL algn="ctr" cmpd="sng" cap="flat" w="0">
+                      <a:noFill/>
+                      <a:prstDash val="solid"/>
+                    </a:lnL>
+                    <a:lnR algn="ctr" cmpd="sng" cap="flat" w="0">
+                      <a:noFill/>
+                      <a:prstDash val="solid"/>
+                    </a:lnR>
+                    <a:lnT algn="ctr" cmpd="sng" cap="flat" w="0">
+                      <a:noFill/>
+                      <a:prstDash val="solid"/>
+                    </a:lnT>
+                    <a:lnB algn="ctr" cmpd="sng" cap="flat" w="0">
+                      <a:noFill/>
+                      <a:prstDash val="solid"/>
+                    </a:lnB>
+                    <a:solidFill>
+                      <a:srgbClr val="FFFFFF">
+                        <a:alpha val="0"/>
+                      </a:srgbClr>
+                    </a:solidFill>
+                  </a:tcPr>
+                </a:tc>
+                <a:tc>
+                  <a:txBody>
+                    <a:bodyPr/>
+                    <a:lstStyle/>
+                    <a:p>
+                      <a:pPr algn="l" marL="63500" marR="63500">
+                        <a:lnSpc>
+                          <a:spcPct val="100000"/>
+                        </a:lnSpc>
+                        <a:spcBef>
+                          <a:spcPts val="500"/>
+                        </a:spcBef>
+                        <a:spcAft>
+                          <a:spcPts val="500"/>
+                        </a:spcAft>
+                        <a:buNone/>
+                      </a:pPr>
+                      <a:r>
+                        <a:rPr cap="none" sz="1200" i="0" b="0" u="none" strike="noStrike">
+                          <a:solidFill>
+                            <a:srgbClr val="5B6770">
+                              <a:alpha val="100000"/>
+                            </a:srgbClr>
+                          </a:solidFill>
+                          <a:latin typeface="Helvetica Neue"/>
+                          <a:cs typeface="Helvetica Neue"/>
+                          <a:ea typeface="Helvetica Neue"/>
+                          <a:sym typeface="Helvetica Neue"/>
+                        </a:rPr>
+                        <a:t>trace</a:t>
+                      </a:r>
+                    </a:p>
+                  </a:txBody>
+                  <a:tcPr anchor="ctr" marB="63500" marT="63500" marR="0" marL="0">
+                    <a:lnL algn="ctr" cmpd="sng" cap="flat" w="0">
+                      <a:noFill/>
+                      <a:prstDash val="solid"/>
+                    </a:lnL>
+                    <a:lnR algn="ctr" cmpd="sng" cap="flat" w="0">
+                      <a:noFill/>
+                      <a:prstDash val="solid"/>
+                    </a:lnR>
+                    <a:lnT algn="ctr" cmpd="sng" cap="flat" w="0">
+                      <a:noFill/>
+                      <a:prstDash val="solid"/>
+                    </a:lnT>
+                    <a:lnB algn="ctr" cmpd="sng" cap="flat" w="0">
+                      <a:noFill/>
+                      <a:prstDash val="solid"/>
+                    </a:lnB>
+                    <a:solidFill>
+                      <a:srgbClr val="FFFFFF">
+                        <a:alpha val="0"/>
+                      </a:srgbClr>
+                    </a:solidFill>
+                  </a:tcPr>
+                </a:tc>
+                <a:tc>
+                  <a:txBody>
+                    <a:bodyPr/>
+                    <a:lstStyle/>
+                    <a:p>
+                      <a:pPr algn="r" marL="63500" marR="63500">
+                        <a:lnSpc>
+                          <a:spcPct val="100000"/>
+                        </a:lnSpc>
+                        <a:spcBef>
+                          <a:spcPts val="500"/>
+                        </a:spcBef>
+                        <a:spcAft>
+                          <a:spcPts val="500"/>
+                        </a:spcAft>
+                        <a:buNone/>
+                      </a:pPr>
+                      <a:r>
+                        <a:rPr cap="none" sz="1200" i="0" b="0" u="none" strike="noStrike">
+                          <a:solidFill>
+                            <a:srgbClr val="5B6770">
+                              <a:alpha val="100000"/>
+                            </a:srgbClr>
+                          </a:solidFill>
+                          <a:latin typeface="Helvetica Neue"/>
+                          <a:cs typeface="Helvetica Neue"/>
+                          <a:ea typeface="Helvetica Neue"/>
+                          <a:sym typeface="Helvetica Neue"/>
+                        </a:rPr>
+                        <a:t>1</a:t>
+                      </a:r>
+                    </a:p>
+                  </a:txBody>
+                  <a:tcPr anchor="ctr" marB="63500" marT="63500" marR="0" marL="0">
+                    <a:lnL algn="ctr" cmpd="sng" cap="flat" w="0">
+                      <a:noFill/>
+                      <a:prstDash val="solid"/>
+                    </a:lnL>
+                    <a:lnR algn="ctr" cmpd="sng" cap="flat" w="0">
+                      <a:noFill/>
+                      <a:prstDash val="solid"/>
+                    </a:lnR>
+                    <a:lnT algn="ctr" cmpd="sng" cap="flat" w="0">
+                      <a:noFill/>
+                      <a:prstDash val="solid"/>
+                    </a:lnT>
+                    <a:lnB algn="ctr" cmpd="sng" cap="flat" w="0">
+                      <a:noFill/>
+                      <a:prstDash val="solid"/>
+                    </a:lnB>
+                    <a:solidFill>
+                      <a:srgbClr val="FFFFFF">
+                        <a:alpha val="0"/>
+                      </a:srgbClr>
+                    </a:solidFill>
+                  </a:tcPr>
+                </a:tc>
+                <a:tc>
+                  <a:txBody>
+                    <a:bodyPr/>
+                    <a:lstStyle/>
+                    <a:p>
+                      <a:pPr algn="l" marL="63500" marR="63500">
+                        <a:lnSpc>
+                          <a:spcPct val="100000"/>
+                        </a:lnSpc>
+                        <a:spcBef>
+                          <a:spcPts val="500"/>
+                        </a:spcBef>
+                        <a:spcAft>
+                          <a:spcPts val="500"/>
+                        </a:spcAft>
+                        <a:buNone/>
+                      </a:pPr>
+                      <a:r>
+                        <a:rPr cap="none" sz="1200" i="0" b="0" u="none" strike="noStrike">
+                          <a:solidFill>
+                            <a:srgbClr val="5B6770">
+                              <a:alpha val="100000"/>
+                            </a:srgbClr>
+                          </a:solidFill>
+                          <a:latin typeface="Helvetica Neue"/>
+                          <a:cs typeface="Helvetica Neue"/>
+                          <a:ea typeface="Helvetica Neue"/>
+                          <a:sym typeface="Helvetica Neue"/>
+                        </a:rPr>
+                        <a:t>604747</a:t>
+                      </a:r>
+                    </a:p>
+                  </a:txBody>
+                  <a:tcPr anchor="ctr" marB="63500" marT="63500" marR="0" marL="0">
+                    <a:lnL algn="ctr" cmpd="sng" cap="flat" w="0">
+                      <a:noFill/>
+                      <a:prstDash val="solid"/>
+                    </a:lnL>
+                    <a:lnR algn="ctr" cmpd="sng" cap="flat" w="0">
+                      <a:noFill/>
+                      <a:prstDash val="solid"/>
+                    </a:lnR>
+                    <a:lnT algn="ctr" cmpd="sng" cap="flat" w="0">
+                      <a:noFill/>
+                      <a:prstDash val="solid"/>
+                    </a:lnT>
+                    <a:lnB algn="ctr" cmpd="sng" cap="flat" w="0">
+                      <a:noFill/>
+                      <a:prstDash val="solid"/>
+                    </a:lnB>
+                    <a:solidFill>
+                      <a:srgbClr val="FFFFFF">
+                        <a:alpha val="0"/>
+                      </a:srgbClr>
+                    </a:solidFill>
+                  </a:tcPr>
+                </a:tc>
+              </a:tr>
+              <a:tr h="401320">
+                <a:tc>
+                  <a:txBody>
+                    <a:bodyPr/>
+                    <a:lstStyle/>
+                    <a:p>
+                      <a:pPr algn="l" marL="63500" marR="63500">
+                        <a:lnSpc>
+                          <a:spcPct val="100000"/>
+                        </a:lnSpc>
+                        <a:spcBef>
+                          <a:spcPts val="500"/>
+                        </a:spcBef>
+                        <a:spcAft>
+                          <a:spcPts val="500"/>
+                        </a:spcAft>
+                        <a:buNone/>
+                      </a:pPr>
+                      <a:r>
+                        <a:rPr cap="none" sz="1200" i="0" b="0" u="none" strike="noStrike">
+                          <a:solidFill>
+                            <a:srgbClr val="5B6770">
+                              <a:alpha val="100000"/>
+                            </a:srgbClr>
+                          </a:solidFill>
+                          <a:latin typeface="Helvetica Neue"/>
+                          <a:cs typeface="Helvetica Neue"/>
+                          <a:ea typeface="Helvetica Neue"/>
+                          <a:sym typeface="Helvetica Neue"/>
+                        </a:rPr>
                         <a:t>buspirone</a:t>
                       </a:r>
                     </a:p>
@@ -11071,8 +11358,8 @@
                       <a:prstDash val="solid"/>
                     </a:lnB>
                     <a:solidFill>
-                      <a:srgbClr val="FFFFFF">
-                        <a:alpha val="0"/>
+                      <a:srgbClr val="F4F8FB">
+                        <a:alpha val="100000"/>
                       </a:srgbClr>
                     </a:solidFill>
                   </a:tcPr>
@@ -11128,8 +11415,8 @@
                       <a:prstDash val="solid"/>
                     </a:lnB>
                     <a:solidFill>
-                      <a:srgbClr val="FFFFFF">
-                        <a:alpha val="0"/>
+                      <a:srgbClr val="F4F8FB">
+                        <a:alpha val="100000"/>
                       </a:srgbClr>
                     </a:solidFill>
                   </a:tcPr>
@@ -11185,8 +11472,8 @@
                       <a:prstDash val="solid"/>
                     </a:lnB>
                     <a:solidFill>
-                      <a:srgbClr val="FFFFFF">
-                        <a:alpha val="0"/>
+                      <a:srgbClr val="F4F8FB">
+                        <a:alpha val="100000"/>
                       </a:srgbClr>
                     </a:solidFill>
                   </a:tcPr>
@@ -11242,8 +11529,8 @@
                       <a:prstDash val="solid"/>
                     </a:lnB>
                     <a:solidFill>
-                      <a:srgbClr val="FFFFFF">
-                        <a:alpha val="0"/>
+                      <a:srgbClr val="F4F8FB">
+                        <a:alpha val="100000"/>
                       </a:srgbClr>
                     </a:solidFill>
                   </a:tcPr>
@@ -11299,8 +11586,8 @@
                       <a:prstDash val="solid"/>
                     </a:lnB>
                     <a:solidFill>
-                      <a:srgbClr val="FFFFFF">
-                        <a:alpha val="0"/>
+                      <a:srgbClr val="F4F8FB">
+                        <a:alpha val="100000"/>
                       </a:srgbClr>
                     </a:solidFill>
                   </a:tcPr>
@@ -11358,8 +11645,8 @@
                       <a:prstDash val="solid"/>
                     </a:lnB>
                     <a:solidFill>
-                      <a:srgbClr val="F4F8FB">
-                        <a:alpha val="100000"/>
+                      <a:srgbClr val="FFFFFF">
+                        <a:alpha val="0"/>
                       </a:srgbClr>
                     </a:solidFill>
                   </a:tcPr>
@@ -11415,8 +11702,8 @@
                       <a:prstDash val="solid"/>
                     </a:lnB>
                     <a:solidFill>
-                      <a:srgbClr val="F4F8FB">
-                        <a:alpha val="100000"/>
+                      <a:srgbClr val="FFFFFF">
+                        <a:alpha val="0"/>
                       </a:srgbClr>
                     </a:solidFill>
                   </a:tcPr>
@@ -11472,8 +11759,8 @@
                       <a:prstDash val="solid"/>
                     </a:lnB>
                     <a:solidFill>
-                      <a:srgbClr val="F4F8FB">
-                        <a:alpha val="100000"/>
+                      <a:srgbClr val="FFFFFF">
+                        <a:alpha val="0"/>
                       </a:srgbClr>
                     </a:solidFill>
                   </a:tcPr>
@@ -11529,8 +11816,8 @@
                       <a:prstDash val="solid"/>
                     </a:lnB>
                     <a:solidFill>
-                      <a:srgbClr val="F4F8FB">
-                        <a:alpha val="100000"/>
+                      <a:srgbClr val="FFFFFF">
+                        <a:alpha val="0"/>
                       </a:srgbClr>
                     </a:solidFill>
                   </a:tcPr>
@@ -11586,8 +11873,8 @@
                       <a:prstDash val="solid"/>
                     </a:lnB>
                     <a:solidFill>
-                      <a:srgbClr val="F4F8FB">
-                        <a:alpha val="100000"/>
+                      <a:srgbClr val="FFFFFF">
+                        <a:alpha val="0"/>
                       </a:srgbClr>
                     </a:solidFill>
                   </a:tcPr>
@@ -11645,8 +11932,8 @@
                       <a:prstDash val="solid"/>
                     </a:lnB>
                     <a:solidFill>
-                      <a:srgbClr val="FFFFFF">
-                        <a:alpha val="0"/>
+                      <a:srgbClr val="F4F8FB">
+                        <a:alpha val="100000"/>
                       </a:srgbClr>
                     </a:solidFill>
                   </a:tcPr>
@@ -11702,8 +11989,8 @@
                       <a:prstDash val="solid"/>
                     </a:lnB>
                     <a:solidFill>
-                      <a:srgbClr val="FFFFFF">
-                        <a:alpha val="0"/>
+                      <a:srgbClr val="F4F8FB">
+                        <a:alpha val="100000"/>
                       </a:srgbClr>
                     </a:solidFill>
                   </a:tcPr>
@@ -11759,8 +12046,8 @@
                       <a:prstDash val="solid"/>
                     </a:lnB>
                     <a:solidFill>
-                      <a:srgbClr val="FFFFFF">
-                        <a:alpha val="0"/>
+                      <a:srgbClr val="F4F8FB">
+                        <a:alpha val="100000"/>
                       </a:srgbClr>
                     </a:solidFill>
                   </a:tcPr>
@@ -11816,8 +12103,8 @@
                       <a:prstDash val="solid"/>
                     </a:lnB>
                     <a:solidFill>
-                      <a:srgbClr val="FFFFFF">
-                        <a:alpha val="0"/>
+                      <a:srgbClr val="F4F8FB">
+                        <a:alpha val="100000"/>
                       </a:srgbClr>
                     </a:solidFill>
                   </a:tcPr>
@@ -11873,8 +12160,8 @@
                       <a:prstDash val="solid"/>
                     </a:lnB>
                     <a:solidFill>
-                      <a:srgbClr val="FFFFFF">
-                        <a:alpha val="0"/>
+                      <a:srgbClr val="F4F8FB">
+                        <a:alpha val="100000"/>
                       </a:srgbClr>
                     </a:solidFill>
                   </a:tcPr>
@@ -11932,8 +12219,8 @@
                       <a:prstDash val="solid"/>
                     </a:lnB>
                     <a:solidFill>
-                      <a:srgbClr val="F4F8FB">
-                        <a:alpha val="100000"/>
+                      <a:srgbClr val="FFFFFF">
+                        <a:alpha val="0"/>
                       </a:srgbClr>
                     </a:solidFill>
                   </a:tcPr>
@@ -11989,8 +12276,8 @@
                       <a:prstDash val="solid"/>
                     </a:lnB>
                     <a:solidFill>
-                      <a:srgbClr val="F4F8FB">
-                        <a:alpha val="100000"/>
+                      <a:srgbClr val="FFFFFF">
+                        <a:alpha val="0"/>
                       </a:srgbClr>
                     </a:solidFill>
                   </a:tcPr>
@@ -12046,8 +12333,8 @@
                       <a:prstDash val="solid"/>
                     </a:lnB>
                     <a:solidFill>
-                      <a:srgbClr val="F4F8FB">
-                        <a:alpha val="100000"/>
+                      <a:srgbClr val="FFFFFF">
+                        <a:alpha val="0"/>
                       </a:srgbClr>
                     </a:solidFill>
                   </a:tcPr>
@@ -12103,8 +12390,8 @@
                       <a:prstDash val="solid"/>
                     </a:lnB>
                     <a:solidFill>
-                      <a:srgbClr val="F4F8FB">
-                        <a:alpha val="100000"/>
+                      <a:srgbClr val="FFFFFF">
+                        <a:alpha val="0"/>
                       </a:srgbClr>
                     </a:solidFill>
                   </a:tcPr>
@@ -12160,8 +12447,8 @@
                       <a:prstDash val="solid"/>
                     </a:lnB>
                     <a:solidFill>
-                      <a:srgbClr val="F4F8FB">
-                        <a:alpha val="100000"/>
+                      <a:srgbClr val="FFFFFF">
+                        <a:alpha val="0"/>
                       </a:srgbClr>
                     </a:solidFill>
                   </a:tcPr>
@@ -12219,8 +12506,8 @@
                       <a:prstDash val="solid"/>
                     </a:lnB>
                     <a:solidFill>
-                      <a:srgbClr val="FFFFFF">
-                        <a:alpha val="0"/>
+                      <a:srgbClr val="F4F8FB">
+                        <a:alpha val="100000"/>
                       </a:srgbClr>
                     </a:solidFill>
                   </a:tcPr>
@@ -12276,8 +12563,8 @@
                       <a:prstDash val="solid"/>
                     </a:lnB>
                     <a:solidFill>
-                      <a:srgbClr val="FFFFFF">
-                        <a:alpha val="0"/>
+                      <a:srgbClr val="F4F8FB">
+                        <a:alpha val="100000"/>
                       </a:srgbClr>
                     </a:solidFill>
                   </a:tcPr>
@@ -12333,8 +12620,8 @@
                       <a:prstDash val="solid"/>
                     </a:lnB>
                     <a:solidFill>
-                      <a:srgbClr val="FFFFFF">
-                        <a:alpha val="0"/>
+                      <a:srgbClr val="F4F8FB">
+                        <a:alpha val="100000"/>
                       </a:srgbClr>
                     </a:solidFill>
                   </a:tcPr>
@@ -12390,8 +12677,8 @@
                       <a:prstDash val="solid"/>
                     </a:lnB>
                     <a:solidFill>
-                      <a:srgbClr val="FFFFFF">
-                        <a:alpha val="0"/>
+                      <a:srgbClr val="F4F8FB">
+                        <a:alpha val="100000"/>
                       </a:srgbClr>
                     </a:solidFill>
                   </a:tcPr>
@@ -12447,8 +12734,8 @@
                       <a:prstDash val="solid"/>
                     </a:lnB>
                     <a:solidFill>
-                      <a:srgbClr val="FFFFFF">
-                        <a:alpha val="0"/>
+                      <a:srgbClr val="F4F8FB">
+                        <a:alpha val="100000"/>
                       </a:srgbClr>
                     </a:solidFill>
                   </a:tcPr>
@@ -12506,8 +12793,8 @@
                       <a:prstDash val="solid"/>
                     </a:lnB>
                     <a:solidFill>
-                      <a:srgbClr val="F4F8FB">
-                        <a:alpha val="100000"/>
+                      <a:srgbClr val="FFFFFF">
+                        <a:alpha val="0"/>
                       </a:srgbClr>
                     </a:solidFill>
                   </a:tcPr>
@@ -12563,8 +12850,8 @@
                       <a:prstDash val="solid"/>
                     </a:lnB>
                     <a:solidFill>
-                      <a:srgbClr val="F4F8FB">
-                        <a:alpha val="100000"/>
+                      <a:srgbClr val="FFFFFF">
+                        <a:alpha val="0"/>
                       </a:srgbClr>
                     </a:solidFill>
                   </a:tcPr>
@@ -12620,8 +12907,8 @@
                       <a:prstDash val="solid"/>
                     </a:lnB>
                     <a:solidFill>
-                      <a:srgbClr val="F4F8FB">
-                        <a:alpha val="100000"/>
+                      <a:srgbClr val="FFFFFF">
+                        <a:alpha val="0"/>
                       </a:srgbClr>
                     </a:solidFill>
                   </a:tcPr>
@@ -12677,8 +12964,8 @@
                       <a:prstDash val="solid"/>
                     </a:lnB>
                     <a:solidFill>
-                      <a:srgbClr val="F4F8FB">
-                        <a:alpha val="100000"/>
+                      <a:srgbClr val="FFFFFF">
+                        <a:alpha val="0"/>
                       </a:srgbClr>
                     </a:solidFill>
                   </a:tcPr>
@@ -12734,8 +13021,8 @@
                       <a:prstDash val="solid"/>
                     </a:lnB>
                     <a:solidFill>
-                      <a:srgbClr val="F4F8FB">
-                        <a:alpha val="100000"/>
+                      <a:srgbClr val="FFFFFF">
+                        <a:alpha val="0"/>
                       </a:srgbClr>
                     </a:solidFill>
                   </a:tcPr>
@@ -12793,8 +13080,8 @@
                       <a:prstDash val="solid"/>
                     </a:lnB>
                     <a:solidFill>
-                      <a:srgbClr val="FFFFFF">
-                        <a:alpha val="0"/>
+                      <a:srgbClr val="F4F8FB">
+                        <a:alpha val="100000"/>
                       </a:srgbClr>
                     </a:solidFill>
                   </a:tcPr>
@@ -12850,8 +13137,8 @@
                       <a:prstDash val="solid"/>
                     </a:lnB>
                     <a:solidFill>
-                      <a:srgbClr val="FFFFFF">
-                        <a:alpha val="0"/>
+                      <a:srgbClr val="F4F8FB">
+                        <a:alpha val="100000"/>
                       </a:srgbClr>
                     </a:solidFill>
                   </a:tcPr>
@@ -12907,8 +13194,8 @@
                       <a:prstDash val="solid"/>
                     </a:lnB>
                     <a:solidFill>
-                      <a:srgbClr val="FFFFFF">
-                        <a:alpha val="0"/>
+                      <a:srgbClr val="F4F8FB">
+                        <a:alpha val="100000"/>
                       </a:srgbClr>
                     </a:solidFill>
                   </a:tcPr>
@@ -12964,8 +13251,8 @@
                       <a:prstDash val="solid"/>
                     </a:lnB>
                     <a:solidFill>
-                      <a:srgbClr val="FFFFFF">
-                        <a:alpha val="0"/>
+                      <a:srgbClr val="F4F8FB">
+                        <a:alpha val="100000"/>
                       </a:srgbClr>
                     </a:solidFill>
                   </a:tcPr>
@@ -13021,8 +13308,8 @@
                       <a:prstDash val="solid"/>
                     </a:lnB>
                     <a:solidFill>
-                      <a:srgbClr val="FFFFFF">
-                        <a:alpha val="0"/>
+                      <a:srgbClr val="F4F8FB">
+                        <a:alpha val="100000"/>
                       </a:srgbClr>
                     </a:solidFill>
                   </a:tcPr>
@@ -13080,8 +13367,8 @@
                       <a:prstDash val="solid"/>
                     </a:lnB>
                     <a:solidFill>
-                      <a:srgbClr val="F4F8FB">
-                        <a:alpha val="100000"/>
+                      <a:srgbClr val="FFFFFF">
+                        <a:alpha val="0"/>
                       </a:srgbClr>
                     </a:solidFill>
                   </a:tcPr>
@@ -13137,8 +13424,8 @@
                       <a:prstDash val="solid"/>
                     </a:lnB>
                     <a:solidFill>
-                      <a:srgbClr val="F4F8FB">
-                        <a:alpha val="100000"/>
+                      <a:srgbClr val="FFFFFF">
+                        <a:alpha val="0"/>
                       </a:srgbClr>
                     </a:solidFill>
                   </a:tcPr>
@@ -13194,8 +13481,8 @@
                       <a:prstDash val="solid"/>
                     </a:lnB>
                     <a:solidFill>
-                      <a:srgbClr val="F4F8FB">
-                        <a:alpha val="100000"/>
+                      <a:srgbClr val="FFFFFF">
+                        <a:alpha val="0"/>
                       </a:srgbClr>
                     </a:solidFill>
                   </a:tcPr>
@@ -13251,8 +13538,8 @@
                       <a:prstDash val="solid"/>
                     </a:lnB>
                     <a:solidFill>
-                      <a:srgbClr val="F4F8FB">
-                        <a:alpha val="100000"/>
+                      <a:srgbClr val="FFFFFF">
+                        <a:alpha val="0"/>
                       </a:srgbClr>
                     </a:solidFill>
                   </a:tcPr>
@@ -13308,8 +13595,8 @@
                       <a:prstDash val="solid"/>
                     </a:lnB>
                     <a:solidFill>
-                      <a:srgbClr val="F4F8FB">
-                        <a:alpha val="100000"/>
+                      <a:srgbClr val="FFFFFF">
+                        <a:alpha val="0"/>
                       </a:srgbClr>
                     </a:solidFill>
                   </a:tcPr>
@@ -13367,8 +13654,8 @@
                       <a:prstDash val="solid"/>
                     </a:lnB>
                     <a:solidFill>
-                      <a:srgbClr val="FFFFFF">
-                        <a:alpha val="0"/>
+                      <a:srgbClr val="F4F8FB">
+                        <a:alpha val="100000"/>
                       </a:srgbClr>
                     </a:solidFill>
                   </a:tcPr>
@@ -13424,8 +13711,8 @@
                       <a:prstDash val="solid"/>
                     </a:lnB>
                     <a:solidFill>
-                      <a:srgbClr val="FFFFFF">
-                        <a:alpha val="0"/>
+                      <a:srgbClr val="F4F8FB">
+                        <a:alpha val="100000"/>
                       </a:srgbClr>
                     </a:solidFill>
                   </a:tcPr>
@@ -13481,8 +13768,8 @@
                       <a:prstDash val="solid"/>
                     </a:lnB>
                     <a:solidFill>
-                      <a:srgbClr val="FFFFFF">
-                        <a:alpha val="0"/>
+                      <a:srgbClr val="F4F8FB">
+                        <a:alpha val="100000"/>
                       </a:srgbClr>
                     </a:solidFill>
                   </a:tcPr>
@@ -13538,8 +13825,8 @@
                       <a:prstDash val="solid"/>
                     </a:lnB>
                     <a:solidFill>
-                      <a:srgbClr val="FFFFFF">
-                        <a:alpha val="0"/>
+                      <a:srgbClr val="F4F8FB">
+                        <a:alpha val="100000"/>
                       </a:srgbClr>
                     </a:solidFill>
                   </a:tcPr>
@@ -13595,8 +13882,8 @@
                       <a:prstDash val="solid"/>
                     </a:lnB>
                     <a:solidFill>
-                      <a:srgbClr val="FFFFFF">
-                        <a:alpha val="0"/>
+                      <a:srgbClr val="F4F8FB">
+                        <a:alpha val="100000"/>
                       </a:srgbClr>
                     </a:solidFill>
                   </a:tcPr>
@@ -13654,8 +13941,8 @@
                       <a:prstDash val="solid"/>
                     </a:lnB>
                     <a:solidFill>
-                      <a:srgbClr val="F4F8FB">
-                        <a:alpha val="100000"/>
+                      <a:srgbClr val="FFFFFF">
+                        <a:alpha val="0"/>
                       </a:srgbClr>
                     </a:solidFill>
                   </a:tcPr>
@@ -13711,8 +13998,8 @@
                       <a:prstDash val="solid"/>
                     </a:lnB>
                     <a:solidFill>
-                      <a:srgbClr val="F4F8FB">
-                        <a:alpha val="100000"/>
+                      <a:srgbClr val="FFFFFF">
+                        <a:alpha val="0"/>
                       </a:srgbClr>
                     </a:solidFill>
                   </a:tcPr>
@@ -13768,8 +14055,8 @@
                       <a:prstDash val="solid"/>
                     </a:lnB>
                     <a:solidFill>
-                      <a:srgbClr val="F4F8FB">
-                        <a:alpha val="100000"/>
+                      <a:srgbClr val="FFFFFF">
+                        <a:alpha val="0"/>
                       </a:srgbClr>
                     </a:solidFill>
                   </a:tcPr>
@@ -13825,8 +14112,8 @@
                       <a:prstDash val="solid"/>
                     </a:lnB>
                     <a:solidFill>
-                      <a:srgbClr val="F4F8FB">
-                        <a:alpha val="100000"/>
+                      <a:srgbClr val="FFFFFF">
+                        <a:alpha val="0"/>
                       </a:srgbClr>
                     </a:solidFill>
                   </a:tcPr>
@@ -13882,14 +14169,14 @@
                       <a:prstDash val="solid"/>
                     </a:lnB>
                     <a:solidFill>
-                      <a:srgbClr val="F4F8FB">
-                        <a:alpha val="100000"/>
+                      <a:srgbClr val="FFFFFF">
+                        <a:alpha val="0"/>
                       </a:srgbClr>
                     </a:solidFill>
                   </a:tcPr>
                 </a:tc>
               </a:tr>
-              <a:tr h="401320">
+              <a:tr h="410845">
                 <a:tc>
                   <a:txBody>
                     <a:bodyPr/>
@@ -13936,13 +14223,17 @@
                       <a:noFill/>
                       <a:prstDash val="solid"/>
                     </a:lnT>
-                    <a:lnB algn="ctr" cmpd="sng" cap="flat" w="0">
-                      <a:noFill/>
+                    <a:lnB algn="ctr" cmpd="sng" cap="flat" w="19050">
+                      <a:solidFill>
+                        <a:srgbClr val="666666">
+                          <a:alpha val="100000"/>
+                        </a:srgbClr>
+                      </a:solidFill>
                       <a:prstDash val="solid"/>
                     </a:lnB>
                     <a:solidFill>
-                      <a:srgbClr val="FFFFFF">
-                        <a:alpha val="0"/>
+                      <a:srgbClr val="F4F8FB">
+                        <a:alpha val="100000"/>
                       </a:srgbClr>
                     </a:solidFill>
                   </a:tcPr>
@@ -13993,13 +14284,17 @@
                       <a:noFill/>
                       <a:prstDash val="solid"/>
                     </a:lnT>
-                    <a:lnB algn="ctr" cmpd="sng" cap="flat" w="0">
-                      <a:noFill/>
+                    <a:lnB algn="ctr" cmpd="sng" cap="flat" w="19050">
+                      <a:solidFill>
+                        <a:srgbClr val="666666">
+                          <a:alpha val="100000"/>
+                        </a:srgbClr>
+                      </a:solidFill>
                       <a:prstDash val="solid"/>
                     </a:lnB>
                     <a:solidFill>
-                      <a:srgbClr val="FFFFFF">
-                        <a:alpha val="0"/>
+                      <a:srgbClr val="F4F8FB">
+                        <a:alpha val="100000"/>
                       </a:srgbClr>
                     </a:solidFill>
                   </a:tcPr>
@@ -14050,13 +14345,17 @@
                       <a:noFill/>
                       <a:prstDash val="solid"/>
                     </a:lnT>
-                    <a:lnB algn="ctr" cmpd="sng" cap="flat" w="0">
-                      <a:noFill/>
+                    <a:lnB algn="ctr" cmpd="sng" cap="flat" w="19050">
+                      <a:solidFill>
+                        <a:srgbClr val="666666">
+                          <a:alpha val="100000"/>
+                        </a:srgbClr>
+                      </a:solidFill>
                       <a:prstDash val="solid"/>
                     </a:lnB>
                     <a:solidFill>
-                      <a:srgbClr val="FFFFFF">
-                        <a:alpha val="0"/>
+                      <a:srgbClr val="F4F8FB">
+                        <a:alpha val="100000"/>
                       </a:srgbClr>
                     </a:solidFill>
                   </a:tcPr>
@@ -14107,122 +14406,6 @@
                       <a:noFill/>
                       <a:prstDash val="solid"/>
                     </a:lnT>
-                    <a:lnB algn="ctr" cmpd="sng" cap="flat" w="0">
-                      <a:noFill/>
-                      <a:prstDash val="solid"/>
-                    </a:lnB>
-                    <a:solidFill>
-                      <a:srgbClr val="FFFFFF">
-                        <a:alpha val="0"/>
-                      </a:srgbClr>
-                    </a:solidFill>
-                  </a:tcPr>
-                </a:tc>
-                <a:tc>
-                  <a:txBody>
-                    <a:bodyPr/>
-                    <a:lstStyle/>
-                    <a:p>
-                      <a:pPr algn="l" marL="63500" marR="63500">
-                        <a:lnSpc>
-                          <a:spcPct val="100000"/>
-                        </a:lnSpc>
-                        <a:spcBef>
-                          <a:spcPts val="500"/>
-                        </a:spcBef>
-                        <a:spcAft>
-                          <a:spcPts val="500"/>
-                        </a:spcAft>
-                        <a:buNone/>
-                      </a:pPr>
-                      <a:r>
-                        <a:rPr cap="none" sz="1200" i="0" b="0" u="none" strike="noStrike">
-                          <a:solidFill>
-                            <a:srgbClr val="5B6770">
-                              <a:alpha val="100000"/>
-                            </a:srgbClr>
-                          </a:solidFill>
-                          <a:latin typeface="Helvetica Neue"/>
-                          <a:cs typeface="Helvetica Neue"/>
-                          <a:ea typeface="Helvetica Neue"/>
-                          <a:sym typeface="Helvetica Neue"/>
-                        </a:rPr>
-                        <a:t>605808</a:t>
-                      </a:r>
-                    </a:p>
-                  </a:txBody>
-                  <a:tcPr anchor="ctr" marB="63500" marT="63500" marR="0" marL="0">
-                    <a:lnL algn="ctr" cmpd="sng" cap="flat" w="0">
-                      <a:noFill/>
-                      <a:prstDash val="solid"/>
-                    </a:lnL>
-                    <a:lnR algn="ctr" cmpd="sng" cap="flat" w="0">
-                      <a:noFill/>
-                      <a:prstDash val="solid"/>
-                    </a:lnR>
-                    <a:lnT algn="ctr" cmpd="sng" cap="flat" w="0">
-                      <a:noFill/>
-                      <a:prstDash val="solid"/>
-                    </a:lnT>
-                    <a:lnB algn="ctr" cmpd="sng" cap="flat" w="0">
-                      <a:noFill/>
-                      <a:prstDash val="solid"/>
-                    </a:lnB>
-                    <a:solidFill>
-                      <a:srgbClr val="FFFFFF">
-                        <a:alpha val="0"/>
-                      </a:srgbClr>
-                    </a:solidFill>
-                  </a:tcPr>
-                </a:tc>
-              </a:tr>
-              <a:tr h="410845">
-                <a:tc>
-                  <a:txBody>
-                    <a:bodyPr/>
-                    <a:lstStyle/>
-                    <a:p>
-                      <a:pPr algn="l" marL="63500" marR="63500">
-                        <a:lnSpc>
-                          <a:spcPct val="100000"/>
-                        </a:lnSpc>
-                        <a:spcBef>
-                          <a:spcPts val="500"/>
-                        </a:spcBef>
-                        <a:spcAft>
-                          <a:spcPts val="500"/>
-                        </a:spcAft>
-                        <a:buNone/>
-                      </a:pPr>
-                      <a:r>
-                        <a:rPr cap="none" sz="1200" i="0" b="0" u="none" strike="noStrike">
-                          <a:solidFill>
-                            <a:srgbClr val="5B6770">
-                              <a:alpha val="100000"/>
-                            </a:srgbClr>
-                          </a:solidFill>
-                          <a:latin typeface="Helvetica Neue"/>
-                          <a:cs typeface="Helvetica Neue"/>
-                          <a:ea typeface="Helvetica Neue"/>
-                          <a:sym typeface="Helvetica Neue"/>
-                        </a:rPr>
-                        <a:t>antipyrine</a:t>
-                      </a:r>
-                    </a:p>
-                  </a:txBody>
-                  <a:tcPr anchor="ctr" marB="63500" marT="63500" marR="0" marL="0">
-                    <a:lnL algn="ctr" cmpd="sng" cap="flat" w="0">
-                      <a:noFill/>
-                      <a:prstDash val="solid"/>
-                    </a:lnL>
-                    <a:lnR algn="ctr" cmpd="sng" cap="flat" w="0">
-                      <a:noFill/>
-                      <a:prstDash val="solid"/>
-                    </a:lnR>
-                    <a:lnT algn="ctr" cmpd="sng" cap="flat" w="0">
-                      <a:noFill/>
-                      <a:prstDash val="solid"/>
-                    </a:lnT>
                     <a:lnB algn="ctr" cmpd="sng" cap="flat" w="19050">
                       <a:solidFill>
                         <a:srgbClr val="666666">
@@ -14267,190 +14450,7 @@
                           <a:ea typeface="Helvetica Neue"/>
                           <a:sym typeface="Helvetica Neue"/>
                         </a:rPr>
-                        <a:t>28 Jul 2026</a:t>
-                      </a:r>
-                    </a:p>
-                  </a:txBody>
-                  <a:tcPr anchor="ctr" marB="63500" marT="63500" marR="0" marL="0">
-                    <a:lnL algn="ctr" cmpd="sng" cap="flat" w="0">
-                      <a:noFill/>
-                      <a:prstDash val="solid"/>
-                    </a:lnL>
-                    <a:lnR algn="ctr" cmpd="sng" cap="flat" w="0">
-                      <a:noFill/>
-                      <a:prstDash val="solid"/>
-                    </a:lnR>
-                    <a:lnT algn="ctr" cmpd="sng" cap="flat" w="0">
-                      <a:noFill/>
-                      <a:prstDash val="solid"/>
-                    </a:lnT>
-                    <a:lnB algn="ctr" cmpd="sng" cap="flat" w="19050">
-                      <a:solidFill>
-                        <a:srgbClr val="666666">
-                          <a:alpha val="100000"/>
-                        </a:srgbClr>
-                      </a:solidFill>
-                      <a:prstDash val="solid"/>
-                    </a:lnB>
-                    <a:solidFill>
-                      <a:srgbClr val="F4F8FB">
-                        <a:alpha val="100000"/>
-                      </a:srgbClr>
-                    </a:solidFill>
-                  </a:tcPr>
-                </a:tc>
-                <a:tc>
-                  <a:txBody>
-                    <a:bodyPr/>
-                    <a:lstStyle/>
-                    <a:p>
-                      <a:pPr algn="l" marL="63500" marR="63500">
-                        <a:lnSpc>
-                          <a:spcPct val="100000"/>
-                        </a:lnSpc>
-                        <a:spcBef>
-                          <a:spcPts val="500"/>
-                        </a:spcBef>
-                        <a:spcAft>
-                          <a:spcPts val="500"/>
-                        </a:spcAft>
-                        <a:buNone/>
-                      </a:pPr>
-                      <a:r>
-                        <a:rPr cap="none" sz="1200" i="0" b="0" u="none" strike="noStrike">
-                          <a:solidFill>
-                            <a:srgbClr val="5B6770">
-                              <a:alpha val="100000"/>
-                            </a:srgbClr>
-                          </a:solidFill>
-                          <a:latin typeface="Helvetica Neue"/>
-                          <a:cs typeface="Helvetica Neue"/>
-                          <a:ea typeface="Helvetica Neue"/>
-                          <a:sym typeface="Helvetica Neue"/>
-                        </a:rPr>
-                        <a:t>primary</a:t>
-                      </a:r>
-                    </a:p>
-                  </a:txBody>
-                  <a:tcPr anchor="ctr" marB="63500" marT="63500" marR="0" marL="0">
-                    <a:lnL algn="ctr" cmpd="sng" cap="flat" w="0">
-                      <a:noFill/>
-                      <a:prstDash val="solid"/>
-                    </a:lnL>
-                    <a:lnR algn="ctr" cmpd="sng" cap="flat" w="0">
-                      <a:noFill/>
-                      <a:prstDash val="solid"/>
-                    </a:lnR>
-                    <a:lnT algn="ctr" cmpd="sng" cap="flat" w="0">
-                      <a:noFill/>
-                      <a:prstDash val="solid"/>
-                    </a:lnT>
-                    <a:lnB algn="ctr" cmpd="sng" cap="flat" w="19050">
-                      <a:solidFill>
-                        <a:srgbClr val="666666">
-                          <a:alpha val="100000"/>
-                        </a:srgbClr>
-                      </a:solidFill>
-                      <a:prstDash val="solid"/>
-                    </a:lnB>
-                    <a:solidFill>
-                      <a:srgbClr val="F4F8FB">
-                        <a:alpha val="100000"/>
-                      </a:srgbClr>
-                    </a:solidFill>
-                  </a:tcPr>
-                </a:tc>
-                <a:tc>
-                  <a:txBody>
-                    <a:bodyPr/>
-                    <a:lstStyle/>
-                    <a:p>
-                      <a:pPr algn="r" marL="63500" marR="63500">
-                        <a:lnSpc>
-                          <a:spcPct val="100000"/>
-                        </a:lnSpc>
-                        <a:spcBef>
-                          <a:spcPts val="500"/>
-                        </a:spcBef>
-                        <a:spcAft>
-                          <a:spcPts val="500"/>
-                        </a:spcAft>
-                        <a:buNone/>
-                      </a:pPr>
-                      <a:r>
-                        <a:rPr cap="none" sz="1200" i="0" b="0" u="none" strike="noStrike">
-                          <a:solidFill>
-                            <a:srgbClr val="5B6770">
-                              <a:alpha val="100000"/>
-                            </a:srgbClr>
-                          </a:solidFill>
-                          <a:latin typeface="Helvetica Neue"/>
-                          <a:cs typeface="Helvetica Neue"/>
-                          <a:ea typeface="Helvetica Neue"/>
-                          <a:sym typeface="Helvetica Neue"/>
-                        </a:rPr>
-                        <a:t>1</a:t>
-                      </a:r>
-                    </a:p>
-                  </a:txBody>
-                  <a:tcPr anchor="ctr" marB="63500" marT="63500" marR="0" marL="0">
-                    <a:lnL algn="ctr" cmpd="sng" cap="flat" w="0">
-                      <a:noFill/>
-                      <a:prstDash val="solid"/>
-                    </a:lnL>
-                    <a:lnR algn="ctr" cmpd="sng" cap="flat" w="0">
-                      <a:noFill/>
-                      <a:prstDash val="solid"/>
-                    </a:lnR>
-                    <a:lnT algn="ctr" cmpd="sng" cap="flat" w="0">
-                      <a:noFill/>
-                      <a:prstDash val="solid"/>
-                    </a:lnT>
-                    <a:lnB algn="ctr" cmpd="sng" cap="flat" w="19050">
-                      <a:solidFill>
-                        <a:srgbClr val="666666">
-                          <a:alpha val="100000"/>
-                        </a:srgbClr>
-                      </a:solidFill>
-                      <a:prstDash val="solid"/>
-                    </a:lnB>
-                    <a:solidFill>
-                      <a:srgbClr val="F4F8FB">
-                        <a:alpha val="100000"/>
-                      </a:srgbClr>
-                    </a:solidFill>
-                  </a:tcPr>
-                </a:tc>
-                <a:tc>
-                  <a:txBody>
-                    <a:bodyPr/>
-                    <a:lstStyle/>
-                    <a:p>
-                      <a:pPr algn="l" marL="63500" marR="63500">
-                        <a:lnSpc>
-                          <a:spcPct val="100000"/>
-                        </a:lnSpc>
-                        <a:spcBef>
-                          <a:spcPts val="500"/>
-                        </a:spcBef>
-                        <a:spcAft>
-                          <a:spcPts val="500"/>
-                        </a:spcAft>
-                        <a:buNone/>
-                      </a:pPr>
-                      <a:r>
-                        <a:rPr cap="none" sz="1200" i="0" b="0" u="none" strike="noStrike">
-                          <a:solidFill>
-                            <a:srgbClr val="5B6770">
-                              <a:alpha val="100000"/>
-                            </a:srgbClr>
-                          </a:solidFill>
-                          <a:latin typeface="Helvetica Neue"/>
-                          <a:cs typeface="Helvetica Neue"/>
-                          <a:ea typeface="Helvetica Neue"/>
-                          <a:sym typeface="Helvetica Neue"/>
-                        </a:rPr>
-                        <a:t>605809</a:t>
+                        <a:t>605808</a:t>
                       </a:r>
                     </a:p>
                   </a:txBody>
@@ -18510,7 +18510,7 @@
                           <a:ea typeface="Helvetica Neue"/>
                           <a:sym typeface="Helvetica Neue"/>
                         </a:rPr>
-                        <a:t>1,539</a:t>
+                        <a:t>1,543</a:t>
                       </a:r>
                     </a:p>
                   </a:txBody>
@@ -20591,7 +20591,7 @@
                           <a:ea typeface="Helvetica Neue"/>
                           <a:sym typeface="Helvetica Neue"/>
                         </a:rPr>
-                        <a:t>1,786</a:t>
+                        <a:t>1,790</a:t>
                       </a:r>
                     </a:p>
                   </a:txBody>
@@ -24942,6 +24942,293 @@
                           <a:ea typeface="Helvetica Neue"/>
                           <a:sym typeface="Helvetica Neue"/>
                         </a:rPr>
+                        <a:t>clonidine</a:t>
+                      </a:r>
+                    </a:p>
+                  </a:txBody>
+                  <a:tcPr anchor="ctr" marB="63500" marT="63500" marR="0" marL="0">
+                    <a:lnL algn="ctr" cmpd="sng" cap="flat" w="0">
+                      <a:noFill/>
+                      <a:prstDash val="solid"/>
+                    </a:lnL>
+                    <a:lnR algn="ctr" cmpd="sng" cap="flat" w="0">
+                      <a:noFill/>
+                      <a:prstDash val="solid"/>
+                    </a:lnR>
+                    <a:lnT algn="ctr" cmpd="sng" cap="flat" w="0">
+                      <a:noFill/>
+                      <a:prstDash val="solid"/>
+                    </a:lnT>
+                    <a:lnB algn="ctr" cmpd="sng" cap="flat" w="0">
+                      <a:noFill/>
+                      <a:prstDash val="solid"/>
+                    </a:lnB>
+                    <a:solidFill>
+                      <a:srgbClr val="FFFFFF">
+                        <a:alpha val="0"/>
+                      </a:srgbClr>
+                    </a:solidFill>
+                  </a:tcPr>
+                </a:tc>
+                <a:tc>
+                  <a:txBody>
+                    <a:bodyPr/>
+                    <a:lstStyle/>
+                    <a:p>
+                      <a:pPr algn="l" marL="63500" marR="63500">
+                        <a:lnSpc>
+                          <a:spcPct val="100000"/>
+                        </a:lnSpc>
+                        <a:spcBef>
+                          <a:spcPts val="500"/>
+                        </a:spcBef>
+                        <a:spcAft>
+                          <a:spcPts val="500"/>
+                        </a:spcAft>
+                        <a:buNone/>
+                      </a:pPr>
+                      <a:r>
+                        <a:rPr cap="none" sz="1200" i="0" b="0" u="none" strike="noStrike">
+                          <a:solidFill>
+                            <a:srgbClr val="5B6770">
+                              <a:alpha val="100000"/>
+                            </a:srgbClr>
+                          </a:solidFill>
+                          <a:latin typeface="Helvetica Neue"/>
+                          <a:cs typeface="Helvetica Neue"/>
+                          <a:ea typeface="Helvetica Neue"/>
+                          <a:sym typeface="Helvetica Neue"/>
+                        </a:rPr>
+                        <a:t>16 Oct 2026</a:t>
+                      </a:r>
+                    </a:p>
+                  </a:txBody>
+                  <a:tcPr anchor="ctr" marB="63500" marT="63500" marR="0" marL="0">
+                    <a:lnL algn="ctr" cmpd="sng" cap="flat" w="0">
+                      <a:noFill/>
+                      <a:prstDash val="solid"/>
+                    </a:lnL>
+                    <a:lnR algn="ctr" cmpd="sng" cap="flat" w="0">
+                      <a:noFill/>
+                      <a:prstDash val="solid"/>
+                    </a:lnR>
+                    <a:lnT algn="ctr" cmpd="sng" cap="flat" w="0">
+                      <a:noFill/>
+                      <a:prstDash val="solid"/>
+                    </a:lnT>
+                    <a:lnB algn="ctr" cmpd="sng" cap="flat" w="0">
+                      <a:noFill/>
+                      <a:prstDash val="solid"/>
+                    </a:lnB>
+                    <a:solidFill>
+                      <a:srgbClr val="FFFFFF">
+                        <a:alpha val="0"/>
+                      </a:srgbClr>
+                    </a:solidFill>
+                  </a:tcPr>
+                </a:tc>
+                <a:tc>
+                  <a:txBody>
+                    <a:bodyPr/>
+                    <a:lstStyle/>
+                    <a:p>
+                      <a:pPr algn="l" marL="63500" marR="63500">
+                        <a:lnSpc>
+                          <a:spcPct val="100000"/>
+                        </a:lnSpc>
+                        <a:spcBef>
+                          <a:spcPts val="500"/>
+                        </a:spcBef>
+                        <a:spcAft>
+                          <a:spcPts val="500"/>
+                        </a:spcAft>
+                        <a:buNone/>
+                      </a:pPr>
+                      <a:r>
+                        <a:rPr cap="none" sz="1200" i="0" b="0" u="none" strike="noStrike">
+                          <a:solidFill>
+                            <a:srgbClr val="5B6770">
+                              <a:alpha val="100000"/>
+                            </a:srgbClr>
+                          </a:solidFill>
+                          <a:latin typeface="Helvetica Neue"/>
+                          <a:cs typeface="Helvetica Neue"/>
+                          <a:ea typeface="Helvetica Neue"/>
+                          <a:sym typeface="Helvetica Neue"/>
+                        </a:rPr>
+                        <a:t>trace</a:t>
+                      </a:r>
+                    </a:p>
+                  </a:txBody>
+                  <a:tcPr anchor="ctr" marB="63500" marT="63500" marR="0" marL="0">
+                    <a:lnL algn="ctr" cmpd="sng" cap="flat" w="0">
+                      <a:noFill/>
+                      <a:prstDash val="solid"/>
+                    </a:lnL>
+                    <a:lnR algn="ctr" cmpd="sng" cap="flat" w="0">
+                      <a:noFill/>
+                      <a:prstDash val="solid"/>
+                    </a:lnR>
+                    <a:lnT algn="ctr" cmpd="sng" cap="flat" w="0">
+                      <a:noFill/>
+                      <a:prstDash val="solid"/>
+                    </a:lnT>
+                    <a:lnB algn="ctr" cmpd="sng" cap="flat" w="0">
+                      <a:noFill/>
+                      <a:prstDash val="solid"/>
+                    </a:lnB>
+                    <a:solidFill>
+                      <a:srgbClr val="FFFFFF">
+                        <a:alpha val="0"/>
+                      </a:srgbClr>
+                    </a:solidFill>
+                  </a:tcPr>
+                </a:tc>
+                <a:tc>
+                  <a:txBody>
+                    <a:bodyPr/>
+                    <a:lstStyle/>
+                    <a:p>
+                      <a:pPr algn="r" marL="63500" marR="63500">
+                        <a:lnSpc>
+                          <a:spcPct val="100000"/>
+                        </a:lnSpc>
+                        <a:spcBef>
+                          <a:spcPts val="500"/>
+                        </a:spcBef>
+                        <a:spcAft>
+                          <a:spcPts val="500"/>
+                        </a:spcAft>
+                        <a:buNone/>
+                      </a:pPr>
+                      <a:r>
+                        <a:rPr cap="none" sz="1200" i="0" b="0" u="none" strike="noStrike">
+                          <a:solidFill>
+                            <a:srgbClr val="5B6770">
+                              <a:alpha val="100000"/>
+                            </a:srgbClr>
+                          </a:solidFill>
+                          <a:latin typeface="Helvetica Neue"/>
+                          <a:cs typeface="Helvetica Neue"/>
+                          <a:ea typeface="Helvetica Neue"/>
+                          <a:sym typeface="Helvetica Neue"/>
+                        </a:rPr>
+                        <a:t>1</a:t>
+                      </a:r>
+                    </a:p>
+                  </a:txBody>
+                  <a:tcPr anchor="ctr" marB="63500" marT="63500" marR="0" marL="0">
+                    <a:lnL algn="ctr" cmpd="sng" cap="flat" w="0">
+                      <a:noFill/>
+                      <a:prstDash val="solid"/>
+                    </a:lnL>
+                    <a:lnR algn="ctr" cmpd="sng" cap="flat" w="0">
+                      <a:noFill/>
+                      <a:prstDash val="solid"/>
+                    </a:lnR>
+                    <a:lnT algn="ctr" cmpd="sng" cap="flat" w="0">
+                      <a:noFill/>
+                      <a:prstDash val="solid"/>
+                    </a:lnT>
+                    <a:lnB algn="ctr" cmpd="sng" cap="flat" w="0">
+                      <a:noFill/>
+                      <a:prstDash val="solid"/>
+                    </a:lnB>
+                    <a:solidFill>
+                      <a:srgbClr val="FFFFFF">
+                        <a:alpha val="0"/>
+                      </a:srgbClr>
+                    </a:solidFill>
+                  </a:tcPr>
+                </a:tc>
+                <a:tc>
+                  <a:txBody>
+                    <a:bodyPr/>
+                    <a:lstStyle/>
+                    <a:p>
+                      <a:pPr algn="l" marL="63500" marR="63500">
+                        <a:lnSpc>
+                          <a:spcPct val="100000"/>
+                        </a:lnSpc>
+                        <a:spcBef>
+                          <a:spcPts val="500"/>
+                        </a:spcBef>
+                        <a:spcAft>
+                          <a:spcPts val="500"/>
+                        </a:spcAft>
+                        <a:buNone/>
+                      </a:pPr>
+                      <a:r>
+                        <a:rPr cap="none" sz="1200" i="0" b="0" u="none" strike="noStrike">
+                          <a:solidFill>
+                            <a:srgbClr val="5B6770">
+                              <a:alpha val="100000"/>
+                            </a:srgbClr>
+                          </a:solidFill>
+                          <a:latin typeface="Helvetica Neue"/>
+                          <a:cs typeface="Helvetica Neue"/>
+                          <a:ea typeface="Helvetica Neue"/>
+                          <a:sym typeface="Helvetica Neue"/>
+                        </a:rPr>
+                        <a:t>604747</a:t>
+                      </a:r>
+                    </a:p>
+                  </a:txBody>
+                  <a:tcPr anchor="ctr" marB="63500" marT="63500" marR="0" marL="0">
+                    <a:lnL algn="ctr" cmpd="sng" cap="flat" w="0">
+                      <a:noFill/>
+                      <a:prstDash val="solid"/>
+                    </a:lnL>
+                    <a:lnR algn="ctr" cmpd="sng" cap="flat" w="0">
+                      <a:noFill/>
+                      <a:prstDash val="solid"/>
+                    </a:lnR>
+                    <a:lnT algn="ctr" cmpd="sng" cap="flat" w="0">
+                      <a:noFill/>
+                      <a:prstDash val="solid"/>
+                    </a:lnT>
+                    <a:lnB algn="ctr" cmpd="sng" cap="flat" w="0">
+                      <a:noFill/>
+                      <a:prstDash val="solid"/>
+                    </a:lnB>
+                    <a:solidFill>
+                      <a:srgbClr val="FFFFFF">
+                        <a:alpha val="0"/>
+                      </a:srgbClr>
+                    </a:solidFill>
+                  </a:tcPr>
+                </a:tc>
+              </a:tr>
+              <a:tr h="401320">
+                <a:tc>
+                  <a:txBody>
+                    <a:bodyPr/>
+                    <a:lstStyle/>
+                    <a:p>
+                      <a:pPr algn="l" marL="63500" marR="63500">
+                        <a:lnSpc>
+                          <a:spcPct val="100000"/>
+                        </a:lnSpc>
+                        <a:spcBef>
+                          <a:spcPts val="500"/>
+                        </a:spcBef>
+                        <a:spcAft>
+                          <a:spcPts val="500"/>
+                        </a:spcAft>
+                        <a:buNone/>
+                      </a:pPr>
+                      <a:r>
+                        <a:rPr cap="none" sz="1200" i="0" b="0" u="none" strike="noStrike">
+                          <a:solidFill>
+                            <a:srgbClr val="5B6770">
+                              <a:alpha val="100000"/>
+                            </a:srgbClr>
+                          </a:solidFill>
+                          <a:latin typeface="Helvetica Neue"/>
+                          <a:cs typeface="Helvetica Neue"/>
+                          <a:ea typeface="Helvetica Neue"/>
+                          <a:sym typeface="Helvetica Neue"/>
+                        </a:rPr>
                         <a:t>buspirone</a:t>
                       </a:r>
                     </a:p>
@@ -24964,8 +25251,8 @@
                       <a:prstDash val="solid"/>
                     </a:lnB>
                     <a:solidFill>
-                      <a:srgbClr val="FFFFFF">
-                        <a:alpha val="0"/>
+                      <a:srgbClr val="F4F8FB">
+                        <a:alpha val="100000"/>
                       </a:srgbClr>
                     </a:solidFill>
                   </a:tcPr>
@@ -25021,8 +25308,8 @@
                       <a:prstDash val="solid"/>
                     </a:lnB>
                     <a:solidFill>
-                      <a:srgbClr val="FFFFFF">
-                        <a:alpha val="0"/>
+                      <a:srgbClr val="F4F8FB">
+                        <a:alpha val="100000"/>
                       </a:srgbClr>
                     </a:solidFill>
                   </a:tcPr>
@@ -25078,8 +25365,8 @@
                       <a:prstDash val="solid"/>
                     </a:lnB>
                     <a:solidFill>
-                      <a:srgbClr val="FFFFFF">
-                        <a:alpha val="0"/>
+                      <a:srgbClr val="F4F8FB">
+                        <a:alpha val="100000"/>
                       </a:srgbClr>
                     </a:solidFill>
                   </a:tcPr>
@@ -25135,8 +25422,8 @@
                       <a:prstDash val="solid"/>
                     </a:lnB>
                     <a:solidFill>
-                      <a:srgbClr val="FFFFFF">
-                        <a:alpha val="0"/>
+                      <a:srgbClr val="F4F8FB">
+                        <a:alpha val="100000"/>
                       </a:srgbClr>
                     </a:solidFill>
                   </a:tcPr>
@@ -25192,8 +25479,8 @@
                       <a:prstDash val="solid"/>
                     </a:lnB>
                     <a:solidFill>
-                      <a:srgbClr val="FFFFFF">
-                        <a:alpha val="0"/>
+                      <a:srgbClr val="F4F8FB">
+                        <a:alpha val="100000"/>
                       </a:srgbClr>
                     </a:solidFill>
                   </a:tcPr>
@@ -25251,8 +25538,8 @@
                       <a:prstDash val="solid"/>
                     </a:lnB>
                     <a:solidFill>
-                      <a:srgbClr val="F4F8FB">
-                        <a:alpha val="100000"/>
+                      <a:srgbClr val="FFFFFF">
+                        <a:alpha val="0"/>
                       </a:srgbClr>
                     </a:solidFill>
                   </a:tcPr>
@@ -25308,8 +25595,8 @@
                       <a:prstDash val="solid"/>
                     </a:lnB>
                     <a:solidFill>
-                      <a:srgbClr val="F4F8FB">
-                        <a:alpha val="100000"/>
+                      <a:srgbClr val="FFFFFF">
+                        <a:alpha val="0"/>
                       </a:srgbClr>
                     </a:solidFill>
                   </a:tcPr>
@@ -25365,8 +25652,8 @@
                       <a:prstDash val="solid"/>
                     </a:lnB>
                     <a:solidFill>
-                      <a:srgbClr val="F4F8FB">
-                        <a:alpha val="100000"/>
+                      <a:srgbClr val="FFFFFF">
+                        <a:alpha val="0"/>
                       </a:srgbClr>
                     </a:solidFill>
                   </a:tcPr>
@@ -25422,8 +25709,8 @@
                       <a:prstDash val="solid"/>
                     </a:lnB>
                     <a:solidFill>
-                      <a:srgbClr val="F4F8FB">
-                        <a:alpha val="100000"/>
+                      <a:srgbClr val="FFFFFF">
+                        <a:alpha val="0"/>
                       </a:srgbClr>
                     </a:solidFill>
                   </a:tcPr>
@@ -25479,8 +25766,8 @@
                       <a:prstDash val="solid"/>
                     </a:lnB>
                     <a:solidFill>
-                      <a:srgbClr val="F4F8FB">
-                        <a:alpha val="100000"/>
+                      <a:srgbClr val="FFFFFF">
+                        <a:alpha val="0"/>
                       </a:srgbClr>
                     </a:solidFill>
                   </a:tcPr>
@@ -25538,8 +25825,8 @@
                       <a:prstDash val="solid"/>
                     </a:lnB>
                     <a:solidFill>
-                      <a:srgbClr val="FFFFFF">
-                        <a:alpha val="0"/>
+                      <a:srgbClr val="F4F8FB">
+                        <a:alpha val="100000"/>
                       </a:srgbClr>
                     </a:solidFill>
                   </a:tcPr>
@@ -25595,8 +25882,8 @@
                       <a:prstDash val="solid"/>
                     </a:lnB>
                     <a:solidFill>
-                      <a:srgbClr val="FFFFFF">
-                        <a:alpha val="0"/>
+                      <a:srgbClr val="F4F8FB">
+                        <a:alpha val="100000"/>
                       </a:srgbClr>
                     </a:solidFill>
                   </a:tcPr>
@@ -25652,8 +25939,8 @@
                       <a:prstDash val="solid"/>
                     </a:lnB>
                     <a:solidFill>
-                      <a:srgbClr val="FFFFFF">
-                        <a:alpha val="0"/>
+                      <a:srgbClr val="F4F8FB">
+                        <a:alpha val="100000"/>
                       </a:srgbClr>
                     </a:solidFill>
                   </a:tcPr>
@@ -25709,8 +25996,8 @@
                       <a:prstDash val="solid"/>
                     </a:lnB>
                     <a:solidFill>
-                      <a:srgbClr val="FFFFFF">
-                        <a:alpha val="0"/>
+                      <a:srgbClr val="F4F8FB">
+                        <a:alpha val="100000"/>
                       </a:srgbClr>
                     </a:solidFill>
                   </a:tcPr>
@@ -25766,8 +26053,8 @@
                       <a:prstDash val="solid"/>
                     </a:lnB>
                     <a:solidFill>
-                      <a:srgbClr val="FFFFFF">
-                        <a:alpha val="0"/>
+                      <a:srgbClr val="F4F8FB">
+                        <a:alpha val="100000"/>
                       </a:srgbClr>
                     </a:solidFill>
                   </a:tcPr>
@@ -25825,8 +26112,8 @@
                       <a:prstDash val="solid"/>
                     </a:lnB>
                     <a:solidFill>
-                      <a:srgbClr val="F4F8FB">
-                        <a:alpha val="100000"/>
+                      <a:srgbClr val="FFFFFF">
+                        <a:alpha val="0"/>
                       </a:srgbClr>
                     </a:solidFill>
                   </a:tcPr>
@@ -25882,8 +26169,8 @@
                       <a:prstDash val="solid"/>
                     </a:lnB>
                     <a:solidFill>
-                      <a:srgbClr val="F4F8FB">
-                        <a:alpha val="100000"/>
+                      <a:srgbClr val="FFFFFF">
+                        <a:alpha val="0"/>
                       </a:srgbClr>
                     </a:solidFill>
                   </a:tcPr>
@@ -25939,8 +26226,8 @@
                       <a:prstDash val="solid"/>
                     </a:lnB>
                     <a:solidFill>
-                      <a:srgbClr val="F4F8FB">
-                        <a:alpha val="100000"/>
+                      <a:srgbClr val="FFFFFF">
+                        <a:alpha val="0"/>
                       </a:srgbClr>
                     </a:solidFill>
                   </a:tcPr>
@@ -25996,8 +26283,8 @@
                       <a:prstDash val="solid"/>
                     </a:lnB>
                     <a:solidFill>
-                      <a:srgbClr val="F4F8FB">
-                        <a:alpha val="100000"/>
+                      <a:srgbClr val="FFFFFF">
+                        <a:alpha val="0"/>
                       </a:srgbClr>
                     </a:solidFill>
                   </a:tcPr>
@@ -26053,8 +26340,8 @@
                       <a:prstDash val="solid"/>
                     </a:lnB>
                     <a:solidFill>
-                      <a:srgbClr val="F4F8FB">
-                        <a:alpha val="100000"/>
+                      <a:srgbClr val="FFFFFF">
+                        <a:alpha val="0"/>
                       </a:srgbClr>
                     </a:solidFill>
                   </a:tcPr>
@@ -26112,8 +26399,8 @@
                       <a:prstDash val="solid"/>
                     </a:lnB>
                     <a:solidFill>
-                      <a:srgbClr val="FFFFFF">
-                        <a:alpha val="0"/>
+                      <a:srgbClr val="F4F8FB">
+                        <a:alpha val="100000"/>
                       </a:srgbClr>
                     </a:solidFill>
                   </a:tcPr>
@@ -26169,8 +26456,8 @@
                       <a:prstDash val="solid"/>
                     </a:lnB>
                     <a:solidFill>
-                      <a:srgbClr val="FFFFFF">
-                        <a:alpha val="0"/>
+                      <a:srgbClr val="F4F8FB">
+                        <a:alpha val="100000"/>
                       </a:srgbClr>
                     </a:solidFill>
                   </a:tcPr>
@@ -26226,8 +26513,8 @@
                       <a:prstDash val="solid"/>
                     </a:lnB>
                     <a:solidFill>
-                      <a:srgbClr val="FFFFFF">
-                        <a:alpha val="0"/>
+                      <a:srgbClr val="F4F8FB">
+                        <a:alpha val="100000"/>
                       </a:srgbClr>
                     </a:solidFill>
                   </a:tcPr>
@@ -26283,8 +26570,8 @@
                       <a:prstDash val="solid"/>
                     </a:lnB>
                     <a:solidFill>
-                      <a:srgbClr val="FFFFFF">
-                        <a:alpha val="0"/>
+                      <a:srgbClr val="F4F8FB">
+                        <a:alpha val="100000"/>
                       </a:srgbClr>
                     </a:solidFill>
                   </a:tcPr>
@@ -26340,8 +26627,8 @@
                       <a:prstDash val="solid"/>
                     </a:lnB>
                     <a:solidFill>
-                      <a:srgbClr val="FFFFFF">
-                        <a:alpha val="0"/>
+                      <a:srgbClr val="F4F8FB">
+                        <a:alpha val="100000"/>
                       </a:srgbClr>
                     </a:solidFill>
                   </a:tcPr>
@@ -26399,8 +26686,8 @@
                       <a:prstDash val="solid"/>
                     </a:lnB>
                     <a:solidFill>
-                      <a:srgbClr val="F4F8FB">
-                        <a:alpha val="100000"/>
+                      <a:srgbClr val="FFFFFF">
+                        <a:alpha val="0"/>
                       </a:srgbClr>
                     </a:solidFill>
                   </a:tcPr>
@@ -26456,8 +26743,8 @@
                       <a:prstDash val="solid"/>
                     </a:lnB>
                     <a:solidFill>
-                      <a:srgbClr val="F4F8FB">
-                        <a:alpha val="100000"/>
+                      <a:srgbClr val="FFFFFF">
+                        <a:alpha val="0"/>
                       </a:srgbClr>
                     </a:solidFill>
                   </a:tcPr>
@@ -26513,8 +26800,8 @@
                       <a:prstDash val="solid"/>
                     </a:lnB>
                     <a:solidFill>
-                      <a:srgbClr val="F4F8FB">
-                        <a:alpha val="100000"/>
+                      <a:srgbClr val="FFFFFF">
+                        <a:alpha val="0"/>
                       </a:srgbClr>
                     </a:solidFill>
                   </a:tcPr>
@@ -26570,8 +26857,8 @@
                       <a:prstDash val="solid"/>
                     </a:lnB>
                     <a:solidFill>
-                      <a:srgbClr val="F4F8FB">
-                        <a:alpha val="100000"/>
+                      <a:srgbClr val="FFFFFF">
+                        <a:alpha val="0"/>
                       </a:srgbClr>
                     </a:solidFill>
                   </a:tcPr>
@@ -26627,8 +26914,8 @@
                       <a:prstDash val="solid"/>
                     </a:lnB>
                     <a:solidFill>
-                      <a:srgbClr val="F4F8FB">
-                        <a:alpha val="100000"/>
+                      <a:srgbClr val="FFFFFF">
+                        <a:alpha val="0"/>
                       </a:srgbClr>
                     </a:solidFill>
                   </a:tcPr>
@@ -26686,8 +26973,8 @@
                       <a:prstDash val="solid"/>
                     </a:lnB>
                     <a:solidFill>
-                      <a:srgbClr val="FFFFFF">
-                        <a:alpha val="0"/>
+                      <a:srgbClr val="F4F8FB">
+                        <a:alpha val="100000"/>
                       </a:srgbClr>
                     </a:solidFill>
                   </a:tcPr>
@@ -26743,8 +27030,8 @@
                       <a:prstDash val="solid"/>
                     </a:lnB>
                     <a:solidFill>
-                      <a:srgbClr val="FFFFFF">
-                        <a:alpha val="0"/>
+                      <a:srgbClr val="F4F8FB">
+                        <a:alpha val="100000"/>
                       </a:srgbClr>
                     </a:solidFill>
                   </a:tcPr>
@@ -26800,8 +27087,8 @@
                       <a:prstDash val="solid"/>
                     </a:lnB>
                     <a:solidFill>
-                      <a:srgbClr val="FFFFFF">
-                        <a:alpha val="0"/>
+                      <a:srgbClr val="F4F8FB">
+                        <a:alpha val="100000"/>
                       </a:srgbClr>
                     </a:solidFill>
                   </a:tcPr>
@@ -26857,8 +27144,8 @@
                       <a:prstDash val="solid"/>
                     </a:lnB>
                     <a:solidFill>
-                      <a:srgbClr val="FFFFFF">
-                        <a:alpha val="0"/>
+                      <a:srgbClr val="F4F8FB">
+                        <a:alpha val="100000"/>
                       </a:srgbClr>
                     </a:solidFill>
                   </a:tcPr>
@@ -26914,8 +27201,8 @@
                       <a:prstDash val="solid"/>
                     </a:lnB>
                     <a:solidFill>
-                      <a:srgbClr val="FFFFFF">
-                        <a:alpha val="0"/>
+                      <a:srgbClr val="F4F8FB">
+                        <a:alpha val="100000"/>
                       </a:srgbClr>
                     </a:solidFill>
                   </a:tcPr>
@@ -26973,8 +27260,8 @@
                       <a:prstDash val="solid"/>
                     </a:lnB>
                     <a:solidFill>
-                      <a:srgbClr val="F4F8FB">
-                        <a:alpha val="100000"/>
+                      <a:srgbClr val="FFFFFF">
+                        <a:alpha val="0"/>
                       </a:srgbClr>
                     </a:solidFill>
                   </a:tcPr>
@@ -27030,8 +27317,8 @@
                       <a:prstDash val="solid"/>
                     </a:lnB>
                     <a:solidFill>
-                      <a:srgbClr val="F4F8FB">
-                        <a:alpha val="100000"/>
+                      <a:srgbClr val="FFFFFF">
+                        <a:alpha val="0"/>
                       </a:srgbClr>
                     </a:solidFill>
                   </a:tcPr>
@@ -27087,8 +27374,8 @@
                       <a:prstDash val="solid"/>
                     </a:lnB>
                     <a:solidFill>
-                      <a:srgbClr val="F4F8FB">
-                        <a:alpha val="100000"/>
+                      <a:srgbClr val="FFFFFF">
+                        <a:alpha val="0"/>
                       </a:srgbClr>
                     </a:solidFill>
                   </a:tcPr>
@@ -27144,8 +27431,8 @@
                       <a:prstDash val="solid"/>
                     </a:lnB>
                     <a:solidFill>
-                      <a:srgbClr val="F4F8FB">
-                        <a:alpha val="100000"/>
+                      <a:srgbClr val="FFFFFF">
+                        <a:alpha val="0"/>
                       </a:srgbClr>
                     </a:solidFill>
                   </a:tcPr>
@@ -27201,8 +27488,8 @@
                       <a:prstDash val="solid"/>
                     </a:lnB>
                     <a:solidFill>
-                      <a:srgbClr val="F4F8FB">
-                        <a:alpha val="100000"/>
+                      <a:srgbClr val="FFFFFF">
+                        <a:alpha val="0"/>
                       </a:srgbClr>
                     </a:solidFill>
                   </a:tcPr>
@@ -27260,8 +27547,8 @@
                       <a:prstDash val="solid"/>
                     </a:lnB>
                     <a:solidFill>
-                      <a:srgbClr val="FFFFFF">
-                        <a:alpha val="0"/>
+                      <a:srgbClr val="F4F8FB">
+                        <a:alpha val="100000"/>
                       </a:srgbClr>
                     </a:solidFill>
                   </a:tcPr>
@@ -27317,8 +27604,8 @@
                       <a:prstDash val="solid"/>
                     </a:lnB>
                     <a:solidFill>
-                      <a:srgbClr val="FFFFFF">
-                        <a:alpha val="0"/>
+                      <a:srgbClr val="F4F8FB">
+                        <a:alpha val="100000"/>
                       </a:srgbClr>
                     </a:solidFill>
                   </a:tcPr>
@@ -27374,8 +27661,8 @@
                       <a:prstDash val="solid"/>
                     </a:lnB>
                     <a:solidFill>
-                      <a:srgbClr val="FFFFFF">
-                        <a:alpha val="0"/>
+                      <a:srgbClr val="F4F8FB">
+                        <a:alpha val="100000"/>
                       </a:srgbClr>
                     </a:solidFill>
                   </a:tcPr>
@@ -27431,8 +27718,8 @@
                       <a:prstDash val="solid"/>
                     </a:lnB>
                     <a:solidFill>
-                      <a:srgbClr val="FFFFFF">
-                        <a:alpha val="0"/>
+                      <a:srgbClr val="F4F8FB">
+                        <a:alpha val="100000"/>
                       </a:srgbClr>
                     </a:solidFill>
                   </a:tcPr>
@@ -27488,8 +27775,8 @@
                       <a:prstDash val="solid"/>
                     </a:lnB>
                     <a:solidFill>
-                      <a:srgbClr val="FFFFFF">
-                        <a:alpha val="0"/>
+                      <a:srgbClr val="F4F8FB">
+                        <a:alpha val="100000"/>
                       </a:srgbClr>
                     </a:solidFill>
                   </a:tcPr>
@@ -27547,8 +27834,8 @@
                       <a:prstDash val="solid"/>
                     </a:lnB>
                     <a:solidFill>
-                      <a:srgbClr val="F4F8FB">
-                        <a:alpha val="100000"/>
+                      <a:srgbClr val="FFFFFF">
+                        <a:alpha val="0"/>
                       </a:srgbClr>
                     </a:solidFill>
                   </a:tcPr>
@@ -27604,8 +27891,8 @@
                       <a:prstDash val="solid"/>
                     </a:lnB>
                     <a:solidFill>
-                      <a:srgbClr val="F4F8FB">
-                        <a:alpha val="100000"/>
+                      <a:srgbClr val="FFFFFF">
+                        <a:alpha val="0"/>
                       </a:srgbClr>
                     </a:solidFill>
                   </a:tcPr>
@@ -27661,8 +27948,8 @@
                       <a:prstDash val="solid"/>
                     </a:lnB>
                     <a:solidFill>
-                      <a:srgbClr val="F4F8FB">
-                        <a:alpha val="100000"/>
+                      <a:srgbClr val="FFFFFF">
+                        <a:alpha val="0"/>
                       </a:srgbClr>
                     </a:solidFill>
                   </a:tcPr>
@@ -27718,8 +28005,8 @@
                       <a:prstDash val="solid"/>
                     </a:lnB>
                     <a:solidFill>
-                      <a:srgbClr val="F4F8FB">
-                        <a:alpha val="100000"/>
+                      <a:srgbClr val="FFFFFF">
+                        <a:alpha val="0"/>
                       </a:srgbClr>
                     </a:solidFill>
                   </a:tcPr>
@@ -27775,14 +28062,14 @@
                       <a:prstDash val="solid"/>
                     </a:lnB>
                     <a:solidFill>
-                      <a:srgbClr val="F4F8FB">
-                        <a:alpha val="100000"/>
+                      <a:srgbClr val="FFFFFF">
+                        <a:alpha val="0"/>
                       </a:srgbClr>
                     </a:solidFill>
                   </a:tcPr>
                 </a:tc>
               </a:tr>
-              <a:tr h="401320">
+              <a:tr h="410845">
                 <a:tc>
                   <a:txBody>
                     <a:bodyPr/>
@@ -27829,13 +28116,17 @@
                       <a:noFill/>
                       <a:prstDash val="solid"/>
                     </a:lnT>
-                    <a:lnB algn="ctr" cmpd="sng" cap="flat" w="0">
-                      <a:noFill/>
+                    <a:lnB algn="ctr" cmpd="sng" cap="flat" w="19050">
+                      <a:solidFill>
+                        <a:srgbClr val="666666">
+                          <a:alpha val="100000"/>
+                        </a:srgbClr>
+                      </a:solidFill>
                       <a:prstDash val="solid"/>
                     </a:lnB>
                     <a:solidFill>
-                      <a:srgbClr val="FFFFFF">
-                        <a:alpha val="0"/>
+                      <a:srgbClr val="F4F8FB">
+                        <a:alpha val="100000"/>
                       </a:srgbClr>
                     </a:solidFill>
                   </a:tcPr>
@@ -27886,13 +28177,17 @@
                       <a:noFill/>
                       <a:prstDash val="solid"/>
                     </a:lnT>
-                    <a:lnB algn="ctr" cmpd="sng" cap="flat" w="0">
-                      <a:noFill/>
+                    <a:lnB algn="ctr" cmpd="sng" cap="flat" w="19050">
+                      <a:solidFill>
+                        <a:srgbClr val="666666">
+                          <a:alpha val="100000"/>
+                        </a:srgbClr>
+                      </a:solidFill>
                       <a:prstDash val="solid"/>
                     </a:lnB>
                     <a:solidFill>
-                      <a:srgbClr val="FFFFFF">
-                        <a:alpha val="0"/>
+                      <a:srgbClr val="F4F8FB">
+                        <a:alpha val="100000"/>
                       </a:srgbClr>
                     </a:solidFill>
                   </a:tcPr>
@@ -27943,13 +28238,17 @@
                       <a:noFill/>
                       <a:prstDash val="solid"/>
                     </a:lnT>
-                    <a:lnB algn="ctr" cmpd="sng" cap="flat" w="0">
-                      <a:noFill/>
+                    <a:lnB algn="ctr" cmpd="sng" cap="flat" w="19050">
+                      <a:solidFill>
+                        <a:srgbClr val="666666">
+                          <a:alpha val="100000"/>
+                        </a:srgbClr>
+                      </a:solidFill>
                       <a:prstDash val="solid"/>
                     </a:lnB>
                     <a:solidFill>
-                      <a:srgbClr val="FFFFFF">
-                        <a:alpha val="0"/>
+                      <a:srgbClr val="F4F8FB">
+                        <a:alpha val="100000"/>
                       </a:srgbClr>
                     </a:solidFill>
                   </a:tcPr>
@@ -28000,122 +28299,6 @@
                       <a:noFill/>
                       <a:prstDash val="solid"/>
                     </a:lnT>
-                    <a:lnB algn="ctr" cmpd="sng" cap="flat" w="0">
-                      <a:noFill/>
-                      <a:prstDash val="solid"/>
-                    </a:lnB>
-                    <a:solidFill>
-                      <a:srgbClr val="FFFFFF">
-                        <a:alpha val="0"/>
-                      </a:srgbClr>
-                    </a:solidFill>
-                  </a:tcPr>
-                </a:tc>
-                <a:tc>
-                  <a:txBody>
-                    <a:bodyPr/>
-                    <a:lstStyle/>
-                    <a:p>
-                      <a:pPr algn="l" marL="63500" marR="63500">
-                        <a:lnSpc>
-                          <a:spcPct val="100000"/>
-                        </a:lnSpc>
-                        <a:spcBef>
-                          <a:spcPts val="500"/>
-                        </a:spcBef>
-                        <a:spcAft>
-                          <a:spcPts val="500"/>
-                        </a:spcAft>
-                        <a:buNone/>
-                      </a:pPr>
-                      <a:r>
-                        <a:rPr cap="none" sz="1200" i="0" b="0" u="none" strike="noStrike">
-                          <a:solidFill>
-                            <a:srgbClr val="5B6770">
-                              <a:alpha val="100000"/>
-                            </a:srgbClr>
-                          </a:solidFill>
-                          <a:latin typeface="Helvetica Neue"/>
-                          <a:cs typeface="Helvetica Neue"/>
-                          <a:ea typeface="Helvetica Neue"/>
-                          <a:sym typeface="Helvetica Neue"/>
-                        </a:rPr>
-                        <a:t>605808</a:t>
-                      </a:r>
-                    </a:p>
-                  </a:txBody>
-                  <a:tcPr anchor="ctr" marB="63500" marT="63500" marR="0" marL="0">
-                    <a:lnL algn="ctr" cmpd="sng" cap="flat" w="0">
-                      <a:noFill/>
-                      <a:prstDash val="solid"/>
-                    </a:lnL>
-                    <a:lnR algn="ctr" cmpd="sng" cap="flat" w="0">
-                      <a:noFill/>
-                      <a:prstDash val="solid"/>
-                    </a:lnR>
-                    <a:lnT algn="ctr" cmpd="sng" cap="flat" w="0">
-                      <a:noFill/>
-                      <a:prstDash val="solid"/>
-                    </a:lnT>
-                    <a:lnB algn="ctr" cmpd="sng" cap="flat" w="0">
-                      <a:noFill/>
-                      <a:prstDash val="solid"/>
-                    </a:lnB>
-                    <a:solidFill>
-                      <a:srgbClr val="FFFFFF">
-                        <a:alpha val="0"/>
-                      </a:srgbClr>
-                    </a:solidFill>
-                  </a:tcPr>
-                </a:tc>
-              </a:tr>
-              <a:tr h="410845">
-                <a:tc>
-                  <a:txBody>
-                    <a:bodyPr/>
-                    <a:lstStyle/>
-                    <a:p>
-                      <a:pPr algn="l" marL="63500" marR="63500">
-                        <a:lnSpc>
-                          <a:spcPct val="100000"/>
-                        </a:lnSpc>
-                        <a:spcBef>
-                          <a:spcPts val="500"/>
-                        </a:spcBef>
-                        <a:spcAft>
-                          <a:spcPts val="500"/>
-                        </a:spcAft>
-                        <a:buNone/>
-                      </a:pPr>
-                      <a:r>
-                        <a:rPr cap="none" sz="1200" i="0" b="0" u="none" strike="noStrike">
-                          <a:solidFill>
-                            <a:srgbClr val="5B6770">
-                              <a:alpha val="100000"/>
-                            </a:srgbClr>
-                          </a:solidFill>
-                          <a:latin typeface="Helvetica Neue"/>
-                          <a:cs typeface="Helvetica Neue"/>
-                          <a:ea typeface="Helvetica Neue"/>
-                          <a:sym typeface="Helvetica Neue"/>
-                        </a:rPr>
-                        <a:t>antipyrine</a:t>
-                      </a:r>
-                    </a:p>
-                  </a:txBody>
-                  <a:tcPr anchor="ctr" marB="63500" marT="63500" marR="0" marL="0">
-                    <a:lnL algn="ctr" cmpd="sng" cap="flat" w="0">
-                      <a:noFill/>
-                      <a:prstDash val="solid"/>
-                    </a:lnL>
-                    <a:lnR algn="ctr" cmpd="sng" cap="flat" w="0">
-                      <a:noFill/>
-                      <a:prstDash val="solid"/>
-                    </a:lnR>
-                    <a:lnT algn="ctr" cmpd="sng" cap="flat" w="0">
-                      <a:noFill/>
-                      <a:prstDash val="solid"/>
-                    </a:lnT>
                     <a:lnB algn="ctr" cmpd="sng" cap="flat" w="19050">
                       <a:solidFill>
                         <a:srgbClr val="666666">
@@ -28160,190 +28343,7 @@
                           <a:ea typeface="Helvetica Neue"/>
                           <a:sym typeface="Helvetica Neue"/>
                         </a:rPr>
-                        <a:t>28 Jul 2026</a:t>
-                      </a:r>
-                    </a:p>
-                  </a:txBody>
-                  <a:tcPr anchor="ctr" marB="63500" marT="63500" marR="0" marL="0">
-                    <a:lnL algn="ctr" cmpd="sng" cap="flat" w="0">
-                      <a:noFill/>
-                      <a:prstDash val="solid"/>
-                    </a:lnL>
-                    <a:lnR algn="ctr" cmpd="sng" cap="flat" w="0">
-                      <a:noFill/>
-                      <a:prstDash val="solid"/>
-                    </a:lnR>
-                    <a:lnT algn="ctr" cmpd="sng" cap="flat" w="0">
-                      <a:noFill/>
-                      <a:prstDash val="solid"/>
-                    </a:lnT>
-                    <a:lnB algn="ctr" cmpd="sng" cap="flat" w="19050">
-                      <a:solidFill>
-                        <a:srgbClr val="666666">
-                          <a:alpha val="100000"/>
-                        </a:srgbClr>
-                      </a:solidFill>
-                      <a:prstDash val="solid"/>
-                    </a:lnB>
-                    <a:solidFill>
-                      <a:srgbClr val="F4F8FB">
-                        <a:alpha val="100000"/>
-                      </a:srgbClr>
-                    </a:solidFill>
-                  </a:tcPr>
-                </a:tc>
-                <a:tc>
-                  <a:txBody>
-                    <a:bodyPr/>
-                    <a:lstStyle/>
-                    <a:p>
-                      <a:pPr algn="l" marL="63500" marR="63500">
-                        <a:lnSpc>
-                          <a:spcPct val="100000"/>
-                        </a:lnSpc>
-                        <a:spcBef>
-                          <a:spcPts val="500"/>
-                        </a:spcBef>
-                        <a:spcAft>
-                          <a:spcPts val="500"/>
-                        </a:spcAft>
-                        <a:buNone/>
-                      </a:pPr>
-                      <a:r>
-                        <a:rPr cap="none" sz="1200" i="0" b="0" u="none" strike="noStrike">
-                          <a:solidFill>
-                            <a:srgbClr val="5B6770">
-                              <a:alpha val="100000"/>
-                            </a:srgbClr>
-                          </a:solidFill>
-                          <a:latin typeface="Helvetica Neue"/>
-                          <a:cs typeface="Helvetica Neue"/>
-                          <a:ea typeface="Helvetica Neue"/>
-                          <a:sym typeface="Helvetica Neue"/>
-                        </a:rPr>
-                        <a:t>primary</a:t>
-                      </a:r>
-                    </a:p>
-                  </a:txBody>
-                  <a:tcPr anchor="ctr" marB="63500" marT="63500" marR="0" marL="0">
-                    <a:lnL algn="ctr" cmpd="sng" cap="flat" w="0">
-                      <a:noFill/>
-                      <a:prstDash val="solid"/>
-                    </a:lnL>
-                    <a:lnR algn="ctr" cmpd="sng" cap="flat" w="0">
-                      <a:noFill/>
-                      <a:prstDash val="solid"/>
-                    </a:lnR>
-                    <a:lnT algn="ctr" cmpd="sng" cap="flat" w="0">
-                      <a:noFill/>
-                      <a:prstDash val="solid"/>
-                    </a:lnT>
-                    <a:lnB algn="ctr" cmpd="sng" cap="flat" w="19050">
-                      <a:solidFill>
-                        <a:srgbClr val="666666">
-                          <a:alpha val="100000"/>
-                        </a:srgbClr>
-                      </a:solidFill>
-                      <a:prstDash val="solid"/>
-                    </a:lnB>
-                    <a:solidFill>
-                      <a:srgbClr val="F4F8FB">
-                        <a:alpha val="100000"/>
-                      </a:srgbClr>
-                    </a:solidFill>
-                  </a:tcPr>
-                </a:tc>
-                <a:tc>
-                  <a:txBody>
-                    <a:bodyPr/>
-                    <a:lstStyle/>
-                    <a:p>
-                      <a:pPr algn="r" marL="63500" marR="63500">
-                        <a:lnSpc>
-                          <a:spcPct val="100000"/>
-                        </a:lnSpc>
-                        <a:spcBef>
-                          <a:spcPts val="500"/>
-                        </a:spcBef>
-                        <a:spcAft>
-                          <a:spcPts val="500"/>
-                        </a:spcAft>
-                        <a:buNone/>
-                      </a:pPr>
-                      <a:r>
-                        <a:rPr cap="none" sz="1200" i="0" b="0" u="none" strike="noStrike">
-                          <a:solidFill>
-                            <a:srgbClr val="5B6770">
-                              <a:alpha val="100000"/>
-                            </a:srgbClr>
-                          </a:solidFill>
-                          <a:latin typeface="Helvetica Neue"/>
-                          <a:cs typeface="Helvetica Neue"/>
-                          <a:ea typeface="Helvetica Neue"/>
-                          <a:sym typeface="Helvetica Neue"/>
-                        </a:rPr>
-                        <a:t>1</a:t>
-                      </a:r>
-                    </a:p>
-                  </a:txBody>
-                  <a:tcPr anchor="ctr" marB="63500" marT="63500" marR="0" marL="0">
-                    <a:lnL algn="ctr" cmpd="sng" cap="flat" w="0">
-                      <a:noFill/>
-                      <a:prstDash val="solid"/>
-                    </a:lnL>
-                    <a:lnR algn="ctr" cmpd="sng" cap="flat" w="0">
-                      <a:noFill/>
-                      <a:prstDash val="solid"/>
-                    </a:lnR>
-                    <a:lnT algn="ctr" cmpd="sng" cap="flat" w="0">
-                      <a:noFill/>
-                      <a:prstDash val="solid"/>
-                    </a:lnT>
-                    <a:lnB algn="ctr" cmpd="sng" cap="flat" w="19050">
-                      <a:solidFill>
-                        <a:srgbClr val="666666">
-                          <a:alpha val="100000"/>
-                        </a:srgbClr>
-                      </a:solidFill>
-                      <a:prstDash val="solid"/>
-                    </a:lnB>
-                    <a:solidFill>
-                      <a:srgbClr val="F4F8FB">
-                        <a:alpha val="100000"/>
-                      </a:srgbClr>
-                    </a:solidFill>
-                  </a:tcPr>
-                </a:tc>
-                <a:tc>
-                  <a:txBody>
-                    <a:bodyPr/>
-                    <a:lstStyle/>
-                    <a:p>
-                      <a:pPr algn="l" marL="63500" marR="63500">
-                        <a:lnSpc>
-                          <a:spcPct val="100000"/>
-                        </a:lnSpc>
-                        <a:spcBef>
-                          <a:spcPts val="500"/>
-                        </a:spcBef>
-                        <a:spcAft>
-                          <a:spcPts val="500"/>
-                        </a:spcAft>
-                        <a:buNone/>
-                      </a:pPr>
-                      <a:r>
-                        <a:rPr cap="none" sz="1200" i="0" b="0" u="none" strike="noStrike">
-                          <a:solidFill>
-                            <a:srgbClr val="5B6770">
-                              <a:alpha val="100000"/>
-                            </a:srgbClr>
-                          </a:solidFill>
-                          <a:latin typeface="Helvetica Neue"/>
-                          <a:cs typeface="Helvetica Neue"/>
-                          <a:ea typeface="Helvetica Neue"/>
-                          <a:sym typeface="Helvetica Neue"/>
-                        </a:rPr>
-                        <a:t>605809</a:t>
+                        <a:t>605808</a:t>
                       </a:r>
                     </a:p>
                   </a:txBody>

</xml_diff>

<commit_message>
nightly deck: data through 2026-10-18
</commit_message>
<xml_diff>
--- a/docs/nc-drug-checking-latest.pptx
+++ b/docs/nc-drug-checking-latest.pptx
@@ -2418,7 +2418,7 @@
                 <a:ea typeface="Helvetica Neue"/>
                 <a:sym typeface="Helvetica Neue"/>
               </a:rPr>
-              <a:t>Generated Saturday, October 17, 2026 · 7:42 AM ET UNC Street Drug Analysis Lab · OpioidData.org · results.streetsafe.supply Download as PowerPoint</a:t>
+              <a:t>Generated Sunday, October 18, 2026 · 8:09 AM ET UNC Street Drug Analysis Lab · OpioidData.org · results.streetsafe.supply Download as PowerPoint</a:t>
             </a:r>
           </a:p>
         </p:txBody>
@@ -3184,7 +3184,7 @@
                 <a:ea typeface="Helvetica Neue"/>
                 <a:sym typeface="Helvetica Neue"/>
               </a:rPr>
-              <a:t>County = samplecounty · left: ≥1 completed analysis ever · right: unique samples per county (sqrt color scale) · all time: 26 Jan 2022 – 16 Oct 2026 · last 12 months: 17 Oct 2025 – 16 Oct 2026* · coverage reflects participation, not prevalence</a:t>
+              <a:t>County = samplecounty · left: ≥1 completed analysis ever · right: unique samples per county (sqrt color scale) · all time: 26 Jan 2022 – 16 Oct 2026 · last 12 months: 18 Oct 2025 – 16 Oct 2026* · coverage reflects participation, not prevalence</a:t>
             </a:r>
           </a:p>
         </p:txBody>
@@ -4323,7 +4323,7 @@
                 <a:ea typeface="Helvetica Neue"/>
                 <a:sym typeface="Helvetica Neue"/>
               </a:rPr>
-              <a:t>Samples with methamphetamine or cocaine detected (any abundance); samples in both classes appear on both slides · sensations semicolon lists parsed + sen_strength (own denominator) · consumed = 1 only · before: 26 Jan 2022 – 16 Oct 2025 · past 12 months: 17 Oct 2025 – 16 Oct 2026* · Δ in percentage points</a:t>
+              <a:t>Samples with methamphetamine or cocaine detected (any abundance); samples in both classes appear on both slides · sensations semicolon lists parsed + sen_strength (own denominator) · consumed = 1 only · before: 26 Jan 2022 – 16 Oct 2025 · past 12 months: 18 Oct 2025 – 16 Oct 2026* · Δ in percentage points</a:t>
             </a:r>
           </a:p>
         </p:txBody>
@@ -4742,7 +4742,7 @@
                 <a:ea typeface="Helvetica Neue"/>
                 <a:sym typeface="Helvetica Neue"/>
               </a:rPr>
-              <a:t>Samples with an opioid (fentanyl, heroin) or benzodiazepine detected (any abundance); samples in both classes appear on both slides · sensations semicolon lists parsed + sen_strength (own denominator) · consumed = 1 only · before: 26 Jan 2022 – 16 Oct 2025 · past 12 months: 17 Oct 2025 – 16 Oct 2026* · Δ in percentage points</a:t>
+              <a:t>Samples with an opioid (fentanyl, heroin) or benzodiazepine detected (any abundance); samples in both classes appear on both slides · sensations semicolon lists parsed + sen_strength (own denominator) · consumed = 1 only · before: 26 Jan 2022 – 16 Oct 2025 · past 12 months: 18 Oct 2025 – 16 Oct 2026* · Δ in percentage points</a:t>
             </a:r>
           </a:p>
         </p:txBody>
@@ -5855,7 +5855,7 @@
                 <a:ea typeface="Helvetica Neue"/>
                 <a:sym typeface="Helvetica Neue"/>
               </a:rPr>
-              <a:t>lab_detail.substance counts · solid = primary abundance, light = trace · standardized names (PubChem-linked) · window: date_complete 17 Oct 2025 – 16 Oct 2026* (trailing 12 months, current month partial)</a:t>
+              <a:t>lab_detail.substance counts · solid = primary abundance, light = trace · standardized names (PubChem-linked) · window: date_complete 18 Oct 2025 – 16 Oct 2026* (trailing 12 months, current month partial)</a:t>
             </a:r>
           </a:p>
         </p:txBody>
@@ -6053,7 +6053,7 @@
                 <a:ea typeface="Helvetica Neue"/>
                 <a:sym typeface="Helvetica Neue"/>
               </a:rPr>
-              <a:t>Distribution of substances detected per sample, both definitions shown side by side · window: date_complete 17 Oct 2025 – 16 Oct 2026* (trailing 12 months, current month partial)</a:t>
+              <a:t>Distribution of substances detected per sample, both definitions shown side by side · window: date_complete 18 Oct 2025 – 16 Oct 2026* (trailing 12 months, current month partial)</a:t>
             </a:r>
           </a:p>
         </p:txBody>

</xml_diff>

<commit_message>
nightly deck: data through 2026-10-19
</commit_message>
<xml_diff>
--- a/docs/nc-drug-checking-latest.pptx
+++ b/docs/nc-drug-checking-latest.pptx
@@ -2418,7 +2418,7 @@
                 <a:ea typeface="Helvetica Neue"/>
                 <a:sym typeface="Helvetica Neue"/>
               </a:rPr>
-              <a:t>Generated Sunday, October 18, 2026 · 8:09 AM ET UNC Street Drug Analysis Lab · OpioidData.org · results.streetsafe.supply Download as PowerPoint</a:t>
+              <a:t>Generated Monday, October 19, 2026 · 10:50 AM ET UNC Street Drug Analysis Lab · OpioidData.org · results.streetsafe.supply Download as PowerPoint</a:t>
             </a:r>
           </a:p>
         </p:txBody>
@@ -3184,7 +3184,7 @@
                 <a:ea typeface="Helvetica Neue"/>
                 <a:sym typeface="Helvetica Neue"/>
               </a:rPr>
-              <a:t>County = samplecounty · left: ≥1 completed analysis ever · right: unique samples per county (sqrt color scale) · all time: 26 Jan 2022 – 16 Oct 2026 · last 12 months: 18 Oct 2025 – 16 Oct 2026* · coverage reflects participation, not prevalence</a:t>
+              <a:t>County = samplecounty · left: ≥1 completed analysis ever · right: unique samples per county (sqrt color scale) · all time: 26 Jan 2022 – 16 Oct 2026 · last 12 months: 19 Oct 2025 – 16 Oct 2026* · coverage reflects participation, not prevalence</a:t>
             </a:r>
           </a:p>
         </p:txBody>
@@ -4323,7 +4323,7 @@
                 <a:ea typeface="Helvetica Neue"/>
                 <a:sym typeface="Helvetica Neue"/>
               </a:rPr>
-              <a:t>Samples with methamphetamine or cocaine detected (any abundance); samples in both classes appear on both slides · sensations semicolon lists parsed + sen_strength (own denominator) · consumed = 1 only · before: 26 Jan 2022 – 16 Oct 2025 · past 12 months: 18 Oct 2025 – 16 Oct 2026* · Δ in percentage points</a:t>
+              <a:t>Samples with methamphetamine or cocaine detected (any abundance); samples in both classes appear on both slides · sensations semicolon lists parsed + sen_strength (own denominator) · consumed = 1 only · before: 26 Jan 2022 – 16 Oct 2025 · past 12 months: 19 Oct 2025 – 16 Oct 2026* · Δ in percentage points</a:t>
             </a:r>
           </a:p>
         </p:txBody>
@@ -4742,7 +4742,7 @@
                 <a:ea typeface="Helvetica Neue"/>
                 <a:sym typeface="Helvetica Neue"/>
               </a:rPr>
-              <a:t>Samples with an opioid (fentanyl, heroin) or benzodiazepine detected (any abundance); samples in both classes appear on both slides · sensations semicolon lists parsed + sen_strength (own denominator) · consumed = 1 only · before: 26 Jan 2022 – 16 Oct 2025 · past 12 months: 18 Oct 2025 – 16 Oct 2026* · Δ in percentage points</a:t>
+              <a:t>Samples with an opioid (fentanyl, heroin) or benzodiazepine detected (any abundance); samples in both classes appear on both slides · sensations semicolon lists parsed + sen_strength (own denominator) · consumed = 1 only · before: 26 Jan 2022 – 16 Oct 2025 · past 12 months: 19 Oct 2025 – 16 Oct 2026* · Δ in percentage points</a:t>
             </a:r>
           </a:p>
         </p:txBody>
@@ -5855,7 +5855,7 @@
                 <a:ea typeface="Helvetica Neue"/>
                 <a:sym typeface="Helvetica Neue"/>
               </a:rPr>
-              <a:t>lab_detail.substance counts · solid = primary abundance, light = trace · standardized names (PubChem-linked) · window: date_complete 18 Oct 2025 – 16 Oct 2026* (trailing 12 months, current month partial)</a:t>
+              <a:t>lab_detail.substance counts · solid = primary abundance, light = trace · standardized names (PubChem-linked) · window: date_complete 19 Oct 2025 – 16 Oct 2026* (trailing 12 months, current month partial)</a:t>
             </a:r>
           </a:p>
         </p:txBody>
@@ -6053,7 +6053,7 @@
                 <a:ea typeface="Helvetica Neue"/>
                 <a:sym typeface="Helvetica Neue"/>
               </a:rPr>
-              <a:t>Distribution of substances detected per sample, both definitions shown side by side · window: date_complete 18 Oct 2025 – 16 Oct 2026* (trailing 12 months, current month partial)</a:t>
+              <a:t>Distribution of substances detected per sample, both definitions shown side by side · window: date_complete 19 Oct 2025 – 16 Oct 2026* (trailing 12 months, current month partial)</a:t>
             </a:r>
           </a:p>
         </p:txBody>

</xml_diff>

<commit_message>
nightly deck: data through 2026-10-20
</commit_message>
<xml_diff>
--- a/docs/nc-drug-checking-latest.pptx
+++ b/docs/nc-drug-checking-latest.pptx
@@ -2418,7 +2418,7 @@
                 <a:ea typeface="Helvetica Neue"/>
                 <a:sym typeface="Helvetica Neue"/>
               </a:rPr>
-              <a:t>Generated Monday, October 19, 2026 · 10:50 AM ET UNC Street Drug Analysis Lab · OpioidData.org · results.streetsafe.supply Download as PowerPoint</a:t>
+              <a:t>Generated Tuesday, October 20, 2026 · 8:50 AM ET UNC Street Drug Analysis Lab · OpioidData.org · results.streetsafe.supply Download as PowerPoint</a:t>
             </a:r>
           </a:p>
         </p:txBody>
@@ -2713,7 +2713,7 @@
                 <a:ea typeface="Helvetica Neue"/>
                 <a:sym typeface="Helvetica Neue"/>
               </a:rPr>
-              <a:t>PLACEHOLDER · figs/stats.json January 2022 to Friday, October 16, 2026 N = 2,987 NC samples analyzed Mailed in from 86 harm reduction programs Collected across 59 counties 251 distinct substances detected to date Unique samples = n_distinct(sampleid) · substances from lab_detail.substance · includes samples with date_complete 26 Jan 2022 – 16 Oct 2026 r/build_nightly.R → figs/stats.json</a:t>
+              <a:t>PLACEHOLDER · figs/stats.json January 2022 to Monday, October 19, 2026 N = 2,992 NC samples analyzed Mailed in from 86 harm reduction programs Collected across 59 counties 251 distinct substances detected to date Unique samples = n_distinct(sampleid) · substances from lab_detail.substance · includes samples with date_complete 26 Jan 2022 – 19 Oct 2026 r/build_nightly.R → figs/stats.json</a:t>
             </a:r>
           </a:p>
         </p:txBody>
@@ -2762,7 +2762,7 @@
                 <a:ea typeface="Helvetica Neue"/>
                 <a:sym typeface="Helvetica Neue"/>
               </a:rPr>
-              <a:t>Unique samples = n_distinct(sampleid) · substances from lab_detail.substance · includes samples with date_complete 26 Jan 2022 – 16 Oct 2026</a:t>
+              <a:t>Unique samples = n_distinct(sampleid) · substances from lab_detail.substance · includes samples with date_complete 26 Jan 2022 – 19 Oct 2026</a:t>
             </a:r>
           </a:p>
         </p:txBody>
@@ -3184,7 +3184,7 @@
                 <a:ea typeface="Helvetica Neue"/>
                 <a:sym typeface="Helvetica Neue"/>
               </a:rPr>
-              <a:t>County = samplecounty · left: ≥1 completed analysis ever · right: unique samples per county (sqrt color scale) · all time: 26 Jan 2022 – 16 Oct 2026 · last 12 months: 19 Oct 2025 – 16 Oct 2026* · coverage reflects participation, not prevalence</a:t>
+              <a:t>County = samplecounty · left: ≥1 completed analysis ever · right: unique samples per county (sqrt color scale) · all time: 26 Jan 2022 – 19 Oct 2026 · last 12 months: 20 Oct 2025 – 19 Oct 2026* · coverage reflects participation, not prevalence</a:t>
             </a:r>
           </a:p>
         </p:txBody>
@@ -3505,7 +3505,7 @@
                 <a:ea typeface="Helvetica Neue"/>
                 <a:sym typeface="Helvetica Neue"/>
               </a:rPr>
-              <a:t>expectedsubstance (verbatim card write-in, semicolon lists split) · derived flags: expect_opioid, expect_fentanyl, expect_meth, expect_cocaine, expect_stimulant… · includes samples with date_complete 26 Jan 2022 – 16 Oct 2026 · data table: Appendix A2</a:t>
+              <a:t>expectedsubstance (verbatim card write-in, semicolon lists split) · derived flags: expect_opioid, expect_fentanyl, expect_meth, expect_cocaine, expect_stimulant… · includes samples with date_complete 26 Jan 2022 – 19 Oct 2026 · data table: Appendix A2</a:t>
             </a:r>
           </a:p>
         </p:txBody>
@@ -3703,7 +3703,7 @@
                 <a:ea typeface="Helvetica Neue"/>
                 <a:sym typeface="Helvetica Neue"/>
               </a:rPr>
-              <a:t>Numerator uses lab_*_any (primary or trace) among samples with expect_* = 1 · includes samples with date_complete 26 Jan 2022 – 16 Oct 2026 · data table: Appendix A3</a:t>
+              <a:t>Numerator uses lab_*_any (primary or trace) among samples with expect_* = 1 · includes samples with date_complete 26 Jan 2022 – 19 Oct 2026 · data table: Appendix A3</a:t>
             </a:r>
           </a:p>
         </p:txBody>
@@ -3901,7 +3901,7 @@
                 <a:ea typeface="Helvetica Neue"/>
                 <a:sym typeface="Helvetica Neue"/>
               </a:rPr>
-              <a:t>sensations (circled on card, semicolon lists split) · post-consumption samples only (consumed = 1) · includes samples with date_complete 26 Jan 2022 – 16 Oct 2026</a:t>
+              <a:t>sensations (circled on card, semicolon lists split) · post-consumption samples only (consumed = 1) · includes samples with date_complete 26 Jan 2022 – 19 Oct 2026</a:t>
             </a:r>
           </a:p>
         </p:txBody>
@@ -4125,7 +4125,7 @@
                 <a:ea typeface="Helvetica Neue"/>
                 <a:sym typeface="Helvetica Neue"/>
               </a:rPr>
-              <a:t>sensations semicolon lists parsed per report · consumed = 1 only · denominator: consumed samples with lab_*_any = 1 · includes samples with date_complete 26 Jan 2022 – 16 Oct 2026</a:t>
+              <a:t>sensations semicolon lists parsed per report · consumed = 1 only · denominator: consumed samples with lab_*_any = 1 · includes samples with date_complete 26 Jan 2022 – 19 Oct 2026</a:t>
             </a:r>
           </a:p>
         </p:txBody>
@@ -4323,7 +4323,7 @@
                 <a:ea typeface="Helvetica Neue"/>
                 <a:sym typeface="Helvetica Neue"/>
               </a:rPr>
-              <a:t>Samples with methamphetamine or cocaine detected (any abundance); samples in both classes appear on both slides · sensations semicolon lists parsed + sen_strength (own denominator) · consumed = 1 only · before: 26 Jan 2022 – 16 Oct 2025 · past 12 months: 19 Oct 2025 – 16 Oct 2026* · Δ in percentage points</a:t>
+              <a:t>Samples with methamphetamine or cocaine detected (any abundance); samples in both classes appear on both slides · sensations semicolon lists parsed + sen_strength (own denominator) · consumed = 1 only · before: 26 Jan 2022 – 19 Oct 2025 · past 12 months: 20 Oct 2025 – 19 Oct 2026* · Δ in percentage points</a:t>
             </a:r>
           </a:p>
         </p:txBody>
@@ -4742,7 +4742,7 @@
                 <a:ea typeface="Helvetica Neue"/>
                 <a:sym typeface="Helvetica Neue"/>
               </a:rPr>
-              <a:t>Samples with an opioid (fentanyl, heroin) or benzodiazepine detected (any abundance); samples in both classes appear on both slides · sensations semicolon lists parsed + sen_strength (own denominator) · consumed = 1 only · before: 26 Jan 2022 – 16 Oct 2025 · past 12 months: 19 Oct 2025 – 16 Oct 2026* · Δ in percentage points</a:t>
+              <a:t>Samples with an opioid (fentanyl, heroin) or benzodiazepine detected (any abundance); samples in both classes appear on both slides · sensations semicolon lists parsed + sen_strength (own denominator) · consumed = 1 only · before: 26 Jan 2022 – 19 Oct 2025 · past 12 months: 20 Oct 2025 – 19 Oct 2026* · Δ in percentage points</a:t>
             </a:r>
           </a:p>
         </p:txBody>
@@ -5138,7 +5138,7 @@
                 <a:ea typeface="Helvetica Neue"/>
                 <a:sym typeface="Helvetica Neue"/>
               </a:rPr>
-              <a:t>color, texture (card v3+, semicolon lists split) · derived: bright_color excludes white/tan/brown family — orange bar above · includes samples with date_complete 26 Jan 2022 – 16 Oct 2026</a:t>
+              <a:t>color, texture (card v3+, semicolon lists split) · derived: bright_color excludes white/tan/brown family — orange bar above · includes samples with date_complete 26 Jan 2022 – 19 Oct 2026</a:t>
             </a:r>
           </a:p>
         </p:txBody>
@@ -5459,7 +5459,7 @@
                 <a:ea typeface="Helvetica Neue"/>
                 <a:sym typeface="Helvetica Neue"/>
               </a:rPr>
-              <a:t>Distribution of substances detected per sample, both definitions shown side by side · includes samples with date_complete 26 Jan 2022 – 16 Oct 2026</a:t>
+              <a:t>Distribution of substances detected per sample, both definitions shown side by side · includes samples with date_complete 26 Jan 2022 – 19 Oct 2026</a:t>
             </a:r>
           </a:p>
         </p:txBody>
@@ -5657,7 +5657,7 @@
                 <a:ea typeface="Helvetica Neue"/>
                 <a:sym typeface="Helvetica Neue"/>
               </a:rPr>
-              <a:t>lab_detail.substance counts · solid = primary abundance, light = trace · standardized names (PubChem-linked) · includes samples with date_complete 26 Jan 2022 – 16 Oct 2026</a:t>
+              <a:t>lab_detail.substance counts · solid = primary abundance, light = trace · standardized names (PubChem-linked) · includes samples with date_complete 26 Jan 2022 – 19 Oct 2026</a:t>
             </a:r>
           </a:p>
         </p:txBody>
@@ -5855,7 +5855,7 @@
                 <a:ea typeface="Helvetica Neue"/>
                 <a:sym typeface="Helvetica Neue"/>
               </a:rPr>
-              <a:t>lab_detail.substance counts · solid = primary abundance, light = trace · standardized names (PubChem-linked) · window: date_complete 19 Oct 2025 – 16 Oct 2026* (trailing 12 months, current month partial)</a:t>
+              <a:t>lab_detail.substance counts · solid = primary abundance, light = trace · standardized names (PubChem-linked) · window: date_complete 20 Oct 2025 – 19 Oct 2026* (trailing 12 months, current month partial)</a:t>
             </a:r>
           </a:p>
         </p:txBody>
@@ -6053,7 +6053,7 @@
                 <a:ea typeface="Helvetica Neue"/>
                 <a:sym typeface="Helvetica Neue"/>
               </a:rPr>
-              <a:t>Distribution of substances detected per sample, both definitions shown side by side · window: date_complete 19 Oct 2025 – 16 Oct 2026* (trailing 12 months, current month partial)</a:t>
+              <a:t>Distribution of substances detected per sample, both definitions shown side by side · window: date_complete 20 Oct 2025 – 19 Oct 2026* (trailing 12 months, current month partial)</a:t>
             </a:r>
           </a:p>
         </p:txBody>
@@ -18510,7 +18510,7 @@
                           <a:ea typeface="Helvetica Neue"/>
                           <a:sym typeface="Helvetica Neue"/>
                         </a:rPr>
-                        <a:t>1,543</a:t>
+                        <a:t>1,546</a:t>
                       </a:r>
                     </a:p>
                   </a:txBody>
@@ -18974,7 +18974,7 @@
                           <a:ea typeface="Helvetica Neue"/>
                           <a:sym typeface="Helvetica Neue"/>
                         </a:rPr>
-                        <a:t>165</a:t>
+                        <a:t>166</a:t>
                       </a:r>
                     </a:p>
                   </a:txBody>
@@ -19729,7 +19729,7 @@
                           <a:ea typeface="Helvetica Neue"/>
                           <a:sym typeface="Helvetica Neue"/>
                         </a:rPr>
-                        <a:t>heroin, fentanyl</a:t>
+                        <a:t>crack</a:t>
                       </a:r>
                     </a:p>
                   </a:txBody>
@@ -20591,7 +20591,7 @@
                           <a:ea typeface="Helvetica Neue"/>
                           <a:sym typeface="Helvetica Neue"/>
                         </a:rPr>
-                        <a:t>1,790</a:t>
+                        <a:t>1,793</a:t>
                       </a:r>
                     </a:p>
                   </a:txBody>
@@ -21051,7 +21051,7 @@
                           <a:ea typeface="Helvetica Neue"/>
                           <a:sym typeface="Helvetica Neue"/>
                         </a:rPr>
-                        <a:t>142</a:t>
+                        <a:t>143</a:t>
                       </a:r>
                     </a:p>
                   </a:txBody>

</xml_diff>

<commit_message>
nightly deck: data through 2026-10-21
</commit_message>
<xml_diff>
--- a/docs/nc-drug-checking-latest.pptx
+++ b/docs/nc-drug-checking-latest.pptx
@@ -2418,7 +2418,7 @@
                 <a:ea typeface="Helvetica Neue"/>
                 <a:sym typeface="Helvetica Neue"/>
               </a:rPr>
-              <a:t>Generated Tuesday, October 20, 2026 · 8:50 AM ET UNC Street Drug Analysis Lab · OpioidData.org · results.streetsafe.supply Download as PowerPoint</a:t>
+              <a:t>Generated Wednesday, October 21, 2026 · 9:03 AM ET UNC Street Drug Analysis Lab · OpioidData.org · results.streetsafe.supply Download as PowerPoint</a:t>
             </a:r>
           </a:p>
         </p:txBody>
@@ -2713,7 +2713,7 @@
                 <a:ea typeface="Helvetica Neue"/>
                 <a:sym typeface="Helvetica Neue"/>
               </a:rPr>
-              <a:t>PLACEHOLDER · figs/stats.json January 2022 to Monday, October 19, 2026 N = 2,992 NC samples analyzed Mailed in from 86 harm reduction programs Collected across 59 counties 251 distinct substances detected to date Unique samples = n_distinct(sampleid) · substances from lab_detail.substance · includes samples with date_complete 26 Jan 2022 – 19 Oct 2026 r/build_nightly.R → figs/stats.json</a:t>
+              <a:t>PLACEHOLDER · figs/stats.json January 2022 to Tuesday, October 20, 2026 N = 3,001 NC samples analyzed Mailed in from 86 harm reduction programs Collected across 59 counties 251 distinct substances detected to date Unique samples = n_distinct(sampleid) · substances from lab_detail.substance · includes samples with date_complete 26 Jan 2022 – 20 Oct 2026 r/build_nightly.R → figs/stats.json</a:t>
             </a:r>
           </a:p>
         </p:txBody>
@@ -2762,7 +2762,7 @@
                 <a:ea typeface="Helvetica Neue"/>
                 <a:sym typeface="Helvetica Neue"/>
               </a:rPr>
-              <a:t>Unique samples = n_distinct(sampleid) · substances from lab_detail.substance · includes samples with date_complete 26 Jan 2022 – 19 Oct 2026</a:t>
+              <a:t>Unique samples = n_distinct(sampleid) · substances from lab_detail.substance · includes samples with date_complete 26 Jan 2022 – 20 Oct 2026</a:t>
             </a:r>
           </a:p>
         </p:txBody>
@@ -3184,7 +3184,7 @@
                 <a:ea typeface="Helvetica Neue"/>
                 <a:sym typeface="Helvetica Neue"/>
               </a:rPr>
-              <a:t>County = samplecounty · left: ≥1 completed analysis ever · right: unique samples per county (sqrt color scale) · all time: 26 Jan 2022 – 19 Oct 2026 · last 12 months: 20 Oct 2025 – 19 Oct 2026* · coverage reflects participation, not prevalence</a:t>
+              <a:t>County = samplecounty · left: ≥1 completed analysis ever · right: unique samples per county (sqrt color scale) · all time: 26 Jan 2022 – 20 Oct 2026 · last 12 months: 21 Oct 2025 – 20 Oct 2026* · coverage reflects participation, not prevalence</a:t>
             </a:r>
           </a:p>
         </p:txBody>
@@ -3505,7 +3505,7 @@
                 <a:ea typeface="Helvetica Neue"/>
                 <a:sym typeface="Helvetica Neue"/>
               </a:rPr>
-              <a:t>expectedsubstance (verbatim card write-in, semicolon lists split) · derived flags: expect_opioid, expect_fentanyl, expect_meth, expect_cocaine, expect_stimulant… · includes samples with date_complete 26 Jan 2022 – 19 Oct 2026 · data table: Appendix A2</a:t>
+              <a:t>expectedsubstance (verbatim card write-in, semicolon lists split) · derived flags: expect_opioid, expect_fentanyl, expect_meth, expect_cocaine, expect_stimulant… · includes samples with date_complete 26 Jan 2022 – 20 Oct 2026 · data table: Appendix A2</a:t>
             </a:r>
           </a:p>
         </p:txBody>
@@ -3703,7 +3703,7 @@
                 <a:ea typeface="Helvetica Neue"/>
                 <a:sym typeface="Helvetica Neue"/>
               </a:rPr>
-              <a:t>Numerator uses lab_*_any (primary or trace) among samples with expect_* = 1 · includes samples with date_complete 26 Jan 2022 – 19 Oct 2026 · data table: Appendix A3</a:t>
+              <a:t>Numerator uses lab_*_any (primary or trace) among samples with expect_* = 1 · includes samples with date_complete 26 Jan 2022 – 20 Oct 2026 · data table: Appendix A3</a:t>
             </a:r>
           </a:p>
         </p:txBody>
@@ -3901,7 +3901,7 @@
                 <a:ea typeface="Helvetica Neue"/>
                 <a:sym typeface="Helvetica Neue"/>
               </a:rPr>
-              <a:t>sensations (circled on card, semicolon lists split) · post-consumption samples only (consumed = 1) · includes samples with date_complete 26 Jan 2022 – 19 Oct 2026</a:t>
+              <a:t>sensations (circled on card, semicolon lists split) · post-consumption samples only (consumed = 1) · includes samples with date_complete 26 Jan 2022 – 20 Oct 2026</a:t>
             </a:r>
           </a:p>
         </p:txBody>
@@ -4125,7 +4125,7 @@
                 <a:ea typeface="Helvetica Neue"/>
                 <a:sym typeface="Helvetica Neue"/>
               </a:rPr>
-              <a:t>sensations semicolon lists parsed per report · consumed = 1 only · denominator: consumed samples with lab_*_any = 1 · includes samples with date_complete 26 Jan 2022 – 19 Oct 2026</a:t>
+              <a:t>sensations semicolon lists parsed per report · consumed = 1 only · denominator: consumed samples with lab_*_any = 1 · includes samples with date_complete 26 Jan 2022 – 20 Oct 2026</a:t>
             </a:r>
           </a:p>
         </p:txBody>
@@ -4323,7 +4323,7 @@
                 <a:ea typeface="Helvetica Neue"/>
                 <a:sym typeface="Helvetica Neue"/>
               </a:rPr>
-              <a:t>Samples with methamphetamine or cocaine detected (any abundance); samples in both classes appear on both slides · sensations semicolon lists parsed + sen_strength (own denominator) · consumed = 1 only · before: 26 Jan 2022 – 19 Oct 2025 · past 12 months: 20 Oct 2025 – 19 Oct 2026* · Δ in percentage points</a:t>
+              <a:t>Samples with methamphetamine or cocaine detected (any abundance); samples in both classes appear on both slides · sensations semicolon lists parsed + sen_strength (own denominator) · consumed = 1 only · before: 26 Jan 2022 – 20 Oct 2025 · past 12 months: 21 Oct 2025 – 20 Oct 2026* · Δ in percentage points</a:t>
             </a:r>
           </a:p>
         </p:txBody>
@@ -4742,7 +4742,7 @@
                 <a:ea typeface="Helvetica Neue"/>
                 <a:sym typeface="Helvetica Neue"/>
               </a:rPr>
-              <a:t>Samples with an opioid (fentanyl, heroin) or benzodiazepine detected (any abundance); samples in both classes appear on both slides · sensations semicolon lists parsed + sen_strength (own denominator) · consumed = 1 only · before: 26 Jan 2022 – 19 Oct 2025 · past 12 months: 20 Oct 2025 – 19 Oct 2026* · Δ in percentage points</a:t>
+              <a:t>Samples with an opioid (fentanyl, heroin) or benzodiazepine detected (any abundance); samples in both classes appear on both slides · sensations semicolon lists parsed + sen_strength (own denominator) · consumed = 1 only · before: 26 Jan 2022 – 20 Oct 2025 · past 12 months: 21 Oct 2025 – 20 Oct 2026* · Δ in percentage points</a:t>
             </a:r>
           </a:p>
         </p:txBody>
@@ -5138,7 +5138,7 @@
                 <a:ea typeface="Helvetica Neue"/>
                 <a:sym typeface="Helvetica Neue"/>
               </a:rPr>
-              <a:t>color, texture (card v3+, semicolon lists split) · derived: bright_color excludes white/tan/brown family — orange bar above · includes samples with date_complete 26 Jan 2022 – 19 Oct 2026</a:t>
+              <a:t>color, texture (card v3+, semicolon lists split) · derived: bright_color excludes white/tan/brown family — orange bar above · includes samples with date_complete 26 Jan 2022 – 20 Oct 2026</a:t>
             </a:r>
           </a:p>
         </p:txBody>
@@ -5459,7 +5459,7 @@
                 <a:ea typeface="Helvetica Neue"/>
                 <a:sym typeface="Helvetica Neue"/>
               </a:rPr>
-              <a:t>Distribution of substances detected per sample, both definitions shown side by side · includes samples with date_complete 26 Jan 2022 – 19 Oct 2026</a:t>
+              <a:t>Distribution of substances detected per sample, both definitions shown side by side · includes samples with date_complete 26 Jan 2022 – 20 Oct 2026</a:t>
             </a:r>
           </a:p>
         </p:txBody>
@@ -5657,7 +5657,7 @@
                 <a:ea typeface="Helvetica Neue"/>
                 <a:sym typeface="Helvetica Neue"/>
               </a:rPr>
-              <a:t>lab_detail.substance counts · solid = primary abundance, light = trace · standardized names (PubChem-linked) · includes samples with date_complete 26 Jan 2022 – 19 Oct 2026</a:t>
+              <a:t>lab_detail.substance counts · solid = primary abundance, light = trace · standardized names (PubChem-linked) · includes samples with date_complete 26 Jan 2022 – 20 Oct 2026</a:t>
             </a:r>
           </a:p>
         </p:txBody>
@@ -5855,7 +5855,7 @@
                 <a:ea typeface="Helvetica Neue"/>
                 <a:sym typeface="Helvetica Neue"/>
               </a:rPr>
-              <a:t>lab_detail.substance counts · solid = primary abundance, light = trace · standardized names (PubChem-linked) · window: date_complete 20 Oct 2025 – 19 Oct 2026* (trailing 12 months, current month partial)</a:t>
+              <a:t>lab_detail.substance counts · solid = primary abundance, light = trace · standardized names (PubChem-linked) · window: date_complete 21 Oct 2025 – 20 Oct 2026* (trailing 12 months, current month partial)</a:t>
             </a:r>
           </a:p>
         </p:txBody>
@@ -6053,7 +6053,7 @@
                 <a:ea typeface="Helvetica Neue"/>
                 <a:sym typeface="Helvetica Neue"/>
               </a:rPr>
-              <a:t>Distribution of substances detected per sample, both definitions shown side by side · window: date_complete 20 Oct 2025 – 19 Oct 2026* (trailing 12 months, current month partial)</a:t>
+              <a:t>Distribution of substances detected per sample, both definitions shown side by side · window: date_complete 21 Oct 2025 – 20 Oct 2026* (trailing 12 months, current month partial)</a:t>
             </a:r>
           </a:p>
         </p:txBody>
@@ -18510,7 +18510,7 @@
                           <a:ea typeface="Helvetica Neue"/>
                           <a:sym typeface="Helvetica Neue"/>
                         </a:rPr>
-                        <a:t>1,546</a:t>
+                        <a:t>1,552</a:t>
                       </a:r>
                     </a:p>
                   </a:txBody>
@@ -18626,7 +18626,7 @@
                           <a:ea typeface="Helvetica Neue"/>
                           <a:sym typeface="Helvetica Neue"/>
                         </a:rPr>
-                        <a:t>454</a:t>
+                        <a:t>456</a:t>
                       </a:r>
                     </a:p>
                   </a:txBody>
@@ -19438,7 +19438,7 @@
                           <a:ea typeface="Helvetica Neue"/>
                           <a:sym typeface="Helvetica Neue"/>
                         </a:rPr>
-                        <a:t>64</a:t>
+                        <a:t>65</a:t>
                       </a:r>
                     </a:p>
                   </a:txBody>
@@ -20591,7 +20591,7 @@
                           <a:ea typeface="Helvetica Neue"/>
                           <a:sym typeface="Helvetica Neue"/>
                         </a:rPr>
-                        <a:t>1,793</a:t>
+                        <a:t>1,800</a:t>
                       </a:r>
                     </a:p>
                   </a:txBody>
@@ -20821,7 +20821,7 @@
                           <a:ea typeface="Helvetica Neue"/>
                           <a:sym typeface="Helvetica Neue"/>
                         </a:rPr>
-                        <a:t>533</a:t>
+                        <a:t>536</a:t>
                       </a:r>
                     </a:p>
                   </a:txBody>

</xml_diff>

<commit_message>
nightly deck: data through 2026-10-22
</commit_message>
<xml_diff>
--- a/docs/nc-drug-checking-latest.pptx
+++ b/docs/nc-drug-checking-latest.pptx
@@ -2418,7 +2418,7 @@
                 <a:ea typeface="Helvetica Neue"/>
                 <a:sym typeface="Helvetica Neue"/>
               </a:rPr>
-              <a:t>Generated Wednesday, October 21, 2026 · 9:03 AM ET UNC Street Drug Analysis Lab · OpioidData.org · results.streetsafe.supply Download as PowerPoint</a:t>
+              <a:t>Generated Thursday, October 22, 2026 · 9:05 AM ET UNC Street Drug Analysis Lab · OpioidData.org · results.streetsafe.supply Download as PowerPoint</a:t>
             </a:r>
           </a:p>
         </p:txBody>
@@ -2713,7 +2713,7 @@
                 <a:ea typeface="Helvetica Neue"/>
                 <a:sym typeface="Helvetica Neue"/>
               </a:rPr>
-              <a:t>PLACEHOLDER · figs/stats.json January 2022 to Tuesday, October 20, 2026 N = 3,001 NC samples analyzed Mailed in from 86 harm reduction programs Collected across 59 counties 251 distinct substances detected to date Unique samples = n_distinct(sampleid) · substances from lab_detail.substance · includes samples with date_complete 26 Jan 2022 – 20 Oct 2026 r/build_nightly.R → figs/stats.json</a:t>
+              <a:t>PLACEHOLDER · figs/stats.json January 2022 to Wednesday, October 21, 2026 N = 3,002 NC samples analyzed Mailed in from 86 harm reduction programs Collected across 59 counties 251 distinct substances detected to date Unique samples = n_distinct(sampleid) · substances from lab_detail.substance · includes samples with date_complete 26 Jan 2022 – 21 Oct 2026 r/build_nightly.R → figs/stats.json</a:t>
             </a:r>
           </a:p>
         </p:txBody>
@@ -2762,7 +2762,7 @@
                 <a:ea typeface="Helvetica Neue"/>
                 <a:sym typeface="Helvetica Neue"/>
               </a:rPr>
-              <a:t>Unique samples = n_distinct(sampleid) · substances from lab_detail.substance · includes samples with date_complete 26 Jan 2022 – 20 Oct 2026</a:t>
+              <a:t>Unique samples = n_distinct(sampleid) · substances from lab_detail.substance · includes samples with date_complete 26 Jan 2022 – 21 Oct 2026</a:t>
             </a:r>
           </a:p>
         </p:txBody>
@@ -3184,7 +3184,7 @@
                 <a:ea typeface="Helvetica Neue"/>
                 <a:sym typeface="Helvetica Neue"/>
               </a:rPr>
-              <a:t>County = samplecounty · left: ≥1 completed analysis ever · right: unique samples per county (sqrt color scale) · all time: 26 Jan 2022 – 20 Oct 2026 · last 12 months: 21 Oct 2025 – 20 Oct 2026* · coverage reflects participation, not prevalence</a:t>
+              <a:t>County = samplecounty · left: ≥1 completed analysis ever · right: unique samples per county (sqrt color scale) · all time: 26 Jan 2022 – 21 Oct 2026 · last 12 months: 22 Oct 2025 – 21 Oct 2026* · coverage reflects participation, not prevalence</a:t>
             </a:r>
           </a:p>
         </p:txBody>
@@ -3505,7 +3505,7 @@
                 <a:ea typeface="Helvetica Neue"/>
                 <a:sym typeface="Helvetica Neue"/>
               </a:rPr>
-              <a:t>expectedsubstance (verbatim card write-in, semicolon lists split) · derived flags: expect_opioid, expect_fentanyl, expect_meth, expect_cocaine, expect_stimulant… · includes samples with date_complete 26 Jan 2022 – 20 Oct 2026 · data table: Appendix A2</a:t>
+              <a:t>expectedsubstance (verbatim card write-in, semicolon lists split) · derived flags: expect_opioid, expect_fentanyl, expect_meth, expect_cocaine, expect_stimulant… · includes samples with date_complete 26 Jan 2022 – 21 Oct 2026 · data table: Appendix A2</a:t>
             </a:r>
           </a:p>
         </p:txBody>
@@ -3703,7 +3703,7 @@
                 <a:ea typeface="Helvetica Neue"/>
                 <a:sym typeface="Helvetica Neue"/>
               </a:rPr>
-              <a:t>Numerator uses lab_*_any (primary or trace) among samples with expect_* = 1 · includes samples with date_complete 26 Jan 2022 – 20 Oct 2026 · data table: Appendix A3</a:t>
+              <a:t>Numerator uses lab_*_any (primary or trace) among samples with expect_* = 1 · includes samples with date_complete 26 Jan 2022 – 21 Oct 2026 · data table: Appendix A3</a:t>
             </a:r>
           </a:p>
         </p:txBody>
@@ -3901,7 +3901,7 @@
                 <a:ea typeface="Helvetica Neue"/>
                 <a:sym typeface="Helvetica Neue"/>
               </a:rPr>
-              <a:t>sensations (circled on card, semicolon lists split) · post-consumption samples only (consumed = 1) · includes samples with date_complete 26 Jan 2022 – 20 Oct 2026</a:t>
+              <a:t>sensations (circled on card, semicolon lists split) · post-consumption samples only (consumed = 1) · includes samples with date_complete 26 Jan 2022 – 21 Oct 2026</a:t>
             </a:r>
           </a:p>
         </p:txBody>
@@ -4125,7 +4125,7 @@
                 <a:ea typeface="Helvetica Neue"/>
                 <a:sym typeface="Helvetica Neue"/>
               </a:rPr>
-              <a:t>sensations semicolon lists parsed per report · consumed = 1 only · denominator: consumed samples with lab_*_any = 1 · includes samples with date_complete 26 Jan 2022 – 20 Oct 2026</a:t>
+              <a:t>sensations semicolon lists parsed per report · consumed = 1 only · denominator: consumed samples with lab_*_any = 1 · includes samples with date_complete 26 Jan 2022 – 21 Oct 2026</a:t>
             </a:r>
           </a:p>
         </p:txBody>
@@ -4323,7 +4323,7 @@
                 <a:ea typeface="Helvetica Neue"/>
                 <a:sym typeface="Helvetica Neue"/>
               </a:rPr>
-              <a:t>Samples with methamphetamine or cocaine detected (any abundance); samples in both classes appear on both slides · sensations semicolon lists parsed + sen_strength (own denominator) · consumed = 1 only · before: 26 Jan 2022 – 20 Oct 2025 · past 12 months: 21 Oct 2025 – 20 Oct 2026* · Δ in percentage points</a:t>
+              <a:t>Samples with methamphetamine or cocaine detected (any abundance); samples in both classes appear on both slides · sensations semicolon lists parsed + sen_strength (own denominator) · consumed = 1 only · before: 26 Jan 2022 – 21 Oct 2025 · past 12 months: 22 Oct 2025 – 21 Oct 2026* · Δ in percentage points</a:t>
             </a:r>
           </a:p>
         </p:txBody>
@@ -4742,7 +4742,7 @@
                 <a:ea typeface="Helvetica Neue"/>
                 <a:sym typeface="Helvetica Neue"/>
               </a:rPr>
-              <a:t>Samples with an opioid (fentanyl, heroin) or benzodiazepine detected (any abundance); samples in both classes appear on both slides · sensations semicolon lists parsed + sen_strength (own denominator) · consumed = 1 only · before: 26 Jan 2022 – 20 Oct 2025 · past 12 months: 21 Oct 2025 – 20 Oct 2026* · Δ in percentage points</a:t>
+              <a:t>Samples with an opioid (fentanyl, heroin) or benzodiazepine detected (any abundance); samples in both classes appear on both slides · sensations semicolon lists parsed + sen_strength (own denominator) · consumed = 1 only · before: 26 Jan 2022 – 21 Oct 2025 · past 12 months: 22 Oct 2025 – 21 Oct 2026* · Δ in percentage points</a:t>
             </a:r>
           </a:p>
         </p:txBody>
@@ -5138,7 +5138,7 @@
                 <a:ea typeface="Helvetica Neue"/>
                 <a:sym typeface="Helvetica Neue"/>
               </a:rPr>
-              <a:t>color, texture (card v3+, semicolon lists split) · derived: bright_color excludes white/tan/brown family — orange bar above · includes samples with date_complete 26 Jan 2022 – 20 Oct 2026</a:t>
+              <a:t>color, texture (card v3+, semicolon lists split) · derived: bright_color excludes white/tan/brown family — orange bar above · includes samples with date_complete 26 Jan 2022 – 21 Oct 2026</a:t>
             </a:r>
           </a:p>
         </p:txBody>
@@ -5459,7 +5459,7 @@
                 <a:ea typeface="Helvetica Neue"/>
                 <a:sym typeface="Helvetica Neue"/>
               </a:rPr>
-              <a:t>Distribution of substances detected per sample, both definitions shown side by side · includes samples with date_complete 26 Jan 2022 – 20 Oct 2026</a:t>
+              <a:t>Distribution of substances detected per sample, both definitions shown side by side · includes samples with date_complete 26 Jan 2022 – 21 Oct 2026</a:t>
             </a:r>
           </a:p>
         </p:txBody>
@@ -5657,7 +5657,7 @@
                 <a:ea typeface="Helvetica Neue"/>
                 <a:sym typeface="Helvetica Neue"/>
               </a:rPr>
-              <a:t>lab_detail.substance counts · solid = primary abundance, light = trace · standardized names (PubChem-linked) · includes samples with date_complete 26 Jan 2022 – 20 Oct 2026</a:t>
+              <a:t>lab_detail.substance counts · solid = primary abundance, light = trace · standardized names (PubChem-linked) · includes samples with date_complete 26 Jan 2022 – 21 Oct 2026</a:t>
             </a:r>
           </a:p>
         </p:txBody>
@@ -5855,7 +5855,7 @@
                 <a:ea typeface="Helvetica Neue"/>
                 <a:sym typeface="Helvetica Neue"/>
               </a:rPr>
-              <a:t>lab_detail.substance counts · solid = primary abundance, light = trace · standardized names (PubChem-linked) · window: date_complete 21 Oct 2025 – 20 Oct 2026* (trailing 12 months, current month partial)</a:t>
+              <a:t>lab_detail.substance counts · solid = primary abundance, light = trace · standardized names (PubChem-linked) · window: date_complete 22 Oct 2025 – 21 Oct 2026* (trailing 12 months, current month partial)</a:t>
             </a:r>
           </a:p>
         </p:txBody>
@@ -6053,7 +6053,7 @@
                 <a:ea typeface="Helvetica Neue"/>
                 <a:sym typeface="Helvetica Neue"/>
               </a:rPr>
-              <a:t>Distribution of substances detected per sample, both definitions shown side by side · window: date_complete 21 Oct 2025 – 20 Oct 2026* (trailing 12 months, current month partial)</a:t>
+              <a:t>Distribution of substances detected per sample, both definitions shown side by side · window: date_complete 22 Oct 2025 – 21 Oct 2026* (trailing 12 months, current month partial)</a:t>
             </a:r>
           </a:p>
         </p:txBody>
@@ -18626,7 +18626,7 @@
                           <a:ea typeface="Helvetica Neue"/>
                           <a:sym typeface="Helvetica Neue"/>
                         </a:rPr>
-                        <a:t>456</a:t>
+                        <a:t>457</a:t>
                       </a:r>
                     </a:p>
                   </a:txBody>
@@ -20821,7 +20821,7 @@
                           <a:ea typeface="Helvetica Neue"/>
                           <a:sym typeface="Helvetica Neue"/>
                         </a:rPr>
-                        <a:t>536</a:t>
+                        <a:t>537</a:t>
                       </a:r>
                     </a:p>
                   </a:txBody>

</xml_diff>

<commit_message>
nightly deck: data through 2026-10-23
</commit_message>
<xml_diff>
--- a/docs/nc-drug-checking-latest.pptx
+++ b/docs/nc-drug-checking-latest.pptx
@@ -2418,7 +2418,7 @@
                 <a:ea typeface="Helvetica Neue"/>
                 <a:sym typeface="Helvetica Neue"/>
               </a:rPr>
-              <a:t>Generated Thursday, October 22, 2026 · 9:05 AM ET UNC Street Drug Analysis Lab · OpioidData.org · results.streetsafe.supply Download as PowerPoint</a:t>
+              <a:t>Generated Friday, October 23, 2026 · 8:44 AM ET UNC Street Drug Analysis Lab · OpioidData.org · results.streetsafe.supply Download as PowerPoint</a:t>
             </a:r>
           </a:p>
         </p:txBody>
@@ -2713,7 +2713,7 @@
                 <a:ea typeface="Helvetica Neue"/>
                 <a:sym typeface="Helvetica Neue"/>
               </a:rPr>
-              <a:t>PLACEHOLDER · figs/stats.json January 2022 to Wednesday, October 21, 2026 N = 3,002 NC samples analyzed Mailed in from 86 harm reduction programs Collected across 59 counties 251 distinct substances detected to date Unique samples = n_distinct(sampleid) · substances from lab_detail.substance · includes samples with date_complete 26 Jan 2022 – 21 Oct 2026 r/build_nightly.R → figs/stats.json</a:t>
+              <a:t>PLACEHOLDER · figs/stats.json January 2022 to Thursday, October 22, 2026 N = 3,012 NC samples analyzed Mailed in from 86 harm reduction programs Collected across 60 counties 251 distinct substances detected to date Unique samples = n_distinct(sampleid) · substances from lab_detail.substance · includes samples with date_complete 26 Jan 2022 – 22 Oct 2026 r/build_nightly.R → figs/stats.json</a:t>
             </a:r>
           </a:p>
         </p:txBody>
@@ -2762,7 +2762,7 @@
                 <a:ea typeface="Helvetica Neue"/>
                 <a:sym typeface="Helvetica Neue"/>
               </a:rPr>
-              <a:t>Unique samples = n_distinct(sampleid) · substances from lab_detail.substance · includes samples with date_complete 26 Jan 2022 – 21 Oct 2026</a:t>
+              <a:t>Unique samples = n_distinct(sampleid) · substances from lab_detail.substance · includes samples with date_complete 26 Jan 2022 – 22 Oct 2026</a:t>
             </a:r>
           </a:p>
         </p:txBody>
@@ -3184,7 +3184,7 @@
                 <a:ea typeface="Helvetica Neue"/>
                 <a:sym typeface="Helvetica Neue"/>
               </a:rPr>
-              <a:t>County = samplecounty · left: ≥1 completed analysis ever · right: unique samples per county (sqrt color scale) · all time: 26 Jan 2022 – 21 Oct 2026 · last 12 months: 22 Oct 2025 – 21 Oct 2026* · coverage reflects participation, not prevalence</a:t>
+              <a:t>County = samplecounty · left: ≥1 completed analysis ever · right: unique samples per county (sqrt color scale) · all time: 26 Jan 2022 – 22 Oct 2026 · last 12 months: 23 Oct 2025 – 22 Oct 2026* · coverage reflects participation, not prevalence</a:t>
             </a:r>
           </a:p>
         </p:txBody>
@@ -3505,7 +3505,7 @@
                 <a:ea typeface="Helvetica Neue"/>
                 <a:sym typeface="Helvetica Neue"/>
               </a:rPr>
-              <a:t>expectedsubstance (verbatim card write-in, semicolon lists split) · derived flags: expect_opioid, expect_fentanyl, expect_meth, expect_cocaine, expect_stimulant… · includes samples with date_complete 26 Jan 2022 – 21 Oct 2026 · data table: Appendix A2</a:t>
+              <a:t>expectedsubstance (verbatim card write-in, semicolon lists split) · derived flags: expect_opioid, expect_fentanyl, expect_meth, expect_cocaine, expect_stimulant… · includes samples with date_complete 26 Jan 2022 – 22 Oct 2026 · data table: Appendix A2</a:t>
             </a:r>
           </a:p>
         </p:txBody>
@@ -3703,7 +3703,7 @@
                 <a:ea typeface="Helvetica Neue"/>
                 <a:sym typeface="Helvetica Neue"/>
               </a:rPr>
-              <a:t>Numerator uses lab_*_any (primary or trace) among samples with expect_* = 1 · includes samples with date_complete 26 Jan 2022 – 21 Oct 2026 · data table: Appendix A3</a:t>
+              <a:t>Numerator uses lab_*_any (primary or trace) among samples with expect_* = 1 · includes samples with date_complete 26 Jan 2022 – 22 Oct 2026 · data table: Appendix A3</a:t>
             </a:r>
           </a:p>
         </p:txBody>
@@ -3901,7 +3901,7 @@
                 <a:ea typeface="Helvetica Neue"/>
                 <a:sym typeface="Helvetica Neue"/>
               </a:rPr>
-              <a:t>sensations (circled on card, semicolon lists split) · post-consumption samples only (consumed = 1) · includes samples with date_complete 26 Jan 2022 – 21 Oct 2026</a:t>
+              <a:t>sensations (circled on card, semicolon lists split) · post-consumption samples only (consumed = 1) · includes samples with date_complete 26 Jan 2022 – 22 Oct 2026</a:t>
             </a:r>
           </a:p>
         </p:txBody>
@@ -4125,7 +4125,7 @@
                 <a:ea typeface="Helvetica Neue"/>
                 <a:sym typeface="Helvetica Neue"/>
               </a:rPr>
-              <a:t>sensations semicolon lists parsed per report · consumed = 1 only · denominator: consumed samples with lab_*_any = 1 · includes samples with date_complete 26 Jan 2022 – 21 Oct 2026</a:t>
+              <a:t>sensations semicolon lists parsed per report · consumed = 1 only · denominator: consumed samples with lab_*_any = 1 · includes samples with date_complete 26 Jan 2022 – 22 Oct 2026</a:t>
             </a:r>
           </a:p>
         </p:txBody>
@@ -4323,7 +4323,7 @@
                 <a:ea typeface="Helvetica Neue"/>
                 <a:sym typeface="Helvetica Neue"/>
               </a:rPr>
-              <a:t>Samples with methamphetamine or cocaine detected (any abundance); samples in both classes appear on both slides · sensations semicolon lists parsed + sen_strength (own denominator) · consumed = 1 only · before: 26 Jan 2022 – 21 Oct 2025 · past 12 months: 22 Oct 2025 – 21 Oct 2026* · Δ in percentage points</a:t>
+              <a:t>Samples with methamphetamine or cocaine detected (any abundance); samples in both classes appear on both slides · sensations semicolon lists parsed + sen_strength (own denominator) · consumed = 1 only · before: 26 Jan 2022 – 22 Oct 2025 · past 12 months: 23 Oct 2025 – 22 Oct 2026* · Δ in percentage points</a:t>
             </a:r>
           </a:p>
         </p:txBody>
@@ -4742,7 +4742,7 @@
                 <a:ea typeface="Helvetica Neue"/>
                 <a:sym typeface="Helvetica Neue"/>
               </a:rPr>
-              <a:t>Samples with an opioid (fentanyl, heroin) or benzodiazepine detected (any abundance); samples in both classes appear on both slides · sensations semicolon lists parsed + sen_strength (own denominator) · consumed = 1 only · before: 26 Jan 2022 – 21 Oct 2025 · past 12 months: 22 Oct 2025 – 21 Oct 2026* · Δ in percentage points</a:t>
+              <a:t>Samples with an opioid (fentanyl, heroin) or benzodiazepine detected (any abundance); samples in both classes appear on both slides · sensations semicolon lists parsed + sen_strength (own denominator) · consumed = 1 only · before: 26 Jan 2022 – 22 Oct 2025 · past 12 months: 23 Oct 2025 – 22 Oct 2026* · Δ in percentage points</a:t>
             </a:r>
           </a:p>
         </p:txBody>
@@ -5138,7 +5138,7 @@
                 <a:ea typeface="Helvetica Neue"/>
                 <a:sym typeface="Helvetica Neue"/>
               </a:rPr>
-              <a:t>color, texture (card v3+, semicolon lists split) · derived: bright_color excludes white/tan/brown family — orange bar above · includes samples with date_complete 26 Jan 2022 – 21 Oct 2026</a:t>
+              <a:t>color, texture (card v3+, semicolon lists split) · derived: bright_color excludes white/tan/brown family — orange bar above · includes samples with date_complete 26 Jan 2022 – 22 Oct 2026</a:t>
             </a:r>
           </a:p>
         </p:txBody>
@@ -5459,7 +5459,7 @@
                 <a:ea typeface="Helvetica Neue"/>
                 <a:sym typeface="Helvetica Neue"/>
               </a:rPr>
-              <a:t>Distribution of substances detected per sample, both definitions shown side by side · includes samples with date_complete 26 Jan 2022 – 21 Oct 2026</a:t>
+              <a:t>Distribution of substances detected per sample, both definitions shown side by side · includes samples with date_complete 26 Jan 2022 – 22 Oct 2026</a:t>
             </a:r>
           </a:p>
         </p:txBody>
@@ -5657,7 +5657,7 @@
                 <a:ea typeface="Helvetica Neue"/>
                 <a:sym typeface="Helvetica Neue"/>
               </a:rPr>
-              <a:t>lab_detail.substance counts · solid = primary abundance, light = trace · standardized names (PubChem-linked) · includes samples with date_complete 26 Jan 2022 – 21 Oct 2026</a:t>
+              <a:t>lab_detail.substance counts · solid = primary abundance, light = trace · standardized names (PubChem-linked) · includes samples with date_complete 26 Jan 2022 – 22 Oct 2026</a:t>
             </a:r>
           </a:p>
         </p:txBody>
@@ -5855,7 +5855,7 @@
                 <a:ea typeface="Helvetica Neue"/>
                 <a:sym typeface="Helvetica Neue"/>
               </a:rPr>
-              <a:t>lab_detail.substance counts · solid = primary abundance, light = trace · standardized names (PubChem-linked) · window: date_complete 22 Oct 2025 – 21 Oct 2026* (trailing 12 months, current month partial)</a:t>
+              <a:t>lab_detail.substance counts · solid = primary abundance, light = trace · standardized names (PubChem-linked) · window: date_complete 23 Oct 2025 – 22 Oct 2026* (trailing 12 months, current month partial)</a:t>
             </a:r>
           </a:p>
         </p:txBody>
@@ -6053,7 +6053,7 @@
                 <a:ea typeface="Helvetica Neue"/>
                 <a:sym typeface="Helvetica Neue"/>
               </a:rPr>
-              <a:t>Distribution of substances detected per sample, both definitions shown side by side · window: date_complete 22 Oct 2025 – 21 Oct 2026* (trailing 12 months, current month partial)</a:t>
+              <a:t>Distribution of substances detected per sample, both definitions shown side by side · window: date_complete 23 Oct 2025 – 22 Oct 2026* (trailing 12 months, current month partial)</a:t>
             </a:r>
           </a:p>
         </p:txBody>
@@ -18626,7 +18626,7 @@
                           <a:ea typeface="Helvetica Neue"/>
                           <a:sym typeface="Helvetica Neue"/>
                         </a:rPr>
-                        <a:t>457</a:t>
+                        <a:t>461</a:t>
                       </a:r>
                     </a:p>
                   </a:txBody>
@@ -18974,7 +18974,7 @@
                           <a:ea typeface="Helvetica Neue"/>
                           <a:sym typeface="Helvetica Neue"/>
                         </a:rPr>
-                        <a:t>166</a:t>
+                        <a:t>167</a:t>
                       </a:r>
                     </a:p>
                   </a:txBody>
@@ -19090,7 +19090,7 @@
                           <a:ea typeface="Helvetica Neue"/>
                           <a:sym typeface="Helvetica Neue"/>
                         </a:rPr>
-                        <a:t>94</a:t>
+                        <a:t>95</a:t>
                       </a:r>
                     </a:p>
                   </a:txBody>
@@ -19206,7 +19206,7 @@
                           <a:ea typeface="Helvetica Neue"/>
                           <a:sym typeface="Helvetica Neue"/>
                         </a:rPr>
-                        <a:t>82</a:t>
+                        <a:t>84</a:t>
                       </a:r>
                     </a:p>
                   </a:txBody>
@@ -19670,7 +19670,7 @@
                           <a:ea typeface="Helvetica Neue"/>
                           <a:sym typeface="Helvetica Neue"/>
                         </a:rPr>
-                        <a:t>50</a:t>
+                        <a:t>52</a:t>
                       </a:r>
                     </a:p>
                   </a:txBody>
@@ -20821,7 +20821,7 @@
                           <a:ea typeface="Helvetica Neue"/>
                           <a:sym typeface="Helvetica Neue"/>
                         </a:rPr>
-                        <a:t>537</a:t>
+                        <a:t>541</a:t>
                       </a:r>
                     </a:p>
                   </a:txBody>
@@ -21051,7 +21051,7 @@
                           <a:ea typeface="Helvetica Neue"/>
                           <a:sym typeface="Helvetica Neue"/>
                         </a:rPr>
-                        <a:t>143</a:t>
+                        <a:t>144</a:t>
                       </a:r>
                     </a:p>
                   </a:txBody>

</xml_diff>

<commit_message>
nightly deck: data through 2026-10-24
</commit_message>
<xml_diff>
--- a/docs/nc-drug-checking-latest.pptx
+++ b/docs/nc-drug-checking-latest.pptx
@@ -2418,7 +2418,7 @@
                 <a:ea typeface="Helvetica Neue"/>
                 <a:sym typeface="Helvetica Neue"/>
               </a:rPr>
-              <a:t>Generated Friday, October 23, 2026 · 8:44 AM ET UNC Street Drug Analysis Lab · OpioidData.org · results.streetsafe.supply Download as PowerPoint</a:t>
+              <a:t>Generated Saturday, October 24, 2026 · 8:08 AM ET UNC Street Drug Analysis Lab · OpioidData.org · results.streetsafe.supply Download as PowerPoint</a:t>
             </a:r>
           </a:p>
         </p:txBody>
@@ -2713,7 +2713,7 @@
                 <a:ea typeface="Helvetica Neue"/>
                 <a:sym typeface="Helvetica Neue"/>
               </a:rPr>
-              <a:t>PLACEHOLDER · figs/stats.json January 2022 to Thursday, October 22, 2026 N = 3,012 NC samples analyzed Mailed in from 86 harm reduction programs Collected across 60 counties 251 distinct substances detected to date Unique samples = n_distinct(sampleid) · substances from lab_detail.substance · includes samples with date_complete 26 Jan 2022 – 22 Oct 2026 r/build_nightly.R → figs/stats.json</a:t>
+              <a:t>PLACEHOLDER · figs/stats.json January 2022 to Friday, October 23, 2026 N = 3,013 NC samples analyzed Mailed in from 86 harm reduction programs Collected across 60 counties 252 distinct substances detected to date Unique samples = n_distinct(sampleid) · substances from lab_detail.substance · includes samples with date_complete 26 Jan 2022 – 23 Oct 2026 r/build_nightly.R → figs/stats.json</a:t>
             </a:r>
           </a:p>
         </p:txBody>
@@ -2762,7 +2762,7 @@
                 <a:ea typeface="Helvetica Neue"/>
                 <a:sym typeface="Helvetica Neue"/>
               </a:rPr>
-              <a:t>Unique samples = n_distinct(sampleid) · substances from lab_detail.substance · includes samples with date_complete 26 Jan 2022 – 22 Oct 2026</a:t>
+              <a:t>Unique samples = n_distinct(sampleid) · substances from lab_detail.substance · includes samples with date_complete 26 Jan 2022 – 23 Oct 2026</a:t>
             </a:r>
           </a:p>
         </p:txBody>
@@ -3184,7 +3184,7 @@
                 <a:ea typeface="Helvetica Neue"/>
                 <a:sym typeface="Helvetica Neue"/>
               </a:rPr>
-              <a:t>County = samplecounty · left: ≥1 completed analysis ever · right: unique samples per county (sqrt color scale) · all time: 26 Jan 2022 – 22 Oct 2026 · last 12 months: 23 Oct 2025 – 22 Oct 2026* · coverage reflects participation, not prevalence</a:t>
+              <a:t>County = samplecounty · left: ≥1 completed analysis ever · right: unique samples per county (sqrt color scale) · all time: 26 Jan 2022 – 23 Oct 2026 · last 12 months: 24 Oct 2025 – 23 Oct 2026* · coverage reflects participation, not prevalence</a:t>
             </a:r>
           </a:p>
         </p:txBody>
@@ -3505,7 +3505,7 @@
                 <a:ea typeface="Helvetica Neue"/>
                 <a:sym typeface="Helvetica Neue"/>
               </a:rPr>
-              <a:t>expectedsubstance (verbatim card write-in, semicolon lists split) · derived flags: expect_opioid, expect_fentanyl, expect_meth, expect_cocaine, expect_stimulant… · includes samples with date_complete 26 Jan 2022 – 22 Oct 2026 · data table: Appendix A2</a:t>
+              <a:t>expectedsubstance (verbatim card write-in, semicolon lists split) · derived flags: expect_opioid, expect_fentanyl, expect_meth, expect_cocaine, expect_stimulant… · includes samples with date_complete 26 Jan 2022 – 23 Oct 2026 · data table: Appendix A2</a:t>
             </a:r>
           </a:p>
         </p:txBody>
@@ -3703,7 +3703,7 @@
                 <a:ea typeface="Helvetica Neue"/>
                 <a:sym typeface="Helvetica Neue"/>
               </a:rPr>
-              <a:t>Numerator uses lab_*_any (primary or trace) among samples with expect_* = 1 · includes samples with date_complete 26 Jan 2022 – 22 Oct 2026 · data table: Appendix A3</a:t>
+              <a:t>Numerator uses lab_*_any (primary or trace) among samples with expect_* = 1 · includes samples with date_complete 26 Jan 2022 – 23 Oct 2026 · data table: Appendix A3</a:t>
             </a:r>
           </a:p>
         </p:txBody>
@@ -3901,7 +3901,7 @@
                 <a:ea typeface="Helvetica Neue"/>
                 <a:sym typeface="Helvetica Neue"/>
               </a:rPr>
-              <a:t>sensations (circled on card, semicolon lists split) · post-consumption samples only (consumed = 1) · includes samples with date_complete 26 Jan 2022 – 22 Oct 2026</a:t>
+              <a:t>sensations (circled on card, semicolon lists split) · post-consumption samples only (consumed = 1) · includes samples with date_complete 26 Jan 2022 – 23 Oct 2026</a:t>
             </a:r>
           </a:p>
         </p:txBody>
@@ -4125,7 +4125,7 @@
                 <a:ea typeface="Helvetica Neue"/>
                 <a:sym typeface="Helvetica Neue"/>
               </a:rPr>
-              <a:t>sensations semicolon lists parsed per report · consumed = 1 only · denominator: consumed samples with lab_*_any = 1 · includes samples with date_complete 26 Jan 2022 – 22 Oct 2026</a:t>
+              <a:t>sensations semicolon lists parsed per report · consumed = 1 only · denominator: consumed samples with lab_*_any = 1 · includes samples with date_complete 26 Jan 2022 – 23 Oct 2026</a:t>
             </a:r>
           </a:p>
         </p:txBody>
@@ -4323,7 +4323,7 @@
                 <a:ea typeface="Helvetica Neue"/>
                 <a:sym typeface="Helvetica Neue"/>
               </a:rPr>
-              <a:t>Samples with methamphetamine or cocaine detected (any abundance); samples in both classes appear on both slides · sensations semicolon lists parsed + sen_strength (own denominator) · consumed = 1 only · before: 26 Jan 2022 – 22 Oct 2025 · past 12 months: 23 Oct 2025 – 22 Oct 2026* · Δ in percentage points</a:t>
+              <a:t>Samples with methamphetamine or cocaine detected (any abundance); samples in both classes appear on both slides · sensations semicolon lists parsed + sen_strength (own denominator) · consumed = 1 only · before: 26 Jan 2022 – 23 Oct 2025 · past 12 months: 24 Oct 2025 – 23 Oct 2026* · Δ in percentage points</a:t>
             </a:r>
           </a:p>
         </p:txBody>
@@ -4742,7 +4742,7 @@
                 <a:ea typeface="Helvetica Neue"/>
                 <a:sym typeface="Helvetica Neue"/>
               </a:rPr>
-              <a:t>Samples with an opioid (fentanyl, heroin) or benzodiazepine detected (any abundance); samples in both classes appear on both slides · sensations semicolon lists parsed + sen_strength (own denominator) · consumed = 1 only · before: 26 Jan 2022 – 22 Oct 2025 · past 12 months: 23 Oct 2025 – 22 Oct 2026* · Δ in percentage points</a:t>
+              <a:t>Samples with an opioid (fentanyl, heroin) or benzodiazepine detected (any abundance); samples in both classes appear on both slides · sensations semicolon lists parsed + sen_strength (own denominator) · consumed = 1 only · before: 26 Jan 2022 – 23 Oct 2025 · past 12 months: 24 Oct 2025 – 23 Oct 2026* · Δ in percentage points</a:t>
             </a:r>
           </a:p>
         </p:txBody>
@@ -5138,7 +5138,7 @@
                 <a:ea typeface="Helvetica Neue"/>
                 <a:sym typeface="Helvetica Neue"/>
               </a:rPr>
-              <a:t>color, texture (card v3+, semicolon lists split) · derived: bright_color excludes white/tan/brown family — orange bar above · includes samples with date_complete 26 Jan 2022 – 22 Oct 2026</a:t>
+              <a:t>color, texture (card v3+, semicolon lists split) · derived: bright_color excludes white/tan/brown family — orange bar above · includes samples with date_complete 26 Jan 2022 – 23 Oct 2026</a:t>
             </a:r>
           </a:p>
         </p:txBody>
@@ -5459,7 +5459,7 @@
                 <a:ea typeface="Helvetica Neue"/>
                 <a:sym typeface="Helvetica Neue"/>
               </a:rPr>
-              <a:t>Distribution of substances detected per sample, both definitions shown side by side · includes samples with date_complete 26 Jan 2022 – 22 Oct 2026</a:t>
+              <a:t>Distribution of substances detected per sample, both definitions shown side by side · includes samples with date_complete 26 Jan 2022 – 23 Oct 2026</a:t>
             </a:r>
           </a:p>
         </p:txBody>
@@ -5657,7 +5657,7 @@
                 <a:ea typeface="Helvetica Neue"/>
                 <a:sym typeface="Helvetica Neue"/>
               </a:rPr>
-              <a:t>lab_detail.substance counts · solid = primary abundance, light = trace · standardized names (PubChem-linked) · includes samples with date_complete 26 Jan 2022 – 22 Oct 2026</a:t>
+              <a:t>lab_detail.substance counts · solid = primary abundance, light = trace · standardized names (PubChem-linked) · includes samples with date_complete 26 Jan 2022 – 23 Oct 2026</a:t>
             </a:r>
           </a:p>
         </p:txBody>
@@ -5855,7 +5855,7 @@
                 <a:ea typeface="Helvetica Neue"/>
                 <a:sym typeface="Helvetica Neue"/>
               </a:rPr>
-              <a:t>lab_detail.substance counts · solid = primary abundance, light = trace · standardized names (PubChem-linked) · window: date_complete 23 Oct 2025 – 22 Oct 2026* (trailing 12 months, current month partial)</a:t>
+              <a:t>lab_detail.substance counts · solid = primary abundance, light = trace · standardized names (PubChem-linked) · window: date_complete 24 Oct 2025 – 23 Oct 2026* (trailing 12 months, current month partial)</a:t>
             </a:r>
           </a:p>
         </p:txBody>
@@ -6053,7 +6053,7 @@
                 <a:ea typeface="Helvetica Neue"/>
                 <a:sym typeface="Helvetica Neue"/>
               </a:rPr>
-              <a:t>Distribution of substances detected per sample, both definitions shown side by side · window: date_complete 23 Oct 2025 – 22 Oct 2026* (trailing 12 months, current month partial)</a:t>
+              <a:t>Distribution of substances detected per sample, both definitions shown side by side · window: date_complete 24 Oct 2025 – 23 Oct 2026* (trailing 12 months, current month partial)</a:t>
             </a:r>
           </a:p>
         </p:txBody>
@@ -11049,6 +11049,293 @@
                           <a:ea typeface="Helvetica Neue"/>
                           <a:sym typeface="Helvetica Neue"/>
                         </a:rPr>
+                        <a:t>psilocybin</a:t>
+                      </a:r>
+                    </a:p>
+                  </a:txBody>
+                  <a:tcPr anchor="ctr" marB="63500" marT="63500" marR="0" marL="0">
+                    <a:lnL algn="ctr" cmpd="sng" cap="flat" w="0">
+                      <a:noFill/>
+                      <a:prstDash val="solid"/>
+                    </a:lnL>
+                    <a:lnR algn="ctr" cmpd="sng" cap="flat" w="0">
+                      <a:noFill/>
+                      <a:prstDash val="solid"/>
+                    </a:lnR>
+                    <a:lnT algn="ctr" cmpd="sng" cap="flat" w="0">
+                      <a:noFill/>
+                      <a:prstDash val="solid"/>
+                    </a:lnT>
+                    <a:lnB algn="ctr" cmpd="sng" cap="flat" w="0">
+                      <a:noFill/>
+                      <a:prstDash val="solid"/>
+                    </a:lnB>
+                    <a:solidFill>
+                      <a:srgbClr val="FFFFFF">
+                        <a:alpha val="0"/>
+                      </a:srgbClr>
+                    </a:solidFill>
+                  </a:tcPr>
+                </a:tc>
+                <a:tc>
+                  <a:txBody>
+                    <a:bodyPr/>
+                    <a:lstStyle/>
+                    <a:p>
+                      <a:pPr algn="l" marL="63500" marR="63500">
+                        <a:lnSpc>
+                          <a:spcPct val="100000"/>
+                        </a:lnSpc>
+                        <a:spcBef>
+                          <a:spcPts val="500"/>
+                        </a:spcBef>
+                        <a:spcAft>
+                          <a:spcPts val="500"/>
+                        </a:spcAft>
+                        <a:buNone/>
+                      </a:pPr>
+                      <a:r>
+                        <a:rPr cap="none" sz="1200" i="0" b="0" u="none" strike="noStrike">
+                          <a:solidFill>
+                            <a:srgbClr val="5B6770">
+                              <a:alpha val="100000"/>
+                            </a:srgbClr>
+                          </a:solidFill>
+                          <a:latin typeface="Helvetica Neue"/>
+                          <a:cs typeface="Helvetica Neue"/>
+                          <a:ea typeface="Helvetica Neue"/>
+                          <a:sym typeface="Helvetica Neue"/>
+                        </a:rPr>
+                        <a:t>23 Oct 2026</a:t>
+                      </a:r>
+                    </a:p>
+                  </a:txBody>
+                  <a:tcPr anchor="ctr" marB="63500" marT="63500" marR="0" marL="0">
+                    <a:lnL algn="ctr" cmpd="sng" cap="flat" w="0">
+                      <a:noFill/>
+                      <a:prstDash val="solid"/>
+                    </a:lnL>
+                    <a:lnR algn="ctr" cmpd="sng" cap="flat" w="0">
+                      <a:noFill/>
+                      <a:prstDash val="solid"/>
+                    </a:lnR>
+                    <a:lnT algn="ctr" cmpd="sng" cap="flat" w="0">
+                      <a:noFill/>
+                      <a:prstDash val="solid"/>
+                    </a:lnT>
+                    <a:lnB algn="ctr" cmpd="sng" cap="flat" w="0">
+                      <a:noFill/>
+                      <a:prstDash val="solid"/>
+                    </a:lnB>
+                    <a:solidFill>
+                      <a:srgbClr val="FFFFFF">
+                        <a:alpha val="0"/>
+                      </a:srgbClr>
+                    </a:solidFill>
+                  </a:tcPr>
+                </a:tc>
+                <a:tc>
+                  <a:txBody>
+                    <a:bodyPr/>
+                    <a:lstStyle/>
+                    <a:p>
+                      <a:pPr algn="l" marL="63500" marR="63500">
+                        <a:lnSpc>
+                          <a:spcPct val="100000"/>
+                        </a:lnSpc>
+                        <a:spcBef>
+                          <a:spcPts val="500"/>
+                        </a:spcBef>
+                        <a:spcAft>
+                          <a:spcPts val="500"/>
+                        </a:spcAft>
+                        <a:buNone/>
+                      </a:pPr>
+                      <a:r>
+                        <a:rPr cap="none" sz="1200" i="0" b="0" u="none" strike="noStrike">
+                          <a:solidFill>
+                            <a:srgbClr val="5B6770">
+                              <a:alpha val="100000"/>
+                            </a:srgbClr>
+                          </a:solidFill>
+                          <a:latin typeface="Helvetica Neue"/>
+                          <a:cs typeface="Helvetica Neue"/>
+                          <a:ea typeface="Helvetica Neue"/>
+                          <a:sym typeface="Helvetica Neue"/>
+                        </a:rPr>
+                        <a:t>primary</a:t>
+                      </a:r>
+                    </a:p>
+                  </a:txBody>
+                  <a:tcPr anchor="ctr" marB="63500" marT="63500" marR="0" marL="0">
+                    <a:lnL algn="ctr" cmpd="sng" cap="flat" w="0">
+                      <a:noFill/>
+                      <a:prstDash val="solid"/>
+                    </a:lnL>
+                    <a:lnR algn="ctr" cmpd="sng" cap="flat" w="0">
+                      <a:noFill/>
+                      <a:prstDash val="solid"/>
+                    </a:lnR>
+                    <a:lnT algn="ctr" cmpd="sng" cap="flat" w="0">
+                      <a:noFill/>
+                      <a:prstDash val="solid"/>
+                    </a:lnT>
+                    <a:lnB algn="ctr" cmpd="sng" cap="flat" w="0">
+                      <a:noFill/>
+                      <a:prstDash val="solid"/>
+                    </a:lnB>
+                    <a:solidFill>
+                      <a:srgbClr val="FFFFFF">
+                        <a:alpha val="0"/>
+                      </a:srgbClr>
+                    </a:solidFill>
+                  </a:tcPr>
+                </a:tc>
+                <a:tc>
+                  <a:txBody>
+                    <a:bodyPr/>
+                    <a:lstStyle/>
+                    <a:p>
+                      <a:pPr algn="r" marL="63500" marR="63500">
+                        <a:lnSpc>
+                          <a:spcPct val="100000"/>
+                        </a:lnSpc>
+                        <a:spcBef>
+                          <a:spcPts val="500"/>
+                        </a:spcBef>
+                        <a:spcAft>
+                          <a:spcPts val="500"/>
+                        </a:spcAft>
+                        <a:buNone/>
+                      </a:pPr>
+                      <a:r>
+                        <a:rPr cap="none" sz="1200" i="0" b="0" u="none" strike="noStrike">
+                          <a:solidFill>
+                            <a:srgbClr val="5B6770">
+                              <a:alpha val="100000"/>
+                            </a:srgbClr>
+                          </a:solidFill>
+                          <a:latin typeface="Helvetica Neue"/>
+                          <a:cs typeface="Helvetica Neue"/>
+                          <a:ea typeface="Helvetica Neue"/>
+                          <a:sym typeface="Helvetica Neue"/>
+                        </a:rPr>
+                        <a:t>1</a:t>
+                      </a:r>
+                    </a:p>
+                  </a:txBody>
+                  <a:tcPr anchor="ctr" marB="63500" marT="63500" marR="0" marL="0">
+                    <a:lnL algn="ctr" cmpd="sng" cap="flat" w="0">
+                      <a:noFill/>
+                      <a:prstDash val="solid"/>
+                    </a:lnL>
+                    <a:lnR algn="ctr" cmpd="sng" cap="flat" w="0">
+                      <a:noFill/>
+                      <a:prstDash val="solid"/>
+                    </a:lnR>
+                    <a:lnT algn="ctr" cmpd="sng" cap="flat" w="0">
+                      <a:noFill/>
+                      <a:prstDash val="solid"/>
+                    </a:lnT>
+                    <a:lnB algn="ctr" cmpd="sng" cap="flat" w="0">
+                      <a:noFill/>
+                      <a:prstDash val="solid"/>
+                    </a:lnB>
+                    <a:solidFill>
+                      <a:srgbClr val="FFFFFF">
+                        <a:alpha val="0"/>
+                      </a:srgbClr>
+                    </a:solidFill>
+                  </a:tcPr>
+                </a:tc>
+                <a:tc>
+                  <a:txBody>
+                    <a:bodyPr/>
+                    <a:lstStyle/>
+                    <a:p>
+                      <a:pPr algn="l" marL="63500" marR="63500">
+                        <a:lnSpc>
+                          <a:spcPct val="100000"/>
+                        </a:lnSpc>
+                        <a:spcBef>
+                          <a:spcPts val="500"/>
+                        </a:spcBef>
+                        <a:spcAft>
+                          <a:spcPts val="500"/>
+                        </a:spcAft>
+                        <a:buNone/>
+                      </a:pPr>
+                      <a:r>
+                        <a:rPr cap="none" sz="1200" i="0" b="0" u="none" strike="noStrike">
+                          <a:solidFill>
+                            <a:srgbClr val="5B6770">
+                              <a:alpha val="100000"/>
+                            </a:srgbClr>
+                          </a:solidFill>
+                          <a:latin typeface="Helvetica Neue"/>
+                          <a:cs typeface="Helvetica Neue"/>
+                          <a:ea typeface="Helvetica Neue"/>
+                          <a:sym typeface="Helvetica Neue"/>
+                        </a:rPr>
+                        <a:t>603618</a:t>
+                      </a:r>
+                    </a:p>
+                  </a:txBody>
+                  <a:tcPr anchor="ctr" marB="63500" marT="63500" marR="0" marL="0">
+                    <a:lnL algn="ctr" cmpd="sng" cap="flat" w="0">
+                      <a:noFill/>
+                      <a:prstDash val="solid"/>
+                    </a:lnL>
+                    <a:lnR algn="ctr" cmpd="sng" cap="flat" w="0">
+                      <a:noFill/>
+                      <a:prstDash val="solid"/>
+                    </a:lnR>
+                    <a:lnT algn="ctr" cmpd="sng" cap="flat" w="0">
+                      <a:noFill/>
+                      <a:prstDash val="solid"/>
+                    </a:lnT>
+                    <a:lnB algn="ctr" cmpd="sng" cap="flat" w="0">
+                      <a:noFill/>
+                      <a:prstDash val="solid"/>
+                    </a:lnB>
+                    <a:solidFill>
+                      <a:srgbClr val="FFFFFF">
+                        <a:alpha val="0"/>
+                      </a:srgbClr>
+                    </a:solidFill>
+                  </a:tcPr>
+                </a:tc>
+              </a:tr>
+              <a:tr h="401320">
+                <a:tc>
+                  <a:txBody>
+                    <a:bodyPr/>
+                    <a:lstStyle/>
+                    <a:p>
+                      <a:pPr algn="l" marL="63500" marR="63500">
+                        <a:lnSpc>
+                          <a:spcPct val="100000"/>
+                        </a:lnSpc>
+                        <a:spcBef>
+                          <a:spcPts val="500"/>
+                        </a:spcBef>
+                        <a:spcAft>
+                          <a:spcPts val="500"/>
+                        </a:spcAft>
+                        <a:buNone/>
+                      </a:pPr>
+                      <a:r>
+                        <a:rPr cap="none" sz="1200" i="0" b="0" u="none" strike="noStrike">
+                          <a:solidFill>
+                            <a:srgbClr val="5B6770">
+                              <a:alpha val="100000"/>
+                            </a:srgbClr>
+                          </a:solidFill>
+                          <a:latin typeface="Helvetica Neue"/>
+                          <a:cs typeface="Helvetica Neue"/>
+                          <a:ea typeface="Helvetica Neue"/>
+                          <a:sym typeface="Helvetica Neue"/>
+                        </a:rPr>
                         <a:t>clonidine</a:t>
                       </a:r>
                     </a:p>
@@ -11071,8 +11358,8 @@
                       <a:prstDash val="solid"/>
                     </a:lnB>
                     <a:solidFill>
-                      <a:srgbClr val="FFFFFF">
-                        <a:alpha val="0"/>
+                      <a:srgbClr val="F4F8FB">
+                        <a:alpha val="100000"/>
                       </a:srgbClr>
                     </a:solidFill>
                   </a:tcPr>
@@ -11128,8 +11415,8 @@
                       <a:prstDash val="solid"/>
                     </a:lnB>
                     <a:solidFill>
-                      <a:srgbClr val="FFFFFF">
-                        <a:alpha val="0"/>
+                      <a:srgbClr val="F4F8FB">
+                        <a:alpha val="100000"/>
                       </a:srgbClr>
                     </a:solidFill>
                   </a:tcPr>
@@ -11185,8 +11472,8 @@
                       <a:prstDash val="solid"/>
                     </a:lnB>
                     <a:solidFill>
-                      <a:srgbClr val="FFFFFF">
-                        <a:alpha val="0"/>
+                      <a:srgbClr val="F4F8FB">
+                        <a:alpha val="100000"/>
                       </a:srgbClr>
                     </a:solidFill>
                   </a:tcPr>
@@ -11242,8 +11529,8 @@
                       <a:prstDash val="solid"/>
                     </a:lnB>
                     <a:solidFill>
-                      <a:srgbClr val="FFFFFF">
-                        <a:alpha val="0"/>
+                      <a:srgbClr val="F4F8FB">
+                        <a:alpha val="100000"/>
                       </a:srgbClr>
                     </a:solidFill>
                   </a:tcPr>
@@ -11299,8 +11586,8 @@
                       <a:prstDash val="solid"/>
                     </a:lnB>
                     <a:solidFill>
-                      <a:srgbClr val="FFFFFF">
-                        <a:alpha val="0"/>
+                      <a:srgbClr val="F4F8FB">
+                        <a:alpha val="100000"/>
                       </a:srgbClr>
                     </a:solidFill>
                   </a:tcPr>
@@ -11358,8 +11645,8 @@
                       <a:prstDash val="solid"/>
                     </a:lnB>
                     <a:solidFill>
-                      <a:srgbClr val="F4F8FB">
-                        <a:alpha val="100000"/>
+                      <a:srgbClr val="FFFFFF">
+                        <a:alpha val="0"/>
                       </a:srgbClr>
                     </a:solidFill>
                   </a:tcPr>
@@ -11415,8 +11702,8 @@
                       <a:prstDash val="solid"/>
                     </a:lnB>
                     <a:solidFill>
-                      <a:srgbClr val="F4F8FB">
-                        <a:alpha val="100000"/>
+                      <a:srgbClr val="FFFFFF">
+                        <a:alpha val="0"/>
                       </a:srgbClr>
                     </a:solidFill>
                   </a:tcPr>
@@ -11472,8 +11759,8 @@
                       <a:prstDash val="solid"/>
                     </a:lnB>
                     <a:solidFill>
-                      <a:srgbClr val="F4F8FB">
-                        <a:alpha val="100000"/>
+                      <a:srgbClr val="FFFFFF">
+                        <a:alpha val="0"/>
                       </a:srgbClr>
                     </a:solidFill>
                   </a:tcPr>
@@ -11529,8 +11816,8 @@
                       <a:prstDash val="solid"/>
                     </a:lnB>
                     <a:solidFill>
-                      <a:srgbClr val="F4F8FB">
-                        <a:alpha val="100000"/>
+                      <a:srgbClr val="FFFFFF">
+                        <a:alpha val="0"/>
                       </a:srgbClr>
                     </a:solidFill>
                   </a:tcPr>
@@ -11586,8 +11873,8 @@
                       <a:prstDash val="solid"/>
                     </a:lnB>
                     <a:solidFill>
-                      <a:srgbClr val="F4F8FB">
-                        <a:alpha val="100000"/>
+                      <a:srgbClr val="FFFFFF">
+                        <a:alpha val="0"/>
                       </a:srgbClr>
                     </a:solidFill>
                   </a:tcPr>
@@ -11645,8 +11932,8 @@
                       <a:prstDash val="solid"/>
                     </a:lnB>
                     <a:solidFill>
-                      <a:srgbClr val="FFFFFF">
-                        <a:alpha val="0"/>
+                      <a:srgbClr val="F4F8FB">
+                        <a:alpha val="100000"/>
                       </a:srgbClr>
                     </a:solidFill>
                   </a:tcPr>
@@ -11702,8 +11989,8 @@
                       <a:prstDash val="solid"/>
                     </a:lnB>
                     <a:solidFill>
-                      <a:srgbClr val="FFFFFF">
-                        <a:alpha val="0"/>
+                      <a:srgbClr val="F4F8FB">
+                        <a:alpha val="100000"/>
                       </a:srgbClr>
                     </a:solidFill>
                   </a:tcPr>
@@ -11759,8 +12046,8 @@
                       <a:prstDash val="solid"/>
                     </a:lnB>
                     <a:solidFill>
-                      <a:srgbClr val="FFFFFF">
-                        <a:alpha val="0"/>
+                      <a:srgbClr val="F4F8FB">
+                        <a:alpha val="100000"/>
                       </a:srgbClr>
                     </a:solidFill>
                   </a:tcPr>
@@ -11816,8 +12103,8 @@
                       <a:prstDash val="solid"/>
                     </a:lnB>
                     <a:solidFill>
-                      <a:srgbClr val="FFFFFF">
-                        <a:alpha val="0"/>
+                      <a:srgbClr val="F4F8FB">
+                        <a:alpha val="100000"/>
                       </a:srgbClr>
                     </a:solidFill>
                   </a:tcPr>
@@ -11873,8 +12160,8 @@
                       <a:prstDash val="solid"/>
                     </a:lnB>
                     <a:solidFill>
-                      <a:srgbClr val="FFFFFF">
-                        <a:alpha val="0"/>
+                      <a:srgbClr val="F4F8FB">
+                        <a:alpha val="100000"/>
                       </a:srgbClr>
                     </a:solidFill>
                   </a:tcPr>
@@ -11932,8 +12219,8 @@
                       <a:prstDash val="solid"/>
                     </a:lnB>
                     <a:solidFill>
-                      <a:srgbClr val="F4F8FB">
-                        <a:alpha val="100000"/>
+                      <a:srgbClr val="FFFFFF">
+                        <a:alpha val="0"/>
                       </a:srgbClr>
                     </a:solidFill>
                   </a:tcPr>
@@ -11989,8 +12276,8 @@
                       <a:prstDash val="solid"/>
                     </a:lnB>
                     <a:solidFill>
-                      <a:srgbClr val="F4F8FB">
-                        <a:alpha val="100000"/>
+                      <a:srgbClr val="FFFFFF">
+                        <a:alpha val="0"/>
                       </a:srgbClr>
                     </a:solidFill>
                   </a:tcPr>
@@ -12046,8 +12333,8 @@
                       <a:prstDash val="solid"/>
                     </a:lnB>
                     <a:solidFill>
-                      <a:srgbClr val="F4F8FB">
-                        <a:alpha val="100000"/>
+                      <a:srgbClr val="FFFFFF">
+                        <a:alpha val="0"/>
                       </a:srgbClr>
                     </a:solidFill>
                   </a:tcPr>
@@ -12103,8 +12390,8 @@
                       <a:prstDash val="solid"/>
                     </a:lnB>
                     <a:solidFill>
-                      <a:srgbClr val="F4F8FB">
-                        <a:alpha val="100000"/>
+                      <a:srgbClr val="FFFFFF">
+                        <a:alpha val="0"/>
                       </a:srgbClr>
                     </a:solidFill>
                   </a:tcPr>
@@ -12160,8 +12447,8 @@
                       <a:prstDash val="solid"/>
                     </a:lnB>
                     <a:solidFill>
-                      <a:srgbClr val="F4F8FB">
-                        <a:alpha val="100000"/>
+                      <a:srgbClr val="FFFFFF">
+                        <a:alpha val="0"/>
                       </a:srgbClr>
                     </a:solidFill>
                   </a:tcPr>
@@ -12219,8 +12506,8 @@
                       <a:prstDash val="solid"/>
                     </a:lnB>
                     <a:solidFill>
-                      <a:srgbClr val="FFFFFF">
-                        <a:alpha val="0"/>
+                      <a:srgbClr val="F4F8FB">
+                        <a:alpha val="100000"/>
                       </a:srgbClr>
                     </a:solidFill>
                   </a:tcPr>
@@ -12276,8 +12563,8 @@
                       <a:prstDash val="solid"/>
                     </a:lnB>
                     <a:solidFill>
-                      <a:srgbClr val="FFFFFF">
-                        <a:alpha val="0"/>
+                      <a:srgbClr val="F4F8FB">
+                        <a:alpha val="100000"/>
                       </a:srgbClr>
                     </a:solidFill>
                   </a:tcPr>
@@ -12333,8 +12620,8 @@
                       <a:prstDash val="solid"/>
                     </a:lnB>
                     <a:solidFill>
-                      <a:srgbClr val="FFFFFF">
-                        <a:alpha val="0"/>
+                      <a:srgbClr val="F4F8FB">
+                        <a:alpha val="100000"/>
                       </a:srgbClr>
                     </a:solidFill>
                   </a:tcPr>
@@ -12390,8 +12677,8 @@
                       <a:prstDash val="solid"/>
                     </a:lnB>
                     <a:solidFill>
-                      <a:srgbClr val="FFFFFF">
-                        <a:alpha val="0"/>
+                      <a:srgbClr val="F4F8FB">
+                        <a:alpha val="100000"/>
                       </a:srgbClr>
                     </a:solidFill>
                   </a:tcPr>
@@ -12447,8 +12734,8 @@
                       <a:prstDash val="solid"/>
                     </a:lnB>
                     <a:solidFill>
-                      <a:srgbClr val="FFFFFF">
-                        <a:alpha val="0"/>
+                      <a:srgbClr val="F4F8FB">
+                        <a:alpha val="100000"/>
                       </a:srgbClr>
                     </a:solidFill>
                   </a:tcPr>
@@ -12506,8 +12793,8 @@
                       <a:prstDash val="solid"/>
                     </a:lnB>
                     <a:solidFill>
-                      <a:srgbClr val="F4F8FB">
-                        <a:alpha val="100000"/>
+                      <a:srgbClr val="FFFFFF">
+                        <a:alpha val="0"/>
                       </a:srgbClr>
                     </a:solidFill>
                   </a:tcPr>
@@ -12563,8 +12850,8 @@
                       <a:prstDash val="solid"/>
                     </a:lnB>
                     <a:solidFill>
-                      <a:srgbClr val="F4F8FB">
-                        <a:alpha val="100000"/>
+                      <a:srgbClr val="FFFFFF">
+                        <a:alpha val="0"/>
                       </a:srgbClr>
                     </a:solidFill>
                   </a:tcPr>
@@ -12620,8 +12907,8 @@
                       <a:prstDash val="solid"/>
                     </a:lnB>
                     <a:solidFill>
-                      <a:srgbClr val="F4F8FB">
-                        <a:alpha val="100000"/>
+                      <a:srgbClr val="FFFFFF">
+                        <a:alpha val="0"/>
                       </a:srgbClr>
                     </a:solidFill>
                   </a:tcPr>
@@ -12677,8 +12964,8 @@
                       <a:prstDash val="solid"/>
                     </a:lnB>
                     <a:solidFill>
-                      <a:srgbClr val="F4F8FB">
-                        <a:alpha val="100000"/>
+                      <a:srgbClr val="FFFFFF">
+                        <a:alpha val="0"/>
                       </a:srgbClr>
                     </a:solidFill>
                   </a:tcPr>
@@ -12734,8 +13021,8 @@
                       <a:prstDash val="solid"/>
                     </a:lnB>
                     <a:solidFill>
-                      <a:srgbClr val="F4F8FB">
-                        <a:alpha val="100000"/>
+                      <a:srgbClr val="FFFFFF">
+                        <a:alpha val="0"/>
                       </a:srgbClr>
                     </a:solidFill>
                   </a:tcPr>
@@ -12793,8 +13080,8 @@
                       <a:prstDash val="solid"/>
                     </a:lnB>
                     <a:solidFill>
-                      <a:srgbClr val="FFFFFF">
-                        <a:alpha val="0"/>
+                      <a:srgbClr val="F4F8FB">
+                        <a:alpha val="100000"/>
                       </a:srgbClr>
                     </a:solidFill>
                   </a:tcPr>
@@ -12850,8 +13137,8 @@
                       <a:prstDash val="solid"/>
                     </a:lnB>
                     <a:solidFill>
-                      <a:srgbClr val="FFFFFF">
-                        <a:alpha val="0"/>
+                      <a:srgbClr val="F4F8FB">
+                        <a:alpha val="100000"/>
                       </a:srgbClr>
                     </a:solidFill>
                   </a:tcPr>
@@ -12907,8 +13194,8 @@
                       <a:prstDash val="solid"/>
                     </a:lnB>
                     <a:solidFill>
-                      <a:srgbClr val="FFFFFF">
-                        <a:alpha val="0"/>
+                      <a:srgbClr val="F4F8FB">
+                        <a:alpha val="100000"/>
                       </a:srgbClr>
                     </a:solidFill>
                   </a:tcPr>
@@ -12964,8 +13251,8 @@
                       <a:prstDash val="solid"/>
                     </a:lnB>
                     <a:solidFill>
-                      <a:srgbClr val="FFFFFF">
-                        <a:alpha val="0"/>
+                      <a:srgbClr val="F4F8FB">
+                        <a:alpha val="100000"/>
                       </a:srgbClr>
                     </a:solidFill>
                   </a:tcPr>
@@ -13021,8 +13308,8 @@
                       <a:prstDash val="solid"/>
                     </a:lnB>
                     <a:solidFill>
-                      <a:srgbClr val="FFFFFF">
-                        <a:alpha val="0"/>
+                      <a:srgbClr val="F4F8FB">
+                        <a:alpha val="100000"/>
                       </a:srgbClr>
                     </a:solidFill>
                   </a:tcPr>
@@ -13080,8 +13367,8 @@
                       <a:prstDash val="solid"/>
                     </a:lnB>
                     <a:solidFill>
-                      <a:srgbClr val="F4F8FB">
-                        <a:alpha val="100000"/>
+                      <a:srgbClr val="FFFFFF">
+                        <a:alpha val="0"/>
                       </a:srgbClr>
                     </a:solidFill>
                   </a:tcPr>
@@ -13137,8 +13424,8 @@
                       <a:prstDash val="solid"/>
                     </a:lnB>
                     <a:solidFill>
-                      <a:srgbClr val="F4F8FB">
-                        <a:alpha val="100000"/>
+                      <a:srgbClr val="FFFFFF">
+                        <a:alpha val="0"/>
                       </a:srgbClr>
                     </a:solidFill>
                   </a:tcPr>
@@ -13194,8 +13481,8 @@
                       <a:prstDash val="solid"/>
                     </a:lnB>
                     <a:solidFill>
-                      <a:srgbClr val="F4F8FB">
-                        <a:alpha val="100000"/>
+                      <a:srgbClr val="FFFFFF">
+                        <a:alpha val="0"/>
                       </a:srgbClr>
                     </a:solidFill>
                   </a:tcPr>
@@ -13251,8 +13538,8 @@
                       <a:prstDash val="solid"/>
                     </a:lnB>
                     <a:solidFill>
-                      <a:srgbClr val="F4F8FB">
-                        <a:alpha val="100000"/>
+                      <a:srgbClr val="FFFFFF">
+                        <a:alpha val="0"/>
                       </a:srgbClr>
                     </a:solidFill>
                   </a:tcPr>
@@ -13308,8 +13595,8 @@
                       <a:prstDash val="solid"/>
                     </a:lnB>
                     <a:solidFill>
-                      <a:srgbClr val="F4F8FB">
-                        <a:alpha val="100000"/>
+                      <a:srgbClr val="FFFFFF">
+                        <a:alpha val="0"/>
                       </a:srgbClr>
                     </a:solidFill>
                   </a:tcPr>
@@ -13367,8 +13654,8 @@
                       <a:prstDash val="solid"/>
                     </a:lnB>
                     <a:solidFill>
-                      <a:srgbClr val="FFFFFF">
-                        <a:alpha val="0"/>
+                      <a:srgbClr val="F4F8FB">
+                        <a:alpha val="100000"/>
                       </a:srgbClr>
                     </a:solidFill>
                   </a:tcPr>
@@ -13424,8 +13711,8 @@
                       <a:prstDash val="solid"/>
                     </a:lnB>
                     <a:solidFill>
-                      <a:srgbClr val="FFFFFF">
-                        <a:alpha val="0"/>
+                      <a:srgbClr val="F4F8FB">
+                        <a:alpha val="100000"/>
                       </a:srgbClr>
                     </a:solidFill>
                   </a:tcPr>
@@ -13481,8 +13768,8 @@
                       <a:prstDash val="solid"/>
                     </a:lnB>
                     <a:solidFill>
-                      <a:srgbClr val="FFFFFF">
-                        <a:alpha val="0"/>
+                      <a:srgbClr val="F4F8FB">
+                        <a:alpha val="100000"/>
                       </a:srgbClr>
                     </a:solidFill>
                   </a:tcPr>
@@ -13538,8 +13825,8 @@
                       <a:prstDash val="solid"/>
                     </a:lnB>
                     <a:solidFill>
-                      <a:srgbClr val="FFFFFF">
-                        <a:alpha val="0"/>
+                      <a:srgbClr val="F4F8FB">
+                        <a:alpha val="100000"/>
                       </a:srgbClr>
                     </a:solidFill>
                   </a:tcPr>
@@ -13595,8 +13882,8 @@
                       <a:prstDash val="solid"/>
                     </a:lnB>
                     <a:solidFill>
-                      <a:srgbClr val="FFFFFF">
-                        <a:alpha val="0"/>
+                      <a:srgbClr val="F4F8FB">
+                        <a:alpha val="100000"/>
                       </a:srgbClr>
                     </a:solidFill>
                   </a:tcPr>
@@ -13654,8 +13941,8 @@
                       <a:prstDash val="solid"/>
                     </a:lnB>
                     <a:solidFill>
-                      <a:srgbClr val="F4F8FB">
-                        <a:alpha val="100000"/>
+                      <a:srgbClr val="FFFFFF">
+                        <a:alpha val="0"/>
                       </a:srgbClr>
                     </a:solidFill>
                   </a:tcPr>
@@ -13711,8 +13998,8 @@
                       <a:prstDash val="solid"/>
                     </a:lnB>
                     <a:solidFill>
-                      <a:srgbClr val="F4F8FB">
-                        <a:alpha val="100000"/>
+                      <a:srgbClr val="FFFFFF">
+                        <a:alpha val="0"/>
                       </a:srgbClr>
                     </a:solidFill>
                   </a:tcPr>
@@ -13768,8 +14055,8 @@
                       <a:prstDash val="solid"/>
                     </a:lnB>
                     <a:solidFill>
-                      <a:srgbClr val="F4F8FB">
-                        <a:alpha val="100000"/>
+                      <a:srgbClr val="FFFFFF">
+                        <a:alpha val="0"/>
                       </a:srgbClr>
                     </a:solidFill>
                   </a:tcPr>
@@ -13825,8 +14112,8 @@
                       <a:prstDash val="solid"/>
                     </a:lnB>
                     <a:solidFill>
-                      <a:srgbClr val="F4F8FB">
-                        <a:alpha val="100000"/>
+                      <a:srgbClr val="FFFFFF">
+                        <a:alpha val="0"/>
                       </a:srgbClr>
                     </a:solidFill>
                   </a:tcPr>
@@ -13882,14 +14169,14 @@
                       <a:prstDash val="solid"/>
                     </a:lnB>
                     <a:solidFill>
-                      <a:srgbClr val="F4F8FB">
-                        <a:alpha val="100000"/>
+                      <a:srgbClr val="FFFFFF">
+                        <a:alpha val="0"/>
                       </a:srgbClr>
                     </a:solidFill>
                   </a:tcPr>
                 </a:tc>
               </a:tr>
-              <a:tr h="401320">
+              <a:tr h="410845">
                 <a:tc>
                   <a:txBody>
                     <a:bodyPr/>
@@ -13936,13 +14223,17 @@
                       <a:noFill/>
                       <a:prstDash val="solid"/>
                     </a:lnT>
-                    <a:lnB algn="ctr" cmpd="sng" cap="flat" w="0">
-                      <a:noFill/>
+                    <a:lnB algn="ctr" cmpd="sng" cap="flat" w="19050">
+                      <a:solidFill>
+                        <a:srgbClr val="666666">
+                          <a:alpha val="100000"/>
+                        </a:srgbClr>
+                      </a:solidFill>
                       <a:prstDash val="solid"/>
                     </a:lnB>
                     <a:solidFill>
-                      <a:srgbClr val="FFFFFF">
-                        <a:alpha val="0"/>
+                      <a:srgbClr val="F4F8FB">
+                        <a:alpha val="100000"/>
                       </a:srgbClr>
                     </a:solidFill>
                   </a:tcPr>
@@ -13993,13 +14284,17 @@
                       <a:noFill/>
                       <a:prstDash val="solid"/>
                     </a:lnT>
-                    <a:lnB algn="ctr" cmpd="sng" cap="flat" w="0">
-                      <a:noFill/>
+                    <a:lnB algn="ctr" cmpd="sng" cap="flat" w="19050">
+                      <a:solidFill>
+                        <a:srgbClr val="666666">
+                          <a:alpha val="100000"/>
+                        </a:srgbClr>
+                      </a:solidFill>
                       <a:prstDash val="solid"/>
                     </a:lnB>
                     <a:solidFill>
-                      <a:srgbClr val="FFFFFF">
-                        <a:alpha val="0"/>
+                      <a:srgbClr val="F4F8FB">
+                        <a:alpha val="100000"/>
                       </a:srgbClr>
                     </a:solidFill>
                   </a:tcPr>
@@ -14050,13 +14345,17 @@
                       <a:noFill/>
                       <a:prstDash val="solid"/>
                     </a:lnT>
-                    <a:lnB algn="ctr" cmpd="sng" cap="flat" w="0">
-                      <a:noFill/>
+                    <a:lnB algn="ctr" cmpd="sng" cap="flat" w="19050">
+                      <a:solidFill>
+                        <a:srgbClr val="666666">
+                          <a:alpha val="100000"/>
+                        </a:srgbClr>
+                      </a:solidFill>
                       <a:prstDash val="solid"/>
                     </a:lnB>
                     <a:solidFill>
-                      <a:srgbClr val="FFFFFF">
-                        <a:alpha val="0"/>
+                      <a:srgbClr val="F4F8FB">
+                        <a:alpha val="100000"/>
                       </a:srgbClr>
                     </a:solidFill>
                   </a:tcPr>
@@ -14107,122 +14406,6 @@
                       <a:noFill/>
                       <a:prstDash val="solid"/>
                     </a:lnT>
-                    <a:lnB algn="ctr" cmpd="sng" cap="flat" w="0">
-                      <a:noFill/>
-                      <a:prstDash val="solid"/>
-                    </a:lnB>
-                    <a:solidFill>
-                      <a:srgbClr val="FFFFFF">
-                        <a:alpha val="0"/>
-                      </a:srgbClr>
-                    </a:solidFill>
-                  </a:tcPr>
-                </a:tc>
-                <a:tc>
-                  <a:txBody>
-                    <a:bodyPr/>
-                    <a:lstStyle/>
-                    <a:p>
-                      <a:pPr algn="l" marL="63500" marR="63500">
-                        <a:lnSpc>
-                          <a:spcPct val="100000"/>
-                        </a:lnSpc>
-                        <a:spcBef>
-                          <a:spcPts val="500"/>
-                        </a:spcBef>
-                        <a:spcAft>
-                          <a:spcPts val="500"/>
-                        </a:spcAft>
-                        <a:buNone/>
-                      </a:pPr>
-                      <a:r>
-                        <a:rPr cap="none" sz="1200" i="0" b="0" u="none" strike="noStrike">
-                          <a:solidFill>
-                            <a:srgbClr val="5B6770">
-                              <a:alpha val="100000"/>
-                            </a:srgbClr>
-                          </a:solidFill>
-                          <a:latin typeface="Helvetica Neue"/>
-                          <a:cs typeface="Helvetica Neue"/>
-                          <a:ea typeface="Helvetica Neue"/>
-                          <a:sym typeface="Helvetica Neue"/>
-                        </a:rPr>
-                        <a:t>816795</a:t>
-                      </a:r>
-                    </a:p>
-                  </a:txBody>
-                  <a:tcPr anchor="ctr" marB="63500" marT="63500" marR="0" marL="0">
-                    <a:lnL algn="ctr" cmpd="sng" cap="flat" w="0">
-                      <a:noFill/>
-                      <a:prstDash val="solid"/>
-                    </a:lnL>
-                    <a:lnR algn="ctr" cmpd="sng" cap="flat" w="0">
-                      <a:noFill/>
-                      <a:prstDash val="solid"/>
-                    </a:lnR>
-                    <a:lnT algn="ctr" cmpd="sng" cap="flat" w="0">
-                      <a:noFill/>
-                      <a:prstDash val="solid"/>
-                    </a:lnT>
-                    <a:lnB algn="ctr" cmpd="sng" cap="flat" w="0">
-                      <a:noFill/>
-                      <a:prstDash val="solid"/>
-                    </a:lnB>
-                    <a:solidFill>
-                      <a:srgbClr val="FFFFFF">
-                        <a:alpha val="0"/>
-                      </a:srgbClr>
-                    </a:solidFill>
-                  </a:tcPr>
-                </a:tc>
-              </a:tr>
-              <a:tr h="410845">
-                <a:tc>
-                  <a:txBody>
-                    <a:bodyPr/>
-                    <a:lstStyle/>
-                    <a:p>
-                      <a:pPr algn="l" marL="63500" marR="63500">
-                        <a:lnSpc>
-                          <a:spcPct val="100000"/>
-                        </a:lnSpc>
-                        <a:spcBef>
-                          <a:spcPts val="500"/>
-                        </a:spcBef>
-                        <a:spcAft>
-                          <a:spcPts val="500"/>
-                        </a:spcAft>
-                        <a:buNone/>
-                      </a:pPr>
-                      <a:r>
-                        <a:rPr cap="none" sz="1200" i="0" b="0" u="none" strike="noStrike">
-                          <a:solidFill>
-                            <a:srgbClr val="5B6770">
-                              <a:alpha val="100000"/>
-                            </a:srgbClr>
-                          </a:solidFill>
-                          <a:latin typeface="Helvetica Neue"/>
-                          <a:cs typeface="Helvetica Neue"/>
-                          <a:ea typeface="Helvetica Neue"/>
-                          <a:sym typeface="Helvetica Neue"/>
-                        </a:rPr>
-                        <a:t>aminopyrine</a:t>
-                      </a:r>
-                    </a:p>
-                  </a:txBody>
-                  <a:tcPr anchor="ctr" marB="63500" marT="63500" marR="0" marL="0">
-                    <a:lnL algn="ctr" cmpd="sng" cap="flat" w="0">
-                      <a:noFill/>
-                      <a:prstDash val="solid"/>
-                    </a:lnL>
-                    <a:lnR algn="ctr" cmpd="sng" cap="flat" w="0">
-                      <a:noFill/>
-                      <a:prstDash val="solid"/>
-                    </a:lnR>
-                    <a:lnT algn="ctr" cmpd="sng" cap="flat" w="0">
-                      <a:noFill/>
-                      <a:prstDash val="solid"/>
-                    </a:lnT>
                     <a:lnB algn="ctr" cmpd="sng" cap="flat" w="19050">
                       <a:solidFill>
                         <a:srgbClr val="666666">
@@ -14267,190 +14450,7 @@
                           <a:ea typeface="Helvetica Neue"/>
                           <a:sym typeface="Helvetica Neue"/>
                         </a:rPr>
-                        <a:t>28 Jul 2026</a:t>
-                      </a:r>
-                    </a:p>
-                  </a:txBody>
-                  <a:tcPr anchor="ctr" marB="63500" marT="63500" marR="0" marL="0">
-                    <a:lnL algn="ctr" cmpd="sng" cap="flat" w="0">
-                      <a:noFill/>
-                      <a:prstDash val="solid"/>
-                    </a:lnL>
-                    <a:lnR algn="ctr" cmpd="sng" cap="flat" w="0">
-                      <a:noFill/>
-                      <a:prstDash val="solid"/>
-                    </a:lnR>
-                    <a:lnT algn="ctr" cmpd="sng" cap="flat" w="0">
-                      <a:noFill/>
-                      <a:prstDash val="solid"/>
-                    </a:lnT>
-                    <a:lnB algn="ctr" cmpd="sng" cap="flat" w="19050">
-                      <a:solidFill>
-                        <a:srgbClr val="666666">
-                          <a:alpha val="100000"/>
-                        </a:srgbClr>
-                      </a:solidFill>
-                      <a:prstDash val="solid"/>
-                    </a:lnB>
-                    <a:solidFill>
-                      <a:srgbClr val="F4F8FB">
-                        <a:alpha val="100000"/>
-                      </a:srgbClr>
-                    </a:solidFill>
-                  </a:tcPr>
-                </a:tc>
-                <a:tc>
-                  <a:txBody>
-                    <a:bodyPr/>
-                    <a:lstStyle/>
-                    <a:p>
-                      <a:pPr algn="l" marL="63500" marR="63500">
-                        <a:lnSpc>
-                          <a:spcPct val="100000"/>
-                        </a:lnSpc>
-                        <a:spcBef>
-                          <a:spcPts val="500"/>
-                        </a:spcBef>
-                        <a:spcAft>
-                          <a:spcPts val="500"/>
-                        </a:spcAft>
-                        <a:buNone/>
-                      </a:pPr>
-                      <a:r>
-                        <a:rPr cap="none" sz="1200" i="0" b="0" u="none" strike="noStrike">
-                          <a:solidFill>
-                            <a:srgbClr val="5B6770">
-                              <a:alpha val="100000"/>
-                            </a:srgbClr>
-                          </a:solidFill>
-                          <a:latin typeface="Helvetica Neue"/>
-                          <a:cs typeface="Helvetica Neue"/>
-                          <a:ea typeface="Helvetica Neue"/>
-                          <a:sym typeface="Helvetica Neue"/>
-                        </a:rPr>
-                        <a:t>primary</a:t>
-                      </a:r>
-                    </a:p>
-                  </a:txBody>
-                  <a:tcPr anchor="ctr" marB="63500" marT="63500" marR="0" marL="0">
-                    <a:lnL algn="ctr" cmpd="sng" cap="flat" w="0">
-                      <a:noFill/>
-                      <a:prstDash val="solid"/>
-                    </a:lnL>
-                    <a:lnR algn="ctr" cmpd="sng" cap="flat" w="0">
-                      <a:noFill/>
-                      <a:prstDash val="solid"/>
-                    </a:lnR>
-                    <a:lnT algn="ctr" cmpd="sng" cap="flat" w="0">
-                      <a:noFill/>
-                      <a:prstDash val="solid"/>
-                    </a:lnT>
-                    <a:lnB algn="ctr" cmpd="sng" cap="flat" w="19050">
-                      <a:solidFill>
-                        <a:srgbClr val="666666">
-                          <a:alpha val="100000"/>
-                        </a:srgbClr>
-                      </a:solidFill>
-                      <a:prstDash val="solid"/>
-                    </a:lnB>
-                    <a:solidFill>
-                      <a:srgbClr val="F4F8FB">
-                        <a:alpha val="100000"/>
-                      </a:srgbClr>
-                    </a:solidFill>
-                  </a:tcPr>
-                </a:tc>
-                <a:tc>
-                  <a:txBody>
-                    <a:bodyPr/>
-                    <a:lstStyle/>
-                    <a:p>
-                      <a:pPr algn="r" marL="63500" marR="63500">
-                        <a:lnSpc>
-                          <a:spcPct val="100000"/>
-                        </a:lnSpc>
-                        <a:spcBef>
-                          <a:spcPts val="500"/>
-                        </a:spcBef>
-                        <a:spcAft>
-                          <a:spcPts val="500"/>
-                        </a:spcAft>
-                        <a:buNone/>
-                      </a:pPr>
-                      <a:r>
-                        <a:rPr cap="none" sz="1200" i="0" b="0" u="none" strike="noStrike">
-                          <a:solidFill>
-                            <a:srgbClr val="5B6770">
-                              <a:alpha val="100000"/>
-                            </a:srgbClr>
-                          </a:solidFill>
-                          <a:latin typeface="Helvetica Neue"/>
-                          <a:cs typeface="Helvetica Neue"/>
-                          <a:ea typeface="Helvetica Neue"/>
-                          <a:sym typeface="Helvetica Neue"/>
-                        </a:rPr>
-                        <a:t>1</a:t>
-                      </a:r>
-                    </a:p>
-                  </a:txBody>
-                  <a:tcPr anchor="ctr" marB="63500" marT="63500" marR="0" marL="0">
-                    <a:lnL algn="ctr" cmpd="sng" cap="flat" w="0">
-                      <a:noFill/>
-                      <a:prstDash val="solid"/>
-                    </a:lnL>
-                    <a:lnR algn="ctr" cmpd="sng" cap="flat" w="0">
-                      <a:noFill/>
-                      <a:prstDash val="solid"/>
-                    </a:lnR>
-                    <a:lnT algn="ctr" cmpd="sng" cap="flat" w="0">
-                      <a:noFill/>
-                      <a:prstDash val="solid"/>
-                    </a:lnT>
-                    <a:lnB algn="ctr" cmpd="sng" cap="flat" w="19050">
-                      <a:solidFill>
-                        <a:srgbClr val="666666">
-                          <a:alpha val="100000"/>
-                        </a:srgbClr>
-                      </a:solidFill>
-                      <a:prstDash val="solid"/>
-                    </a:lnB>
-                    <a:solidFill>
-                      <a:srgbClr val="F4F8FB">
-                        <a:alpha val="100000"/>
-                      </a:srgbClr>
-                    </a:solidFill>
-                  </a:tcPr>
-                </a:tc>
-                <a:tc>
-                  <a:txBody>
-                    <a:bodyPr/>
-                    <a:lstStyle/>
-                    <a:p>
-                      <a:pPr algn="l" marL="63500" marR="63500">
-                        <a:lnSpc>
-                          <a:spcPct val="100000"/>
-                        </a:lnSpc>
-                        <a:spcBef>
-                          <a:spcPts val="500"/>
-                        </a:spcBef>
-                        <a:spcAft>
-                          <a:spcPts val="500"/>
-                        </a:spcAft>
-                        <a:buNone/>
-                      </a:pPr>
-                      <a:r>
-                        <a:rPr cap="none" sz="1200" i="0" b="0" u="none" strike="noStrike">
-                          <a:solidFill>
-                            <a:srgbClr val="5B6770">
-                              <a:alpha val="100000"/>
-                            </a:srgbClr>
-                          </a:solidFill>
-                          <a:latin typeface="Helvetica Neue"/>
-                          <a:cs typeface="Helvetica Neue"/>
-                          <a:ea typeface="Helvetica Neue"/>
-                          <a:sym typeface="Helvetica Neue"/>
-                        </a:rPr>
-                        <a:t>605808</a:t>
+                        <a:t>816795</a:t>
                       </a:r>
                     </a:p>
                   </a:txBody>
@@ -24942,6 +24942,293 @@
                           <a:ea typeface="Helvetica Neue"/>
                           <a:sym typeface="Helvetica Neue"/>
                         </a:rPr>
+                        <a:t>psilocybin</a:t>
+                      </a:r>
+                    </a:p>
+                  </a:txBody>
+                  <a:tcPr anchor="ctr" marB="63500" marT="63500" marR="0" marL="0">
+                    <a:lnL algn="ctr" cmpd="sng" cap="flat" w="0">
+                      <a:noFill/>
+                      <a:prstDash val="solid"/>
+                    </a:lnL>
+                    <a:lnR algn="ctr" cmpd="sng" cap="flat" w="0">
+                      <a:noFill/>
+                      <a:prstDash val="solid"/>
+                    </a:lnR>
+                    <a:lnT algn="ctr" cmpd="sng" cap="flat" w="0">
+                      <a:noFill/>
+                      <a:prstDash val="solid"/>
+                    </a:lnT>
+                    <a:lnB algn="ctr" cmpd="sng" cap="flat" w="0">
+                      <a:noFill/>
+                      <a:prstDash val="solid"/>
+                    </a:lnB>
+                    <a:solidFill>
+                      <a:srgbClr val="FFFFFF">
+                        <a:alpha val="0"/>
+                      </a:srgbClr>
+                    </a:solidFill>
+                  </a:tcPr>
+                </a:tc>
+                <a:tc>
+                  <a:txBody>
+                    <a:bodyPr/>
+                    <a:lstStyle/>
+                    <a:p>
+                      <a:pPr algn="l" marL="63500" marR="63500">
+                        <a:lnSpc>
+                          <a:spcPct val="100000"/>
+                        </a:lnSpc>
+                        <a:spcBef>
+                          <a:spcPts val="500"/>
+                        </a:spcBef>
+                        <a:spcAft>
+                          <a:spcPts val="500"/>
+                        </a:spcAft>
+                        <a:buNone/>
+                      </a:pPr>
+                      <a:r>
+                        <a:rPr cap="none" sz="1200" i="0" b="0" u="none" strike="noStrike">
+                          <a:solidFill>
+                            <a:srgbClr val="5B6770">
+                              <a:alpha val="100000"/>
+                            </a:srgbClr>
+                          </a:solidFill>
+                          <a:latin typeface="Helvetica Neue"/>
+                          <a:cs typeface="Helvetica Neue"/>
+                          <a:ea typeface="Helvetica Neue"/>
+                          <a:sym typeface="Helvetica Neue"/>
+                        </a:rPr>
+                        <a:t>23 Oct 2026</a:t>
+                      </a:r>
+                    </a:p>
+                  </a:txBody>
+                  <a:tcPr anchor="ctr" marB="63500" marT="63500" marR="0" marL="0">
+                    <a:lnL algn="ctr" cmpd="sng" cap="flat" w="0">
+                      <a:noFill/>
+                      <a:prstDash val="solid"/>
+                    </a:lnL>
+                    <a:lnR algn="ctr" cmpd="sng" cap="flat" w="0">
+                      <a:noFill/>
+                      <a:prstDash val="solid"/>
+                    </a:lnR>
+                    <a:lnT algn="ctr" cmpd="sng" cap="flat" w="0">
+                      <a:noFill/>
+                      <a:prstDash val="solid"/>
+                    </a:lnT>
+                    <a:lnB algn="ctr" cmpd="sng" cap="flat" w="0">
+                      <a:noFill/>
+                      <a:prstDash val="solid"/>
+                    </a:lnB>
+                    <a:solidFill>
+                      <a:srgbClr val="FFFFFF">
+                        <a:alpha val="0"/>
+                      </a:srgbClr>
+                    </a:solidFill>
+                  </a:tcPr>
+                </a:tc>
+                <a:tc>
+                  <a:txBody>
+                    <a:bodyPr/>
+                    <a:lstStyle/>
+                    <a:p>
+                      <a:pPr algn="l" marL="63500" marR="63500">
+                        <a:lnSpc>
+                          <a:spcPct val="100000"/>
+                        </a:lnSpc>
+                        <a:spcBef>
+                          <a:spcPts val="500"/>
+                        </a:spcBef>
+                        <a:spcAft>
+                          <a:spcPts val="500"/>
+                        </a:spcAft>
+                        <a:buNone/>
+                      </a:pPr>
+                      <a:r>
+                        <a:rPr cap="none" sz="1200" i="0" b="0" u="none" strike="noStrike">
+                          <a:solidFill>
+                            <a:srgbClr val="5B6770">
+                              <a:alpha val="100000"/>
+                            </a:srgbClr>
+                          </a:solidFill>
+                          <a:latin typeface="Helvetica Neue"/>
+                          <a:cs typeface="Helvetica Neue"/>
+                          <a:ea typeface="Helvetica Neue"/>
+                          <a:sym typeface="Helvetica Neue"/>
+                        </a:rPr>
+                        <a:t>primary</a:t>
+                      </a:r>
+                    </a:p>
+                  </a:txBody>
+                  <a:tcPr anchor="ctr" marB="63500" marT="63500" marR="0" marL="0">
+                    <a:lnL algn="ctr" cmpd="sng" cap="flat" w="0">
+                      <a:noFill/>
+                      <a:prstDash val="solid"/>
+                    </a:lnL>
+                    <a:lnR algn="ctr" cmpd="sng" cap="flat" w="0">
+                      <a:noFill/>
+                      <a:prstDash val="solid"/>
+                    </a:lnR>
+                    <a:lnT algn="ctr" cmpd="sng" cap="flat" w="0">
+                      <a:noFill/>
+                      <a:prstDash val="solid"/>
+                    </a:lnT>
+                    <a:lnB algn="ctr" cmpd="sng" cap="flat" w="0">
+                      <a:noFill/>
+                      <a:prstDash val="solid"/>
+                    </a:lnB>
+                    <a:solidFill>
+                      <a:srgbClr val="FFFFFF">
+                        <a:alpha val="0"/>
+                      </a:srgbClr>
+                    </a:solidFill>
+                  </a:tcPr>
+                </a:tc>
+                <a:tc>
+                  <a:txBody>
+                    <a:bodyPr/>
+                    <a:lstStyle/>
+                    <a:p>
+                      <a:pPr algn="r" marL="63500" marR="63500">
+                        <a:lnSpc>
+                          <a:spcPct val="100000"/>
+                        </a:lnSpc>
+                        <a:spcBef>
+                          <a:spcPts val="500"/>
+                        </a:spcBef>
+                        <a:spcAft>
+                          <a:spcPts val="500"/>
+                        </a:spcAft>
+                        <a:buNone/>
+                      </a:pPr>
+                      <a:r>
+                        <a:rPr cap="none" sz="1200" i="0" b="0" u="none" strike="noStrike">
+                          <a:solidFill>
+                            <a:srgbClr val="5B6770">
+                              <a:alpha val="100000"/>
+                            </a:srgbClr>
+                          </a:solidFill>
+                          <a:latin typeface="Helvetica Neue"/>
+                          <a:cs typeface="Helvetica Neue"/>
+                          <a:ea typeface="Helvetica Neue"/>
+                          <a:sym typeface="Helvetica Neue"/>
+                        </a:rPr>
+                        <a:t>1</a:t>
+                      </a:r>
+                    </a:p>
+                  </a:txBody>
+                  <a:tcPr anchor="ctr" marB="63500" marT="63500" marR="0" marL="0">
+                    <a:lnL algn="ctr" cmpd="sng" cap="flat" w="0">
+                      <a:noFill/>
+                      <a:prstDash val="solid"/>
+                    </a:lnL>
+                    <a:lnR algn="ctr" cmpd="sng" cap="flat" w="0">
+                      <a:noFill/>
+                      <a:prstDash val="solid"/>
+                    </a:lnR>
+                    <a:lnT algn="ctr" cmpd="sng" cap="flat" w="0">
+                      <a:noFill/>
+                      <a:prstDash val="solid"/>
+                    </a:lnT>
+                    <a:lnB algn="ctr" cmpd="sng" cap="flat" w="0">
+                      <a:noFill/>
+                      <a:prstDash val="solid"/>
+                    </a:lnB>
+                    <a:solidFill>
+                      <a:srgbClr val="FFFFFF">
+                        <a:alpha val="0"/>
+                      </a:srgbClr>
+                    </a:solidFill>
+                  </a:tcPr>
+                </a:tc>
+                <a:tc>
+                  <a:txBody>
+                    <a:bodyPr/>
+                    <a:lstStyle/>
+                    <a:p>
+                      <a:pPr algn="l" marL="63500" marR="63500">
+                        <a:lnSpc>
+                          <a:spcPct val="100000"/>
+                        </a:lnSpc>
+                        <a:spcBef>
+                          <a:spcPts val="500"/>
+                        </a:spcBef>
+                        <a:spcAft>
+                          <a:spcPts val="500"/>
+                        </a:spcAft>
+                        <a:buNone/>
+                      </a:pPr>
+                      <a:r>
+                        <a:rPr cap="none" sz="1200" i="0" b="0" u="none" strike="noStrike">
+                          <a:solidFill>
+                            <a:srgbClr val="5B6770">
+                              <a:alpha val="100000"/>
+                            </a:srgbClr>
+                          </a:solidFill>
+                          <a:latin typeface="Helvetica Neue"/>
+                          <a:cs typeface="Helvetica Neue"/>
+                          <a:ea typeface="Helvetica Neue"/>
+                          <a:sym typeface="Helvetica Neue"/>
+                        </a:rPr>
+                        <a:t>603618</a:t>
+                      </a:r>
+                    </a:p>
+                  </a:txBody>
+                  <a:tcPr anchor="ctr" marB="63500" marT="63500" marR="0" marL="0">
+                    <a:lnL algn="ctr" cmpd="sng" cap="flat" w="0">
+                      <a:noFill/>
+                      <a:prstDash val="solid"/>
+                    </a:lnL>
+                    <a:lnR algn="ctr" cmpd="sng" cap="flat" w="0">
+                      <a:noFill/>
+                      <a:prstDash val="solid"/>
+                    </a:lnR>
+                    <a:lnT algn="ctr" cmpd="sng" cap="flat" w="0">
+                      <a:noFill/>
+                      <a:prstDash val="solid"/>
+                    </a:lnT>
+                    <a:lnB algn="ctr" cmpd="sng" cap="flat" w="0">
+                      <a:noFill/>
+                      <a:prstDash val="solid"/>
+                    </a:lnB>
+                    <a:solidFill>
+                      <a:srgbClr val="FFFFFF">
+                        <a:alpha val="0"/>
+                      </a:srgbClr>
+                    </a:solidFill>
+                  </a:tcPr>
+                </a:tc>
+              </a:tr>
+              <a:tr h="401320">
+                <a:tc>
+                  <a:txBody>
+                    <a:bodyPr/>
+                    <a:lstStyle/>
+                    <a:p>
+                      <a:pPr algn="l" marL="63500" marR="63500">
+                        <a:lnSpc>
+                          <a:spcPct val="100000"/>
+                        </a:lnSpc>
+                        <a:spcBef>
+                          <a:spcPts val="500"/>
+                        </a:spcBef>
+                        <a:spcAft>
+                          <a:spcPts val="500"/>
+                        </a:spcAft>
+                        <a:buNone/>
+                      </a:pPr>
+                      <a:r>
+                        <a:rPr cap="none" sz="1200" i="0" b="0" u="none" strike="noStrike">
+                          <a:solidFill>
+                            <a:srgbClr val="5B6770">
+                              <a:alpha val="100000"/>
+                            </a:srgbClr>
+                          </a:solidFill>
+                          <a:latin typeface="Helvetica Neue"/>
+                          <a:cs typeface="Helvetica Neue"/>
+                          <a:ea typeface="Helvetica Neue"/>
+                          <a:sym typeface="Helvetica Neue"/>
+                        </a:rPr>
                         <a:t>clonidine</a:t>
                       </a:r>
                     </a:p>
@@ -24964,8 +25251,8 @@
                       <a:prstDash val="solid"/>
                     </a:lnB>
                     <a:solidFill>
-                      <a:srgbClr val="FFFFFF">
-                        <a:alpha val="0"/>
+                      <a:srgbClr val="F4F8FB">
+                        <a:alpha val="100000"/>
                       </a:srgbClr>
                     </a:solidFill>
                   </a:tcPr>
@@ -25021,8 +25308,8 @@
                       <a:prstDash val="solid"/>
                     </a:lnB>
                     <a:solidFill>
-                      <a:srgbClr val="FFFFFF">
-                        <a:alpha val="0"/>
+                      <a:srgbClr val="F4F8FB">
+                        <a:alpha val="100000"/>
                       </a:srgbClr>
                     </a:solidFill>
                   </a:tcPr>
@@ -25078,8 +25365,8 @@
                       <a:prstDash val="solid"/>
                     </a:lnB>
                     <a:solidFill>
-                      <a:srgbClr val="FFFFFF">
-                        <a:alpha val="0"/>
+                      <a:srgbClr val="F4F8FB">
+                        <a:alpha val="100000"/>
                       </a:srgbClr>
                     </a:solidFill>
                   </a:tcPr>
@@ -25135,8 +25422,8 @@
                       <a:prstDash val="solid"/>
                     </a:lnB>
                     <a:solidFill>
-                      <a:srgbClr val="FFFFFF">
-                        <a:alpha val="0"/>
+                      <a:srgbClr val="F4F8FB">
+                        <a:alpha val="100000"/>
                       </a:srgbClr>
                     </a:solidFill>
                   </a:tcPr>
@@ -25192,8 +25479,8 @@
                       <a:prstDash val="solid"/>
                     </a:lnB>
                     <a:solidFill>
-                      <a:srgbClr val="FFFFFF">
-                        <a:alpha val="0"/>
+                      <a:srgbClr val="F4F8FB">
+                        <a:alpha val="100000"/>
                       </a:srgbClr>
                     </a:solidFill>
                   </a:tcPr>
@@ -25251,8 +25538,8 @@
                       <a:prstDash val="solid"/>
                     </a:lnB>
                     <a:solidFill>
-                      <a:srgbClr val="F4F8FB">
-                        <a:alpha val="100000"/>
+                      <a:srgbClr val="FFFFFF">
+                        <a:alpha val="0"/>
                       </a:srgbClr>
                     </a:solidFill>
                   </a:tcPr>
@@ -25308,8 +25595,8 @@
                       <a:prstDash val="solid"/>
                     </a:lnB>
                     <a:solidFill>
-                      <a:srgbClr val="F4F8FB">
-                        <a:alpha val="100000"/>
+                      <a:srgbClr val="FFFFFF">
+                        <a:alpha val="0"/>
                       </a:srgbClr>
                     </a:solidFill>
                   </a:tcPr>
@@ -25365,8 +25652,8 @@
                       <a:prstDash val="solid"/>
                     </a:lnB>
                     <a:solidFill>
-                      <a:srgbClr val="F4F8FB">
-                        <a:alpha val="100000"/>
+                      <a:srgbClr val="FFFFFF">
+                        <a:alpha val="0"/>
                       </a:srgbClr>
                     </a:solidFill>
                   </a:tcPr>
@@ -25422,8 +25709,8 @@
                       <a:prstDash val="solid"/>
                     </a:lnB>
                     <a:solidFill>
-                      <a:srgbClr val="F4F8FB">
-                        <a:alpha val="100000"/>
+                      <a:srgbClr val="FFFFFF">
+                        <a:alpha val="0"/>
                       </a:srgbClr>
                     </a:solidFill>
                   </a:tcPr>
@@ -25479,8 +25766,8 @@
                       <a:prstDash val="solid"/>
                     </a:lnB>
                     <a:solidFill>
-                      <a:srgbClr val="F4F8FB">
-                        <a:alpha val="100000"/>
+                      <a:srgbClr val="FFFFFF">
+                        <a:alpha val="0"/>
                       </a:srgbClr>
                     </a:solidFill>
                   </a:tcPr>
@@ -25538,8 +25825,8 @@
                       <a:prstDash val="solid"/>
                     </a:lnB>
                     <a:solidFill>
-                      <a:srgbClr val="FFFFFF">
-                        <a:alpha val="0"/>
+                      <a:srgbClr val="F4F8FB">
+                        <a:alpha val="100000"/>
                       </a:srgbClr>
                     </a:solidFill>
                   </a:tcPr>
@@ -25595,8 +25882,8 @@
                       <a:prstDash val="solid"/>
                     </a:lnB>
                     <a:solidFill>
-                      <a:srgbClr val="FFFFFF">
-                        <a:alpha val="0"/>
+                      <a:srgbClr val="F4F8FB">
+                        <a:alpha val="100000"/>
                       </a:srgbClr>
                     </a:solidFill>
                   </a:tcPr>
@@ -25652,8 +25939,8 @@
                       <a:prstDash val="solid"/>
                     </a:lnB>
                     <a:solidFill>
-                      <a:srgbClr val="FFFFFF">
-                        <a:alpha val="0"/>
+                      <a:srgbClr val="F4F8FB">
+                        <a:alpha val="100000"/>
                       </a:srgbClr>
                     </a:solidFill>
                   </a:tcPr>
@@ -25709,8 +25996,8 @@
                       <a:prstDash val="solid"/>
                     </a:lnB>
                     <a:solidFill>
-                      <a:srgbClr val="FFFFFF">
-                        <a:alpha val="0"/>
+                      <a:srgbClr val="F4F8FB">
+                        <a:alpha val="100000"/>
                       </a:srgbClr>
                     </a:solidFill>
                   </a:tcPr>
@@ -25766,8 +26053,8 @@
                       <a:prstDash val="solid"/>
                     </a:lnB>
                     <a:solidFill>
-                      <a:srgbClr val="FFFFFF">
-                        <a:alpha val="0"/>
+                      <a:srgbClr val="F4F8FB">
+                        <a:alpha val="100000"/>
                       </a:srgbClr>
                     </a:solidFill>
                   </a:tcPr>
@@ -25825,8 +26112,8 @@
                       <a:prstDash val="solid"/>
                     </a:lnB>
                     <a:solidFill>
-                      <a:srgbClr val="F4F8FB">
-                        <a:alpha val="100000"/>
+                      <a:srgbClr val="FFFFFF">
+                        <a:alpha val="0"/>
                       </a:srgbClr>
                     </a:solidFill>
                   </a:tcPr>
@@ -25882,8 +26169,8 @@
                       <a:prstDash val="solid"/>
                     </a:lnB>
                     <a:solidFill>
-                      <a:srgbClr val="F4F8FB">
-                        <a:alpha val="100000"/>
+                      <a:srgbClr val="FFFFFF">
+                        <a:alpha val="0"/>
                       </a:srgbClr>
                     </a:solidFill>
                   </a:tcPr>
@@ -25939,8 +26226,8 @@
                       <a:prstDash val="solid"/>
                     </a:lnB>
                     <a:solidFill>
-                      <a:srgbClr val="F4F8FB">
-                        <a:alpha val="100000"/>
+                      <a:srgbClr val="FFFFFF">
+                        <a:alpha val="0"/>
                       </a:srgbClr>
                     </a:solidFill>
                   </a:tcPr>
@@ -25996,8 +26283,8 @@
                       <a:prstDash val="solid"/>
                     </a:lnB>
                     <a:solidFill>
-                      <a:srgbClr val="F4F8FB">
-                        <a:alpha val="100000"/>
+                      <a:srgbClr val="FFFFFF">
+                        <a:alpha val="0"/>
                       </a:srgbClr>
                     </a:solidFill>
                   </a:tcPr>
@@ -26053,8 +26340,8 @@
                       <a:prstDash val="solid"/>
                     </a:lnB>
                     <a:solidFill>
-                      <a:srgbClr val="F4F8FB">
-                        <a:alpha val="100000"/>
+                      <a:srgbClr val="FFFFFF">
+                        <a:alpha val="0"/>
                       </a:srgbClr>
                     </a:solidFill>
                   </a:tcPr>
@@ -26112,8 +26399,8 @@
                       <a:prstDash val="solid"/>
                     </a:lnB>
                     <a:solidFill>
-                      <a:srgbClr val="FFFFFF">
-                        <a:alpha val="0"/>
+                      <a:srgbClr val="F4F8FB">
+                        <a:alpha val="100000"/>
                       </a:srgbClr>
                     </a:solidFill>
                   </a:tcPr>
@@ -26169,8 +26456,8 @@
                       <a:prstDash val="solid"/>
                     </a:lnB>
                     <a:solidFill>
-                      <a:srgbClr val="FFFFFF">
-                        <a:alpha val="0"/>
+                      <a:srgbClr val="F4F8FB">
+                        <a:alpha val="100000"/>
                       </a:srgbClr>
                     </a:solidFill>
                   </a:tcPr>
@@ -26226,8 +26513,8 @@
                       <a:prstDash val="solid"/>
                     </a:lnB>
                     <a:solidFill>
-                      <a:srgbClr val="FFFFFF">
-                        <a:alpha val="0"/>
+                      <a:srgbClr val="F4F8FB">
+                        <a:alpha val="100000"/>
                       </a:srgbClr>
                     </a:solidFill>
                   </a:tcPr>
@@ -26283,8 +26570,8 @@
                       <a:prstDash val="solid"/>
                     </a:lnB>
                     <a:solidFill>
-                      <a:srgbClr val="FFFFFF">
-                        <a:alpha val="0"/>
+                      <a:srgbClr val="F4F8FB">
+                        <a:alpha val="100000"/>
                       </a:srgbClr>
                     </a:solidFill>
                   </a:tcPr>
@@ -26340,8 +26627,8 @@
                       <a:prstDash val="solid"/>
                     </a:lnB>
                     <a:solidFill>
-                      <a:srgbClr val="FFFFFF">
-                        <a:alpha val="0"/>
+                      <a:srgbClr val="F4F8FB">
+                        <a:alpha val="100000"/>
                       </a:srgbClr>
                     </a:solidFill>
                   </a:tcPr>
@@ -26399,8 +26686,8 @@
                       <a:prstDash val="solid"/>
                     </a:lnB>
                     <a:solidFill>
-                      <a:srgbClr val="F4F8FB">
-                        <a:alpha val="100000"/>
+                      <a:srgbClr val="FFFFFF">
+                        <a:alpha val="0"/>
                       </a:srgbClr>
                     </a:solidFill>
                   </a:tcPr>
@@ -26456,8 +26743,8 @@
                       <a:prstDash val="solid"/>
                     </a:lnB>
                     <a:solidFill>
-                      <a:srgbClr val="F4F8FB">
-                        <a:alpha val="100000"/>
+                      <a:srgbClr val="FFFFFF">
+                        <a:alpha val="0"/>
                       </a:srgbClr>
                     </a:solidFill>
                   </a:tcPr>
@@ -26513,8 +26800,8 @@
                       <a:prstDash val="solid"/>
                     </a:lnB>
                     <a:solidFill>
-                      <a:srgbClr val="F4F8FB">
-                        <a:alpha val="100000"/>
+                      <a:srgbClr val="FFFFFF">
+                        <a:alpha val="0"/>
                       </a:srgbClr>
                     </a:solidFill>
                   </a:tcPr>
@@ -26570,8 +26857,8 @@
                       <a:prstDash val="solid"/>
                     </a:lnB>
                     <a:solidFill>
-                      <a:srgbClr val="F4F8FB">
-                        <a:alpha val="100000"/>
+                      <a:srgbClr val="FFFFFF">
+                        <a:alpha val="0"/>
                       </a:srgbClr>
                     </a:solidFill>
                   </a:tcPr>
@@ -26627,8 +26914,8 @@
                       <a:prstDash val="solid"/>
                     </a:lnB>
                     <a:solidFill>
-                      <a:srgbClr val="F4F8FB">
-                        <a:alpha val="100000"/>
+                      <a:srgbClr val="FFFFFF">
+                        <a:alpha val="0"/>
                       </a:srgbClr>
                     </a:solidFill>
                   </a:tcPr>
@@ -26686,8 +26973,8 @@
                       <a:prstDash val="solid"/>
                     </a:lnB>
                     <a:solidFill>
-                      <a:srgbClr val="FFFFFF">
-                        <a:alpha val="0"/>
+                      <a:srgbClr val="F4F8FB">
+                        <a:alpha val="100000"/>
                       </a:srgbClr>
                     </a:solidFill>
                   </a:tcPr>
@@ -26743,8 +27030,8 @@
                       <a:prstDash val="solid"/>
                     </a:lnB>
                     <a:solidFill>
-                      <a:srgbClr val="FFFFFF">
-                        <a:alpha val="0"/>
+                      <a:srgbClr val="F4F8FB">
+                        <a:alpha val="100000"/>
                       </a:srgbClr>
                     </a:solidFill>
                   </a:tcPr>
@@ -26800,8 +27087,8 @@
                       <a:prstDash val="solid"/>
                     </a:lnB>
                     <a:solidFill>
-                      <a:srgbClr val="FFFFFF">
-                        <a:alpha val="0"/>
+                      <a:srgbClr val="F4F8FB">
+                        <a:alpha val="100000"/>
                       </a:srgbClr>
                     </a:solidFill>
                   </a:tcPr>
@@ -26857,8 +27144,8 @@
                       <a:prstDash val="solid"/>
                     </a:lnB>
                     <a:solidFill>
-                      <a:srgbClr val="FFFFFF">
-                        <a:alpha val="0"/>
+                      <a:srgbClr val="F4F8FB">
+                        <a:alpha val="100000"/>
                       </a:srgbClr>
                     </a:solidFill>
                   </a:tcPr>
@@ -26914,8 +27201,8 @@
                       <a:prstDash val="solid"/>
                     </a:lnB>
                     <a:solidFill>
-                      <a:srgbClr val="FFFFFF">
-                        <a:alpha val="0"/>
+                      <a:srgbClr val="F4F8FB">
+                        <a:alpha val="100000"/>
                       </a:srgbClr>
                     </a:solidFill>
                   </a:tcPr>
@@ -26973,8 +27260,8 @@
                       <a:prstDash val="solid"/>
                     </a:lnB>
                     <a:solidFill>
-                      <a:srgbClr val="F4F8FB">
-                        <a:alpha val="100000"/>
+                      <a:srgbClr val="FFFFFF">
+                        <a:alpha val="0"/>
                       </a:srgbClr>
                     </a:solidFill>
                   </a:tcPr>
@@ -27030,8 +27317,8 @@
                       <a:prstDash val="solid"/>
                     </a:lnB>
                     <a:solidFill>
-                      <a:srgbClr val="F4F8FB">
-                        <a:alpha val="100000"/>
+                      <a:srgbClr val="FFFFFF">
+                        <a:alpha val="0"/>
                       </a:srgbClr>
                     </a:solidFill>
                   </a:tcPr>
@@ -27087,8 +27374,8 @@
                       <a:prstDash val="solid"/>
                     </a:lnB>
                     <a:solidFill>
-                      <a:srgbClr val="F4F8FB">
-                        <a:alpha val="100000"/>
+                      <a:srgbClr val="FFFFFF">
+                        <a:alpha val="0"/>
                       </a:srgbClr>
                     </a:solidFill>
                   </a:tcPr>
@@ -27144,8 +27431,8 @@
                       <a:prstDash val="solid"/>
                     </a:lnB>
                     <a:solidFill>
-                      <a:srgbClr val="F4F8FB">
-                        <a:alpha val="100000"/>
+                      <a:srgbClr val="FFFFFF">
+                        <a:alpha val="0"/>
                       </a:srgbClr>
                     </a:solidFill>
                   </a:tcPr>
@@ -27201,8 +27488,8 @@
                       <a:prstDash val="solid"/>
                     </a:lnB>
                     <a:solidFill>
-                      <a:srgbClr val="F4F8FB">
-                        <a:alpha val="100000"/>
+                      <a:srgbClr val="FFFFFF">
+                        <a:alpha val="0"/>
                       </a:srgbClr>
                     </a:solidFill>
                   </a:tcPr>
@@ -27260,8 +27547,8 @@
                       <a:prstDash val="solid"/>
                     </a:lnB>
                     <a:solidFill>
-                      <a:srgbClr val="FFFFFF">
-                        <a:alpha val="0"/>
+                      <a:srgbClr val="F4F8FB">
+                        <a:alpha val="100000"/>
                       </a:srgbClr>
                     </a:solidFill>
                   </a:tcPr>
@@ -27317,8 +27604,8 @@
                       <a:prstDash val="solid"/>
                     </a:lnB>
                     <a:solidFill>
-                      <a:srgbClr val="FFFFFF">
-                        <a:alpha val="0"/>
+                      <a:srgbClr val="F4F8FB">
+                        <a:alpha val="100000"/>
                       </a:srgbClr>
                     </a:solidFill>
                   </a:tcPr>
@@ -27374,8 +27661,8 @@
                       <a:prstDash val="solid"/>
                     </a:lnB>
                     <a:solidFill>
-                      <a:srgbClr val="FFFFFF">
-                        <a:alpha val="0"/>
+                      <a:srgbClr val="F4F8FB">
+                        <a:alpha val="100000"/>
                       </a:srgbClr>
                     </a:solidFill>
                   </a:tcPr>
@@ -27431,8 +27718,8 @@
                       <a:prstDash val="solid"/>
                     </a:lnB>
                     <a:solidFill>
-                      <a:srgbClr val="FFFFFF">
-                        <a:alpha val="0"/>
+                      <a:srgbClr val="F4F8FB">
+                        <a:alpha val="100000"/>
                       </a:srgbClr>
                     </a:solidFill>
                   </a:tcPr>
@@ -27488,8 +27775,8 @@
                       <a:prstDash val="solid"/>
                     </a:lnB>
                     <a:solidFill>
-                      <a:srgbClr val="FFFFFF">
-                        <a:alpha val="0"/>
+                      <a:srgbClr val="F4F8FB">
+                        <a:alpha val="100000"/>
                       </a:srgbClr>
                     </a:solidFill>
                   </a:tcPr>
@@ -27547,8 +27834,8 @@
                       <a:prstDash val="solid"/>
                     </a:lnB>
                     <a:solidFill>
-                      <a:srgbClr val="F4F8FB">
-                        <a:alpha val="100000"/>
+                      <a:srgbClr val="FFFFFF">
+                        <a:alpha val="0"/>
                       </a:srgbClr>
                     </a:solidFill>
                   </a:tcPr>
@@ -27604,8 +27891,8 @@
                       <a:prstDash val="solid"/>
                     </a:lnB>
                     <a:solidFill>
-                      <a:srgbClr val="F4F8FB">
-                        <a:alpha val="100000"/>
+                      <a:srgbClr val="FFFFFF">
+                        <a:alpha val="0"/>
                       </a:srgbClr>
                     </a:solidFill>
                   </a:tcPr>
@@ -27661,8 +27948,8 @@
                       <a:prstDash val="solid"/>
                     </a:lnB>
                     <a:solidFill>
-                      <a:srgbClr val="F4F8FB">
-                        <a:alpha val="100000"/>
+                      <a:srgbClr val="FFFFFF">
+                        <a:alpha val="0"/>
                       </a:srgbClr>
                     </a:solidFill>
                   </a:tcPr>
@@ -27718,8 +28005,8 @@
                       <a:prstDash val="solid"/>
                     </a:lnB>
                     <a:solidFill>
-                      <a:srgbClr val="F4F8FB">
-                        <a:alpha val="100000"/>
+                      <a:srgbClr val="FFFFFF">
+                        <a:alpha val="0"/>
                       </a:srgbClr>
                     </a:solidFill>
                   </a:tcPr>
@@ -27775,14 +28062,14 @@
                       <a:prstDash val="solid"/>
                     </a:lnB>
                     <a:solidFill>
-                      <a:srgbClr val="F4F8FB">
-                        <a:alpha val="100000"/>
+                      <a:srgbClr val="FFFFFF">
+                        <a:alpha val="0"/>
                       </a:srgbClr>
                     </a:solidFill>
                   </a:tcPr>
                 </a:tc>
               </a:tr>
-              <a:tr h="401320">
+              <a:tr h="410845">
                 <a:tc>
                   <a:txBody>
                     <a:bodyPr/>
@@ -27829,13 +28116,17 @@
                       <a:noFill/>
                       <a:prstDash val="solid"/>
                     </a:lnT>
-                    <a:lnB algn="ctr" cmpd="sng" cap="flat" w="0">
-                      <a:noFill/>
+                    <a:lnB algn="ctr" cmpd="sng" cap="flat" w="19050">
+                      <a:solidFill>
+                        <a:srgbClr val="666666">
+                          <a:alpha val="100000"/>
+                        </a:srgbClr>
+                      </a:solidFill>
                       <a:prstDash val="solid"/>
                     </a:lnB>
                     <a:solidFill>
-                      <a:srgbClr val="FFFFFF">
-                        <a:alpha val="0"/>
+                      <a:srgbClr val="F4F8FB">
+                        <a:alpha val="100000"/>
                       </a:srgbClr>
                     </a:solidFill>
                   </a:tcPr>
@@ -27886,13 +28177,17 @@
                       <a:noFill/>
                       <a:prstDash val="solid"/>
                     </a:lnT>
-                    <a:lnB algn="ctr" cmpd="sng" cap="flat" w="0">
-                      <a:noFill/>
+                    <a:lnB algn="ctr" cmpd="sng" cap="flat" w="19050">
+                      <a:solidFill>
+                        <a:srgbClr val="666666">
+                          <a:alpha val="100000"/>
+                        </a:srgbClr>
+                      </a:solidFill>
                       <a:prstDash val="solid"/>
                     </a:lnB>
                     <a:solidFill>
-                      <a:srgbClr val="FFFFFF">
-                        <a:alpha val="0"/>
+                      <a:srgbClr val="F4F8FB">
+                        <a:alpha val="100000"/>
                       </a:srgbClr>
                     </a:solidFill>
                   </a:tcPr>
@@ -27943,13 +28238,17 @@
                       <a:noFill/>
                       <a:prstDash val="solid"/>
                     </a:lnT>
-                    <a:lnB algn="ctr" cmpd="sng" cap="flat" w="0">
-                      <a:noFill/>
+                    <a:lnB algn="ctr" cmpd="sng" cap="flat" w="19050">
+                      <a:solidFill>
+                        <a:srgbClr val="666666">
+                          <a:alpha val="100000"/>
+                        </a:srgbClr>
+                      </a:solidFill>
                       <a:prstDash val="solid"/>
                     </a:lnB>
                     <a:solidFill>
-                      <a:srgbClr val="FFFFFF">
-                        <a:alpha val="0"/>
+                      <a:srgbClr val="F4F8FB">
+                        <a:alpha val="100000"/>
                       </a:srgbClr>
                     </a:solidFill>
                   </a:tcPr>
@@ -28000,122 +28299,6 @@
                       <a:noFill/>
                       <a:prstDash val="solid"/>
                     </a:lnT>
-                    <a:lnB algn="ctr" cmpd="sng" cap="flat" w="0">
-                      <a:noFill/>
-                      <a:prstDash val="solid"/>
-                    </a:lnB>
-                    <a:solidFill>
-                      <a:srgbClr val="FFFFFF">
-                        <a:alpha val="0"/>
-                      </a:srgbClr>
-                    </a:solidFill>
-                  </a:tcPr>
-                </a:tc>
-                <a:tc>
-                  <a:txBody>
-                    <a:bodyPr/>
-                    <a:lstStyle/>
-                    <a:p>
-                      <a:pPr algn="l" marL="63500" marR="63500">
-                        <a:lnSpc>
-                          <a:spcPct val="100000"/>
-                        </a:lnSpc>
-                        <a:spcBef>
-                          <a:spcPts val="500"/>
-                        </a:spcBef>
-                        <a:spcAft>
-                          <a:spcPts val="500"/>
-                        </a:spcAft>
-                        <a:buNone/>
-                      </a:pPr>
-                      <a:r>
-                        <a:rPr cap="none" sz="1200" i="0" b="0" u="none" strike="noStrike">
-                          <a:solidFill>
-                            <a:srgbClr val="5B6770">
-                              <a:alpha val="100000"/>
-                            </a:srgbClr>
-                          </a:solidFill>
-                          <a:latin typeface="Helvetica Neue"/>
-                          <a:cs typeface="Helvetica Neue"/>
-                          <a:ea typeface="Helvetica Neue"/>
-                          <a:sym typeface="Helvetica Neue"/>
-                        </a:rPr>
-                        <a:t>816795</a:t>
-                      </a:r>
-                    </a:p>
-                  </a:txBody>
-                  <a:tcPr anchor="ctr" marB="63500" marT="63500" marR="0" marL="0">
-                    <a:lnL algn="ctr" cmpd="sng" cap="flat" w="0">
-                      <a:noFill/>
-                      <a:prstDash val="solid"/>
-                    </a:lnL>
-                    <a:lnR algn="ctr" cmpd="sng" cap="flat" w="0">
-                      <a:noFill/>
-                      <a:prstDash val="solid"/>
-                    </a:lnR>
-                    <a:lnT algn="ctr" cmpd="sng" cap="flat" w="0">
-                      <a:noFill/>
-                      <a:prstDash val="solid"/>
-                    </a:lnT>
-                    <a:lnB algn="ctr" cmpd="sng" cap="flat" w="0">
-                      <a:noFill/>
-                      <a:prstDash val="solid"/>
-                    </a:lnB>
-                    <a:solidFill>
-                      <a:srgbClr val="FFFFFF">
-                        <a:alpha val="0"/>
-                      </a:srgbClr>
-                    </a:solidFill>
-                  </a:tcPr>
-                </a:tc>
-              </a:tr>
-              <a:tr h="410845">
-                <a:tc>
-                  <a:txBody>
-                    <a:bodyPr/>
-                    <a:lstStyle/>
-                    <a:p>
-                      <a:pPr algn="l" marL="63500" marR="63500">
-                        <a:lnSpc>
-                          <a:spcPct val="100000"/>
-                        </a:lnSpc>
-                        <a:spcBef>
-                          <a:spcPts val="500"/>
-                        </a:spcBef>
-                        <a:spcAft>
-                          <a:spcPts val="500"/>
-                        </a:spcAft>
-                        <a:buNone/>
-                      </a:pPr>
-                      <a:r>
-                        <a:rPr cap="none" sz="1200" i="0" b="0" u="none" strike="noStrike">
-                          <a:solidFill>
-                            <a:srgbClr val="5B6770">
-                              <a:alpha val="100000"/>
-                            </a:srgbClr>
-                          </a:solidFill>
-                          <a:latin typeface="Helvetica Neue"/>
-                          <a:cs typeface="Helvetica Neue"/>
-                          <a:ea typeface="Helvetica Neue"/>
-                          <a:sym typeface="Helvetica Neue"/>
-                        </a:rPr>
-                        <a:t>aminopyrine</a:t>
-                      </a:r>
-                    </a:p>
-                  </a:txBody>
-                  <a:tcPr anchor="ctr" marB="63500" marT="63500" marR="0" marL="0">
-                    <a:lnL algn="ctr" cmpd="sng" cap="flat" w="0">
-                      <a:noFill/>
-                      <a:prstDash val="solid"/>
-                    </a:lnL>
-                    <a:lnR algn="ctr" cmpd="sng" cap="flat" w="0">
-                      <a:noFill/>
-                      <a:prstDash val="solid"/>
-                    </a:lnR>
-                    <a:lnT algn="ctr" cmpd="sng" cap="flat" w="0">
-                      <a:noFill/>
-                      <a:prstDash val="solid"/>
-                    </a:lnT>
                     <a:lnB algn="ctr" cmpd="sng" cap="flat" w="19050">
                       <a:solidFill>
                         <a:srgbClr val="666666">
@@ -28160,190 +28343,7 @@
                           <a:ea typeface="Helvetica Neue"/>
                           <a:sym typeface="Helvetica Neue"/>
                         </a:rPr>
-                        <a:t>28 Jul 2026</a:t>
-                      </a:r>
-                    </a:p>
-                  </a:txBody>
-                  <a:tcPr anchor="ctr" marB="63500" marT="63500" marR="0" marL="0">
-                    <a:lnL algn="ctr" cmpd="sng" cap="flat" w="0">
-                      <a:noFill/>
-                      <a:prstDash val="solid"/>
-                    </a:lnL>
-                    <a:lnR algn="ctr" cmpd="sng" cap="flat" w="0">
-                      <a:noFill/>
-                      <a:prstDash val="solid"/>
-                    </a:lnR>
-                    <a:lnT algn="ctr" cmpd="sng" cap="flat" w="0">
-                      <a:noFill/>
-                      <a:prstDash val="solid"/>
-                    </a:lnT>
-                    <a:lnB algn="ctr" cmpd="sng" cap="flat" w="19050">
-                      <a:solidFill>
-                        <a:srgbClr val="666666">
-                          <a:alpha val="100000"/>
-                        </a:srgbClr>
-                      </a:solidFill>
-                      <a:prstDash val="solid"/>
-                    </a:lnB>
-                    <a:solidFill>
-                      <a:srgbClr val="F4F8FB">
-                        <a:alpha val="100000"/>
-                      </a:srgbClr>
-                    </a:solidFill>
-                  </a:tcPr>
-                </a:tc>
-                <a:tc>
-                  <a:txBody>
-                    <a:bodyPr/>
-                    <a:lstStyle/>
-                    <a:p>
-                      <a:pPr algn="l" marL="63500" marR="63500">
-                        <a:lnSpc>
-                          <a:spcPct val="100000"/>
-                        </a:lnSpc>
-                        <a:spcBef>
-                          <a:spcPts val="500"/>
-                        </a:spcBef>
-                        <a:spcAft>
-                          <a:spcPts val="500"/>
-                        </a:spcAft>
-                        <a:buNone/>
-                      </a:pPr>
-                      <a:r>
-                        <a:rPr cap="none" sz="1200" i="0" b="0" u="none" strike="noStrike">
-                          <a:solidFill>
-                            <a:srgbClr val="5B6770">
-                              <a:alpha val="100000"/>
-                            </a:srgbClr>
-                          </a:solidFill>
-                          <a:latin typeface="Helvetica Neue"/>
-                          <a:cs typeface="Helvetica Neue"/>
-                          <a:ea typeface="Helvetica Neue"/>
-                          <a:sym typeface="Helvetica Neue"/>
-                        </a:rPr>
-                        <a:t>primary</a:t>
-                      </a:r>
-                    </a:p>
-                  </a:txBody>
-                  <a:tcPr anchor="ctr" marB="63500" marT="63500" marR="0" marL="0">
-                    <a:lnL algn="ctr" cmpd="sng" cap="flat" w="0">
-                      <a:noFill/>
-                      <a:prstDash val="solid"/>
-                    </a:lnL>
-                    <a:lnR algn="ctr" cmpd="sng" cap="flat" w="0">
-                      <a:noFill/>
-                      <a:prstDash val="solid"/>
-                    </a:lnR>
-                    <a:lnT algn="ctr" cmpd="sng" cap="flat" w="0">
-                      <a:noFill/>
-                      <a:prstDash val="solid"/>
-                    </a:lnT>
-                    <a:lnB algn="ctr" cmpd="sng" cap="flat" w="19050">
-                      <a:solidFill>
-                        <a:srgbClr val="666666">
-                          <a:alpha val="100000"/>
-                        </a:srgbClr>
-                      </a:solidFill>
-                      <a:prstDash val="solid"/>
-                    </a:lnB>
-                    <a:solidFill>
-                      <a:srgbClr val="F4F8FB">
-                        <a:alpha val="100000"/>
-                      </a:srgbClr>
-                    </a:solidFill>
-                  </a:tcPr>
-                </a:tc>
-                <a:tc>
-                  <a:txBody>
-                    <a:bodyPr/>
-                    <a:lstStyle/>
-                    <a:p>
-                      <a:pPr algn="r" marL="63500" marR="63500">
-                        <a:lnSpc>
-                          <a:spcPct val="100000"/>
-                        </a:lnSpc>
-                        <a:spcBef>
-                          <a:spcPts val="500"/>
-                        </a:spcBef>
-                        <a:spcAft>
-                          <a:spcPts val="500"/>
-                        </a:spcAft>
-                        <a:buNone/>
-                      </a:pPr>
-                      <a:r>
-                        <a:rPr cap="none" sz="1200" i="0" b="0" u="none" strike="noStrike">
-                          <a:solidFill>
-                            <a:srgbClr val="5B6770">
-                              <a:alpha val="100000"/>
-                            </a:srgbClr>
-                          </a:solidFill>
-                          <a:latin typeface="Helvetica Neue"/>
-                          <a:cs typeface="Helvetica Neue"/>
-                          <a:ea typeface="Helvetica Neue"/>
-                          <a:sym typeface="Helvetica Neue"/>
-                        </a:rPr>
-                        <a:t>1</a:t>
-                      </a:r>
-                    </a:p>
-                  </a:txBody>
-                  <a:tcPr anchor="ctr" marB="63500" marT="63500" marR="0" marL="0">
-                    <a:lnL algn="ctr" cmpd="sng" cap="flat" w="0">
-                      <a:noFill/>
-                      <a:prstDash val="solid"/>
-                    </a:lnL>
-                    <a:lnR algn="ctr" cmpd="sng" cap="flat" w="0">
-                      <a:noFill/>
-                      <a:prstDash val="solid"/>
-                    </a:lnR>
-                    <a:lnT algn="ctr" cmpd="sng" cap="flat" w="0">
-                      <a:noFill/>
-                      <a:prstDash val="solid"/>
-                    </a:lnT>
-                    <a:lnB algn="ctr" cmpd="sng" cap="flat" w="19050">
-                      <a:solidFill>
-                        <a:srgbClr val="666666">
-                          <a:alpha val="100000"/>
-                        </a:srgbClr>
-                      </a:solidFill>
-                      <a:prstDash val="solid"/>
-                    </a:lnB>
-                    <a:solidFill>
-                      <a:srgbClr val="F4F8FB">
-                        <a:alpha val="100000"/>
-                      </a:srgbClr>
-                    </a:solidFill>
-                  </a:tcPr>
-                </a:tc>
-                <a:tc>
-                  <a:txBody>
-                    <a:bodyPr/>
-                    <a:lstStyle/>
-                    <a:p>
-                      <a:pPr algn="l" marL="63500" marR="63500">
-                        <a:lnSpc>
-                          <a:spcPct val="100000"/>
-                        </a:lnSpc>
-                        <a:spcBef>
-                          <a:spcPts val="500"/>
-                        </a:spcBef>
-                        <a:spcAft>
-                          <a:spcPts val="500"/>
-                        </a:spcAft>
-                        <a:buNone/>
-                      </a:pPr>
-                      <a:r>
-                        <a:rPr cap="none" sz="1200" i="0" b="0" u="none" strike="noStrike">
-                          <a:solidFill>
-                            <a:srgbClr val="5B6770">
-                              <a:alpha val="100000"/>
-                            </a:srgbClr>
-                          </a:solidFill>
-                          <a:latin typeface="Helvetica Neue"/>
-                          <a:cs typeface="Helvetica Neue"/>
-                          <a:ea typeface="Helvetica Neue"/>
-                          <a:sym typeface="Helvetica Neue"/>
-                        </a:rPr>
-                        <a:t>605808</a:t>
+                        <a:t>816795</a:t>
                       </a:r>
                     </a:p>
                   </a:txBody>

</xml_diff>

<commit_message>
nightly deck: data through 2026-10-25
</commit_message>
<xml_diff>
--- a/docs/nc-drug-checking-latest.pptx
+++ b/docs/nc-drug-checking-latest.pptx
@@ -2418,7 +2418,7 @@
                 <a:ea typeface="Helvetica Neue"/>
                 <a:sym typeface="Helvetica Neue"/>
               </a:rPr>
-              <a:t>Generated Saturday, October 24, 2026 · 8:08 AM ET UNC Street Drug Analysis Lab · OpioidData.org · results.streetsafe.supply Download as PowerPoint</a:t>
+              <a:t>Generated Sunday, October 25, 2026 · 8:41 AM ET UNC Street Drug Analysis Lab · OpioidData.org · results.streetsafe.supply Download as PowerPoint</a:t>
             </a:r>
           </a:p>
         </p:txBody>
@@ -3184,7 +3184,7 @@
                 <a:ea typeface="Helvetica Neue"/>
                 <a:sym typeface="Helvetica Neue"/>
               </a:rPr>
-              <a:t>County = samplecounty · left: ≥1 completed analysis ever · right: unique samples per county (sqrt color scale) · all time: 26 Jan 2022 – 23 Oct 2026 · last 12 months: 24 Oct 2025 – 23 Oct 2026* · coverage reflects participation, not prevalence</a:t>
+              <a:t>County = samplecounty · left: ≥1 completed analysis ever · right: unique samples per county (sqrt color scale) · all time: 26 Jan 2022 – 23 Oct 2026 · last 12 months: 25 Oct 2025 – 23 Oct 2026* · coverage reflects participation, not prevalence</a:t>
             </a:r>
           </a:p>
         </p:txBody>
@@ -4323,7 +4323,7 @@
                 <a:ea typeface="Helvetica Neue"/>
                 <a:sym typeface="Helvetica Neue"/>
               </a:rPr>
-              <a:t>Samples with methamphetamine or cocaine detected (any abundance); samples in both classes appear on both slides · sensations semicolon lists parsed + sen_strength (own denominator) · consumed = 1 only · before: 26 Jan 2022 – 23 Oct 2025 · past 12 months: 24 Oct 2025 – 23 Oct 2026* · Δ in percentage points</a:t>
+              <a:t>Samples with methamphetamine or cocaine detected (any abundance); samples in both classes appear on both slides · sensations semicolon lists parsed + sen_strength (own denominator) · consumed = 1 only · before: 26 Jan 2022 – 23 Oct 2025 · past 12 months: 25 Oct 2025 – 23 Oct 2026* · Δ in percentage points</a:t>
             </a:r>
           </a:p>
         </p:txBody>
@@ -4742,7 +4742,7 @@
                 <a:ea typeface="Helvetica Neue"/>
                 <a:sym typeface="Helvetica Neue"/>
               </a:rPr>
-              <a:t>Samples with an opioid (fentanyl, heroin) or benzodiazepine detected (any abundance); samples in both classes appear on both slides · sensations semicolon lists parsed + sen_strength (own denominator) · consumed = 1 only · before: 26 Jan 2022 – 23 Oct 2025 · past 12 months: 24 Oct 2025 – 23 Oct 2026* · Δ in percentage points</a:t>
+              <a:t>Samples with an opioid (fentanyl, heroin) or benzodiazepine detected (any abundance); samples in both classes appear on both slides · sensations semicolon lists parsed + sen_strength (own denominator) · consumed = 1 only · before: 26 Jan 2022 – 23 Oct 2025 · past 12 months: 25 Oct 2025 – 23 Oct 2026* · Δ in percentage points</a:t>
             </a:r>
           </a:p>
         </p:txBody>
@@ -5855,7 +5855,7 @@
                 <a:ea typeface="Helvetica Neue"/>
                 <a:sym typeface="Helvetica Neue"/>
               </a:rPr>
-              <a:t>lab_detail.substance counts · solid = primary abundance, light = trace · standardized names (PubChem-linked) · window: date_complete 24 Oct 2025 – 23 Oct 2026* (trailing 12 months, current month partial)</a:t>
+              <a:t>lab_detail.substance counts · solid = primary abundance, light = trace · standardized names (PubChem-linked) · window: date_complete 25 Oct 2025 – 23 Oct 2026* (trailing 12 months, current month partial)</a:t>
             </a:r>
           </a:p>
         </p:txBody>
@@ -6053,7 +6053,7 @@
                 <a:ea typeface="Helvetica Neue"/>
                 <a:sym typeface="Helvetica Neue"/>
               </a:rPr>
-              <a:t>Distribution of substances detected per sample, both definitions shown side by side · window: date_complete 24 Oct 2025 – 23 Oct 2026* (trailing 12 months, current month partial)</a:t>
+              <a:t>Distribution of substances detected per sample, both definitions shown side by side · window: date_complete 25 Oct 2025 – 23 Oct 2026* (trailing 12 months, current month partial)</a:t>
             </a:r>
           </a:p>
         </p:txBody>

</xml_diff>

<commit_message>
nightly deck: data through 2026-10-26
</commit_message>
<xml_diff>
--- a/docs/nc-drug-checking-latest.pptx
+++ b/docs/nc-drug-checking-latest.pptx
@@ -2418,7 +2418,7 @@
                 <a:ea typeface="Helvetica Neue"/>
                 <a:sym typeface="Helvetica Neue"/>
               </a:rPr>
-              <a:t>Generated Sunday, October 25, 2026 · 8:41 AM ET UNC Street Drug Analysis Lab · OpioidData.org · results.streetsafe.supply Download as PowerPoint</a:t>
+              <a:t>Generated Monday, October 26, 2026 · 10:27 AM ET UNC Street Drug Analysis Lab · OpioidData.org · results.streetsafe.supply Download as PowerPoint</a:t>
             </a:r>
           </a:p>
         </p:txBody>
@@ -3184,7 +3184,7 @@
                 <a:ea typeface="Helvetica Neue"/>
                 <a:sym typeface="Helvetica Neue"/>
               </a:rPr>
-              <a:t>County = samplecounty · left: ≥1 completed analysis ever · right: unique samples per county (sqrt color scale) · all time: 26 Jan 2022 – 23 Oct 2026 · last 12 months: 25 Oct 2025 – 23 Oct 2026* · coverage reflects participation, not prevalence</a:t>
+              <a:t>County = samplecounty · left: ≥1 completed analysis ever · right: unique samples per county (sqrt color scale) · all time: 26 Jan 2022 – 23 Oct 2026 · last 12 months: 26 Oct 2025 – 23 Oct 2026* · coverage reflects participation, not prevalence</a:t>
             </a:r>
           </a:p>
         </p:txBody>
@@ -4323,7 +4323,7 @@
                 <a:ea typeface="Helvetica Neue"/>
                 <a:sym typeface="Helvetica Neue"/>
               </a:rPr>
-              <a:t>Samples with methamphetamine or cocaine detected (any abundance); samples in both classes appear on both slides · sensations semicolon lists parsed + sen_strength (own denominator) · consumed = 1 only · before: 26 Jan 2022 – 23 Oct 2025 · past 12 months: 25 Oct 2025 – 23 Oct 2026* · Δ in percentage points</a:t>
+              <a:t>Samples with methamphetamine or cocaine detected (any abundance); samples in both classes appear on both slides · sensations semicolon lists parsed + sen_strength (own denominator) · consumed = 1 only · before: 26 Jan 2022 – 23 Oct 2025 · past 12 months: 26 Oct 2025 – 23 Oct 2026* · Δ in percentage points</a:t>
             </a:r>
           </a:p>
         </p:txBody>
@@ -4742,7 +4742,7 @@
                 <a:ea typeface="Helvetica Neue"/>
                 <a:sym typeface="Helvetica Neue"/>
               </a:rPr>
-              <a:t>Samples with an opioid (fentanyl, heroin) or benzodiazepine detected (any abundance); samples in both classes appear on both slides · sensations semicolon lists parsed + sen_strength (own denominator) · consumed = 1 only · before: 26 Jan 2022 – 23 Oct 2025 · past 12 months: 25 Oct 2025 – 23 Oct 2026* · Δ in percentage points</a:t>
+              <a:t>Samples with an opioid (fentanyl, heroin) or benzodiazepine detected (any abundance); samples in both classes appear on both slides · sensations semicolon lists parsed + sen_strength (own denominator) · consumed = 1 only · before: 26 Jan 2022 – 23 Oct 2025 · past 12 months: 26 Oct 2025 – 23 Oct 2026* · Δ in percentage points</a:t>
             </a:r>
           </a:p>
         </p:txBody>
@@ -5855,7 +5855,7 @@
                 <a:ea typeface="Helvetica Neue"/>
                 <a:sym typeface="Helvetica Neue"/>
               </a:rPr>
-              <a:t>lab_detail.substance counts · solid = primary abundance, light = trace · standardized names (PubChem-linked) · window: date_complete 25 Oct 2025 – 23 Oct 2026* (trailing 12 months, current month partial)</a:t>
+              <a:t>lab_detail.substance counts · solid = primary abundance, light = trace · standardized names (PubChem-linked) · window: date_complete 26 Oct 2025 – 23 Oct 2026* (trailing 12 months, current month partial)</a:t>
             </a:r>
           </a:p>
         </p:txBody>
@@ -6053,7 +6053,7 @@
                 <a:ea typeface="Helvetica Neue"/>
                 <a:sym typeface="Helvetica Neue"/>
               </a:rPr>
-              <a:t>Distribution of substances detected per sample, both definitions shown side by side · window: date_complete 25 Oct 2025 – 23 Oct 2026* (trailing 12 months, current month partial)</a:t>
+              <a:t>Distribution of substances detected per sample, both definitions shown side by side · window: date_complete 26 Oct 2025 – 23 Oct 2026* (trailing 12 months, current month partial)</a:t>
             </a:r>
           </a:p>
         </p:txBody>

</xml_diff>

<commit_message>
nightly deck: data through 2026-10-27
</commit_message>
<xml_diff>
--- a/docs/nc-drug-checking-latest.pptx
+++ b/docs/nc-drug-checking-latest.pptx
@@ -2418,7 +2418,7 @@
                 <a:ea typeface="Helvetica Neue"/>
                 <a:sym typeface="Helvetica Neue"/>
               </a:rPr>
-              <a:t>Generated Monday, October 26, 2026 · 10:27 AM ET UNC Street Drug Analysis Lab · OpioidData.org · results.streetsafe.supply Download as PowerPoint</a:t>
+              <a:t>Generated Tuesday, October 27, 2026 · 9:27 AM ET UNC Street Drug Analysis Lab · OpioidData.org · results.streetsafe.supply Download as PowerPoint</a:t>
             </a:r>
           </a:p>
         </p:txBody>
@@ -2713,7 +2713,7 @@
                 <a:ea typeface="Helvetica Neue"/>
                 <a:sym typeface="Helvetica Neue"/>
               </a:rPr>
-              <a:t>PLACEHOLDER · figs/stats.json January 2022 to Friday, October 23, 2026 N = 3,013 NC samples analyzed Mailed in from 86 harm reduction programs Collected across 60 counties 252 distinct substances detected to date Unique samples = n_distinct(sampleid) · substances from lab_detail.substance · includes samples with date_complete 26 Jan 2022 – 23 Oct 2026 r/build_nightly.R → figs/stats.json</a:t>
+              <a:t>PLACEHOLDER · figs/stats.json January 2022 to Monday, October 26, 2026 N = 3,047 NC samples analyzed Mailed in from 86 harm reduction programs Collected across 60 counties 252 distinct substances detected to date Unique samples = n_distinct(sampleid) · substances from lab_detail.substance · includes samples with date_complete 26 Jan 2022 – 26 Oct 2026 r/build_nightly.R → figs/stats.json</a:t>
             </a:r>
           </a:p>
         </p:txBody>
@@ -2762,7 +2762,7 @@
                 <a:ea typeface="Helvetica Neue"/>
                 <a:sym typeface="Helvetica Neue"/>
               </a:rPr>
-              <a:t>Unique samples = n_distinct(sampleid) · substances from lab_detail.substance · includes samples with date_complete 26 Jan 2022 – 23 Oct 2026</a:t>
+              <a:t>Unique samples = n_distinct(sampleid) · substances from lab_detail.substance · includes samples with date_complete 26 Jan 2022 – 26 Oct 2026</a:t>
             </a:r>
           </a:p>
         </p:txBody>
@@ -3184,7 +3184,7 @@
                 <a:ea typeface="Helvetica Neue"/>
                 <a:sym typeface="Helvetica Neue"/>
               </a:rPr>
-              <a:t>County = samplecounty · left: ≥1 completed analysis ever · right: unique samples per county (sqrt color scale) · all time: 26 Jan 2022 – 23 Oct 2026 · last 12 months: 26 Oct 2025 – 23 Oct 2026* · coverage reflects participation, not prevalence</a:t>
+              <a:t>County = samplecounty · left: ≥1 completed analysis ever · right: unique samples per county (sqrt color scale) · all time: 26 Jan 2022 – 26 Oct 2026 · last 12 months: 27 Oct 2025 – 26 Oct 2026* · coverage reflects participation, not prevalence</a:t>
             </a:r>
           </a:p>
         </p:txBody>
@@ -3505,7 +3505,7 @@
                 <a:ea typeface="Helvetica Neue"/>
                 <a:sym typeface="Helvetica Neue"/>
               </a:rPr>
-              <a:t>expectedsubstance (verbatim card write-in, semicolon lists split) · derived flags: expect_opioid, expect_fentanyl, expect_meth, expect_cocaine, expect_stimulant… · includes samples with date_complete 26 Jan 2022 – 23 Oct 2026 · data table: Appendix A2</a:t>
+              <a:t>expectedsubstance (verbatim card write-in, semicolon lists split) · derived flags: expect_opioid, expect_fentanyl, expect_meth, expect_cocaine, expect_stimulant… · includes samples with date_complete 26 Jan 2022 – 26 Oct 2026 · data table: Appendix A2</a:t>
             </a:r>
           </a:p>
         </p:txBody>
@@ -3703,7 +3703,7 @@
                 <a:ea typeface="Helvetica Neue"/>
                 <a:sym typeface="Helvetica Neue"/>
               </a:rPr>
-              <a:t>Numerator uses lab_*_any (primary or trace) among samples with expect_* = 1 · includes samples with date_complete 26 Jan 2022 – 23 Oct 2026 · data table: Appendix A3</a:t>
+              <a:t>Numerator uses lab_*_any (primary or trace) among samples with expect_* = 1 · includes samples with date_complete 26 Jan 2022 – 26 Oct 2026 · data table: Appendix A3</a:t>
             </a:r>
           </a:p>
         </p:txBody>
@@ -3901,7 +3901,7 @@
                 <a:ea typeface="Helvetica Neue"/>
                 <a:sym typeface="Helvetica Neue"/>
               </a:rPr>
-              <a:t>sensations (circled on card, semicolon lists split) · post-consumption samples only (consumed = 1) · includes samples with date_complete 26 Jan 2022 – 23 Oct 2026</a:t>
+              <a:t>sensations (circled on card, semicolon lists split) · post-consumption samples only (consumed = 1) · includes samples with date_complete 26 Jan 2022 – 26 Oct 2026</a:t>
             </a:r>
           </a:p>
         </p:txBody>
@@ -4125,7 +4125,7 @@
                 <a:ea typeface="Helvetica Neue"/>
                 <a:sym typeface="Helvetica Neue"/>
               </a:rPr>
-              <a:t>sensations semicolon lists parsed per report · consumed = 1 only · denominator: consumed samples with lab_*_any = 1 · includes samples with date_complete 26 Jan 2022 – 23 Oct 2026</a:t>
+              <a:t>sensations semicolon lists parsed per report · consumed = 1 only · denominator: consumed samples with lab_*_any = 1 · includes samples with date_complete 26 Jan 2022 – 26 Oct 2026</a:t>
             </a:r>
           </a:p>
         </p:txBody>
@@ -4323,7 +4323,7 @@
                 <a:ea typeface="Helvetica Neue"/>
                 <a:sym typeface="Helvetica Neue"/>
               </a:rPr>
-              <a:t>Samples with methamphetamine or cocaine detected (any abundance); samples in both classes appear on both slides · sensations semicolon lists parsed + sen_strength (own denominator) · consumed = 1 only · before: 26 Jan 2022 – 23 Oct 2025 · past 12 months: 26 Oct 2025 – 23 Oct 2026* · Δ in percentage points</a:t>
+              <a:t>Samples with methamphetamine or cocaine detected (any abundance); samples in both classes appear on both slides · sensations semicolon lists parsed + sen_strength (own denominator) · consumed = 1 only · before: 26 Jan 2022 – 26 Oct 2025 · past 12 months: 27 Oct 2025 – 26 Oct 2026* · Δ in percentage points</a:t>
             </a:r>
           </a:p>
         </p:txBody>
@@ -4742,7 +4742,7 @@
                 <a:ea typeface="Helvetica Neue"/>
                 <a:sym typeface="Helvetica Neue"/>
               </a:rPr>
-              <a:t>Samples with an opioid (fentanyl, heroin) or benzodiazepine detected (any abundance); samples in both classes appear on both slides · sensations semicolon lists parsed + sen_strength (own denominator) · consumed = 1 only · before: 26 Jan 2022 – 23 Oct 2025 · past 12 months: 26 Oct 2025 – 23 Oct 2026* · Δ in percentage points</a:t>
+              <a:t>Samples with an opioid (fentanyl, heroin) or benzodiazepine detected (any abundance); samples in both classes appear on both slides · sensations semicolon lists parsed + sen_strength (own denominator) · consumed = 1 only · before: 26 Jan 2022 – 26 Oct 2025 · past 12 months: 27 Oct 2025 – 26 Oct 2026* · Δ in percentage points</a:t>
             </a:r>
           </a:p>
         </p:txBody>
@@ -5138,7 +5138,7 @@
                 <a:ea typeface="Helvetica Neue"/>
                 <a:sym typeface="Helvetica Neue"/>
               </a:rPr>
-              <a:t>color, texture (card v3+, semicolon lists split) · derived: bright_color excludes white/tan/brown family — orange bar above · includes samples with date_complete 26 Jan 2022 – 23 Oct 2026</a:t>
+              <a:t>color, texture (card v3+, semicolon lists split) · derived: bright_color excludes white/tan/brown family — orange bar above · includes samples with date_complete 26 Jan 2022 – 26 Oct 2026</a:t>
             </a:r>
           </a:p>
         </p:txBody>
@@ -5459,7 +5459,7 @@
                 <a:ea typeface="Helvetica Neue"/>
                 <a:sym typeface="Helvetica Neue"/>
               </a:rPr>
-              <a:t>Distribution of substances detected per sample, both definitions shown side by side · includes samples with date_complete 26 Jan 2022 – 23 Oct 2026</a:t>
+              <a:t>Distribution of substances detected per sample, both definitions shown side by side · includes samples with date_complete 26 Jan 2022 – 26 Oct 2026</a:t>
             </a:r>
           </a:p>
         </p:txBody>
@@ -5657,7 +5657,7 @@
                 <a:ea typeface="Helvetica Neue"/>
                 <a:sym typeface="Helvetica Neue"/>
               </a:rPr>
-              <a:t>lab_detail.substance counts · solid = primary abundance, light = trace · standardized names (PubChem-linked) · includes samples with date_complete 26 Jan 2022 – 23 Oct 2026</a:t>
+              <a:t>lab_detail.substance counts · solid = primary abundance, light = trace · standardized names (PubChem-linked) · includes samples with date_complete 26 Jan 2022 – 26 Oct 2026</a:t>
             </a:r>
           </a:p>
         </p:txBody>
@@ -5855,7 +5855,7 @@
                 <a:ea typeface="Helvetica Neue"/>
                 <a:sym typeface="Helvetica Neue"/>
               </a:rPr>
-              <a:t>lab_detail.substance counts · solid = primary abundance, light = trace · standardized names (PubChem-linked) · window: date_complete 26 Oct 2025 – 23 Oct 2026* (trailing 12 months, current month partial)</a:t>
+              <a:t>lab_detail.substance counts · solid = primary abundance, light = trace · standardized names (PubChem-linked) · window: date_complete 27 Oct 2025 – 26 Oct 2026* (trailing 12 months, current month partial)</a:t>
             </a:r>
           </a:p>
         </p:txBody>
@@ -6053,7 +6053,7 @@
                 <a:ea typeface="Helvetica Neue"/>
                 <a:sym typeface="Helvetica Neue"/>
               </a:rPr>
-              <a:t>Distribution of substances detected per sample, both definitions shown side by side · window: date_complete 26 Oct 2025 – 23 Oct 2026* (trailing 12 months, current month partial)</a:t>
+              <a:t>Distribution of substances detected per sample, both definitions shown side by side · window: date_complete 27 Oct 2025 – 26 Oct 2026* (trailing 12 months, current month partial)</a:t>
             </a:r>
           </a:p>
         </p:txBody>
@@ -18510,7 +18510,7 @@
                           <a:ea typeface="Helvetica Neue"/>
                           <a:sym typeface="Helvetica Neue"/>
                         </a:rPr>
-                        <a:t>1,552</a:t>
+                        <a:t>1,580</a:t>
                       </a:r>
                     </a:p>
                   </a:txBody>
@@ -18626,7 +18626,7 @@
                           <a:ea typeface="Helvetica Neue"/>
                           <a:sym typeface="Helvetica Neue"/>
                         </a:rPr>
-                        <a:t>461</a:t>
+                        <a:t>463</a:t>
                       </a:r>
                     </a:p>
                   </a:txBody>
@@ -19322,7 +19322,7 @@
                           <a:ea typeface="Helvetica Neue"/>
                           <a:sym typeface="Helvetica Neue"/>
                         </a:rPr>
-                        <a:t>68</a:t>
+                        <a:t>70</a:t>
                       </a:r>
                     </a:p>
                   </a:txBody>
@@ -19438,7 +19438,7 @@
                           <a:ea typeface="Helvetica Neue"/>
                           <a:sym typeface="Helvetica Neue"/>
                         </a:rPr>
-                        <a:t>65</a:t>
+                        <a:t>66</a:t>
                       </a:r>
                     </a:p>
                   </a:txBody>
@@ -20591,7 +20591,7 @@
                           <a:ea typeface="Helvetica Neue"/>
                           <a:sym typeface="Helvetica Neue"/>
                         </a:rPr>
-                        <a:t>1,800</a:t>
+                        <a:t>1,832</a:t>
                       </a:r>
                     </a:p>
                   </a:txBody>
@@ -20821,7 +20821,7 @@
                           <a:ea typeface="Helvetica Neue"/>
                           <a:sym typeface="Helvetica Neue"/>
                         </a:rPr>
-                        <a:t>541</a:t>
+                        <a:t>544</a:t>
                       </a:r>
                     </a:p>
                   </a:txBody>
@@ -21051,7 +21051,7 @@
                           <a:ea typeface="Helvetica Neue"/>
                           <a:sym typeface="Helvetica Neue"/>
                         </a:rPr>
-                        <a:t>144</a:t>
+                        <a:t>146</a:t>
                       </a:r>
                     </a:p>
                   </a:txBody>
@@ -21108,7 +21108,7 @@
                           <a:ea typeface="Helvetica Neue"/>
                           <a:sym typeface="Helvetica Neue"/>
                         </a:rPr>
-                        <a:t>89%</a:t>
+                        <a:t>88%</a:t>
                       </a:r>
                     </a:p>
                   </a:txBody>
@@ -21515,7 +21515,7 @@
                           <a:ea typeface="Helvetica Neue"/>
                           <a:sym typeface="Helvetica Neue"/>
                         </a:rPr>
-                        <a:t>371</a:t>
+                        <a:t>373</a:t>
                       </a:r>
                     </a:p>
                   </a:txBody>

</xml_diff>

<commit_message>
nightly deck: data through 2026-10-28
</commit_message>
<xml_diff>
--- a/docs/nc-drug-checking-latest.pptx
+++ b/docs/nc-drug-checking-latest.pptx
@@ -2418,7 +2418,7 @@
                 <a:ea typeface="Helvetica Neue"/>
                 <a:sym typeface="Helvetica Neue"/>
               </a:rPr>
-              <a:t>Generated Tuesday, October 27, 2026 · 9:27 AM ET UNC Street Drug Analysis Lab · OpioidData.org · results.streetsafe.supply Download as PowerPoint</a:t>
+              <a:t>Generated Wednesday, October 28, 2026 · 10:14 AM ET UNC Street Drug Analysis Lab · OpioidData.org · results.streetsafe.supply Download as PowerPoint</a:t>
             </a:r>
           </a:p>
         </p:txBody>
@@ -2713,7 +2713,7 @@
                 <a:ea typeface="Helvetica Neue"/>
                 <a:sym typeface="Helvetica Neue"/>
               </a:rPr>
-              <a:t>PLACEHOLDER · figs/stats.json January 2022 to Monday, October 26, 2026 N = 3,047 NC samples analyzed Mailed in from 86 harm reduction programs Collected across 60 counties 252 distinct substances detected to date Unique samples = n_distinct(sampleid) · substances from lab_detail.substance · includes samples with date_complete 26 Jan 2022 – 26 Oct 2026 r/build_nightly.R → figs/stats.json</a:t>
+              <a:t>PLACEHOLDER · figs/stats.json January 2022 to Tuesday, October 27, 2026 N = 3,051 NC samples analyzed Mailed in from 86 harm reduction programs Collected across 60 counties 253 distinct substances detected to date Unique samples = n_distinct(sampleid) · substances from lab_detail.substance · includes samples with date_complete 26 Jan 2022 – 27 Oct 2026 r/build_nightly.R → figs/stats.json</a:t>
             </a:r>
           </a:p>
         </p:txBody>
@@ -2762,7 +2762,7 @@
                 <a:ea typeface="Helvetica Neue"/>
                 <a:sym typeface="Helvetica Neue"/>
               </a:rPr>
-              <a:t>Unique samples = n_distinct(sampleid) · substances from lab_detail.substance · includes samples with date_complete 26 Jan 2022 – 26 Oct 2026</a:t>
+              <a:t>Unique samples = n_distinct(sampleid) · substances from lab_detail.substance · includes samples with date_complete 26 Jan 2022 – 27 Oct 2026</a:t>
             </a:r>
           </a:p>
         </p:txBody>
@@ -3184,7 +3184,7 @@
                 <a:ea typeface="Helvetica Neue"/>
                 <a:sym typeface="Helvetica Neue"/>
               </a:rPr>
-              <a:t>County = samplecounty · left: ≥1 completed analysis ever · right: unique samples per county (sqrt color scale) · all time: 26 Jan 2022 – 26 Oct 2026 · last 12 months: 27 Oct 2025 – 26 Oct 2026* · coverage reflects participation, not prevalence</a:t>
+              <a:t>County = samplecounty · left: ≥1 completed analysis ever · right: unique samples per county (sqrt color scale) · all time: 26 Jan 2022 – 27 Oct 2026 · last 12 months: 28 Oct 2025 – 27 Oct 2026* · coverage reflects participation, not prevalence</a:t>
             </a:r>
           </a:p>
         </p:txBody>
@@ -3505,7 +3505,7 @@
                 <a:ea typeface="Helvetica Neue"/>
                 <a:sym typeface="Helvetica Neue"/>
               </a:rPr>
-              <a:t>expectedsubstance (verbatim card write-in, semicolon lists split) · derived flags: expect_opioid, expect_fentanyl, expect_meth, expect_cocaine, expect_stimulant… · includes samples with date_complete 26 Jan 2022 – 26 Oct 2026 · data table: Appendix A2</a:t>
+              <a:t>expectedsubstance (verbatim card write-in, semicolon lists split) · derived flags: expect_opioid, expect_fentanyl, expect_meth, expect_cocaine, expect_stimulant… · includes samples with date_complete 26 Jan 2022 – 27 Oct 2026 · data table: Appendix A2</a:t>
             </a:r>
           </a:p>
         </p:txBody>
@@ -3703,7 +3703,7 @@
                 <a:ea typeface="Helvetica Neue"/>
                 <a:sym typeface="Helvetica Neue"/>
               </a:rPr>
-              <a:t>Numerator uses lab_*_any (primary or trace) among samples with expect_* = 1 · includes samples with date_complete 26 Jan 2022 – 26 Oct 2026 · data table: Appendix A3</a:t>
+              <a:t>Numerator uses lab_*_any (primary or trace) among samples with expect_* = 1 · includes samples with date_complete 26 Jan 2022 – 27 Oct 2026 · data table: Appendix A3</a:t>
             </a:r>
           </a:p>
         </p:txBody>
@@ -3901,7 +3901,7 @@
                 <a:ea typeface="Helvetica Neue"/>
                 <a:sym typeface="Helvetica Neue"/>
               </a:rPr>
-              <a:t>sensations (circled on card, semicolon lists split) · post-consumption samples only (consumed = 1) · includes samples with date_complete 26 Jan 2022 – 26 Oct 2026</a:t>
+              <a:t>sensations (circled on card, semicolon lists split) · post-consumption samples only (consumed = 1) · includes samples with date_complete 26 Jan 2022 – 27 Oct 2026</a:t>
             </a:r>
           </a:p>
         </p:txBody>
@@ -4125,7 +4125,7 @@
                 <a:ea typeface="Helvetica Neue"/>
                 <a:sym typeface="Helvetica Neue"/>
               </a:rPr>
-              <a:t>sensations semicolon lists parsed per report · consumed = 1 only · denominator: consumed samples with lab_*_any = 1 · includes samples with date_complete 26 Jan 2022 – 26 Oct 2026</a:t>
+              <a:t>sensations semicolon lists parsed per report · consumed = 1 only · denominator: consumed samples with lab_*_any = 1 · includes samples with date_complete 26 Jan 2022 – 27 Oct 2026</a:t>
             </a:r>
           </a:p>
         </p:txBody>
@@ -4323,7 +4323,7 @@
                 <a:ea typeface="Helvetica Neue"/>
                 <a:sym typeface="Helvetica Neue"/>
               </a:rPr>
-              <a:t>Samples with methamphetamine or cocaine detected (any abundance); samples in both classes appear on both slides · sensations semicolon lists parsed + sen_strength (own denominator) · consumed = 1 only · before: 26 Jan 2022 – 26 Oct 2025 · past 12 months: 27 Oct 2025 – 26 Oct 2026* · Δ in percentage points</a:t>
+              <a:t>Samples with methamphetamine or cocaine detected (any abundance); samples in both classes appear on both slides · sensations semicolon lists parsed + sen_strength (own denominator) · consumed = 1 only · before: 26 Jan 2022 – 27 Oct 2025 · past 12 months: 28 Oct 2025 – 27 Oct 2026* · Δ in percentage points</a:t>
             </a:r>
           </a:p>
         </p:txBody>
@@ -4742,7 +4742,7 @@
                 <a:ea typeface="Helvetica Neue"/>
                 <a:sym typeface="Helvetica Neue"/>
               </a:rPr>
-              <a:t>Samples with an opioid (fentanyl, heroin) or benzodiazepine detected (any abundance); samples in both classes appear on both slides · sensations semicolon lists parsed + sen_strength (own denominator) · consumed = 1 only · before: 26 Jan 2022 – 26 Oct 2025 · past 12 months: 27 Oct 2025 – 26 Oct 2026* · Δ in percentage points</a:t>
+              <a:t>Samples with an opioid (fentanyl, heroin) or benzodiazepine detected (any abundance); samples in both classes appear on both slides · sensations semicolon lists parsed + sen_strength (own denominator) · consumed = 1 only · before: 26 Jan 2022 – 27 Oct 2025 · past 12 months: 28 Oct 2025 – 27 Oct 2026* · Δ in percentage points</a:t>
             </a:r>
           </a:p>
         </p:txBody>
@@ -5138,7 +5138,7 @@
                 <a:ea typeface="Helvetica Neue"/>
                 <a:sym typeface="Helvetica Neue"/>
               </a:rPr>
-              <a:t>color, texture (card v3+, semicolon lists split) · derived: bright_color excludes white/tan/brown family — orange bar above · includes samples with date_complete 26 Jan 2022 – 26 Oct 2026</a:t>
+              <a:t>color, texture (card v3+, semicolon lists split) · derived: bright_color excludes white/tan/brown family — orange bar above · includes samples with date_complete 26 Jan 2022 – 27 Oct 2026</a:t>
             </a:r>
           </a:p>
         </p:txBody>
@@ -5459,7 +5459,7 @@
                 <a:ea typeface="Helvetica Neue"/>
                 <a:sym typeface="Helvetica Neue"/>
               </a:rPr>
-              <a:t>Distribution of substances detected per sample, both definitions shown side by side · includes samples with date_complete 26 Jan 2022 – 26 Oct 2026</a:t>
+              <a:t>Distribution of substances detected per sample, both definitions shown side by side · includes samples with date_complete 26 Jan 2022 – 27 Oct 2026</a:t>
             </a:r>
           </a:p>
         </p:txBody>
@@ -5657,7 +5657,7 @@
                 <a:ea typeface="Helvetica Neue"/>
                 <a:sym typeface="Helvetica Neue"/>
               </a:rPr>
-              <a:t>lab_detail.substance counts · solid = primary abundance, light = trace · standardized names (PubChem-linked) · includes samples with date_complete 26 Jan 2022 – 26 Oct 2026</a:t>
+              <a:t>lab_detail.substance counts · solid = primary abundance, light = trace · standardized names (PubChem-linked) · includes samples with date_complete 26 Jan 2022 – 27 Oct 2026</a:t>
             </a:r>
           </a:p>
         </p:txBody>
@@ -5855,7 +5855,7 @@
                 <a:ea typeface="Helvetica Neue"/>
                 <a:sym typeface="Helvetica Neue"/>
               </a:rPr>
-              <a:t>lab_detail.substance counts · solid = primary abundance, light = trace · standardized names (PubChem-linked) · window: date_complete 27 Oct 2025 – 26 Oct 2026* (trailing 12 months, current month partial)</a:t>
+              <a:t>lab_detail.substance counts · solid = primary abundance, light = trace · standardized names (PubChem-linked) · window: date_complete 28 Oct 2025 – 27 Oct 2026* (trailing 12 months, current month partial)</a:t>
             </a:r>
           </a:p>
         </p:txBody>
@@ -6053,7 +6053,7 @@
                 <a:ea typeface="Helvetica Neue"/>
                 <a:sym typeface="Helvetica Neue"/>
               </a:rPr>
-              <a:t>Distribution of substances detected per sample, both definitions shown side by side · window: date_complete 27 Oct 2025 – 26 Oct 2026* (trailing 12 months, current month partial)</a:t>
+              <a:t>Distribution of substances detected per sample, both definitions shown side by side · window: date_complete 28 Oct 2025 – 27 Oct 2026* (trailing 12 months, current month partial)</a:t>
             </a:r>
           </a:p>
         </p:txBody>
@@ -11049,6 +11049,293 @@
                           <a:ea typeface="Helvetica Neue"/>
                           <a:sym typeface="Helvetica Neue"/>
                         </a:rPr>
+                        <a:t>mifepristone</a:t>
+                      </a:r>
+                    </a:p>
+                  </a:txBody>
+                  <a:tcPr anchor="ctr" marB="63500" marT="63500" marR="0" marL="0">
+                    <a:lnL algn="ctr" cmpd="sng" cap="flat" w="0">
+                      <a:noFill/>
+                      <a:prstDash val="solid"/>
+                    </a:lnL>
+                    <a:lnR algn="ctr" cmpd="sng" cap="flat" w="0">
+                      <a:noFill/>
+                      <a:prstDash val="solid"/>
+                    </a:lnR>
+                    <a:lnT algn="ctr" cmpd="sng" cap="flat" w="0">
+                      <a:noFill/>
+                      <a:prstDash val="solid"/>
+                    </a:lnT>
+                    <a:lnB algn="ctr" cmpd="sng" cap="flat" w="0">
+                      <a:noFill/>
+                      <a:prstDash val="solid"/>
+                    </a:lnB>
+                    <a:solidFill>
+                      <a:srgbClr val="FFFFFF">
+                        <a:alpha val="0"/>
+                      </a:srgbClr>
+                    </a:solidFill>
+                  </a:tcPr>
+                </a:tc>
+                <a:tc>
+                  <a:txBody>
+                    <a:bodyPr/>
+                    <a:lstStyle/>
+                    <a:p>
+                      <a:pPr algn="l" marL="63500" marR="63500">
+                        <a:lnSpc>
+                          <a:spcPct val="100000"/>
+                        </a:lnSpc>
+                        <a:spcBef>
+                          <a:spcPts val="500"/>
+                        </a:spcBef>
+                        <a:spcAft>
+                          <a:spcPts val="500"/>
+                        </a:spcAft>
+                        <a:buNone/>
+                      </a:pPr>
+                      <a:r>
+                        <a:rPr cap="none" sz="1200" i="0" b="0" u="none" strike="noStrike">
+                          <a:solidFill>
+                            <a:srgbClr val="5B6770">
+                              <a:alpha val="100000"/>
+                            </a:srgbClr>
+                          </a:solidFill>
+                          <a:latin typeface="Helvetica Neue"/>
+                          <a:cs typeface="Helvetica Neue"/>
+                          <a:ea typeface="Helvetica Neue"/>
+                          <a:sym typeface="Helvetica Neue"/>
+                        </a:rPr>
+                        <a:t>27 Oct 2026</a:t>
+                      </a:r>
+                    </a:p>
+                  </a:txBody>
+                  <a:tcPr anchor="ctr" marB="63500" marT="63500" marR="0" marL="0">
+                    <a:lnL algn="ctr" cmpd="sng" cap="flat" w="0">
+                      <a:noFill/>
+                      <a:prstDash val="solid"/>
+                    </a:lnL>
+                    <a:lnR algn="ctr" cmpd="sng" cap="flat" w="0">
+                      <a:noFill/>
+                      <a:prstDash val="solid"/>
+                    </a:lnR>
+                    <a:lnT algn="ctr" cmpd="sng" cap="flat" w="0">
+                      <a:noFill/>
+                      <a:prstDash val="solid"/>
+                    </a:lnT>
+                    <a:lnB algn="ctr" cmpd="sng" cap="flat" w="0">
+                      <a:noFill/>
+                      <a:prstDash val="solid"/>
+                    </a:lnB>
+                    <a:solidFill>
+                      <a:srgbClr val="FFFFFF">
+                        <a:alpha val="0"/>
+                      </a:srgbClr>
+                    </a:solidFill>
+                  </a:tcPr>
+                </a:tc>
+                <a:tc>
+                  <a:txBody>
+                    <a:bodyPr/>
+                    <a:lstStyle/>
+                    <a:p>
+                      <a:pPr algn="l" marL="63500" marR="63500">
+                        <a:lnSpc>
+                          <a:spcPct val="100000"/>
+                        </a:lnSpc>
+                        <a:spcBef>
+                          <a:spcPts val="500"/>
+                        </a:spcBef>
+                        <a:spcAft>
+                          <a:spcPts val="500"/>
+                        </a:spcAft>
+                        <a:buNone/>
+                      </a:pPr>
+                      <a:r>
+                        <a:rPr cap="none" sz="1200" i="0" b="0" u="none" strike="noStrike">
+                          <a:solidFill>
+                            <a:srgbClr val="5B6770">
+                              <a:alpha val="100000"/>
+                            </a:srgbClr>
+                          </a:solidFill>
+                          <a:latin typeface="Helvetica Neue"/>
+                          <a:cs typeface="Helvetica Neue"/>
+                          <a:ea typeface="Helvetica Neue"/>
+                          <a:sym typeface="Helvetica Neue"/>
+                        </a:rPr>
+                        <a:t>primary</a:t>
+                      </a:r>
+                    </a:p>
+                  </a:txBody>
+                  <a:tcPr anchor="ctr" marB="63500" marT="63500" marR="0" marL="0">
+                    <a:lnL algn="ctr" cmpd="sng" cap="flat" w="0">
+                      <a:noFill/>
+                      <a:prstDash val="solid"/>
+                    </a:lnL>
+                    <a:lnR algn="ctr" cmpd="sng" cap="flat" w="0">
+                      <a:noFill/>
+                      <a:prstDash val="solid"/>
+                    </a:lnR>
+                    <a:lnT algn="ctr" cmpd="sng" cap="flat" w="0">
+                      <a:noFill/>
+                      <a:prstDash val="solid"/>
+                    </a:lnT>
+                    <a:lnB algn="ctr" cmpd="sng" cap="flat" w="0">
+                      <a:noFill/>
+                      <a:prstDash val="solid"/>
+                    </a:lnB>
+                    <a:solidFill>
+                      <a:srgbClr val="FFFFFF">
+                        <a:alpha val="0"/>
+                      </a:srgbClr>
+                    </a:solidFill>
+                  </a:tcPr>
+                </a:tc>
+                <a:tc>
+                  <a:txBody>
+                    <a:bodyPr/>
+                    <a:lstStyle/>
+                    <a:p>
+                      <a:pPr algn="r" marL="63500" marR="63500">
+                        <a:lnSpc>
+                          <a:spcPct val="100000"/>
+                        </a:lnSpc>
+                        <a:spcBef>
+                          <a:spcPts val="500"/>
+                        </a:spcBef>
+                        <a:spcAft>
+                          <a:spcPts val="500"/>
+                        </a:spcAft>
+                        <a:buNone/>
+                      </a:pPr>
+                      <a:r>
+                        <a:rPr cap="none" sz="1200" i="0" b="0" u="none" strike="noStrike">
+                          <a:solidFill>
+                            <a:srgbClr val="5B6770">
+                              <a:alpha val="100000"/>
+                            </a:srgbClr>
+                          </a:solidFill>
+                          <a:latin typeface="Helvetica Neue"/>
+                          <a:cs typeface="Helvetica Neue"/>
+                          <a:ea typeface="Helvetica Neue"/>
+                          <a:sym typeface="Helvetica Neue"/>
+                        </a:rPr>
+                        <a:t>1</a:t>
+                      </a:r>
+                    </a:p>
+                  </a:txBody>
+                  <a:tcPr anchor="ctr" marB="63500" marT="63500" marR="0" marL="0">
+                    <a:lnL algn="ctr" cmpd="sng" cap="flat" w="0">
+                      <a:noFill/>
+                      <a:prstDash val="solid"/>
+                    </a:lnL>
+                    <a:lnR algn="ctr" cmpd="sng" cap="flat" w="0">
+                      <a:noFill/>
+                      <a:prstDash val="solid"/>
+                    </a:lnR>
+                    <a:lnT algn="ctr" cmpd="sng" cap="flat" w="0">
+                      <a:noFill/>
+                      <a:prstDash val="solid"/>
+                    </a:lnT>
+                    <a:lnB algn="ctr" cmpd="sng" cap="flat" w="0">
+                      <a:noFill/>
+                      <a:prstDash val="solid"/>
+                    </a:lnB>
+                    <a:solidFill>
+                      <a:srgbClr val="FFFFFF">
+                        <a:alpha val="0"/>
+                      </a:srgbClr>
+                    </a:solidFill>
+                  </a:tcPr>
+                </a:tc>
+                <a:tc>
+                  <a:txBody>
+                    <a:bodyPr/>
+                    <a:lstStyle/>
+                    <a:p>
+                      <a:pPr algn="l" marL="63500" marR="63500">
+                        <a:lnSpc>
+                          <a:spcPct val="100000"/>
+                        </a:lnSpc>
+                        <a:spcBef>
+                          <a:spcPts val="500"/>
+                        </a:spcBef>
+                        <a:spcAft>
+                          <a:spcPts val="500"/>
+                        </a:spcAft>
+                        <a:buNone/>
+                      </a:pPr>
+                      <a:r>
+                        <a:rPr cap="none" sz="1200" i="0" b="0" u="none" strike="noStrike">
+                          <a:solidFill>
+                            <a:srgbClr val="5B6770">
+                              <a:alpha val="100000"/>
+                            </a:srgbClr>
+                          </a:solidFill>
+                          <a:latin typeface="Helvetica Neue"/>
+                          <a:cs typeface="Helvetica Neue"/>
+                          <a:ea typeface="Helvetica Neue"/>
+                          <a:sym typeface="Helvetica Neue"/>
+                        </a:rPr>
+                        <a:t>821731</a:t>
+                      </a:r>
+                    </a:p>
+                  </a:txBody>
+                  <a:tcPr anchor="ctr" marB="63500" marT="63500" marR="0" marL="0">
+                    <a:lnL algn="ctr" cmpd="sng" cap="flat" w="0">
+                      <a:noFill/>
+                      <a:prstDash val="solid"/>
+                    </a:lnL>
+                    <a:lnR algn="ctr" cmpd="sng" cap="flat" w="0">
+                      <a:noFill/>
+                      <a:prstDash val="solid"/>
+                    </a:lnR>
+                    <a:lnT algn="ctr" cmpd="sng" cap="flat" w="0">
+                      <a:noFill/>
+                      <a:prstDash val="solid"/>
+                    </a:lnT>
+                    <a:lnB algn="ctr" cmpd="sng" cap="flat" w="0">
+                      <a:noFill/>
+                      <a:prstDash val="solid"/>
+                    </a:lnB>
+                    <a:solidFill>
+                      <a:srgbClr val="FFFFFF">
+                        <a:alpha val="0"/>
+                      </a:srgbClr>
+                    </a:solidFill>
+                  </a:tcPr>
+                </a:tc>
+              </a:tr>
+              <a:tr h="401320">
+                <a:tc>
+                  <a:txBody>
+                    <a:bodyPr/>
+                    <a:lstStyle/>
+                    <a:p>
+                      <a:pPr algn="l" marL="63500" marR="63500">
+                        <a:lnSpc>
+                          <a:spcPct val="100000"/>
+                        </a:lnSpc>
+                        <a:spcBef>
+                          <a:spcPts val="500"/>
+                        </a:spcBef>
+                        <a:spcAft>
+                          <a:spcPts val="500"/>
+                        </a:spcAft>
+                        <a:buNone/>
+                      </a:pPr>
+                      <a:r>
+                        <a:rPr cap="none" sz="1200" i="0" b="0" u="none" strike="noStrike">
+                          <a:solidFill>
+                            <a:srgbClr val="5B6770">
+                              <a:alpha val="100000"/>
+                            </a:srgbClr>
+                          </a:solidFill>
+                          <a:latin typeface="Helvetica Neue"/>
+                          <a:cs typeface="Helvetica Neue"/>
+                          <a:ea typeface="Helvetica Neue"/>
+                          <a:sym typeface="Helvetica Neue"/>
+                        </a:rPr>
                         <a:t>psilocybin</a:t>
                       </a:r>
                     </a:p>
@@ -11071,8 +11358,8 @@
                       <a:prstDash val="solid"/>
                     </a:lnB>
                     <a:solidFill>
-                      <a:srgbClr val="FFFFFF">
-                        <a:alpha val="0"/>
+                      <a:srgbClr val="F4F8FB">
+                        <a:alpha val="100000"/>
                       </a:srgbClr>
                     </a:solidFill>
                   </a:tcPr>
@@ -11128,8 +11415,8 @@
                       <a:prstDash val="solid"/>
                     </a:lnB>
                     <a:solidFill>
-                      <a:srgbClr val="FFFFFF">
-                        <a:alpha val="0"/>
+                      <a:srgbClr val="F4F8FB">
+                        <a:alpha val="100000"/>
                       </a:srgbClr>
                     </a:solidFill>
                   </a:tcPr>
@@ -11185,8 +11472,8 @@
                       <a:prstDash val="solid"/>
                     </a:lnB>
                     <a:solidFill>
-                      <a:srgbClr val="FFFFFF">
-                        <a:alpha val="0"/>
+                      <a:srgbClr val="F4F8FB">
+                        <a:alpha val="100000"/>
                       </a:srgbClr>
                     </a:solidFill>
                   </a:tcPr>
@@ -11242,8 +11529,8 @@
                       <a:prstDash val="solid"/>
                     </a:lnB>
                     <a:solidFill>
-                      <a:srgbClr val="FFFFFF">
-                        <a:alpha val="0"/>
+                      <a:srgbClr val="F4F8FB">
+                        <a:alpha val="100000"/>
                       </a:srgbClr>
                     </a:solidFill>
                   </a:tcPr>
@@ -11299,8 +11586,8 @@
                       <a:prstDash val="solid"/>
                     </a:lnB>
                     <a:solidFill>
-                      <a:srgbClr val="FFFFFF">
-                        <a:alpha val="0"/>
+                      <a:srgbClr val="F4F8FB">
+                        <a:alpha val="100000"/>
                       </a:srgbClr>
                     </a:solidFill>
                   </a:tcPr>
@@ -11358,8 +11645,8 @@
                       <a:prstDash val="solid"/>
                     </a:lnB>
                     <a:solidFill>
-                      <a:srgbClr val="F4F8FB">
-                        <a:alpha val="100000"/>
+                      <a:srgbClr val="FFFFFF">
+                        <a:alpha val="0"/>
                       </a:srgbClr>
                     </a:solidFill>
                   </a:tcPr>
@@ -11415,8 +11702,8 @@
                       <a:prstDash val="solid"/>
                     </a:lnB>
                     <a:solidFill>
-                      <a:srgbClr val="F4F8FB">
-                        <a:alpha val="100000"/>
+                      <a:srgbClr val="FFFFFF">
+                        <a:alpha val="0"/>
                       </a:srgbClr>
                     </a:solidFill>
                   </a:tcPr>
@@ -11472,8 +11759,8 @@
                       <a:prstDash val="solid"/>
                     </a:lnB>
                     <a:solidFill>
-                      <a:srgbClr val="F4F8FB">
-                        <a:alpha val="100000"/>
+                      <a:srgbClr val="FFFFFF">
+                        <a:alpha val="0"/>
                       </a:srgbClr>
                     </a:solidFill>
                   </a:tcPr>
@@ -11529,8 +11816,8 @@
                       <a:prstDash val="solid"/>
                     </a:lnB>
                     <a:solidFill>
-                      <a:srgbClr val="F4F8FB">
-                        <a:alpha val="100000"/>
+                      <a:srgbClr val="FFFFFF">
+                        <a:alpha val="0"/>
                       </a:srgbClr>
                     </a:solidFill>
                   </a:tcPr>
@@ -11586,8 +11873,8 @@
                       <a:prstDash val="solid"/>
                     </a:lnB>
                     <a:solidFill>
-                      <a:srgbClr val="F4F8FB">
-                        <a:alpha val="100000"/>
+                      <a:srgbClr val="FFFFFF">
+                        <a:alpha val="0"/>
                       </a:srgbClr>
                     </a:solidFill>
                   </a:tcPr>
@@ -11645,8 +11932,8 @@
                       <a:prstDash val="solid"/>
                     </a:lnB>
                     <a:solidFill>
-                      <a:srgbClr val="FFFFFF">
-                        <a:alpha val="0"/>
+                      <a:srgbClr val="F4F8FB">
+                        <a:alpha val="100000"/>
                       </a:srgbClr>
                     </a:solidFill>
                   </a:tcPr>
@@ -11702,8 +11989,8 @@
                       <a:prstDash val="solid"/>
                     </a:lnB>
                     <a:solidFill>
-                      <a:srgbClr val="FFFFFF">
-                        <a:alpha val="0"/>
+                      <a:srgbClr val="F4F8FB">
+                        <a:alpha val="100000"/>
                       </a:srgbClr>
                     </a:solidFill>
                   </a:tcPr>
@@ -11759,8 +12046,8 @@
                       <a:prstDash val="solid"/>
                     </a:lnB>
                     <a:solidFill>
-                      <a:srgbClr val="FFFFFF">
-                        <a:alpha val="0"/>
+                      <a:srgbClr val="F4F8FB">
+                        <a:alpha val="100000"/>
                       </a:srgbClr>
                     </a:solidFill>
                   </a:tcPr>
@@ -11816,8 +12103,8 @@
                       <a:prstDash val="solid"/>
                     </a:lnB>
                     <a:solidFill>
-                      <a:srgbClr val="FFFFFF">
-                        <a:alpha val="0"/>
+                      <a:srgbClr val="F4F8FB">
+                        <a:alpha val="100000"/>
                       </a:srgbClr>
                     </a:solidFill>
                   </a:tcPr>
@@ -11873,8 +12160,8 @@
                       <a:prstDash val="solid"/>
                     </a:lnB>
                     <a:solidFill>
-                      <a:srgbClr val="FFFFFF">
-                        <a:alpha val="0"/>
+                      <a:srgbClr val="F4F8FB">
+                        <a:alpha val="100000"/>
                       </a:srgbClr>
                     </a:solidFill>
                   </a:tcPr>
@@ -11932,8 +12219,8 @@
                       <a:prstDash val="solid"/>
                     </a:lnB>
                     <a:solidFill>
-                      <a:srgbClr val="F4F8FB">
-                        <a:alpha val="100000"/>
+                      <a:srgbClr val="FFFFFF">
+                        <a:alpha val="0"/>
                       </a:srgbClr>
                     </a:solidFill>
                   </a:tcPr>
@@ -11989,8 +12276,8 @@
                       <a:prstDash val="solid"/>
                     </a:lnB>
                     <a:solidFill>
-                      <a:srgbClr val="F4F8FB">
-                        <a:alpha val="100000"/>
+                      <a:srgbClr val="FFFFFF">
+                        <a:alpha val="0"/>
                       </a:srgbClr>
                     </a:solidFill>
                   </a:tcPr>
@@ -12046,8 +12333,8 @@
                       <a:prstDash val="solid"/>
                     </a:lnB>
                     <a:solidFill>
-                      <a:srgbClr val="F4F8FB">
-                        <a:alpha val="100000"/>
+                      <a:srgbClr val="FFFFFF">
+                        <a:alpha val="0"/>
                       </a:srgbClr>
                     </a:solidFill>
                   </a:tcPr>
@@ -12103,8 +12390,8 @@
                       <a:prstDash val="solid"/>
                     </a:lnB>
                     <a:solidFill>
-                      <a:srgbClr val="F4F8FB">
-                        <a:alpha val="100000"/>
+                      <a:srgbClr val="FFFFFF">
+                        <a:alpha val="0"/>
                       </a:srgbClr>
                     </a:solidFill>
                   </a:tcPr>
@@ -12160,8 +12447,8 @@
                       <a:prstDash val="solid"/>
                     </a:lnB>
                     <a:solidFill>
-                      <a:srgbClr val="F4F8FB">
-                        <a:alpha val="100000"/>
+                      <a:srgbClr val="FFFFFF">
+                        <a:alpha val="0"/>
                       </a:srgbClr>
                     </a:solidFill>
                   </a:tcPr>
@@ -12219,8 +12506,8 @@
                       <a:prstDash val="solid"/>
                     </a:lnB>
                     <a:solidFill>
-                      <a:srgbClr val="FFFFFF">
-                        <a:alpha val="0"/>
+                      <a:srgbClr val="F4F8FB">
+                        <a:alpha val="100000"/>
                       </a:srgbClr>
                     </a:solidFill>
                   </a:tcPr>
@@ -12276,8 +12563,8 @@
                       <a:prstDash val="solid"/>
                     </a:lnB>
                     <a:solidFill>
-                      <a:srgbClr val="FFFFFF">
-                        <a:alpha val="0"/>
+                      <a:srgbClr val="F4F8FB">
+                        <a:alpha val="100000"/>
                       </a:srgbClr>
                     </a:solidFill>
                   </a:tcPr>
@@ -12333,8 +12620,8 @@
                       <a:prstDash val="solid"/>
                     </a:lnB>
                     <a:solidFill>
-                      <a:srgbClr val="FFFFFF">
-                        <a:alpha val="0"/>
+                      <a:srgbClr val="F4F8FB">
+                        <a:alpha val="100000"/>
                       </a:srgbClr>
                     </a:solidFill>
                   </a:tcPr>
@@ -12390,8 +12677,8 @@
                       <a:prstDash val="solid"/>
                     </a:lnB>
                     <a:solidFill>
-                      <a:srgbClr val="FFFFFF">
-                        <a:alpha val="0"/>
+                      <a:srgbClr val="F4F8FB">
+                        <a:alpha val="100000"/>
                       </a:srgbClr>
                     </a:solidFill>
                   </a:tcPr>
@@ -12447,8 +12734,8 @@
                       <a:prstDash val="solid"/>
                     </a:lnB>
                     <a:solidFill>
-                      <a:srgbClr val="FFFFFF">
-                        <a:alpha val="0"/>
+                      <a:srgbClr val="F4F8FB">
+                        <a:alpha val="100000"/>
                       </a:srgbClr>
                     </a:solidFill>
                   </a:tcPr>
@@ -12506,8 +12793,8 @@
                       <a:prstDash val="solid"/>
                     </a:lnB>
                     <a:solidFill>
-                      <a:srgbClr val="F4F8FB">
-                        <a:alpha val="100000"/>
+                      <a:srgbClr val="FFFFFF">
+                        <a:alpha val="0"/>
                       </a:srgbClr>
                     </a:solidFill>
                   </a:tcPr>
@@ -12563,8 +12850,8 @@
                       <a:prstDash val="solid"/>
                     </a:lnB>
                     <a:solidFill>
-                      <a:srgbClr val="F4F8FB">
-                        <a:alpha val="100000"/>
+                      <a:srgbClr val="FFFFFF">
+                        <a:alpha val="0"/>
                       </a:srgbClr>
                     </a:solidFill>
                   </a:tcPr>
@@ -12620,8 +12907,8 @@
                       <a:prstDash val="solid"/>
                     </a:lnB>
                     <a:solidFill>
-                      <a:srgbClr val="F4F8FB">
-                        <a:alpha val="100000"/>
+                      <a:srgbClr val="FFFFFF">
+                        <a:alpha val="0"/>
                       </a:srgbClr>
                     </a:solidFill>
                   </a:tcPr>
@@ -12677,8 +12964,8 @@
                       <a:prstDash val="solid"/>
                     </a:lnB>
                     <a:solidFill>
-                      <a:srgbClr val="F4F8FB">
-                        <a:alpha val="100000"/>
+                      <a:srgbClr val="FFFFFF">
+                        <a:alpha val="0"/>
                       </a:srgbClr>
                     </a:solidFill>
                   </a:tcPr>
@@ -12734,8 +13021,8 @@
                       <a:prstDash val="solid"/>
                     </a:lnB>
                     <a:solidFill>
-                      <a:srgbClr val="F4F8FB">
-                        <a:alpha val="100000"/>
+                      <a:srgbClr val="FFFFFF">
+                        <a:alpha val="0"/>
                       </a:srgbClr>
                     </a:solidFill>
                   </a:tcPr>
@@ -12793,8 +13080,8 @@
                       <a:prstDash val="solid"/>
                     </a:lnB>
                     <a:solidFill>
-                      <a:srgbClr val="FFFFFF">
-                        <a:alpha val="0"/>
+                      <a:srgbClr val="F4F8FB">
+                        <a:alpha val="100000"/>
                       </a:srgbClr>
                     </a:solidFill>
                   </a:tcPr>
@@ -12850,8 +13137,8 @@
                       <a:prstDash val="solid"/>
                     </a:lnB>
                     <a:solidFill>
-                      <a:srgbClr val="FFFFFF">
-                        <a:alpha val="0"/>
+                      <a:srgbClr val="F4F8FB">
+                        <a:alpha val="100000"/>
                       </a:srgbClr>
                     </a:solidFill>
                   </a:tcPr>
@@ -12907,8 +13194,8 @@
                       <a:prstDash val="solid"/>
                     </a:lnB>
                     <a:solidFill>
-                      <a:srgbClr val="FFFFFF">
-                        <a:alpha val="0"/>
+                      <a:srgbClr val="F4F8FB">
+                        <a:alpha val="100000"/>
                       </a:srgbClr>
                     </a:solidFill>
                   </a:tcPr>
@@ -12964,8 +13251,8 @@
                       <a:prstDash val="solid"/>
                     </a:lnB>
                     <a:solidFill>
-                      <a:srgbClr val="FFFFFF">
-                        <a:alpha val="0"/>
+                      <a:srgbClr val="F4F8FB">
+                        <a:alpha val="100000"/>
                       </a:srgbClr>
                     </a:solidFill>
                   </a:tcPr>
@@ -13021,8 +13308,8 @@
                       <a:prstDash val="solid"/>
                     </a:lnB>
                     <a:solidFill>
-                      <a:srgbClr val="FFFFFF">
-                        <a:alpha val="0"/>
+                      <a:srgbClr val="F4F8FB">
+                        <a:alpha val="100000"/>
                       </a:srgbClr>
                     </a:solidFill>
                   </a:tcPr>
@@ -13080,8 +13367,8 @@
                       <a:prstDash val="solid"/>
                     </a:lnB>
                     <a:solidFill>
-                      <a:srgbClr val="F4F8FB">
-                        <a:alpha val="100000"/>
+                      <a:srgbClr val="FFFFFF">
+                        <a:alpha val="0"/>
                       </a:srgbClr>
                     </a:solidFill>
                   </a:tcPr>
@@ -13137,8 +13424,8 @@
                       <a:prstDash val="solid"/>
                     </a:lnB>
                     <a:solidFill>
-                      <a:srgbClr val="F4F8FB">
-                        <a:alpha val="100000"/>
+                      <a:srgbClr val="FFFFFF">
+                        <a:alpha val="0"/>
                       </a:srgbClr>
                     </a:solidFill>
                   </a:tcPr>
@@ -13194,8 +13481,8 @@
                       <a:prstDash val="solid"/>
                     </a:lnB>
                     <a:solidFill>
-                      <a:srgbClr val="F4F8FB">
-                        <a:alpha val="100000"/>
+                      <a:srgbClr val="FFFFFF">
+                        <a:alpha val="0"/>
                       </a:srgbClr>
                     </a:solidFill>
                   </a:tcPr>
@@ -13251,8 +13538,8 @@
                       <a:prstDash val="solid"/>
                     </a:lnB>
                     <a:solidFill>
-                      <a:srgbClr val="F4F8FB">
-                        <a:alpha val="100000"/>
+                      <a:srgbClr val="FFFFFF">
+                        <a:alpha val="0"/>
                       </a:srgbClr>
                     </a:solidFill>
                   </a:tcPr>
@@ -13308,8 +13595,8 @@
                       <a:prstDash val="solid"/>
                     </a:lnB>
                     <a:solidFill>
-                      <a:srgbClr val="F4F8FB">
-                        <a:alpha val="100000"/>
+                      <a:srgbClr val="FFFFFF">
+                        <a:alpha val="0"/>
                       </a:srgbClr>
                     </a:solidFill>
                   </a:tcPr>
@@ -13367,8 +13654,8 @@
                       <a:prstDash val="solid"/>
                     </a:lnB>
                     <a:solidFill>
-                      <a:srgbClr val="FFFFFF">
-                        <a:alpha val="0"/>
+                      <a:srgbClr val="F4F8FB">
+                        <a:alpha val="100000"/>
                       </a:srgbClr>
                     </a:solidFill>
                   </a:tcPr>
@@ -13424,8 +13711,8 @@
                       <a:prstDash val="solid"/>
                     </a:lnB>
                     <a:solidFill>
-                      <a:srgbClr val="FFFFFF">
-                        <a:alpha val="0"/>
+                      <a:srgbClr val="F4F8FB">
+                        <a:alpha val="100000"/>
                       </a:srgbClr>
                     </a:solidFill>
                   </a:tcPr>
@@ -13481,8 +13768,8 @@
                       <a:prstDash val="solid"/>
                     </a:lnB>
                     <a:solidFill>
-                      <a:srgbClr val="FFFFFF">
-                        <a:alpha val="0"/>
+                      <a:srgbClr val="F4F8FB">
+                        <a:alpha val="100000"/>
                       </a:srgbClr>
                     </a:solidFill>
                   </a:tcPr>
@@ -13538,8 +13825,8 @@
                       <a:prstDash val="solid"/>
                     </a:lnB>
                     <a:solidFill>
-                      <a:srgbClr val="FFFFFF">
-                        <a:alpha val="0"/>
+                      <a:srgbClr val="F4F8FB">
+                        <a:alpha val="100000"/>
                       </a:srgbClr>
                     </a:solidFill>
                   </a:tcPr>
@@ -13595,8 +13882,8 @@
                       <a:prstDash val="solid"/>
                     </a:lnB>
                     <a:solidFill>
-                      <a:srgbClr val="FFFFFF">
-                        <a:alpha val="0"/>
+                      <a:srgbClr val="F4F8FB">
+                        <a:alpha val="100000"/>
                       </a:srgbClr>
                     </a:solidFill>
                   </a:tcPr>
@@ -13654,8 +13941,8 @@
                       <a:prstDash val="solid"/>
                     </a:lnB>
                     <a:solidFill>
-                      <a:srgbClr val="F4F8FB">
-                        <a:alpha val="100000"/>
+                      <a:srgbClr val="FFFFFF">
+                        <a:alpha val="0"/>
                       </a:srgbClr>
                     </a:solidFill>
                   </a:tcPr>
@@ -13711,8 +13998,8 @@
                       <a:prstDash val="solid"/>
                     </a:lnB>
                     <a:solidFill>
-                      <a:srgbClr val="F4F8FB">
-                        <a:alpha val="100000"/>
+                      <a:srgbClr val="FFFFFF">
+                        <a:alpha val="0"/>
                       </a:srgbClr>
                     </a:solidFill>
                   </a:tcPr>
@@ -13768,8 +14055,8 @@
                       <a:prstDash val="solid"/>
                     </a:lnB>
                     <a:solidFill>
-                      <a:srgbClr val="F4F8FB">
-                        <a:alpha val="100000"/>
+                      <a:srgbClr val="FFFFFF">
+                        <a:alpha val="0"/>
                       </a:srgbClr>
                     </a:solidFill>
                   </a:tcPr>
@@ -13825,8 +14112,8 @@
                       <a:prstDash val="solid"/>
                     </a:lnB>
                     <a:solidFill>
-                      <a:srgbClr val="F4F8FB">
-                        <a:alpha val="100000"/>
+                      <a:srgbClr val="FFFFFF">
+                        <a:alpha val="0"/>
                       </a:srgbClr>
                     </a:solidFill>
                   </a:tcPr>
@@ -13882,14 +14169,14 @@
                       <a:prstDash val="solid"/>
                     </a:lnB>
                     <a:solidFill>
-                      <a:srgbClr val="F4F8FB">
-                        <a:alpha val="100000"/>
+                      <a:srgbClr val="FFFFFF">
+                        <a:alpha val="0"/>
                       </a:srgbClr>
                     </a:solidFill>
                   </a:tcPr>
                 </a:tc>
               </a:tr>
-              <a:tr h="401320">
+              <a:tr h="410845">
                 <a:tc>
                   <a:txBody>
                     <a:bodyPr/>
@@ -13936,13 +14223,17 @@
                       <a:noFill/>
                       <a:prstDash val="solid"/>
                     </a:lnT>
-                    <a:lnB algn="ctr" cmpd="sng" cap="flat" w="0">
-                      <a:noFill/>
+                    <a:lnB algn="ctr" cmpd="sng" cap="flat" w="19050">
+                      <a:solidFill>
+                        <a:srgbClr val="666666">
+                          <a:alpha val="100000"/>
+                        </a:srgbClr>
+                      </a:solidFill>
                       <a:prstDash val="solid"/>
                     </a:lnB>
                     <a:solidFill>
-                      <a:srgbClr val="FFFFFF">
-                        <a:alpha val="0"/>
+                      <a:srgbClr val="F4F8FB">
+                        <a:alpha val="100000"/>
                       </a:srgbClr>
                     </a:solidFill>
                   </a:tcPr>
@@ -13993,13 +14284,17 @@
                       <a:noFill/>
                       <a:prstDash val="solid"/>
                     </a:lnT>
-                    <a:lnB algn="ctr" cmpd="sng" cap="flat" w="0">
-                      <a:noFill/>
+                    <a:lnB algn="ctr" cmpd="sng" cap="flat" w="19050">
+                      <a:solidFill>
+                        <a:srgbClr val="666666">
+                          <a:alpha val="100000"/>
+                        </a:srgbClr>
+                      </a:solidFill>
                       <a:prstDash val="solid"/>
                     </a:lnB>
                     <a:solidFill>
-                      <a:srgbClr val="FFFFFF">
-                        <a:alpha val="0"/>
+                      <a:srgbClr val="F4F8FB">
+                        <a:alpha val="100000"/>
                       </a:srgbClr>
                     </a:solidFill>
                   </a:tcPr>
@@ -14050,13 +14345,17 @@
                       <a:noFill/>
                       <a:prstDash val="solid"/>
                     </a:lnT>
-                    <a:lnB algn="ctr" cmpd="sng" cap="flat" w="0">
-                      <a:noFill/>
+                    <a:lnB algn="ctr" cmpd="sng" cap="flat" w="19050">
+                      <a:solidFill>
+                        <a:srgbClr val="666666">
+                          <a:alpha val="100000"/>
+                        </a:srgbClr>
+                      </a:solidFill>
                       <a:prstDash val="solid"/>
                     </a:lnB>
                     <a:solidFill>
-                      <a:srgbClr val="FFFFFF">
-                        <a:alpha val="0"/>
+                      <a:srgbClr val="F4F8FB">
+                        <a:alpha val="100000"/>
                       </a:srgbClr>
                     </a:solidFill>
                   </a:tcPr>
@@ -14107,122 +14406,6 @@
                       <a:noFill/>
                       <a:prstDash val="solid"/>
                     </a:lnT>
-                    <a:lnB algn="ctr" cmpd="sng" cap="flat" w="0">
-                      <a:noFill/>
-                      <a:prstDash val="solid"/>
-                    </a:lnB>
-                    <a:solidFill>
-                      <a:srgbClr val="FFFFFF">
-                        <a:alpha val="0"/>
-                      </a:srgbClr>
-                    </a:solidFill>
-                  </a:tcPr>
-                </a:tc>
-                <a:tc>
-                  <a:txBody>
-                    <a:bodyPr/>
-                    <a:lstStyle/>
-                    <a:p>
-                      <a:pPr algn="l" marL="63500" marR="63500">
-                        <a:lnSpc>
-                          <a:spcPct val="100000"/>
-                        </a:lnSpc>
-                        <a:spcBef>
-                          <a:spcPts val="500"/>
-                        </a:spcBef>
-                        <a:spcAft>
-                          <a:spcPts val="500"/>
-                        </a:spcAft>
-                        <a:buNone/>
-                      </a:pPr>
-                      <a:r>
-                        <a:rPr cap="none" sz="1200" i="0" b="0" u="none" strike="noStrike">
-                          <a:solidFill>
-                            <a:srgbClr val="5B6770">
-                              <a:alpha val="100000"/>
-                            </a:srgbClr>
-                          </a:solidFill>
-                          <a:latin typeface="Helvetica Neue"/>
-                          <a:cs typeface="Helvetica Neue"/>
-                          <a:ea typeface="Helvetica Neue"/>
-                          <a:sym typeface="Helvetica Neue"/>
-                        </a:rPr>
-                        <a:t>816799</a:t>
-                      </a:r>
-                    </a:p>
-                  </a:txBody>
-                  <a:tcPr anchor="ctr" marB="63500" marT="63500" marR="0" marL="0">
-                    <a:lnL algn="ctr" cmpd="sng" cap="flat" w="0">
-                      <a:noFill/>
-                      <a:prstDash val="solid"/>
-                    </a:lnL>
-                    <a:lnR algn="ctr" cmpd="sng" cap="flat" w="0">
-                      <a:noFill/>
-                      <a:prstDash val="solid"/>
-                    </a:lnR>
-                    <a:lnT algn="ctr" cmpd="sng" cap="flat" w="0">
-                      <a:noFill/>
-                      <a:prstDash val="solid"/>
-                    </a:lnT>
-                    <a:lnB algn="ctr" cmpd="sng" cap="flat" w="0">
-                      <a:noFill/>
-                      <a:prstDash val="solid"/>
-                    </a:lnB>
-                    <a:solidFill>
-                      <a:srgbClr val="FFFFFF">
-                        <a:alpha val="0"/>
-                      </a:srgbClr>
-                    </a:solidFill>
-                  </a:tcPr>
-                </a:tc>
-              </a:tr>
-              <a:tr h="410845">
-                <a:tc>
-                  <a:txBody>
-                    <a:bodyPr/>
-                    <a:lstStyle/>
-                    <a:p>
-                      <a:pPr algn="l" marL="63500" marR="63500">
-                        <a:lnSpc>
-                          <a:spcPct val="100000"/>
-                        </a:lnSpc>
-                        <a:spcBef>
-                          <a:spcPts val="500"/>
-                        </a:spcBef>
-                        <a:spcAft>
-                          <a:spcPts val="500"/>
-                        </a:spcAft>
-                        <a:buNone/>
-                      </a:pPr>
-                      <a:r>
-                        <a:rPr cap="none" sz="1200" i="0" b="0" u="none" strike="noStrike">
-                          <a:solidFill>
-                            <a:srgbClr val="5B6770">
-                              <a:alpha val="100000"/>
-                            </a:srgbClr>
-                          </a:solidFill>
-                          <a:latin typeface="Helvetica Neue"/>
-                          <a:cs typeface="Helvetica Neue"/>
-                          <a:ea typeface="Helvetica Neue"/>
-                          <a:sym typeface="Helvetica Neue"/>
-                        </a:rPr>
-                        <a:t>sucrose octaacetate</a:t>
-                      </a:r>
-                    </a:p>
-                  </a:txBody>
-                  <a:tcPr anchor="ctr" marB="63500" marT="63500" marR="0" marL="0">
-                    <a:lnL algn="ctr" cmpd="sng" cap="flat" w="0">
-                      <a:noFill/>
-                      <a:prstDash val="solid"/>
-                    </a:lnL>
-                    <a:lnR algn="ctr" cmpd="sng" cap="flat" w="0">
-                      <a:noFill/>
-                      <a:prstDash val="solid"/>
-                    </a:lnR>
-                    <a:lnT algn="ctr" cmpd="sng" cap="flat" w="0">
-                      <a:noFill/>
-                      <a:prstDash val="solid"/>
-                    </a:lnT>
                     <a:lnB algn="ctr" cmpd="sng" cap="flat" w="19050">
                       <a:solidFill>
                         <a:srgbClr val="666666">
@@ -14267,190 +14450,7 @@
                           <a:ea typeface="Helvetica Neue"/>
                           <a:sym typeface="Helvetica Neue"/>
                         </a:rPr>
-                        <a:t>30 Jul 2026</a:t>
-                      </a:r>
-                    </a:p>
-                  </a:txBody>
-                  <a:tcPr anchor="ctr" marB="63500" marT="63500" marR="0" marL="0">
-                    <a:lnL algn="ctr" cmpd="sng" cap="flat" w="0">
-                      <a:noFill/>
-                      <a:prstDash val="solid"/>
-                    </a:lnL>
-                    <a:lnR algn="ctr" cmpd="sng" cap="flat" w="0">
-                      <a:noFill/>
-                      <a:prstDash val="solid"/>
-                    </a:lnR>
-                    <a:lnT algn="ctr" cmpd="sng" cap="flat" w="0">
-                      <a:noFill/>
-                      <a:prstDash val="solid"/>
-                    </a:lnT>
-                    <a:lnB algn="ctr" cmpd="sng" cap="flat" w="19050">
-                      <a:solidFill>
-                        <a:srgbClr val="666666">
-                          <a:alpha val="100000"/>
-                        </a:srgbClr>
-                      </a:solidFill>
-                      <a:prstDash val="solid"/>
-                    </a:lnB>
-                    <a:solidFill>
-                      <a:srgbClr val="F4F8FB">
-                        <a:alpha val="100000"/>
-                      </a:srgbClr>
-                    </a:solidFill>
-                  </a:tcPr>
-                </a:tc>
-                <a:tc>
-                  <a:txBody>
-                    <a:bodyPr/>
-                    <a:lstStyle/>
-                    <a:p>
-                      <a:pPr algn="l" marL="63500" marR="63500">
-                        <a:lnSpc>
-                          <a:spcPct val="100000"/>
-                        </a:lnSpc>
-                        <a:spcBef>
-                          <a:spcPts val="500"/>
-                        </a:spcBef>
-                        <a:spcAft>
-                          <a:spcPts val="500"/>
-                        </a:spcAft>
-                        <a:buNone/>
-                      </a:pPr>
-                      <a:r>
-                        <a:rPr cap="none" sz="1200" i="0" b="0" u="none" strike="noStrike">
-                          <a:solidFill>
-                            <a:srgbClr val="5B6770">
-                              <a:alpha val="100000"/>
-                            </a:srgbClr>
-                          </a:solidFill>
-                          <a:latin typeface="Helvetica Neue"/>
-                          <a:cs typeface="Helvetica Neue"/>
-                          <a:ea typeface="Helvetica Neue"/>
-                          <a:sym typeface="Helvetica Neue"/>
-                        </a:rPr>
-                        <a:t>primary</a:t>
-                      </a:r>
-                    </a:p>
-                  </a:txBody>
-                  <a:tcPr anchor="ctr" marB="63500" marT="63500" marR="0" marL="0">
-                    <a:lnL algn="ctr" cmpd="sng" cap="flat" w="0">
-                      <a:noFill/>
-                      <a:prstDash val="solid"/>
-                    </a:lnL>
-                    <a:lnR algn="ctr" cmpd="sng" cap="flat" w="0">
-                      <a:noFill/>
-                      <a:prstDash val="solid"/>
-                    </a:lnR>
-                    <a:lnT algn="ctr" cmpd="sng" cap="flat" w="0">
-                      <a:noFill/>
-                      <a:prstDash val="solid"/>
-                    </a:lnT>
-                    <a:lnB algn="ctr" cmpd="sng" cap="flat" w="19050">
-                      <a:solidFill>
-                        <a:srgbClr val="666666">
-                          <a:alpha val="100000"/>
-                        </a:srgbClr>
-                      </a:solidFill>
-                      <a:prstDash val="solid"/>
-                    </a:lnB>
-                    <a:solidFill>
-                      <a:srgbClr val="F4F8FB">
-                        <a:alpha val="100000"/>
-                      </a:srgbClr>
-                    </a:solidFill>
-                  </a:tcPr>
-                </a:tc>
-                <a:tc>
-                  <a:txBody>
-                    <a:bodyPr/>
-                    <a:lstStyle/>
-                    <a:p>
-                      <a:pPr algn="r" marL="63500" marR="63500">
-                        <a:lnSpc>
-                          <a:spcPct val="100000"/>
-                        </a:lnSpc>
-                        <a:spcBef>
-                          <a:spcPts val="500"/>
-                        </a:spcBef>
-                        <a:spcAft>
-                          <a:spcPts val="500"/>
-                        </a:spcAft>
-                        <a:buNone/>
-                      </a:pPr>
-                      <a:r>
-                        <a:rPr cap="none" sz="1200" i="0" b="0" u="none" strike="noStrike">
-                          <a:solidFill>
-                            <a:srgbClr val="5B6770">
-                              <a:alpha val="100000"/>
-                            </a:srgbClr>
-                          </a:solidFill>
-                          <a:latin typeface="Helvetica Neue"/>
-                          <a:cs typeface="Helvetica Neue"/>
-                          <a:ea typeface="Helvetica Neue"/>
-                          <a:sym typeface="Helvetica Neue"/>
-                        </a:rPr>
-                        <a:t>1</a:t>
-                      </a:r>
-                    </a:p>
-                  </a:txBody>
-                  <a:tcPr anchor="ctr" marB="63500" marT="63500" marR="0" marL="0">
-                    <a:lnL algn="ctr" cmpd="sng" cap="flat" w="0">
-                      <a:noFill/>
-                      <a:prstDash val="solid"/>
-                    </a:lnL>
-                    <a:lnR algn="ctr" cmpd="sng" cap="flat" w="0">
-                      <a:noFill/>
-                      <a:prstDash val="solid"/>
-                    </a:lnR>
-                    <a:lnT algn="ctr" cmpd="sng" cap="flat" w="0">
-                      <a:noFill/>
-                      <a:prstDash val="solid"/>
-                    </a:lnT>
-                    <a:lnB algn="ctr" cmpd="sng" cap="flat" w="19050">
-                      <a:solidFill>
-                        <a:srgbClr val="666666">
-                          <a:alpha val="100000"/>
-                        </a:srgbClr>
-                      </a:solidFill>
-                      <a:prstDash val="solid"/>
-                    </a:lnB>
-                    <a:solidFill>
-                      <a:srgbClr val="F4F8FB">
-                        <a:alpha val="100000"/>
-                      </a:srgbClr>
-                    </a:solidFill>
-                  </a:tcPr>
-                </a:tc>
-                <a:tc>
-                  <a:txBody>
-                    <a:bodyPr/>
-                    <a:lstStyle/>
-                    <a:p>
-                      <a:pPr algn="l" marL="63500" marR="63500">
-                        <a:lnSpc>
-                          <a:spcPct val="100000"/>
-                        </a:lnSpc>
-                        <a:spcBef>
-                          <a:spcPts val="500"/>
-                        </a:spcBef>
-                        <a:spcAft>
-                          <a:spcPts val="500"/>
-                        </a:spcAft>
-                        <a:buNone/>
-                      </a:pPr>
-                      <a:r>
-                        <a:rPr cap="none" sz="1200" i="0" b="0" u="none" strike="noStrike">
-                          <a:solidFill>
-                            <a:srgbClr val="5B6770">
-                              <a:alpha val="100000"/>
-                            </a:srgbClr>
-                          </a:solidFill>
-                          <a:latin typeface="Helvetica Neue"/>
-                          <a:cs typeface="Helvetica Neue"/>
-                          <a:ea typeface="Helvetica Neue"/>
-                          <a:sym typeface="Helvetica Neue"/>
-                        </a:rPr>
-                        <a:t>816795</a:t>
+                        <a:t>816799</a:t>
                       </a:r>
                     </a:p>
                   </a:txBody>
@@ -18626,7 +18626,7 @@
                           <a:ea typeface="Helvetica Neue"/>
                           <a:sym typeface="Helvetica Neue"/>
                         </a:rPr>
-                        <a:t>463</a:t>
+                        <a:t>464</a:t>
                       </a:r>
                     </a:p>
                   </a:txBody>
@@ -19438,7 +19438,7 @@
                           <a:ea typeface="Helvetica Neue"/>
                           <a:sym typeface="Helvetica Neue"/>
                         </a:rPr>
-                        <a:t>66</a:t>
+                        <a:t>67</a:t>
                       </a:r>
                     </a:p>
                   </a:txBody>
@@ -20591,7 +20591,7 @@
                           <a:ea typeface="Helvetica Neue"/>
                           <a:sym typeface="Helvetica Neue"/>
                         </a:rPr>
-                        <a:t>1,832</a:t>
+                        <a:t>1,833</a:t>
                       </a:r>
                     </a:p>
                   </a:txBody>
@@ -20821,7 +20821,7 @@
                           <a:ea typeface="Helvetica Neue"/>
                           <a:sym typeface="Helvetica Neue"/>
                         </a:rPr>
-                        <a:t>544</a:t>
+                        <a:t>546</a:t>
                       </a:r>
                     </a:p>
                   </a:txBody>
@@ -24942,6 +24942,293 @@
                           <a:ea typeface="Helvetica Neue"/>
                           <a:sym typeface="Helvetica Neue"/>
                         </a:rPr>
+                        <a:t>mifepristone</a:t>
+                      </a:r>
+                    </a:p>
+                  </a:txBody>
+                  <a:tcPr anchor="ctr" marB="63500" marT="63500" marR="0" marL="0">
+                    <a:lnL algn="ctr" cmpd="sng" cap="flat" w="0">
+                      <a:noFill/>
+                      <a:prstDash val="solid"/>
+                    </a:lnL>
+                    <a:lnR algn="ctr" cmpd="sng" cap="flat" w="0">
+                      <a:noFill/>
+                      <a:prstDash val="solid"/>
+                    </a:lnR>
+                    <a:lnT algn="ctr" cmpd="sng" cap="flat" w="0">
+                      <a:noFill/>
+                      <a:prstDash val="solid"/>
+                    </a:lnT>
+                    <a:lnB algn="ctr" cmpd="sng" cap="flat" w="0">
+                      <a:noFill/>
+                      <a:prstDash val="solid"/>
+                    </a:lnB>
+                    <a:solidFill>
+                      <a:srgbClr val="FFFFFF">
+                        <a:alpha val="0"/>
+                      </a:srgbClr>
+                    </a:solidFill>
+                  </a:tcPr>
+                </a:tc>
+                <a:tc>
+                  <a:txBody>
+                    <a:bodyPr/>
+                    <a:lstStyle/>
+                    <a:p>
+                      <a:pPr algn="l" marL="63500" marR="63500">
+                        <a:lnSpc>
+                          <a:spcPct val="100000"/>
+                        </a:lnSpc>
+                        <a:spcBef>
+                          <a:spcPts val="500"/>
+                        </a:spcBef>
+                        <a:spcAft>
+                          <a:spcPts val="500"/>
+                        </a:spcAft>
+                        <a:buNone/>
+                      </a:pPr>
+                      <a:r>
+                        <a:rPr cap="none" sz="1200" i="0" b="0" u="none" strike="noStrike">
+                          <a:solidFill>
+                            <a:srgbClr val="5B6770">
+                              <a:alpha val="100000"/>
+                            </a:srgbClr>
+                          </a:solidFill>
+                          <a:latin typeface="Helvetica Neue"/>
+                          <a:cs typeface="Helvetica Neue"/>
+                          <a:ea typeface="Helvetica Neue"/>
+                          <a:sym typeface="Helvetica Neue"/>
+                        </a:rPr>
+                        <a:t>27 Oct 2026</a:t>
+                      </a:r>
+                    </a:p>
+                  </a:txBody>
+                  <a:tcPr anchor="ctr" marB="63500" marT="63500" marR="0" marL="0">
+                    <a:lnL algn="ctr" cmpd="sng" cap="flat" w="0">
+                      <a:noFill/>
+                      <a:prstDash val="solid"/>
+                    </a:lnL>
+                    <a:lnR algn="ctr" cmpd="sng" cap="flat" w="0">
+                      <a:noFill/>
+                      <a:prstDash val="solid"/>
+                    </a:lnR>
+                    <a:lnT algn="ctr" cmpd="sng" cap="flat" w="0">
+                      <a:noFill/>
+                      <a:prstDash val="solid"/>
+                    </a:lnT>
+                    <a:lnB algn="ctr" cmpd="sng" cap="flat" w="0">
+                      <a:noFill/>
+                      <a:prstDash val="solid"/>
+                    </a:lnB>
+                    <a:solidFill>
+                      <a:srgbClr val="FFFFFF">
+                        <a:alpha val="0"/>
+                      </a:srgbClr>
+                    </a:solidFill>
+                  </a:tcPr>
+                </a:tc>
+                <a:tc>
+                  <a:txBody>
+                    <a:bodyPr/>
+                    <a:lstStyle/>
+                    <a:p>
+                      <a:pPr algn="l" marL="63500" marR="63500">
+                        <a:lnSpc>
+                          <a:spcPct val="100000"/>
+                        </a:lnSpc>
+                        <a:spcBef>
+                          <a:spcPts val="500"/>
+                        </a:spcBef>
+                        <a:spcAft>
+                          <a:spcPts val="500"/>
+                        </a:spcAft>
+                        <a:buNone/>
+                      </a:pPr>
+                      <a:r>
+                        <a:rPr cap="none" sz="1200" i="0" b="0" u="none" strike="noStrike">
+                          <a:solidFill>
+                            <a:srgbClr val="5B6770">
+                              <a:alpha val="100000"/>
+                            </a:srgbClr>
+                          </a:solidFill>
+                          <a:latin typeface="Helvetica Neue"/>
+                          <a:cs typeface="Helvetica Neue"/>
+                          <a:ea typeface="Helvetica Neue"/>
+                          <a:sym typeface="Helvetica Neue"/>
+                        </a:rPr>
+                        <a:t>primary</a:t>
+                      </a:r>
+                    </a:p>
+                  </a:txBody>
+                  <a:tcPr anchor="ctr" marB="63500" marT="63500" marR="0" marL="0">
+                    <a:lnL algn="ctr" cmpd="sng" cap="flat" w="0">
+                      <a:noFill/>
+                      <a:prstDash val="solid"/>
+                    </a:lnL>
+                    <a:lnR algn="ctr" cmpd="sng" cap="flat" w="0">
+                      <a:noFill/>
+                      <a:prstDash val="solid"/>
+                    </a:lnR>
+                    <a:lnT algn="ctr" cmpd="sng" cap="flat" w="0">
+                      <a:noFill/>
+                      <a:prstDash val="solid"/>
+                    </a:lnT>
+                    <a:lnB algn="ctr" cmpd="sng" cap="flat" w="0">
+                      <a:noFill/>
+                      <a:prstDash val="solid"/>
+                    </a:lnB>
+                    <a:solidFill>
+                      <a:srgbClr val="FFFFFF">
+                        <a:alpha val="0"/>
+                      </a:srgbClr>
+                    </a:solidFill>
+                  </a:tcPr>
+                </a:tc>
+                <a:tc>
+                  <a:txBody>
+                    <a:bodyPr/>
+                    <a:lstStyle/>
+                    <a:p>
+                      <a:pPr algn="r" marL="63500" marR="63500">
+                        <a:lnSpc>
+                          <a:spcPct val="100000"/>
+                        </a:lnSpc>
+                        <a:spcBef>
+                          <a:spcPts val="500"/>
+                        </a:spcBef>
+                        <a:spcAft>
+                          <a:spcPts val="500"/>
+                        </a:spcAft>
+                        <a:buNone/>
+                      </a:pPr>
+                      <a:r>
+                        <a:rPr cap="none" sz="1200" i="0" b="0" u="none" strike="noStrike">
+                          <a:solidFill>
+                            <a:srgbClr val="5B6770">
+                              <a:alpha val="100000"/>
+                            </a:srgbClr>
+                          </a:solidFill>
+                          <a:latin typeface="Helvetica Neue"/>
+                          <a:cs typeface="Helvetica Neue"/>
+                          <a:ea typeface="Helvetica Neue"/>
+                          <a:sym typeface="Helvetica Neue"/>
+                        </a:rPr>
+                        <a:t>1</a:t>
+                      </a:r>
+                    </a:p>
+                  </a:txBody>
+                  <a:tcPr anchor="ctr" marB="63500" marT="63500" marR="0" marL="0">
+                    <a:lnL algn="ctr" cmpd="sng" cap="flat" w="0">
+                      <a:noFill/>
+                      <a:prstDash val="solid"/>
+                    </a:lnL>
+                    <a:lnR algn="ctr" cmpd="sng" cap="flat" w="0">
+                      <a:noFill/>
+                      <a:prstDash val="solid"/>
+                    </a:lnR>
+                    <a:lnT algn="ctr" cmpd="sng" cap="flat" w="0">
+                      <a:noFill/>
+                      <a:prstDash val="solid"/>
+                    </a:lnT>
+                    <a:lnB algn="ctr" cmpd="sng" cap="flat" w="0">
+                      <a:noFill/>
+                      <a:prstDash val="solid"/>
+                    </a:lnB>
+                    <a:solidFill>
+                      <a:srgbClr val="FFFFFF">
+                        <a:alpha val="0"/>
+                      </a:srgbClr>
+                    </a:solidFill>
+                  </a:tcPr>
+                </a:tc>
+                <a:tc>
+                  <a:txBody>
+                    <a:bodyPr/>
+                    <a:lstStyle/>
+                    <a:p>
+                      <a:pPr algn="l" marL="63500" marR="63500">
+                        <a:lnSpc>
+                          <a:spcPct val="100000"/>
+                        </a:lnSpc>
+                        <a:spcBef>
+                          <a:spcPts val="500"/>
+                        </a:spcBef>
+                        <a:spcAft>
+                          <a:spcPts val="500"/>
+                        </a:spcAft>
+                        <a:buNone/>
+                      </a:pPr>
+                      <a:r>
+                        <a:rPr cap="none" sz="1200" i="0" b="0" u="none" strike="noStrike">
+                          <a:solidFill>
+                            <a:srgbClr val="5B6770">
+                              <a:alpha val="100000"/>
+                            </a:srgbClr>
+                          </a:solidFill>
+                          <a:latin typeface="Helvetica Neue"/>
+                          <a:cs typeface="Helvetica Neue"/>
+                          <a:ea typeface="Helvetica Neue"/>
+                          <a:sym typeface="Helvetica Neue"/>
+                        </a:rPr>
+                        <a:t>821731</a:t>
+                      </a:r>
+                    </a:p>
+                  </a:txBody>
+                  <a:tcPr anchor="ctr" marB="63500" marT="63500" marR="0" marL="0">
+                    <a:lnL algn="ctr" cmpd="sng" cap="flat" w="0">
+                      <a:noFill/>
+                      <a:prstDash val="solid"/>
+                    </a:lnL>
+                    <a:lnR algn="ctr" cmpd="sng" cap="flat" w="0">
+                      <a:noFill/>
+                      <a:prstDash val="solid"/>
+                    </a:lnR>
+                    <a:lnT algn="ctr" cmpd="sng" cap="flat" w="0">
+                      <a:noFill/>
+                      <a:prstDash val="solid"/>
+                    </a:lnT>
+                    <a:lnB algn="ctr" cmpd="sng" cap="flat" w="0">
+                      <a:noFill/>
+                      <a:prstDash val="solid"/>
+                    </a:lnB>
+                    <a:solidFill>
+                      <a:srgbClr val="FFFFFF">
+                        <a:alpha val="0"/>
+                      </a:srgbClr>
+                    </a:solidFill>
+                  </a:tcPr>
+                </a:tc>
+              </a:tr>
+              <a:tr h="401320">
+                <a:tc>
+                  <a:txBody>
+                    <a:bodyPr/>
+                    <a:lstStyle/>
+                    <a:p>
+                      <a:pPr algn="l" marL="63500" marR="63500">
+                        <a:lnSpc>
+                          <a:spcPct val="100000"/>
+                        </a:lnSpc>
+                        <a:spcBef>
+                          <a:spcPts val="500"/>
+                        </a:spcBef>
+                        <a:spcAft>
+                          <a:spcPts val="500"/>
+                        </a:spcAft>
+                        <a:buNone/>
+                      </a:pPr>
+                      <a:r>
+                        <a:rPr cap="none" sz="1200" i="0" b="0" u="none" strike="noStrike">
+                          <a:solidFill>
+                            <a:srgbClr val="5B6770">
+                              <a:alpha val="100000"/>
+                            </a:srgbClr>
+                          </a:solidFill>
+                          <a:latin typeface="Helvetica Neue"/>
+                          <a:cs typeface="Helvetica Neue"/>
+                          <a:ea typeface="Helvetica Neue"/>
+                          <a:sym typeface="Helvetica Neue"/>
+                        </a:rPr>
                         <a:t>psilocybin</a:t>
                       </a:r>
                     </a:p>
@@ -24964,8 +25251,8 @@
                       <a:prstDash val="solid"/>
                     </a:lnB>
                     <a:solidFill>
-                      <a:srgbClr val="FFFFFF">
-                        <a:alpha val="0"/>
+                      <a:srgbClr val="F4F8FB">
+                        <a:alpha val="100000"/>
                       </a:srgbClr>
                     </a:solidFill>
                   </a:tcPr>
@@ -25021,8 +25308,8 @@
                       <a:prstDash val="solid"/>
                     </a:lnB>
                     <a:solidFill>
-                      <a:srgbClr val="FFFFFF">
-                        <a:alpha val="0"/>
+                      <a:srgbClr val="F4F8FB">
+                        <a:alpha val="100000"/>
                       </a:srgbClr>
                     </a:solidFill>
                   </a:tcPr>
@@ -25078,8 +25365,8 @@
                       <a:prstDash val="solid"/>
                     </a:lnB>
                     <a:solidFill>
-                      <a:srgbClr val="FFFFFF">
-                        <a:alpha val="0"/>
+                      <a:srgbClr val="F4F8FB">
+                        <a:alpha val="100000"/>
                       </a:srgbClr>
                     </a:solidFill>
                   </a:tcPr>
@@ -25135,8 +25422,8 @@
                       <a:prstDash val="solid"/>
                     </a:lnB>
                     <a:solidFill>
-                      <a:srgbClr val="FFFFFF">
-                        <a:alpha val="0"/>
+                      <a:srgbClr val="F4F8FB">
+                        <a:alpha val="100000"/>
                       </a:srgbClr>
                     </a:solidFill>
                   </a:tcPr>
@@ -25192,8 +25479,8 @@
                       <a:prstDash val="solid"/>
                     </a:lnB>
                     <a:solidFill>
-                      <a:srgbClr val="FFFFFF">
-                        <a:alpha val="0"/>
+                      <a:srgbClr val="F4F8FB">
+                        <a:alpha val="100000"/>
                       </a:srgbClr>
                     </a:solidFill>
                   </a:tcPr>
@@ -25251,8 +25538,8 @@
                       <a:prstDash val="solid"/>
                     </a:lnB>
                     <a:solidFill>
-                      <a:srgbClr val="F4F8FB">
-                        <a:alpha val="100000"/>
+                      <a:srgbClr val="FFFFFF">
+                        <a:alpha val="0"/>
                       </a:srgbClr>
                     </a:solidFill>
                   </a:tcPr>
@@ -25308,8 +25595,8 @@
                       <a:prstDash val="solid"/>
                     </a:lnB>
                     <a:solidFill>
-                      <a:srgbClr val="F4F8FB">
-                        <a:alpha val="100000"/>
+                      <a:srgbClr val="FFFFFF">
+                        <a:alpha val="0"/>
                       </a:srgbClr>
                     </a:solidFill>
                   </a:tcPr>
@@ -25365,8 +25652,8 @@
                       <a:prstDash val="solid"/>
                     </a:lnB>
                     <a:solidFill>
-                      <a:srgbClr val="F4F8FB">
-                        <a:alpha val="100000"/>
+                      <a:srgbClr val="FFFFFF">
+                        <a:alpha val="0"/>
                       </a:srgbClr>
                     </a:solidFill>
                   </a:tcPr>
@@ -25422,8 +25709,8 @@
                       <a:prstDash val="solid"/>
                     </a:lnB>
                     <a:solidFill>
-                      <a:srgbClr val="F4F8FB">
-                        <a:alpha val="100000"/>
+                      <a:srgbClr val="FFFFFF">
+                        <a:alpha val="0"/>
                       </a:srgbClr>
                     </a:solidFill>
                   </a:tcPr>
@@ -25479,8 +25766,8 @@
                       <a:prstDash val="solid"/>
                     </a:lnB>
                     <a:solidFill>
-                      <a:srgbClr val="F4F8FB">
-                        <a:alpha val="100000"/>
+                      <a:srgbClr val="FFFFFF">
+                        <a:alpha val="0"/>
                       </a:srgbClr>
                     </a:solidFill>
                   </a:tcPr>
@@ -25538,8 +25825,8 @@
                       <a:prstDash val="solid"/>
                     </a:lnB>
                     <a:solidFill>
-                      <a:srgbClr val="FFFFFF">
-                        <a:alpha val="0"/>
+                      <a:srgbClr val="F4F8FB">
+                        <a:alpha val="100000"/>
                       </a:srgbClr>
                     </a:solidFill>
                   </a:tcPr>
@@ -25595,8 +25882,8 @@
                       <a:prstDash val="solid"/>
                     </a:lnB>
                     <a:solidFill>
-                      <a:srgbClr val="FFFFFF">
-                        <a:alpha val="0"/>
+                      <a:srgbClr val="F4F8FB">
+                        <a:alpha val="100000"/>
                       </a:srgbClr>
                     </a:solidFill>
                   </a:tcPr>
@@ -25652,8 +25939,8 @@
                       <a:prstDash val="solid"/>
                     </a:lnB>
                     <a:solidFill>
-                      <a:srgbClr val="FFFFFF">
-                        <a:alpha val="0"/>
+                      <a:srgbClr val="F4F8FB">
+                        <a:alpha val="100000"/>
                       </a:srgbClr>
                     </a:solidFill>
                   </a:tcPr>
@@ -25709,8 +25996,8 @@
                       <a:prstDash val="solid"/>
                     </a:lnB>
                     <a:solidFill>
-                      <a:srgbClr val="FFFFFF">
-                        <a:alpha val="0"/>
+                      <a:srgbClr val="F4F8FB">
+                        <a:alpha val="100000"/>
                       </a:srgbClr>
                     </a:solidFill>
                   </a:tcPr>
@@ -25766,8 +26053,8 @@
                       <a:prstDash val="solid"/>
                     </a:lnB>
                     <a:solidFill>
-                      <a:srgbClr val="FFFFFF">
-                        <a:alpha val="0"/>
+                      <a:srgbClr val="F4F8FB">
+                        <a:alpha val="100000"/>
                       </a:srgbClr>
                     </a:solidFill>
                   </a:tcPr>
@@ -25825,8 +26112,8 @@
                       <a:prstDash val="solid"/>
                     </a:lnB>
                     <a:solidFill>
-                      <a:srgbClr val="F4F8FB">
-                        <a:alpha val="100000"/>
+                      <a:srgbClr val="FFFFFF">
+                        <a:alpha val="0"/>
                       </a:srgbClr>
                     </a:solidFill>
                   </a:tcPr>
@@ -25882,8 +26169,8 @@
                       <a:prstDash val="solid"/>
                     </a:lnB>
                     <a:solidFill>
-                      <a:srgbClr val="F4F8FB">
-                        <a:alpha val="100000"/>
+                      <a:srgbClr val="FFFFFF">
+                        <a:alpha val="0"/>
                       </a:srgbClr>
                     </a:solidFill>
                   </a:tcPr>
@@ -25939,8 +26226,8 @@
                       <a:prstDash val="solid"/>
                     </a:lnB>
                     <a:solidFill>
-                      <a:srgbClr val="F4F8FB">
-                        <a:alpha val="100000"/>
+                      <a:srgbClr val="FFFFFF">
+                        <a:alpha val="0"/>
                       </a:srgbClr>
                     </a:solidFill>
                   </a:tcPr>
@@ -25996,8 +26283,8 @@
                       <a:prstDash val="solid"/>
                     </a:lnB>
                     <a:solidFill>
-                      <a:srgbClr val="F4F8FB">
-                        <a:alpha val="100000"/>
+                      <a:srgbClr val="FFFFFF">
+                        <a:alpha val="0"/>
                       </a:srgbClr>
                     </a:solidFill>
                   </a:tcPr>
@@ -26053,8 +26340,8 @@
                       <a:prstDash val="solid"/>
                     </a:lnB>
                     <a:solidFill>
-                      <a:srgbClr val="F4F8FB">
-                        <a:alpha val="100000"/>
+                      <a:srgbClr val="FFFFFF">
+                        <a:alpha val="0"/>
                       </a:srgbClr>
                     </a:solidFill>
                   </a:tcPr>
@@ -26112,8 +26399,8 @@
                       <a:prstDash val="solid"/>
                     </a:lnB>
                     <a:solidFill>
-                      <a:srgbClr val="FFFFFF">
-                        <a:alpha val="0"/>
+                      <a:srgbClr val="F4F8FB">
+                        <a:alpha val="100000"/>
                       </a:srgbClr>
                     </a:solidFill>
                   </a:tcPr>
@@ -26169,8 +26456,8 @@
                       <a:prstDash val="solid"/>
                     </a:lnB>
                     <a:solidFill>
-                      <a:srgbClr val="FFFFFF">
-                        <a:alpha val="0"/>
+                      <a:srgbClr val="F4F8FB">
+                        <a:alpha val="100000"/>
                       </a:srgbClr>
                     </a:solidFill>
                   </a:tcPr>
@@ -26226,8 +26513,8 @@
                       <a:prstDash val="solid"/>
                     </a:lnB>
                     <a:solidFill>
-                      <a:srgbClr val="FFFFFF">
-                        <a:alpha val="0"/>
+                      <a:srgbClr val="F4F8FB">
+                        <a:alpha val="100000"/>
                       </a:srgbClr>
                     </a:solidFill>
                   </a:tcPr>
@@ -26283,8 +26570,8 @@
                       <a:prstDash val="solid"/>
                     </a:lnB>
                     <a:solidFill>
-                      <a:srgbClr val="FFFFFF">
-                        <a:alpha val="0"/>
+                      <a:srgbClr val="F4F8FB">
+                        <a:alpha val="100000"/>
                       </a:srgbClr>
                     </a:solidFill>
                   </a:tcPr>
@@ -26340,8 +26627,8 @@
                       <a:prstDash val="solid"/>
                     </a:lnB>
                     <a:solidFill>
-                      <a:srgbClr val="FFFFFF">
-                        <a:alpha val="0"/>
+                      <a:srgbClr val="F4F8FB">
+                        <a:alpha val="100000"/>
                       </a:srgbClr>
                     </a:solidFill>
                   </a:tcPr>
@@ -26399,8 +26686,8 @@
                       <a:prstDash val="solid"/>
                     </a:lnB>
                     <a:solidFill>
-                      <a:srgbClr val="F4F8FB">
-                        <a:alpha val="100000"/>
+                      <a:srgbClr val="FFFFFF">
+                        <a:alpha val="0"/>
                       </a:srgbClr>
                     </a:solidFill>
                   </a:tcPr>
@@ -26456,8 +26743,8 @@
                       <a:prstDash val="solid"/>
                     </a:lnB>
                     <a:solidFill>
-                      <a:srgbClr val="F4F8FB">
-                        <a:alpha val="100000"/>
+                      <a:srgbClr val="FFFFFF">
+                        <a:alpha val="0"/>
                       </a:srgbClr>
                     </a:solidFill>
                   </a:tcPr>
@@ -26513,8 +26800,8 @@
                       <a:prstDash val="solid"/>
                     </a:lnB>
                     <a:solidFill>
-                      <a:srgbClr val="F4F8FB">
-                        <a:alpha val="100000"/>
+                      <a:srgbClr val="FFFFFF">
+                        <a:alpha val="0"/>
                       </a:srgbClr>
                     </a:solidFill>
                   </a:tcPr>
@@ -26570,8 +26857,8 @@
                       <a:prstDash val="solid"/>
                     </a:lnB>
                     <a:solidFill>
-                      <a:srgbClr val="F4F8FB">
-                        <a:alpha val="100000"/>
+                      <a:srgbClr val="FFFFFF">
+                        <a:alpha val="0"/>
                       </a:srgbClr>
                     </a:solidFill>
                   </a:tcPr>
@@ -26627,8 +26914,8 @@
                       <a:prstDash val="solid"/>
                     </a:lnB>
                     <a:solidFill>
-                      <a:srgbClr val="F4F8FB">
-                        <a:alpha val="100000"/>
+                      <a:srgbClr val="FFFFFF">
+                        <a:alpha val="0"/>
                       </a:srgbClr>
                     </a:solidFill>
                   </a:tcPr>
@@ -26686,8 +26973,8 @@
                       <a:prstDash val="solid"/>
                     </a:lnB>
                     <a:solidFill>
-                      <a:srgbClr val="FFFFFF">
-                        <a:alpha val="0"/>
+                      <a:srgbClr val="F4F8FB">
+                        <a:alpha val="100000"/>
                       </a:srgbClr>
                     </a:solidFill>
                   </a:tcPr>
@@ -26743,8 +27030,8 @@
                       <a:prstDash val="solid"/>
                     </a:lnB>
                     <a:solidFill>
-                      <a:srgbClr val="FFFFFF">
-                        <a:alpha val="0"/>
+                      <a:srgbClr val="F4F8FB">
+                        <a:alpha val="100000"/>
                       </a:srgbClr>
                     </a:solidFill>
                   </a:tcPr>
@@ -26800,8 +27087,8 @@
                       <a:prstDash val="solid"/>
                     </a:lnB>
                     <a:solidFill>
-                      <a:srgbClr val="FFFFFF">
-                        <a:alpha val="0"/>
+                      <a:srgbClr val="F4F8FB">
+                        <a:alpha val="100000"/>
                       </a:srgbClr>
                     </a:solidFill>
                   </a:tcPr>
@@ -26857,8 +27144,8 @@
                       <a:prstDash val="solid"/>
                     </a:lnB>
                     <a:solidFill>
-                      <a:srgbClr val="FFFFFF">
-                        <a:alpha val="0"/>
+                      <a:srgbClr val="F4F8FB">
+                        <a:alpha val="100000"/>
                       </a:srgbClr>
                     </a:solidFill>
                   </a:tcPr>
@@ -26914,8 +27201,8 @@
                       <a:prstDash val="solid"/>
                     </a:lnB>
                     <a:solidFill>
-                      <a:srgbClr val="FFFFFF">
-                        <a:alpha val="0"/>
+                      <a:srgbClr val="F4F8FB">
+                        <a:alpha val="100000"/>
                       </a:srgbClr>
                     </a:solidFill>
                   </a:tcPr>
@@ -26973,8 +27260,8 @@
                       <a:prstDash val="solid"/>
                     </a:lnB>
                     <a:solidFill>
-                      <a:srgbClr val="F4F8FB">
-                        <a:alpha val="100000"/>
+                      <a:srgbClr val="FFFFFF">
+                        <a:alpha val="0"/>
                       </a:srgbClr>
                     </a:solidFill>
                   </a:tcPr>
@@ -27030,8 +27317,8 @@
                       <a:prstDash val="solid"/>
                     </a:lnB>
                     <a:solidFill>
-                      <a:srgbClr val="F4F8FB">
-                        <a:alpha val="100000"/>
+                      <a:srgbClr val="FFFFFF">
+                        <a:alpha val="0"/>
                       </a:srgbClr>
                     </a:solidFill>
                   </a:tcPr>
@@ -27087,8 +27374,8 @@
                       <a:prstDash val="solid"/>
                     </a:lnB>
                     <a:solidFill>
-                      <a:srgbClr val="F4F8FB">
-                        <a:alpha val="100000"/>
+                      <a:srgbClr val="FFFFFF">
+                        <a:alpha val="0"/>
                       </a:srgbClr>
                     </a:solidFill>
                   </a:tcPr>
@@ -27144,8 +27431,8 @@
                       <a:prstDash val="solid"/>
                     </a:lnB>
                     <a:solidFill>
-                      <a:srgbClr val="F4F8FB">
-                        <a:alpha val="100000"/>
+                      <a:srgbClr val="FFFFFF">
+                        <a:alpha val="0"/>
                       </a:srgbClr>
                     </a:solidFill>
                   </a:tcPr>
@@ -27201,8 +27488,8 @@
                       <a:prstDash val="solid"/>
                     </a:lnB>
                     <a:solidFill>
-                      <a:srgbClr val="F4F8FB">
-                        <a:alpha val="100000"/>
+                      <a:srgbClr val="FFFFFF">
+                        <a:alpha val="0"/>
                       </a:srgbClr>
                     </a:solidFill>
                   </a:tcPr>
@@ -27260,8 +27547,8 @@
                       <a:prstDash val="solid"/>
                     </a:lnB>
                     <a:solidFill>
-                      <a:srgbClr val="FFFFFF">
-                        <a:alpha val="0"/>
+                      <a:srgbClr val="F4F8FB">
+                        <a:alpha val="100000"/>
                       </a:srgbClr>
                     </a:solidFill>
                   </a:tcPr>
@@ -27317,8 +27604,8 @@
                       <a:prstDash val="solid"/>
                     </a:lnB>
                     <a:solidFill>
-                      <a:srgbClr val="FFFFFF">
-                        <a:alpha val="0"/>
+                      <a:srgbClr val="F4F8FB">
+                        <a:alpha val="100000"/>
                       </a:srgbClr>
                     </a:solidFill>
                   </a:tcPr>
@@ -27374,8 +27661,8 @@
                       <a:prstDash val="solid"/>
                     </a:lnB>
                     <a:solidFill>
-                      <a:srgbClr val="FFFFFF">
-                        <a:alpha val="0"/>
+                      <a:srgbClr val="F4F8FB">
+                        <a:alpha val="100000"/>
                       </a:srgbClr>
                     </a:solidFill>
                   </a:tcPr>
@@ -27431,8 +27718,8 @@
                       <a:prstDash val="solid"/>
                     </a:lnB>
                     <a:solidFill>
-                      <a:srgbClr val="FFFFFF">
-                        <a:alpha val="0"/>
+                      <a:srgbClr val="F4F8FB">
+                        <a:alpha val="100000"/>
                       </a:srgbClr>
                     </a:solidFill>
                   </a:tcPr>
@@ -27488,8 +27775,8 @@
                       <a:prstDash val="solid"/>
                     </a:lnB>
                     <a:solidFill>
-                      <a:srgbClr val="FFFFFF">
-                        <a:alpha val="0"/>
+                      <a:srgbClr val="F4F8FB">
+                        <a:alpha val="100000"/>
                       </a:srgbClr>
                     </a:solidFill>
                   </a:tcPr>
@@ -27547,8 +27834,8 @@
                       <a:prstDash val="solid"/>
                     </a:lnB>
                     <a:solidFill>
-                      <a:srgbClr val="F4F8FB">
-                        <a:alpha val="100000"/>
+                      <a:srgbClr val="FFFFFF">
+                        <a:alpha val="0"/>
                       </a:srgbClr>
                     </a:solidFill>
                   </a:tcPr>
@@ -27604,8 +27891,8 @@
                       <a:prstDash val="solid"/>
                     </a:lnB>
                     <a:solidFill>
-                      <a:srgbClr val="F4F8FB">
-                        <a:alpha val="100000"/>
+                      <a:srgbClr val="FFFFFF">
+                        <a:alpha val="0"/>
                       </a:srgbClr>
                     </a:solidFill>
                   </a:tcPr>
@@ -27661,8 +27948,8 @@
                       <a:prstDash val="solid"/>
                     </a:lnB>
                     <a:solidFill>
-                      <a:srgbClr val="F4F8FB">
-                        <a:alpha val="100000"/>
+                      <a:srgbClr val="FFFFFF">
+                        <a:alpha val="0"/>
                       </a:srgbClr>
                     </a:solidFill>
                   </a:tcPr>
@@ -27718,8 +28005,8 @@
                       <a:prstDash val="solid"/>
                     </a:lnB>
                     <a:solidFill>
-                      <a:srgbClr val="F4F8FB">
-                        <a:alpha val="100000"/>
+                      <a:srgbClr val="FFFFFF">
+                        <a:alpha val="0"/>
                       </a:srgbClr>
                     </a:solidFill>
                   </a:tcPr>
@@ -27775,14 +28062,14 @@
                       <a:prstDash val="solid"/>
                     </a:lnB>
                     <a:solidFill>
-                      <a:srgbClr val="F4F8FB">
-                        <a:alpha val="100000"/>
+                      <a:srgbClr val="FFFFFF">
+                        <a:alpha val="0"/>
                       </a:srgbClr>
                     </a:solidFill>
                   </a:tcPr>
                 </a:tc>
               </a:tr>
-              <a:tr h="401320">
+              <a:tr h="410845">
                 <a:tc>
                   <a:txBody>
                     <a:bodyPr/>
@@ -27829,13 +28116,17 @@
                       <a:noFill/>
                       <a:prstDash val="solid"/>
                     </a:lnT>
-                    <a:lnB algn="ctr" cmpd="sng" cap="flat" w="0">
-                      <a:noFill/>
+                    <a:lnB algn="ctr" cmpd="sng" cap="flat" w="19050">
+                      <a:solidFill>
+                        <a:srgbClr val="666666">
+                          <a:alpha val="100000"/>
+                        </a:srgbClr>
+                      </a:solidFill>
                       <a:prstDash val="solid"/>
                     </a:lnB>
                     <a:solidFill>
-                      <a:srgbClr val="FFFFFF">
-                        <a:alpha val="0"/>
+                      <a:srgbClr val="F4F8FB">
+                        <a:alpha val="100000"/>
                       </a:srgbClr>
                     </a:solidFill>
                   </a:tcPr>
@@ -27886,13 +28177,17 @@
                       <a:noFill/>
                       <a:prstDash val="solid"/>
                     </a:lnT>
-                    <a:lnB algn="ctr" cmpd="sng" cap="flat" w="0">
-                      <a:noFill/>
+                    <a:lnB algn="ctr" cmpd="sng" cap="flat" w="19050">
+                      <a:solidFill>
+                        <a:srgbClr val="666666">
+                          <a:alpha val="100000"/>
+                        </a:srgbClr>
+                      </a:solidFill>
                       <a:prstDash val="solid"/>
                     </a:lnB>
                     <a:solidFill>
-                      <a:srgbClr val="FFFFFF">
-                        <a:alpha val="0"/>
+                      <a:srgbClr val="F4F8FB">
+                        <a:alpha val="100000"/>
                       </a:srgbClr>
                     </a:solidFill>
                   </a:tcPr>
@@ -27943,13 +28238,17 @@
                       <a:noFill/>
                       <a:prstDash val="solid"/>
                     </a:lnT>
-                    <a:lnB algn="ctr" cmpd="sng" cap="flat" w="0">
-                      <a:noFill/>
+                    <a:lnB algn="ctr" cmpd="sng" cap="flat" w="19050">
+                      <a:solidFill>
+                        <a:srgbClr val="666666">
+                          <a:alpha val="100000"/>
+                        </a:srgbClr>
+                      </a:solidFill>
                       <a:prstDash val="solid"/>
                     </a:lnB>
                     <a:solidFill>
-                      <a:srgbClr val="FFFFFF">
-                        <a:alpha val="0"/>
+                      <a:srgbClr val="F4F8FB">
+                        <a:alpha val="100000"/>
                       </a:srgbClr>
                     </a:solidFill>
                   </a:tcPr>
@@ -28000,122 +28299,6 @@
                       <a:noFill/>
                       <a:prstDash val="solid"/>
                     </a:lnT>
-                    <a:lnB algn="ctr" cmpd="sng" cap="flat" w="0">
-                      <a:noFill/>
-                      <a:prstDash val="solid"/>
-                    </a:lnB>
-                    <a:solidFill>
-                      <a:srgbClr val="FFFFFF">
-                        <a:alpha val="0"/>
-                      </a:srgbClr>
-                    </a:solidFill>
-                  </a:tcPr>
-                </a:tc>
-                <a:tc>
-                  <a:txBody>
-                    <a:bodyPr/>
-                    <a:lstStyle/>
-                    <a:p>
-                      <a:pPr algn="l" marL="63500" marR="63500">
-                        <a:lnSpc>
-                          <a:spcPct val="100000"/>
-                        </a:lnSpc>
-                        <a:spcBef>
-                          <a:spcPts val="500"/>
-                        </a:spcBef>
-                        <a:spcAft>
-                          <a:spcPts val="500"/>
-                        </a:spcAft>
-                        <a:buNone/>
-                      </a:pPr>
-                      <a:r>
-                        <a:rPr cap="none" sz="1200" i="0" b="0" u="none" strike="noStrike">
-                          <a:solidFill>
-                            <a:srgbClr val="5B6770">
-                              <a:alpha val="100000"/>
-                            </a:srgbClr>
-                          </a:solidFill>
-                          <a:latin typeface="Helvetica Neue"/>
-                          <a:cs typeface="Helvetica Neue"/>
-                          <a:ea typeface="Helvetica Neue"/>
-                          <a:sym typeface="Helvetica Neue"/>
-                        </a:rPr>
-                        <a:t>816799</a:t>
-                      </a:r>
-                    </a:p>
-                  </a:txBody>
-                  <a:tcPr anchor="ctr" marB="63500" marT="63500" marR="0" marL="0">
-                    <a:lnL algn="ctr" cmpd="sng" cap="flat" w="0">
-                      <a:noFill/>
-                      <a:prstDash val="solid"/>
-                    </a:lnL>
-                    <a:lnR algn="ctr" cmpd="sng" cap="flat" w="0">
-                      <a:noFill/>
-                      <a:prstDash val="solid"/>
-                    </a:lnR>
-                    <a:lnT algn="ctr" cmpd="sng" cap="flat" w="0">
-                      <a:noFill/>
-                      <a:prstDash val="solid"/>
-                    </a:lnT>
-                    <a:lnB algn="ctr" cmpd="sng" cap="flat" w="0">
-                      <a:noFill/>
-                      <a:prstDash val="solid"/>
-                    </a:lnB>
-                    <a:solidFill>
-                      <a:srgbClr val="FFFFFF">
-                        <a:alpha val="0"/>
-                      </a:srgbClr>
-                    </a:solidFill>
-                  </a:tcPr>
-                </a:tc>
-              </a:tr>
-              <a:tr h="410845">
-                <a:tc>
-                  <a:txBody>
-                    <a:bodyPr/>
-                    <a:lstStyle/>
-                    <a:p>
-                      <a:pPr algn="l" marL="63500" marR="63500">
-                        <a:lnSpc>
-                          <a:spcPct val="100000"/>
-                        </a:lnSpc>
-                        <a:spcBef>
-                          <a:spcPts val="500"/>
-                        </a:spcBef>
-                        <a:spcAft>
-                          <a:spcPts val="500"/>
-                        </a:spcAft>
-                        <a:buNone/>
-                      </a:pPr>
-                      <a:r>
-                        <a:rPr cap="none" sz="1200" i="0" b="0" u="none" strike="noStrike">
-                          <a:solidFill>
-                            <a:srgbClr val="5B6770">
-                              <a:alpha val="100000"/>
-                            </a:srgbClr>
-                          </a:solidFill>
-                          <a:latin typeface="Helvetica Neue"/>
-                          <a:cs typeface="Helvetica Neue"/>
-                          <a:ea typeface="Helvetica Neue"/>
-                          <a:sym typeface="Helvetica Neue"/>
-                        </a:rPr>
-                        <a:t>sucrose octaacetate</a:t>
-                      </a:r>
-                    </a:p>
-                  </a:txBody>
-                  <a:tcPr anchor="ctr" marB="63500" marT="63500" marR="0" marL="0">
-                    <a:lnL algn="ctr" cmpd="sng" cap="flat" w="0">
-                      <a:noFill/>
-                      <a:prstDash val="solid"/>
-                    </a:lnL>
-                    <a:lnR algn="ctr" cmpd="sng" cap="flat" w="0">
-                      <a:noFill/>
-                      <a:prstDash val="solid"/>
-                    </a:lnR>
-                    <a:lnT algn="ctr" cmpd="sng" cap="flat" w="0">
-                      <a:noFill/>
-                      <a:prstDash val="solid"/>
-                    </a:lnT>
                     <a:lnB algn="ctr" cmpd="sng" cap="flat" w="19050">
                       <a:solidFill>
                         <a:srgbClr val="666666">
@@ -28160,190 +28343,7 @@
                           <a:ea typeface="Helvetica Neue"/>
                           <a:sym typeface="Helvetica Neue"/>
                         </a:rPr>
-                        <a:t>30 Jul 2026</a:t>
-                      </a:r>
-                    </a:p>
-                  </a:txBody>
-                  <a:tcPr anchor="ctr" marB="63500" marT="63500" marR="0" marL="0">
-                    <a:lnL algn="ctr" cmpd="sng" cap="flat" w="0">
-                      <a:noFill/>
-                      <a:prstDash val="solid"/>
-                    </a:lnL>
-                    <a:lnR algn="ctr" cmpd="sng" cap="flat" w="0">
-                      <a:noFill/>
-                      <a:prstDash val="solid"/>
-                    </a:lnR>
-                    <a:lnT algn="ctr" cmpd="sng" cap="flat" w="0">
-                      <a:noFill/>
-                      <a:prstDash val="solid"/>
-                    </a:lnT>
-                    <a:lnB algn="ctr" cmpd="sng" cap="flat" w="19050">
-                      <a:solidFill>
-                        <a:srgbClr val="666666">
-                          <a:alpha val="100000"/>
-                        </a:srgbClr>
-                      </a:solidFill>
-                      <a:prstDash val="solid"/>
-                    </a:lnB>
-                    <a:solidFill>
-                      <a:srgbClr val="F4F8FB">
-                        <a:alpha val="100000"/>
-                      </a:srgbClr>
-                    </a:solidFill>
-                  </a:tcPr>
-                </a:tc>
-                <a:tc>
-                  <a:txBody>
-                    <a:bodyPr/>
-                    <a:lstStyle/>
-                    <a:p>
-                      <a:pPr algn="l" marL="63500" marR="63500">
-                        <a:lnSpc>
-                          <a:spcPct val="100000"/>
-                        </a:lnSpc>
-                        <a:spcBef>
-                          <a:spcPts val="500"/>
-                        </a:spcBef>
-                        <a:spcAft>
-                          <a:spcPts val="500"/>
-                        </a:spcAft>
-                        <a:buNone/>
-                      </a:pPr>
-                      <a:r>
-                        <a:rPr cap="none" sz="1200" i="0" b="0" u="none" strike="noStrike">
-                          <a:solidFill>
-                            <a:srgbClr val="5B6770">
-                              <a:alpha val="100000"/>
-                            </a:srgbClr>
-                          </a:solidFill>
-                          <a:latin typeface="Helvetica Neue"/>
-                          <a:cs typeface="Helvetica Neue"/>
-                          <a:ea typeface="Helvetica Neue"/>
-                          <a:sym typeface="Helvetica Neue"/>
-                        </a:rPr>
-                        <a:t>primary</a:t>
-                      </a:r>
-                    </a:p>
-                  </a:txBody>
-                  <a:tcPr anchor="ctr" marB="63500" marT="63500" marR="0" marL="0">
-                    <a:lnL algn="ctr" cmpd="sng" cap="flat" w="0">
-                      <a:noFill/>
-                      <a:prstDash val="solid"/>
-                    </a:lnL>
-                    <a:lnR algn="ctr" cmpd="sng" cap="flat" w="0">
-                      <a:noFill/>
-                      <a:prstDash val="solid"/>
-                    </a:lnR>
-                    <a:lnT algn="ctr" cmpd="sng" cap="flat" w="0">
-                      <a:noFill/>
-                      <a:prstDash val="solid"/>
-                    </a:lnT>
-                    <a:lnB algn="ctr" cmpd="sng" cap="flat" w="19050">
-                      <a:solidFill>
-                        <a:srgbClr val="666666">
-                          <a:alpha val="100000"/>
-                        </a:srgbClr>
-                      </a:solidFill>
-                      <a:prstDash val="solid"/>
-                    </a:lnB>
-                    <a:solidFill>
-                      <a:srgbClr val="F4F8FB">
-                        <a:alpha val="100000"/>
-                      </a:srgbClr>
-                    </a:solidFill>
-                  </a:tcPr>
-                </a:tc>
-                <a:tc>
-                  <a:txBody>
-                    <a:bodyPr/>
-                    <a:lstStyle/>
-                    <a:p>
-                      <a:pPr algn="r" marL="63500" marR="63500">
-                        <a:lnSpc>
-                          <a:spcPct val="100000"/>
-                        </a:lnSpc>
-                        <a:spcBef>
-                          <a:spcPts val="500"/>
-                        </a:spcBef>
-                        <a:spcAft>
-                          <a:spcPts val="500"/>
-                        </a:spcAft>
-                        <a:buNone/>
-                      </a:pPr>
-                      <a:r>
-                        <a:rPr cap="none" sz="1200" i="0" b="0" u="none" strike="noStrike">
-                          <a:solidFill>
-                            <a:srgbClr val="5B6770">
-                              <a:alpha val="100000"/>
-                            </a:srgbClr>
-                          </a:solidFill>
-                          <a:latin typeface="Helvetica Neue"/>
-                          <a:cs typeface="Helvetica Neue"/>
-                          <a:ea typeface="Helvetica Neue"/>
-                          <a:sym typeface="Helvetica Neue"/>
-                        </a:rPr>
-                        <a:t>1</a:t>
-                      </a:r>
-                    </a:p>
-                  </a:txBody>
-                  <a:tcPr anchor="ctr" marB="63500" marT="63500" marR="0" marL="0">
-                    <a:lnL algn="ctr" cmpd="sng" cap="flat" w="0">
-                      <a:noFill/>
-                      <a:prstDash val="solid"/>
-                    </a:lnL>
-                    <a:lnR algn="ctr" cmpd="sng" cap="flat" w="0">
-                      <a:noFill/>
-                      <a:prstDash val="solid"/>
-                    </a:lnR>
-                    <a:lnT algn="ctr" cmpd="sng" cap="flat" w="0">
-                      <a:noFill/>
-                      <a:prstDash val="solid"/>
-                    </a:lnT>
-                    <a:lnB algn="ctr" cmpd="sng" cap="flat" w="19050">
-                      <a:solidFill>
-                        <a:srgbClr val="666666">
-                          <a:alpha val="100000"/>
-                        </a:srgbClr>
-                      </a:solidFill>
-                      <a:prstDash val="solid"/>
-                    </a:lnB>
-                    <a:solidFill>
-                      <a:srgbClr val="F4F8FB">
-                        <a:alpha val="100000"/>
-                      </a:srgbClr>
-                    </a:solidFill>
-                  </a:tcPr>
-                </a:tc>
-                <a:tc>
-                  <a:txBody>
-                    <a:bodyPr/>
-                    <a:lstStyle/>
-                    <a:p>
-                      <a:pPr algn="l" marL="63500" marR="63500">
-                        <a:lnSpc>
-                          <a:spcPct val="100000"/>
-                        </a:lnSpc>
-                        <a:spcBef>
-                          <a:spcPts val="500"/>
-                        </a:spcBef>
-                        <a:spcAft>
-                          <a:spcPts val="500"/>
-                        </a:spcAft>
-                        <a:buNone/>
-                      </a:pPr>
-                      <a:r>
-                        <a:rPr cap="none" sz="1200" i="0" b="0" u="none" strike="noStrike">
-                          <a:solidFill>
-                            <a:srgbClr val="5B6770">
-                              <a:alpha val="100000"/>
-                            </a:srgbClr>
-                          </a:solidFill>
-                          <a:latin typeface="Helvetica Neue"/>
-                          <a:cs typeface="Helvetica Neue"/>
-                          <a:ea typeface="Helvetica Neue"/>
-                          <a:sym typeface="Helvetica Neue"/>
-                        </a:rPr>
-                        <a:t>816795</a:t>
+                        <a:t>816799</a:t>
                       </a:r>
                     </a:p>
                   </a:txBody>

</xml_diff>

<commit_message>
nightly deck: data through 2026-10-29
</commit_message>
<xml_diff>
--- a/docs/nc-drug-checking-latest.pptx
+++ b/docs/nc-drug-checking-latest.pptx
@@ -2418,7 +2418,7 @@
                 <a:ea typeface="Helvetica Neue"/>
                 <a:sym typeface="Helvetica Neue"/>
               </a:rPr>
-              <a:t>Generated Wednesday, October 28, 2026 · 10:14 AM ET UNC Street Drug Analysis Lab · OpioidData.org · results.streetsafe.supply Download as PowerPoint</a:t>
+              <a:t>Generated Thursday, October 29, 2026 · 10:33 AM ET UNC Street Drug Analysis Lab · OpioidData.org · results.streetsafe.supply Download as PowerPoint</a:t>
             </a:r>
           </a:p>
         </p:txBody>
@@ -2713,7 +2713,7 @@
                 <a:ea typeface="Helvetica Neue"/>
                 <a:sym typeface="Helvetica Neue"/>
               </a:rPr>
-              <a:t>PLACEHOLDER · figs/stats.json January 2022 to Tuesday, October 27, 2026 N = 3,051 NC samples analyzed Mailed in from 86 harm reduction programs Collected across 60 counties 253 distinct substances detected to date Unique samples = n_distinct(sampleid) · substances from lab_detail.substance · includes samples with date_complete 26 Jan 2022 – 27 Oct 2026 r/build_nightly.R → figs/stats.json</a:t>
+              <a:t>PLACEHOLDER · figs/stats.json January 2022 to Thursday, October 29, 2026 N = 3,067 NC samples analyzed Mailed in from 86 harm reduction programs Collected across 61 counties 253 distinct substances detected to date Unique samples = n_distinct(sampleid) · substances from lab_detail.substance · includes samples with date_complete 26 Jan 2022 – 29 Oct 2026 r/build_nightly.R → figs/stats.json</a:t>
             </a:r>
           </a:p>
         </p:txBody>
@@ -2762,7 +2762,7 @@
                 <a:ea typeface="Helvetica Neue"/>
                 <a:sym typeface="Helvetica Neue"/>
               </a:rPr>
-              <a:t>Unique samples = n_distinct(sampleid) · substances from lab_detail.substance · includes samples with date_complete 26 Jan 2022 – 27 Oct 2026</a:t>
+              <a:t>Unique samples = n_distinct(sampleid) · substances from lab_detail.substance · includes samples with date_complete 26 Jan 2022 – 29 Oct 2026</a:t>
             </a:r>
           </a:p>
         </p:txBody>
@@ -3184,7 +3184,7 @@
                 <a:ea typeface="Helvetica Neue"/>
                 <a:sym typeface="Helvetica Neue"/>
               </a:rPr>
-              <a:t>County = samplecounty · left: ≥1 completed analysis ever · right: unique samples per county (sqrt color scale) · all time: 26 Jan 2022 – 27 Oct 2026 · last 12 months: 28 Oct 2025 – 27 Oct 2026* · coverage reflects participation, not prevalence</a:t>
+              <a:t>County = samplecounty · left: ≥1 completed analysis ever · right: unique samples per county (sqrt color scale) · all time: 26 Jan 2022 – 29 Oct 2026 · last 12 months: 29 Oct 2025 – 29 Oct 2026* · coverage reflects participation, not prevalence</a:t>
             </a:r>
           </a:p>
         </p:txBody>
@@ -3505,7 +3505,7 @@
                 <a:ea typeface="Helvetica Neue"/>
                 <a:sym typeface="Helvetica Neue"/>
               </a:rPr>
-              <a:t>expectedsubstance (verbatim card write-in, semicolon lists split) · derived flags: expect_opioid, expect_fentanyl, expect_meth, expect_cocaine, expect_stimulant… · includes samples with date_complete 26 Jan 2022 – 27 Oct 2026 · data table: Appendix A2</a:t>
+              <a:t>expectedsubstance (verbatim card write-in, semicolon lists split) · derived flags: expect_opioid, expect_fentanyl, expect_meth, expect_cocaine, expect_stimulant… · includes samples with date_complete 26 Jan 2022 – 29 Oct 2026 · data table: Appendix A2</a:t>
             </a:r>
           </a:p>
         </p:txBody>
@@ -3703,7 +3703,7 @@
                 <a:ea typeface="Helvetica Neue"/>
                 <a:sym typeface="Helvetica Neue"/>
               </a:rPr>
-              <a:t>Numerator uses lab_*_any (primary or trace) among samples with expect_* = 1 · includes samples with date_complete 26 Jan 2022 – 27 Oct 2026 · data table: Appendix A3</a:t>
+              <a:t>Numerator uses lab_*_any (primary or trace) among samples with expect_* = 1 · includes samples with date_complete 26 Jan 2022 – 29 Oct 2026 · data table: Appendix A3</a:t>
             </a:r>
           </a:p>
         </p:txBody>
@@ -3901,7 +3901,7 @@
                 <a:ea typeface="Helvetica Neue"/>
                 <a:sym typeface="Helvetica Neue"/>
               </a:rPr>
-              <a:t>sensations (circled on card, semicolon lists split) · post-consumption samples only (consumed = 1) · includes samples with date_complete 26 Jan 2022 – 27 Oct 2026</a:t>
+              <a:t>sensations (circled on card, semicolon lists split) · post-consumption samples only (consumed = 1) · includes samples with date_complete 26 Jan 2022 – 29 Oct 2026</a:t>
             </a:r>
           </a:p>
         </p:txBody>
@@ -4125,7 +4125,7 @@
                 <a:ea typeface="Helvetica Neue"/>
                 <a:sym typeface="Helvetica Neue"/>
               </a:rPr>
-              <a:t>sensations semicolon lists parsed per report · consumed = 1 only · denominator: consumed samples with lab_*_any = 1 · includes samples with date_complete 26 Jan 2022 – 27 Oct 2026</a:t>
+              <a:t>sensations semicolon lists parsed per report · consumed = 1 only · denominator: consumed samples with lab_*_any = 1 · includes samples with date_complete 26 Jan 2022 – 29 Oct 2026</a:t>
             </a:r>
           </a:p>
         </p:txBody>
@@ -4323,7 +4323,7 @@
                 <a:ea typeface="Helvetica Neue"/>
                 <a:sym typeface="Helvetica Neue"/>
               </a:rPr>
-              <a:t>Samples with methamphetamine or cocaine detected (any abundance); samples in both classes appear on both slides · sensations semicolon lists parsed + sen_strength (own denominator) · consumed = 1 only · before: 26 Jan 2022 – 27 Oct 2025 · past 12 months: 28 Oct 2025 – 27 Oct 2026* · Δ in percentage points</a:t>
+              <a:t>Samples with methamphetamine or cocaine detected (any abundance); samples in both classes appear on both slides · sensations semicolon lists parsed + sen_strength (own denominator) · consumed = 1 only · before: 26 Jan 2022 – 29 Oct 2025 · past 12 months: 29 Oct 2025 – 29 Oct 2026* · Δ in percentage points</a:t>
             </a:r>
           </a:p>
         </p:txBody>
@@ -4742,7 +4742,7 @@
                 <a:ea typeface="Helvetica Neue"/>
                 <a:sym typeface="Helvetica Neue"/>
               </a:rPr>
-              <a:t>Samples with an opioid (fentanyl, heroin) or benzodiazepine detected (any abundance); samples in both classes appear on both slides · sensations semicolon lists parsed + sen_strength (own denominator) · consumed = 1 only · before: 26 Jan 2022 – 27 Oct 2025 · past 12 months: 28 Oct 2025 – 27 Oct 2026* · Δ in percentage points</a:t>
+              <a:t>Samples with an opioid (fentanyl, heroin) or benzodiazepine detected (any abundance); samples in both classes appear on both slides · sensations semicolon lists parsed + sen_strength (own denominator) · consumed = 1 only · before: 26 Jan 2022 – 29 Oct 2025 · past 12 months: 29 Oct 2025 – 29 Oct 2026* · Δ in percentage points</a:t>
             </a:r>
           </a:p>
         </p:txBody>
@@ -5138,7 +5138,7 @@
                 <a:ea typeface="Helvetica Neue"/>
                 <a:sym typeface="Helvetica Neue"/>
               </a:rPr>
-              <a:t>color, texture (card v3+, semicolon lists split) · derived: bright_color excludes white/tan/brown family — orange bar above · includes samples with date_complete 26 Jan 2022 – 27 Oct 2026</a:t>
+              <a:t>color, texture (card v3+, semicolon lists split) · derived: bright_color excludes white/tan/brown family — orange bar above · includes samples with date_complete 26 Jan 2022 – 29 Oct 2026</a:t>
             </a:r>
           </a:p>
         </p:txBody>
@@ -5459,7 +5459,7 @@
                 <a:ea typeface="Helvetica Neue"/>
                 <a:sym typeface="Helvetica Neue"/>
               </a:rPr>
-              <a:t>Distribution of substances detected per sample, both definitions shown side by side · includes samples with date_complete 26 Jan 2022 – 27 Oct 2026</a:t>
+              <a:t>Distribution of substances detected per sample, both definitions shown side by side · includes samples with date_complete 26 Jan 2022 – 29 Oct 2026</a:t>
             </a:r>
           </a:p>
         </p:txBody>
@@ -5657,7 +5657,7 @@
                 <a:ea typeface="Helvetica Neue"/>
                 <a:sym typeface="Helvetica Neue"/>
               </a:rPr>
-              <a:t>lab_detail.substance counts · solid = primary abundance, light = trace · standardized names (PubChem-linked) · includes samples with date_complete 26 Jan 2022 – 27 Oct 2026</a:t>
+              <a:t>lab_detail.substance counts · solid = primary abundance, light = trace · standardized names (PubChem-linked) · includes samples with date_complete 26 Jan 2022 – 29 Oct 2026</a:t>
             </a:r>
           </a:p>
         </p:txBody>
@@ -5855,7 +5855,7 @@
                 <a:ea typeface="Helvetica Neue"/>
                 <a:sym typeface="Helvetica Neue"/>
               </a:rPr>
-              <a:t>lab_detail.substance counts · solid = primary abundance, light = trace · standardized names (PubChem-linked) · window: date_complete 28 Oct 2025 – 27 Oct 2026* (trailing 12 months, current month partial)</a:t>
+              <a:t>lab_detail.substance counts · solid = primary abundance, light = trace · standardized names (PubChem-linked) · window: date_complete 29 Oct 2025 – 29 Oct 2026* (trailing 12 months, current month partial)</a:t>
             </a:r>
           </a:p>
         </p:txBody>
@@ -6053,7 +6053,7 @@
                 <a:ea typeface="Helvetica Neue"/>
                 <a:sym typeface="Helvetica Neue"/>
               </a:rPr>
-              <a:t>Distribution of substances detected per sample, both definitions shown side by side · window: date_complete 28 Oct 2025 – 27 Oct 2026* (trailing 12 months, current month partial)</a:t>
+              <a:t>Distribution of substances detected per sample, both definitions shown side by side · window: date_complete 29 Oct 2025 – 29 Oct 2026* (trailing 12 months, current month partial)</a:t>
             </a:r>
           </a:p>
         </p:txBody>
@@ -18510,7 +18510,7 @@
                           <a:ea typeface="Helvetica Neue"/>
                           <a:sym typeface="Helvetica Neue"/>
                         </a:rPr>
-                        <a:t>1,580</a:t>
+                        <a:t>1,586</a:t>
                       </a:r>
                     </a:p>
                   </a:txBody>
@@ -18626,7 +18626,7 @@
                           <a:ea typeface="Helvetica Neue"/>
                           <a:sym typeface="Helvetica Neue"/>
                         </a:rPr>
-                        <a:t>464</a:t>
+                        <a:t>466</a:t>
                       </a:r>
                     </a:p>
                   </a:txBody>
@@ -18974,7 +18974,7 @@
                           <a:ea typeface="Helvetica Neue"/>
                           <a:sym typeface="Helvetica Neue"/>
                         </a:rPr>
-                        <a:t>167</a:t>
+                        <a:t>169</a:t>
                       </a:r>
                     </a:p>
                   </a:txBody>
@@ -19322,7 +19322,7 @@
                           <a:ea typeface="Helvetica Neue"/>
                           <a:sym typeface="Helvetica Neue"/>
                         </a:rPr>
-                        <a:t>70</a:t>
+                        <a:t>72</a:t>
                       </a:r>
                     </a:p>
                   </a:txBody>
@@ -19554,7 +19554,7 @@
                           <a:ea typeface="Helvetica Neue"/>
                           <a:sym typeface="Helvetica Neue"/>
                         </a:rPr>
-                        <a:t>57</a:t>
+                        <a:t>59</a:t>
                       </a:r>
                     </a:p>
                   </a:txBody>
@@ -20591,7 +20591,7 @@
                           <a:ea typeface="Helvetica Neue"/>
                           <a:sym typeface="Helvetica Neue"/>
                         </a:rPr>
-                        <a:t>1,833</a:t>
+                        <a:t>1,842</a:t>
                       </a:r>
                     </a:p>
                   </a:txBody>
@@ -20821,7 +20821,7 @@
                           <a:ea typeface="Helvetica Neue"/>
                           <a:sym typeface="Helvetica Neue"/>
                         </a:rPr>
-                        <a:t>546</a:t>
+                        <a:t>548</a:t>
                       </a:r>
                     </a:p>
                   </a:txBody>
@@ -21281,7 +21281,7 @@
                           <a:ea typeface="Helvetica Neue"/>
                           <a:sym typeface="Helvetica Neue"/>
                         </a:rPr>
-                        <a:t>70</a:t>
+                        <a:t>72</a:t>
                       </a:r>
                     </a:p>
                   </a:txBody>
@@ -21338,7 +21338,7 @@
                           <a:ea typeface="Helvetica Neue"/>
                           <a:sym typeface="Helvetica Neue"/>
                         </a:rPr>
-                        <a:t>59%</a:t>
+                        <a:t>60%</a:t>
                       </a:r>
                     </a:p>
                   </a:txBody>
@@ -21515,7 +21515,7 @@
                           <a:ea typeface="Helvetica Neue"/>
                           <a:sym typeface="Helvetica Neue"/>
                         </a:rPr>
-                        <a:t>373</a:t>
+                        <a:t>375</a:t>
                       </a:r>
                     </a:p>
                   </a:txBody>

</xml_diff>

<commit_message>
nightly deck: data through 2026-10-30
</commit_message>
<xml_diff>
--- a/docs/nc-drug-checking-latest.pptx
+++ b/docs/nc-drug-checking-latest.pptx
@@ -2418,7 +2418,7 @@
                 <a:ea typeface="Helvetica Neue"/>
                 <a:sym typeface="Helvetica Neue"/>
               </a:rPr>
-              <a:t>Generated Thursday, October 29, 2026 · 10:33 AM ET UNC Street Drug Analysis Lab · OpioidData.org · results.streetsafe.supply Download as PowerPoint</a:t>
+              <a:t>Generated Friday, October 30, 2026 · 10:25 AM ET UNC Street Drug Analysis Lab · OpioidData.org · results.streetsafe.supply Download as PowerPoint</a:t>
             </a:r>
           </a:p>
         </p:txBody>
@@ -2713,7 +2713,7 @@
                 <a:ea typeface="Helvetica Neue"/>
                 <a:sym typeface="Helvetica Neue"/>
               </a:rPr>
-              <a:t>PLACEHOLDER · figs/stats.json January 2022 to Thursday, October 29, 2026 N = 3,067 NC samples analyzed Mailed in from 86 harm reduction programs Collected across 61 counties 253 distinct substances detected to date Unique samples = n_distinct(sampleid) · substances from lab_detail.substance · includes samples with date_complete 26 Jan 2022 – 29 Oct 2026 r/build_nightly.R → figs/stats.json</a:t>
+              <a:t>PLACEHOLDER · figs/stats.json January 2022 to Friday, October 30, 2026 N = 3,082 NC samples analyzed Mailed in from 86 harm reduction programs Collected across 61 counties 254 distinct substances detected to date Unique samples = n_distinct(sampleid) · substances from lab_detail.substance · includes samples with date_complete 26 Jan 2022 – 30 Oct 2026 r/build_nightly.R → figs/stats.json</a:t>
             </a:r>
           </a:p>
         </p:txBody>
@@ -2762,7 +2762,7 @@
                 <a:ea typeface="Helvetica Neue"/>
                 <a:sym typeface="Helvetica Neue"/>
               </a:rPr>
-              <a:t>Unique samples = n_distinct(sampleid) · substances from lab_detail.substance · includes samples with date_complete 26 Jan 2022 – 29 Oct 2026</a:t>
+              <a:t>Unique samples = n_distinct(sampleid) · substances from lab_detail.substance · includes samples with date_complete 26 Jan 2022 – 30 Oct 2026</a:t>
             </a:r>
           </a:p>
         </p:txBody>
@@ -3184,7 +3184,7 @@
                 <a:ea typeface="Helvetica Neue"/>
                 <a:sym typeface="Helvetica Neue"/>
               </a:rPr>
-              <a:t>County = samplecounty · left: ≥1 completed analysis ever · right: unique samples per county (sqrt color scale) · all time: 26 Jan 2022 – 29 Oct 2026 · last 12 months: 29 Oct 2025 – 29 Oct 2026* · coverage reflects participation, not prevalence</a:t>
+              <a:t>County = samplecounty · left: ≥1 completed analysis ever · right: unique samples per county (sqrt color scale) · all time: 26 Jan 2022 – 30 Oct 2026 · last 12 months: 30 Oct 2025 – 30 Oct 2026* · coverage reflects participation, not prevalence</a:t>
             </a:r>
           </a:p>
         </p:txBody>
@@ -3505,7 +3505,7 @@
                 <a:ea typeface="Helvetica Neue"/>
                 <a:sym typeface="Helvetica Neue"/>
               </a:rPr>
-              <a:t>expectedsubstance (verbatim card write-in, semicolon lists split) · derived flags: expect_opioid, expect_fentanyl, expect_meth, expect_cocaine, expect_stimulant… · includes samples with date_complete 26 Jan 2022 – 29 Oct 2026 · data table: Appendix A2</a:t>
+              <a:t>expectedsubstance (verbatim card write-in, semicolon lists split) · derived flags: expect_opioid, expect_fentanyl, expect_meth, expect_cocaine, expect_stimulant… · includes samples with date_complete 26 Jan 2022 – 30 Oct 2026 · data table: Appendix A2</a:t>
             </a:r>
           </a:p>
         </p:txBody>
@@ -3703,7 +3703,7 @@
                 <a:ea typeface="Helvetica Neue"/>
                 <a:sym typeface="Helvetica Neue"/>
               </a:rPr>
-              <a:t>Numerator uses lab_*_any (primary or trace) among samples with expect_* = 1 · includes samples with date_complete 26 Jan 2022 – 29 Oct 2026 · data table: Appendix A3</a:t>
+              <a:t>Numerator uses lab_*_any (primary or trace) among samples with expect_* = 1 · includes samples with date_complete 26 Jan 2022 – 30 Oct 2026 · data table: Appendix A3</a:t>
             </a:r>
           </a:p>
         </p:txBody>
@@ -3901,7 +3901,7 @@
                 <a:ea typeface="Helvetica Neue"/>
                 <a:sym typeface="Helvetica Neue"/>
               </a:rPr>
-              <a:t>sensations (circled on card, semicolon lists split) · post-consumption samples only (consumed = 1) · includes samples with date_complete 26 Jan 2022 – 29 Oct 2026</a:t>
+              <a:t>sensations (circled on card, semicolon lists split) · post-consumption samples only (consumed = 1) · includes samples with date_complete 26 Jan 2022 – 30 Oct 2026</a:t>
             </a:r>
           </a:p>
         </p:txBody>
@@ -4125,7 +4125,7 @@
                 <a:ea typeface="Helvetica Neue"/>
                 <a:sym typeface="Helvetica Neue"/>
               </a:rPr>
-              <a:t>sensations semicolon lists parsed per report · consumed = 1 only · denominator: consumed samples with lab_*_any = 1 · includes samples with date_complete 26 Jan 2022 – 29 Oct 2026</a:t>
+              <a:t>sensations semicolon lists parsed per report · consumed = 1 only · denominator: consumed samples with lab_*_any = 1 · includes samples with date_complete 26 Jan 2022 – 30 Oct 2026</a:t>
             </a:r>
           </a:p>
         </p:txBody>
@@ -4323,7 +4323,7 @@
                 <a:ea typeface="Helvetica Neue"/>
                 <a:sym typeface="Helvetica Neue"/>
               </a:rPr>
-              <a:t>Samples with methamphetamine or cocaine detected (any abundance); samples in both classes appear on both slides · sensations semicolon lists parsed + sen_strength (own denominator) · consumed = 1 only · before: 26 Jan 2022 – 29 Oct 2025 · past 12 months: 29 Oct 2025 – 29 Oct 2026* · Δ in percentage points</a:t>
+              <a:t>Samples with methamphetamine or cocaine detected (any abundance); samples in both classes appear on both slides · sensations semicolon lists parsed + sen_strength (own denominator) · consumed = 1 only · before: 26 Jan 2022 – 30 Oct 2025 · past 12 months: 30 Oct 2025 – 30 Oct 2026* · Δ in percentage points</a:t>
             </a:r>
           </a:p>
         </p:txBody>
@@ -4742,7 +4742,7 @@
                 <a:ea typeface="Helvetica Neue"/>
                 <a:sym typeface="Helvetica Neue"/>
               </a:rPr>
-              <a:t>Samples with an opioid (fentanyl, heroin) or benzodiazepine detected (any abundance); samples in both classes appear on both slides · sensations semicolon lists parsed + sen_strength (own denominator) · consumed = 1 only · before: 26 Jan 2022 – 29 Oct 2025 · past 12 months: 29 Oct 2025 – 29 Oct 2026* · Δ in percentage points</a:t>
+              <a:t>Samples with an opioid (fentanyl, heroin) or benzodiazepine detected (any abundance); samples in both classes appear on both slides · sensations semicolon lists parsed + sen_strength (own denominator) · consumed = 1 only · before: 26 Jan 2022 – 30 Oct 2025 · past 12 months: 30 Oct 2025 – 30 Oct 2026* · Δ in percentage points</a:t>
             </a:r>
           </a:p>
         </p:txBody>
@@ -5138,7 +5138,7 @@
                 <a:ea typeface="Helvetica Neue"/>
                 <a:sym typeface="Helvetica Neue"/>
               </a:rPr>
-              <a:t>color, texture (card v3+, semicolon lists split) · derived: bright_color excludes white/tan/brown family — orange bar above · includes samples with date_complete 26 Jan 2022 – 29 Oct 2026</a:t>
+              <a:t>color, texture (card v3+, semicolon lists split) · derived: bright_color excludes white/tan/brown family — orange bar above · includes samples with date_complete 26 Jan 2022 – 30 Oct 2026</a:t>
             </a:r>
           </a:p>
         </p:txBody>
@@ -5459,7 +5459,7 @@
                 <a:ea typeface="Helvetica Neue"/>
                 <a:sym typeface="Helvetica Neue"/>
               </a:rPr>
-              <a:t>Distribution of substances detected per sample, both definitions shown side by side · includes samples with date_complete 26 Jan 2022 – 29 Oct 2026</a:t>
+              <a:t>Distribution of substances detected per sample, both definitions shown side by side · includes samples with date_complete 26 Jan 2022 – 30 Oct 2026</a:t>
             </a:r>
           </a:p>
         </p:txBody>
@@ -5657,7 +5657,7 @@
                 <a:ea typeface="Helvetica Neue"/>
                 <a:sym typeface="Helvetica Neue"/>
               </a:rPr>
-              <a:t>lab_detail.substance counts · solid = primary abundance, light = trace · standardized names (PubChem-linked) · includes samples with date_complete 26 Jan 2022 – 29 Oct 2026</a:t>
+              <a:t>lab_detail.substance counts · solid = primary abundance, light = trace · standardized names (PubChem-linked) · includes samples with date_complete 26 Jan 2022 – 30 Oct 2026</a:t>
             </a:r>
           </a:p>
         </p:txBody>
@@ -5855,7 +5855,7 @@
                 <a:ea typeface="Helvetica Neue"/>
                 <a:sym typeface="Helvetica Neue"/>
               </a:rPr>
-              <a:t>lab_detail.substance counts · solid = primary abundance, light = trace · standardized names (PubChem-linked) · window: date_complete 29 Oct 2025 – 29 Oct 2026* (trailing 12 months, current month partial)</a:t>
+              <a:t>lab_detail.substance counts · solid = primary abundance, light = trace · standardized names (PubChem-linked) · window: date_complete 30 Oct 2025 – 30 Oct 2026* (trailing 12 months, current month partial)</a:t>
             </a:r>
           </a:p>
         </p:txBody>
@@ -6053,7 +6053,7 @@
                 <a:ea typeface="Helvetica Neue"/>
                 <a:sym typeface="Helvetica Neue"/>
               </a:rPr>
-              <a:t>Distribution of substances detected per sample, both definitions shown side by side · window: date_complete 29 Oct 2025 – 29 Oct 2026* (trailing 12 months, current month partial)</a:t>
+              <a:t>Distribution of substances detected per sample, both definitions shown side by side · window: date_complete 30 Oct 2025 – 30 Oct 2026* (trailing 12 months, current month partial)</a:t>
             </a:r>
           </a:p>
         </p:txBody>
@@ -11049,6 +11049,293 @@
                           <a:ea typeface="Helvetica Neue"/>
                           <a:sym typeface="Helvetica Neue"/>
                         </a:rPr>
+                        <a:t>N-propionylmethamphetamine</a:t>
+                      </a:r>
+                    </a:p>
+                  </a:txBody>
+                  <a:tcPr anchor="ctr" marB="63500" marT="63500" marR="0" marL="0">
+                    <a:lnL algn="ctr" cmpd="sng" cap="flat" w="0">
+                      <a:noFill/>
+                      <a:prstDash val="solid"/>
+                    </a:lnL>
+                    <a:lnR algn="ctr" cmpd="sng" cap="flat" w="0">
+                      <a:noFill/>
+                      <a:prstDash val="solid"/>
+                    </a:lnR>
+                    <a:lnT algn="ctr" cmpd="sng" cap="flat" w="0">
+                      <a:noFill/>
+                      <a:prstDash val="solid"/>
+                    </a:lnT>
+                    <a:lnB algn="ctr" cmpd="sng" cap="flat" w="0">
+                      <a:noFill/>
+                      <a:prstDash val="solid"/>
+                    </a:lnB>
+                    <a:solidFill>
+                      <a:srgbClr val="FFFFFF">
+                        <a:alpha val="0"/>
+                      </a:srgbClr>
+                    </a:solidFill>
+                  </a:tcPr>
+                </a:tc>
+                <a:tc>
+                  <a:txBody>
+                    <a:bodyPr/>
+                    <a:lstStyle/>
+                    <a:p>
+                      <a:pPr algn="l" marL="63500" marR="63500">
+                        <a:lnSpc>
+                          <a:spcPct val="100000"/>
+                        </a:lnSpc>
+                        <a:spcBef>
+                          <a:spcPts val="500"/>
+                        </a:spcBef>
+                        <a:spcAft>
+                          <a:spcPts val="500"/>
+                        </a:spcAft>
+                        <a:buNone/>
+                      </a:pPr>
+                      <a:r>
+                        <a:rPr cap="none" sz="1200" i="0" b="0" u="none" strike="noStrike">
+                          <a:solidFill>
+                            <a:srgbClr val="5B6770">
+                              <a:alpha val="100000"/>
+                            </a:srgbClr>
+                          </a:solidFill>
+                          <a:latin typeface="Helvetica Neue"/>
+                          <a:cs typeface="Helvetica Neue"/>
+                          <a:ea typeface="Helvetica Neue"/>
+                          <a:sym typeface="Helvetica Neue"/>
+                        </a:rPr>
+                        <a:t>29 Oct 2026</a:t>
+                      </a:r>
+                    </a:p>
+                  </a:txBody>
+                  <a:tcPr anchor="ctr" marB="63500" marT="63500" marR="0" marL="0">
+                    <a:lnL algn="ctr" cmpd="sng" cap="flat" w="0">
+                      <a:noFill/>
+                      <a:prstDash val="solid"/>
+                    </a:lnL>
+                    <a:lnR algn="ctr" cmpd="sng" cap="flat" w="0">
+                      <a:noFill/>
+                      <a:prstDash val="solid"/>
+                    </a:lnR>
+                    <a:lnT algn="ctr" cmpd="sng" cap="flat" w="0">
+                      <a:noFill/>
+                      <a:prstDash val="solid"/>
+                    </a:lnT>
+                    <a:lnB algn="ctr" cmpd="sng" cap="flat" w="0">
+                      <a:noFill/>
+                      <a:prstDash val="solid"/>
+                    </a:lnB>
+                    <a:solidFill>
+                      <a:srgbClr val="FFFFFF">
+                        <a:alpha val="0"/>
+                      </a:srgbClr>
+                    </a:solidFill>
+                  </a:tcPr>
+                </a:tc>
+                <a:tc>
+                  <a:txBody>
+                    <a:bodyPr/>
+                    <a:lstStyle/>
+                    <a:p>
+                      <a:pPr algn="l" marL="63500" marR="63500">
+                        <a:lnSpc>
+                          <a:spcPct val="100000"/>
+                        </a:lnSpc>
+                        <a:spcBef>
+                          <a:spcPts val="500"/>
+                        </a:spcBef>
+                        <a:spcAft>
+                          <a:spcPts val="500"/>
+                        </a:spcAft>
+                        <a:buNone/>
+                      </a:pPr>
+                      <a:r>
+                        <a:rPr cap="none" sz="1200" i="0" b="0" u="none" strike="noStrike">
+                          <a:solidFill>
+                            <a:srgbClr val="5B6770">
+                              <a:alpha val="100000"/>
+                            </a:srgbClr>
+                          </a:solidFill>
+                          <a:latin typeface="Helvetica Neue"/>
+                          <a:cs typeface="Helvetica Neue"/>
+                          <a:ea typeface="Helvetica Neue"/>
+                          <a:sym typeface="Helvetica Neue"/>
+                        </a:rPr>
+                        <a:t>primary</a:t>
+                      </a:r>
+                    </a:p>
+                  </a:txBody>
+                  <a:tcPr anchor="ctr" marB="63500" marT="63500" marR="0" marL="0">
+                    <a:lnL algn="ctr" cmpd="sng" cap="flat" w="0">
+                      <a:noFill/>
+                      <a:prstDash val="solid"/>
+                    </a:lnL>
+                    <a:lnR algn="ctr" cmpd="sng" cap="flat" w="0">
+                      <a:noFill/>
+                      <a:prstDash val="solid"/>
+                    </a:lnR>
+                    <a:lnT algn="ctr" cmpd="sng" cap="flat" w="0">
+                      <a:noFill/>
+                      <a:prstDash val="solid"/>
+                    </a:lnT>
+                    <a:lnB algn="ctr" cmpd="sng" cap="flat" w="0">
+                      <a:noFill/>
+                      <a:prstDash val="solid"/>
+                    </a:lnB>
+                    <a:solidFill>
+                      <a:srgbClr val="FFFFFF">
+                        <a:alpha val="0"/>
+                      </a:srgbClr>
+                    </a:solidFill>
+                  </a:tcPr>
+                </a:tc>
+                <a:tc>
+                  <a:txBody>
+                    <a:bodyPr/>
+                    <a:lstStyle/>
+                    <a:p>
+                      <a:pPr algn="r" marL="63500" marR="63500">
+                        <a:lnSpc>
+                          <a:spcPct val="100000"/>
+                        </a:lnSpc>
+                        <a:spcBef>
+                          <a:spcPts val="500"/>
+                        </a:spcBef>
+                        <a:spcAft>
+                          <a:spcPts val="500"/>
+                        </a:spcAft>
+                        <a:buNone/>
+                      </a:pPr>
+                      <a:r>
+                        <a:rPr cap="none" sz="1200" i="0" b="0" u="none" strike="noStrike">
+                          <a:solidFill>
+                            <a:srgbClr val="5B6770">
+                              <a:alpha val="100000"/>
+                            </a:srgbClr>
+                          </a:solidFill>
+                          <a:latin typeface="Helvetica Neue"/>
+                          <a:cs typeface="Helvetica Neue"/>
+                          <a:ea typeface="Helvetica Neue"/>
+                          <a:sym typeface="Helvetica Neue"/>
+                        </a:rPr>
+                        <a:t>1</a:t>
+                      </a:r>
+                    </a:p>
+                  </a:txBody>
+                  <a:tcPr anchor="ctr" marB="63500" marT="63500" marR="0" marL="0">
+                    <a:lnL algn="ctr" cmpd="sng" cap="flat" w="0">
+                      <a:noFill/>
+                      <a:prstDash val="solid"/>
+                    </a:lnL>
+                    <a:lnR algn="ctr" cmpd="sng" cap="flat" w="0">
+                      <a:noFill/>
+                      <a:prstDash val="solid"/>
+                    </a:lnR>
+                    <a:lnT algn="ctr" cmpd="sng" cap="flat" w="0">
+                      <a:noFill/>
+                      <a:prstDash val="solid"/>
+                    </a:lnT>
+                    <a:lnB algn="ctr" cmpd="sng" cap="flat" w="0">
+                      <a:noFill/>
+                      <a:prstDash val="solid"/>
+                    </a:lnB>
+                    <a:solidFill>
+                      <a:srgbClr val="FFFFFF">
+                        <a:alpha val="0"/>
+                      </a:srgbClr>
+                    </a:solidFill>
+                  </a:tcPr>
+                </a:tc>
+                <a:tc>
+                  <a:txBody>
+                    <a:bodyPr/>
+                    <a:lstStyle/>
+                    <a:p>
+                      <a:pPr algn="l" marL="63500" marR="63500">
+                        <a:lnSpc>
+                          <a:spcPct val="100000"/>
+                        </a:lnSpc>
+                        <a:spcBef>
+                          <a:spcPts val="500"/>
+                        </a:spcBef>
+                        <a:spcAft>
+                          <a:spcPts val="500"/>
+                        </a:spcAft>
+                        <a:buNone/>
+                      </a:pPr>
+                      <a:r>
+                        <a:rPr cap="none" sz="1200" i="0" b="0" u="none" strike="noStrike">
+                          <a:solidFill>
+                            <a:srgbClr val="5B6770">
+                              <a:alpha val="100000"/>
+                            </a:srgbClr>
+                          </a:solidFill>
+                          <a:latin typeface="Helvetica Neue"/>
+                          <a:cs typeface="Helvetica Neue"/>
+                          <a:ea typeface="Helvetica Neue"/>
+                          <a:sym typeface="Helvetica Neue"/>
+                        </a:rPr>
+                        <a:t>901278</a:t>
+                      </a:r>
+                    </a:p>
+                  </a:txBody>
+                  <a:tcPr anchor="ctr" marB="63500" marT="63500" marR="0" marL="0">
+                    <a:lnL algn="ctr" cmpd="sng" cap="flat" w="0">
+                      <a:noFill/>
+                      <a:prstDash val="solid"/>
+                    </a:lnL>
+                    <a:lnR algn="ctr" cmpd="sng" cap="flat" w="0">
+                      <a:noFill/>
+                      <a:prstDash val="solid"/>
+                    </a:lnR>
+                    <a:lnT algn="ctr" cmpd="sng" cap="flat" w="0">
+                      <a:noFill/>
+                      <a:prstDash val="solid"/>
+                    </a:lnT>
+                    <a:lnB algn="ctr" cmpd="sng" cap="flat" w="0">
+                      <a:noFill/>
+                      <a:prstDash val="solid"/>
+                    </a:lnB>
+                    <a:solidFill>
+                      <a:srgbClr val="FFFFFF">
+                        <a:alpha val="0"/>
+                      </a:srgbClr>
+                    </a:solidFill>
+                  </a:tcPr>
+                </a:tc>
+              </a:tr>
+              <a:tr h="401320">
+                <a:tc>
+                  <a:txBody>
+                    <a:bodyPr/>
+                    <a:lstStyle/>
+                    <a:p>
+                      <a:pPr algn="l" marL="63500" marR="63500">
+                        <a:lnSpc>
+                          <a:spcPct val="100000"/>
+                        </a:lnSpc>
+                        <a:spcBef>
+                          <a:spcPts val="500"/>
+                        </a:spcBef>
+                        <a:spcAft>
+                          <a:spcPts val="500"/>
+                        </a:spcAft>
+                        <a:buNone/>
+                      </a:pPr>
+                      <a:r>
+                        <a:rPr cap="none" sz="1200" i="0" b="0" u="none" strike="noStrike">
+                          <a:solidFill>
+                            <a:srgbClr val="5B6770">
+                              <a:alpha val="100000"/>
+                            </a:srgbClr>
+                          </a:solidFill>
+                          <a:latin typeface="Helvetica Neue"/>
+                          <a:cs typeface="Helvetica Neue"/>
+                          <a:ea typeface="Helvetica Neue"/>
+                          <a:sym typeface="Helvetica Neue"/>
+                        </a:rPr>
                         <a:t>mifepristone</a:t>
                       </a:r>
                     </a:p>
@@ -11071,8 +11358,8 @@
                       <a:prstDash val="solid"/>
                     </a:lnB>
                     <a:solidFill>
-                      <a:srgbClr val="FFFFFF">
-                        <a:alpha val="0"/>
+                      <a:srgbClr val="F4F8FB">
+                        <a:alpha val="100000"/>
                       </a:srgbClr>
                     </a:solidFill>
                   </a:tcPr>
@@ -11128,8 +11415,8 @@
                       <a:prstDash val="solid"/>
                     </a:lnB>
                     <a:solidFill>
-                      <a:srgbClr val="FFFFFF">
-                        <a:alpha val="0"/>
+                      <a:srgbClr val="F4F8FB">
+                        <a:alpha val="100000"/>
                       </a:srgbClr>
                     </a:solidFill>
                   </a:tcPr>
@@ -11185,8 +11472,8 @@
                       <a:prstDash val="solid"/>
                     </a:lnB>
                     <a:solidFill>
-                      <a:srgbClr val="FFFFFF">
-                        <a:alpha val="0"/>
+                      <a:srgbClr val="F4F8FB">
+                        <a:alpha val="100000"/>
                       </a:srgbClr>
                     </a:solidFill>
                   </a:tcPr>
@@ -11242,8 +11529,8 @@
                       <a:prstDash val="solid"/>
                     </a:lnB>
                     <a:solidFill>
-                      <a:srgbClr val="FFFFFF">
-                        <a:alpha val="0"/>
+                      <a:srgbClr val="F4F8FB">
+                        <a:alpha val="100000"/>
                       </a:srgbClr>
                     </a:solidFill>
                   </a:tcPr>
@@ -11299,8 +11586,8 @@
                       <a:prstDash val="solid"/>
                     </a:lnB>
                     <a:solidFill>
-                      <a:srgbClr val="FFFFFF">
-                        <a:alpha val="0"/>
+                      <a:srgbClr val="F4F8FB">
+                        <a:alpha val="100000"/>
                       </a:srgbClr>
                     </a:solidFill>
                   </a:tcPr>
@@ -11358,8 +11645,8 @@
                       <a:prstDash val="solid"/>
                     </a:lnB>
                     <a:solidFill>
-                      <a:srgbClr val="F4F8FB">
-                        <a:alpha val="100000"/>
+                      <a:srgbClr val="FFFFFF">
+                        <a:alpha val="0"/>
                       </a:srgbClr>
                     </a:solidFill>
                   </a:tcPr>
@@ -11415,8 +11702,8 @@
                       <a:prstDash val="solid"/>
                     </a:lnB>
                     <a:solidFill>
-                      <a:srgbClr val="F4F8FB">
-                        <a:alpha val="100000"/>
+                      <a:srgbClr val="FFFFFF">
+                        <a:alpha val="0"/>
                       </a:srgbClr>
                     </a:solidFill>
                   </a:tcPr>
@@ -11472,8 +11759,8 @@
                       <a:prstDash val="solid"/>
                     </a:lnB>
                     <a:solidFill>
-                      <a:srgbClr val="F4F8FB">
-                        <a:alpha val="100000"/>
+                      <a:srgbClr val="FFFFFF">
+                        <a:alpha val="0"/>
                       </a:srgbClr>
                     </a:solidFill>
                   </a:tcPr>
@@ -11529,8 +11816,8 @@
                       <a:prstDash val="solid"/>
                     </a:lnB>
                     <a:solidFill>
-                      <a:srgbClr val="F4F8FB">
-                        <a:alpha val="100000"/>
+                      <a:srgbClr val="FFFFFF">
+                        <a:alpha val="0"/>
                       </a:srgbClr>
                     </a:solidFill>
                   </a:tcPr>
@@ -11586,8 +11873,8 @@
                       <a:prstDash val="solid"/>
                     </a:lnB>
                     <a:solidFill>
-                      <a:srgbClr val="F4F8FB">
-                        <a:alpha val="100000"/>
+                      <a:srgbClr val="FFFFFF">
+                        <a:alpha val="0"/>
                       </a:srgbClr>
                     </a:solidFill>
                   </a:tcPr>
@@ -11645,8 +11932,8 @@
                       <a:prstDash val="solid"/>
                     </a:lnB>
                     <a:solidFill>
-                      <a:srgbClr val="FFFFFF">
-                        <a:alpha val="0"/>
+                      <a:srgbClr val="F4F8FB">
+                        <a:alpha val="100000"/>
                       </a:srgbClr>
                     </a:solidFill>
                   </a:tcPr>
@@ -11702,8 +11989,8 @@
                       <a:prstDash val="solid"/>
                     </a:lnB>
                     <a:solidFill>
-                      <a:srgbClr val="FFFFFF">
-                        <a:alpha val="0"/>
+                      <a:srgbClr val="F4F8FB">
+                        <a:alpha val="100000"/>
                       </a:srgbClr>
                     </a:solidFill>
                   </a:tcPr>
@@ -11759,8 +12046,8 @@
                       <a:prstDash val="solid"/>
                     </a:lnB>
                     <a:solidFill>
-                      <a:srgbClr val="FFFFFF">
-                        <a:alpha val="0"/>
+                      <a:srgbClr val="F4F8FB">
+                        <a:alpha val="100000"/>
                       </a:srgbClr>
                     </a:solidFill>
                   </a:tcPr>
@@ -11816,8 +12103,8 @@
                       <a:prstDash val="solid"/>
                     </a:lnB>
                     <a:solidFill>
-                      <a:srgbClr val="FFFFFF">
-                        <a:alpha val="0"/>
+                      <a:srgbClr val="F4F8FB">
+                        <a:alpha val="100000"/>
                       </a:srgbClr>
                     </a:solidFill>
                   </a:tcPr>
@@ -11873,8 +12160,8 @@
                       <a:prstDash val="solid"/>
                     </a:lnB>
                     <a:solidFill>
-                      <a:srgbClr val="FFFFFF">
-                        <a:alpha val="0"/>
+                      <a:srgbClr val="F4F8FB">
+                        <a:alpha val="100000"/>
                       </a:srgbClr>
                     </a:solidFill>
                   </a:tcPr>
@@ -11932,8 +12219,8 @@
                       <a:prstDash val="solid"/>
                     </a:lnB>
                     <a:solidFill>
-                      <a:srgbClr val="F4F8FB">
-                        <a:alpha val="100000"/>
+                      <a:srgbClr val="FFFFFF">
+                        <a:alpha val="0"/>
                       </a:srgbClr>
                     </a:solidFill>
                   </a:tcPr>
@@ -11989,8 +12276,8 @@
                       <a:prstDash val="solid"/>
                     </a:lnB>
                     <a:solidFill>
-                      <a:srgbClr val="F4F8FB">
-                        <a:alpha val="100000"/>
+                      <a:srgbClr val="FFFFFF">
+                        <a:alpha val="0"/>
                       </a:srgbClr>
                     </a:solidFill>
                   </a:tcPr>
@@ -12046,8 +12333,8 @@
                       <a:prstDash val="solid"/>
                     </a:lnB>
                     <a:solidFill>
-                      <a:srgbClr val="F4F8FB">
-                        <a:alpha val="100000"/>
+                      <a:srgbClr val="FFFFFF">
+                        <a:alpha val="0"/>
                       </a:srgbClr>
                     </a:solidFill>
                   </a:tcPr>
@@ -12103,8 +12390,8 @@
                       <a:prstDash val="solid"/>
                     </a:lnB>
                     <a:solidFill>
-                      <a:srgbClr val="F4F8FB">
-                        <a:alpha val="100000"/>
+                      <a:srgbClr val="FFFFFF">
+                        <a:alpha val="0"/>
                       </a:srgbClr>
                     </a:solidFill>
                   </a:tcPr>
@@ -12160,8 +12447,8 @@
                       <a:prstDash val="solid"/>
                     </a:lnB>
                     <a:solidFill>
-                      <a:srgbClr val="F4F8FB">
-                        <a:alpha val="100000"/>
+                      <a:srgbClr val="FFFFFF">
+                        <a:alpha val="0"/>
                       </a:srgbClr>
                     </a:solidFill>
                   </a:tcPr>
@@ -12219,8 +12506,8 @@
                       <a:prstDash val="solid"/>
                     </a:lnB>
                     <a:solidFill>
-                      <a:srgbClr val="FFFFFF">
-                        <a:alpha val="0"/>
+                      <a:srgbClr val="F4F8FB">
+                        <a:alpha val="100000"/>
                       </a:srgbClr>
                     </a:solidFill>
                   </a:tcPr>
@@ -12276,8 +12563,8 @@
                       <a:prstDash val="solid"/>
                     </a:lnB>
                     <a:solidFill>
-                      <a:srgbClr val="FFFFFF">
-                        <a:alpha val="0"/>
+                      <a:srgbClr val="F4F8FB">
+                        <a:alpha val="100000"/>
                       </a:srgbClr>
                     </a:solidFill>
                   </a:tcPr>
@@ -12333,8 +12620,8 @@
                       <a:prstDash val="solid"/>
                     </a:lnB>
                     <a:solidFill>
-                      <a:srgbClr val="FFFFFF">
-                        <a:alpha val="0"/>
+                      <a:srgbClr val="F4F8FB">
+                        <a:alpha val="100000"/>
                       </a:srgbClr>
                     </a:solidFill>
                   </a:tcPr>
@@ -12390,8 +12677,8 @@
                       <a:prstDash val="solid"/>
                     </a:lnB>
                     <a:solidFill>
-                      <a:srgbClr val="FFFFFF">
-                        <a:alpha val="0"/>
+                      <a:srgbClr val="F4F8FB">
+                        <a:alpha val="100000"/>
                       </a:srgbClr>
                     </a:solidFill>
                   </a:tcPr>
@@ -12447,8 +12734,8 @@
                       <a:prstDash val="solid"/>
                     </a:lnB>
                     <a:solidFill>
-                      <a:srgbClr val="FFFFFF">
-                        <a:alpha val="0"/>
+                      <a:srgbClr val="F4F8FB">
+                        <a:alpha val="100000"/>
                       </a:srgbClr>
                     </a:solidFill>
                   </a:tcPr>
@@ -12506,8 +12793,8 @@
                       <a:prstDash val="solid"/>
                     </a:lnB>
                     <a:solidFill>
-                      <a:srgbClr val="F4F8FB">
-                        <a:alpha val="100000"/>
+                      <a:srgbClr val="FFFFFF">
+                        <a:alpha val="0"/>
                       </a:srgbClr>
                     </a:solidFill>
                   </a:tcPr>
@@ -12563,8 +12850,8 @@
                       <a:prstDash val="solid"/>
                     </a:lnB>
                     <a:solidFill>
-                      <a:srgbClr val="F4F8FB">
-                        <a:alpha val="100000"/>
+                      <a:srgbClr val="FFFFFF">
+                        <a:alpha val="0"/>
                       </a:srgbClr>
                     </a:solidFill>
                   </a:tcPr>
@@ -12620,8 +12907,8 @@
                       <a:prstDash val="solid"/>
                     </a:lnB>
                     <a:solidFill>
-                      <a:srgbClr val="F4F8FB">
-                        <a:alpha val="100000"/>
+                      <a:srgbClr val="FFFFFF">
+                        <a:alpha val="0"/>
                       </a:srgbClr>
                     </a:solidFill>
                   </a:tcPr>
@@ -12677,8 +12964,8 @@
                       <a:prstDash val="solid"/>
                     </a:lnB>
                     <a:solidFill>
-                      <a:srgbClr val="F4F8FB">
-                        <a:alpha val="100000"/>
+                      <a:srgbClr val="FFFFFF">
+                        <a:alpha val="0"/>
                       </a:srgbClr>
                     </a:solidFill>
                   </a:tcPr>
@@ -12734,8 +13021,8 @@
                       <a:prstDash val="solid"/>
                     </a:lnB>
                     <a:solidFill>
-                      <a:srgbClr val="F4F8FB">
-                        <a:alpha val="100000"/>
+                      <a:srgbClr val="FFFFFF">
+                        <a:alpha val="0"/>
                       </a:srgbClr>
                     </a:solidFill>
                   </a:tcPr>
@@ -12793,8 +13080,8 @@
                       <a:prstDash val="solid"/>
                     </a:lnB>
                     <a:solidFill>
-                      <a:srgbClr val="FFFFFF">
-                        <a:alpha val="0"/>
+                      <a:srgbClr val="F4F8FB">
+                        <a:alpha val="100000"/>
                       </a:srgbClr>
                     </a:solidFill>
                   </a:tcPr>
@@ -12850,8 +13137,8 @@
                       <a:prstDash val="solid"/>
                     </a:lnB>
                     <a:solidFill>
-                      <a:srgbClr val="FFFFFF">
-                        <a:alpha val="0"/>
+                      <a:srgbClr val="F4F8FB">
+                        <a:alpha val="100000"/>
                       </a:srgbClr>
                     </a:solidFill>
                   </a:tcPr>
@@ -12907,8 +13194,8 @@
                       <a:prstDash val="solid"/>
                     </a:lnB>
                     <a:solidFill>
-                      <a:srgbClr val="FFFFFF">
-                        <a:alpha val="0"/>
+                      <a:srgbClr val="F4F8FB">
+                        <a:alpha val="100000"/>
                       </a:srgbClr>
                     </a:solidFill>
                   </a:tcPr>
@@ -12964,8 +13251,8 @@
                       <a:prstDash val="solid"/>
                     </a:lnB>
                     <a:solidFill>
-                      <a:srgbClr val="FFFFFF">
-                        <a:alpha val="0"/>
+                      <a:srgbClr val="F4F8FB">
+                        <a:alpha val="100000"/>
                       </a:srgbClr>
                     </a:solidFill>
                   </a:tcPr>
@@ -13021,8 +13308,8 @@
                       <a:prstDash val="solid"/>
                     </a:lnB>
                     <a:solidFill>
-                      <a:srgbClr val="FFFFFF">
-                        <a:alpha val="0"/>
+                      <a:srgbClr val="F4F8FB">
+                        <a:alpha val="100000"/>
                       </a:srgbClr>
                     </a:solidFill>
                   </a:tcPr>
@@ -13080,8 +13367,8 @@
                       <a:prstDash val="solid"/>
                     </a:lnB>
                     <a:solidFill>
-                      <a:srgbClr val="F4F8FB">
-                        <a:alpha val="100000"/>
+                      <a:srgbClr val="FFFFFF">
+                        <a:alpha val="0"/>
                       </a:srgbClr>
                     </a:solidFill>
                   </a:tcPr>
@@ -13137,8 +13424,8 @@
                       <a:prstDash val="solid"/>
                     </a:lnB>
                     <a:solidFill>
-                      <a:srgbClr val="F4F8FB">
-                        <a:alpha val="100000"/>
+                      <a:srgbClr val="FFFFFF">
+                        <a:alpha val="0"/>
                       </a:srgbClr>
                     </a:solidFill>
                   </a:tcPr>
@@ -13194,8 +13481,8 @@
                       <a:prstDash val="solid"/>
                     </a:lnB>
                     <a:solidFill>
-                      <a:srgbClr val="F4F8FB">
-                        <a:alpha val="100000"/>
+                      <a:srgbClr val="FFFFFF">
+                        <a:alpha val="0"/>
                       </a:srgbClr>
                     </a:solidFill>
                   </a:tcPr>
@@ -13251,8 +13538,8 @@
                       <a:prstDash val="solid"/>
                     </a:lnB>
                     <a:solidFill>
-                      <a:srgbClr val="F4F8FB">
-                        <a:alpha val="100000"/>
+                      <a:srgbClr val="FFFFFF">
+                        <a:alpha val="0"/>
                       </a:srgbClr>
                     </a:solidFill>
                   </a:tcPr>
@@ -13308,8 +13595,8 @@
                       <a:prstDash val="solid"/>
                     </a:lnB>
                     <a:solidFill>
-                      <a:srgbClr val="F4F8FB">
-                        <a:alpha val="100000"/>
+                      <a:srgbClr val="FFFFFF">
+                        <a:alpha val="0"/>
                       </a:srgbClr>
                     </a:solidFill>
                   </a:tcPr>
@@ -13367,8 +13654,8 @@
                       <a:prstDash val="solid"/>
                     </a:lnB>
                     <a:solidFill>
-                      <a:srgbClr val="FFFFFF">
-                        <a:alpha val="0"/>
+                      <a:srgbClr val="F4F8FB">
+                        <a:alpha val="100000"/>
                       </a:srgbClr>
                     </a:solidFill>
                   </a:tcPr>
@@ -13424,8 +13711,8 @@
                       <a:prstDash val="solid"/>
                     </a:lnB>
                     <a:solidFill>
-                      <a:srgbClr val="FFFFFF">
-                        <a:alpha val="0"/>
+                      <a:srgbClr val="F4F8FB">
+                        <a:alpha val="100000"/>
                       </a:srgbClr>
                     </a:solidFill>
                   </a:tcPr>
@@ -13481,8 +13768,8 @@
                       <a:prstDash val="solid"/>
                     </a:lnB>
                     <a:solidFill>
-                      <a:srgbClr val="FFFFFF">
-                        <a:alpha val="0"/>
+                      <a:srgbClr val="F4F8FB">
+                        <a:alpha val="100000"/>
                       </a:srgbClr>
                     </a:solidFill>
                   </a:tcPr>
@@ -13538,8 +13825,8 @@
                       <a:prstDash val="solid"/>
                     </a:lnB>
                     <a:solidFill>
-                      <a:srgbClr val="FFFFFF">
-                        <a:alpha val="0"/>
+                      <a:srgbClr val="F4F8FB">
+                        <a:alpha val="100000"/>
                       </a:srgbClr>
                     </a:solidFill>
                   </a:tcPr>
@@ -13595,8 +13882,8 @@
                       <a:prstDash val="solid"/>
                     </a:lnB>
                     <a:solidFill>
-                      <a:srgbClr val="FFFFFF">
-                        <a:alpha val="0"/>
+                      <a:srgbClr val="F4F8FB">
+                        <a:alpha val="100000"/>
                       </a:srgbClr>
                     </a:solidFill>
                   </a:tcPr>
@@ -13654,8 +13941,8 @@
                       <a:prstDash val="solid"/>
                     </a:lnB>
                     <a:solidFill>
-                      <a:srgbClr val="F4F8FB">
-                        <a:alpha val="100000"/>
+                      <a:srgbClr val="FFFFFF">
+                        <a:alpha val="0"/>
                       </a:srgbClr>
                     </a:solidFill>
                   </a:tcPr>
@@ -13711,8 +13998,8 @@
                       <a:prstDash val="solid"/>
                     </a:lnB>
                     <a:solidFill>
-                      <a:srgbClr val="F4F8FB">
-                        <a:alpha val="100000"/>
+                      <a:srgbClr val="FFFFFF">
+                        <a:alpha val="0"/>
                       </a:srgbClr>
                     </a:solidFill>
                   </a:tcPr>
@@ -13768,8 +14055,8 @@
                       <a:prstDash val="solid"/>
                     </a:lnB>
                     <a:solidFill>
-                      <a:srgbClr val="F4F8FB">
-                        <a:alpha val="100000"/>
+                      <a:srgbClr val="FFFFFF">
+                        <a:alpha val="0"/>
                       </a:srgbClr>
                     </a:solidFill>
                   </a:tcPr>
@@ -13825,8 +14112,8 @@
                       <a:prstDash val="solid"/>
                     </a:lnB>
                     <a:solidFill>
-                      <a:srgbClr val="F4F8FB">
-                        <a:alpha val="100000"/>
+                      <a:srgbClr val="FFFFFF">
+                        <a:alpha val="0"/>
                       </a:srgbClr>
                     </a:solidFill>
                   </a:tcPr>
@@ -13882,14 +14169,14 @@
                       <a:prstDash val="solid"/>
                     </a:lnB>
                     <a:solidFill>
-                      <a:srgbClr val="F4F8FB">
-                        <a:alpha val="100000"/>
+                      <a:srgbClr val="FFFFFF">
+                        <a:alpha val="0"/>
                       </a:srgbClr>
                     </a:solidFill>
                   </a:tcPr>
                 </a:tc>
               </a:tr>
-              <a:tr h="401320">
+              <a:tr h="410845">
                 <a:tc>
                   <a:txBody>
                     <a:bodyPr/>
@@ -13936,13 +14223,17 @@
                       <a:noFill/>
                       <a:prstDash val="solid"/>
                     </a:lnT>
-                    <a:lnB algn="ctr" cmpd="sng" cap="flat" w="0">
-                      <a:noFill/>
+                    <a:lnB algn="ctr" cmpd="sng" cap="flat" w="19050">
+                      <a:solidFill>
+                        <a:srgbClr val="666666">
+                          <a:alpha val="100000"/>
+                        </a:srgbClr>
+                      </a:solidFill>
                       <a:prstDash val="solid"/>
                     </a:lnB>
                     <a:solidFill>
-                      <a:srgbClr val="FFFFFF">
-                        <a:alpha val="0"/>
+                      <a:srgbClr val="F4F8FB">
+                        <a:alpha val="100000"/>
                       </a:srgbClr>
                     </a:solidFill>
                   </a:tcPr>
@@ -13993,13 +14284,17 @@
                       <a:noFill/>
                       <a:prstDash val="solid"/>
                     </a:lnT>
-                    <a:lnB algn="ctr" cmpd="sng" cap="flat" w="0">
-                      <a:noFill/>
+                    <a:lnB algn="ctr" cmpd="sng" cap="flat" w="19050">
+                      <a:solidFill>
+                        <a:srgbClr val="666666">
+                          <a:alpha val="100000"/>
+                        </a:srgbClr>
+                      </a:solidFill>
                       <a:prstDash val="solid"/>
                     </a:lnB>
                     <a:solidFill>
-                      <a:srgbClr val="FFFFFF">
-                        <a:alpha val="0"/>
+                      <a:srgbClr val="F4F8FB">
+                        <a:alpha val="100000"/>
                       </a:srgbClr>
                     </a:solidFill>
                   </a:tcPr>
@@ -14050,13 +14345,17 @@
                       <a:noFill/>
                       <a:prstDash val="solid"/>
                     </a:lnT>
-                    <a:lnB algn="ctr" cmpd="sng" cap="flat" w="0">
-                      <a:noFill/>
+                    <a:lnB algn="ctr" cmpd="sng" cap="flat" w="19050">
+                      <a:solidFill>
+                        <a:srgbClr val="666666">
+                          <a:alpha val="100000"/>
+                        </a:srgbClr>
+                      </a:solidFill>
                       <a:prstDash val="solid"/>
                     </a:lnB>
                     <a:solidFill>
-                      <a:srgbClr val="FFFFFF">
-                        <a:alpha val="0"/>
+                      <a:srgbClr val="F4F8FB">
+                        <a:alpha val="100000"/>
                       </a:srgbClr>
                     </a:solidFill>
                   </a:tcPr>
@@ -14107,122 +14406,6 @@
                       <a:noFill/>
                       <a:prstDash val="solid"/>
                     </a:lnT>
-                    <a:lnB algn="ctr" cmpd="sng" cap="flat" w="0">
-                      <a:noFill/>
-                      <a:prstDash val="solid"/>
-                    </a:lnB>
-                    <a:solidFill>
-                      <a:srgbClr val="FFFFFF">
-                        <a:alpha val="0"/>
-                      </a:srgbClr>
-                    </a:solidFill>
-                  </a:tcPr>
-                </a:tc>
-                <a:tc>
-                  <a:txBody>
-                    <a:bodyPr/>
-                    <a:lstStyle/>
-                    <a:p>
-                      <a:pPr algn="l" marL="63500" marR="63500">
-                        <a:lnSpc>
-                          <a:spcPct val="100000"/>
-                        </a:lnSpc>
-                        <a:spcBef>
-                          <a:spcPts val="500"/>
-                        </a:spcBef>
-                        <a:spcAft>
-                          <a:spcPts val="500"/>
-                        </a:spcAft>
-                        <a:buNone/>
-                      </a:pPr>
-                      <a:r>
-                        <a:rPr cap="none" sz="1200" i="0" b="0" u="none" strike="noStrike">
-                          <a:solidFill>
-                            <a:srgbClr val="5B6770">
-                              <a:alpha val="100000"/>
-                            </a:srgbClr>
-                          </a:solidFill>
-                          <a:latin typeface="Helvetica Neue"/>
-                          <a:cs typeface="Helvetica Neue"/>
-                          <a:ea typeface="Helvetica Neue"/>
-                          <a:sym typeface="Helvetica Neue"/>
-                        </a:rPr>
-                        <a:t>605335</a:t>
-                      </a:r>
-                    </a:p>
-                  </a:txBody>
-                  <a:tcPr anchor="ctr" marB="63500" marT="63500" marR="0" marL="0">
-                    <a:lnL algn="ctr" cmpd="sng" cap="flat" w="0">
-                      <a:noFill/>
-                      <a:prstDash val="solid"/>
-                    </a:lnL>
-                    <a:lnR algn="ctr" cmpd="sng" cap="flat" w="0">
-                      <a:noFill/>
-                      <a:prstDash val="solid"/>
-                    </a:lnR>
-                    <a:lnT algn="ctr" cmpd="sng" cap="flat" w="0">
-                      <a:noFill/>
-                      <a:prstDash val="solid"/>
-                    </a:lnT>
-                    <a:lnB algn="ctr" cmpd="sng" cap="flat" w="0">
-                      <a:noFill/>
-                      <a:prstDash val="solid"/>
-                    </a:lnB>
-                    <a:solidFill>
-                      <a:srgbClr val="FFFFFF">
-                        <a:alpha val="0"/>
-                      </a:srgbClr>
-                    </a:solidFill>
-                  </a:tcPr>
-                </a:tc>
-              </a:tr>
-              <a:tr h="410845">
-                <a:tc>
-                  <a:txBody>
-                    <a:bodyPr/>
-                    <a:lstStyle/>
-                    <a:p>
-                      <a:pPr algn="l" marL="63500" marR="63500">
-                        <a:lnSpc>
-                          <a:spcPct val="100000"/>
-                        </a:lnSpc>
-                        <a:spcBef>
-                          <a:spcPts val="500"/>
-                        </a:spcBef>
-                        <a:spcAft>
-                          <a:spcPts val="500"/>
-                        </a:spcAft>
-                        <a:buNone/>
-                      </a:pPr>
-                      <a:r>
-                        <a:rPr cap="none" sz="1200" i="0" b="0" u="none" strike="noStrike">
-                          <a:solidFill>
-                            <a:srgbClr val="5B6770">
-                              <a:alpha val="100000"/>
-                            </a:srgbClr>
-                          </a:solidFill>
-                          <a:latin typeface="Helvetica Neue"/>
-                          <a:cs typeface="Helvetica Neue"/>
-                          <a:ea typeface="Helvetica Neue"/>
-                          <a:sym typeface="Helvetica Neue"/>
-                        </a:rPr>
-                        <a:t>misoprostol</a:t>
-                      </a:r>
-                    </a:p>
-                  </a:txBody>
-                  <a:tcPr anchor="ctr" marB="63500" marT="63500" marR="0" marL="0">
-                    <a:lnL algn="ctr" cmpd="sng" cap="flat" w="0">
-                      <a:noFill/>
-                      <a:prstDash val="solid"/>
-                    </a:lnL>
-                    <a:lnR algn="ctr" cmpd="sng" cap="flat" w="0">
-                      <a:noFill/>
-                      <a:prstDash val="solid"/>
-                    </a:lnR>
-                    <a:lnT algn="ctr" cmpd="sng" cap="flat" w="0">
-                      <a:noFill/>
-                      <a:prstDash val="solid"/>
-                    </a:lnT>
                     <a:lnB algn="ctr" cmpd="sng" cap="flat" w="19050">
                       <a:solidFill>
                         <a:srgbClr val="666666">
@@ -14267,190 +14450,7 @@
                           <a:ea typeface="Helvetica Neue"/>
                           <a:sym typeface="Helvetica Neue"/>
                         </a:rPr>
-                        <a:t>06 Aug 2026</a:t>
-                      </a:r>
-                    </a:p>
-                  </a:txBody>
-                  <a:tcPr anchor="ctr" marB="63500" marT="63500" marR="0" marL="0">
-                    <a:lnL algn="ctr" cmpd="sng" cap="flat" w="0">
-                      <a:noFill/>
-                      <a:prstDash val="solid"/>
-                    </a:lnL>
-                    <a:lnR algn="ctr" cmpd="sng" cap="flat" w="0">
-                      <a:noFill/>
-                      <a:prstDash val="solid"/>
-                    </a:lnR>
-                    <a:lnT algn="ctr" cmpd="sng" cap="flat" w="0">
-                      <a:noFill/>
-                      <a:prstDash val="solid"/>
-                    </a:lnT>
-                    <a:lnB algn="ctr" cmpd="sng" cap="flat" w="19050">
-                      <a:solidFill>
-                        <a:srgbClr val="666666">
-                          <a:alpha val="100000"/>
-                        </a:srgbClr>
-                      </a:solidFill>
-                      <a:prstDash val="solid"/>
-                    </a:lnB>
-                    <a:solidFill>
-                      <a:srgbClr val="F4F8FB">
-                        <a:alpha val="100000"/>
-                      </a:srgbClr>
-                    </a:solidFill>
-                  </a:tcPr>
-                </a:tc>
-                <a:tc>
-                  <a:txBody>
-                    <a:bodyPr/>
-                    <a:lstStyle/>
-                    <a:p>
-                      <a:pPr algn="l" marL="63500" marR="63500">
-                        <a:lnSpc>
-                          <a:spcPct val="100000"/>
-                        </a:lnSpc>
-                        <a:spcBef>
-                          <a:spcPts val="500"/>
-                        </a:spcBef>
-                        <a:spcAft>
-                          <a:spcPts val="500"/>
-                        </a:spcAft>
-                        <a:buNone/>
-                      </a:pPr>
-                      <a:r>
-                        <a:rPr cap="none" sz="1200" i="0" b="0" u="none" strike="noStrike">
-                          <a:solidFill>
-                            <a:srgbClr val="5B6770">
-                              <a:alpha val="100000"/>
-                            </a:srgbClr>
-                          </a:solidFill>
-                          <a:latin typeface="Helvetica Neue"/>
-                          <a:cs typeface="Helvetica Neue"/>
-                          <a:ea typeface="Helvetica Neue"/>
-                          <a:sym typeface="Helvetica Neue"/>
-                        </a:rPr>
-                        <a:t>primary</a:t>
-                      </a:r>
-                    </a:p>
-                  </a:txBody>
-                  <a:tcPr anchor="ctr" marB="63500" marT="63500" marR="0" marL="0">
-                    <a:lnL algn="ctr" cmpd="sng" cap="flat" w="0">
-                      <a:noFill/>
-                      <a:prstDash val="solid"/>
-                    </a:lnL>
-                    <a:lnR algn="ctr" cmpd="sng" cap="flat" w="0">
-                      <a:noFill/>
-                      <a:prstDash val="solid"/>
-                    </a:lnR>
-                    <a:lnT algn="ctr" cmpd="sng" cap="flat" w="0">
-                      <a:noFill/>
-                      <a:prstDash val="solid"/>
-                    </a:lnT>
-                    <a:lnB algn="ctr" cmpd="sng" cap="flat" w="19050">
-                      <a:solidFill>
-                        <a:srgbClr val="666666">
-                          <a:alpha val="100000"/>
-                        </a:srgbClr>
-                      </a:solidFill>
-                      <a:prstDash val="solid"/>
-                    </a:lnB>
-                    <a:solidFill>
-                      <a:srgbClr val="F4F8FB">
-                        <a:alpha val="100000"/>
-                      </a:srgbClr>
-                    </a:solidFill>
-                  </a:tcPr>
-                </a:tc>
-                <a:tc>
-                  <a:txBody>
-                    <a:bodyPr/>
-                    <a:lstStyle/>
-                    <a:p>
-                      <a:pPr algn="r" marL="63500" marR="63500">
-                        <a:lnSpc>
-                          <a:spcPct val="100000"/>
-                        </a:lnSpc>
-                        <a:spcBef>
-                          <a:spcPts val="500"/>
-                        </a:spcBef>
-                        <a:spcAft>
-                          <a:spcPts val="500"/>
-                        </a:spcAft>
-                        <a:buNone/>
-                      </a:pPr>
-                      <a:r>
-                        <a:rPr cap="none" sz="1200" i="0" b="0" u="none" strike="noStrike">
-                          <a:solidFill>
-                            <a:srgbClr val="5B6770">
-                              <a:alpha val="100000"/>
-                            </a:srgbClr>
-                          </a:solidFill>
-                          <a:latin typeface="Helvetica Neue"/>
-                          <a:cs typeface="Helvetica Neue"/>
-                          <a:ea typeface="Helvetica Neue"/>
-                          <a:sym typeface="Helvetica Neue"/>
-                        </a:rPr>
-                        <a:t>1</a:t>
-                      </a:r>
-                    </a:p>
-                  </a:txBody>
-                  <a:tcPr anchor="ctr" marB="63500" marT="63500" marR="0" marL="0">
-                    <a:lnL algn="ctr" cmpd="sng" cap="flat" w="0">
-                      <a:noFill/>
-                      <a:prstDash val="solid"/>
-                    </a:lnL>
-                    <a:lnR algn="ctr" cmpd="sng" cap="flat" w="0">
-                      <a:noFill/>
-                      <a:prstDash val="solid"/>
-                    </a:lnR>
-                    <a:lnT algn="ctr" cmpd="sng" cap="flat" w="0">
-                      <a:noFill/>
-                      <a:prstDash val="solid"/>
-                    </a:lnT>
-                    <a:lnB algn="ctr" cmpd="sng" cap="flat" w="19050">
-                      <a:solidFill>
-                        <a:srgbClr val="666666">
-                          <a:alpha val="100000"/>
-                        </a:srgbClr>
-                      </a:solidFill>
-                      <a:prstDash val="solid"/>
-                    </a:lnB>
-                    <a:solidFill>
-                      <a:srgbClr val="F4F8FB">
-                        <a:alpha val="100000"/>
-                      </a:srgbClr>
-                    </a:solidFill>
-                  </a:tcPr>
-                </a:tc>
-                <a:tc>
-                  <a:txBody>
-                    <a:bodyPr/>
-                    <a:lstStyle/>
-                    <a:p>
-                      <a:pPr algn="l" marL="63500" marR="63500">
-                        <a:lnSpc>
-                          <a:spcPct val="100000"/>
-                        </a:lnSpc>
-                        <a:spcBef>
-                          <a:spcPts val="500"/>
-                        </a:spcBef>
-                        <a:spcAft>
-                          <a:spcPts val="500"/>
-                        </a:spcAft>
-                        <a:buNone/>
-                      </a:pPr>
-                      <a:r>
-                        <a:rPr cap="none" sz="1200" i="0" b="0" u="none" strike="noStrike">
-                          <a:solidFill>
-                            <a:srgbClr val="5B6770">
-                              <a:alpha val="100000"/>
-                            </a:srgbClr>
-                          </a:solidFill>
-                          <a:latin typeface="Helvetica Neue"/>
-                          <a:cs typeface="Helvetica Neue"/>
-                          <a:ea typeface="Helvetica Neue"/>
-                          <a:sym typeface="Helvetica Neue"/>
-                        </a:rPr>
-                        <a:t>816799</a:t>
+                        <a:t>605335</a:t>
                       </a:r>
                     </a:p>
                   </a:txBody>
@@ -18510,7 +18510,7 @@
                           <a:ea typeface="Helvetica Neue"/>
                           <a:sym typeface="Helvetica Neue"/>
                         </a:rPr>
-                        <a:t>1,586</a:t>
+                        <a:t>1,596</a:t>
                       </a:r>
                     </a:p>
                   </a:txBody>
@@ -18626,7 +18626,7 @@
                           <a:ea typeface="Helvetica Neue"/>
                           <a:sym typeface="Helvetica Neue"/>
                         </a:rPr>
-                        <a:t>466</a:t>
+                        <a:t>469</a:t>
                       </a:r>
                     </a:p>
                   </a:txBody>
@@ -18974,7 +18974,7 @@
                           <a:ea typeface="Helvetica Neue"/>
                           <a:sym typeface="Helvetica Neue"/>
                         </a:rPr>
-                        <a:t>169</a:t>
+                        <a:t>170</a:t>
                       </a:r>
                     </a:p>
                   </a:txBody>
@@ -20591,7 +20591,7 @@
                           <a:ea typeface="Helvetica Neue"/>
                           <a:sym typeface="Helvetica Neue"/>
                         </a:rPr>
-                        <a:t>1,842</a:t>
+                        <a:t>1,853</a:t>
                       </a:r>
                     </a:p>
                   </a:txBody>
@@ -20821,7 +20821,7 @@
                           <a:ea typeface="Helvetica Neue"/>
                           <a:sym typeface="Helvetica Neue"/>
                         </a:rPr>
-                        <a:t>548</a:t>
+                        <a:t>551</a:t>
                       </a:r>
                     </a:p>
                   </a:txBody>
@@ -21515,7 +21515,7 @@
                           <a:ea typeface="Helvetica Neue"/>
                           <a:sym typeface="Helvetica Neue"/>
                         </a:rPr>
-                        <a:t>375</a:t>
+                        <a:t>376</a:t>
                       </a:r>
                     </a:p>
                   </a:txBody>
@@ -24942,6 +24942,293 @@
                           <a:ea typeface="Helvetica Neue"/>
                           <a:sym typeface="Helvetica Neue"/>
                         </a:rPr>
+                        <a:t>N-propionylmethamphetamine</a:t>
+                      </a:r>
+                    </a:p>
+                  </a:txBody>
+                  <a:tcPr anchor="ctr" marB="63500" marT="63500" marR="0" marL="0">
+                    <a:lnL algn="ctr" cmpd="sng" cap="flat" w="0">
+                      <a:noFill/>
+                      <a:prstDash val="solid"/>
+                    </a:lnL>
+                    <a:lnR algn="ctr" cmpd="sng" cap="flat" w="0">
+                      <a:noFill/>
+                      <a:prstDash val="solid"/>
+                    </a:lnR>
+                    <a:lnT algn="ctr" cmpd="sng" cap="flat" w="0">
+                      <a:noFill/>
+                      <a:prstDash val="solid"/>
+                    </a:lnT>
+                    <a:lnB algn="ctr" cmpd="sng" cap="flat" w="0">
+                      <a:noFill/>
+                      <a:prstDash val="solid"/>
+                    </a:lnB>
+                    <a:solidFill>
+                      <a:srgbClr val="FFFFFF">
+                        <a:alpha val="0"/>
+                      </a:srgbClr>
+                    </a:solidFill>
+                  </a:tcPr>
+                </a:tc>
+                <a:tc>
+                  <a:txBody>
+                    <a:bodyPr/>
+                    <a:lstStyle/>
+                    <a:p>
+                      <a:pPr algn="l" marL="63500" marR="63500">
+                        <a:lnSpc>
+                          <a:spcPct val="100000"/>
+                        </a:lnSpc>
+                        <a:spcBef>
+                          <a:spcPts val="500"/>
+                        </a:spcBef>
+                        <a:spcAft>
+                          <a:spcPts val="500"/>
+                        </a:spcAft>
+                        <a:buNone/>
+                      </a:pPr>
+                      <a:r>
+                        <a:rPr cap="none" sz="1200" i="0" b="0" u="none" strike="noStrike">
+                          <a:solidFill>
+                            <a:srgbClr val="5B6770">
+                              <a:alpha val="100000"/>
+                            </a:srgbClr>
+                          </a:solidFill>
+                          <a:latin typeface="Helvetica Neue"/>
+                          <a:cs typeface="Helvetica Neue"/>
+                          <a:ea typeface="Helvetica Neue"/>
+                          <a:sym typeface="Helvetica Neue"/>
+                        </a:rPr>
+                        <a:t>29 Oct 2026</a:t>
+                      </a:r>
+                    </a:p>
+                  </a:txBody>
+                  <a:tcPr anchor="ctr" marB="63500" marT="63500" marR="0" marL="0">
+                    <a:lnL algn="ctr" cmpd="sng" cap="flat" w="0">
+                      <a:noFill/>
+                      <a:prstDash val="solid"/>
+                    </a:lnL>
+                    <a:lnR algn="ctr" cmpd="sng" cap="flat" w="0">
+                      <a:noFill/>
+                      <a:prstDash val="solid"/>
+                    </a:lnR>
+                    <a:lnT algn="ctr" cmpd="sng" cap="flat" w="0">
+                      <a:noFill/>
+                      <a:prstDash val="solid"/>
+                    </a:lnT>
+                    <a:lnB algn="ctr" cmpd="sng" cap="flat" w="0">
+                      <a:noFill/>
+                      <a:prstDash val="solid"/>
+                    </a:lnB>
+                    <a:solidFill>
+                      <a:srgbClr val="FFFFFF">
+                        <a:alpha val="0"/>
+                      </a:srgbClr>
+                    </a:solidFill>
+                  </a:tcPr>
+                </a:tc>
+                <a:tc>
+                  <a:txBody>
+                    <a:bodyPr/>
+                    <a:lstStyle/>
+                    <a:p>
+                      <a:pPr algn="l" marL="63500" marR="63500">
+                        <a:lnSpc>
+                          <a:spcPct val="100000"/>
+                        </a:lnSpc>
+                        <a:spcBef>
+                          <a:spcPts val="500"/>
+                        </a:spcBef>
+                        <a:spcAft>
+                          <a:spcPts val="500"/>
+                        </a:spcAft>
+                        <a:buNone/>
+                      </a:pPr>
+                      <a:r>
+                        <a:rPr cap="none" sz="1200" i="0" b="0" u="none" strike="noStrike">
+                          <a:solidFill>
+                            <a:srgbClr val="5B6770">
+                              <a:alpha val="100000"/>
+                            </a:srgbClr>
+                          </a:solidFill>
+                          <a:latin typeface="Helvetica Neue"/>
+                          <a:cs typeface="Helvetica Neue"/>
+                          <a:ea typeface="Helvetica Neue"/>
+                          <a:sym typeface="Helvetica Neue"/>
+                        </a:rPr>
+                        <a:t>primary</a:t>
+                      </a:r>
+                    </a:p>
+                  </a:txBody>
+                  <a:tcPr anchor="ctr" marB="63500" marT="63500" marR="0" marL="0">
+                    <a:lnL algn="ctr" cmpd="sng" cap="flat" w="0">
+                      <a:noFill/>
+                      <a:prstDash val="solid"/>
+                    </a:lnL>
+                    <a:lnR algn="ctr" cmpd="sng" cap="flat" w="0">
+                      <a:noFill/>
+                      <a:prstDash val="solid"/>
+                    </a:lnR>
+                    <a:lnT algn="ctr" cmpd="sng" cap="flat" w="0">
+                      <a:noFill/>
+                      <a:prstDash val="solid"/>
+                    </a:lnT>
+                    <a:lnB algn="ctr" cmpd="sng" cap="flat" w="0">
+                      <a:noFill/>
+                      <a:prstDash val="solid"/>
+                    </a:lnB>
+                    <a:solidFill>
+                      <a:srgbClr val="FFFFFF">
+                        <a:alpha val="0"/>
+                      </a:srgbClr>
+                    </a:solidFill>
+                  </a:tcPr>
+                </a:tc>
+                <a:tc>
+                  <a:txBody>
+                    <a:bodyPr/>
+                    <a:lstStyle/>
+                    <a:p>
+                      <a:pPr algn="r" marL="63500" marR="63500">
+                        <a:lnSpc>
+                          <a:spcPct val="100000"/>
+                        </a:lnSpc>
+                        <a:spcBef>
+                          <a:spcPts val="500"/>
+                        </a:spcBef>
+                        <a:spcAft>
+                          <a:spcPts val="500"/>
+                        </a:spcAft>
+                        <a:buNone/>
+                      </a:pPr>
+                      <a:r>
+                        <a:rPr cap="none" sz="1200" i="0" b="0" u="none" strike="noStrike">
+                          <a:solidFill>
+                            <a:srgbClr val="5B6770">
+                              <a:alpha val="100000"/>
+                            </a:srgbClr>
+                          </a:solidFill>
+                          <a:latin typeface="Helvetica Neue"/>
+                          <a:cs typeface="Helvetica Neue"/>
+                          <a:ea typeface="Helvetica Neue"/>
+                          <a:sym typeface="Helvetica Neue"/>
+                        </a:rPr>
+                        <a:t>1</a:t>
+                      </a:r>
+                    </a:p>
+                  </a:txBody>
+                  <a:tcPr anchor="ctr" marB="63500" marT="63500" marR="0" marL="0">
+                    <a:lnL algn="ctr" cmpd="sng" cap="flat" w="0">
+                      <a:noFill/>
+                      <a:prstDash val="solid"/>
+                    </a:lnL>
+                    <a:lnR algn="ctr" cmpd="sng" cap="flat" w="0">
+                      <a:noFill/>
+                      <a:prstDash val="solid"/>
+                    </a:lnR>
+                    <a:lnT algn="ctr" cmpd="sng" cap="flat" w="0">
+                      <a:noFill/>
+                      <a:prstDash val="solid"/>
+                    </a:lnT>
+                    <a:lnB algn="ctr" cmpd="sng" cap="flat" w="0">
+                      <a:noFill/>
+                      <a:prstDash val="solid"/>
+                    </a:lnB>
+                    <a:solidFill>
+                      <a:srgbClr val="FFFFFF">
+                        <a:alpha val="0"/>
+                      </a:srgbClr>
+                    </a:solidFill>
+                  </a:tcPr>
+                </a:tc>
+                <a:tc>
+                  <a:txBody>
+                    <a:bodyPr/>
+                    <a:lstStyle/>
+                    <a:p>
+                      <a:pPr algn="l" marL="63500" marR="63500">
+                        <a:lnSpc>
+                          <a:spcPct val="100000"/>
+                        </a:lnSpc>
+                        <a:spcBef>
+                          <a:spcPts val="500"/>
+                        </a:spcBef>
+                        <a:spcAft>
+                          <a:spcPts val="500"/>
+                        </a:spcAft>
+                        <a:buNone/>
+                      </a:pPr>
+                      <a:r>
+                        <a:rPr cap="none" sz="1200" i="0" b="0" u="none" strike="noStrike">
+                          <a:solidFill>
+                            <a:srgbClr val="5B6770">
+                              <a:alpha val="100000"/>
+                            </a:srgbClr>
+                          </a:solidFill>
+                          <a:latin typeface="Helvetica Neue"/>
+                          <a:cs typeface="Helvetica Neue"/>
+                          <a:ea typeface="Helvetica Neue"/>
+                          <a:sym typeface="Helvetica Neue"/>
+                        </a:rPr>
+                        <a:t>901278</a:t>
+                      </a:r>
+                    </a:p>
+                  </a:txBody>
+                  <a:tcPr anchor="ctr" marB="63500" marT="63500" marR="0" marL="0">
+                    <a:lnL algn="ctr" cmpd="sng" cap="flat" w="0">
+                      <a:noFill/>
+                      <a:prstDash val="solid"/>
+                    </a:lnL>
+                    <a:lnR algn="ctr" cmpd="sng" cap="flat" w="0">
+                      <a:noFill/>
+                      <a:prstDash val="solid"/>
+                    </a:lnR>
+                    <a:lnT algn="ctr" cmpd="sng" cap="flat" w="0">
+                      <a:noFill/>
+                      <a:prstDash val="solid"/>
+                    </a:lnT>
+                    <a:lnB algn="ctr" cmpd="sng" cap="flat" w="0">
+                      <a:noFill/>
+                      <a:prstDash val="solid"/>
+                    </a:lnB>
+                    <a:solidFill>
+                      <a:srgbClr val="FFFFFF">
+                        <a:alpha val="0"/>
+                      </a:srgbClr>
+                    </a:solidFill>
+                  </a:tcPr>
+                </a:tc>
+              </a:tr>
+              <a:tr h="401320">
+                <a:tc>
+                  <a:txBody>
+                    <a:bodyPr/>
+                    <a:lstStyle/>
+                    <a:p>
+                      <a:pPr algn="l" marL="63500" marR="63500">
+                        <a:lnSpc>
+                          <a:spcPct val="100000"/>
+                        </a:lnSpc>
+                        <a:spcBef>
+                          <a:spcPts val="500"/>
+                        </a:spcBef>
+                        <a:spcAft>
+                          <a:spcPts val="500"/>
+                        </a:spcAft>
+                        <a:buNone/>
+                      </a:pPr>
+                      <a:r>
+                        <a:rPr cap="none" sz="1200" i="0" b="0" u="none" strike="noStrike">
+                          <a:solidFill>
+                            <a:srgbClr val="5B6770">
+                              <a:alpha val="100000"/>
+                            </a:srgbClr>
+                          </a:solidFill>
+                          <a:latin typeface="Helvetica Neue"/>
+                          <a:cs typeface="Helvetica Neue"/>
+                          <a:ea typeface="Helvetica Neue"/>
+                          <a:sym typeface="Helvetica Neue"/>
+                        </a:rPr>
                         <a:t>mifepristone</a:t>
                       </a:r>
                     </a:p>
@@ -24964,8 +25251,8 @@
                       <a:prstDash val="solid"/>
                     </a:lnB>
                     <a:solidFill>
-                      <a:srgbClr val="FFFFFF">
-                        <a:alpha val="0"/>
+                      <a:srgbClr val="F4F8FB">
+                        <a:alpha val="100000"/>
                       </a:srgbClr>
                     </a:solidFill>
                   </a:tcPr>
@@ -25021,8 +25308,8 @@
                       <a:prstDash val="solid"/>
                     </a:lnB>
                     <a:solidFill>
-                      <a:srgbClr val="FFFFFF">
-                        <a:alpha val="0"/>
+                      <a:srgbClr val="F4F8FB">
+                        <a:alpha val="100000"/>
                       </a:srgbClr>
                     </a:solidFill>
                   </a:tcPr>
@@ -25078,8 +25365,8 @@
                       <a:prstDash val="solid"/>
                     </a:lnB>
                     <a:solidFill>
-                      <a:srgbClr val="FFFFFF">
-                        <a:alpha val="0"/>
+                      <a:srgbClr val="F4F8FB">
+                        <a:alpha val="100000"/>
                       </a:srgbClr>
                     </a:solidFill>
                   </a:tcPr>
@@ -25135,8 +25422,8 @@
                       <a:prstDash val="solid"/>
                     </a:lnB>
                     <a:solidFill>
-                      <a:srgbClr val="FFFFFF">
-                        <a:alpha val="0"/>
+                      <a:srgbClr val="F4F8FB">
+                        <a:alpha val="100000"/>
                       </a:srgbClr>
                     </a:solidFill>
                   </a:tcPr>
@@ -25192,8 +25479,8 @@
                       <a:prstDash val="solid"/>
                     </a:lnB>
                     <a:solidFill>
-                      <a:srgbClr val="FFFFFF">
-                        <a:alpha val="0"/>
+                      <a:srgbClr val="F4F8FB">
+                        <a:alpha val="100000"/>
                       </a:srgbClr>
                     </a:solidFill>
                   </a:tcPr>
@@ -25251,8 +25538,8 @@
                       <a:prstDash val="solid"/>
                     </a:lnB>
                     <a:solidFill>
-                      <a:srgbClr val="F4F8FB">
-                        <a:alpha val="100000"/>
+                      <a:srgbClr val="FFFFFF">
+                        <a:alpha val="0"/>
                       </a:srgbClr>
                     </a:solidFill>
                   </a:tcPr>
@@ -25308,8 +25595,8 @@
                       <a:prstDash val="solid"/>
                     </a:lnB>
                     <a:solidFill>
-                      <a:srgbClr val="F4F8FB">
-                        <a:alpha val="100000"/>
+                      <a:srgbClr val="FFFFFF">
+                        <a:alpha val="0"/>
                       </a:srgbClr>
                     </a:solidFill>
                   </a:tcPr>
@@ -25365,8 +25652,8 @@
                       <a:prstDash val="solid"/>
                     </a:lnB>
                     <a:solidFill>
-                      <a:srgbClr val="F4F8FB">
-                        <a:alpha val="100000"/>
+                      <a:srgbClr val="FFFFFF">
+                        <a:alpha val="0"/>
                       </a:srgbClr>
                     </a:solidFill>
                   </a:tcPr>
@@ -25422,8 +25709,8 @@
                       <a:prstDash val="solid"/>
                     </a:lnB>
                     <a:solidFill>
-                      <a:srgbClr val="F4F8FB">
-                        <a:alpha val="100000"/>
+                      <a:srgbClr val="FFFFFF">
+                        <a:alpha val="0"/>
                       </a:srgbClr>
                     </a:solidFill>
                   </a:tcPr>
@@ -25479,8 +25766,8 @@
                       <a:prstDash val="solid"/>
                     </a:lnB>
                     <a:solidFill>
-                      <a:srgbClr val="F4F8FB">
-                        <a:alpha val="100000"/>
+                      <a:srgbClr val="FFFFFF">
+                        <a:alpha val="0"/>
                       </a:srgbClr>
                     </a:solidFill>
                   </a:tcPr>
@@ -25538,8 +25825,8 @@
                       <a:prstDash val="solid"/>
                     </a:lnB>
                     <a:solidFill>
-                      <a:srgbClr val="FFFFFF">
-                        <a:alpha val="0"/>
+                      <a:srgbClr val="F4F8FB">
+                        <a:alpha val="100000"/>
                       </a:srgbClr>
                     </a:solidFill>
                   </a:tcPr>
@@ -25595,8 +25882,8 @@
                       <a:prstDash val="solid"/>
                     </a:lnB>
                     <a:solidFill>
-                      <a:srgbClr val="FFFFFF">
-                        <a:alpha val="0"/>
+                      <a:srgbClr val="F4F8FB">
+                        <a:alpha val="100000"/>
                       </a:srgbClr>
                     </a:solidFill>
                   </a:tcPr>
@@ -25652,8 +25939,8 @@
                       <a:prstDash val="solid"/>
                     </a:lnB>
                     <a:solidFill>
-                      <a:srgbClr val="FFFFFF">
-                        <a:alpha val="0"/>
+                      <a:srgbClr val="F4F8FB">
+                        <a:alpha val="100000"/>
                       </a:srgbClr>
                     </a:solidFill>
                   </a:tcPr>
@@ -25709,8 +25996,8 @@
                       <a:prstDash val="solid"/>
                     </a:lnB>
                     <a:solidFill>
-                      <a:srgbClr val="FFFFFF">
-                        <a:alpha val="0"/>
+                      <a:srgbClr val="F4F8FB">
+                        <a:alpha val="100000"/>
                       </a:srgbClr>
                     </a:solidFill>
                   </a:tcPr>
@@ -25766,8 +26053,8 @@
                       <a:prstDash val="solid"/>
                     </a:lnB>
                     <a:solidFill>
-                      <a:srgbClr val="FFFFFF">
-                        <a:alpha val="0"/>
+                      <a:srgbClr val="F4F8FB">
+                        <a:alpha val="100000"/>
                       </a:srgbClr>
                     </a:solidFill>
                   </a:tcPr>
@@ -25825,8 +26112,8 @@
                       <a:prstDash val="solid"/>
                     </a:lnB>
                     <a:solidFill>
-                      <a:srgbClr val="F4F8FB">
-                        <a:alpha val="100000"/>
+                      <a:srgbClr val="FFFFFF">
+                        <a:alpha val="0"/>
                       </a:srgbClr>
                     </a:solidFill>
                   </a:tcPr>
@@ -25882,8 +26169,8 @@
                       <a:prstDash val="solid"/>
                     </a:lnB>
                     <a:solidFill>
-                      <a:srgbClr val="F4F8FB">
-                        <a:alpha val="100000"/>
+                      <a:srgbClr val="FFFFFF">
+                        <a:alpha val="0"/>
                       </a:srgbClr>
                     </a:solidFill>
                   </a:tcPr>
@@ -25939,8 +26226,8 @@
                       <a:prstDash val="solid"/>
                     </a:lnB>
                     <a:solidFill>
-                      <a:srgbClr val="F4F8FB">
-                        <a:alpha val="100000"/>
+                      <a:srgbClr val="FFFFFF">
+                        <a:alpha val="0"/>
                       </a:srgbClr>
                     </a:solidFill>
                   </a:tcPr>
@@ -25996,8 +26283,8 @@
                       <a:prstDash val="solid"/>
                     </a:lnB>
                     <a:solidFill>
-                      <a:srgbClr val="F4F8FB">
-                        <a:alpha val="100000"/>
+                      <a:srgbClr val="FFFFFF">
+                        <a:alpha val="0"/>
                       </a:srgbClr>
                     </a:solidFill>
                   </a:tcPr>
@@ -26053,8 +26340,8 @@
                       <a:prstDash val="solid"/>
                     </a:lnB>
                     <a:solidFill>
-                      <a:srgbClr val="F4F8FB">
-                        <a:alpha val="100000"/>
+                      <a:srgbClr val="FFFFFF">
+                        <a:alpha val="0"/>
                       </a:srgbClr>
                     </a:solidFill>
                   </a:tcPr>
@@ -26112,8 +26399,8 @@
                       <a:prstDash val="solid"/>
                     </a:lnB>
                     <a:solidFill>
-                      <a:srgbClr val="FFFFFF">
-                        <a:alpha val="0"/>
+                      <a:srgbClr val="F4F8FB">
+                        <a:alpha val="100000"/>
                       </a:srgbClr>
                     </a:solidFill>
                   </a:tcPr>
@@ -26169,8 +26456,8 @@
                       <a:prstDash val="solid"/>
                     </a:lnB>
                     <a:solidFill>
-                      <a:srgbClr val="FFFFFF">
-                        <a:alpha val="0"/>
+                      <a:srgbClr val="F4F8FB">
+                        <a:alpha val="100000"/>
                       </a:srgbClr>
                     </a:solidFill>
                   </a:tcPr>
@@ -26226,8 +26513,8 @@
                       <a:prstDash val="solid"/>
                     </a:lnB>
                     <a:solidFill>
-                      <a:srgbClr val="FFFFFF">
-                        <a:alpha val="0"/>
+                      <a:srgbClr val="F4F8FB">
+                        <a:alpha val="100000"/>
                       </a:srgbClr>
                     </a:solidFill>
                   </a:tcPr>
@@ -26283,8 +26570,8 @@
                       <a:prstDash val="solid"/>
                     </a:lnB>
                     <a:solidFill>
-                      <a:srgbClr val="FFFFFF">
-                        <a:alpha val="0"/>
+                      <a:srgbClr val="F4F8FB">
+                        <a:alpha val="100000"/>
                       </a:srgbClr>
                     </a:solidFill>
                   </a:tcPr>
@@ -26340,8 +26627,8 @@
                       <a:prstDash val="solid"/>
                     </a:lnB>
                     <a:solidFill>
-                      <a:srgbClr val="FFFFFF">
-                        <a:alpha val="0"/>
+                      <a:srgbClr val="F4F8FB">
+                        <a:alpha val="100000"/>
                       </a:srgbClr>
                     </a:solidFill>
                   </a:tcPr>
@@ -26399,8 +26686,8 @@
                       <a:prstDash val="solid"/>
                     </a:lnB>
                     <a:solidFill>
-                      <a:srgbClr val="F4F8FB">
-                        <a:alpha val="100000"/>
+                      <a:srgbClr val="FFFFFF">
+                        <a:alpha val="0"/>
                       </a:srgbClr>
                     </a:solidFill>
                   </a:tcPr>
@@ -26456,8 +26743,8 @@
                       <a:prstDash val="solid"/>
                     </a:lnB>
                     <a:solidFill>
-                      <a:srgbClr val="F4F8FB">
-                        <a:alpha val="100000"/>
+                      <a:srgbClr val="FFFFFF">
+                        <a:alpha val="0"/>
                       </a:srgbClr>
                     </a:solidFill>
                   </a:tcPr>
@@ -26513,8 +26800,8 @@
                       <a:prstDash val="solid"/>
                     </a:lnB>
                     <a:solidFill>
-                      <a:srgbClr val="F4F8FB">
-                        <a:alpha val="100000"/>
+                      <a:srgbClr val="FFFFFF">
+                        <a:alpha val="0"/>
                       </a:srgbClr>
                     </a:solidFill>
                   </a:tcPr>
@@ -26570,8 +26857,8 @@
                       <a:prstDash val="solid"/>
                     </a:lnB>
                     <a:solidFill>
-                      <a:srgbClr val="F4F8FB">
-                        <a:alpha val="100000"/>
+                      <a:srgbClr val="FFFFFF">
+                        <a:alpha val="0"/>
                       </a:srgbClr>
                     </a:solidFill>
                   </a:tcPr>
@@ -26627,8 +26914,8 @@
                       <a:prstDash val="solid"/>
                     </a:lnB>
                     <a:solidFill>
-                      <a:srgbClr val="F4F8FB">
-                        <a:alpha val="100000"/>
+                      <a:srgbClr val="FFFFFF">
+                        <a:alpha val="0"/>
                       </a:srgbClr>
                     </a:solidFill>
                   </a:tcPr>
@@ -26686,8 +26973,8 @@
                       <a:prstDash val="solid"/>
                     </a:lnB>
                     <a:solidFill>
-                      <a:srgbClr val="FFFFFF">
-                        <a:alpha val="0"/>
+                      <a:srgbClr val="F4F8FB">
+                        <a:alpha val="100000"/>
                       </a:srgbClr>
                     </a:solidFill>
                   </a:tcPr>
@@ -26743,8 +27030,8 @@
                       <a:prstDash val="solid"/>
                     </a:lnB>
                     <a:solidFill>
-                      <a:srgbClr val="FFFFFF">
-                        <a:alpha val="0"/>
+                      <a:srgbClr val="F4F8FB">
+                        <a:alpha val="100000"/>
                       </a:srgbClr>
                     </a:solidFill>
                   </a:tcPr>
@@ -26800,8 +27087,8 @@
                       <a:prstDash val="solid"/>
                     </a:lnB>
                     <a:solidFill>
-                      <a:srgbClr val="FFFFFF">
-                        <a:alpha val="0"/>
+                      <a:srgbClr val="F4F8FB">
+                        <a:alpha val="100000"/>
                       </a:srgbClr>
                     </a:solidFill>
                   </a:tcPr>
@@ -26857,8 +27144,8 @@
                       <a:prstDash val="solid"/>
                     </a:lnB>
                     <a:solidFill>
-                      <a:srgbClr val="FFFFFF">
-                        <a:alpha val="0"/>
+                      <a:srgbClr val="F4F8FB">
+                        <a:alpha val="100000"/>
                       </a:srgbClr>
                     </a:solidFill>
                   </a:tcPr>
@@ -26914,8 +27201,8 @@
                       <a:prstDash val="solid"/>
                     </a:lnB>
                     <a:solidFill>
-                      <a:srgbClr val="FFFFFF">
-                        <a:alpha val="0"/>
+                      <a:srgbClr val="F4F8FB">
+                        <a:alpha val="100000"/>
                       </a:srgbClr>
                     </a:solidFill>
                   </a:tcPr>
@@ -26973,8 +27260,8 @@
                       <a:prstDash val="solid"/>
                     </a:lnB>
                     <a:solidFill>
-                      <a:srgbClr val="F4F8FB">
-                        <a:alpha val="100000"/>
+                      <a:srgbClr val="FFFFFF">
+                        <a:alpha val="0"/>
                       </a:srgbClr>
                     </a:solidFill>
                   </a:tcPr>
@@ -27030,8 +27317,8 @@
                       <a:prstDash val="solid"/>
                     </a:lnB>
                     <a:solidFill>
-                      <a:srgbClr val="F4F8FB">
-                        <a:alpha val="100000"/>
+                      <a:srgbClr val="FFFFFF">
+                        <a:alpha val="0"/>
                       </a:srgbClr>
                     </a:solidFill>
                   </a:tcPr>
@@ -27087,8 +27374,8 @@
                       <a:prstDash val="solid"/>
                     </a:lnB>
                     <a:solidFill>
-                      <a:srgbClr val="F4F8FB">
-                        <a:alpha val="100000"/>
+                      <a:srgbClr val="FFFFFF">
+                        <a:alpha val="0"/>
                       </a:srgbClr>
                     </a:solidFill>
                   </a:tcPr>
@@ -27144,8 +27431,8 @@
                       <a:prstDash val="solid"/>
                     </a:lnB>
                     <a:solidFill>
-                      <a:srgbClr val="F4F8FB">
-                        <a:alpha val="100000"/>
+                      <a:srgbClr val="FFFFFF">
+                        <a:alpha val="0"/>
                       </a:srgbClr>
                     </a:solidFill>
                   </a:tcPr>
@@ -27201,8 +27488,8 @@
                       <a:prstDash val="solid"/>
                     </a:lnB>
                     <a:solidFill>
-                      <a:srgbClr val="F4F8FB">
-                        <a:alpha val="100000"/>
+                      <a:srgbClr val="FFFFFF">
+                        <a:alpha val="0"/>
                       </a:srgbClr>
                     </a:solidFill>
                   </a:tcPr>
@@ -27260,8 +27547,8 @@
                       <a:prstDash val="solid"/>
                     </a:lnB>
                     <a:solidFill>
-                      <a:srgbClr val="FFFFFF">
-                        <a:alpha val="0"/>
+                      <a:srgbClr val="F4F8FB">
+                        <a:alpha val="100000"/>
                       </a:srgbClr>
                     </a:solidFill>
                   </a:tcPr>
@@ -27317,8 +27604,8 @@
                       <a:prstDash val="solid"/>
                     </a:lnB>
                     <a:solidFill>
-                      <a:srgbClr val="FFFFFF">
-                        <a:alpha val="0"/>
+                      <a:srgbClr val="F4F8FB">
+                        <a:alpha val="100000"/>
                       </a:srgbClr>
                     </a:solidFill>
                   </a:tcPr>
@@ -27374,8 +27661,8 @@
                       <a:prstDash val="solid"/>
                     </a:lnB>
                     <a:solidFill>
-                      <a:srgbClr val="FFFFFF">
-                        <a:alpha val="0"/>
+                      <a:srgbClr val="F4F8FB">
+                        <a:alpha val="100000"/>
                       </a:srgbClr>
                     </a:solidFill>
                   </a:tcPr>
@@ -27431,8 +27718,8 @@
                       <a:prstDash val="solid"/>
                     </a:lnB>
                     <a:solidFill>
-                      <a:srgbClr val="FFFFFF">
-                        <a:alpha val="0"/>
+                      <a:srgbClr val="F4F8FB">
+                        <a:alpha val="100000"/>
                       </a:srgbClr>
                     </a:solidFill>
                   </a:tcPr>
@@ -27488,8 +27775,8 @@
                       <a:prstDash val="solid"/>
                     </a:lnB>
                     <a:solidFill>
-                      <a:srgbClr val="FFFFFF">
-                        <a:alpha val="0"/>
+                      <a:srgbClr val="F4F8FB">
+                        <a:alpha val="100000"/>
                       </a:srgbClr>
                     </a:solidFill>
                   </a:tcPr>
@@ -27547,8 +27834,8 @@
                       <a:prstDash val="solid"/>
                     </a:lnB>
                     <a:solidFill>
-                      <a:srgbClr val="F4F8FB">
-                        <a:alpha val="100000"/>
+                      <a:srgbClr val="FFFFFF">
+                        <a:alpha val="0"/>
                       </a:srgbClr>
                     </a:solidFill>
                   </a:tcPr>
@@ -27604,8 +27891,8 @@
                       <a:prstDash val="solid"/>
                     </a:lnB>
                     <a:solidFill>
-                      <a:srgbClr val="F4F8FB">
-                        <a:alpha val="100000"/>
+                      <a:srgbClr val="FFFFFF">
+                        <a:alpha val="0"/>
                       </a:srgbClr>
                     </a:solidFill>
                   </a:tcPr>
@@ -27661,8 +27948,8 @@
                       <a:prstDash val="solid"/>
                     </a:lnB>
                     <a:solidFill>
-                      <a:srgbClr val="F4F8FB">
-                        <a:alpha val="100000"/>
+                      <a:srgbClr val="FFFFFF">
+                        <a:alpha val="0"/>
                       </a:srgbClr>
                     </a:solidFill>
                   </a:tcPr>
@@ -27718,8 +28005,8 @@
                       <a:prstDash val="solid"/>
                     </a:lnB>
                     <a:solidFill>
-                      <a:srgbClr val="F4F8FB">
-                        <a:alpha val="100000"/>
+                      <a:srgbClr val="FFFFFF">
+                        <a:alpha val="0"/>
                       </a:srgbClr>
                     </a:solidFill>
                   </a:tcPr>
@@ -27775,14 +28062,14 @@
                       <a:prstDash val="solid"/>
                     </a:lnB>
                     <a:solidFill>
-                      <a:srgbClr val="F4F8FB">
-                        <a:alpha val="100000"/>
+                      <a:srgbClr val="FFFFFF">
+                        <a:alpha val="0"/>
                       </a:srgbClr>
                     </a:solidFill>
                   </a:tcPr>
                 </a:tc>
               </a:tr>
-              <a:tr h="401320">
+              <a:tr h="410845">
                 <a:tc>
                   <a:txBody>
                     <a:bodyPr/>
@@ -27829,13 +28116,17 @@
                       <a:noFill/>
                       <a:prstDash val="solid"/>
                     </a:lnT>
-                    <a:lnB algn="ctr" cmpd="sng" cap="flat" w="0">
-                      <a:noFill/>
+                    <a:lnB algn="ctr" cmpd="sng" cap="flat" w="19050">
+                      <a:solidFill>
+                        <a:srgbClr val="666666">
+                          <a:alpha val="100000"/>
+                        </a:srgbClr>
+                      </a:solidFill>
                       <a:prstDash val="solid"/>
                     </a:lnB>
                     <a:solidFill>
-                      <a:srgbClr val="FFFFFF">
-                        <a:alpha val="0"/>
+                      <a:srgbClr val="F4F8FB">
+                        <a:alpha val="100000"/>
                       </a:srgbClr>
                     </a:solidFill>
                   </a:tcPr>
@@ -27886,13 +28177,17 @@
                       <a:noFill/>
                       <a:prstDash val="solid"/>
                     </a:lnT>
-                    <a:lnB algn="ctr" cmpd="sng" cap="flat" w="0">
-                      <a:noFill/>
+                    <a:lnB algn="ctr" cmpd="sng" cap="flat" w="19050">
+                      <a:solidFill>
+                        <a:srgbClr val="666666">
+                          <a:alpha val="100000"/>
+                        </a:srgbClr>
+                      </a:solidFill>
                       <a:prstDash val="solid"/>
                     </a:lnB>
                     <a:solidFill>
-                      <a:srgbClr val="FFFFFF">
-                        <a:alpha val="0"/>
+                      <a:srgbClr val="F4F8FB">
+                        <a:alpha val="100000"/>
                       </a:srgbClr>
                     </a:solidFill>
                   </a:tcPr>
@@ -27943,13 +28238,17 @@
                       <a:noFill/>
                       <a:prstDash val="solid"/>
                     </a:lnT>
-                    <a:lnB algn="ctr" cmpd="sng" cap="flat" w="0">
-                      <a:noFill/>
+                    <a:lnB algn="ctr" cmpd="sng" cap="flat" w="19050">
+                      <a:solidFill>
+                        <a:srgbClr val="666666">
+                          <a:alpha val="100000"/>
+                        </a:srgbClr>
+                      </a:solidFill>
                       <a:prstDash val="solid"/>
                     </a:lnB>
                     <a:solidFill>
-                      <a:srgbClr val="FFFFFF">
-                        <a:alpha val="0"/>
+                      <a:srgbClr val="F4F8FB">
+                        <a:alpha val="100000"/>
                       </a:srgbClr>
                     </a:solidFill>
                   </a:tcPr>
@@ -28000,122 +28299,6 @@
                       <a:noFill/>
                       <a:prstDash val="solid"/>
                     </a:lnT>
-                    <a:lnB algn="ctr" cmpd="sng" cap="flat" w="0">
-                      <a:noFill/>
-                      <a:prstDash val="solid"/>
-                    </a:lnB>
-                    <a:solidFill>
-                      <a:srgbClr val="FFFFFF">
-                        <a:alpha val="0"/>
-                      </a:srgbClr>
-                    </a:solidFill>
-                  </a:tcPr>
-                </a:tc>
-                <a:tc>
-                  <a:txBody>
-                    <a:bodyPr/>
-                    <a:lstStyle/>
-                    <a:p>
-                      <a:pPr algn="l" marL="63500" marR="63500">
-                        <a:lnSpc>
-                          <a:spcPct val="100000"/>
-                        </a:lnSpc>
-                        <a:spcBef>
-                          <a:spcPts val="500"/>
-                        </a:spcBef>
-                        <a:spcAft>
-                          <a:spcPts val="500"/>
-                        </a:spcAft>
-                        <a:buNone/>
-                      </a:pPr>
-                      <a:r>
-                        <a:rPr cap="none" sz="1200" i="0" b="0" u="none" strike="noStrike">
-                          <a:solidFill>
-                            <a:srgbClr val="5B6770">
-                              <a:alpha val="100000"/>
-                            </a:srgbClr>
-                          </a:solidFill>
-                          <a:latin typeface="Helvetica Neue"/>
-                          <a:cs typeface="Helvetica Neue"/>
-                          <a:ea typeface="Helvetica Neue"/>
-                          <a:sym typeface="Helvetica Neue"/>
-                        </a:rPr>
-                        <a:t>605335</a:t>
-                      </a:r>
-                    </a:p>
-                  </a:txBody>
-                  <a:tcPr anchor="ctr" marB="63500" marT="63500" marR="0" marL="0">
-                    <a:lnL algn="ctr" cmpd="sng" cap="flat" w="0">
-                      <a:noFill/>
-                      <a:prstDash val="solid"/>
-                    </a:lnL>
-                    <a:lnR algn="ctr" cmpd="sng" cap="flat" w="0">
-                      <a:noFill/>
-                      <a:prstDash val="solid"/>
-                    </a:lnR>
-                    <a:lnT algn="ctr" cmpd="sng" cap="flat" w="0">
-                      <a:noFill/>
-                      <a:prstDash val="solid"/>
-                    </a:lnT>
-                    <a:lnB algn="ctr" cmpd="sng" cap="flat" w="0">
-                      <a:noFill/>
-                      <a:prstDash val="solid"/>
-                    </a:lnB>
-                    <a:solidFill>
-                      <a:srgbClr val="FFFFFF">
-                        <a:alpha val="0"/>
-                      </a:srgbClr>
-                    </a:solidFill>
-                  </a:tcPr>
-                </a:tc>
-              </a:tr>
-              <a:tr h="410845">
-                <a:tc>
-                  <a:txBody>
-                    <a:bodyPr/>
-                    <a:lstStyle/>
-                    <a:p>
-                      <a:pPr algn="l" marL="63500" marR="63500">
-                        <a:lnSpc>
-                          <a:spcPct val="100000"/>
-                        </a:lnSpc>
-                        <a:spcBef>
-                          <a:spcPts val="500"/>
-                        </a:spcBef>
-                        <a:spcAft>
-                          <a:spcPts val="500"/>
-                        </a:spcAft>
-                        <a:buNone/>
-                      </a:pPr>
-                      <a:r>
-                        <a:rPr cap="none" sz="1200" i="0" b="0" u="none" strike="noStrike">
-                          <a:solidFill>
-                            <a:srgbClr val="5B6770">
-                              <a:alpha val="100000"/>
-                            </a:srgbClr>
-                          </a:solidFill>
-                          <a:latin typeface="Helvetica Neue"/>
-                          <a:cs typeface="Helvetica Neue"/>
-                          <a:ea typeface="Helvetica Neue"/>
-                          <a:sym typeface="Helvetica Neue"/>
-                        </a:rPr>
-                        <a:t>misoprostol</a:t>
-                      </a:r>
-                    </a:p>
-                  </a:txBody>
-                  <a:tcPr anchor="ctr" marB="63500" marT="63500" marR="0" marL="0">
-                    <a:lnL algn="ctr" cmpd="sng" cap="flat" w="0">
-                      <a:noFill/>
-                      <a:prstDash val="solid"/>
-                    </a:lnL>
-                    <a:lnR algn="ctr" cmpd="sng" cap="flat" w="0">
-                      <a:noFill/>
-                      <a:prstDash val="solid"/>
-                    </a:lnR>
-                    <a:lnT algn="ctr" cmpd="sng" cap="flat" w="0">
-                      <a:noFill/>
-                      <a:prstDash val="solid"/>
-                    </a:lnT>
                     <a:lnB algn="ctr" cmpd="sng" cap="flat" w="19050">
                       <a:solidFill>
                         <a:srgbClr val="666666">
@@ -28160,190 +28343,7 @@
                           <a:ea typeface="Helvetica Neue"/>
                           <a:sym typeface="Helvetica Neue"/>
                         </a:rPr>
-                        <a:t>06 Aug 2026</a:t>
-                      </a:r>
-                    </a:p>
-                  </a:txBody>
-                  <a:tcPr anchor="ctr" marB="63500" marT="63500" marR="0" marL="0">
-                    <a:lnL algn="ctr" cmpd="sng" cap="flat" w="0">
-                      <a:noFill/>
-                      <a:prstDash val="solid"/>
-                    </a:lnL>
-                    <a:lnR algn="ctr" cmpd="sng" cap="flat" w="0">
-                      <a:noFill/>
-                      <a:prstDash val="solid"/>
-                    </a:lnR>
-                    <a:lnT algn="ctr" cmpd="sng" cap="flat" w="0">
-                      <a:noFill/>
-                      <a:prstDash val="solid"/>
-                    </a:lnT>
-                    <a:lnB algn="ctr" cmpd="sng" cap="flat" w="19050">
-                      <a:solidFill>
-                        <a:srgbClr val="666666">
-                          <a:alpha val="100000"/>
-                        </a:srgbClr>
-                      </a:solidFill>
-                      <a:prstDash val="solid"/>
-                    </a:lnB>
-                    <a:solidFill>
-                      <a:srgbClr val="F4F8FB">
-                        <a:alpha val="100000"/>
-                      </a:srgbClr>
-                    </a:solidFill>
-                  </a:tcPr>
-                </a:tc>
-                <a:tc>
-                  <a:txBody>
-                    <a:bodyPr/>
-                    <a:lstStyle/>
-                    <a:p>
-                      <a:pPr algn="l" marL="63500" marR="63500">
-                        <a:lnSpc>
-                          <a:spcPct val="100000"/>
-                        </a:lnSpc>
-                        <a:spcBef>
-                          <a:spcPts val="500"/>
-                        </a:spcBef>
-                        <a:spcAft>
-                          <a:spcPts val="500"/>
-                        </a:spcAft>
-                        <a:buNone/>
-                      </a:pPr>
-                      <a:r>
-                        <a:rPr cap="none" sz="1200" i="0" b="0" u="none" strike="noStrike">
-                          <a:solidFill>
-                            <a:srgbClr val="5B6770">
-                              <a:alpha val="100000"/>
-                            </a:srgbClr>
-                          </a:solidFill>
-                          <a:latin typeface="Helvetica Neue"/>
-                          <a:cs typeface="Helvetica Neue"/>
-                          <a:ea typeface="Helvetica Neue"/>
-                          <a:sym typeface="Helvetica Neue"/>
-                        </a:rPr>
-                        <a:t>primary</a:t>
-                      </a:r>
-                    </a:p>
-                  </a:txBody>
-                  <a:tcPr anchor="ctr" marB="63500" marT="63500" marR="0" marL="0">
-                    <a:lnL algn="ctr" cmpd="sng" cap="flat" w="0">
-                      <a:noFill/>
-                      <a:prstDash val="solid"/>
-                    </a:lnL>
-                    <a:lnR algn="ctr" cmpd="sng" cap="flat" w="0">
-                      <a:noFill/>
-                      <a:prstDash val="solid"/>
-                    </a:lnR>
-                    <a:lnT algn="ctr" cmpd="sng" cap="flat" w="0">
-                      <a:noFill/>
-                      <a:prstDash val="solid"/>
-                    </a:lnT>
-                    <a:lnB algn="ctr" cmpd="sng" cap="flat" w="19050">
-                      <a:solidFill>
-                        <a:srgbClr val="666666">
-                          <a:alpha val="100000"/>
-                        </a:srgbClr>
-                      </a:solidFill>
-                      <a:prstDash val="solid"/>
-                    </a:lnB>
-                    <a:solidFill>
-                      <a:srgbClr val="F4F8FB">
-                        <a:alpha val="100000"/>
-                      </a:srgbClr>
-                    </a:solidFill>
-                  </a:tcPr>
-                </a:tc>
-                <a:tc>
-                  <a:txBody>
-                    <a:bodyPr/>
-                    <a:lstStyle/>
-                    <a:p>
-                      <a:pPr algn="r" marL="63500" marR="63500">
-                        <a:lnSpc>
-                          <a:spcPct val="100000"/>
-                        </a:lnSpc>
-                        <a:spcBef>
-                          <a:spcPts val="500"/>
-                        </a:spcBef>
-                        <a:spcAft>
-                          <a:spcPts val="500"/>
-                        </a:spcAft>
-                        <a:buNone/>
-                      </a:pPr>
-                      <a:r>
-                        <a:rPr cap="none" sz="1200" i="0" b="0" u="none" strike="noStrike">
-                          <a:solidFill>
-                            <a:srgbClr val="5B6770">
-                              <a:alpha val="100000"/>
-                            </a:srgbClr>
-                          </a:solidFill>
-                          <a:latin typeface="Helvetica Neue"/>
-                          <a:cs typeface="Helvetica Neue"/>
-                          <a:ea typeface="Helvetica Neue"/>
-                          <a:sym typeface="Helvetica Neue"/>
-                        </a:rPr>
-                        <a:t>1</a:t>
-                      </a:r>
-                    </a:p>
-                  </a:txBody>
-                  <a:tcPr anchor="ctr" marB="63500" marT="63500" marR="0" marL="0">
-                    <a:lnL algn="ctr" cmpd="sng" cap="flat" w="0">
-                      <a:noFill/>
-                      <a:prstDash val="solid"/>
-                    </a:lnL>
-                    <a:lnR algn="ctr" cmpd="sng" cap="flat" w="0">
-                      <a:noFill/>
-                      <a:prstDash val="solid"/>
-                    </a:lnR>
-                    <a:lnT algn="ctr" cmpd="sng" cap="flat" w="0">
-                      <a:noFill/>
-                      <a:prstDash val="solid"/>
-                    </a:lnT>
-                    <a:lnB algn="ctr" cmpd="sng" cap="flat" w="19050">
-                      <a:solidFill>
-                        <a:srgbClr val="666666">
-                          <a:alpha val="100000"/>
-                        </a:srgbClr>
-                      </a:solidFill>
-                      <a:prstDash val="solid"/>
-                    </a:lnB>
-                    <a:solidFill>
-                      <a:srgbClr val="F4F8FB">
-                        <a:alpha val="100000"/>
-                      </a:srgbClr>
-                    </a:solidFill>
-                  </a:tcPr>
-                </a:tc>
-                <a:tc>
-                  <a:txBody>
-                    <a:bodyPr/>
-                    <a:lstStyle/>
-                    <a:p>
-                      <a:pPr algn="l" marL="63500" marR="63500">
-                        <a:lnSpc>
-                          <a:spcPct val="100000"/>
-                        </a:lnSpc>
-                        <a:spcBef>
-                          <a:spcPts val="500"/>
-                        </a:spcBef>
-                        <a:spcAft>
-                          <a:spcPts val="500"/>
-                        </a:spcAft>
-                        <a:buNone/>
-                      </a:pPr>
-                      <a:r>
-                        <a:rPr cap="none" sz="1200" i="0" b="0" u="none" strike="noStrike">
-                          <a:solidFill>
-                            <a:srgbClr val="5B6770">
-                              <a:alpha val="100000"/>
-                            </a:srgbClr>
-                          </a:solidFill>
-                          <a:latin typeface="Helvetica Neue"/>
-                          <a:cs typeface="Helvetica Neue"/>
-                          <a:ea typeface="Helvetica Neue"/>
-                          <a:sym typeface="Helvetica Neue"/>
-                        </a:rPr>
-                        <a:t>816799</a:t>
+                        <a:t>605335</a:t>
                       </a:r>
                     </a:p>
                   </a:txBody>

</xml_diff>

<commit_message>
nightly deck: data through 2026-10-31
</commit_message>
<xml_diff>
--- a/docs/nc-drug-checking-latest.pptx
+++ b/docs/nc-drug-checking-latest.pptx
@@ -2418,7 +2418,7 @@
                 <a:ea typeface="Helvetica Neue"/>
                 <a:sym typeface="Helvetica Neue"/>
               </a:rPr>
-              <a:t>Generated Friday, October 30, 2026 · 10:25 AM ET UNC Street Drug Analysis Lab · OpioidData.org · results.streetsafe.supply Download as PowerPoint</a:t>
+              <a:t>Generated Saturday, October 31, 2026 · 9:46 AM ET UNC Street Drug Analysis Lab · OpioidData.org · results.streetsafe.supply Download as PowerPoint</a:t>
             </a:r>
           </a:p>
         </p:txBody>
@@ -3184,7 +3184,7 @@
                 <a:ea typeface="Helvetica Neue"/>
                 <a:sym typeface="Helvetica Neue"/>
               </a:rPr>
-              <a:t>County = samplecounty · left: ≥1 completed analysis ever · right: unique samples per county (sqrt color scale) · all time: 26 Jan 2022 – 30 Oct 2026 · last 12 months: 30 Oct 2025 – 30 Oct 2026* · coverage reflects participation, not prevalence</a:t>
+              <a:t>County = samplecounty · left: ≥1 completed analysis ever · right: unique samples per county (sqrt color scale) · all time: 26 Jan 2022 – 30 Oct 2026 · last 12 months: 31 Oct 2025 – 30 Oct 2026* · coverage reflects participation, not prevalence</a:t>
             </a:r>
           </a:p>
         </p:txBody>
@@ -4323,7 +4323,7 @@
                 <a:ea typeface="Helvetica Neue"/>
                 <a:sym typeface="Helvetica Neue"/>
               </a:rPr>
-              <a:t>Samples with methamphetamine or cocaine detected (any abundance); samples in both classes appear on both slides · sensations semicolon lists parsed + sen_strength (own denominator) · consumed = 1 only · before: 26 Jan 2022 – 30 Oct 2025 · past 12 months: 30 Oct 2025 – 30 Oct 2026* · Δ in percentage points</a:t>
+              <a:t>Samples with methamphetamine or cocaine detected (any abundance); samples in both classes appear on both slides · sensations semicolon lists parsed + sen_strength (own denominator) · consumed = 1 only · before: 26 Jan 2022 – 30 Oct 2025 · past 12 months: 31 Oct 2025 – 30 Oct 2026* · Δ in percentage points</a:t>
             </a:r>
           </a:p>
         </p:txBody>
@@ -4742,7 +4742,7 @@
                 <a:ea typeface="Helvetica Neue"/>
                 <a:sym typeface="Helvetica Neue"/>
               </a:rPr>
-              <a:t>Samples with an opioid (fentanyl, heroin) or benzodiazepine detected (any abundance); samples in both classes appear on both slides · sensations semicolon lists parsed + sen_strength (own denominator) · consumed = 1 only · before: 26 Jan 2022 – 30 Oct 2025 · past 12 months: 30 Oct 2025 – 30 Oct 2026* · Δ in percentage points</a:t>
+              <a:t>Samples with an opioid (fentanyl, heroin) or benzodiazepine detected (any abundance); samples in both classes appear on both slides · sensations semicolon lists parsed + sen_strength (own denominator) · consumed = 1 only · before: 26 Jan 2022 – 30 Oct 2025 · past 12 months: 31 Oct 2025 – 30 Oct 2026* · Δ in percentage points</a:t>
             </a:r>
           </a:p>
         </p:txBody>
@@ -5855,7 +5855,7 @@
                 <a:ea typeface="Helvetica Neue"/>
                 <a:sym typeface="Helvetica Neue"/>
               </a:rPr>
-              <a:t>lab_detail.substance counts · solid = primary abundance, light = trace · standardized names (PubChem-linked) · window: date_complete 30 Oct 2025 – 30 Oct 2026* (trailing 12 months, current month partial)</a:t>
+              <a:t>lab_detail.substance counts · solid = primary abundance, light = trace · standardized names (PubChem-linked) · window: date_complete 31 Oct 2025 – 30 Oct 2026* (trailing 12 months, current month partial)</a:t>
             </a:r>
           </a:p>
         </p:txBody>
@@ -6053,7 +6053,7 @@
                 <a:ea typeface="Helvetica Neue"/>
                 <a:sym typeface="Helvetica Neue"/>
               </a:rPr>
-              <a:t>Distribution of substances detected per sample, both definitions shown side by side · window: date_complete 30 Oct 2025 – 30 Oct 2026* (trailing 12 months, current month partial)</a:t>
+              <a:t>Distribution of substances detected per sample, both definitions shown side by side · window: date_complete 31 Oct 2025 – 30 Oct 2026* (trailing 12 months, current month partial)</a:t>
             </a:r>
           </a:p>
         </p:txBody>

</xml_diff>